<commit_message>
Refactor output paths and enhance presentation generation scripts
- Updated `build_exec_summary.py` and `build_main_deck.py` to use relative paths for output files, ensuring compatibility across different environments.
- Introduced `build_explorer.py` to create a comprehensive HTML data explorer for the raw dataset, integrating profiles and verdicts for better data understanding.
- Enhanced `deck_style.py` to standardize figure paths, improving consistency in presentation design.
- Added new visualizations and refined existing content in the executive summary and case study decks to better communicate findings on customer churn.

These changes aim to improve the usability and clarity of the project outputs while ensuring that the presentation materials are accessible and informative.
</commit_message>
<xml_diff>
--- a/outputs/decks/AvePoint_Case_Study.pptx
+++ b/outputs/decks/AvePoint_Case_Study.pptx
@@ -20,6 +20,7 @@
     <p:sldId id="268" r:id="rId20"/>
     <p:sldId id="269" r:id="rId21"/>
     <p:sldId id="270" r:id="rId22"/>
+    <p:sldId id="271" r:id="rId23"/>
   </p:sldIdLst>
   <p:sldSz cx="12191695" cy="6858000" type="screen4x3"/>
   <p:notesSz cx="6858000" cy="9144000"/>
@@ -522,7 +523,7 @@
           <a:p/>
           <a:p>
             <a:r>
-              <a:t>The second clause is the part to sit on if there is only time for one thing. The strongest result I had — churn accelerating through 2024, p = 2e-16 — is reproduced exactly by a simulation containing nothing but a random number generator. Slide 10 is that test. Finding it is the piece of work I would most want to be judged on.</a:t>
+              <a:t>The second clause is the part to sit on if there is only time for one thing. The strongest result I had — churn accelerating through 2024, p = 2e-16 — is reproduced exactly by a simulation containing nothing but a random number generator. Slide 11 is that test. Finding it is the piece of work I would most want to be judged on.</a:t>
             </a:r>
           </a:p>
         </p:txBody>
@@ -592,7 +593,7 @@
           <a:lstStyle/>
           <a:p>
             <a:r>
-              <a:t>Lead with the target problem. Along with slide 10 it is the most valuable thing here, and it shows the instinct to check the label before fitting anything.</a:t>
+              <a:t>Lead with the target problem. Along with slide 11 it is the most valuable thing here, and it shows the instinct to check the label before fitting anything.</a:t>
             </a:r>
           </a:p>
           <a:p/>
@@ -3835,7 +3836,7 @@
                 </a:solidFill>
                 <a:latin typeface="Calibri"/>
               </a:rPr>
-              <a:t>PART 4 · RECOMMENDATION 1</a:t>
+              <a:t>PART 3 · MODELLING</a:t>
             </a:r>
           </a:p>
           <a:p>
@@ -3847,11 +3848,11 @@
             <a:r>
               <a:rPr sz="2800" b="1" i="0">
                 <a:solidFill>
-                  <a:srgbClr val="B02E2E"/>
-                </a:solidFill>
-                <a:latin typeface="Calibri"/>
-              </a:rPr>
-              <a:t>Do not go looking for what changed in 2024</a:t>
+                  <a:srgbClr val="2E5F8A"/>
+                </a:solidFill>
+                <a:latin typeface="Calibri"/>
+              </a:rPr>
+              <a:t>Interpretability, and how it can mislead you</a:t>
             </a:r>
           </a:p>
         </p:txBody>
@@ -3902,7 +3903,7 @@
       </p:sp>
       <p:pic>
         <p:nvPicPr>
-          <p:cNvPr id="4" name="Picture 3" descr="16_generator_artefact.png"/>
+          <p:cNvPr id="4" name="Picture 3" descr="13_shap_real_vs_shuffled.png"/>
           <p:cNvPicPr>
             <a:picLocks noChangeAspect="1"/>
           </p:cNvPicPr>
@@ -3916,8 +3917,8 @@
         </p:blipFill>
         <p:spPr>
           <a:xfrm>
-            <a:off x="1906186" y="1554480"/>
-            <a:ext cx="8379323" cy="2788920"/>
+            <a:off x="2260186" y="1572768"/>
+            <a:ext cx="7671323" cy="2514600"/>
           </a:xfrm>
           <a:prstGeom prst="rect">
             <a:avLst/>
@@ -3932,7 +3933,7 @@
         </p:nvSpPr>
         <p:spPr>
           <a:xfrm>
-            <a:off x="685800" y="4572000"/>
+            <a:off x="685800" y="4315968"/>
             <a:ext cx="10820095" cy="4572000"/>
           </a:xfrm>
           <a:prstGeom prst="rect">
@@ -3954,11 +3955,27 @@
             <a:r>
               <a:rPr sz="1250" b="1" i="0">
                 <a:solidFill>
+                  <a:srgbClr val="B02E2E"/>
+                </a:solidFill>
+                <a:latin typeface="Calibri"/>
+              </a:rPr>
+              <a:t>These are the same chart. The right-hand one is built from labels I shuffled at random — and it is more confident about its winner than the real one is.</a:t>
+            </a:r>
+          </a:p>
+          <a:p>
+            <a:pPr>
+              <a:spcAft>
+                <a:spcPts val="400"/>
+              </a:spcAft>
+            </a:pPr>
+            <a:r>
+              <a:rPr sz="1250" b="1" i="0">
+                <a:solidFill>
                   <a:srgbClr val="1A1A1A"/>
                 </a:solidFill>
                 <a:latin typeface="Calibri"/>
               </a:rPr>
-              <a:t>Churn looks like it is accelerating. About 5 in every 100 customers left each month in 2023, rising to 22 in 100 by December 2024 — a 2.8x rise per year, p = 2e-16. It was by far the strongest number in this study.</a:t>
+              <a:t>SHAP will always return a clean, ordered, plausible ranking. It has no way to tell you it has nothing to say, which is why every attribution method here is paired with a random baseline before it is believed.</a:t>
             </a:r>
           </a:p>
           <a:p>
@@ -3968,29 +3985,13 @@
               </a:spcAft>
             </a:pPr>
             <a:r>
-              <a:rPr sz="1250" b="1" i="0">
-                <a:solidFill>
-                  <a:srgbClr val="B02E2E"/>
-                </a:solidFill>
-                <a:latin typeface="Calibri"/>
-              </a:rPr>
-              <a:t>It is not a fact about customers. Every churn date in this file is a random date between the day the customer joined and the last day of the extract. A random date has nowhere to go but the end of the file, so the rate climbs on its own, with nothing happening in the business.</a:t>
-            </a:r>
-          </a:p>
-          <a:p>
-            <a:pPr>
-              <a:spcAft>
-                <a:spcPts val="400"/>
-              </a:spcAft>
-            </a:pPr>
-            <a:r>
-              <a:rPr sz="1250" b="1" i="0">
+              <a:rPr sz="1250" b="0" i="0">
                 <a:solidFill>
                   <a:srgbClr val="1A1A1A"/>
                 </a:solidFill>
                 <a:latin typeface="Calibri"/>
               </a:rPr>
-              <a:t>Rebuilding the data from that one rule gives the same answer: a 2.78x rise per year, all 24 months inside the range chance produces, and our result sitting at the 52nd percentile of pure noise. So there is nothing here to investigate, and that is the recommendation.</a:t>
+              <a:t>The numbers underneath: the top feature beats random labels only 3 times in 4 (p = 0.24). Twelve different features take first place across 25 reruns. Permutation importance on held-out data is beaten by noise outright.</a:t>
             </a:r>
           </a:p>
         </p:txBody>
@@ -4020,11 +4021,11 @@
             <a:r>
               <a:rPr sz="1150" b="0" i="1">
                 <a:solidFill>
-                  <a:srgbClr val="1A1A1A"/>
-                </a:solidFill>
-                <a:latin typeface="Calibri"/>
-              </a:rPr>
-              <a:t>The test that mattered was not "is this bigger than noise" — it was, comfortably. It was "would the file produce this on its own". On generated data that is the only null worth testing, and it is the one I had not run.</a:t>
+                  <a:srgbClr val="5A6270"/>
+                </a:solidFill>
+                <a:latin typeface="Calibri"/>
+              </a:rPr>
+              <a:t>Read without the right-hand panel, the left one says support load per seat drives churn, then contract size, then tenure. All three are plausible. That is exactly what makes it dangerous.</a:t>
             </a:r>
           </a:p>
         </p:txBody>
@@ -4076,7 +4077,7 @@
                 </a:solidFill>
                 <a:latin typeface="Calibri"/>
               </a:rPr>
-              <a:t>PART 4 · RECOMMENDATION 2</a:t>
+              <a:t>PART 4 · RECOMMENDATION 1</a:t>
             </a:r>
           </a:p>
           <a:p>
@@ -4092,7 +4093,7 @@
                 </a:solidFill>
                 <a:latin typeface="Calibri"/>
               </a:rPr>
-              <a:t>Do not build the onboarding programme</a:t>
+              <a:t>Do not go looking for what changed in 2024</a:t>
             </a:r>
           </a:p>
         </p:txBody>
@@ -4143,7 +4144,7 @@
       </p:sp>
       <p:pic>
         <p:nvPicPr>
-          <p:cNvPr id="4" name="Picture 3" descr="12_cohort_gradient.png"/>
+          <p:cNvPr id="4" name="Picture 3" descr="16_generator_artefact.png"/>
           <p:cNvPicPr>
             <a:picLocks noChangeAspect="1"/>
           </p:cNvPicPr>
@@ -4157,8 +4158,8 @@
         </p:blipFill>
         <p:spPr>
           <a:xfrm>
-            <a:off x="3590694" y="1627632"/>
-            <a:ext cx="5010307" cy="2743200"/>
+            <a:off x="1906186" y="1554480"/>
+            <a:ext cx="8379323" cy="2788920"/>
           </a:xfrm>
           <a:prstGeom prst="rect">
             <a:avLst/>
@@ -4173,7 +4174,7 @@
         </p:nvSpPr>
         <p:spPr>
           <a:xfrm>
-            <a:off x="685800" y="4526280"/>
+            <a:off x="685800" y="4572000"/>
             <a:ext cx="10820095" cy="4572000"/>
           </a:xfrm>
           <a:prstGeom prst="rect">
@@ -4199,7 +4200,7 @@
                 </a:solidFill>
                 <a:latin typeface="Calibri"/>
               </a:rPr>
-              <a:t>New customers look fragile, and risk looks like it falls with age. That is the usual reason to fund onboarding, and the evidence for it looks strong: 30-day survival drops from 0.98 for the 2023 intake to 0.59 for the 2024 one, measured at the same age.</a:t>
+              <a:t>Churn looks like it is accelerating. About 5 in every 100 customers left each month in 2023, rising to 22 in 100 by December 2024 — a 2.8x rise per year, p = 2e-16. It was by far the strongest number in this study.</a:t>
             </a:r>
           </a:p>
           <a:p>
@@ -4215,7 +4216,7 @@
                 </a:solidFill>
                 <a:latin typeface="Calibri"/>
               </a:rPr>
-              <a:t>It is the same random date. A customer who joined recently has a shorter window for that date to land in, so a larger share of their draws fall inside any 90-day question we ask. They look worse at every age without anything about them being worse.</a:t>
+              <a:t>It is not a fact about customers. Every churn date in this file is a random date between the day the customer joined and the last day of the extract. A random date has nowhere to go but the end of the file, so the rate climbs on its own, with nothing happening in the business.</a:t>
             </a:r>
           </a:p>
           <a:p>
@@ -4231,7 +4232,7 @@
                 </a:solidFill>
                 <a:latin typeface="Calibri"/>
               </a:rPr>
-              <a:t>Simulated data with no tenure effect in it at all clears the significance bar in 93% of runs, and does so more strongly than the real data does (p = 0.002 against 0.006). Within one joining month there is nothing left: a day-300 customer leaves as often as a day-10 one.</a:t>
+              <a:t>Rebuilding the data from that one rule gives the same answer: a 2.78x rise per year, all 24 months inside the range chance produces, and our result sitting at the 52nd percentile of pure noise. So there is nothing here to investigate, and that is the recommendation.</a:t>
             </a:r>
           </a:p>
         </p:txBody>
@@ -4261,11 +4262,11 @@
             <a:r>
               <a:rPr sz="1150" b="0" i="1">
                 <a:solidFill>
-                  <a:srgbClr val="5A6270"/>
-                </a:solidFill>
-                <a:latin typeface="Calibri"/>
-              </a:rPr>
-              <a:t>The recommendation does not change; the reason for it gets one layer deeper. This is the same finding as slide 10, applied to a spending decision instead of an investigation.</a:t>
+                  <a:srgbClr val="1A1A1A"/>
+                </a:solidFill>
+                <a:latin typeface="Calibri"/>
+              </a:rPr>
+              <a:t>The test that mattered was not "is this bigger than noise" — it was, comfortably. It was "would the file produce this on its own". On generated data that is the only null worth testing, and it is the one I had not run.</a:t>
             </a:r>
           </a:p>
         </p:txBody>
@@ -4317,7 +4318,7 @@
                 </a:solidFill>
                 <a:latin typeface="Calibri"/>
               </a:rPr>
-              <a:t>PART 4 · RECOMMENDATION 3</a:t>
+              <a:t>PART 4 · RECOMMENDATION 2</a:t>
             </a:r>
           </a:p>
           <a:p>
@@ -4329,11 +4330,11 @@
             <a:r>
               <a:rPr sz="2800" b="1" i="0">
                 <a:solidFill>
-                  <a:srgbClr val="1E7A4B"/>
-                </a:solidFill>
-                <a:latin typeface="Calibri"/>
-              </a:rPr>
-              <a:t>Call every at-risk customer, do not rank them</a:t>
+                  <a:srgbClr val="B02E2E"/>
+                </a:solidFill>
+                <a:latin typeface="Calibri"/>
+              </a:rPr>
+              <a:t>Do not build the onboarding programme</a:t>
             </a:r>
           </a:p>
         </p:txBody>
@@ -4384,7 +4385,7 @@
       </p:sp>
       <p:pic>
         <p:nvPicPr>
-          <p:cNvPr id="4" name="Picture 3" descr="15_breakeven_grid.png"/>
+          <p:cNvPr id="4" name="Picture 3" descr="12_cohort_gradient.png"/>
           <p:cNvPicPr>
             <a:picLocks noChangeAspect="1"/>
           </p:cNvPicPr>
@@ -4398,8 +4399,8 @@
         </p:blipFill>
         <p:spPr>
           <a:xfrm>
-            <a:off x="3492925" y="1645920"/>
-            <a:ext cx="5205845" cy="3017520"/>
+            <a:off x="3590694" y="1627632"/>
+            <a:ext cx="5010307" cy="2743200"/>
           </a:xfrm>
           <a:prstGeom prst="rect">
             <a:avLst/>
@@ -4414,7 +4415,7 @@
         </p:nvSpPr>
         <p:spPr>
           <a:xfrm>
-            <a:off x="685800" y="4846320"/>
+            <a:off x="685800" y="4526280"/>
             <a:ext cx="10820095" cy="4572000"/>
           </a:xfrm>
           <a:prstGeom prst="rect">
@@ -4430,33 +4431,49 @@
           <a:p>
             <a:pPr>
               <a:spcAft>
-                <a:spcPts val="900"/>
-              </a:spcAft>
-            </a:pPr>
-            <a:r>
-              <a:rPr sz="1300" b="1" i="0">
+                <a:spcPts val="400"/>
+              </a:spcAft>
+            </a:pPr>
+            <a:r>
+              <a:rPr sz="1250" b="1" i="0">
                 <a:solidFill>
                   <a:srgbClr val="1A1A1A"/>
                 </a:solidFill>
                 <a:latin typeface="Calibri"/>
               </a:rPr>
-              <a:t>A call costs about $150. A customer is worth about $7,300. If the call works one time in five, it pays for itself on any customer with more than a 10% chance of leaving. In this group, 31% leave.</a:t>
-            </a:r>
-          </a:p>
-          <a:p>
-            <a:pPr>
-              <a:spcAft>
-                <a:spcPts val="900"/>
-              </a:spcAft>
-            </a:pPr>
-            <a:r>
-              <a:rPr sz="1300" b="1" i="0">
-                <a:solidFill>
-                  <a:srgbClr val="1E7A4B"/>
-                </a:solidFill>
-                <a:latin typeface="Calibri"/>
-              </a:rPr>
-              <a:t>So calling everyone already makes money, and no ranking can improve on a decision that is right for every customer. Using the model adds $600 on top of $52,400. That is a 1% gain, and even that is generous.</a:t>
+              <a:t>New customers look fragile, and risk looks like it falls with age. That is the usual reason to fund onboarding, and the evidence for it looks strong: 30-day survival drops from 0.98 for the 2023 intake to 0.59 for the 2024 one, measured at the same age.</a:t>
+            </a:r>
+          </a:p>
+          <a:p>
+            <a:pPr>
+              <a:spcAft>
+                <a:spcPts val="400"/>
+              </a:spcAft>
+            </a:pPr>
+            <a:r>
+              <a:rPr sz="1250" b="1" i="0">
+                <a:solidFill>
+                  <a:srgbClr val="B02E2E"/>
+                </a:solidFill>
+                <a:latin typeface="Calibri"/>
+              </a:rPr>
+              <a:t>It is the same random date. A customer who joined recently has a shorter window for that date to land in, so a larger share of their draws fall inside any 90-day question we ask. They look worse at every age without anything about them being worse.</a:t>
+            </a:r>
+          </a:p>
+          <a:p>
+            <a:pPr>
+              <a:spcAft>
+                <a:spcPts val="400"/>
+              </a:spcAft>
+            </a:pPr>
+            <a:r>
+              <a:rPr sz="1250" b="1" i="0">
+                <a:solidFill>
+                  <a:srgbClr val="1A1A1A"/>
+                </a:solidFill>
+                <a:latin typeface="Calibri"/>
+              </a:rPr>
+              <a:t>Simulated data with no tenure effect in it at all clears the significance bar in 93% of runs, and does so more strongly than the real data does (p = 0.002 against 0.006). Within one joining month there is nothing left: a day-300 customer leaves as often as a day-10 one.</a:t>
             </a:r>
           </a:p>
         </p:txBody>
@@ -4490,7 +4507,7 @@
                 </a:solidFill>
                 <a:latin typeface="Calibri"/>
               </a:rPr>
-              <a:t>This is one division. Had I run it first, it would have shown that a working model was never the thing standing between us and the decision.</a:t>
+              <a:t>The recommendation does not change; the reason for it gets one layer deeper. This is the same finding as slide 11, applied to a spending decision instead of an investigation.</a:t>
             </a:r>
           </a:p>
         </p:txBody>
@@ -4542,7 +4559,7 @@
                 </a:solidFill>
                 <a:latin typeface="Calibri"/>
               </a:rPr>
-              <a:t>PART 4 · TESTING APPROACH</a:t>
+              <a:t>PART 4 · RECOMMENDATION 3</a:t>
             </a:r>
           </a:p>
           <a:p>
@@ -4554,11 +4571,11 @@
             <a:r>
               <a:rPr sz="2800" b="1" i="0">
                 <a:solidFill>
-                  <a:srgbClr val="1A1A1A"/>
-                </a:solidFill>
-                <a:latin typeface="Calibri"/>
-              </a:rPr>
-              <a:t>How I would test this, and what is worth testing</a:t>
+                  <a:srgbClr val="1E7A4B"/>
+                </a:solidFill>
+                <a:latin typeface="Calibri"/>
+              </a:rPr>
+              <a:t>Call every at-risk customer, do not rank them</a:t>
             </a:r>
           </a:p>
         </p:txBody>
@@ -4609,7 +4626,7 @@
       </p:sp>
       <p:pic>
         <p:nvPicPr>
-          <p:cNvPr id="4" name="Picture 3" descr="15_experiment_power.png"/>
+          <p:cNvPr id="4" name="Picture 3" descr="15_breakeven_grid.png"/>
           <p:cNvPicPr>
             <a:picLocks noChangeAspect="1"/>
           </p:cNvPicPr>
@@ -4623,8 +4640,8 @@
         </p:blipFill>
         <p:spPr>
           <a:xfrm>
-            <a:off x="6492240" y="1737360"/>
-            <a:ext cx="5344328" cy="2926080"/>
+            <a:off x="3492925" y="1645920"/>
+            <a:ext cx="5205845" cy="3017520"/>
           </a:xfrm>
           <a:prstGeom prst="rect">
             <a:avLst/>
@@ -4639,8 +4656,8 @@
         </p:nvSpPr>
         <p:spPr>
           <a:xfrm>
-            <a:off x="685800" y="1719072"/>
-            <a:ext cx="5486400" cy="4572000"/>
+            <a:off x="685800" y="4846320"/>
+            <a:ext cx="10820095" cy="4572000"/>
           </a:xfrm>
           <a:prstGeom prst="rect">
             <a:avLst/>
@@ -4659,157 +4676,29 @@
               </a:spcAft>
             </a:pPr>
             <a:r>
-              <a:rPr sz="1400" b="1" i="0">
+              <a:rPr sz="1300" b="1" i="0">
                 <a:solidFill>
                   <a:srgbClr val="1A1A1A"/>
                 </a:solidFill>
                 <a:latin typeface="Calibri"/>
               </a:rPr>
-              <a:t>Recommendation 1 is not an experiment. It is a data request.</a:t>
-            </a:r>
-          </a:p>
-          <a:p>
-            <a:pPr lvl="1">
+              <a:t>A call costs about $150. A customer is worth about $7,300. If the call works one time in five, it pays for itself on any customer with more than a 10% chance of leaving. In this group, 31% leave.</a:t>
+            </a:r>
+          </a:p>
+          <a:p>
+            <a:pPr>
               <a:spcAft>
                 <a:spcPts val="900"/>
               </a:spcAft>
             </a:pPr>
             <a:r>
-              <a:rPr sz="1200" b="0" i="0">
-                <a:solidFill>
-                  <a:srgbClr val="5A6270"/>
-                </a:solidFill>
-                <a:latin typeface="Calibri"/>
-              </a:rPr>
-              <a:t>Nothing in this extract can say why customers leave, because the timestamps were never recorded against the customers they belong to. Ask for an export where they are, then rerun this pipeline and compare against the score written down today.</a:t>
-            </a:r>
-          </a:p>
-          <a:p>
-            <a:pPr>
-              <a:spcAft>
-                <a:spcPts val="900"/>
-              </a:spcAft>
-            </a:pPr>
-            <a:r>
-              <a:rPr sz="600" b="0" i="0">
-                <a:solidFill>
-                  <a:srgbClr val="1A1A1A"/>
-                </a:solidFill>
-                <a:latin typeface="Calibri"/>
-              </a:rPr>
-              <a:t> </a:t>
-            </a:r>
-          </a:p>
-          <a:p>
-            <a:pPr>
-              <a:spcAft>
-                <a:spcPts val="900"/>
-              </a:spcAft>
-            </a:pPr>
-            <a:r>
-              <a:rPr sz="1400" b="1" i="0">
-                <a:solidFill>
-                  <a:srgbClr val="1A1A1A"/>
-                </a:solidFill>
-                <a:latin typeface="Calibri"/>
-              </a:rPr>
-              <a:t>Recommendation 3 is a proper experiment.</a:t>
-            </a:r>
-          </a:p>
-          <a:p>
-            <a:pPr lvl="1">
-              <a:spcAft>
-                <a:spcPts val="900"/>
-              </a:spcAft>
-            </a:pPr>
-            <a:r>
-              <a:rPr sz="1200" b="0" i="0">
-                <a:solidFill>
-                  <a:srgbClr val="5A6270"/>
-                </a:solidFill>
-                <a:latin typeface="Calibri"/>
-              </a:rPr>
-              <a:t>Split the at-risk customers in half at random. One half gets a call, one half does not. Measure retention after 180 days, and measure money kept as well, so a costly save is not mistaken for a win.</a:t>
-            </a:r>
-          </a:p>
-          <a:p>
-            <a:pPr>
-              <a:spcAft>
-                <a:spcPts val="900"/>
-              </a:spcAft>
-            </a:pPr>
-            <a:r>
-              <a:rPr sz="600" b="0" i="0">
-                <a:solidFill>
-                  <a:srgbClr val="1A1A1A"/>
-                </a:solidFill>
-                <a:latin typeface="Calibri"/>
-              </a:rPr>
-              <a:t> </a:t>
-            </a:r>
-          </a:p>
-          <a:p>
-            <a:pPr>
-              <a:spcAft>
-                <a:spcPts val="900"/>
-              </a:spcAft>
-            </a:pPr>
-            <a:r>
-              <a:rPr sz="1400" b="1" i="0">
-                <a:solidFill>
-                  <a:srgbClr val="B02E2E"/>
-                </a:solidFill>
-                <a:latin typeface="Calibri"/>
-              </a:rPr>
-              <a:t>But be realistic about what we can detect.</a:t>
-            </a:r>
-          </a:p>
-          <a:p>
-            <a:pPr lvl="1">
-              <a:spcAft>
-                <a:spcPts val="900"/>
-              </a:spcAft>
-            </a:pPr>
-            <a:r>
-              <a:rPr sz="1200" b="0" i="0">
-                <a:solidFill>
-                  <a:srgbClr val="5A6270"/>
-                </a:solidFill>
-                <a:latin typeface="Calibri"/>
-              </a:rPr>
-              <a:t>At about 21 new customers a month, only a very large effect can be proved:</a:t>
-            </a:r>
-          </a:p>
-          <a:p>
-            <a:pPr lvl="1">
-              <a:spcAft>
-                <a:spcPts val="900"/>
-              </a:spcAft>
-            </a:pPr>
-            <a:r>
-              <a:rPr sz="1200" b="0" i="0">
-                <a:solidFill>
-                  <a:srgbClr val="5A6270"/>
-                </a:solidFill>
-                <a:latin typeface="Calibri"/>
-              </a:rPr>
-              <a:t>Halving churn takes about 15 months to show.</a:t>
-            </a:r>
-          </a:p>
-          <a:p>
-            <a:pPr lvl="1">
-              <a:spcAft>
-                <a:spcPts val="900"/>
-              </a:spcAft>
-            </a:pPr>
-            <a:r>
-              <a:rPr sz="1200" b="0" i="0">
-                <a:solidFill>
-                  <a:srgbClr val="5A6270"/>
-                </a:solidFill>
-                <a:latin typeface="Calibri"/>
-              </a:rPr>
-              <a:t>A 5 point improvement would take over 10 years.</a:t>
+              <a:rPr sz="1300" b="1" i="0">
+                <a:solidFill>
+                  <a:srgbClr val="1E7A4B"/>
+                </a:solidFill>
+                <a:latin typeface="Calibri"/>
+              </a:rPr>
+              <a:t>So calling everyone already makes money, and no ranking can improve on a decision that is right for every customer. Using the model adds $600 on top of $52,400. That is a 1% gain, and even that is generous.</a:t>
             </a:r>
           </a:p>
         </p:txBody>
@@ -4843,7 +4732,7 @@
                 </a:solidFill>
                 <a:latin typeface="Calibri"/>
               </a:rPr>
-              <a:t>Two separate methods agree on this. A standard power calculation and a simulation both say we cannot detect anything smaller than about a 15 point change.</a:t>
+              <a:t>This is one division. Had I run it first, it would have shown that a working model was never the thing standing between us and the decision.</a:t>
             </a:r>
           </a:p>
         </p:txBody>
@@ -4895,7 +4784,7 @@
                 </a:solidFill>
                 <a:latin typeface="Calibri"/>
               </a:rPr>
-              <a:t>PART 5 · MENTORSHIP</a:t>
+              <a:t>PART 4 · TESTING APPROACH</a:t>
             </a:r>
           </a:p>
           <a:p>
@@ -4911,7 +4800,7 @@
                 </a:solidFill>
                 <a:latin typeface="Calibri"/>
               </a:rPr>
-              <a:t>What I would teach a junior engineer</a:t>
+              <a:t>How I would test this, and what is worth testing</a:t>
             </a:r>
           </a:p>
         </p:txBody>
@@ -4960,16 +4849,40 @@
           </a:p>
         </p:txBody>
       </p:sp>
-      <p:sp>
-        <p:nvSpPr>
-          <p:cNvPr id="4" name="TextBox 3"/>
+      <p:pic>
+        <p:nvPicPr>
+          <p:cNvPr id="4" name="Picture 3" descr="15_experiment_power.png"/>
+          <p:cNvPicPr>
+            <a:picLocks noChangeAspect="1"/>
+          </p:cNvPicPr>
+          <p:nvPr/>
+        </p:nvPicPr>
+        <p:blipFill>
+          <a:blip r:embed="rId2"/>
+          <a:stretch>
+            <a:fillRect/>
+          </a:stretch>
+        </p:blipFill>
+        <p:spPr>
+          <a:xfrm>
+            <a:off x="6492240" y="1737360"/>
+            <a:ext cx="5344328" cy="2926080"/>
+          </a:xfrm>
+          <a:prstGeom prst="rect">
+            <a:avLst/>
+          </a:prstGeom>
+        </p:spPr>
+      </p:pic>
+      <p:sp>
+        <p:nvSpPr>
+          <p:cNvPr id="5" name="TextBox 4"/>
           <p:cNvSpPr txBox="1"/>
           <p:nvPr/>
         </p:nvSpPr>
         <p:spPr>
           <a:xfrm>
             <a:off x="685800" y="1719072"/>
-            <a:ext cx="10820095" cy="4572000"/>
+            <a:ext cx="5486400" cy="4572000"/>
           </a:xfrm>
           <a:prstGeom prst="rect">
             <a:avLst/>
@@ -4984,23 +4897,39 @@
           <a:p>
             <a:pPr>
               <a:spcAft>
-                <a:spcPts val="400"/>
-              </a:spcAft>
-            </a:pPr>
-            <a:r>
-              <a:rPr sz="1300" b="1" i="0">
+                <a:spcPts val="900"/>
+              </a:spcAft>
+            </a:pPr>
+            <a:r>
+              <a:rPr sz="1400" b="1" i="0">
                 <a:solidFill>
                   <a:srgbClr val="1A1A1A"/>
                 </a:solidFill>
                 <a:latin typeface="Calibri"/>
               </a:rPr>
-              <a:t>I would hand them my own worst mistake on this project, because that is where the judgement that transfers to other work lives.</a:t>
-            </a:r>
-          </a:p>
-          <a:p>
-            <a:pPr>
-              <a:spcAft>
-                <a:spcPts val="400"/>
+              <a:t>Recommendation 1 is not an experiment. It is a data request.</a:t>
+            </a:r>
+          </a:p>
+          <a:p>
+            <a:pPr lvl="1">
+              <a:spcAft>
+                <a:spcPts val="900"/>
+              </a:spcAft>
+            </a:pPr>
+            <a:r>
+              <a:rPr sz="1200" b="0" i="0">
+                <a:solidFill>
+                  <a:srgbClr val="5A6270"/>
+                </a:solidFill>
+                <a:latin typeface="Calibri"/>
+              </a:rPr>
+              <a:t>Nothing in this extract can say why customers leave, because the timestamps were never recorded against the customers they belong to. Ask for an export where they are, then rerun this pipeline and compare against the score written down today.</a:t>
+            </a:r>
+          </a:p>
+          <a:p>
+            <a:pPr>
+              <a:spcAft>
+                <a:spcPts val="900"/>
               </a:spcAft>
             </a:pPr>
             <a:r>
@@ -5016,200 +4945,120 @@
           <a:p>
             <a:pPr>
               <a:spcAft>
-                <a:spcPts val="400"/>
-              </a:spcAft>
-            </a:pPr>
-            <a:r>
-              <a:rPr sz="1300" b="1" i="0">
+                <a:spcPts val="900"/>
+              </a:spcAft>
+            </a:pPr>
+            <a:r>
+              <a:rPr sz="1400" b="1" i="0">
+                <a:solidFill>
+                  <a:srgbClr val="1A1A1A"/>
+                </a:solidFill>
+                <a:latin typeface="Calibri"/>
+              </a:rPr>
+              <a:t>Recommendation 3 is a proper experiment.</a:t>
+            </a:r>
+          </a:p>
+          <a:p>
+            <a:pPr lvl="1">
+              <a:spcAft>
+                <a:spcPts val="900"/>
+              </a:spcAft>
+            </a:pPr>
+            <a:r>
+              <a:rPr sz="1200" b="0" i="0">
+                <a:solidFill>
+                  <a:srgbClr val="5A6270"/>
+                </a:solidFill>
+                <a:latin typeface="Calibri"/>
+              </a:rPr>
+              <a:t>Split the at-risk customers in half at random. One half gets a call, one half does not. Measure retention after 180 days, and measure money kept as well, so a costly save is not mistaken for a win.</a:t>
+            </a:r>
+          </a:p>
+          <a:p>
+            <a:pPr>
+              <a:spcAft>
+                <a:spcPts val="900"/>
+              </a:spcAft>
+            </a:pPr>
+            <a:r>
+              <a:rPr sz="600" b="0" i="0">
+                <a:solidFill>
+                  <a:srgbClr val="1A1A1A"/>
+                </a:solidFill>
+                <a:latin typeface="Calibri"/>
+              </a:rPr>
+              <a:t> </a:t>
+            </a:r>
+          </a:p>
+          <a:p>
+            <a:pPr>
+              <a:spcAft>
+                <a:spcPts val="900"/>
+              </a:spcAft>
+            </a:pPr>
+            <a:r>
+              <a:rPr sz="1400" b="1" i="0">
                 <a:solidFill>
                   <a:srgbClr val="B02E2E"/>
                 </a:solidFill>
                 <a:latin typeface="Calibri"/>
               </a:rPr>
-              <a:t>1. Be hardest on the finding you like.</a:t>
+              <a:t>But be realistic about what we can detect.</a:t>
             </a:r>
           </a:p>
           <a:p>
             <a:pPr lvl="1">
               <a:spcAft>
-                <a:spcPts val="400"/>
-              </a:spcAft>
-            </a:pPr>
-            <a:r>
-              <a:rPr sz="1100" b="0" i="0">
+                <a:spcPts val="900"/>
+              </a:spcAft>
+            </a:pPr>
+            <a:r>
+              <a:rPr sz="1200" b="0" i="0">
                 <a:solidFill>
                   <a:srgbClr val="5A6270"/>
                 </a:solidFill>
                 <a:latin typeface="Calibri"/>
               </a:rPr>
-              <a:t>I had one positive result and a page of nulls, and I checked the nulls. The positive one was manufactured by the file. Ask of any finding: what else could have produced this, and can I generate it from nothing?</a:t>
-            </a:r>
-          </a:p>
-          <a:p>
-            <a:pPr>
-              <a:spcAft>
-                <a:spcPts val="400"/>
-              </a:spcAft>
-            </a:pPr>
-            <a:r>
-              <a:rPr sz="1300" b="1" i="0">
-                <a:solidFill>
-                  <a:srgbClr val="B02E2E"/>
-                </a:solidFill>
-                <a:latin typeface="Calibri"/>
-              </a:rPr>
-              <a:t>2. A small p-value is not evidence. It is evidence against one null.</a:t>
+              <a:t>At about 21 new customers a month, only a very large effect can be proved:</a:t>
             </a:r>
           </a:p>
           <a:p>
             <a:pPr lvl="1">
               <a:spcAft>
-                <a:spcPts val="400"/>
-              </a:spcAft>
-            </a:pPr>
-            <a:r>
-              <a:rPr sz="1100" b="0" i="0">
+                <a:spcPts val="900"/>
+              </a:spcAft>
+            </a:pPr>
+            <a:r>
+              <a:rPr sz="1200" b="0" i="0">
                 <a:solidFill>
                   <a:srgbClr val="5A6270"/>
                 </a:solidFill>
                 <a:latin typeface="Calibri"/>
               </a:rPr>
-              <a:t>p = 2e-16 felt unarguable. Random dates gave p = 3e-16. If the null is the wrong one, no amount of significance rescues it.</a:t>
-            </a:r>
-          </a:p>
-          <a:p>
-            <a:pPr>
-              <a:spcAft>
-                <a:spcPts val="400"/>
-              </a:spcAft>
-            </a:pPr>
-            <a:r>
-              <a:rPr sz="1300" b="1" i="0">
-                <a:solidFill>
-                  <a:srgbClr val="1A1A1A"/>
-                </a:solidFill>
-                <a:latin typeface="Calibri"/>
-              </a:rPr>
-              <a:t>3. Start with the target, not the model.</a:t>
+              <a:t>Halving churn takes about 15 months to show.</a:t>
             </a:r>
           </a:p>
           <a:p>
             <a:pPr lvl="1">
               <a:spcAft>
-                <a:spcPts val="400"/>
-              </a:spcAft>
-            </a:pPr>
-            <a:r>
-              <a:rPr sz="1100" b="0" i="0">
+                <a:spcPts val="900"/>
+              </a:spcAft>
+            </a:pPr>
+            <a:r>
+              <a:rPr sz="1200" b="0" i="0">
                 <a:solidFill>
                   <a:srgbClr val="5A6270"/>
                 </a:solidFill>
                 <a:latin typeface="Calibri"/>
               </a:rPr>
-              <a:t>My first version modelled a flag unrelated to the event log. Counting rows found it. Then check your own check: I first called 38% agreement ‘worse than a coin flip’, and it is not — for two columns this different in size, chance agreement is 39%, not 50%.</a:t>
-            </a:r>
-          </a:p>
-          <a:p>
-            <a:pPr>
-              <a:spcAft>
-                <a:spcPts val="400"/>
-              </a:spcAft>
-            </a:pPr>
-            <a:r>
-              <a:rPr sz="1300" b="1" i="0">
-                <a:solidFill>
-                  <a:srgbClr val="1A1A1A"/>
-                </a:solidFill>
-                <a:latin typeface="Calibri"/>
-              </a:rPr>
-              <a:t>4. Ask of every column: would I really have this on the day I predict?</a:t>
-            </a:r>
-          </a:p>
-          <a:p>
-            <a:pPr lvl="1">
-              <a:spcAft>
-                <a:spcPts val="400"/>
-              </a:spcAft>
-            </a:pPr>
-            <a:r>
-              <a:rPr sz="1100" b="0" i="0">
-                <a:solidFill>
-                  <a:srgbClr val="5A6270"/>
-                </a:solidFill>
-                <a:latin typeface="Calibri"/>
-              </a:rPr>
-              <a:t>Then write the check down so a machine runs it. Reading caught the obvious problem; the automatic check caught the one I missed.</a:t>
-            </a:r>
-          </a:p>
-          <a:p>
-            <a:pPr>
-              <a:spcAft>
-                <a:spcPts val="400"/>
-              </a:spcAft>
-            </a:pPr>
-            <a:r>
-              <a:rPr sz="1300" b="1" i="0">
-                <a:solidFill>
-                  <a:srgbClr val="1A1A1A"/>
-                </a:solidFill>
-                <a:latin typeface="Calibri"/>
-              </a:rPr>
-              <a:t>5. Find the floor, and report the range.</a:t>
-            </a:r>
-          </a:p>
-          <a:p>
-            <a:pPr lvl="1">
-              <a:spcAft>
-                <a:spcPts val="400"/>
-              </a:spcAft>
-            </a:pPr>
-            <a:r>
-              <a:rPr sz="1100" b="0" i="0">
-                <a:solidFill>
-                  <a:srgbClr val="5A6270"/>
-                </a:solidFill>
-                <a:latin typeface="Calibri"/>
-              </a:rPr>
-              <a:t>Always run the model with no features first. A range that includes guessing says something the average hides.</a:t>
-            </a:r>
-          </a:p>
-          <a:p>
-            <a:pPr>
-              <a:spcAft>
-                <a:spcPts val="400"/>
-              </a:spcAft>
-            </a:pPr>
-            <a:r>
-              <a:rPr sz="1300" b="1" i="0">
-                <a:solidFill>
-                  <a:srgbClr val="2E5F8A"/>
-                </a:solidFill>
-                <a:latin typeface="Calibri"/>
-              </a:rPr>
-              <a:t>6. Choosing a model is part of fitting it.</a:t>
-            </a:r>
-          </a:p>
-          <a:p>
-            <a:pPr lvl="1">
-              <a:spcAft>
-                <a:spcPts val="400"/>
-              </a:spcAft>
-            </a:pPr>
-            <a:r>
-              <a:rPr sz="1100" b="0" i="0">
-                <a:solidFill>
-                  <a:srgbClr val="5A6270"/>
-                </a:solidFill>
-                <a:latin typeface="Calibri"/>
-              </a:rPr>
-              <a:t>Here the gap between the best model and the honest score was the entire apparent signal.</a:t>
-            </a:r>
-          </a:p>
-        </p:txBody>
-      </p:sp>
-      <p:sp>
-        <p:nvSpPr>
-          <p:cNvPr id="5" name="TextBox 4"/>
+              <a:t>A 5 point improvement would take over 10 years.</a:t>
+            </a:r>
+          </a:p>
+        </p:txBody>
+      </p:sp>
+      <p:sp>
+        <p:nvSpPr>
+          <p:cNvPr id="6" name="TextBox 5"/>
           <p:cNvSpPr txBox="1"/>
           <p:nvPr/>
         </p:nvSpPr>
@@ -5236,7 +5085,7 @@
                 </a:solidFill>
                 <a:latin typeface="Calibri"/>
               </a:rPr>
-              <a:t>I would teach all of it as experiments rather than lectures. Switch off the banned column list and watch AUC jump from 0.58 to 0.79. Then simulate a dataset with nothing in it and watch it produce a publishable-looking trend.</a:t>
+              <a:t>Two separate methods agree on this. A standard power calculation and a simulation both say we cannot detect anything smaller than about a 15 point change.</a:t>
             </a:r>
           </a:p>
         </p:txBody>
@@ -5288,6 +5137,399 @@
                 </a:solidFill>
                 <a:latin typeface="Calibri"/>
               </a:rPr>
+              <a:t>PART 5 · MENTORSHIP</a:t>
+            </a:r>
+          </a:p>
+          <a:p>
+            <a:pPr>
+              <a:spcBef>
+                <a:spcPts val="400"/>
+              </a:spcBef>
+            </a:pPr>
+            <a:r>
+              <a:rPr sz="2800" b="1" i="0">
+                <a:solidFill>
+                  <a:srgbClr val="1A1A1A"/>
+                </a:solidFill>
+                <a:latin typeface="Calibri"/>
+              </a:rPr>
+              <a:t>What I would teach a junior engineer</a:t>
+            </a:r>
+          </a:p>
+        </p:txBody>
+      </p:sp>
+      <p:sp>
+        <p:nvSpPr>
+          <p:cNvPr id="3" name="Rectangle 2"/>
+          <p:cNvSpPr/>
+          <p:nvPr/>
+        </p:nvSpPr>
+        <p:spPr>
+          <a:xfrm>
+            <a:off x="685800" y="1426464"/>
+            <a:ext cx="10820095" cy="9525"/>
+          </a:xfrm>
+          <a:prstGeom prst="rect">
+            <a:avLst/>
+          </a:prstGeom>
+          <a:solidFill>
+            <a:srgbClr val="D8DCE0"/>
+          </a:solidFill>
+          <a:ln>
+            <a:noFill/>
+          </a:ln>
+          <a:effectLst/>
+        </p:spPr>
+        <p:style>
+          <a:lnRef idx="1">
+            <a:schemeClr val="accent1"/>
+          </a:lnRef>
+          <a:fillRef idx="3">
+            <a:schemeClr val="accent1"/>
+          </a:fillRef>
+          <a:effectRef idx="2">
+            <a:schemeClr val="accent1"/>
+          </a:effectRef>
+          <a:fontRef idx="minor">
+            <a:schemeClr val="lt1"/>
+          </a:fontRef>
+        </p:style>
+        <p:txBody>
+          <a:bodyPr rtlCol="0" anchor="ctr"/>
+          <a:lstStyle/>
+          <a:p>
+            <a:pPr algn="ctr"/>
+          </a:p>
+        </p:txBody>
+      </p:sp>
+      <p:sp>
+        <p:nvSpPr>
+          <p:cNvPr id="4" name="TextBox 3"/>
+          <p:cNvSpPr txBox="1"/>
+          <p:nvPr/>
+        </p:nvSpPr>
+        <p:spPr>
+          <a:xfrm>
+            <a:off x="685800" y="1719072"/>
+            <a:ext cx="10820095" cy="4572000"/>
+          </a:xfrm>
+          <a:prstGeom prst="rect">
+            <a:avLst/>
+          </a:prstGeom>
+          <a:noFill/>
+        </p:spPr>
+        <p:txBody>
+          <a:bodyPr wrap="square">
+            <a:spAutoFit/>
+          </a:bodyPr>
+          <a:lstStyle/>
+          <a:p>
+            <a:pPr>
+              <a:spcAft>
+                <a:spcPts val="400"/>
+              </a:spcAft>
+            </a:pPr>
+            <a:r>
+              <a:rPr sz="1300" b="1" i="0">
+                <a:solidFill>
+                  <a:srgbClr val="1A1A1A"/>
+                </a:solidFill>
+                <a:latin typeface="Calibri"/>
+              </a:rPr>
+              <a:t>I would hand them my own worst mistake on this project, because that is where the judgement that transfers to other work lives.</a:t>
+            </a:r>
+          </a:p>
+          <a:p>
+            <a:pPr>
+              <a:spcAft>
+                <a:spcPts val="400"/>
+              </a:spcAft>
+            </a:pPr>
+            <a:r>
+              <a:rPr sz="600" b="0" i="0">
+                <a:solidFill>
+                  <a:srgbClr val="1A1A1A"/>
+                </a:solidFill>
+                <a:latin typeface="Calibri"/>
+              </a:rPr>
+              <a:t> </a:t>
+            </a:r>
+          </a:p>
+          <a:p>
+            <a:pPr>
+              <a:spcAft>
+                <a:spcPts val="400"/>
+              </a:spcAft>
+            </a:pPr>
+            <a:r>
+              <a:rPr sz="1300" b="1" i="0">
+                <a:solidFill>
+                  <a:srgbClr val="B02E2E"/>
+                </a:solidFill>
+                <a:latin typeface="Calibri"/>
+              </a:rPr>
+              <a:t>1. Be hardest on the finding you like.</a:t>
+            </a:r>
+          </a:p>
+          <a:p>
+            <a:pPr lvl="1">
+              <a:spcAft>
+                <a:spcPts val="400"/>
+              </a:spcAft>
+            </a:pPr>
+            <a:r>
+              <a:rPr sz="1100" b="0" i="0">
+                <a:solidFill>
+                  <a:srgbClr val="5A6270"/>
+                </a:solidFill>
+                <a:latin typeface="Calibri"/>
+              </a:rPr>
+              <a:t>I had one positive result and a page of nulls, and I checked the nulls. The positive one was manufactured by the file. Ask of any finding: what else could have produced this, and can I generate it from nothing?</a:t>
+            </a:r>
+          </a:p>
+          <a:p>
+            <a:pPr>
+              <a:spcAft>
+                <a:spcPts val="400"/>
+              </a:spcAft>
+            </a:pPr>
+            <a:r>
+              <a:rPr sz="1300" b="1" i="0">
+                <a:solidFill>
+                  <a:srgbClr val="B02E2E"/>
+                </a:solidFill>
+                <a:latin typeface="Calibri"/>
+              </a:rPr>
+              <a:t>2. A small p-value is not evidence. It is evidence against one null.</a:t>
+            </a:r>
+          </a:p>
+          <a:p>
+            <a:pPr lvl="1">
+              <a:spcAft>
+                <a:spcPts val="400"/>
+              </a:spcAft>
+            </a:pPr>
+            <a:r>
+              <a:rPr sz="1100" b="0" i="0">
+                <a:solidFill>
+                  <a:srgbClr val="5A6270"/>
+                </a:solidFill>
+                <a:latin typeface="Calibri"/>
+              </a:rPr>
+              <a:t>p = 2e-16 felt unarguable. Random dates gave p = 3e-16. If the null is the wrong one, no amount of significance rescues it.</a:t>
+            </a:r>
+          </a:p>
+          <a:p>
+            <a:pPr>
+              <a:spcAft>
+                <a:spcPts val="400"/>
+              </a:spcAft>
+            </a:pPr>
+            <a:r>
+              <a:rPr sz="1300" b="1" i="0">
+                <a:solidFill>
+                  <a:srgbClr val="1A1A1A"/>
+                </a:solidFill>
+                <a:latin typeface="Calibri"/>
+              </a:rPr>
+              <a:t>3. Start with the target, not the model.</a:t>
+            </a:r>
+          </a:p>
+          <a:p>
+            <a:pPr lvl="1">
+              <a:spcAft>
+                <a:spcPts val="400"/>
+              </a:spcAft>
+            </a:pPr>
+            <a:r>
+              <a:rPr sz="1100" b="0" i="0">
+                <a:solidFill>
+                  <a:srgbClr val="5A6270"/>
+                </a:solidFill>
+                <a:latin typeface="Calibri"/>
+              </a:rPr>
+              <a:t>My first version modelled a flag unrelated to the event log. Counting rows found it. Then check your own check: I first called 38% agreement ‘worse than a coin flip’, and it is not — for two columns this different in size, chance agreement is 39%, not 50%.</a:t>
+            </a:r>
+          </a:p>
+          <a:p>
+            <a:pPr>
+              <a:spcAft>
+                <a:spcPts val="400"/>
+              </a:spcAft>
+            </a:pPr>
+            <a:r>
+              <a:rPr sz="1300" b="1" i="0">
+                <a:solidFill>
+                  <a:srgbClr val="1A1A1A"/>
+                </a:solidFill>
+                <a:latin typeface="Calibri"/>
+              </a:rPr>
+              <a:t>4. Ask of every column: would I really have this on the day I predict?</a:t>
+            </a:r>
+          </a:p>
+          <a:p>
+            <a:pPr lvl="1">
+              <a:spcAft>
+                <a:spcPts val="400"/>
+              </a:spcAft>
+            </a:pPr>
+            <a:r>
+              <a:rPr sz="1100" b="0" i="0">
+                <a:solidFill>
+                  <a:srgbClr val="5A6270"/>
+                </a:solidFill>
+                <a:latin typeface="Calibri"/>
+              </a:rPr>
+              <a:t>Then write the check down so a machine runs it. Reading caught the obvious problem; the automatic check caught the one I missed.</a:t>
+            </a:r>
+          </a:p>
+          <a:p>
+            <a:pPr>
+              <a:spcAft>
+                <a:spcPts val="400"/>
+              </a:spcAft>
+            </a:pPr>
+            <a:r>
+              <a:rPr sz="1300" b="1" i="0">
+                <a:solidFill>
+                  <a:srgbClr val="1A1A1A"/>
+                </a:solidFill>
+                <a:latin typeface="Calibri"/>
+              </a:rPr>
+              <a:t>5. Find the floor, and report the range.</a:t>
+            </a:r>
+          </a:p>
+          <a:p>
+            <a:pPr lvl="1">
+              <a:spcAft>
+                <a:spcPts val="400"/>
+              </a:spcAft>
+            </a:pPr>
+            <a:r>
+              <a:rPr sz="1100" b="0" i="0">
+                <a:solidFill>
+                  <a:srgbClr val="5A6270"/>
+                </a:solidFill>
+                <a:latin typeface="Calibri"/>
+              </a:rPr>
+              <a:t>Always run the model with no features first. A range that includes guessing says something the average hides.</a:t>
+            </a:r>
+          </a:p>
+          <a:p>
+            <a:pPr>
+              <a:spcAft>
+                <a:spcPts val="400"/>
+              </a:spcAft>
+            </a:pPr>
+            <a:r>
+              <a:rPr sz="1300" b="1" i="0">
+                <a:solidFill>
+                  <a:srgbClr val="2E5F8A"/>
+                </a:solidFill>
+                <a:latin typeface="Calibri"/>
+              </a:rPr>
+              <a:t>6. Choosing a model is part of fitting it.</a:t>
+            </a:r>
+          </a:p>
+          <a:p>
+            <a:pPr lvl="1">
+              <a:spcAft>
+                <a:spcPts val="400"/>
+              </a:spcAft>
+            </a:pPr>
+            <a:r>
+              <a:rPr sz="1100" b="0" i="0">
+                <a:solidFill>
+                  <a:srgbClr val="5A6270"/>
+                </a:solidFill>
+                <a:latin typeface="Calibri"/>
+              </a:rPr>
+              <a:t>Here the gap between the best model and the honest score was the entire apparent signal.</a:t>
+            </a:r>
+          </a:p>
+        </p:txBody>
+      </p:sp>
+      <p:sp>
+        <p:nvSpPr>
+          <p:cNvPr id="5" name="TextBox 4"/>
+          <p:cNvSpPr txBox="1"/>
+          <p:nvPr/>
+        </p:nvSpPr>
+        <p:spPr>
+          <a:xfrm>
+            <a:off x="685800" y="6126480"/>
+            <a:ext cx="10820095" cy="502920"/>
+          </a:xfrm>
+          <a:prstGeom prst="rect">
+            <a:avLst/>
+          </a:prstGeom>
+          <a:noFill/>
+        </p:spPr>
+        <p:txBody>
+          <a:bodyPr wrap="square">
+            <a:spAutoFit/>
+          </a:bodyPr>
+          <a:lstStyle/>
+          <a:p>
+            <a:r>
+              <a:rPr sz="1150" b="0" i="1">
+                <a:solidFill>
+                  <a:srgbClr val="5A6270"/>
+                </a:solidFill>
+                <a:latin typeface="Calibri"/>
+              </a:rPr>
+              <a:t>I would teach all of it as experiments rather than lectures. Switch off the banned column list and watch AUC jump from 0.58 to 0.79. Then simulate a dataset with nothing in it and watch it produce a publishable-looking trend.</a:t>
+            </a:r>
+          </a:p>
+        </p:txBody>
+      </p:sp>
+    </p:spTree>
+  </p:cSld>
+  <p:clrMapOvr>
+    <a:masterClrMapping/>
+  </p:clrMapOvr>
+</p:sld>
+</file>
+
+<file path=ppt/slides/slide16.xml><?xml version="1.0" encoding="utf-8"?>
+<p:sld xmlns:a="http://schemas.openxmlformats.org/drawingml/2006/main" xmlns:p="http://schemas.openxmlformats.org/presentationml/2006/main" xmlns:r="http://schemas.openxmlformats.org/officeDocument/2006/relationships">
+  <p:cSld>
+    <p:spTree>
+      <p:nvGrpSpPr>
+        <p:cNvPr id="1" name=""/>
+        <p:cNvGrpSpPr/>
+        <p:nvPr/>
+      </p:nvGrpSpPr>
+      <p:grpSpPr/>
+      <p:sp>
+        <p:nvSpPr>
+          <p:cNvPr id="2" name="TextBox 1"/>
+          <p:cNvSpPr txBox="1"/>
+          <p:nvPr/>
+        </p:nvSpPr>
+        <p:spPr>
+          <a:xfrm>
+            <a:off x="685800" y="365760"/>
+            <a:ext cx="10820095" cy="1051560"/>
+          </a:xfrm>
+          <a:prstGeom prst="rect">
+            <a:avLst/>
+          </a:prstGeom>
+          <a:noFill/>
+        </p:spPr>
+        <p:txBody>
+          <a:bodyPr wrap="square">
+            <a:spAutoFit/>
+          </a:bodyPr>
+          <a:lstStyle/>
+          <a:p>
+            <a:r>
+              <a:rPr sz="1200" b="1" i="0">
+                <a:solidFill>
+                  <a:srgbClr val="5A6270"/>
+                </a:solidFill>
+                <a:latin typeface="Calibri"/>
+              </a:rPr>
               <a:t>PART 5 · SCALABILITY</a:t>
             </a:r>
           </a:p>
@@ -6875,7 +7117,7 @@
                 </a:solidFill>
                 <a:latin typeface="Calibri"/>
               </a:rPr>
-              <a:t>This is a generated dataset, so every finding is tested against a null that imitates the generator — including the findings I liked. Slide 10 is that test, and it is the one that changed the answer.</a:t>
+              <a:t>This is a generated dataset, so every finding is tested against a null that imitates the generator — including the findings I liked. Slide 11 is that test, and it is the one that changed the answer.</a:t>
             </a:r>
           </a:p>
         </p:txBody>
@@ -7645,16 +7887,40 @@
           </a:p>
         </p:txBody>
       </p:sp>
-      <p:sp>
-        <p:nvSpPr>
-          <p:cNvPr id="4" name="TextBox 3"/>
+      <p:pic>
+        <p:nvPicPr>
+          <p:cNvPr id="4" name="Picture 3" descr="09_selection_null.png"/>
+          <p:cNvPicPr>
+            <a:picLocks noChangeAspect="1"/>
+          </p:cNvPicPr>
+          <p:nvPr/>
+        </p:nvPicPr>
+        <p:blipFill>
+          <a:blip r:embed="rId2"/>
+          <a:stretch>
+            <a:fillRect/>
+          </a:stretch>
+        </p:blipFill>
+        <p:spPr>
+          <a:xfrm>
+            <a:off x="6812280" y="1783080"/>
+            <a:ext cx="4212139" cy="2331720"/>
+          </a:xfrm>
+          <a:prstGeom prst="rect">
+            <a:avLst/>
+          </a:prstGeom>
+        </p:spPr>
+      </p:pic>
+      <p:sp>
+        <p:nvSpPr>
+          <p:cNvPr id="5" name="TextBox 4"/>
           <p:cNvSpPr txBox="1"/>
           <p:nvPr/>
         </p:nvSpPr>
         <p:spPr>
           <a:xfrm>
-            <a:off x="685800" y="1719072"/>
-            <a:ext cx="10820095" cy="4572000"/>
+            <a:off x="685800" y="1783080"/>
+            <a:ext cx="5760720" cy="4572000"/>
           </a:xfrm>
           <a:prstGeom prst="rect">
             <a:avLst/>
@@ -7669,27 +7935,27 @@
           <a:p>
             <a:pPr>
               <a:spcAft>
-                <a:spcPts val="600"/>
-              </a:spcAft>
-            </a:pPr>
-            <a:r>
-              <a:rPr sz="1350" b="0" i="0">
+                <a:spcPts val="500"/>
+              </a:spcAft>
+            </a:pPr>
+            <a:r>
+              <a:rPr sz="1300" b="0" i="0">
                 <a:solidFill>
                   <a:srgbClr val="5A6270"/>
                 </a:solidFill>
                 <a:latin typeface="Calibri"/>
               </a:rPr>
-              <a:t>Best single model, taken at face value:  AUC 0.583, range 0.37 to 0.75</a:t>
-            </a:r>
-          </a:p>
-          <a:p>
-            <a:pPr>
-              <a:spcAft>
-                <a:spcPts val="600"/>
-              </a:spcAft>
-            </a:pPr>
-            <a:r>
-              <a:rPr sz="1350" b="1" i="0">
+              <a:t>Best single model, taken at face value:  AUC 0.583</a:t>
+            </a:r>
+          </a:p>
+          <a:p>
+            <a:pPr>
+              <a:spcAft>
+                <a:spcPts val="500"/>
+              </a:spcAft>
+            </a:pPr>
+            <a:r>
+              <a:rPr sz="1300" b="1" i="0">
                 <a:solidFill>
                   <a:srgbClr val="1A1A1A"/>
                 </a:solidFill>
@@ -7701,11 +7967,11 @@
           <a:p>
             <a:pPr>
               <a:spcAft>
-                <a:spcPts val="600"/>
-              </a:spcAft>
-            </a:pPr>
-            <a:r>
-              <a:rPr sz="1350" b="0" i="0">
+                <a:spcPts val="500"/>
+              </a:spcAft>
+            </a:pPr>
+            <a:r>
+              <a:rPr sz="1300" b="0" i="0">
                 <a:solidFill>
                   <a:srgbClr val="5A6270"/>
                 </a:solidFill>
@@ -7717,7 +7983,7 @@
           <a:p>
             <a:pPr>
               <a:spcAft>
-                <a:spcPts val="600"/>
+                <a:spcPts val="500"/>
               </a:spcAft>
             </a:pPr>
             <a:r>
@@ -7733,91 +7999,98 @@
           <a:p>
             <a:pPr>
               <a:spcAft>
-                <a:spcPts val="600"/>
-              </a:spcAft>
-            </a:pPr>
-            <a:r>
-              <a:rPr sz="1350" b="1" i="0">
+                <a:spcPts val="500"/>
+              </a:spcAft>
+            </a:pPr>
+            <a:r>
+              <a:rPr sz="1300" b="1" i="0">
                 <a:solidFill>
                   <a:srgbClr val="B02E2E"/>
                 </a:solidFill>
                 <a:latin typeface="Calibri"/>
               </a:rPr>
-              <a:t>The gap between those two numbers is the point.</a:t>
+              <a:t>Picking the best of ten models is itself a form of fitting.</a:t>
             </a:r>
           </a:p>
           <a:p>
             <a:pPr lvl="1">
               <a:spcAft>
-                <a:spcPts val="600"/>
-              </a:spcAft>
-            </a:pPr>
-            <a:r>
-              <a:rPr sz="1150" b="0" i="0">
+                <a:spcPts val="500"/>
+              </a:spcAft>
+            </a:pPr>
+            <a:r>
+              <a:rPr sz="1100" b="0" i="0">
                 <a:solidFill>
                   <a:srgbClr val="5A6270"/>
                 </a:solidFill>
                 <a:latin typeface="Calibri"/>
               </a:rPr>
-              <a:t>Picking the best of ten models is itself a form of fitting. Once you measure that properly, 0.049 of AUC disappears. That is most of what looked like signal.</a:t>
+              <a:t>Measure that properly and 0.049 of AUC disappears — most of what looked like signal. The chart is why: run the same ten-model search against shuffled labels and the whole distribution slides right, past our result.</a:t>
             </a:r>
           </a:p>
           <a:p>
             <a:pPr lvl="1">
               <a:spcAft>
-                <a:spcPts val="600"/>
-              </a:spcAft>
-            </a:pPr>
-            <a:r>
-              <a:rPr sz="1150" b="0" i="0">
+                <a:spcPts val="500"/>
+              </a:spcAft>
+            </a:pPr>
+            <a:r>
+              <a:rPr sz="1100" b="0" i="0">
                 <a:solidFill>
                   <a:srgbClr val="5A6270"/>
                 </a:solidFill>
                 <a:latin typeface="Calibri"/>
               </a:rPr>
-              <a:t>Across 25 test rounds, eight of the ten models won at least once. A genuinely better model wins nearly every time. Eight different winners is what noise looks like.</a:t>
-            </a:r>
-          </a:p>
-          <a:p>
-            <a:pPr>
-              <a:spcAft>
-                <a:spcPts val="600"/>
-              </a:spcAft>
-            </a:pPr>
-            <a:r>
-              <a:rPr sz="600" b="0" i="0">
+              <a:t>Across 25 rounds, eight of the ten models won at least once. A genuinely better model wins nearly every time.</a:t>
+            </a:r>
+          </a:p>
+        </p:txBody>
+      </p:sp>
+      <p:sp>
+        <p:nvSpPr>
+          <p:cNvPr id="6" name="TextBox 5"/>
+          <p:cNvSpPr txBox="1"/>
+          <p:nvPr/>
+        </p:nvSpPr>
+        <p:spPr>
+          <a:xfrm>
+            <a:off x="685800" y="4315968"/>
+            <a:ext cx="10820095" cy="4572000"/>
+          </a:xfrm>
+          <a:prstGeom prst="rect">
+            <a:avLst/>
+          </a:prstGeom>
+          <a:noFill/>
+        </p:spPr>
+        <p:txBody>
+          <a:bodyPr wrap="square">
+            <a:spAutoFit/>
+          </a:bodyPr>
+          <a:lstStyle/>
+          <a:p>
+            <a:pPr>
+              <a:spcAft>
+                <a:spcPts val="500"/>
+              </a:spcAft>
+            </a:pPr>
+            <a:r>
+              <a:rPr sz="1300" b="1" i="0">
                 <a:solidFill>
                   <a:srgbClr val="1A1A1A"/>
                 </a:solidFill>
                 <a:latin typeface="Calibri"/>
               </a:rPr>
-              <a:t> </a:t>
-            </a:r>
-          </a:p>
-          <a:p>
-            <a:pPr>
-              <a:spcAft>
-                <a:spcPts val="600"/>
-              </a:spcAft>
-            </a:pPr>
-            <a:r>
-              <a:rPr sz="1350" b="1" i="0">
-                <a:solidFill>
-                  <a:srgbClr val="1A1A1A"/>
-                </a:solidFill>
-                <a:latin typeface="Calibri"/>
-              </a:rPr>
               <a:t>Why the score is low. Each cause is measured, not guessed at.</a:t>
             </a:r>
           </a:p>
           <a:p>
             <a:pPr lvl="1">
               <a:spcAft>
-                <a:spcPts val="600"/>
-              </a:spcAft>
-            </a:pPr>
-            <a:r>
-              <a:rPr sz="1150" b="0" i="0">
+                <a:spcPts val="500"/>
+              </a:spcAft>
+            </a:pPr>
+            <a:r>
+              <a:rPr sz="1100" b="0" i="0">
                 <a:solidFill>
                   <a:srgbClr val="5A6270"/>
                 </a:solidFill>
@@ -7829,72 +8102,40 @@
           <a:p>
             <a:pPr lvl="1">
               <a:spcAft>
-                <a:spcPts val="600"/>
-              </a:spcAft>
-            </a:pPr>
-            <a:r>
-              <a:rPr sz="1150" b="0" i="0">
+                <a:spcPts val="500"/>
+              </a:spcAft>
+            </a:pPr>
+            <a:r>
+              <a:rPr sz="1100" b="0" i="0">
                 <a:solidFill>
                   <a:srgbClr val="5A6270"/>
                 </a:solidFill>
                 <a:latin typeface="Calibri"/>
               </a:rPr>
-              <a:t>The target is a random date. Every churn date is a coin toss between the day the customer joined and the last day of the file. Slide 10 is that test.</a:t>
+              <a:t>The target is a random date — a coin toss between the day the customer joined and the last day of the file. Slide 11 is that test. Subscriptions is the one table with real rules, and none of it relates to churn.</a:t>
             </a:r>
           </a:p>
           <a:p>
             <a:pPr lvl="1">
               <a:spcAft>
-                <a:spcPts val="600"/>
-              </a:spcAft>
-            </a:pPr>
-            <a:r>
-              <a:rPr sz="1150" b="0" i="0">
+                <a:spcPts val="500"/>
+              </a:spcAft>
+            </a:pPr>
+            <a:r>
+              <a:rPr sz="1100" b="0" i="0">
                 <a:solidFill>
                   <a:srgbClr val="5A6270"/>
                 </a:solidFill>
                 <a:latin typeface="Calibri"/>
               </a:rPr>
-              <a:t>Subscriptions is the one table with real rules, and none of it relates to churn.</a:t>
-            </a:r>
-          </a:p>
-          <a:p>
-            <a:pPr lvl="1">
-              <a:spcAft>
-                <a:spcPts val="600"/>
-              </a:spcAft>
-            </a:pPr>
-            <a:r>
-              <a:rPr sz="1150" b="0" i="0">
-                <a:solidFill>
-                  <a:srgbClr val="5A6270"/>
-                </a:solidFill>
-                <a:latin typeface="Calibri"/>
-              </a:rPr>
-              <a:t>Sample size is real but secondary: 54 churners against 73 features.</a:t>
-            </a:r>
-          </a:p>
-          <a:p>
-            <a:pPr lvl="1">
-              <a:spcAft>
-                <a:spcPts val="600"/>
-              </a:spcAft>
-            </a:pPr>
-            <a:r>
-              <a:rPr sz="1150" b="0" i="0">
-                <a:solidFill>
-                  <a:srgbClr val="5A6270"/>
-                </a:solidFill>
-                <a:latin typeface="Calibri"/>
-              </a:rPr>
-              <a:t>It is not leakage, not the feature build, and not tuning. I checked all three.</a:t>
-            </a:r>
-          </a:p>
-        </p:txBody>
-      </p:sp>
-      <p:sp>
-        <p:nvSpPr>
-          <p:cNvPr id="5" name="TextBox 4"/>
+              <a:t>Sample size is real but secondary: 54 churners against 73 features. It is not leakage, not the feature build, and not tuning. I checked all three.</a:t>
+            </a:r>
+          </a:p>
+        </p:txBody>
+      </p:sp>
+      <p:sp>
+        <p:nvSpPr>
+          <p:cNvPr id="7" name="TextBox 6"/>
           <p:cNvSpPr txBox="1"/>
           <p:nvPr/>
         </p:nvSpPr>
@@ -7989,7 +8230,7 @@
                 </a:solidFill>
                 <a:latin typeface="Calibri"/>
               </a:rPr>
-              <a:t>Imbalance, leakage and interpretability</a:t>
+              <a:t>Class imbalance, and what leakage is worth</a:t>
             </a:r>
           </a:p>
         </p:txBody>
@@ -8038,16 +8279,40 @@
           </a:p>
         </p:txBody>
       </p:sp>
-      <p:sp>
-        <p:nvSpPr>
-          <p:cNvPr id="4" name="TextBox 3"/>
+      <p:pic>
+        <p:nvPicPr>
+          <p:cNvPr id="4" name="Picture 3" descr="06_leakage_effect.png"/>
+          <p:cNvPicPr>
+            <a:picLocks noChangeAspect="1"/>
+          </p:cNvPicPr>
+          <p:nvPr/>
+        </p:nvPicPr>
+        <p:blipFill>
+          <a:blip r:embed="rId2"/>
+          <a:stretch>
+            <a:fillRect/>
+          </a:stretch>
+        </p:blipFill>
+        <p:spPr>
+          <a:xfrm>
+            <a:off x="6446520" y="1737360"/>
+            <a:ext cx="5533595" cy="3063240"/>
+          </a:xfrm>
+          <a:prstGeom prst="rect">
+            <a:avLst/>
+          </a:prstGeom>
+        </p:spPr>
+      </p:pic>
+      <p:sp>
+        <p:nvSpPr>
+          <p:cNvPr id="5" name="TextBox 4"/>
           <p:cNvSpPr txBox="1"/>
           <p:nvPr/>
         </p:nvSpPr>
         <p:spPr>
           <a:xfrm>
-            <a:off x="685800" y="1719072"/>
-            <a:ext cx="10820095" cy="4572000"/>
+            <a:off x="685800" y="1737360"/>
+            <a:ext cx="5486400" cy="4572000"/>
           </a:xfrm>
           <a:prstGeom prst="rect">
             <a:avLst/>
@@ -8062,11 +8327,11 @@
           <a:p>
             <a:pPr>
               <a:spcAft>
-                <a:spcPts val="500"/>
-              </a:spcAft>
-            </a:pPr>
-            <a:r>
-              <a:rPr sz="1400" b="1" i="0">
+                <a:spcPts val="600"/>
+              </a:spcAft>
+            </a:pPr>
+            <a:r>
+              <a:rPr sz="1350" b="1" i="0">
                 <a:solidFill>
                   <a:srgbClr val="1A1A1A"/>
                 </a:solidFill>
@@ -8078,27 +8343,27 @@
           <a:p>
             <a:pPr lvl="1">
               <a:spcAft>
-                <a:spcPts val="500"/>
-              </a:spcAft>
-            </a:pPr>
-            <a:r>
-              <a:rPr sz="1200" b="0" i="0">
+                <a:spcPts val="600"/>
+              </a:spcAft>
+            </a:pPr>
+            <a:r>
+              <a:rPr sz="1150" b="0" i="0">
                 <a:solidFill>
                   <a:srgbClr val="5A6270"/>
                 </a:solidFill>
                 <a:latin typeface="Calibri"/>
               </a:rPr>
-              <a:t>31% of customers left, so the classes are uneven but not badly so. I weight the rare class rather than inventing synthetic customers. With only 54 real examples, synthetic ones are copies of copies and they flatter the score.</a:t>
+              <a:t>31% of customers left, so the classes are uneven but not badly so. I weight the rare class rather than inventing synthetic customers: with 54 real examples, synthetic ones are copies of copies and they flatter the score.</a:t>
             </a:r>
           </a:p>
           <a:p>
             <a:pPr lvl="1">
               <a:spcAft>
-                <a:spcPts val="500"/>
-              </a:spcAft>
-            </a:pPr>
-            <a:r>
-              <a:rPr sz="1200" b="0" i="0">
+                <a:spcPts val="600"/>
+              </a:spcAft>
+            </a:pPr>
+            <a:r>
+              <a:rPr sz="1150" b="0" i="0">
                 <a:solidFill>
                   <a:srgbClr val="5A6270"/>
                 </a:solidFill>
@@ -8110,23 +8375,23 @@
           <a:p>
             <a:pPr lvl="1">
               <a:spcAft>
-                <a:spcPts val="500"/>
-              </a:spcAft>
-            </a:pPr>
-            <a:r>
-              <a:rPr sz="1200" b="0" i="0">
+                <a:spcPts val="600"/>
+              </a:spcAft>
+            </a:pPr>
+            <a:r>
+              <a:rPr sz="1150" b="0" i="0">
                 <a:solidFill>
                   <a:srgbClr val="5A6270"/>
                 </a:solidFill>
                 <a:latin typeface="Calibri"/>
               </a:rPr>
-              <a:t>I report ROC-AUC because its baseline stays 0.50 at any class balance, which keeps the twelve horizon cells comparable when their churn rates run 11% to 45%. Precision-recall and F1 agree, so the metric is not choosing the answer.</a:t>
-            </a:r>
-          </a:p>
-          <a:p>
-            <a:pPr>
-              <a:spcAft>
-                <a:spcPts val="500"/>
+              <a:t>I report ROC-AUC because its baseline stays 0.50 at any class balance, which keeps the twelve horizon cells comparable when their churn rates run 11% to 45%. Precision-recall and F1 agree.</a:t>
+            </a:r>
+          </a:p>
+          <a:p>
+            <a:pPr>
+              <a:spcAft>
+                <a:spcPts val="600"/>
               </a:spcAft>
             </a:pPr>
             <a:r>
@@ -8142,129 +8407,67 @@
           <a:p>
             <a:pPr>
               <a:spcAft>
-                <a:spcPts val="500"/>
-              </a:spcAft>
-            </a:pPr>
-            <a:r>
-              <a:rPr sz="1400" b="1" i="0">
+                <a:spcPts val="600"/>
+              </a:spcAft>
+            </a:pPr>
+            <a:r>
+              <a:rPr sz="1350" b="1" i="0">
                 <a:solidFill>
                   <a:srgbClr val="B02E2E"/>
                 </a:solidFill>
                 <a:latin typeface="Calibri"/>
               </a:rPr>
-              <a:t>Data leakage</a:t>
+              <a:t>I do not rely on reading the code to catch leakage.</a:t>
             </a:r>
           </a:p>
           <a:p>
             <a:pPr lvl="1">
               <a:spcAft>
-                <a:spcPts val="500"/>
-              </a:spcAft>
-            </a:pPr>
-            <a:r>
-              <a:rPr sz="1200" b="0" i="0">
+                <a:spcPts val="600"/>
+              </a:spcAft>
+            </a:pPr>
+            <a:r>
+              <a:rPr sz="1150" b="0" i="0">
                 <a:solidFill>
                   <a:srgbClr val="5A6270"/>
                 </a:solidFill>
                 <a:latin typeface="Calibri"/>
               </a:rPr>
-              <a:t>I do not rely on reading the code. A set of automatic checks runs before any result is reported, and it blocks the result if anything fails.</a:t>
-            </a:r>
-          </a:p>
-          <a:p>
-            <a:pPr lvl="1">
-              <a:spcAft>
-                <a:spcPts val="500"/>
-              </a:spcAft>
-            </a:pPr>
-            <a:r>
-              <a:rPr sz="1200" b="0" i="0">
-                <a:solidFill>
-                  <a:srgbClr val="5A6270"/>
-                </a:solidFill>
-                <a:latin typeface="Calibri"/>
-              </a:rPr>
-              <a:t>The checks look for dates after the cutoff, for banned columns by name, and for any single feature that predicts too well.</a:t>
-            </a:r>
-          </a:p>
-          <a:p>
-            <a:pPr lvl="1">
-              <a:spcAft>
-                <a:spcPts val="500"/>
-              </a:spcAft>
-            </a:pPr>
-            <a:r>
-              <a:rPr sz="1200" b="0" i="0">
-                <a:solidFill>
-                  <a:srgbClr val="5A6270"/>
-                </a:solidFill>
-                <a:latin typeface="Calibri"/>
-              </a:rPr>
-              <a:t>Columns that only exist after a customer leaves are worth 0.37 of extra AUC. They push the model to AUC 0.79, which looks like a good model rather than a broken one. That is exactly why they are dangerous.</a:t>
-            </a:r>
-          </a:p>
-          <a:p>
-            <a:pPr>
-              <a:spcAft>
-                <a:spcPts val="500"/>
-              </a:spcAft>
-            </a:pPr>
-            <a:r>
-              <a:rPr sz="600" b="0" i="0">
+              <a:t>Automatic checks run before any result is reported and block it if anything fails. They look for dates after the cutoff, banned columns by name, and any single feature that predicts too well.</a:t>
+            </a:r>
+          </a:p>
+        </p:txBody>
+      </p:sp>
+      <p:sp>
+        <p:nvSpPr>
+          <p:cNvPr id="6" name="TextBox 5"/>
+          <p:cNvSpPr txBox="1"/>
+          <p:nvPr/>
+        </p:nvSpPr>
+        <p:spPr>
+          <a:xfrm>
+            <a:off x="685800" y="6126480"/>
+            <a:ext cx="10820095" cy="502920"/>
+          </a:xfrm>
+          <a:prstGeom prst="rect">
+            <a:avLst/>
+          </a:prstGeom>
+          <a:noFill/>
+        </p:spPr>
+        <p:txBody>
+          <a:bodyPr wrap="square">
+            <a:spAutoFit/>
+          </a:bodyPr>
+          <a:lstStyle/>
+          <a:p>
+            <a:r>
+              <a:rPr sz="1150" b="0" i="1">
                 <a:solidFill>
                   <a:srgbClr val="1A1A1A"/>
                 </a:solidFill>
                 <a:latin typeface="Calibri"/>
               </a:rPr>
-              <a:t> </a:t>
-            </a:r>
-          </a:p>
-          <a:p>
-            <a:pPr>
-              <a:spcAft>
-                <a:spcPts val="500"/>
-              </a:spcAft>
-            </a:pPr>
-            <a:r>
-              <a:rPr sz="1400" b="1" i="0">
-                <a:solidFill>
-                  <a:srgbClr val="2E5F8A"/>
-                </a:solidFill>
-                <a:latin typeface="Calibri"/>
-              </a:rPr>
-              <a:t>Interpretability, and how it can mislead you</a:t>
-            </a:r>
-          </a:p>
-          <a:p>
-            <a:pPr lvl="1">
-              <a:spcAft>
-                <a:spcPts val="500"/>
-              </a:spcAft>
-            </a:pPr>
-            <a:r>
-              <a:rPr sz="1200" b="0" i="0">
-                <a:solidFill>
-                  <a:srgbClr val="5A6270"/>
-                </a:solidFill>
-                <a:latin typeface="Calibri"/>
-              </a:rPr>
-              <a:t>SHAP gives a clean, confident chart of what drives the prediction. I checked it against shuffled data, where by definition there is nothing to find. The chart looked just as convincing.</a:t>
-            </a:r>
-          </a:p>
-          <a:p>
-            <a:pPr lvl="1">
-              <a:spcAft>
-                <a:spcPts val="500"/>
-              </a:spcAft>
-            </a:pPr>
-            <a:r>
-              <a:rPr sz="1200" b="0" i="0">
-                <a:solidFill>
-                  <a:srgbClr val="5A6270"/>
-                </a:solidFill>
-                <a:latin typeface="Calibri"/>
-              </a:rPr>
-              <a:t>The top feature beats random labels only 3 times in 4. Twelve different features take first place across 25 reruns. These tools never tell you when they have nothing to say, so I pair every one with a random baseline.</a:t>
+              <a:t>The chart is why those checks earn their place. Columns that only exist after a customer leaves are worth 0.37 of extra AUC — they push the model to 0.79, which looks like a good model rather than a broken one. A pipeline that lets the future in scores 0.42, below guessing. Both failures are invisible in the score alone.</a:t>
             </a:r>
           </a:p>
         </p:txBody>

</xml_diff>

<commit_message>
Refactor README and add robustness documentation
- Updated `README.md` to clarify the regeneration of numbers and redefined key findings related to churn analysis, emphasizing actionable insights for the business.
- Introduced `ROBUSTNESS.md` to detail the limitations and potential pitfalls in the churn prediction model, including lead time effects and the impact of data leakage.
- Added `RUNNING.md` to provide instructions for setting up the project environment and executing notebooks, ensuring clarity on dependencies and execution order.

These changes aim to enhance the documentation's clarity and usability, providing a comprehensive understanding of the project's findings and operational guidelines.
</commit_message>
<xml_diff>
--- a/outputs/decks/AvePoint_Case_Study.pptx
+++ b/outputs/decks/AvePoint_Case_Study.pptx
@@ -4,25 +4,28 @@
   <p:sldMasterIdLst>
     <p:sldMasterId id="2147483648" r:id="rId1"/>
   </p:sldMasterIdLst>
+  <p:notesMasterIdLst>
+    <p:notesMasterId r:id="rId18"/>
+  </p:notesMasterIdLst>
   <p:sldIdLst>
-    <p:sldId id="256" r:id="rId7"/>
-    <p:sldId id="257" r:id="rId9"/>
-    <p:sldId id="258" r:id="rId10"/>
-    <p:sldId id="259" r:id="rId11"/>
-    <p:sldId id="260" r:id="rId12"/>
-    <p:sldId id="261" r:id="rId13"/>
-    <p:sldId id="262" r:id="rId14"/>
-    <p:sldId id="263" r:id="rId15"/>
-    <p:sldId id="264" r:id="rId16"/>
-    <p:sldId id="265" r:id="rId17"/>
-    <p:sldId id="266" r:id="rId18"/>
-    <p:sldId id="267" r:id="rId19"/>
-    <p:sldId id="268" r:id="rId20"/>
-    <p:sldId id="269" r:id="rId21"/>
-    <p:sldId id="270" r:id="rId22"/>
-    <p:sldId id="271" r:id="rId23"/>
+    <p:sldId id="256" r:id="rId2"/>
+    <p:sldId id="257" r:id="rId3"/>
+    <p:sldId id="258" r:id="rId4"/>
+    <p:sldId id="259" r:id="rId5"/>
+    <p:sldId id="260" r:id="rId6"/>
+    <p:sldId id="261" r:id="rId7"/>
+    <p:sldId id="262" r:id="rId8"/>
+    <p:sldId id="263" r:id="rId9"/>
+    <p:sldId id="264" r:id="rId10"/>
+    <p:sldId id="265" r:id="rId11"/>
+    <p:sldId id="266" r:id="rId12"/>
+    <p:sldId id="267" r:id="rId13"/>
+    <p:sldId id="268" r:id="rId14"/>
+    <p:sldId id="269" r:id="rId15"/>
+    <p:sldId id="270" r:id="rId16"/>
+    <p:sldId id="271" r:id="rId17"/>
   </p:sldIdLst>
-  <p:sldSz cx="12191695" cy="6858000" type="screen4x3"/>
+  <p:sldSz cx="12192000" cy="6858000"/>
   <p:notesSz cx="6858000" cy="9144000"/>
   <p:defaultTextStyle>
     <a:defPPr>
@@ -119,11 +122,56 @@
       </a:defRPr>
     </a:lvl9pPr>
   </p:defaultTextStyle>
+  <p:extLst>
+    <p:ext uri="{EFAFB233-063F-42B5-8137-9DF3F51BA10A}">
+      <p15:sldGuideLst xmlns:p15="http://schemas.microsoft.com/office/powerpoint/2012/main">
+        <p15:guide id="1" orient="horz" pos="2160">
+          <p15:clr>
+            <a:srgbClr val="A4A3A4"/>
+          </p15:clr>
+        </p15:guide>
+        <p15:guide id="2" pos="2880">
+          <p15:clr>
+            <a:srgbClr val="A4A3A4"/>
+          </p15:clr>
+        </p15:guide>
+      </p15:sldGuideLst>
+    </p:ext>
+  </p:extLst>
 </p:presentation>
 </file>
 
+<file path=ppt/changesInfos/changesInfo1.xml><?xml version="1.0" encoding="utf-8"?>
+<pc:chgInfo xmlns:a="http://schemas.openxmlformats.org/drawingml/2006/main" xmlns:r="http://schemas.openxmlformats.org/officeDocument/2006/relationships" xmlns:ac="http://schemas.microsoft.com/office/drawing/2013/main/command" xmlns:pc="http://schemas.microsoft.com/office/powerpoint/2013/main/command">
+  <pc:docChgLst>
+    <pc:chgData name="Dmitriy Ratushny" userId="08050032e8047aee" providerId="LiveId" clId="{78EB1A6D-D3A9-4525-A4D5-A50D4E20D487}"/>
+    <pc:docChg chg="modSld">
+      <pc:chgData name="Dmitriy Ratushny" userId="08050032e8047aee" providerId="LiveId" clId="{78EB1A6D-D3A9-4525-A4D5-A50D4E20D487}" dt="2026-07-28T21:40:26.915" v="1" actId="1076"/>
+      <pc:docMkLst>
+        <pc:docMk/>
+      </pc:docMkLst>
+      <pc:sldChg chg="modSp mod">
+        <pc:chgData name="Dmitriy Ratushny" userId="08050032e8047aee" providerId="LiveId" clId="{78EB1A6D-D3A9-4525-A4D5-A50D4E20D487}" dt="2026-07-28T21:40:26.915" v="1" actId="1076"/>
+        <pc:sldMkLst>
+          <pc:docMk/>
+          <pc:sldMk cId="0" sldId="260"/>
+        </pc:sldMkLst>
+        <pc:picChg chg="mod">
+          <ac:chgData name="Dmitriy Ratushny" userId="08050032e8047aee" providerId="LiveId" clId="{78EB1A6D-D3A9-4525-A4D5-A50D4E20D487}" dt="2026-07-28T21:40:26.915" v="1" actId="1076"/>
+          <ac:picMkLst>
+            <pc:docMk/>
+            <pc:sldMk cId="0" sldId="260"/>
+            <ac:picMk id="4" creationId="{00000000-0000-0000-0000-000000000000}"/>
+          </ac:picMkLst>
+        </pc:picChg>
+      </pc:sldChg>
+    </pc:docChg>
+  </pc:docChgLst>
+</pc:chgInfo>
+</file>
+
 <file path=ppt/notesMasters/notesMaster1.xml><?xml version="1.0" encoding="utf-8"?>
-<p:notesMaster xmlns:a="http://schemas.openxmlformats.org/drawingml/2006/main" xmlns:p="http://schemas.openxmlformats.org/presentationml/2006/main" xmlns:r="http://schemas.openxmlformats.org/officeDocument/2006/relationships">
+<p:notesMaster xmlns:a="http://schemas.openxmlformats.org/drawingml/2006/main" xmlns:r="http://schemas.openxmlformats.org/officeDocument/2006/relationships" xmlns:p="http://schemas.openxmlformats.org/presentationml/2006/main">
   <p:cSld>
     <p:bg>
       <p:bgRef idx="1001">
@@ -144,241 +192,16 @@
           <a:chExt cx="0" cy="0"/>
         </a:xfrm>
       </p:grpSpPr>
-      <p:sp>
-        <p:nvSpPr>
-          <p:cNvPr id="2" name="Header Placeholder 1"/>
-          <p:cNvSpPr>
-            <a:spLocks noGrp="1"/>
-          </p:cNvSpPr>
-          <p:nvPr>
-            <p:ph type="hdr" sz="quarter"/>
-          </p:nvPr>
-        </p:nvSpPr>
-        <p:spPr>
-          <a:xfrm>
-            <a:off x="0" y="0"/>
-            <a:ext cx="2971800" cy="457200"/>
-          </a:xfrm>
-          <a:prstGeom prst="rect">
-            <a:avLst/>
-          </a:prstGeom>
-        </p:spPr>
-        <p:txBody>
-          <a:bodyPr vert="horz" lIns="91440" tIns="45720" rIns="91440" bIns="45720" rtlCol="0"/>
-          <a:lstStyle>
-            <a:lvl1pPr algn="l">
-              <a:defRPr sz="1200"/>
-            </a:lvl1pPr>
-          </a:lstStyle>
-          <a:p>
-            <a:endParaRPr lang="en-US"/>
-          </a:p>
-        </p:txBody>
-      </p:sp>
-      <p:sp>
-        <p:nvSpPr>
-          <p:cNvPr id="3" name="Date Placeholder 2"/>
-          <p:cNvSpPr>
-            <a:spLocks noGrp="1"/>
-          </p:cNvSpPr>
-          <p:nvPr>
-            <p:ph type="dt" idx="1"/>
-          </p:nvPr>
-        </p:nvSpPr>
-        <p:spPr>
-          <a:xfrm>
-            <a:off x="3884613" y="0"/>
-            <a:ext cx="2971800" cy="457200"/>
-          </a:xfrm>
-          <a:prstGeom prst="rect">
-            <a:avLst/>
-          </a:prstGeom>
-        </p:spPr>
-        <p:txBody>
-          <a:bodyPr vert="horz" lIns="91440" tIns="45720" rIns="91440" bIns="45720" rtlCol="0"/>
-          <a:lstStyle>
-            <a:lvl1pPr algn="r">
-              <a:defRPr sz="1200"/>
-            </a:lvl1pPr>
-          </a:lstStyle>
-          <a:p>
-            <a:fld id="{0F89C1C7-3DCD-1040-A9CF-14679D8B5DDD}" type="datetimeFigureOut">
-              <a:rPr lang="en-US" smtClean="0"/>
-              <a:t>10/17/16</a:t>
-            </a:fld>
-            <a:endParaRPr lang="en-US"/>
-          </a:p>
-        </p:txBody>
-      </p:sp>
-      <p:sp>
-        <p:nvSpPr>
-          <p:cNvPr id="4" name="Slide Image Placeholder 3"/>
-          <p:cNvSpPr>
-            <a:spLocks noGrp="1" noRot="1" noChangeAspect="1"/>
-          </p:cNvSpPr>
-          <p:nvPr>
-            <p:ph type="sldImg" idx="2"/>
-          </p:nvPr>
-        </p:nvSpPr>
-        <p:spPr>
-          <a:xfrm>
-            <a:off x="1143000" y="685800"/>
-            <a:ext cx="4572000" cy="3429000"/>
-          </a:xfrm>
-          <a:prstGeom prst="rect">
-            <a:avLst/>
-          </a:prstGeom>
-          <a:noFill/>
-          <a:ln w="12700">
-            <a:solidFill>
-              <a:prstClr val="black"/>
-            </a:solidFill>
-          </a:ln>
-        </p:spPr>
-        <p:txBody>
-          <a:bodyPr vert="horz" lIns="91440" tIns="45720" rIns="91440" bIns="45720" rtlCol="0" anchor="ctr"/>
-          <a:lstStyle/>
-          <a:p>
-            <a:endParaRPr lang="en-US"/>
-          </a:p>
-        </p:txBody>
-      </p:sp>
-      <p:sp>
-        <p:nvSpPr>
-          <p:cNvPr id="5" name="Notes Placeholder 4"/>
-          <p:cNvSpPr>
-            <a:spLocks noGrp="1"/>
-          </p:cNvSpPr>
-          <p:nvPr>
-            <p:ph type="body" sz="quarter" idx="3"/>
-          </p:nvPr>
-        </p:nvSpPr>
-        <p:spPr>
-          <a:xfrm>
-            <a:off x="685800" y="4343400"/>
-            <a:ext cx="5486400" cy="4114800"/>
-          </a:xfrm>
-          <a:prstGeom prst="rect">
-            <a:avLst/>
-          </a:prstGeom>
-        </p:spPr>
-        <p:txBody>
-          <a:bodyPr vert="horz" lIns="91440" tIns="45720" rIns="91440" bIns="45720" rtlCol="0"/>
-          <a:lstStyle/>
-          <a:p>
-            <a:pPr lvl="0"/>
-            <a:r>
-              <a:rPr lang="en-US" smtClean="0"/>
-              <a:t>Click to edit Master text styles</a:t>
-            </a:r>
-          </a:p>
-          <a:p>
-            <a:pPr lvl="1"/>
-            <a:r>
-              <a:rPr lang="en-US" smtClean="0"/>
-              <a:t>Second level</a:t>
-            </a:r>
-          </a:p>
-          <a:p>
-            <a:pPr lvl="2"/>
-            <a:r>
-              <a:rPr lang="en-US" smtClean="0"/>
-              <a:t>Third level</a:t>
-            </a:r>
-          </a:p>
-          <a:p>
-            <a:pPr lvl="3"/>
-            <a:r>
-              <a:rPr lang="en-US" smtClean="0"/>
-              <a:t>Fourth level</a:t>
-            </a:r>
-          </a:p>
-          <a:p>
-            <a:pPr lvl="4"/>
-            <a:r>
-              <a:rPr lang="en-US" smtClean="0"/>
-              <a:t>Fifth level</a:t>
-            </a:r>
-            <a:endParaRPr lang="en-US"/>
-          </a:p>
-        </p:txBody>
-      </p:sp>
-      <p:sp>
-        <p:nvSpPr>
-          <p:cNvPr id="6" name="Footer Placeholder 5"/>
-          <p:cNvSpPr>
-            <a:spLocks noGrp="1"/>
-          </p:cNvSpPr>
-          <p:nvPr>
-            <p:ph type="ftr" sz="quarter" idx="4"/>
-          </p:nvPr>
-        </p:nvSpPr>
-        <p:spPr>
-          <a:xfrm>
-            <a:off x="0" y="8685213"/>
-            <a:ext cx="2971800" cy="457200"/>
-          </a:xfrm>
-          <a:prstGeom prst="rect">
-            <a:avLst/>
-          </a:prstGeom>
-        </p:spPr>
-        <p:txBody>
-          <a:bodyPr vert="horz" lIns="91440" tIns="45720" rIns="91440" bIns="45720" rtlCol="0" anchor="b"/>
-          <a:lstStyle>
-            <a:lvl1pPr algn="l">
-              <a:defRPr sz="1200"/>
-            </a:lvl1pPr>
-          </a:lstStyle>
-          <a:p>
-            <a:endParaRPr lang="en-US"/>
-          </a:p>
-        </p:txBody>
-      </p:sp>
-      <p:sp>
-        <p:nvSpPr>
-          <p:cNvPr id="7" name="Slide Number Placeholder 6"/>
-          <p:cNvSpPr>
-            <a:spLocks noGrp="1"/>
-          </p:cNvSpPr>
-          <p:nvPr>
-            <p:ph type="sldNum" sz="quarter" idx="5"/>
-          </p:nvPr>
-        </p:nvSpPr>
-        <p:spPr>
-          <a:xfrm>
-            <a:off x="3884613" y="8685213"/>
-            <a:ext cx="2971800" cy="457200"/>
-          </a:xfrm>
-          <a:prstGeom prst="rect">
-            <a:avLst/>
-          </a:prstGeom>
-        </p:spPr>
-        <p:txBody>
-          <a:bodyPr vert="horz" lIns="91440" tIns="45720" rIns="91440" bIns="45720" rtlCol="0" anchor="b"/>
-          <a:lstStyle>
-            <a:lvl1pPr algn="r">
-              <a:defRPr sz="1200"/>
-            </a:lvl1pPr>
-          </a:lstStyle>
-          <a:p>
-            <a:fld id="{BB5E49A5-4136-284D-997B-48E1D791AD67}" type="slidenum">
-              <a:rPr lang="en-US" smtClean="0"/>
-              <a:t>‹#›</a:t>
-            </a:fld>
-            <a:endParaRPr lang="en-US"/>
-          </a:p>
-        </p:txBody>
-      </p:sp>
     </p:spTree>
     <p:extLst>
       <p:ext uri="{BB962C8B-B14F-4D97-AF65-F5344CB8AC3E}">
-        <p14:creationId xmlns:p14="http://schemas.microsoft.com/office/powerpoint/2010/main" val="2623252185"/>
+        <p14:creationId xmlns:p14="http://schemas.microsoft.com/office/powerpoint/2010/main" val="2384198597"/>
       </p:ext>
     </p:extLst>
   </p:cSld>
   <p:clrMap bg1="lt1" tx1="dk1" bg2="lt2" tx2="dk2" accent1="accent1" accent2="accent2" accent3="accent3" accent4="accent4" accent5="accent5" accent6="accent6" hlink="hlink" folHlink="folHlink"/>
   <p:notesStyle>
-    <a:lvl1pPr marL="0" algn="l" defTabSz="457200" rtl="0" eaLnBrk="1" latinLnBrk="0" hangingPunct="1">
+    <a:lvl1pPr marL="0" algn="l" defTabSz="914400" rtl="0" eaLnBrk="1" latinLnBrk="0" hangingPunct="1">
       <a:defRPr sz="1200" kern="1200">
         <a:solidFill>
           <a:schemeClr val="tx1"/>
@@ -388,7 +211,7 @@
         <a:cs typeface="+mn-cs"/>
       </a:defRPr>
     </a:lvl1pPr>
-    <a:lvl2pPr marL="457200" algn="l" defTabSz="457200" rtl="0" eaLnBrk="1" latinLnBrk="0" hangingPunct="1">
+    <a:lvl2pPr marL="457200" algn="l" defTabSz="914400" rtl="0" eaLnBrk="1" latinLnBrk="0" hangingPunct="1">
       <a:defRPr sz="1200" kern="1200">
         <a:solidFill>
           <a:schemeClr val="tx1"/>
@@ -398,7 +221,7 @@
         <a:cs typeface="+mn-cs"/>
       </a:defRPr>
     </a:lvl2pPr>
-    <a:lvl3pPr marL="914400" algn="l" defTabSz="457200" rtl="0" eaLnBrk="1" latinLnBrk="0" hangingPunct="1">
+    <a:lvl3pPr marL="914400" algn="l" defTabSz="914400" rtl="0" eaLnBrk="1" latinLnBrk="0" hangingPunct="1">
       <a:defRPr sz="1200" kern="1200">
         <a:solidFill>
           <a:schemeClr val="tx1"/>
@@ -408,7 +231,7 @@
         <a:cs typeface="+mn-cs"/>
       </a:defRPr>
     </a:lvl3pPr>
-    <a:lvl4pPr marL="1371600" algn="l" defTabSz="457200" rtl="0" eaLnBrk="1" latinLnBrk="0" hangingPunct="1">
+    <a:lvl4pPr marL="1371600" algn="l" defTabSz="914400" rtl="0" eaLnBrk="1" latinLnBrk="0" hangingPunct="1">
       <a:defRPr sz="1200" kern="1200">
         <a:solidFill>
           <a:schemeClr val="tx1"/>
@@ -418,7 +241,7 @@
         <a:cs typeface="+mn-cs"/>
       </a:defRPr>
     </a:lvl4pPr>
-    <a:lvl5pPr marL="1828800" algn="l" defTabSz="457200" rtl="0" eaLnBrk="1" latinLnBrk="0" hangingPunct="1">
+    <a:lvl5pPr marL="1828800" algn="l" defTabSz="914400" rtl="0" eaLnBrk="1" latinLnBrk="0" hangingPunct="1">
       <a:defRPr sz="1200" kern="1200">
         <a:solidFill>
           <a:schemeClr val="tx1"/>
@@ -428,7 +251,7 @@
         <a:cs typeface="+mn-cs"/>
       </a:defRPr>
     </a:lvl5pPr>
-    <a:lvl6pPr marL="2286000" algn="l" defTabSz="457200" rtl="0" eaLnBrk="1" latinLnBrk="0" hangingPunct="1">
+    <a:lvl6pPr marL="2286000" algn="l" defTabSz="914400" rtl="0" eaLnBrk="1" latinLnBrk="0" hangingPunct="1">
       <a:defRPr sz="1200" kern="1200">
         <a:solidFill>
           <a:schemeClr val="tx1"/>
@@ -438,7 +261,7 @@
         <a:cs typeface="+mn-cs"/>
       </a:defRPr>
     </a:lvl6pPr>
-    <a:lvl7pPr marL="2743200" algn="l" defTabSz="457200" rtl="0" eaLnBrk="1" latinLnBrk="0" hangingPunct="1">
+    <a:lvl7pPr marL="2743200" algn="l" defTabSz="914400" rtl="0" eaLnBrk="1" latinLnBrk="0" hangingPunct="1">
       <a:defRPr sz="1200" kern="1200">
         <a:solidFill>
           <a:schemeClr val="tx1"/>
@@ -448,7 +271,7 @@
         <a:cs typeface="+mn-cs"/>
       </a:defRPr>
     </a:lvl7pPr>
-    <a:lvl8pPr marL="3200400" algn="l" defTabSz="457200" rtl="0" eaLnBrk="1" latinLnBrk="0" hangingPunct="1">
+    <a:lvl8pPr marL="3200400" algn="l" defTabSz="914400" rtl="0" eaLnBrk="1" latinLnBrk="0" hangingPunct="1">
       <a:defRPr sz="1200" kern="1200">
         <a:solidFill>
           <a:schemeClr val="tx1"/>
@@ -458,7 +281,7 @@
         <a:cs typeface="+mn-cs"/>
       </a:defRPr>
     </a:lvl8pPr>
-    <a:lvl9pPr marL="3657600" algn="l" defTabSz="457200" rtl="0" eaLnBrk="1" latinLnBrk="0" hangingPunct="1">
+    <a:lvl9pPr marL="3657600" algn="l" defTabSz="914400" rtl="0" eaLnBrk="1" latinLnBrk="0" hangingPunct="1">
       <a:defRPr sz="1200" kern="1200">
         <a:solidFill>
           <a:schemeClr val="tx1"/>
@@ -473,7 +296,7 @@
 </file>
 
 <file path=ppt/notesSlides/notesSlide1.xml><?xml version="1.0" encoding="utf-8"?>
-<p:notes xmlns:a="http://schemas.openxmlformats.org/drawingml/2006/main" xmlns:p="http://schemas.openxmlformats.org/presentationml/2006/main" xmlns:r="http://schemas.openxmlformats.org/officeDocument/2006/relationships">
+<p:notes xmlns:a="http://schemas.openxmlformats.org/drawingml/2006/main" xmlns:r="http://schemas.openxmlformats.org/officeDocument/2006/relationships" xmlns:p="http://schemas.openxmlformats.org/presentationml/2006/main">
   <p:cSld>
     <p:spTree>
       <p:nvGrpSpPr>
@@ -493,7 +316,7 @@
         <p:nvSpPr>
           <p:cNvPr id="2" name="Slide Image Placeholder 1"/>
           <p:cNvSpPr>
-            <a:spLocks noGrp="1"/>
+            <a:spLocks noGrp="1" noRot="1" noChangeAspect="1"/>
           </p:cNvSpPr>
           <p:nvPr>
             <p:ph type="sldImg" idx="2"/>
@@ -508,7 +331,7 @@
             <a:spLocks noGrp="1"/>
           </p:cNvSpPr>
           <p:nvPr>
-            <p:ph type="body" idx="3" sz="quarter"/>
+            <p:ph type="body" sz="quarter" idx="3"/>
           </p:nvPr>
         </p:nvSpPr>
         <p:spPr/>
@@ -520,7 +343,9 @@
               <a:t>Thirty to forty minutes, five parts, following the brief. I say the headline up front because the value of this work is in proving the negatives properly and in what we do anyway.</a:t>
             </a:r>
           </a:p>
-          <a:p/>
+          <a:p>
+            <a:endParaRPr/>
+          </a:p>
           <a:p>
             <a:r>
               <a:t>The second clause is the part to sit on if there is only time for one thing. The strongest result I had — churn accelerating through 2024, p = 2e-16 — is reproduced exactly by a simulation containing nothing but a random number generator. Slide 11 is that test. Finding it is the piece of work I would most want to be judged on.</a:t>
@@ -535,7 +360,7 @@
             <a:spLocks noGrp="1"/>
           </p:cNvSpPr>
           <p:nvPr>
-            <p:ph type="sldNum" idx="5" sz="quarter"/>
+            <p:ph type="sldNum" sz="quarter" idx="5"/>
           </p:nvPr>
         </p:nvSpPr>
         <p:spPr/>
@@ -549,7 +374,7 @@
 </file>
 
 <file path=ppt/notesSlides/notesSlide2.xml><?xml version="1.0" encoding="utf-8"?>
-<p:notes xmlns:a="http://schemas.openxmlformats.org/drawingml/2006/main" xmlns:p="http://schemas.openxmlformats.org/presentationml/2006/main" xmlns:r="http://schemas.openxmlformats.org/officeDocument/2006/relationships">
+<p:notes xmlns:a="http://schemas.openxmlformats.org/drawingml/2006/main" xmlns:r="http://schemas.openxmlformats.org/officeDocument/2006/relationships" xmlns:p="http://schemas.openxmlformats.org/presentationml/2006/main">
   <p:cSld>
     <p:spTree>
       <p:nvGrpSpPr>
@@ -569,7 +394,7 @@
         <p:nvSpPr>
           <p:cNvPr id="2" name="Slide Image Placeholder 1"/>
           <p:cNvSpPr>
-            <a:spLocks noGrp="1"/>
+            <a:spLocks noGrp="1" noRot="1" noChangeAspect="1"/>
           </p:cNvSpPr>
           <p:nvPr>
             <p:ph type="sldImg" idx="2"/>
@@ -584,7 +409,7 @@
             <a:spLocks noGrp="1"/>
           </p:cNvSpPr>
           <p:nvPr>
-            <p:ph type="body" idx="3" sz="quarter"/>
+            <p:ph type="body" sz="quarter" idx="3"/>
           </p:nvPr>
         </p:nvSpPr>
         <p:spPr/>
@@ -596,25 +421,33 @@
               <a:t>Lead with the target problem. Along with slide 11 it is the most valuable thing here, and it shows the instinct to check the label before fitting anything.</a:t>
             </a:r>
           </a:p>
-          <a:p/>
+          <a:p>
+            <a:endParaRPr/>
+          </a:p>
           <a:p>
             <a:r>
               <a:t>If challenged on the 188: the point is not that agreement is low, it is that it is exactly what chance produces. The flag fires for 22% of customers and the event log for 70%, so two unrelated columns agree 38.6% of the time. We observe 37.6%. Cohen's kappa is -0.02, where 0 means unrelated, and chi-square gives p = 0.56.</a:t>
             </a:r>
           </a:p>
-          <a:p/>
+          <a:p>
+            <a:endParaRPr/>
+          </a:p>
           <a:p>
             <a:r>
               <a:t>Pre-empt the obvious follow-up: 'so invert the flag and you get 62%'. No. Inverted it scores 62.4% against 61.4% expected by chance, kappa +0.03. There is no information in it either way round.</a:t>
             </a:r>
           </a:p>
-          <a:p/>
+          <a:p>
+            <a:endParaRPr/>
+          </a:p>
           <a:p>
             <a:r>
               <a:t>The subscription line is the strongest part because it never touches the flag: 386 churn events can be compared to a subscription ending, and only 6 land on the same day. Median gap 62 days. All three recordings of 'this customer left' are mutually unrelated.</a:t>
             </a:r>
           </a:p>
-          <a:p/>
+          <a:p>
+            <a:endParaRPr/>
+          </a:p>
           <a:p>
             <a:r>
               <a:t>Computed in src/audit.py by label_source_agreement and churn_date_coherence, and shown in notebooks 01 and 10.</a:t>
@@ -629,7 +462,7 @@
             <a:spLocks noGrp="1"/>
           </p:cNvSpPr>
           <p:nvPr>
-            <p:ph type="sldNum" idx="5" sz="quarter"/>
+            <p:ph type="sldNum" sz="quarter" idx="5"/>
           </p:nvPr>
         </p:nvSpPr>
         <p:spPr/>
@@ -643,7 +476,7 @@
 </file>
 
 <file path=ppt/notesSlides/notesSlide3.xml><?xml version="1.0" encoding="utf-8"?>
-<p:notes xmlns:a="http://schemas.openxmlformats.org/drawingml/2006/main" xmlns:p="http://schemas.openxmlformats.org/presentationml/2006/main" xmlns:r="http://schemas.openxmlformats.org/officeDocument/2006/relationships">
+<p:notes xmlns:a="http://schemas.openxmlformats.org/drawingml/2006/main" xmlns:r="http://schemas.openxmlformats.org/officeDocument/2006/relationships" xmlns:p="http://schemas.openxmlformats.org/presentationml/2006/main">
   <p:cSld>
     <p:spTree>
       <p:nvGrpSpPr>
@@ -663,7 +496,7 @@
         <p:nvSpPr>
           <p:cNvPr id="2" name="Slide Image Placeholder 1"/>
           <p:cNvSpPr>
-            <a:spLocks noGrp="1"/>
+            <a:spLocks noGrp="1" noRot="1" noChangeAspect="1"/>
           </p:cNvSpPr>
           <p:nvPr>
             <p:ph type="sldImg" idx="2"/>
@@ -678,7 +511,7 @@
             <a:spLocks noGrp="1"/>
           </p:cNvSpPr>
           <p:nvPr>
-            <p:ph type="body" idx="3" sz="quarter"/>
+            <p:ph type="body" sz="quarter" idx="3"/>
           </p:nvPr>
         </p:nvSpPr>
         <p:spPr/>
@@ -690,31 +523,41 @@
               <a:t>This is the slide I would want to be asked about.</a:t>
             </a:r>
           </a:p>
-          <a:p/>
+          <a:p>
+            <a:endParaRPr/>
+          </a:p>
           <a:p>
             <a:r>
               <a:t>How the artefact works: no churn date can land after 2024-12-31. If each is drawn uniformly between signup and that boundary, the hazard is 1/(END - t), which rises without limit as t approaches the end. Pooled across accounts that signed up over two years, that is indistinguishable by eye from a business problem.</a:t>
             </a:r>
           </a:p>
-          <a:p/>
+          <a:p>
+            <a:endParaRPr/>
+          </a:p>
           <a:p>
             <a:r>
               <a:t>The evidence, in order. Rescale each churn date to its position in the account's own window: uniform, KS p = 0.92 on 600 events, mean position 0.503, and uniform inside every signup quarter. Then the simulation — keep each account's real signup date and real number of churn events, redraw only the dates, run the same survival.calendar_hazard used to produce the original claim, 400 times. Observed rate ratio 1.0893, null 1.0885 with a 95% band of [1.072, 1.106].</a:t>
             </a:r>
           </a:p>
-          <a:p/>
+          <a:p>
+            <a:endParaRPr/>
+          </a:p>
           <a:p>
             <a:r>
               <a:t>The p-value is the part worth dwelling on. p = 2e-16 felt like the most secure number I had. The null rule produces a median p of 2.8e-16 — very slightly more significant than the real data. A p-value tells you nothing about whether the null it tests is the one that matters.</a:t>
             </a:r>
           </a:p>
-          <a:p/>
+          <a:p>
+            <a:endParaRPr/>
+          </a:p>
           <a:p>
             <a:r>
               <a:t>If asked what I would have done differently: run this before writing the recommendation, not after. On any generated or vendor-supplied extract, simulate the file before trusting a time trend in it.</a:t>
             </a:r>
           </a:p>
-          <a:p/>
+          <a:p>
+            <a:endParaRPr/>
+          </a:p>
           <a:p>
             <a:r>
               <a:t>src/generator.py, notebook 16.</a:t>
@@ -729,7 +572,7 @@
             <a:spLocks noGrp="1"/>
           </p:cNvSpPr>
           <p:nvPr>
-            <p:ph type="sldNum" idx="5" sz="quarter"/>
+            <p:ph type="sldNum" sz="quarter" idx="5"/>
           </p:nvPr>
         </p:nvSpPr>
         <p:spPr/>
@@ -780,10 +623,9 @@
           <a:lstStyle/>
           <a:p>
             <a:r>
-              <a:rPr lang="en-US" smtClean="0"/>
+              <a:rPr lang="en-US"/>
               <a:t>Click to edit Master title style</a:t>
             </a:r>
-            <a:endParaRPr lang="en-US"/>
           </a:p>
         </p:txBody>
       </p:sp>
@@ -899,10 +741,9 @@
           </a:lstStyle>
           <a:p>
             <a:r>
-              <a:rPr lang="en-US" smtClean="0"/>
+              <a:rPr lang="en-US"/>
               <a:t>Click to edit Master subtitle style</a:t>
             </a:r>
-            <a:endParaRPr lang="en-US"/>
           </a:p>
         </p:txBody>
       </p:sp>
@@ -923,7 +764,7 @@
           <a:p>
             <a:fld id="{5BCAD085-E8A6-8845-BD4E-CB4CCA059FC4}" type="datetimeFigureOut">
               <a:rPr lang="en-US" smtClean="0"/>
-              <a:t>1/27/13</a:t>
+              <a:t>7/28/2026</a:t>
             </a:fld>
             <a:endParaRPr lang="en-US"/>
           </a:p>
@@ -1017,10 +858,9 @@
           <a:lstStyle/>
           <a:p>
             <a:r>
-              <a:rPr lang="en-US" smtClean="0"/>
+              <a:rPr lang="en-US"/>
               <a:t>Click to edit Master title style</a:t>
             </a:r>
-            <a:endParaRPr lang="en-US"/>
           </a:p>
         </p:txBody>
       </p:sp>
@@ -1041,38 +881,37 @@
           <a:p>
             <a:pPr lvl="0"/>
             <a:r>
-              <a:rPr lang="en-US" smtClean="0"/>
+              <a:rPr lang="en-US"/>
               <a:t>Click to edit Master text styles</a:t>
             </a:r>
           </a:p>
           <a:p>
             <a:pPr lvl="1"/>
             <a:r>
-              <a:rPr lang="en-US" smtClean="0"/>
+              <a:rPr lang="en-US"/>
               <a:t>Second level</a:t>
             </a:r>
           </a:p>
           <a:p>
             <a:pPr lvl="2"/>
             <a:r>
-              <a:rPr lang="en-US" smtClean="0"/>
+              <a:rPr lang="en-US"/>
               <a:t>Third level</a:t>
             </a:r>
           </a:p>
           <a:p>
             <a:pPr lvl="3"/>
             <a:r>
-              <a:rPr lang="en-US" smtClean="0"/>
+              <a:rPr lang="en-US"/>
               <a:t>Fourth level</a:t>
             </a:r>
           </a:p>
           <a:p>
             <a:pPr lvl="4"/>
             <a:r>
-              <a:rPr lang="en-US" smtClean="0"/>
+              <a:rPr lang="en-US"/>
               <a:t>Fifth level</a:t>
             </a:r>
-            <a:endParaRPr lang="en-US"/>
           </a:p>
         </p:txBody>
       </p:sp>
@@ -1093,7 +932,7 @@
           <a:p>
             <a:fld id="{5BCAD085-E8A6-8845-BD4E-CB4CCA059FC4}" type="datetimeFigureOut">
               <a:rPr lang="en-US" smtClean="0"/>
-              <a:t>1/27/13</a:t>
+              <a:t>7/28/2026</a:t>
             </a:fld>
             <a:endParaRPr lang="en-US"/>
           </a:p>
@@ -1192,10 +1031,9 @@
           <a:lstStyle/>
           <a:p>
             <a:r>
-              <a:rPr lang="en-US" smtClean="0"/>
+              <a:rPr lang="en-US"/>
               <a:t>Click to edit Master title style</a:t>
             </a:r>
-            <a:endParaRPr lang="en-US"/>
           </a:p>
         </p:txBody>
       </p:sp>
@@ -1221,38 +1059,37 @@
           <a:p>
             <a:pPr lvl="0"/>
             <a:r>
-              <a:rPr lang="en-US" smtClean="0"/>
+              <a:rPr lang="en-US"/>
               <a:t>Click to edit Master text styles</a:t>
             </a:r>
           </a:p>
           <a:p>
             <a:pPr lvl="1"/>
             <a:r>
-              <a:rPr lang="en-US" smtClean="0"/>
+              <a:rPr lang="en-US"/>
               <a:t>Second level</a:t>
             </a:r>
           </a:p>
           <a:p>
             <a:pPr lvl="2"/>
             <a:r>
-              <a:rPr lang="en-US" smtClean="0"/>
+              <a:rPr lang="en-US"/>
               <a:t>Third level</a:t>
             </a:r>
           </a:p>
           <a:p>
             <a:pPr lvl="3"/>
             <a:r>
-              <a:rPr lang="en-US" smtClean="0"/>
+              <a:rPr lang="en-US"/>
               <a:t>Fourth level</a:t>
             </a:r>
           </a:p>
           <a:p>
             <a:pPr lvl="4"/>
             <a:r>
-              <a:rPr lang="en-US" smtClean="0"/>
+              <a:rPr lang="en-US"/>
               <a:t>Fifth level</a:t>
             </a:r>
-            <a:endParaRPr lang="en-US"/>
           </a:p>
         </p:txBody>
       </p:sp>
@@ -1273,7 +1110,7 @@
           <a:p>
             <a:fld id="{5BCAD085-E8A6-8845-BD4E-CB4CCA059FC4}" type="datetimeFigureOut">
               <a:rPr lang="en-US" smtClean="0"/>
-              <a:t>1/27/13</a:t>
+              <a:t>7/28/2026</a:t>
             </a:fld>
             <a:endParaRPr lang="en-US"/>
           </a:p>
@@ -1367,10 +1204,9 @@
           <a:lstStyle/>
           <a:p>
             <a:r>
-              <a:rPr lang="en-US" smtClean="0"/>
+              <a:rPr lang="en-US"/>
               <a:t>Click to edit Master title style</a:t>
             </a:r>
-            <a:endParaRPr lang="en-US"/>
           </a:p>
         </p:txBody>
       </p:sp>
@@ -1391,38 +1227,37 @@
           <a:p>
             <a:pPr lvl="0"/>
             <a:r>
-              <a:rPr lang="en-US" smtClean="0"/>
+              <a:rPr lang="en-US"/>
               <a:t>Click to edit Master text styles</a:t>
             </a:r>
           </a:p>
           <a:p>
             <a:pPr lvl="1"/>
             <a:r>
-              <a:rPr lang="en-US" smtClean="0"/>
+              <a:rPr lang="en-US"/>
               <a:t>Second level</a:t>
             </a:r>
           </a:p>
           <a:p>
             <a:pPr lvl="2"/>
             <a:r>
-              <a:rPr lang="en-US" smtClean="0"/>
+              <a:rPr lang="en-US"/>
               <a:t>Third level</a:t>
             </a:r>
           </a:p>
           <a:p>
             <a:pPr lvl="3"/>
             <a:r>
-              <a:rPr lang="en-US" smtClean="0"/>
+              <a:rPr lang="en-US"/>
               <a:t>Fourth level</a:t>
             </a:r>
           </a:p>
           <a:p>
             <a:pPr lvl="4"/>
             <a:r>
-              <a:rPr lang="en-US" smtClean="0"/>
+              <a:rPr lang="en-US"/>
               <a:t>Fifth level</a:t>
             </a:r>
-            <a:endParaRPr lang="en-US"/>
           </a:p>
         </p:txBody>
       </p:sp>
@@ -1443,7 +1278,7 @@
           <a:p>
             <a:fld id="{5BCAD085-E8A6-8845-BD4E-CB4CCA059FC4}" type="datetimeFigureOut">
               <a:rPr lang="en-US" smtClean="0"/>
-              <a:t>1/27/13</a:t>
+              <a:t>7/28/2026</a:t>
             </a:fld>
             <a:endParaRPr lang="en-US"/>
           </a:p>
@@ -1546,10 +1381,9 @@
           </a:lstStyle>
           <a:p>
             <a:r>
-              <a:rPr lang="en-US" smtClean="0"/>
+              <a:rPr lang="en-US"/>
               <a:t>Click to edit Master title style</a:t>
             </a:r>
-            <a:endParaRPr lang="en-US"/>
           </a:p>
         </p:txBody>
       </p:sp>
@@ -1666,7 +1500,7 @@
           <a:p>
             <a:pPr lvl="0"/>
             <a:r>
-              <a:rPr lang="en-US" smtClean="0"/>
+              <a:rPr lang="en-US"/>
               <a:t>Click to edit Master text styles</a:t>
             </a:r>
           </a:p>
@@ -1689,7 +1523,7 @@
           <a:p>
             <a:fld id="{5BCAD085-E8A6-8845-BD4E-CB4CCA059FC4}" type="datetimeFigureOut">
               <a:rPr lang="en-US" smtClean="0"/>
-              <a:t>1/27/13</a:t>
+              <a:t>7/28/2026</a:t>
             </a:fld>
             <a:endParaRPr lang="en-US"/>
           </a:p>
@@ -1783,10 +1617,9 @@
           <a:lstStyle/>
           <a:p>
             <a:r>
-              <a:rPr lang="en-US" smtClean="0"/>
+              <a:rPr lang="en-US"/>
               <a:t>Click to edit Master title style</a:t>
             </a:r>
-            <a:endParaRPr lang="en-US"/>
           </a:p>
         </p:txBody>
       </p:sp>
@@ -1840,38 +1673,37 @@
           <a:p>
             <a:pPr lvl="0"/>
             <a:r>
-              <a:rPr lang="en-US" smtClean="0"/>
+              <a:rPr lang="en-US"/>
               <a:t>Click to edit Master text styles</a:t>
             </a:r>
           </a:p>
           <a:p>
             <a:pPr lvl="1"/>
             <a:r>
-              <a:rPr lang="en-US" smtClean="0"/>
+              <a:rPr lang="en-US"/>
               <a:t>Second level</a:t>
             </a:r>
           </a:p>
           <a:p>
             <a:pPr lvl="2"/>
             <a:r>
-              <a:rPr lang="en-US" smtClean="0"/>
+              <a:rPr lang="en-US"/>
               <a:t>Third level</a:t>
             </a:r>
           </a:p>
           <a:p>
             <a:pPr lvl="3"/>
             <a:r>
-              <a:rPr lang="en-US" smtClean="0"/>
+              <a:rPr lang="en-US"/>
               <a:t>Fourth level</a:t>
             </a:r>
           </a:p>
           <a:p>
             <a:pPr lvl="4"/>
             <a:r>
-              <a:rPr lang="en-US" smtClean="0"/>
+              <a:rPr lang="en-US"/>
               <a:t>Fifth level</a:t>
             </a:r>
-            <a:endParaRPr lang="en-US"/>
           </a:p>
         </p:txBody>
       </p:sp>
@@ -1925,38 +1757,37 @@
           <a:p>
             <a:pPr lvl="0"/>
             <a:r>
-              <a:rPr lang="en-US" smtClean="0"/>
+              <a:rPr lang="en-US"/>
               <a:t>Click to edit Master text styles</a:t>
             </a:r>
           </a:p>
           <a:p>
             <a:pPr lvl="1"/>
             <a:r>
-              <a:rPr lang="en-US" smtClean="0"/>
+              <a:rPr lang="en-US"/>
               <a:t>Second level</a:t>
             </a:r>
           </a:p>
           <a:p>
             <a:pPr lvl="2"/>
             <a:r>
-              <a:rPr lang="en-US" smtClean="0"/>
+              <a:rPr lang="en-US"/>
               <a:t>Third level</a:t>
             </a:r>
           </a:p>
           <a:p>
             <a:pPr lvl="3"/>
             <a:r>
-              <a:rPr lang="en-US" smtClean="0"/>
+              <a:rPr lang="en-US"/>
               <a:t>Fourth level</a:t>
             </a:r>
           </a:p>
           <a:p>
             <a:pPr lvl="4"/>
             <a:r>
-              <a:rPr lang="en-US" smtClean="0"/>
+              <a:rPr lang="en-US"/>
               <a:t>Fifth level</a:t>
             </a:r>
-            <a:endParaRPr lang="en-US"/>
           </a:p>
         </p:txBody>
       </p:sp>
@@ -1977,7 +1808,7 @@
           <a:p>
             <a:fld id="{5BCAD085-E8A6-8845-BD4E-CB4CCA059FC4}" type="datetimeFigureOut">
               <a:rPr lang="en-US" smtClean="0"/>
-              <a:t>1/27/13</a:t>
+              <a:t>7/28/2026</a:t>
             </a:fld>
             <a:endParaRPr lang="en-US"/>
           </a:p>
@@ -2075,10 +1906,9 @@
           </a:lstStyle>
           <a:p>
             <a:r>
-              <a:rPr lang="en-US" smtClean="0"/>
+              <a:rPr lang="en-US"/>
               <a:t>Click to edit Master title style</a:t>
             </a:r>
-            <a:endParaRPr lang="en-US"/>
           </a:p>
         </p:txBody>
       </p:sp>
@@ -2141,7 +1971,7 @@
           <a:p>
             <a:pPr lvl="0"/>
             <a:r>
-              <a:rPr lang="en-US" smtClean="0"/>
+              <a:rPr lang="en-US"/>
               <a:t>Click to edit Master text styles</a:t>
             </a:r>
           </a:p>
@@ -2197,38 +2027,37 @@
           <a:p>
             <a:pPr lvl="0"/>
             <a:r>
-              <a:rPr lang="en-US" smtClean="0"/>
+              <a:rPr lang="en-US"/>
               <a:t>Click to edit Master text styles</a:t>
             </a:r>
           </a:p>
           <a:p>
             <a:pPr lvl="1"/>
             <a:r>
-              <a:rPr lang="en-US" smtClean="0"/>
+              <a:rPr lang="en-US"/>
               <a:t>Second level</a:t>
             </a:r>
           </a:p>
           <a:p>
             <a:pPr lvl="2"/>
             <a:r>
-              <a:rPr lang="en-US" smtClean="0"/>
+              <a:rPr lang="en-US"/>
               <a:t>Third level</a:t>
             </a:r>
           </a:p>
           <a:p>
             <a:pPr lvl="3"/>
             <a:r>
-              <a:rPr lang="en-US" smtClean="0"/>
+              <a:rPr lang="en-US"/>
               <a:t>Fourth level</a:t>
             </a:r>
           </a:p>
           <a:p>
             <a:pPr lvl="4"/>
             <a:r>
-              <a:rPr lang="en-US" smtClean="0"/>
+              <a:rPr lang="en-US"/>
               <a:t>Fifth level</a:t>
             </a:r>
-            <a:endParaRPr lang="en-US"/>
           </a:p>
         </p:txBody>
       </p:sp>
@@ -2291,7 +2120,7 @@
           <a:p>
             <a:pPr lvl="0"/>
             <a:r>
-              <a:rPr lang="en-US" smtClean="0"/>
+              <a:rPr lang="en-US"/>
               <a:t>Click to edit Master text styles</a:t>
             </a:r>
           </a:p>
@@ -2347,38 +2176,37 @@
           <a:p>
             <a:pPr lvl="0"/>
             <a:r>
-              <a:rPr lang="en-US" smtClean="0"/>
+              <a:rPr lang="en-US"/>
               <a:t>Click to edit Master text styles</a:t>
             </a:r>
           </a:p>
           <a:p>
             <a:pPr lvl="1"/>
             <a:r>
-              <a:rPr lang="en-US" smtClean="0"/>
+              <a:rPr lang="en-US"/>
               <a:t>Second level</a:t>
             </a:r>
           </a:p>
           <a:p>
             <a:pPr lvl="2"/>
             <a:r>
-              <a:rPr lang="en-US" smtClean="0"/>
+              <a:rPr lang="en-US"/>
               <a:t>Third level</a:t>
             </a:r>
           </a:p>
           <a:p>
             <a:pPr lvl="3"/>
             <a:r>
-              <a:rPr lang="en-US" smtClean="0"/>
+              <a:rPr lang="en-US"/>
               <a:t>Fourth level</a:t>
             </a:r>
           </a:p>
           <a:p>
             <a:pPr lvl="4"/>
             <a:r>
-              <a:rPr lang="en-US" smtClean="0"/>
+              <a:rPr lang="en-US"/>
               <a:t>Fifth level</a:t>
             </a:r>
-            <a:endParaRPr lang="en-US"/>
           </a:p>
         </p:txBody>
       </p:sp>
@@ -2399,7 +2227,7 @@
           <a:p>
             <a:fld id="{5BCAD085-E8A6-8845-BD4E-CB4CCA059FC4}" type="datetimeFigureOut">
               <a:rPr lang="en-US" smtClean="0"/>
-              <a:t>1/27/13</a:t>
+              <a:t>7/28/2026</a:t>
             </a:fld>
             <a:endParaRPr lang="en-US"/>
           </a:p>
@@ -2493,10 +2321,9 @@
           <a:lstStyle/>
           <a:p>
             <a:r>
-              <a:rPr lang="en-US" smtClean="0"/>
+              <a:rPr lang="en-US"/>
               <a:t>Click to edit Master title style</a:t>
             </a:r>
-            <a:endParaRPr lang="en-US"/>
           </a:p>
         </p:txBody>
       </p:sp>
@@ -2517,7 +2344,7 @@
           <a:p>
             <a:fld id="{5BCAD085-E8A6-8845-BD4E-CB4CCA059FC4}" type="datetimeFigureOut">
               <a:rPr lang="en-US" smtClean="0"/>
-              <a:t>1/27/13</a:t>
+              <a:t>7/28/2026</a:t>
             </a:fld>
             <a:endParaRPr lang="en-US"/>
           </a:p>
@@ -2612,7 +2439,7 @@
           <a:p>
             <a:fld id="{5BCAD085-E8A6-8845-BD4E-CB4CCA059FC4}" type="datetimeFigureOut">
               <a:rPr lang="en-US" smtClean="0"/>
-              <a:t>1/27/13</a:t>
+              <a:t>7/28/2026</a:t>
             </a:fld>
             <a:endParaRPr lang="en-US"/>
           </a:p>
@@ -2715,10 +2542,9 @@
           </a:lstStyle>
           <a:p>
             <a:r>
-              <a:rPr lang="en-US" smtClean="0"/>
+              <a:rPr lang="en-US"/>
               <a:t>Click to edit Master title style</a:t>
             </a:r>
-            <a:endParaRPr lang="en-US"/>
           </a:p>
         </p:txBody>
       </p:sp>
@@ -2772,38 +2598,37 @@
           <a:p>
             <a:pPr lvl="0"/>
             <a:r>
-              <a:rPr lang="en-US" smtClean="0"/>
+              <a:rPr lang="en-US"/>
               <a:t>Click to edit Master text styles</a:t>
             </a:r>
           </a:p>
           <a:p>
             <a:pPr lvl="1"/>
             <a:r>
-              <a:rPr lang="en-US" smtClean="0"/>
+              <a:rPr lang="en-US"/>
               <a:t>Second level</a:t>
             </a:r>
           </a:p>
           <a:p>
             <a:pPr lvl="2"/>
             <a:r>
-              <a:rPr lang="en-US" smtClean="0"/>
+              <a:rPr lang="en-US"/>
               <a:t>Third level</a:t>
             </a:r>
           </a:p>
           <a:p>
             <a:pPr lvl="3"/>
             <a:r>
-              <a:rPr lang="en-US" smtClean="0"/>
+              <a:rPr lang="en-US"/>
               <a:t>Fourth level</a:t>
             </a:r>
           </a:p>
           <a:p>
             <a:pPr lvl="4"/>
             <a:r>
-              <a:rPr lang="en-US" smtClean="0"/>
+              <a:rPr lang="en-US"/>
               <a:t>Fifth level</a:t>
             </a:r>
-            <a:endParaRPr lang="en-US"/>
           </a:p>
         </p:txBody>
       </p:sp>
@@ -2866,7 +2691,7 @@
           <a:p>
             <a:pPr lvl="0"/>
             <a:r>
-              <a:rPr lang="en-US" smtClean="0"/>
+              <a:rPr lang="en-US"/>
               <a:t>Click to edit Master text styles</a:t>
             </a:r>
           </a:p>
@@ -2889,7 +2714,7 @@
           <a:p>
             <a:fld id="{5BCAD085-E8A6-8845-BD4E-CB4CCA059FC4}" type="datetimeFigureOut">
               <a:rPr lang="en-US" smtClean="0"/>
-              <a:t>1/27/13</a:t>
+              <a:t>7/28/2026</a:t>
             </a:fld>
             <a:endParaRPr lang="en-US"/>
           </a:p>
@@ -2992,10 +2817,9 @@
           </a:lstStyle>
           <a:p>
             <a:r>
-              <a:rPr lang="en-US" smtClean="0"/>
+              <a:rPr lang="en-US"/>
               <a:t>Click to edit Master title style</a:t>
             </a:r>
-            <a:endParaRPr lang="en-US"/>
           </a:p>
         </p:txBody>
       </p:sp>
@@ -3119,7 +2943,7 @@
           <a:p>
             <a:pPr lvl="0"/>
             <a:r>
-              <a:rPr lang="en-US" smtClean="0"/>
+              <a:rPr lang="en-US"/>
               <a:t>Click to edit Master text styles</a:t>
             </a:r>
           </a:p>
@@ -3142,7 +2966,7 @@
           <a:p>
             <a:fld id="{5BCAD085-E8A6-8845-BD4E-CB4CCA059FC4}" type="datetimeFigureOut">
               <a:rPr lang="en-US" smtClean="0"/>
-              <a:t>1/27/13</a:t>
+              <a:t>7/28/2026</a:t>
             </a:fld>
             <a:endParaRPr lang="en-US"/>
           </a:p>
@@ -3251,10 +3075,9 @@
           <a:lstStyle/>
           <a:p>
             <a:r>
-              <a:rPr lang="en-US" smtClean="0"/>
+              <a:rPr lang="en-US"/>
               <a:t>Click to edit Master title style</a:t>
             </a:r>
-            <a:endParaRPr lang="en-US"/>
           </a:p>
         </p:txBody>
       </p:sp>
@@ -3285,38 +3108,37 @@
           <a:p>
             <a:pPr lvl="0"/>
             <a:r>
-              <a:rPr lang="en-US" smtClean="0"/>
+              <a:rPr lang="en-US"/>
               <a:t>Click to edit Master text styles</a:t>
             </a:r>
           </a:p>
           <a:p>
             <a:pPr lvl="1"/>
             <a:r>
-              <a:rPr lang="en-US" smtClean="0"/>
+              <a:rPr lang="en-US"/>
               <a:t>Second level</a:t>
             </a:r>
           </a:p>
           <a:p>
             <a:pPr lvl="2"/>
             <a:r>
-              <a:rPr lang="en-US" smtClean="0"/>
+              <a:rPr lang="en-US"/>
               <a:t>Third level</a:t>
             </a:r>
           </a:p>
           <a:p>
             <a:pPr lvl="3"/>
             <a:r>
-              <a:rPr lang="en-US" smtClean="0"/>
+              <a:rPr lang="en-US"/>
               <a:t>Fourth level</a:t>
             </a:r>
           </a:p>
           <a:p>
             <a:pPr lvl="4"/>
             <a:r>
-              <a:rPr lang="en-US" smtClean="0"/>
+              <a:rPr lang="en-US"/>
               <a:t>Fifth level</a:t>
             </a:r>
-            <a:endParaRPr lang="en-US"/>
           </a:p>
         </p:txBody>
       </p:sp>
@@ -3355,7 +3177,7 @@
           <a:p>
             <a:fld id="{5BCAD085-E8A6-8845-BD4E-CB4CCA059FC4}" type="datetimeFigureOut">
               <a:rPr lang="en-US" smtClean="0"/>
-              <a:t>1/27/13</a:t>
+              <a:t>7/28/2026</a:t>
             </a:fld>
             <a:endParaRPr lang="en-US"/>
           </a:p>
@@ -3714,7 +3536,7 @@
 </file>
 
 <file path=ppt/slides/slide1.xml><?xml version="1.0" encoding="utf-8"?>
-<p:sld xmlns:a="http://schemas.openxmlformats.org/drawingml/2006/main" xmlns:p="http://schemas.openxmlformats.org/presentationml/2006/main" xmlns:r="http://schemas.openxmlformats.org/officeDocument/2006/relationships">
+<p:sld xmlns:a="http://schemas.openxmlformats.org/drawingml/2006/main" xmlns:r="http://schemas.openxmlformats.org/officeDocument/2006/relationships" xmlns:p="http://schemas.openxmlformats.org/presentationml/2006/main">
   <p:cSld>
     <p:spTree>
       <p:nvGrpSpPr>
@@ -3722,7 +3544,14 @@
         <p:cNvGrpSpPr/>
         <p:nvPr/>
       </p:nvGrpSpPr>
-      <p:grpSpPr/>
+      <p:grpSpPr>
+        <a:xfrm>
+          <a:off x="0" y="0"/>
+          <a:ext cx="0" cy="0"/>
+          <a:chOff x="0" y="0"/>
+          <a:chExt cx="0" cy="0"/>
+        </a:xfrm>
+      </p:grpSpPr>
       <p:sp>
         <p:nvSpPr>
           <p:cNvPr id="2" name="TextBox 1"/>
@@ -3798,7 +3627,7 @@
 </file>
 
 <file path=ppt/slides/slide10.xml><?xml version="1.0" encoding="utf-8"?>
-<p:sld xmlns:a="http://schemas.openxmlformats.org/drawingml/2006/main" xmlns:p="http://schemas.openxmlformats.org/presentationml/2006/main" xmlns:r="http://schemas.openxmlformats.org/officeDocument/2006/relationships">
+<p:sld xmlns:a="http://schemas.openxmlformats.org/drawingml/2006/main" xmlns:r="http://schemas.openxmlformats.org/officeDocument/2006/relationships" xmlns:p="http://schemas.openxmlformats.org/presentationml/2006/main">
   <p:cSld>
     <p:spTree>
       <p:nvGrpSpPr>
@@ -3806,7 +3635,14 @@
         <p:cNvGrpSpPr/>
         <p:nvPr/>
       </p:nvGrpSpPr>
-      <p:grpSpPr/>
+      <p:grpSpPr>
+        <a:xfrm>
+          <a:off x="0" y="0"/>
+          <a:ext cx="0" cy="0"/>
+          <a:chOff x="0" y="0"/>
+          <a:chExt cx="0" cy="0"/>
+        </a:xfrm>
+      </p:grpSpPr>
       <p:sp>
         <p:nvSpPr>
           <p:cNvPr id="2" name="TextBox 1"/>
@@ -3898,6 +3734,7 @@
           <a:lstStyle/>
           <a:p>
             <a:pPr algn="ctr"/>
+            <a:endParaRPr/>
           </a:p>
         </p:txBody>
       </p:sp>
@@ -4039,7 +3876,7 @@
 </file>
 
 <file path=ppt/slides/slide11.xml><?xml version="1.0" encoding="utf-8"?>
-<p:sld xmlns:a="http://schemas.openxmlformats.org/drawingml/2006/main" xmlns:p="http://schemas.openxmlformats.org/presentationml/2006/main" xmlns:r="http://schemas.openxmlformats.org/officeDocument/2006/relationships">
+<p:sld xmlns:a="http://schemas.openxmlformats.org/drawingml/2006/main" xmlns:r="http://schemas.openxmlformats.org/officeDocument/2006/relationships" xmlns:p="http://schemas.openxmlformats.org/presentationml/2006/main">
   <p:cSld>
     <p:spTree>
       <p:nvGrpSpPr>
@@ -4047,7 +3884,14 @@
         <p:cNvGrpSpPr/>
         <p:nvPr/>
       </p:nvGrpSpPr>
-      <p:grpSpPr/>
+      <p:grpSpPr>
+        <a:xfrm>
+          <a:off x="0" y="0"/>
+          <a:ext cx="0" cy="0"/>
+          <a:chOff x="0" y="0"/>
+          <a:chExt cx="0" cy="0"/>
+        </a:xfrm>
+      </p:grpSpPr>
       <p:sp>
         <p:nvSpPr>
           <p:cNvPr id="2" name="TextBox 1"/>
@@ -4139,6 +3983,7 @@
           <a:lstStyle/>
           <a:p>
             <a:pPr algn="ctr"/>
+            <a:endParaRPr/>
           </a:p>
         </p:txBody>
       </p:sp>
@@ -4151,7 +3996,7 @@
           <p:nvPr/>
         </p:nvPicPr>
         <p:blipFill>
-          <a:blip r:embed="rId2"/>
+          <a:blip r:embed="rId3"/>
           <a:stretch>
             <a:fillRect/>
           </a:stretch>
@@ -4280,7 +4125,7 @@
 </file>
 
 <file path=ppt/slides/slide12.xml><?xml version="1.0" encoding="utf-8"?>
-<p:sld xmlns:a="http://schemas.openxmlformats.org/drawingml/2006/main" xmlns:p="http://schemas.openxmlformats.org/presentationml/2006/main" xmlns:r="http://schemas.openxmlformats.org/officeDocument/2006/relationships">
+<p:sld xmlns:a="http://schemas.openxmlformats.org/drawingml/2006/main" xmlns:r="http://schemas.openxmlformats.org/officeDocument/2006/relationships" xmlns:p="http://schemas.openxmlformats.org/presentationml/2006/main">
   <p:cSld>
     <p:spTree>
       <p:nvGrpSpPr>
@@ -4288,7 +4133,14 @@
         <p:cNvGrpSpPr/>
         <p:nvPr/>
       </p:nvGrpSpPr>
-      <p:grpSpPr/>
+      <p:grpSpPr>
+        <a:xfrm>
+          <a:off x="0" y="0"/>
+          <a:ext cx="0" cy="0"/>
+          <a:chOff x="0" y="0"/>
+          <a:chExt cx="0" cy="0"/>
+        </a:xfrm>
+      </p:grpSpPr>
       <p:sp>
         <p:nvSpPr>
           <p:cNvPr id="2" name="TextBox 1"/>
@@ -4380,6 +4232,7 @@
           <a:lstStyle/>
           <a:p>
             <a:pPr algn="ctr"/>
+            <a:endParaRPr/>
           </a:p>
         </p:txBody>
       </p:sp>
@@ -4521,7 +4374,7 @@
 </file>
 
 <file path=ppt/slides/slide13.xml><?xml version="1.0" encoding="utf-8"?>
-<p:sld xmlns:a="http://schemas.openxmlformats.org/drawingml/2006/main" xmlns:p="http://schemas.openxmlformats.org/presentationml/2006/main" xmlns:r="http://schemas.openxmlformats.org/officeDocument/2006/relationships">
+<p:sld xmlns:a="http://schemas.openxmlformats.org/drawingml/2006/main" xmlns:r="http://schemas.openxmlformats.org/officeDocument/2006/relationships" xmlns:p="http://schemas.openxmlformats.org/presentationml/2006/main">
   <p:cSld>
     <p:spTree>
       <p:nvGrpSpPr>
@@ -4529,7 +4382,14 @@
         <p:cNvGrpSpPr/>
         <p:nvPr/>
       </p:nvGrpSpPr>
-      <p:grpSpPr/>
+      <p:grpSpPr>
+        <a:xfrm>
+          <a:off x="0" y="0"/>
+          <a:ext cx="0" cy="0"/>
+          <a:chOff x="0" y="0"/>
+          <a:chExt cx="0" cy="0"/>
+        </a:xfrm>
+      </p:grpSpPr>
       <p:sp>
         <p:nvSpPr>
           <p:cNvPr id="2" name="TextBox 1"/>
@@ -4621,6 +4481,7 @@
           <a:lstStyle/>
           <a:p>
             <a:pPr algn="ctr"/>
+            <a:endParaRPr/>
           </a:p>
         </p:txBody>
       </p:sp>
@@ -4746,7 +4607,7 @@
 </file>
 
 <file path=ppt/slides/slide14.xml><?xml version="1.0" encoding="utf-8"?>
-<p:sld xmlns:a="http://schemas.openxmlformats.org/drawingml/2006/main" xmlns:p="http://schemas.openxmlformats.org/presentationml/2006/main" xmlns:r="http://schemas.openxmlformats.org/officeDocument/2006/relationships">
+<p:sld xmlns:a="http://schemas.openxmlformats.org/drawingml/2006/main" xmlns:r="http://schemas.openxmlformats.org/officeDocument/2006/relationships" xmlns:p="http://schemas.openxmlformats.org/presentationml/2006/main">
   <p:cSld>
     <p:spTree>
       <p:nvGrpSpPr>
@@ -4754,7 +4615,14 @@
         <p:cNvGrpSpPr/>
         <p:nvPr/>
       </p:nvGrpSpPr>
-      <p:grpSpPr/>
+      <p:grpSpPr>
+        <a:xfrm>
+          <a:off x="0" y="0"/>
+          <a:ext cx="0" cy="0"/>
+          <a:chOff x="0" y="0"/>
+          <a:chExt cx="0" cy="0"/>
+        </a:xfrm>
+      </p:grpSpPr>
       <p:sp>
         <p:nvSpPr>
           <p:cNvPr id="2" name="TextBox 1"/>
@@ -4846,6 +4714,7 @@
           <a:lstStyle/>
           <a:p>
             <a:pPr algn="ctr"/>
+            <a:endParaRPr/>
           </a:p>
         </p:txBody>
       </p:sp>
@@ -5099,7 +4968,7 @@
 </file>
 
 <file path=ppt/slides/slide15.xml><?xml version="1.0" encoding="utf-8"?>
-<p:sld xmlns:a="http://schemas.openxmlformats.org/drawingml/2006/main" xmlns:p="http://schemas.openxmlformats.org/presentationml/2006/main" xmlns:r="http://schemas.openxmlformats.org/officeDocument/2006/relationships">
+<p:sld xmlns:a="http://schemas.openxmlformats.org/drawingml/2006/main" xmlns:r="http://schemas.openxmlformats.org/officeDocument/2006/relationships" xmlns:p="http://schemas.openxmlformats.org/presentationml/2006/main">
   <p:cSld>
     <p:spTree>
       <p:nvGrpSpPr>
@@ -5107,7 +4976,14 @@
         <p:cNvGrpSpPr/>
         <p:nvPr/>
       </p:nvGrpSpPr>
-      <p:grpSpPr/>
+      <p:grpSpPr>
+        <a:xfrm>
+          <a:off x="0" y="0"/>
+          <a:ext cx="0" cy="0"/>
+          <a:chOff x="0" y="0"/>
+          <a:chExt cx="0" cy="0"/>
+        </a:xfrm>
+      </p:grpSpPr>
       <p:sp>
         <p:nvSpPr>
           <p:cNvPr id="2" name="TextBox 1"/>
@@ -5199,6 +5075,7 @@
           <a:lstStyle/>
           <a:p>
             <a:pPr algn="ctr"/>
+            <a:endParaRPr/>
           </a:p>
         </p:txBody>
       </p:sp>
@@ -5492,7 +5369,7 @@
 </file>
 
 <file path=ppt/slides/slide16.xml><?xml version="1.0" encoding="utf-8"?>
-<p:sld xmlns:a="http://schemas.openxmlformats.org/drawingml/2006/main" xmlns:p="http://schemas.openxmlformats.org/presentationml/2006/main" xmlns:r="http://schemas.openxmlformats.org/officeDocument/2006/relationships">
+<p:sld xmlns:a="http://schemas.openxmlformats.org/drawingml/2006/main" xmlns:r="http://schemas.openxmlformats.org/officeDocument/2006/relationships" xmlns:p="http://schemas.openxmlformats.org/presentationml/2006/main">
   <p:cSld>
     <p:spTree>
       <p:nvGrpSpPr>
@@ -5500,7 +5377,14 @@
         <p:cNvGrpSpPr/>
         <p:nvPr/>
       </p:nvGrpSpPr>
-      <p:grpSpPr/>
+      <p:grpSpPr>
+        <a:xfrm>
+          <a:off x="0" y="0"/>
+          <a:ext cx="0" cy="0"/>
+          <a:chOff x="0" y="0"/>
+          <a:chExt cx="0" cy="0"/>
+        </a:xfrm>
+      </p:grpSpPr>
       <p:sp>
         <p:nvSpPr>
           <p:cNvPr id="2" name="TextBox 1"/>
@@ -5592,6 +5476,7 @@
           <a:lstStyle/>
           <a:p>
             <a:pPr algn="ctr"/>
+            <a:endParaRPr/>
           </a:p>
         </p:txBody>
       </p:sp>
@@ -6052,7 +5937,7 @@
 </file>
 
 <file path=ppt/slides/slide2.xml><?xml version="1.0" encoding="utf-8"?>
-<p:sld xmlns:a="http://schemas.openxmlformats.org/drawingml/2006/main" xmlns:p="http://schemas.openxmlformats.org/presentationml/2006/main" xmlns:r="http://schemas.openxmlformats.org/officeDocument/2006/relationships">
+<p:sld xmlns:a="http://schemas.openxmlformats.org/drawingml/2006/main" xmlns:r="http://schemas.openxmlformats.org/officeDocument/2006/relationships" xmlns:p="http://schemas.openxmlformats.org/presentationml/2006/main">
   <p:cSld>
     <p:spTree>
       <p:nvGrpSpPr>
@@ -6060,7 +5945,14 @@
         <p:cNvGrpSpPr/>
         <p:nvPr/>
       </p:nvGrpSpPr>
-      <p:grpSpPr/>
+      <p:grpSpPr>
+        <a:xfrm>
+          <a:off x="0" y="0"/>
+          <a:ext cx="0" cy="0"/>
+          <a:chOff x="0" y="0"/>
+          <a:chExt cx="0" cy="0"/>
+        </a:xfrm>
+      </p:grpSpPr>
       <p:sp>
         <p:nvSpPr>
           <p:cNvPr id="2" name="TextBox 1"/>
@@ -6152,6 +6044,7 @@
           <a:lstStyle/>
           <a:p>
             <a:pPr algn="ctr"/>
+            <a:endParaRPr/>
           </a:p>
         </p:txBody>
       </p:sp>
@@ -6413,7 +6306,7 @@
 </file>
 
 <file path=ppt/slides/slide3.xml><?xml version="1.0" encoding="utf-8"?>
-<p:sld xmlns:a="http://schemas.openxmlformats.org/drawingml/2006/main" xmlns:p="http://schemas.openxmlformats.org/presentationml/2006/main" xmlns:r="http://schemas.openxmlformats.org/officeDocument/2006/relationships">
+<p:sld xmlns:a="http://schemas.openxmlformats.org/drawingml/2006/main" xmlns:r="http://schemas.openxmlformats.org/officeDocument/2006/relationships" xmlns:p="http://schemas.openxmlformats.org/presentationml/2006/main">
   <p:cSld>
     <p:spTree>
       <p:nvGrpSpPr>
@@ -6421,7 +6314,14 @@
         <p:cNvGrpSpPr/>
         <p:nvPr/>
       </p:nvGrpSpPr>
-      <p:grpSpPr/>
+      <p:grpSpPr>
+        <a:xfrm>
+          <a:off x="0" y="0"/>
+          <a:ext cx="0" cy="0"/>
+          <a:chOff x="0" y="0"/>
+          <a:chExt cx="0" cy="0"/>
+        </a:xfrm>
+      </p:grpSpPr>
       <p:sp>
         <p:nvSpPr>
           <p:cNvPr id="2" name="TextBox 1"/>
@@ -6513,6 +6413,7 @@
           <a:lstStyle/>
           <a:p>
             <a:pPr algn="ctr"/>
+            <a:endParaRPr/>
           </a:p>
         </p:txBody>
       </p:sp>
@@ -6756,7 +6657,7 @@
 </file>
 
 <file path=ppt/slides/slide4.xml><?xml version="1.0" encoding="utf-8"?>
-<p:sld xmlns:a="http://schemas.openxmlformats.org/drawingml/2006/main" xmlns:p="http://schemas.openxmlformats.org/presentationml/2006/main" xmlns:r="http://schemas.openxmlformats.org/officeDocument/2006/relationships">
+<p:sld xmlns:a="http://schemas.openxmlformats.org/drawingml/2006/main" xmlns:r="http://schemas.openxmlformats.org/officeDocument/2006/relationships" xmlns:p="http://schemas.openxmlformats.org/presentationml/2006/main">
   <p:cSld>
     <p:spTree>
       <p:nvGrpSpPr>
@@ -6764,7 +6665,14 @@
         <p:cNvGrpSpPr/>
         <p:nvPr/>
       </p:nvGrpSpPr>
-      <p:grpSpPr/>
+      <p:grpSpPr>
+        <a:xfrm>
+          <a:off x="0" y="0"/>
+          <a:ext cx="0" cy="0"/>
+          <a:chOff x="0" y="0"/>
+          <a:chExt cx="0" cy="0"/>
+        </a:xfrm>
+      </p:grpSpPr>
       <p:sp>
         <p:nvSpPr>
           <p:cNvPr id="2" name="TextBox 1"/>
@@ -6856,6 +6764,7 @@
           <a:lstStyle/>
           <a:p>
             <a:pPr algn="ctr"/>
+            <a:endParaRPr/>
           </a:p>
         </p:txBody>
       </p:sp>
@@ -7131,7 +7040,7 @@
 </file>
 
 <file path=ppt/slides/slide5.xml><?xml version="1.0" encoding="utf-8"?>
-<p:sld xmlns:a="http://schemas.openxmlformats.org/drawingml/2006/main" xmlns:p="http://schemas.openxmlformats.org/presentationml/2006/main" xmlns:r="http://schemas.openxmlformats.org/officeDocument/2006/relationships">
+<p:sld xmlns:a="http://schemas.openxmlformats.org/drawingml/2006/main" xmlns:r="http://schemas.openxmlformats.org/officeDocument/2006/relationships" xmlns:p="http://schemas.openxmlformats.org/presentationml/2006/main">
   <p:cSld>
     <p:spTree>
       <p:nvGrpSpPr>
@@ -7139,7 +7048,14 @@
         <p:cNvGrpSpPr/>
         <p:nvPr/>
       </p:nvGrpSpPr>
-      <p:grpSpPr/>
+      <p:grpSpPr>
+        <a:xfrm>
+          <a:off x="0" y="0"/>
+          <a:ext cx="0" cy="0"/>
+          <a:chOff x="0" y="0"/>
+          <a:chExt cx="0" cy="0"/>
+        </a:xfrm>
+      </p:grpSpPr>
       <p:sp>
         <p:nvSpPr>
           <p:cNvPr id="2" name="TextBox 1"/>
@@ -7231,6 +7147,7 @@
           <a:lstStyle/>
           <a:p>
             <a:pPr algn="ctr"/>
+            <a:endParaRPr/>
           </a:p>
         </p:txBody>
       </p:sp>
@@ -7250,8 +7167,8 @@
         </p:blipFill>
         <p:spPr>
           <a:xfrm>
-            <a:off x="-333124" y="1645920"/>
-            <a:ext cx="12857944" cy="3108960"/>
+            <a:off x="566057" y="1655445"/>
+            <a:ext cx="10706906" cy="2588854"/>
           </a:xfrm>
           <a:prstGeom prst="rect">
             <a:avLst/>
@@ -7322,7 +7239,7 @@
 </file>
 
 <file path=ppt/slides/slide6.xml><?xml version="1.0" encoding="utf-8"?>
-<p:sld xmlns:a="http://schemas.openxmlformats.org/drawingml/2006/main" xmlns:p="http://schemas.openxmlformats.org/presentationml/2006/main" xmlns:r="http://schemas.openxmlformats.org/officeDocument/2006/relationships">
+<p:sld xmlns:a="http://schemas.openxmlformats.org/drawingml/2006/main" xmlns:r="http://schemas.openxmlformats.org/officeDocument/2006/relationships" xmlns:p="http://schemas.openxmlformats.org/presentationml/2006/main">
   <p:cSld>
     <p:spTree>
       <p:nvGrpSpPr>
@@ -7330,7 +7247,14 @@
         <p:cNvGrpSpPr/>
         <p:nvPr/>
       </p:nvGrpSpPr>
-      <p:grpSpPr/>
+      <p:grpSpPr>
+        <a:xfrm>
+          <a:off x="0" y="0"/>
+          <a:ext cx="0" cy="0"/>
+          <a:chOff x="0" y="0"/>
+          <a:chExt cx="0" cy="0"/>
+        </a:xfrm>
+      </p:grpSpPr>
       <p:sp>
         <p:nvSpPr>
           <p:cNvPr id="2" name="TextBox 1"/>
@@ -7422,6 +7346,7 @@
           <a:lstStyle/>
           <a:p>
             <a:pPr algn="ctr"/>
+            <a:endParaRPr/>
           </a:p>
         </p:txBody>
       </p:sp>
@@ -7593,7 +7518,7 @@
 </file>
 
 <file path=ppt/slides/slide7.xml><?xml version="1.0" encoding="utf-8"?>
-<p:sld xmlns:a="http://schemas.openxmlformats.org/drawingml/2006/main" xmlns:p="http://schemas.openxmlformats.org/presentationml/2006/main" xmlns:r="http://schemas.openxmlformats.org/officeDocument/2006/relationships">
+<p:sld xmlns:a="http://schemas.openxmlformats.org/drawingml/2006/main" xmlns:r="http://schemas.openxmlformats.org/officeDocument/2006/relationships" xmlns:p="http://schemas.openxmlformats.org/presentationml/2006/main">
   <p:cSld>
     <p:spTree>
       <p:nvGrpSpPr>
@@ -7601,7 +7526,14 @@
         <p:cNvGrpSpPr/>
         <p:nvPr/>
       </p:nvGrpSpPr>
-      <p:grpSpPr/>
+      <p:grpSpPr>
+        <a:xfrm>
+          <a:off x="0" y="0"/>
+          <a:ext cx="0" cy="0"/>
+          <a:chOff x="0" y="0"/>
+          <a:chExt cx="0" cy="0"/>
+        </a:xfrm>
+      </p:grpSpPr>
       <p:sp>
         <p:nvSpPr>
           <p:cNvPr id="2" name="TextBox 1"/>
@@ -7693,6 +7625,7 @@
           <a:lstStyle/>
           <a:p>
             <a:pPr algn="ctr"/>
+            <a:endParaRPr/>
           </a:p>
         </p:txBody>
       </p:sp>
@@ -7784,7 +7717,7 @@
 </file>
 
 <file path=ppt/slides/slide8.xml><?xml version="1.0" encoding="utf-8"?>
-<p:sld xmlns:a="http://schemas.openxmlformats.org/drawingml/2006/main" xmlns:p="http://schemas.openxmlformats.org/presentationml/2006/main" xmlns:r="http://schemas.openxmlformats.org/officeDocument/2006/relationships">
+<p:sld xmlns:a="http://schemas.openxmlformats.org/drawingml/2006/main" xmlns:r="http://schemas.openxmlformats.org/officeDocument/2006/relationships" xmlns:p="http://schemas.openxmlformats.org/presentationml/2006/main">
   <p:cSld>
     <p:spTree>
       <p:nvGrpSpPr>
@@ -7792,7 +7725,14 @@
         <p:cNvGrpSpPr/>
         <p:nvPr/>
       </p:nvGrpSpPr>
-      <p:grpSpPr/>
+      <p:grpSpPr>
+        <a:xfrm>
+          <a:off x="0" y="0"/>
+          <a:ext cx="0" cy="0"/>
+          <a:chOff x="0" y="0"/>
+          <a:chExt cx="0" cy="0"/>
+        </a:xfrm>
+      </p:grpSpPr>
       <p:sp>
         <p:nvSpPr>
           <p:cNvPr id="2" name="TextBox 1"/>
@@ -7884,6 +7824,7 @@
           <a:lstStyle/>
           <a:p>
             <a:pPr algn="ctr"/>
+            <a:endParaRPr/>
           </a:p>
         </p:txBody>
       </p:sp>
@@ -8176,7 +8117,7 @@
 </file>
 
 <file path=ppt/slides/slide9.xml><?xml version="1.0" encoding="utf-8"?>
-<p:sld xmlns:a="http://schemas.openxmlformats.org/drawingml/2006/main" xmlns:p="http://schemas.openxmlformats.org/presentationml/2006/main" xmlns:r="http://schemas.openxmlformats.org/officeDocument/2006/relationships">
+<p:sld xmlns:a="http://schemas.openxmlformats.org/drawingml/2006/main" xmlns:r="http://schemas.openxmlformats.org/officeDocument/2006/relationships" xmlns:p="http://schemas.openxmlformats.org/presentationml/2006/main">
   <p:cSld>
     <p:spTree>
       <p:nvGrpSpPr>
@@ -8184,7 +8125,14 @@
         <p:cNvGrpSpPr/>
         <p:nvPr/>
       </p:nvGrpSpPr>
-      <p:grpSpPr/>
+      <p:grpSpPr>
+        <a:xfrm>
+          <a:off x="0" y="0"/>
+          <a:ext cx="0" cy="0"/>
+          <a:chOff x="0" y="0"/>
+          <a:chExt cx="0" cy="0"/>
+        </a:xfrm>
+      </p:grpSpPr>
       <p:sp>
         <p:nvSpPr>
           <p:cNvPr id="2" name="TextBox 1"/>
@@ -8276,6 +8224,7 @@
           <a:lstStyle/>
           <a:p>
             <a:pPr algn="ctr"/>
+            <a:endParaRPr/>
           </a:p>
         </p:txBody>
       </p:sp>
@@ -8811,44 +8760,44 @@
         <a:sysClr val="window" lastClr="FFFFFF"/>
       </a:lt1>
       <a:dk2>
-        <a:srgbClr val="1F497D"/>
+        <a:srgbClr val="0E2841"/>
       </a:dk2>
       <a:lt2>
-        <a:srgbClr val="EEECE1"/>
+        <a:srgbClr val="E8E8E8"/>
       </a:lt2>
       <a:accent1>
-        <a:srgbClr val="4F81BD"/>
+        <a:srgbClr val="156082"/>
       </a:accent1>
       <a:accent2>
-        <a:srgbClr val="C0504D"/>
+        <a:srgbClr val="E97132"/>
       </a:accent2>
       <a:accent3>
-        <a:srgbClr val="9BBB59"/>
+        <a:srgbClr val="196B24"/>
       </a:accent3>
       <a:accent4>
-        <a:srgbClr val="8064A2"/>
+        <a:srgbClr val="0F9ED5"/>
       </a:accent4>
       <a:accent5>
-        <a:srgbClr val="4BACC6"/>
+        <a:srgbClr val="A02B93"/>
       </a:accent5>
       <a:accent6>
-        <a:srgbClr val="F79646"/>
+        <a:srgbClr val="4EA72E"/>
       </a:accent6>
       <a:hlink>
-        <a:srgbClr val="0000FF"/>
+        <a:srgbClr val="467886"/>
       </a:hlink>
       <a:folHlink>
-        <a:srgbClr val="800080"/>
+        <a:srgbClr val="96607D"/>
       </a:folHlink>
     </a:clrScheme>
     <a:fontScheme name="Office">
       <a:majorFont>
-        <a:latin typeface="Calibri"/>
+        <a:latin typeface="Aptos Display" panose="02110004020202020204"/>
         <a:ea typeface=""/>
         <a:cs typeface=""/>
-        <a:font script="Jpan" typeface="ＭＳ Ｐゴシック"/>
+        <a:font script="Jpan" typeface="游ゴシック Light"/>
         <a:font script="Hang" typeface="맑은 고딕"/>
-        <a:font script="Hans" typeface="宋体"/>
+        <a:font script="Hans" typeface="等线 Light"/>
         <a:font script="Hant" typeface="新細明體"/>
         <a:font script="Arab" typeface="Times New Roman"/>
         <a:font script="Hebr" typeface="Times New Roman"/>
@@ -8876,14 +8825,31 @@
         <a:font script="Viet" typeface="Times New Roman"/>
         <a:font script="Uigh" typeface="Microsoft Uighur"/>
         <a:font script="Geor" typeface="Sylfaen"/>
+        <a:font script="Armn" typeface="Arial"/>
+        <a:font script="Bugi" typeface="Leelawadee UI"/>
+        <a:font script="Bopo" typeface="Microsoft JhengHei"/>
+        <a:font script="Java" typeface="Javanese Text"/>
+        <a:font script="Lisu" typeface="Segoe UI"/>
+        <a:font script="Mymr" typeface="Myanmar Text"/>
+        <a:font script="Nkoo" typeface="Ebrima"/>
+        <a:font script="Olck" typeface="Nirmala UI"/>
+        <a:font script="Osma" typeface="Ebrima"/>
+        <a:font script="Phag" typeface="Phagspa"/>
+        <a:font script="Syrn" typeface="Estrangelo Edessa"/>
+        <a:font script="Syrj" typeface="Estrangelo Edessa"/>
+        <a:font script="Syre" typeface="Estrangelo Edessa"/>
+        <a:font script="Sora" typeface="Nirmala UI"/>
+        <a:font script="Tale" typeface="Microsoft Tai Le"/>
+        <a:font script="Talu" typeface="Microsoft New Tai Lue"/>
+        <a:font script="Tfng" typeface="Ebrima"/>
       </a:majorFont>
       <a:minorFont>
-        <a:latin typeface="Calibri"/>
+        <a:latin typeface="Aptos" panose="02110004020202020204"/>
         <a:ea typeface=""/>
         <a:cs typeface=""/>
-        <a:font script="Jpan" typeface="ＭＳ Ｐゴシック"/>
+        <a:font script="Jpan" typeface="游ゴシック"/>
         <a:font script="Hang" typeface="맑은 고딕"/>
-        <a:font script="Hans" typeface="宋体"/>
+        <a:font script="Hans" typeface="等线"/>
         <a:font script="Hant" typeface="新細明體"/>
         <a:font script="Arab" typeface="Arial"/>
         <a:font script="Hebr" typeface="Arial"/>
@@ -8911,6 +8877,23 @@
         <a:font script="Viet" typeface="Arial"/>
         <a:font script="Uigh" typeface="Microsoft Uighur"/>
         <a:font script="Geor" typeface="Sylfaen"/>
+        <a:font script="Armn" typeface="Arial"/>
+        <a:font script="Bugi" typeface="Leelawadee UI"/>
+        <a:font script="Bopo" typeface="Microsoft JhengHei"/>
+        <a:font script="Java" typeface="Javanese Text"/>
+        <a:font script="Lisu" typeface="Segoe UI"/>
+        <a:font script="Mymr" typeface="Myanmar Text"/>
+        <a:font script="Nkoo" typeface="Ebrima"/>
+        <a:font script="Olck" typeface="Nirmala UI"/>
+        <a:font script="Osma" typeface="Ebrima"/>
+        <a:font script="Phag" typeface="Phagspa"/>
+        <a:font script="Syrn" typeface="Estrangelo Edessa"/>
+        <a:font script="Syrj" typeface="Estrangelo Edessa"/>
+        <a:font script="Syre" typeface="Estrangelo Edessa"/>
+        <a:font script="Sora" typeface="Nirmala UI"/>
+        <a:font script="Tale" typeface="Microsoft Tai Le"/>
+        <a:font script="Talu" typeface="Microsoft New Tai Lue"/>
+        <a:font script="Tfng" typeface="Ebrima"/>
       </a:minorFont>
     </a:fontScheme>
     <a:fmtScheme name="Office">
@@ -8922,180 +8905,136 @@
           <a:gsLst>
             <a:gs pos="0">
               <a:schemeClr val="phClr">
-                <a:tint val="50000"/>
-                <a:satMod val="300000"/>
+                <a:lumMod val="110000"/>
+                <a:satMod val="105000"/>
+                <a:tint val="67000"/>
               </a:schemeClr>
             </a:gs>
-            <a:gs pos="35000">
+            <a:gs pos="50000">
               <a:schemeClr val="phClr">
-                <a:tint val="37000"/>
-                <a:satMod val="300000"/>
+                <a:lumMod val="105000"/>
+                <a:satMod val="103000"/>
+                <a:tint val="73000"/>
               </a:schemeClr>
             </a:gs>
             <a:gs pos="100000">
               <a:schemeClr val="phClr">
-                <a:tint val="15000"/>
-                <a:satMod val="350000"/>
+                <a:lumMod val="105000"/>
+                <a:satMod val="109000"/>
+                <a:tint val="81000"/>
               </a:schemeClr>
             </a:gs>
           </a:gsLst>
-          <a:lin ang="16200000" scaled="1"/>
+          <a:lin ang="5400000" scaled="0"/>
         </a:gradFill>
         <a:gradFill rotWithShape="1">
           <a:gsLst>
             <a:gs pos="0">
               <a:schemeClr val="phClr">
-                <a:tint val="100000"/>
+                <a:satMod val="103000"/>
+                <a:lumMod val="102000"/>
+                <a:tint val="94000"/>
+              </a:schemeClr>
+            </a:gs>
+            <a:gs pos="50000">
+              <a:schemeClr val="phClr">
+                <a:satMod val="110000"/>
+                <a:lumMod val="100000"/>
                 <a:shade val="100000"/>
-                <a:satMod val="130000"/>
               </a:schemeClr>
             </a:gs>
             <a:gs pos="100000">
               <a:schemeClr val="phClr">
-                <a:tint val="50000"/>
-                <a:shade val="100000"/>
-                <a:satMod val="350000"/>
+                <a:lumMod val="99000"/>
+                <a:satMod val="120000"/>
+                <a:shade val="78000"/>
               </a:schemeClr>
             </a:gs>
           </a:gsLst>
-          <a:lin ang="16200000" scaled="0"/>
+          <a:lin ang="5400000" scaled="0"/>
         </a:gradFill>
       </a:fillStyleLst>
       <a:lnStyleLst>
-        <a:ln w="9525" cap="flat" cmpd="sng" algn="ctr">
+        <a:ln w="12700" cap="flat" cmpd="sng" algn="ctr">
           <a:solidFill>
-            <a:schemeClr val="phClr">
-              <a:shade val="95000"/>
-              <a:satMod val="105000"/>
-            </a:schemeClr>
+            <a:schemeClr val="phClr"/>
           </a:solidFill>
           <a:prstDash val="solid"/>
+          <a:miter lim="800000"/>
+        </a:ln>
+        <a:ln w="19050" cap="flat" cmpd="sng" algn="ctr">
+          <a:solidFill>
+            <a:schemeClr val="phClr"/>
+          </a:solidFill>
+          <a:prstDash val="solid"/>
+          <a:miter lim="800000"/>
         </a:ln>
         <a:ln w="25400" cap="flat" cmpd="sng" algn="ctr">
           <a:solidFill>
             <a:schemeClr val="phClr"/>
           </a:solidFill>
           <a:prstDash val="solid"/>
-        </a:ln>
-        <a:ln w="38100" cap="flat" cmpd="sng" algn="ctr">
-          <a:solidFill>
-            <a:schemeClr val="phClr"/>
-          </a:solidFill>
-          <a:prstDash val="solid"/>
+          <a:miter lim="800000"/>
         </a:ln>
       </a:lnStyleLst>
       <a:effectStyleLst>
         <a:effectStyle>
+          <a:effectLst/>
+        </a:effectStyle>
+        <a:effectStyle>
+          <a:effectLst/>
+        </a:effectStyle>
+        <a:effectStyle>
           <a:effectLst>
-            <a:outerShdw blurRad="40000" dist="20000" dir="5400000" rotWithShape="0">
+            <a:outerShdw blurRad="57150" dist="19050" dir="5400000" algn="ctr" rotWithShape="0">
               <a:srgbClr val="000000">
-                <a:alpha val="38000"/>
+                <a:alpha val="63000"/>
               </a:srgbClr>
             </a:outerShdw>
           </a:effectLst>
-        </a:effectStyle>
-        <a:effectStyle>
-          <a:effectLst>
-            <a:outerShdw blurRad="40000" dist="23000" dir="5400000" rotWithShape="0">
-              <a:srgbClr val="000000">
-                <a:alpha val="35000"/>
-              </a:srgbClr>
-            </a:outerShdw>
-          </a:effectLst>
-        </a:effectStyle>
-        <a:effectStyle>
-          <a:effectLst>
-            <a:outerShdw blurRad="40000" dist="23000" dir="5400000" rotWithShape="0">
-              <a:srgbClr val="000000">
-                <a:alpha val="35000"/>
-              </a:srgbClr>
-            </a:outerShdw>
-          </a:effectLst>
-          <a:scene3d>
-            <a:camera prst="orthographicFront">
-              <a:rot lat="0" lon="0" rev="0"/>
-            </a:camera>
-            <a:lightRig rig="threePt" dir="t">
-              <a:rot lat="0" lon="0" rev="1200000"/>
-            </a:lightRig>
-          </a:scene3d>
-          <a:sp3d>
-            <a:bevelT w="63500" h="25400"/>
-          </a:sp3d>
         </a:effectStyle>
       </a:effectStyleLst>
       <a:bgFillStyleLst>
         <a:solidFill>
           <a:schemeClr val="phClr"/>
         </a:solidFill>
+        <a:solidFill>
+          <a:schemeClr val="phClr">
+            <a:tint val="95000"/>
+            <a:satMod val="170000"/>
+          </a:schemeClr>
+        </a:solidFill>
         <a:gradFill rotWithShape="1">
           <a:gsLst>
             <a:gs pos="0">
               <a:schemeClr val="phClr">
-                <a:tint val="40000"/>
-                <a:satMod val="350000"/>
+                <a:tint val="93000"/>
+                <a:satMod val="150000"/>
+                <a:shade val="98000"/>
+                <a:lumMod val="102000"/>
               </a:schemeClr>
             </a:gs>
-            <a:gs pos="40000">
+            <a:gs pos="50000">
               <a:schemeClr val="phClr">
-                <a:tint val="45000"/>
-                <a:shade val="99000"/>
-                <a:satMod val="350000"/>
+                <a:tint val="98000"/>
+                <a:satMod val="130000"/>
+                <a:shade val="90000"/>
+                <a:lumMod val="103000"/>
               </a:schemeClr>
             </a:gs>
             <a:gs pos="100000">
               <a:schemeClr val="phClr">
-                <a:shade val="20000"/>
-                <a:satMod val="255000"/>
+                <a:shade val="63000"/>
+                <a:satMod val="120000"/>
               </a:schemeClr>
             </a:gs>
           </a:gsLst>
-          <a:path path="circle">
-            <a:fillToRect l="50000" t="-80000" r="50000" b="180000"/>
-          </a:path>
-        </a:gradFill>
-        <a:gradFill rotWithShape="1">
-          <a:gsLst>
-            <a:gs pos="0">
-              <a:schemeClr val="phClr">
-                <a:tint val="80000"/>
-                <a:satMod val="300000"/>
-              </a:schemeClr>
-            </a:gs>
-            <a:gs pos="100000">
-              <a:schemeClr val="phClr">
-                <a:shade val="30000"/>
-                <a:satMod val="200000"/>
-              </a:schemeClr>
-            </a:gs>
-          </a:gsLst>
-          <a:path path="circle">
-            <a:fillToRect l="50000" t="50000" r="50000" b="50000"/>
-          </a:path>
+          <a:lin ang="5400000" scaled="0"/>
         </a:gradFill>
       </a:bgFillStyleLst>
     </a:fmtScheme>
   </a:themeElements>
   <a:objectDefaults>
-    <a:spDef>
-      <a:spPr/>
-      <a:bodyPr/>
-      <a:lstStyle/>
-      <a:style>
-        <a:lnRef idx="1">
-          <a:schemeClr val="accent1"/>
-        </a:lnRef>
-        <a:fillRef idx="3">
-          <a:schemeClr val="accent1"/>
-        </a:fillRef>
-        <a:effectRef idx="2">
-          <a:schemeClr val="accent1"/>
-        </a:effectRef>
-        <a:fontRef idx="minor">
-          <a:schemeClr val="lt1"/>
-        </a:fontRef>
-      </a:style>
-    </a:spDef>
     <a:lnDef>
       <a:spPr/>
       <a:bodyPr/>
@@ -9117,5 +9056,10 @@
     </a:lnDef>
   </a:objectDefaults>
   <a:extraClrSchemeLst/>
+  <a:extLst>
+    <a:ext uri="{05A4C25C-085E-4340-85A3-A5531E510DB2}">
+      <thm15:themeFamily xmlns:thm15="http://schemas.microsoft.com/office/thememl/2012/main" name="Office Theme" id="{2E142A2C-CD16-42D6-873A-C26D2A0506FA}" vid="{1BDDFF52-6CD6-40A5-AB3C-68EB2F1E4D0A}"/>
+    </a:ext>
+  </a:extLst>
 </a:theme>
 </file>
</xml_diff>

<commit_message>
Add new content to the main deck for problem framing
- Introduced a new section in `build_main_deck.py` titled "Part 1 · Problem framing" that discusses the concept of rolling origin in relation to customer churn analysis.
- Added a visual representation (`02_rolling_origin.png`) and detailed notes explaining the implications of measuring churn across multiple dates, emphasizing the importance of understanding data dependencies and measurement noise.
- Updated the case study deck (`AvePoint_Case_Study.pptx`) to reflect these changes, enhancing the overall presentation of findings.

These updates aim to improve the clarity and depth of the analysis presented in the case study deck, providing a more comprehensive understanding of the problem framing related to customer churn.
</commit_message>
<xml_diff>
--- a/outputs/decks/AvePoint_Case_Study.pptx
+++ b/outputs/decks/AvePoint_Case_Study.pptx
@@ -141,27 +141,66 @@
 </p:presentation>
 </file>
 
+<file path=ppt/revisionInfo.xml><?xml version="1.0" encoding="utf-8"?>
+<p1510:revInfo xmlns:a="http://schemas.openxmlformats.org/drawingml/2006/main" xmlns:r="http://schemas.openxmlformats.org/officeDocument/2006/relationships" xmlns:p1510="http://schemas.microsoft.com/office/powerpoint/2015/10/main">
+  <p1510:revLst>
+    <p1510:client id="{25DC7B8B-EC09-4841-A573-8FF6489E0CC5}" v="21" dt="2026-07-28T23:21:04.133"/>
+  </p1510:revLst>
+</p1510:revInfo>
+</file>
+
 <file path=ppt/changesInfos/changesInfo1.xml><?xml version="1.0" encoding="utf-8"?>
 <pc:chgInfo xmlns:a="http://schemas.openxmlformats.org/drawingml/2006/main" xmlns:r="http://schemas.openxmlformats.org/officeDocument/2006/relationships" xmlns:ac="http://schemas.microsoft.com/office/drawing/2013/main/command" xmlns:pc="http://schemas.microsoft.com/office/powerpoint/2013/main/command">
   <pc:docChgLst>
     <pc:chgData name="Dmitriy Ratushny" userId="08050032e8047aee" providerId="LiveId" clId="{78EB1A6D-D3A9-4525-A4D5-A50D4E20D487}"/>
-    <pc:docChg chg="modSld">
-      <pc:chgData name="Dmitriy Ratushny" userId="08050032e8047aee" providerId="LiveId" clId="{78EB1A6D-D3A9-4525-A4D5-A50D4E20D487}" dt="2026-07-28T21:40:26.915" v="1" actId="1076"/>
+    <pc:docChg chg="undo custSel modSld">
+      <pc:chgData name="Dmitriy Ratushny" userId="08050032e8047aee" providerId="LiveId" clId="{78EB1A6D-D3A9-4525-A4D5-A50D4E20D487}" dt="2026-07-28T23:21:18.353" v="326" actId="20577"/>
       <pc:docMkLst>
         <pc:docMk/>
       </pc:docMkLst>
       <pc:sldChg chg="modSp mod">
-        <pc:chgData name="Dmitriy Ratushny" userId="08050032e8047aee" providerId="LiveId" clId="{78EB1A6D-D3A9-4525-A4D5-A50D4E20D487}" dt="2026-07-28T21:40:26.915" v="1" actId="1076"/>
+        <pc:chgData name="Dmitriy Ratushny" userId="08050032e8047aee" providerId="LiveId" clId="{78EB1A6D-D3A9-4525-A4D5-A50D4E20D487}" dt="2026-07-28T23:00:06.670" v="13" actId="20577"/>
         <pc:sldMkLst>
           <pc:docMk/>
-          <pc:sldMk cId="0" sldId="260"/>
+          <pc:sldMk cId="0" sldId="256"/>
         </pc:sldMkLst>
-        <pc:picChg chg="mod">
-          <ac:chgData name="Dmitriy Ratushny" userId="08050032e8047aee" providerId="LiveId" clId="{78EB1A6D-D3A9-4525-A4D5-A50D4E20D487}" dt="2026-07-28T21:40:26.915" v="1" actId="1076"/>
+        <pc:spChg chg="mod">
+          <ac:chgData name="Dmitriy Ratushny" userId="08050032e8047aee" providerId="LiveId" clId="{78EB1A6D-D3A9-4525-A4D5-A50D4E20D487}" dt="2026-07-28T23:00:06.670" v="13" actId="20577"/>
+          <ac:spMkLst>
+            <pc:docMk/>
+            <pc:sldMk cId="0" sldId="256"/>
+            <ac:spMk id="2" creationId="{00000000-0000-0000-0000-000000000000}"/>
+          </ac:spMkLst>
+        </pc:spChg>
+      </pc:sldChg>
+      <pc:sldChg chg="delSp modSp mod">
+        <pc:chgData name="Dmitriy Ratushny" userId="08050032e8047aee" providerId="LiveId" clId="{78EB1A6D-D3A9-4525-A4D5-A50D4E20D487}" dt="2026-07-28T23:21:18.353" v="326" actId="20577"/>
+        <pc:sldMkLst>
+          <pc:docMk/>
+          <pc:sldMk cId="0" sldId="257"/>
+        </pc:sldMkLst>
+        <pc:spChg chg="mod">
+          <ac:chgData name="Dmitriy Ratushny" userId="08050032e8047aee" providerId="LiveId" clId="{78EB1A6D-D3A9-4525-A4D5-A50D4E20D487}" dt="2026-07-28T23:21:18.353" v="326" actId="20577"/>
+          <ac:spMkLst>
+            <pc:docMk/>
+            <pc:sldMk cId="0" sldId="257"/>
+            <ac:spMk id="4" creationId="{00000000-0000-0000-0000-000000000000}"/>
+          </ac:spMkLst>
+        </pc:spChg>
+        <pc:spChg chg="del">
+          <ac:chgData name="Dmitriy Ratushny" userId="08050032e8047aee" providerId="LiveId" clId="{78EB1A6D-D3A9-4525-A4D5-A50D4E20D487}" dt="2026-07-28T22:56:21.088" v="4" actId="478"/>
+          <ac:spMkLst>
+            <pc:docMk/>
+            <pc:sldMk cId="0" sldId="257"/>
+            <ac:spMk id="6" creationId="{00000000-0000-0000-0000-000000000000}"/>
+          </ac:spMkLst>
+        </pc:spChg>
+        <pc:picChg chg="mod modCrop">
+          <ac:chgData name="Dmitriy Ratushny" userId="08050032e8047aee" providerId="LiveId" clId="{78EB1A6D-D3A9-4525-A4D5-A50D4E20D487}" dt="2026-07-28T23:06:28.700" v="110" actId="1076"/>
           <ac:picMkLst>
             <pc:docMk/>
-            <pc:sldMk cId="0" sldId="260"/>
-            <ac:picMk id="4" creationId="{00000000-0000-0000-0000-000000000000}"/>
+            <pc:sldMk cId="0" sldId="257"/>
+            <ac:picMk id="5" creationId="{00000000-0000-0000-0000-000000000000}"/>
           </ac:picMkLst>
         </pc:picChg>
       </pc:sldChg>
@@ -195,7 +234,7 @@
     </p:spTree>
     <p:extLst>
       <p:ext uri="{BB962C8B-B14F-4D97-AF65-F5344CB8AC3E}">
-        <p14:creationId xmlns:p14="http://schemas.microsoft.com/office/powerpoint/2010/main" val="2384198597"/>
+        <p14:creationId xmlns:p14="http://schemas.microsoft.com/office/powerpoint/2010/main" val="2568318937"/>
       </p:ext>
     </p:extLst>
   </p:cSld>
@@ -323,6 +362,13 @@
           </p:nvPr>
         </p:nvSpPr>
         <p:spPr/>
+        <p:txBody>
+          <a:bodyPr/>
+          <a:lstStyle/>
+          <a:p>
+            <a:endParaRPr lang="en-US"/>
+          </a:p>
+        </p:txBody>
       </p:sp>
       <p:sp>
         <p:nvSpPr>
@@ -364,6 +410,13 @@
           </p:nvPr>
         </p:nvSpPr>
         <p:spPr/>
+        <p:txBody>
+          <a:bodyPr/>
+          <a:lstStyle/>
+          <a:p>
+            <a:endParaRPr lang="en-US"/>
+          </a:p>
+        </p:txBody>
       </p:sp>
     </p:spTree>
   </p:cSld>
@@ -401,6 +454,13 @@
           </p:nvPr>
         </p:nvSpPr>
         <p:spPr/>
+        <p:txBody>
+          <a:bodyPr/>
+          <a:lstStyle/>
+          <a:p>
+            <a:endParaRPr lang="en-US"/>
+          </a:p>
+        </p:txBody>
       </p:sp>
       <p:sp>
         <p:nvSpPr>
@@ -466,6 +526,13 @@
           </p:nvPr>
         </p:nvSpPr>
         <p:spPr/>
+        <p:txBody>
+          <a:bodyPr/>
+          <a:lstStyle/>
+          <a:p>
+            <a:endParaRPr lang="en-US"/>
+          </a:p>
+        </p:txBody>
       </p:sp>
     </p:spTree>
   </p:cSld>
@@ -503,6 +570,13 @@
           </p:nvPr>
         </p:nvSpPr>
         <p:spPr/>
+        <p:txBody>
+          <a:bodyPr/>
+          <a:lstStyle/>
+          <a:p>
+            <a:endParaRPr lang="en-US"/>
+          </a:p>
+        </p:txBody>
       </p:sp>
       <p:sp>
         <p:nvSpPr>
@@ -576,6 +650,13 @@
           </p:nvPr>
         </p:nvSpPr>
         <p:spPr/>
+        <p:txBody>
+          <a:bodyPr/>
+          <a:lstStyle/>
+          <a:p>
+            <a:endParaRPr lang="en-US"/>
+          </a:p>
+        </p:txBody>
       </p:sp>
     </p:spTree>
   </p:cSld>
@@ -3561,7 +3642,7 @@
         <p:spPr>
           <a:xfrm>
             <a:off x="685800" y="2194560"/>
-            <a:ext cx="10820095" cy="2560320"/>
+            <a:ext cx="10820095" cy="2133918"/>
           </a:xfrm>
           <a:prstGeom prst="rect">
             <a:avLst/>
@@ -3575,7 +3656,7 @@
           <a:lstStyle/>
           <a:p>
             <a:r>
-              <a:rPr sz="4000" b="1" i="0">
+              <a:rPr sz="4000" b="1" i="0" dirty="0">
                 <a:solidFill>
                   <a:srgbClr val="1A1A1A"/>
                 </a:solidFill>
@@ -3591,13 +3672,31 @@
               </a:spcBef>
             </a:pPr>
             <a:r>
-              <a:rPr sz="1800" b="0" i="0">
-                <a:solidFill>
-                  <a:srgbClr val="5A6270"/>
-                </a:solidFill>
-                <a:latin typeface="Calibri"/>
-              </a:rPr>
-              <a:t>Senior ML Engineer case study. RavenStack subscription data: 500 customers across 5 tables.</a:t>
+              <a:rPr sz="1800" b="0" i="0" dirty="0">
+                <a:solidFill>
+                  <a:srgbClr val="5A6270"/>
+                </a:solidFill>
+                <a:latin typeface="Calibri"/>
+              </a:rPr>
+              <a:t>Senior ML Engineer case study. </a:t>
+            </a:r>
+            <a:r>
+              <a:rPr sz="1800" b="0" i="0" dirty="0" err="1">
+                <a:solidFill>
+                  <a:srgbClr val="5A6270"/>
+                </a:solidFill>
+                <a:latin typeface="Calibri"/>
+              </a:rPr>
+              <a:t>RavenStack</a:t>
+            </a:r>
+            <a:r>
+              <a:rPr sz="1800" b="0" i="0" dirty="0">
+                <a:solidFill>
+                  <a:srgbClr val="5A6270"/>
+                </a:solidFill>
+                <a:latin typeface="Calibri"/>
+              </a:rPr>
+              <a:t> subscription data: 500 customers across 5 tables.</a:t>
             </a:r>
           </a:p>
           <a:p>
@@ -3607,14 +3706,19 @@
               </a:spcBef>
             </a:pPr>
             <a:r>
-              <a:rPr sz="1900" b="1" i="0">
+              <a:rPr lang="en-US" sz="1900" b="1" dirty="0">
                 <a:solidFill>
                   <a:srgbClr val="2E5F8A"/>
                 </a:solidFill>
-                <a:latin typeface="Calibri"/>
-              </a:rPr>
-              <a:t>The short version: no model here beats a coin flip, the one pattern that looked like a cause comes from how the file was written, and three actions still follow.</a:t>
-            </a:r>
+              </a:rPr>
+              <a:t>The short version: this data cannot predict who will leave. The one trend that looked real — churn rising through 2024 was invented by the dataset, not by customers. Three recommendations still follow.</a:t>
+            </a:r>
+            <a:endParaRPr sz="1900" b="1" i="0" dirty="0">
+              <a:solidFill>
+                <a:srgbClr val="2E5F8A"/>
+              </a:solidFill>
+              <a:latin typeface="Calibri"/>
+            </a:endParaRPr>
           </a:p>
         </p:txBody>
       </p:sp>
@@ -6056,8 +6160,8 @@
         </p:nvSpPr>
         <p:spPr>
           <a:xfrm>
-            <a:off x="685800" y="1719072"/>
-            <a:ext cx="10820095" cy="4572000"/>
+            <a:off x="685799" y="1594108"/>
+            <a:ext cx="10820095" cy="3277820"/>
           </a:xfrm>
           <a:prstGeom prst="rect">
             <a:avLst/>
@@ -6070,13 +6174,13 @@
           </a:bodyPr>
           <a:lstStyle/>
           <a:p>
-            <a:pPr>
+            <a:pPr algn="just">
               <a:spcAft>
                 <a:spcPts val="600"/>
               </a:spcAft>
             </a:pPr>
             <a:r>
-              <a:rPr sz="1400" b="1" i="0">
+              <a:rPr sz="1400" b="1" i="0" dirty="0">
                 <a:solidFill>
                   <a:srgbClr val="1A1A1A"/>
                 </a:solidFill>
@@ -6086,29 +6190,47 @@
             </a:r>
           </a:p>
           <a:p>
-            <a:pPr>
+            <a:pPr algn="just">
               <a:spcAft>
                 <a:spcPts val="600"/>
               </a:spcAft>
             </a:pPr>
             <a:r>
-              <a:rPr sz="1400" b="0" i="0">
+              <a:rPr sz="1400" b="0" i="0" dirty="0">
                 <a:solidFill>
                   <a:srgbClr val="1A1A1A"/>
                 </a:solidFill>
                 <a:latin typeface="Calibri"/>
               </a:rPr>
-              <a:t>By the churn event log, seven out of ten customers leave in the end. The typical customer pays $931 a month and is worth about $7,300 in total. Churn is the largest cost we can actually control.</a:t>
-            </a:r>
-          </a:p>
-          <a:p>
-            <a:pPr>
+              <a:t>Seven in ten customers leave in the end. The typical </a:t>
+            </a:r>
+            <a:r>
+              <a:rPr lang="en-US" sz="1400" b="0" i="0" dirty="0">
+                <a:solidFill>
+                  <a:srgbClr val="1A1A1A"/>
+                </a:solidFill>
+                <a:latin typeface="Calibri"/>
+              </a:rPr>
+              <a:t>customer</a:t>
+            </a:r>
+            <a:r>
+              <a:rPr sz="1400" b="0" i="0" dirty="0">
+                <a:solidFill>
+                  <a:srgbClr val="1A1A1A"/>
+                </a:solidFill>
+                <a:latin typeface="Calibri"/>
+              </a:rPr>
+              <a:t> pays $931 a month and is worth about $7,300.</a:t>
+            </a:r>
+          </a:p>
+          <a:p>
+            <a:pPr algn="just">
               <a:spcAft>
                 <a:spcPts val="600"/>
               </a:spcAft>
             </a:pPr>
             <a:r>
-              <a:rPr sz="600" b="0" i="0">
+              <a:rPr sz="600" b="0" i="0" dirty="0">
                 <a:solidFill>
                   <a:srgbClr val="1A1A1A"/>
                 </a:solidFill>
@@ -6118,77 +6240,299 @@
             </a:r>
           </a:p>
           <a:p>
-            <a:pPr>
+            <a:pPr algn="just">
               <a:spcAft>
                 <a:spcPts val="600"/>
               </a:spcAft>
             </a:pPr>
             <a:r>
-              <a:rPr sz="1400" b="1" i="0">
+              <a:rPr sz="1400" b="1" i="0" dirty="0">
                 <a:solidFill>
                   <a:srgbClr val="B02E2E"/>
                 </a:solidFill>
                 <a:latin typeface="Calibri"/>
               </a:rPr>
-              <a:t>The churn flag in the data cannot be used.</a:t>
-            </a:r>
-          </a:p>
-          <a:p>
-            <a:pPr lvl="1">
+              <a:t>The churn flag</a:t>
+            </a:r>
+            <a:r>
+              <a:rPr lang="en-US" sz="1400" b="1" dirty="0">
+                <a:solidFill>
+                  <a:srgbClr val="B02E2E"/>
+                </a:solidFill>
+              </a:rPr>
+              <a:t> </a:t>
+            </a:r>
+            <a:r>
+              <a:rPr lang="en-US" sz="1400" b="1" dirty="0">
+                <a:solidFill>
+                  <a:schemeClr val="tx2"/>
+                </a:solidFill>
+              </a:rPr>
+              <a:t>accounts.churn_flag</a:t>
+            </a:r>
+            <a:r>
+              <a:rPr sz="1400" b="1" i="0" dirty="0">
+                <a:solidFill>
+                  <a:srgbClr val="B02E2E"/>
+                </a:solidFill>
+                <a:latin typeface="Calibri"/>
+              </a:rPr>
+              <a:t> in the data cannot be used.</a:t>
+            </a:r>
+          </a:p>
+          <a:p>
+            <a:pPr marL="685800" lvl="1" indent="-228600" algn="just">
               <a:spcAft>
                 <a:spcPts val="600"/>
               </a:spcAft>
-            </a:pPr>
-            <a:r>
-              <a:rPr sz="1200" b="0" i="0">
-                <a:solidFill>
-                  <a:srgbClr val="5A6270"/>
-                </a:solidFill>
-                <a:latin typeface="Calibri"/>
-              </a:rPr>
-              <a:t>It has no date on it. So we cannot tell whether a customer had already left on any given day.</a:t>
-            </a:r>
-          </a:p>
-          <a:p>
-            <a:pPr lvl="1">
+              <a:buFont typeface="+mj-lt"/>
+              <a:buAutoNum type="arabicPeriod"/>
+            </a:pPr>
+            <a:r>
+              <a:rPr lang="en-US" sz="1200" b="1" dirty="0">
+                <a:solidFill>
+                  <a:schemeClr val="tx2"/>
+                </a:solidFill>
+              </a:rPr>
+              <a:t>accounts.churn_flag</a:t>
+            </a:r>
+            <a:r>
+              <a:rPr sz="1200" b="0" i="0" dirty="0">
+                <a:solidFill>
+                  <a:srgbClr val="5A6270"/>
+                </a:solidFill>
+                <a:latin typeface="Calibri"/>
+              </a:rPr>
+              <a:t> has no date. </a:t>
+            </a:r>
+            <a:r>
+              <a:rPr lang="en-US" sz="1200" b="0" i="0" dirty="0">
+                <a:solidFill>
+                  <a:srgbClr val="5A6270"/>
+                </a:solidFill>
+                <a:latin typeface="Calibri"/>
+              </a:rPr>
+              <a:t>So,</a:t>
+            </a:r>
+            <a:r>
+              <a:rPr sz="1200" b="0" i="0" dirty="0">
+                <a:solidFill>
+                  <a:srgbClr val="5A6270"/>
+                </a:solidFill>
+                <a:latin typeface="Calibri"/>
+              </a:rPr>
+              <a:t> we cannot ask whether a customer </a:t>
+            </a:r>
+            <a:r>
+              <a:rPr lang="en-US" sz="1200" b="0" i="0" dirty="0">
+                <a:solidFill>
+                  <a:srgbClr val="5A6270"/>
+                </a:solidFill>
+                <a:latin typeface="Calibri"/>
+              </a:rPr>
+              <a:t>has</a:t>
+            </a:r>
+            <a:r>
+              <a:rPr sz="1200" b="0" i="0" dirty="0">
+                <a:solidFill>
+                  <a:srgbClr val="5A6270"/>
+                </a:solidFill>
+                <a:latin typeface="Calibri"/>
+              </a:rPr>
+              <a:t> already left by any given day.</a:t>
+            </a:r>
+            <a:endParaRPr lang="en-US" sz="1200" b="0" i="0" dirty="0">
+              <a:solidFill>
+                <a:srgbClr val="5A6270"/>
+              </a:solidFill>
+              <a:latin typeface="Calibri"/>
+            </a:endParaRPr>
+          </a:p>
+          <a:p>
+            <a:pPr marL="685800" lvl="1" indent="-228600" algn="just">
               <a:spcAft>
                 <a:spcPts val="600"/>
               </a:spcAft>
-            </a:pPr>
-            <a:r>
-              <a:rPr sz="1200" b="0" i="0">
-                <a:solidFill>
-                  <a:srgbClr val="5A6270"/>
-                </a:solidFill>
-                <a:latin typeface="Calibri"/>
-              </a:rPr>
-              <a:t>It agrees with the churn event log for 188 of the 500 customers. Two unrelated columns would agree for about 193. So the flag is not a rough version of the truth. It tells us nothing at all about who left.</a:t>
-            </a:r>
-          </a:p>
-          <a:p>
-            <a:pPr lvl="1">
+              <a:buFont typeface="+mj-lt"/>
+              <a:buAutoNum type="arabicPeriod"/>
+            </a:pPr>
+            <a:r>
+              <a:rPr lang="en-US" sz="1200" dirty="0">
+                <a:solidFill>
+                  <a:srgbClr val="5A6270"/>
+                </a:solidFill>
+              </a:rPr>
+              <a:t>Churn is recorded three times - </a:t>
+            </a:r>
+            <a:r>
+              <a:rPr lang="en-US" sz="1200" b="1" dirty="0">
+                <a:solidFill>
+                  <a:schemeClr val="tx2"/>
+                </a:solidFill>
+              </a:rPr>
+              <a:t>accounts.churn_flag</a:t>
+            </a:r>
+            <a:r>
+              <a:rPr lang="en-US" sz="1200" dirty="0">
+                <a:solidFill>
+                  <a:srgbClr val="5A6270"/>
+                </a:solidFill>
+              </a:rPr>
+              <a:t>, </a:t>
+            </a:r>
+            <a:r>
+              <a:rPr lang="en-US" sz="1200" b="1" dirty="0">
+                <a:solidFill>
+                  <a:schemeClr val="tx2"/>
+                </a:solidFill>
+              </a:rPr>
+              <a:t>churn_events.churn_date</a:t>
+            </a:r>
+            <a:r>
+              <a:rPr lang="en-US" sz="1200" dirty="0">
+                <a:solidFill>
+                  <a:srgbClr val="5A6270"/>
+                </a:solidFill>
+              </a:rPr>
+              <a:t>, </a:t>
+            </a:r>
+            <a:r>
+              <a:rPr lang="en-US" sz="1200" b="1" dirty="0">
+                <a:solidFill>
+                  <a:schemeClr val="tx2"/>
+                </a:solidFill>
+              </a:rPr>
+              <a:t>subscriptions.end_date</a:t>
+            </a:r>
+            <a:r>
+              <a:rPr lang="en-US" sz="1200" dirty="0">
+                <a:solidFill>
+                  <a:srgbClr val="5A6270"/>
+                </a:solidFill>
+              </a:rPr>
+              <a:t> - and all three disagree.</a:t>
+            </a:r>
+            <a:endParaRPr sz="1200" b="0" i="0" dirty="0">
+              <a:solidFill>
+                <a:srgbClr val="5A6270"/>
+              </a:solidFill>
+              <a:latin typeface="Calibri"/>
+            </a:endParaRPr>
+          </a:p>
+          <a:p>
+            <a:pPr marL="685800" lvl="1" indent="-228600" algn="just">
               <a:spcAft>
                 <a:spcPts val="600"/>
               </a:spcAft>
-            </a:pPr>
-            <a:r>
-              <a:rPr sz="1200" b="0" i="0">
-                <a:solidFill>
-                  <a:srgbClr val="5A6270"/>
-                </a:solidFill>
-                <a:latin typeface="Calibri"/>
-              </a:rPr>
-              <a:t>The other two records do not line up either. A churn date and a subscription ending fall on the same day 2% of the time. The usual gap is two months.</a:t>
-            </a:r>
-          </a:p>
-          <a:p>
-            <a:pPr>
+              <a:buFont typeface="+mj-lt"/>
+              <a:buAutoNum type="arabicPeriod"/>
+            </a:pPr>
+            <a:r>
+              <a:rPr lang="en-US" sz="1200" dirty="0"/>
+              <a:t>Column</a:t>
+            </a:r>
+            <a:r>
+              <a:rPr lang="en-US" sz="1200" b="1" dirty="0">
+                <a:solidFill>
+                  <a:schemeClr val="tx2"/>
+                </a:solidFill>
+              </a:rPr>
+              <a:t> accounts.churn_flag</a:t>
+            </a:r>
+            <a:r>
+              <a:rPr lang="en-US" sz="1200" dirty="0">
+                <a:solidFill>
+                  <a:srgbClr val="5A6270"/>
+                </a:solidFill>
+              </a:rPr>
+              <a:t> asserts churn for 22% of customers; </a:t>
+            </a:r>
+            <a:r>
+              <a:rPr lang="en-US" sz="1200" b="1" dirty="0">
+                <a:solidFill>
+                  <a:schemeClr val="tx2"/>
+                </a:solidFill>
+              </a:rPr>
+              <a:t>churn_events</a:t>
+            </a:r>
+            <a:r>
+              <a:rPr lang="en-US" sz="1200" dirty="0">
+                <a:solidFill>
+                  <a:srgbClr val="5A6270"/>
+                </a:solidFill>
+              </a:rPr>
+              <a:t> asserts churn for 70% of customers. They agree on 188 of 500. Shuffle the </a:t>
+            </a:r>
+            <a:r>
+              <a:rPr lang="en-US" sz="1200" b="1" dirty="0">
+                <a:solidFill>
+                  <a:schemeClr val="tx2"/>
+                </a:solidFill>
+              </a:rPr>
+              <a:t>accounts.churn_flag</a:t>
+            </a:r>
+            <a:r>
+              <a:rPr lang="en-US" sz="1200" dirty="0">
+                <a:solidFill>
+                  <a:srgbClr val="5A6270"/>
+                </a:solidFill>
+              </a:rPr>
+              <a:t> at random and you would expect 193. The real column does no better than the shuffled one.</a:t>
+            </a:r>
+          </a:p>
+          <a:p>
+            <a:pPr marL="685800" lvl="1" indent="-228600" algn="just">
               <a:spcAft>
                 <a:spcPts val="600"/>
               </a:spcAft>
-            </a:pPr>
-            <a:r>
-              <a:rPr sz="600" b="0" i="0">
+              <a:buFont typeface="+mj-lt"/>
+              <a:buAutoNum type="arabicPeriod"/>
+            </a:pPr>
+            <a:r>
+              <a:rPr lang="en-US" sz="1200" dirty="0"/>
+              <a:t>The</a:t>
+            </a:r>
+            <a:r>
+              <a:rPr lang="en-US" sz="1200" b="1" dirty="0">
+                <a:solidFill>
+                  <a:schemeClr val="tx2"/>
+                </a:solidFill>
+              </a:rPr>
+              <a:t> churn_events.churn_date</a:t>
+            </a:r>
+            <a:r>
+              <a:rPr lang="en-US" sz="1200" dirty="0">
+                <a:solidFill>
+                  <a:srgbClr val="5A6270"/>
+                </a:solidFill>
+              </a:rPr>
+              <a:t> and </a:t>
+            </a:r>
+            <a:r>
+              <a:rPr lang="en-US" sz="1200" b="1" dirty="0">
+                <a:solidFill>
+                  <a:schemeClr val="tx2"/>
+                </a:solidFill>
+              </a:rPr>
+              <a:t>subscriptions.end_date</a:t>
+            </a:r>
+            <a:r>
+              <a:rPr lang="en-US" sz="1200" dirty="0">
+                <a:solidFill>
+                  <a:srgbClr val="5A6270"/>
+                </a:solidFill>
+              </a:rPr>
+              <a:t> disagree too: of 386 matched pairs, 6 land on the same day. The usual gap is two months.</a:t>
+            </a:r>
+          </a:p>
+          <a:p>
+            <a:pPr algn="just">
+              <a:spcAft>
+                <a:spcPts val="600"/>
+              </a:spcAft>
+            </a:pPr>
+            <a:r>
+              <a:rPr lang="en-US" sz="600" b="0" i="0" dirty="0">
                 <a:solidFill>
                   <a:srgbClr val="1A1A1A"/>
                 </a:solidFill>
@@ -6198,105 +6542,119 @@
             </a:r>
           </a:p>
           <a:p>
-            <a:pPr>
+            <a:pPr algn="just">
               <a:spcAft>
                 <a:spcPts val="600"/>
               </a:spcAft>
             </a:pPr>
             <a:r>
-              <a:rPr sz="1400" b="1" i="0">
+              <a:rPr lang="en-US" sz="1400" b="1" i="0" dirty="0">
                 <a:solidFill>
                   <a:srgbClr val="1A1A1A"/>
                 </a:solidFill>
                 <a:latin typeface="Calibri"/>
               </a:rPr>
-              <a:t>So I rebuilt the target as a question with a date in it:</a:t>
-            </a:r>
-          </a:p>
-          <a:p>
-            <a:pPr lvl="1">
+              <a:t>So, I rebuilt the target as a question with a date in it:</a:t>
+            </a:r>
+          </a:p>
+          <a:p>
+            <a:pPr marL="685800" lvl="1" indent="-228600" algn="just">
               <a:spcAft>
                 <a:spcPts val="600"/>
               </a:spcAft>
-            </a:pPr>
-            <a:r>
-              <a:rPr sz="1200" b="0" i="0">
-                <a:solidFill>
-                  <a:srgbClr val="5A6270"/>
-                </a:solidFill>
-                <a:latin typeface="Calibri"/>
-              </a:rPr>
-              <a:t>On 30 June 2024, using only what we knew that day, will this customer leave within the next 90 days?</a:t>
-            </a:r>
-          </a:p>
-          <a:p>
-            <a:pPr lvl="1">
+              <a:buFont typeface="+mj-lt"/>
+              <a:buAutoNum type="arabicPeriod"/>
+            </a:pPr>
+            <a:r>
+              <a:rPr sz="1200" b="0" i="0" dirty="0">
+                <a:solidFill>
+                  <a:srgbClr val="5A6270"/>
+                </a:solidFill>
+                <a:latin typeface="Calibri"/>
+              </a:rPr>
+              <a:t>On each of four quarter-end dates, using only what we knew that day, will this customer leave in the next 90 days? </a:t>
+            </a:r>
+            <a:endParaRPr lang="en-US" sz="1200" b="0" i="0" dirty="0">
+              <a:solidFill>
+                <a:srgbClr val="5A6270"/>
+              </a:solidFill>
+              <a:latin typeface="Calibri"/>
+            </a:endParaRPr>
+          </a:p>
+          <a:p>
+            <a:pPr marL="685800" lvl="1" indent="-228600" algn="just">
               <a:spcAft>
                 <a:spcPts val="600"/>
               </a:spcAft>
-            </a:pPr>
-            <a:r>
-              <a:rPr sz="1200" b="0" i="0">
-                <a:solidFill>
-                  <a:srgbClr val="5A6270"/>
-                </a:solidFill>
-                <a:latin typeface="Calibri"/>
-              </a:rPr>
-              <a:t>That gives 177 customers who could still leave. 54 of them did, which is 31%.</a:t>
-            </a:r>
-          </a:p>
-          <a:p>
-            <a:pPr lvl="1">
-              <a:spcAft>
-                <a:spcPts val="600"/>
-              </a:spcAft>
-            </a:pPr>
-            <a:r>
-              <a:rPr sz="1200" b="0" i="0">
-                <a:solidFill>
-                  <a:srgbClr val="5A6270"/>
-                </a:solidFill>
-                <a:latin typeface="Calibri"/>
-              </a:rPr>
-              <a:t>Features use only data dated before that day. Anything still unresolved on that day is blanked out.</a:t>
-            </a:r>
-          </a:p>
-        </p:txBody>
-      </p:sp>
-      <p:sp>
-        <p:nvSpPr>
-          <p:cNvPr id="5" name="TextBox 4"/>
-          <p:cNvSpPr txBox="1"/>
+              <a:buFont typeface="+mj-lt"/>
+              <a:buAutoNum type="arabicPeriod"/>
+            </a:pPr>
+            <a:r>
+              <a:rPr lang="en-US" sz="1200" dirty="0">
+                <a:solidFill>
+                  <a:srgbClr val="5A6270"/>
+                </a:solidFill>
+              </a:rPr>
+              <a:t>“Churn” definition is </a:t>
+            </a:r>
+            <a:r>
+              <a:rPr lang="en-US" sz="1200" b="1" dirty="0">
+                <a:solidFill>
+                  <a:schemeClr val="tx2"/>
+                </a:solidFill>
+              </a:rPr>
+              <a:t>churn_events.churn_date</a:t>
+            </a:r>
+            <a:r>
+              <a:rPr lang="en-US" sz="1200" dirty="0">
+                <a:solidFill>
+                  <a:srgbClr val="5A6270"/>
+                </a:solidFill>
+              </a:rPr>
+              <a:t>. "Still a customer" is a subscriptions row open on that </a:t>
+            </a:r>
+            <a:r>
+              <a:rPr lang="en-US" sz="1200">
+                <a:solidFill>
+                  <a:srgbClr val="5A6270"/>
+                </a:solidFill>
+              </a:rPr>
+              <a:t>date.</a:t>
+            </a:r>
+            <a:endParaRPr sz="1200" b="0" i="0" dirty="0">
+              <a:solidFill>
+                <a:srgbClr val="5A6270"/>
+              </a:solidFill>
+              <a:latin typeface="Calibri"/>
+            </a:endParaRPr>
+          </a:p>
+        </p:txBody>
+      </p:sp>
+      <p:pic>
+        <p:nvPicPr>
+          <p:cNvPr id="5" name="Picture 4" descr="02_rolling_origin.png"/>
+          <p:cNvPicPr>
+            <a:picLocks noChangeAspect="1"/>
+          </p:cNvPicPr>
           <p:nvPr/>
-        </p:nvSpPr>
+        </p:nvPicPr>
+        <p:blipFill>
+          <a:blip r:embed="rId3"/>
+          <a:srcRect t="12677"/>
+          <a:stretch>
+            <a:fillRect/>
+          </a:stretch>
+        </p:blipFill>
         <p:spPr>
           <a:xfrm>
-            <a:off x="685800" y="6126480"/>
-            <a:ext cx="10820095" cy="502920"/>
+            <a:off x="279400" y="4953103"/>
+            <a:ext cx="8233726" cy="1858392"/>
           </a:xfrm>
           <a:prstGeom prst="rect">
             <a:avLst/>
           </a:prstGeom>
-          <a:noFill/>
         </p:spPr>
-        <p:txBody>
-          <a:bodyPr wrap="square">
-            <a:spAutoFit/>
-          </a:bodyPr>
-          <a:lstStyle/>
-          <a:p>
-            <a:r>
-              <a:rPr sz="1150" b="0" i="1">
-                <a:solidFill>
-                  <a:srgbClr val="5A6270"/>
-                </a:solidFill>
-                <a:latin typeface="Calibri"/>
-              </a:rPr>
-              <a:t>I found this by counting, not by modelling. No algorithm recovers a fact the source data never recorded the same way twice.</a:t>
-            </a:r>
-          </a:p>
-        </p:txBody>
-      </p:sp>
+      </p:pic>
     </p:spTree>
   </p:cSld>
   <p:clrMapOvr>
@@ -7167,8 +7525,8 @@
         </p:blipFill>
         <p:spPr>
           <a:xfrm>
-            <a:off x="566057" y="1655445"/>
-            <a:ext cx="10706906" cy="2588854"/>
+            <a:off x="-333124" y="1645920"/>
+            <a:ext cx="12857944" cy="3108960"/>
           </a:xfrm>
           <a:prstGeom prst="rect">
             <a:avLst/>

</xml_diff>

<commit_message>
Update case study deck with new content and visual enhancements
- Modified the `AvePoint_Case_Study.pptx` to incorporate recent changes and improvements in the analysis of customer churn.
- Enhanced visual elements and overall presentation quality to better communicate findings and insights.

These updates aim to provide a clearer and more engaging representation of the case study's conclusions.
</commit_message>
<xml_diff>
--- a/outputs/decks/AvePoint_Case_Study.pptx
+++ b/outputs/decks/AvePoint_Case_Study.pptx
@@ -154,7 +154,7 @@
   <pc:docChgLst>
     <pc:chgData name="Dmitriy Ratushny" userId="08050032e8047aee" providerId="LiveId" clId="{78EB1A6D-D3A9-4525-A4D5-A50D4E20D487}"/>
     <pc:docChg chg="undo custSel modSld">
-      <pc:chgData name="Dmitriy Ratushny" userId="08050032e8047aee" providerId="LiveId" clId="{78EB1A6D-D3A9-4525-A4D5-A50D4E20D487}" dt="2026-07-28T23:21:18.353" v="326" actId="20577"/>
+      <pc:chgData name="Dmitriy Ratushny" userId="08050032e8047aee" providerId="LiveId" clId="{78EB1A6D-D3A9-4525-A4D5-A50D4E20D487}" dt="2026-07-28T23:45:30.726" v="350" actId="1076"/>
       <pc:docMkLst>
         <pc:docMk/>
       </pc:docMkLst>
@@ -201,6 +201,45 @@
             <pc:docMk/>
             <pc:sldMk cId="0" sldId="257"/>
             <ac:picMk id="5" creationId="{00000000-0000-0000-0000-000000000000}"/>
+          </ac:picMkLst>
+        </pc:picChg>
+      </pc:sldChg>
+      <pc:sldChg chg="addSp modSp mod">
+        <pc:chgData name="Dmitriy Ratushny" userId="08050032e8047aee" providerId="LiveId" clId="{78EB1A6D-D3A9-4525-A4D5-A50D4E20D487}" dt="2026-07-28T23:45:30.726" v="350" actId="1076"/>
+        <pc:sldMkLst>
+          <pc:docMk/>
+          <pc:sldMk cId="0" sldId="258"/>
+        </pc:sldMkLst>
+        <pc:spChg chg="mod">
+          <ac:chgData name="Dmitriy Ratushny" userId="08050032e8047aee" providerId="LiveId" clId="{78EB1A6D-D3A9-4525-A4D5-A50D4E20D487}" dt="2026-07-28T23:39:35.568" v="336" actId="1076"/>
+          <ac:spMkLst>
+            <pc:docMk/>
+            <pc:sldMk cId="0" sldId="258"/>
+            <ac:spMk id="2" creationId="{00000000-0000-0000-0000-000000000000}"/>
+          </ac:spMkLst>
+        </pc:spChg>
+        <pc:spChg chg="mod">
+          <ac:chgData name="Dmitriy Ratushny" userId="08050032e8047aee" providerId="LiveId" clId="{78EB1A6D-D3A9-4525-A4D5-A50D4E20D487}" dt="2026-07-28T23:39:37.779" v="337" actId="1076"/>
+          <ac:spMkLst>
+            <pc:docMk/>
+            <pc:sldMk cId="0" sldId="258"/>
+            <ac:spMk id="3" creationId="{00000000-0000-0000-0000-000000000000}"/>
+          </ac:spMkLst>
+        </pc:spChg>
+        <pc:spChg chg="mod">
+          <ac:chgData name="Dmitriy Ratushny" userId="08050032e8047aee" providerId="LiveId" clId="{78EB1A6D-D3A9-4525-A4D5-A50D4E20D487}" dt="2026-07-28T23:45:25.877" v="348" actId="1076"/>
+          <ac:spMkLst>
+            <pc:docMk/>
+            <pc:sldMk cId="0" sldId="258"/>
+            <ac:spMk id="4" creationId="{00000000-0000-0000-0000-000000000000}"/>
+          </ac:spMkLst>
+        </pc:spChg>
+        <pc:picChg chg="add mod">
+          <ac:chgData name="Dmitriy Ratushny" userId="08050032e8047aee" providerId="LiveId" clId="{78EB1A6D-D3A9-4525-A4D5-A50D4E20D487}" dt="2026-07-28T23:45:30.726" v="350" actId="1076"/>
+          <ac:picMkLst>
+            <pc:docMk/>
+            <pc:sldMk cId="0" sldId="258"/>
+            <ac:picMk id="6" creationId="{E355C817-C75E-F7EE-C8D2-DD4E3A010816}"/>
           </ac:picMkLst>
         </pc:picChg>
       </pc:sldChg>
@@ -6688,7 +6727,7 @@
         </p:nvSpPr>
         <p:spPr>
           <a:xfrm>
-            <a:off x="685800" y="365760"/>
+            <a:off x="685800" y="262393"/>
             <a:ext cx="10820095" cy="1051560"/>
           </a:xfrm>
           <a:prstGeom prst="rect">
@@ -6738,7 +6777,7 @@
         </p:nvSpPr>
         <p:spPr>
           <a:xfrm>
-            <a:off x="685800" y="1426464"/>
+            <a:off x="685799" y="1187925"/>
             <a:ext cx="10820095" cy="9525"/>
           </a:xfrm>
           <a:prstGeom prst="rect">
@@ -6783,8 +6822,8 @@
         </p:nvSpPr>
         <p:spPr>
           <a:xfrm>
-            <a:off x="685800" y="1719072"/>
-            <a:ext cx="10820095" cy="4572000"/>
+            <a:off x="189021" y="1159681"/>
+            <a:ext cx="11813650" cy="5570756"/>
           </a:xfrm>
           <a:prstGeom prst="rect">
             <a:avLst/>
@@ -6797,13 +6836,13 @@
           </a:bodyPr>
           <a:lstStyle/>
           <a:p>
-            <a:pPr>
+            <a:pPr algn="just">
               <a:spcAft>
                 <a:spcPts val="900"/>
               </a:spcAft>
             </a:pPr>
             <a:r>
-              <a:rPr sz="1600" b="1" i="0">
+              <a:rPr sz="1600" b="1" i="0" dirty="0">
                 <a:solidFill>
                   <a:srgbClr val="1A1A1A"/>
                 </a:solidFill>
@@ -6813,13 +6852,15 @@
             </a:r>
           </a:p>
           <a:p>
-            <a:pPr lvl="1">
+            <a:pPr marL="800100" lvl="1" indent="-342900" algn="just">
               <a:spcAft>
                 <a:spcPts val="900"/>
               </a:spcAft>
-            </a:pPr>
-            <a:r>
-              <a:rPr sz="1400" b="0" i="0">
+              <a:buFont typeface="+mj-lt"/>
+              <a:buAutoNum type="arabicPeriod"/>
+            </a:pPr>
+            <a:r>
+              <a:rPr sz="1400" b="0" i="0" dirty="0">
                 <a:solidFill>
                   <a:srgbClr val="5A6270"/>
                 </a:solidFill>
@@ -6829,29 +6870,51 @@
             </a:r>
           </a:p>
           <a:p>
-            <a:pPr lvl="1">
+            <a:pPr marL="800100" lvl="1" indent="-342900" algn="just">
               <a:spcAft>
                 <a:spcPts val="900"/>
               </a:spcAft>
-            </a:pPr>
-            <a:r>
-              <a:rPr sz="1400" b="0" i="0">
-                <a:solidFill>
-                  <a:srgbClr val="5A6270"/>
-                </a:solidFill>
-                <a:latin typeface="Calibri"/>
-              </a:rPr>
-              <a:t>I also report precision and recall, because they say what the CS team actually experiences when they work the list.</a:t>
-            </a:r>
-          </a:p>
-          <a:p>
-            <a:pPr lvl="1">
+              <a:buFont typeface="+mj-lt"/>
+              <a:buAutoNum type="arabicPeriod"/>
+            </a:pPr>
+            <a:r>
+              <a:rPr sz="1400" b="0" i="0" dirty="0">
+                <a:solidFill>
+                  <a:srgbClr val="5A6270"/>
+                </a:solidFill>
+                <a:latin typeface="Calibri"/>
+              </a:rPr>
+              <a:t>I also report precision and recall, because they say what the CS team </a:t>
+            </a:r>
+            <a:r>
+              <a:rPr lang="en-US" sz="1400" b="0" i="0" dirty="0">
+                <a:solidFill>
+                  <a:srgbClr val="5A6270"/>
+                </a:solidFill>
+                <a:latin typeface="Calibri"/>
+              </a:rPr>
+              <a:t>actually experiences</a:t>
+            </a:r>
+            <a:r>
+              <a:rPr sz="1400" b="0" i="0" dirty="0">
+                <a:solidFill>
+                  <a:srgbClr val="5A6270"/>
+                </a:solidFill>
+                <a:latin typeface="Calibri"/>
+              </a:rPr>
+              <a:t> when they work the list.</a:t>
+            </a:r>
+          </a:p>
+          <a:p>
+            <a:pPr marL="800100" lvl="1" indent="-342900" algn="just">
               <a:spcAft>
                 <a:spcPts val="900"/>
               </a:spcAft>
-            </a:pPr>
-            <a:r>
-              <a:rPr sz="1400" b="0" i="0">
+              <a:buFont typeface="+mj-lt"/>
+              <a:buAutoNum type="arabicPeriod"/>
+            </a:pPr>
+            <a:r>
+              <a:rPr sz="1400" b="0" i="0" dirty="0">
                 <a:solidFill>
                   <a:srgbClr val="5A6270"/>
                 </a:solidFill>
@@ -6861,13 +6924,13 @@
             </a:r>
           </a:p>
           <a:p>
-            <a:pPr>
+            <a:pPr algn="just">
               <a:spcAft>
                 <a:spcPts val="900"/>
               </a:spcAft>
             </a:pPr>
             <a:r>
-              <a:rPr sz="600" b="0" i="0">
+              <a:rPr sz="600" b="0" i="0" dirty="0">
                 <a:solidFill>
                   <a:srgbClr val="1A1A1A"/>
                 </a:solidFill>
@@ -6877,13 +6940,65 @@
             </a:r>
           </a:p>
           <a:p>
-            <a:pPr>
+            <a:pPr algn="just">
               <a:spcAft>
                 <a:spcPts val="900"/>
               </a:spcAft>
             </a:pPr>
-            <a:r>
-              <a:rPr sz="1600" b="1" i="0">
+            <a:endParaRPr lang="en-US" sz="1600" b="1" i="0" dirty="0">
+              <a:solidFill>
+                <a:srgbClr val="1A1A1A"/>
+              </a:solidFill>
+              <a:latin typeface="Calibri"/>
+            </a:endParaRPr>
+          </a:p>
+          <a:p>
+            <a:pPr algn="just">
+              <a:spcAft>
+                <a:spcPts val="900"/>
+              </a:spcAft>
+            </a:pPr>
+            <a:endParaRPr lang="en-US" sz="1600" b="1" dirty="0">
+              <a:solidFill>
+                <a:srgbClr val="1A1A1A"/>
+              </a:solidFill>
+              <a:latin typeface="Calibri"/>
+            </a:endParaRPr>
+          </a:p>
+          <a:p>
+            <a:pPr algn="just">
+              <a:spcAft>
+                <a:spcPts val="900"/>
+              </a:spcAft>
+            </a:pPr>
+            <a:endParaRPr lang="en-US" sz="1600" b="1" i="0" dirty="0">
+              <a:solidFill>
+                <a:srgbClr val="1A1A1A"/>
+              </a:solidFill>
+              <a:latin typeface="Calibri"/>
+            </a:endParaRPr>
+          </a:p>
+          <a:p>
+            <a:pPr algn="just">
+              <a:spcAft>
+                <a:spcPts val="900"/>
+              </a:spcAft>
+            </a:pPr>
+            <a:endParaRPr lang="en-US" sz="1600" b="1" dirty="0">
+              <a:solidFill>
+                <a:srgbClr val="1A1A1A"/>
+              </a:solidFill>
+              <a:latin typeface="Calibri"/>
+            </a:endParaRPr>
+          </a:p>
+          <a:p>
+            <a:pPr algn="just">
+              <a:spcAft>
+                <a:spcPts val="900"/>
+              </a:spcAft>
+            </a:pPr>
+            <a:r>
+              <a:rPr sz="1600" b="1" i="0" dirty="0">
                 <a:solidFill>
                   <a:srgbClr val="1A1A1A"/>
                 </a:solidFill>
@@ -6893,13 +7008,15 @@
             </a:r>
           </a:p>
           <a:p>
-            <a:pPr lvl="1">
+            <a:pPr marL="800100" lvl="1" indent="-342900" algn="just">
               <a:spcAft>
                 <a:spcPts val="900"/>
               </a:spcAft>
-            </a:pPr>
-            <a:r>
-              <a:rPr sz="1400" b="0" i="0">
+              <a:buFont typeface="+mj-lt"/>
+              <a:buAutoNum type="arabicPeriod"/>
+            </a:pPr>
+            <a:r>
+              <a:rPr sz="1400" b="0" i="0" dirty="0">
                 <a:solidFill>
                   <a:srgbClr val="5A6270"/>
                 </a:solidFill>
@@ -6909,13 +7026,15 @@
             </a:r>
           </a:p>
           <a:p>
-            <a:pPr lvl="1">
+            <a:pPr marL="800100" lvl="1" indent="-342900" algn="just">
               <a:spcAft>
                 <a:spcPts val="900"/>
               </a:spcAft>
-            </a:pPr>
-            <a:r>
-              <a:rPr sz="1400" b="0" i="0">
+              <a:buFont typeface="+mj-lt"/>
+              <a:buAutoNum type="arabicPeriod"/>
+            </a:pPr>
+            <a:r>
+              <a:rPr sz="1400" b="0" i="0" dirty="0">
                 <a:solidFill>
                   <a:srgbClr val="5A6270"/>
                 </a:solidFill>
@@ -6925,13 +7044,15 @@
             </a:r>
           </a:p>
           <a:p>
-            <a:pPr lvl="1">
+            <a:pPr marL="800100" lvl="1" indent="-342900" algn="just">
               <a:spcAft>
                 <a:spcPts val="900"/>
               </a:spcAft>
-            </a:pPr>
-            <a:r>
-              <a:rPr sz="1400" b="0" i="0">
+              <a:buFont typeface="+mj-lt"/>
+              <a:buAutoNum type="arabicPeriod"/>
+            </a:pPr>
+            <a:r>
+              <a:rPr sz="1400" b="0" i="0" dirty="0">
                 <a:solidFill>
                   <a:srgbClr val="5A6270"/>
                 </a:solidFill>
@@ -6941,13 +7062,13 @@
             </a:r>
           </a:p>
           <a:p>
-            <a:pPr>
+            <a:pPr algn="just">
               <a:spcAft>
                 <a:spcPts val="900"/>
               </a:spcAft>
             </a:pPr>
             <a:r>
-              <a:rPr sz="600" b="0" i="0">
+              <a:rPr sz="600" b="0" i="0" dirty="0">
                 <a:solidFill>
                   <a:srgbClr val="1A1A1A"/>
                 </a:solidFill>
@@ -6957,13 +7078,13 @@
             </a:r>
           </a:p>
           <a:p>
-            <a:pPr>
+            <a:pPr algn="just">
               <a:spcAft>
                 <a:spcPts val="900"/>
               </a:spcAft>
             </a:pPr>
             <a:r>
-              <a:rPr sz="1600" b="1" i="0">
+              <a:rPr sz="1600" b="1" i="0" dirty="0">
                 <a:solidFill>
                   <a:srgbClr val="2E5F8A"/>
                 </a:solidFill>
@@ -6973,13 +7094,15 @@
             </a:r>
           </a:p>
           <a:p>
-            <a:pPr lvl="1">
+            <a:pPr marL="800100" lvl="1" indent="-342900" algn="just">
               <a:spcAft>
                 <a:spcPts val="900"/>
               </a:spcAft>
-            </a:pPr>
-            <a:r>
-              <a:rPr sz="1400" b="0" i="0">
+              <a:buFont typeface="+mj-lt"/>
+              <a:buAutoNum type="arabicPeriod"/>
+            </a:pPr>
+            <a:r>
+              <a:rPr sz="1400" b="0" i="0" dirty="0">
                 <a:solidFill>
                   <a:srgbClr val="5A6270"/>
                 </a:solidFill>
@@ -6989,13 +7112,15 @@
             </a:r>
           </a:p>
           <a:p>
-            <a:pPr lvl="1">
+            <a:pPr marL="800100" lvl="1" indent="-342900" algn="just">
               <a:spcAft>
                 <a:spcPts val="900"/>
               </a:spcAft>
-            </a:pPr>
-            <a:r>
-              <a:rPr sz="1400" b="0" i="0">
+              <a:buFont typeface="+mj-lt"/>
+              <a:buAutoNum type="arabicPeriod"/>
+            </a:pPr>
+            <a:r>
+              <a:rPr sz="1400" b="0" i="0" dirty="0">
                 <a:solidFill>
                   <a:srgbClr val="5A6270"/>
                 </a:solidFill>
@@ -7006,6 +7131,36 @@
           </a:p>
         </p:txBody>
       </p:sp>
+      <p:pic>
+        <p:nvPicPr>
+          <p:cNvPr id="6" name="Picture 5">
+            <a:extLst>
+              <a:ext uri="{FF2B5EF4-FFF2-40B4-BE49-F238E27FC236}">
+                <a16:creationId xmlns:a16="http://schemas.microsoft.com/office/drawing/2014/main" id="{E355C817-C75E-F7EE-C8D2-DD4E3A010816}"/>
+              </a:ext>
+            </a:extLst>
+          </p:cNvPr>
+          <p:cNvPicPr>
+            <a:picLocks noChangeAspect="1"/>
+          </p:cNvPicPr>
+          <p:nvPr/>
+        </p:nvPicPr>
+        <p:blipFill>
+          <a:blip r:embed="rId2"/>
+          <a:stretch>
+            <a:fillRect/>
+          </a:stretch>
+        </p:blipFill>
+        <p:spPr>
+          <a:xfrm>
+            <a:off x="1828800" y="2476749"/>
+            <a:ext cx="8158700" cy="2039676"/>
+          </a:xfrm>
+          <a:prstGeom prst="rect">
+            <a:avLst/>
+          </a:prstGeom>
+        </p:spPr>
+      </p:pic>
     </p:spTree>
   </p:cSld>
   <p:clrMapOvr>

</xml_diff>

<commit_message>
Update presentation materials and enhance HTML content
- Updated `AvePoint_Case_Study.pptx` and `03_how_the_range_is_made_html.png` to reflect new visual enhancements and content adjustments.
- Modified `03_how_the_range_is_made.html` to improve clarity in the presentation of scores, replacing specific score details with more descriptive text and refining explanatory notes.

These changes aim to enhance the overall quality and clarity of the presentation materials, ensuring better communication of the case study findings.
</commit_message>
<xml_diff>
--- a/outputs/decks/AvePoint_Case_Study.pptx
+++ b/outputs/decks/AvePoint_Case_Study.pptx
@@ -154,7 +154,7 @@
   <pc:docChgLst>
     <pc:chgData name="Dmitriy Ratushny" userId="08050032e8047aee" providerId="LiveId" clId="{78EB1A6D-D3A9-4525-A4D5-A50D4E20D487}"/>
     <pc:docChg chg="undo custSel modSld">
-      <pc:chgData name="Dmitriy Ratushny" userId="08050032e8047aee" providerId="LiveId" clId="{78EB1A6D-D3A9-4525-A4D5-A50D4E20D487}" dt="2026-07-28T23:45:30.726" v="350" actId="1076"/>
+      <pc:chgData name="Dmitriy Ratushny" userId="08050032e8047aee" providerId="LiveId" clId="{78EB1A6D-D3A9-4525-A4D5-A50D4E20D487}" dt="2026-07-29T00:23:21.369" v="357" actId="1076"/>
       <pc:docMkLst>
         <pc:docMk/>
       </pc:docMkLst>
@@ -205,7 +205,7 @@
         </pc:picChg>
       </pc:sldChg>
       <pc:sldChg chg="addSp modSp mod">
-        <pc:chgData name="Dmitriy Ratushny" userId="08050032e8047aee" providerId="LiveId" clId="{78EB1A6D-D3A9-4525-A4D5-A50D4E20D487}" dt="2026-07-28T23:45:30.726" v="350" actId="1076"/>
+        <pc:chgData name="Dmitriy Ratushny" userId="08050032e8047aee" providerId="LiveId" clId="{78EB1A6D-D3A9-4525-A4D5-A50D4E20D487}" dt="2026-07-29T00:23:21.369" v="357" actId="1076"/>
         <pc:sldMkLst>
           <pc:docMk/>
           <pc:sldMk cId="0" sldId="258"/>
@@ -227,7 +227,7 @@
           </ac:spMkLst>
         </pc:spChg>
         <pc:spChg chg="mod">
-          <ac:chgData name="Dmitriy Ratushny" userId="08050032e8047aee" providerId="LiveId" clId="{78EB1A6D-D3A9-4525-A4D5-A50D4E20D487}" dt="2026-07-28T23:45:25.877" v="348" actId="1076"/>
+          <ac:chgData name="Dmitriy Ratushny" userId="08050032e8047aee" providerId="LiveId" clId="{78EB1A6D-D3A9-4525-A4D5-A50D4E20D487}" dt="2026-07-29T00:23:18.359" v="356" actId="1076"/>
           <ac:spMkLst>
             <pc:docMk/>
             <pc:sldMk cId="0" sldId="258"/>
@@ -235,7 +235,7 @@
           </ac:spMkLst>
         </pc:spChg>
         <pc:picChg chg="add mod">
-          <ac:chgData name="Dmitriy Ratushny" userId="08050032e8047aee" providerId="LiveId" clId="{78EB1A6D-D3A9-4525-A4D5-A50D4E20D487}" dt="2026-07-28T23:45:30.726" v="350" actId="1076"/>
+          <ac:chgData name="Dmitriy Ratushny" userId="08050032e8047aee" providerId="LiveId" clId="{78EB1A6D-D3A9-4525-A4D5-A50D4E20D487}" dt="2026-07-29T00:23:21.369" v="357" actId="1076"/>
           <ac:picMkLst>
             <pc:docMk/>
             <pc:sldMk cId="0" sldId="258"/>
@@ -6822,8 +6822,8 @@
         </p:nvSpPr>
         <p:spPr>
           <a:xfrm>
-            <a:off x="189021" y="1159681"/>
-            <a:ext cx="11813650" cy="5570756"/>
+            <a:off x="654050" y="1159681"/>
+            <a:ext cx="11277599" cy="5786199"/>
           </a:xfrm>
           <a:prstGeom prst="rect">
             <a:avLst/>
@@ -7153,7 +7153,7 @@
         </p:blipFill>
         <p:spPr>
           <a:xfrm>
-            <a:off x="1828800" y="2476749"/>
+            <a:off x="2616200" y="2667249"/>
             <a:ext cx="8158700" cy="2039676"/>
           </a:xfrm>
           <a:prstGeom prst="rect">

</xml_diff>

<commit_message>
Remove outdated content from main deck and update presentation deck
- Deleted the "Part 1 · Problem framing" section related to rolling origin from `build_main_deck.py`, streamlining the content for clarity.
- Updated the `AvePoint_Case_Study.pptx` to reflect these changes, ensuring the presentation aligns with the revised analysis and messaging.

These modifications aim to enhance the focus and coherence of the presentation materials, improving the communication of key findings.
</commit_message>
<xml_diff>
--- a/outputs/decks/AvePoint_Case_Study.pptx
+++ b/outputs/decks/AvePoint_Case_Study.pptx
@@ -144,7 +144,7 @@
 <file path=ppt/revisionInfo.xml><?xml version="1.0" encoding="utf-8"?>
 <p1510:revInfo xmlns:a="http://schemas.openxmlformats.org/drawingml/2006/main" xmlns:r="http://schemas.openxmlformats.org/officeDocument/2006/relationships" xmlns:p1510="http://schemas.microsoft.com/office/powerpoint/2015/10/main">
   <p1510:revLst>
-    <p1510:client id="{25DC7B8B-EC09-4841-A573-8FF6489E0CC5}" v="21" dt="2026-07-28T23:21:04.133"/>
+    <p1510:client id="{25DC7B8B-EC09-4841-A573-8FF6489E0CC5}" v="35" dt="2026-07-29T02:51:42.781"/>
   </p1510:revLst>
 </p1510:revInfo>
 </file>
@@ -154,7 +154,7 @@
   <pc:docChgLst>
     <pc:chgData name="Dmitriy Ratushny" userId="08050032e8047aee" providerId="LiveId" clId="{78EB1A6D-D3A9-4525-A4D5-A50D4E20D487}"/>
     <pc:docChg chg="undo custSel modSld">
-      <pc:chgData name="Dmitriy Ratushny" userId="08050032e8047aee" providerId="LiveId" clId="{78EB1A6D-D3A9-4525-A4D5-A50D4E20D487}" dt="2026-07-29T00:23:21.369" v="357" actId="1076"/>
+      <pc:chgData name="Dmitriy Ratushny" userId="08050032e8047aee" providerId="LiveId" clId="{78EB1A6D-D3A9-4525-A4D5-A50D4E20D487}" dt="2026-07-29T02:52:36.714" v="706" actId="1076"/>
       <pc:docMkLst>
         <pc:docMk/>
       </pc:docMkLst>
@@ -174,13 +174,21 @@
         </pc:spChg>
       </pc:sldChg>
       <pc:sldChg chg="delSp modSp mod">
-        <pc:chgData name="Dmitriy Ratushny" userId="08050032e8047aee" providerId="LiveId" clId="{78EB1A6D-D3A9-4525-A4D5-A50D4E20D487}" dt="2026-07-28T23:21:18.353" v="326" actId="20577"/>
+        <pc:chgData name="Dmitriy Ratushny" userId="08050032e8047aee" providerId="LiveId" clId="{78EB1A6D-D3A9-4525-A4D5-A50D4E20D487}" dt="2026-07-29T02:48:43.005" v="636" actId="20577"/>
         <pc:sldMkLst>
           <pc:docMk/>
           <pc:sldMk cId="0" sldId="257"/>
         </pc:sldMkLst>
         <pc:spChg chg="mod">
-          <ac:chgData name="Dmitriy Ratushny" userId="08050032e8047aee" providerId="LiveId" clId="{78EB1A6D-D3A9-4525-A4D5-A50D4E20D487}" dt="2026-07-28T23:21:18.353" v="326" actId="20577"/>
+          <ac:chgData name="Dmitriy Ratushny" userId="08050032e8047aee" providerId="LiveId" clId="{78EB1A6D-D3A9-4525-A4D5-A50D4E20D487}" dt="2026-07-29T02:47:45.155" v="617" actId="1076"/>
+          <ac:spMkLst>
+            <pc:docMk/>
+            <pc:sldMk cId="0" sldId="257"/>
+            <ac:spMk id="3" creationId="{00000000-0000-0000-0000-000000000000}"/>
+          </ac:spMkLst>
+        </pc:spChg>
+        <pc:spChg chg="mod">
+          <ac:chgData name="Dmitriy Ratushny" userId="08050032e8047aee" providerId="LiveId" clId="{78EB1A6D-D3A9-4525-A4D5-A50D4E20D487}" dt="2026-07-29T02:48:43.005" v="636" actId="20577"/>
           <ac:spMkLst>
             <pc:docMk/>
             <pc:sldMk cId="0" sldId="257"/>
@@ -196,7 +204,7 @@
           </ac:spMkLst>
         </pc:spChg>
         <pc:picChg chg="mod modCrop">
-          <ac:chgData name="Dmitriy Ratushny" userId="08050032e8047aee" providerId="LiveId" clId="{78EB1A6D-D3A9-4525-A4D5-A50D4E20D487}" dt="2026-07-28T23:06:28.700" v="110" actId="1076"/>
+          <ac:chgData name="Dmitriy Ratushny" userId="08050032e8047aee" providerId="LiveId" clId="{78EB1A6D-D3A9-4525-A4D5-A50D4E20D487}" dt="2026-07-29T02:48:36.726" v="634" actId="1076"/>
           <ac:picMkLst>
             <pc:docMk/>
             <pc:sldMk cId="0" sldId="257"/>
@@ -204,8 +212,8 @@
           </ac:picMkLst>
         </pc:picChg>
       </pc:sldChg>
-      <pc:sldChg chg="addSp modSp mod">
-        <pc:chgData name="Dmitriy Ratushny" userId="08050032e8047aee" providerId="LiveId" clId="{78EB1A6D-D3A9-4525-A4D5-A50D4E20D487}" dt="2026-07-29T00:23:21.369" v="357" actId="1076"/>
+      <pc:sldChg chg="addSp delSp modSp mod">
+        <pc:chgData name="Dmitriy Ratushny" userId="08050032e8047aee" providerId="LiveId" clId="{78EB1A6D-D3A9-4525-A4D5-A50D4E20D487}" dt="2026-07-29T02:52:36.714" v="706" actId="1076"/>
         <pc:sldMkLst>
           <pc:docMk/>
           <pc:sldMk cId="0" sldId="258"/>
@@ -227,19 +235,27 @@
           </ac:spMkLst>
         </pc:spChg>
         <pc:spChg chg="mod">
-          <ac:chgData name="Dmitriy Ratushny" userId="08050032e8047aee" providerId="LiveId" clId="{78EB1A6D-D3A9-4525-A4D5-A50D4E20D487}" dt="2026-07-29T00:23:18.359" v="356" actId="1076"/>
+          <ac:chgData name="Dmitriy Ratushny" userId="08050032e8047aee" providerId="LiveId" clId="{78EB1A6D-D3A9-4525-A4D5-A50D4E20D487}" dt="2026-07-29T02:52:27.656" v="705" actId="1076"/>
           <ac:spMkLst>
             <pc:docMk/>
             <pc:sldMk cId="0" sldId="258"/>
             <ac:spMk id="4" creationId="{00000000-0000-0000-0000-000000000000}"/>
           </ac:spMkLst>
         </pc:spChg>
-        <pc:picChg chg="add mod">
-          <ac:chgData name="Dmitriy Ratushny" userId="08050032e8047aee" providerId="LiveId" clId="{78EB1A6D-D3A9-4525-A4D5-A50D4E20D487}" dt="2026-07-29T00:23:21.369" v="357" actId="1076"/>
+        <pc:picChg chg="add del mod">
+          <ac:chgData name="Dmitriy Ratushny" userId="08050032e8047aee" providerId="LiveId" clId="{78EB1A6D-D3A9-4525-A4D5-A50D4E20D487}" dt="2026-07-29T02:08:27.146" v="361" actId="478"/>
           <ac:picMkLst>
             <pc:docMk/>
             <pc:sldMk cId="0" sldId="258"/>
             <ac:picMk id="6" creationId="{E355C817-C75E-F7EE-C8D2-DD4E3A010816}"/>
+          </ac:picMkLst>
+        </pc:picChg>
+        <pc:picChg chg="add mod">
+          <ac:chgData name="Dmitriy Ratushny" userId="08050032e8047aee" providerId="LiveId" clId="{78EB1A6D-D3A9-4525-A4D5-A50D4E20D487}" dt="2026-07-29T02:52:36.714" v="706" actId="1076"/>
+          <ac:picMkLst>
+            <pc:docMk/>
+            <pc:sldMk cId="0" sldId="258"/>
+            <ac:picMk id="7" creationId="{D4F31BD9-B3BF-043E-1566-F360B51678E4}"/>
           </ac:picMkLst>
         </pc:picChg>
       </pc:sldChg>
@@ -6154,7 +6170,7 @@
         </p:nvSpPr>
         <p:spPr>
           <a:xfrm>
-            <a:off x="685800" y="1426464"/>
+            <a:off x="685800" y="1210564"/>
             <a:ext cx="10820095" cy="9525"/>
           </a:xfrm>
           <a:prstGeom prst="rect">
@@ -6199,8 +6215,8 @@
         </p:nvSpPr>
         <p:spPr>
           <a:xfrm>
-            <a:off x="685799" y="1594108"/>
-            <a:ext cx="10820095" cy="3277820"/>
+            <a:off x="685799" y="1298647"/>
+            <a:ext cx="10820095" cy="5555367"/>
           </a:xfrm>
           <a:prstGeom prst="rect">
             <a:avLst/>
@@ -6628,20 +6644,158 @@
               <a:buFont typeface="+mj-lt"/>
               <a:buAutoNum type="arabicPeriod"/>
             </a:pPr>
+            <a:endParaRPr lang="en-US" sz="1200" dirty="0">
+              <a:solidFill>
+                <a:srgbClr val="5A6270"/>
+              </a:solidFill>
+              <a:latin typeface="Calibri"/>
+            </a:endParaRPr>
+          </a:p>
+          <a:p>
+            <a:pPr marL="685800" lvl="1" indent="-228600" algn="just">
+              <a:spcAft>
+                <a:spcPts val="600"/>
+              </a:spcAft>
+              <a:buFont typeface="+mj-lt"/>
+              <a:buAutoNum type="arabicPeriod"/>
+            </a:pPr>
+            <a:endParaRPr lang="en-US" sz="1200" b="0" i="0" dirty="0">
+              <a:solidFill>
+                <a:srgbClr val="5A6270"/>
+              </a:solidFill>
+              <a:latin typeface="Calibri"/>
+            </a:endParaRPr>
+          </a:p>
+          <a:p>
+            <a:pPr marL="685800" lvl="1" indent="-228600" algn="just">
+              <a:spcAft>
+                <a:spcPts val="600"/>
+              </a:spcAft>
+              <a:buFont typeface="+mj-lt"/>
+              <a:buAutoNum type="arabicPeriod"/>
+            </a:pPr>
+            <a:endParaRPr lang="en-US" sz="1200" dirty="0">
+              <a:solidFill>
+                <a:srgbClr val="5A6270"/>
+              </a:solidFill>
+              <a:latin typeface="Calibri"/>
+            </a:endParaRPr>
+          </a:p>
+          <a:p>
+            <a:pPr marL="685800" lvl="1" indent="-228600" algn="just">
+              <a:spcAft>
+                <a:spcPts val="600"/>
+              </a:spcAft>
+              <a:buFont typeface="+mj-lt"/>
+              <a:buAutoNum type="arabicPeriod"/>
+            </a:pPr>
+            <a:endParaRPr lang="en-US" sz="1200" b="0" i="0" dirty="0">
+              <a:solidFill>
+                <a:srgbClr val="5A6270"/>
+              </a:solidFill>
+              <a:latin typeface="Calibri"/>
+            </a:endParaRPr>
+          </a:p>
+          <a:p>
+            <a:pPr marL="685800" lvl="1" indent="-228600" algn="just">
+              <a:spcAft>
+                <a:spcPts val="600"/>
+              </a:spcAft>
+              <a:buFont typeface="+mj-lt"/>
+              <a:buAutoNum type="arabicPeriod"/>
+            </a:pPr>
+            <a:endParaRPr lang="en-US" sz="1200" dirty="0">
+              <a:solidFill>
+                <a:srgbClr val="5A6270"/>
+              </a:solidFill>
+              <a:latin typeface="Calibri"/>
+            </a:endParaRPr>
+          </a:p>
+          <a:p>
+            <a:pPr marL="685800" lvl="1" indent="-228600" algn="just">
+              <a:spcAft>
+                <a:spcPts val="600"/>
+              </a:spcAft>
+              <a:buFont typeface="+mj-lt"/>
+              <a:buAutoNum type="arabicPeriod"/>
+            </a:pPr>
+            <a:endParaRPr lang="en-US" sz="1200" b="0" i="0" dirty="0">
+              <a:solidFill>
+                <a:srgbClr val="5A6270"/>
+              </a:solidFill>
+              <a:latin typeface="Calibri"/>
+            </a:endParaRPr>
+          </a:p>
+          <a:p>
+            <a:pPr marL="685800" lvl="1" indent="-228600" algn="just">
+              <a:spcAft>
+                <a:spcPts val="600"/>
+              </a:spcAft>
+              <a:buFont typeface="+mj-lt"/>
+              <a:buAutoNum type="arabicPeriod"/>
+            </a:pPr>
+            <a:endParaRPr lang="en-US" sz="1200" b="0" i="0" dirty="0">
+              <a:solidFill>
+                <a:srgbClr val="5A6270"/>
+              </a:solidFill>
+              <a:latin typeface="Calibri"/>
+            </a:endParaRPr>
+          </a:p>
+          <a:p>
+            <a:pPr marL="685800" lvl="1" indent="-228600" algn="just">
+              <a:spcAft>
+                <a:spcPts val="600"/>
+              </a:spcAft>
+              <a:buFont typeface="+mj-lt"/>
+              <a:buAutoNum type="arabicPeriod"/>
+            </a:pPr>
             <a:r>
               <a:rPr lang="en-US" sz="1200" dirty="0">
                 <a:solidFill>
                   <a:srgbClr val="5A6270"/>
                 </a:solidFill>
               </a:rPr>
-              <a:t>“Churn” definition is </a:t>
-            </a:r>
-            <a:r>
-              <a:rPr lang="en-US" sz="1200" b="1" dirty="0">
+              <a:t>That gives 648 customer-dates, 281 distinct customers, and 159 leavers - 24.5%. The rate per cutoff runs 17% to 31%</a:t>
+            </a:r>
+          </a:p>
+          <a:p>
+            <a:pPr marL="685800" lvl="1" indent="-228600" algn="just">
+              <a:spcAft>
+                <a:spcPts val="600"/>
+              </a:spcAft>
+              <a:buFont typeface="+mj-lt"/>
+              <a:buAutoNum type="arabicPeriod"/>
+            </a:pPr>
+            <a:r>
+              <a:rPr lang="en-US" sz="1200" dirty="0">
+                <a:solidFill>
+                  <a:srgbClr val="5A6270"/>
+                </a:solidFill>
+              </a:rPr>
+              <a:t>The label comes from </a:t>
+            </a:r>
+            <a:r>
+              <a:rPr lang="en-US" sz="1200" b="1" dirty="0" err="1">
                 <a:solidFill>
                   <a:schemeClr val="tx2"/>
                 </a:solidFill>
               </a:rPr>
+              <a:t>churn_events</a:t>
+            </a:r>
+            <a:r>
+              <a:rPr lang="en-US" sz="1200" dirty="0">
+                <a:solidFill>
+                  <a:srgbClr val="5A6270"/>
+                </a:solidFill>
+              </a:rPr>
+              <a:t>: an eligible account is positive if its earliest </a:t>
+            </a:r>
+            <a:r>
+              <a:rPr lang="en-US" sz="1200" b="1" dirty="0" err="1">
+                <a:solidFill>
+                  <a:schemeClr val="tx2"/>
+                </a:solidFill>
+              </a:rPr>
               <a:t>churn_events.churn_date</a:t>
             </a:r>
             <a:r>
@@ -6650,15 +6804,7 @@
                   <a:srgbClr val="5A6270"/>
                 </a:solidFill>
               </a:rPr>
-              <a:t>. "Still a customer" is a subscriptions row open on that </a:t>
-            </a:r>
-            <a:r>
-              <a:rPr lang="en-US" sz="1200">
-                <a:solidFill>
-                  <a:srgbClr val="5A6270"/>
-                </a:solidFill>
-              </a:rPr>
-              <a:t>date.</a:t>
+              <a:t> falls within the 90 days from the cutoff. Everything else is negative. </a:t>
             </a:r>
             <a:endParaRPr sz="1200" b="0" i="0" dirty="0">
               <a:solidFill>
@@ -6686,8 +6832,8 @@
         </p:blipFill>
         <p:spPr>
           <a:xfrm>
-            <a:off x="279400" y="4953103"/>
-            <a:ext cx="8233726" cy="1858392"/>
+            <a:off x="1327150" y="4335023"/>
+            <a:ext cx="7427274" cy="1676372"/>
           </a:xfrm>
           <a:prstGeom prst="rect">
             <a:avLst/>
@@ -6742,7 +6888,7 @@
           <a:lstStyle/>
           <a:p>
             <a:r>
-              <a:rPr sz="1200" b="1" i="0">
+              <a:rPr sz="1200" b="1" i="0" dirty="0">
                 <a:solidFill>
                   <a:srgbClr val="5A6270"/>
                 </a:solidFill>
@@ -6758,7 +6904,7 @@
               </a:spcBef>
             </a:pPr>
             <a:r>
-              <a:rPr sz="2800" b="1" i="0">
+              <a:rPr sz="2800" b="1" i="0" dirty="0">
                 <a:solidFill>
                   <a:srgbClr val="1A1A1A"/>
                 </a:solidFill>
@@ -6822,8 +6968,8 @@
         </p:nvSpPr>
         <p:spPr>
           <a:xfrm>
-            <a:off x="654050" y="1159681"/>
-            <a:ext cx="11277599" cy="5786199"/>
+            <a:off x="654049" y="1306835"/>
+            <a:ext cx="11277599" cy="5640006"/>
           </a:xfrm>
           <a:prstGeom prst="rect">
             <a:avLst/>
@@ -6866,7 +7012,7 @@
                 </a:solidFill>
                 <a:latin typeface="Calibri"/>
               </a:rPr>
-              <a:t>ROC-AUC measures how well the model sorts customers by risk. 0.5 means it is guessing. I always report a range around it, never a single number.</a:t>
+              <a:t>ROC-AUC measures how well the model sorts customers by risk. 0.5 means it is guessing</a:t>
             </a:r>
           </a:p>
           <a:p>
@@ -6914,30 +7060,19 @@
               <a:buAutoNum type="arabicPeriod"/>
             </a:pPr>
             <a:r>
-              <a:rPr sz="1400" b="0" i="0" dirty="0">
-                <a:solidFill>
-                  <a:srgbClr val="5A6270"/>
-                </a:solidFill>
-                <a:latin typeface="Calibri"/>
-              </a:rPr>
-              <a:t>The headline number comes from nested cross-validation. That is the only version that accounts for the fact that I also chose the model.</a:t>
-            </a:r>
-          </a:p>
-          <a:p>
-            <a:pPr algn="just">
-              <a:spcAft>
-                <a:spcPts val="900"/>
-              </a:spcAft>
-            </a:pPr>
-            <a:r>
-              <a:rPr sz="600" b="0" i="0" dirty="0">
-                <a:solidFill>
-                  <a:srgbClr val="1A1A1A"/>
-                </a:solidFill>
-                <a:latin typeface="Calibri"/>
-              </a:rPr>
-              <a:t> </a:t>
-            </a:r>
+              <a:rPr lang="en-US" sz="1400" dirty="0">
+                <a:solidFill>
+                  <a:srgbClr val="5A6270"/>
+                </a:solidFill>
+              </a:rPr>
+              <a:t>I score the same model 25 times, each time holding out a different group of customers completely. What I report is where those 25 land and how far apart they are</a:t>
+            </a:r>
+            <a:endParaRPr lang="en-US" sz="1600" b="1" dirty="0">
+              <a:solidFill>
+                <a:srgbClr val="1A1A1A"/>
+              </a:solidFill>
+              <a:latin typeface="Calibri"/>
+            </a:endParaRPr>
           </a:p>
           <a:p>
             <a:pPr algn="just">
@@ -6958,6 +7093,32 @@
                 <a:spcPts val="900"/>
               </a:spcAft>
             </a:pPr>
+            <a:endParaRPr lang="en-US" sz="1600" dirty="0">
+              <a:solidFill>
+                <a:srgbClr val="1A1A1A"/>
+              </a:solidFill>
+              <a:latin typeface="Calibri"/>
+            </a:endParaRPr>
+          </a:p>
+          <a:p>
+            <a:pPr algn="just">
+              <a:spcAft>
+                <a:spcPts val="900"/>
+              </a:spcAft>
+            </a:pPr>
+            <a:endParaRPr lang="en-US" sz="1600" b="1" i="0" dirty="0">
+              <a:solidFill>
+                <a:srgbClr val="1A1A1A"/>
+              </a:solidFill>
+              <a:latin typeface="Calibri"/>
+            </a:endParaRPr>
+          </a:p>
+          <a:p>
+            <a:pPr algn="just">
+              <a:spcAft>
+                <a:spcPts val="900"/>
+              </a:spcAft>
+            </a:pPr>
             <a:endParaRPr lang="en-US" sz="1600" b="1" dirty="0">
               <a:solidFill>
                 <a:srgbClr val="1A1A1A"/>
@@ -6984,6 +7145,19 @@
                 <a:spcPts val="900"/>
               </a:spcAft>
             </a:pPr>
+            <a:endParaRPr lang="en-US" sz="1600" b="1" i="0" dirty="0">
+              <a:solidFill>
+                <a:srgbClr val="1A1A1A"/>
+              </a:solidFill>
+              <a:latin typeface="Calibri"/>
+            </a:endParaRPr>
+          </a:p>
+          <a:p>
+            <a:pPr algn="just">
+              <a:spcAft>
+                <a:spcPts val="900"/>
+              </a:spcAft>
+            </a:pPr>
             <a:endParaRPr lang="en-US" sz="1600" b="1" dirty="0">
               <a:solidFill>
                 <a:srgbClr val="1A1A1A"/>
@@ -7016,13 +7190,12 @@
               <a:buAutoNum type="arabicPeriod"/>
             </a:pPr>
             <a:r>
-              <a:rPr sz="1400" b="0" i="0" dirty="0">
-                <a:solidFill>
-                  <a:srgbClr val="5A6270"/>
-                </a:solidFill>
-                <a:latin typeface="Calibri"/>
-              </a:rPr>
-              <a:t>Retention 180 days after any change we make.</a:t>
+              <a:rPr lang="en-US" sz="1400" dirty="0">
+                <a:solidFill>
+                  <a:srgbClr val="5A6270"/>
+                </a:solidFill>
+              </a:rPr>
+              <a:t>Did they stay? Compare the customers we called against a half we deliberately didn’t.</a:t>
             </a:r>
           </a:p>
           <a:p>
@@ -7034,13 +7207,12 @@
               <a:buAutoNum type="arabicPeriod"/>
             </a:pPr>
             <a:r>
-              <a:rPr sz="1400" b="0" i="0" dirty="0">
-                <a:solidFill>
-                  <a:srgbClr val="5A6270"/>
-                </a:solidFill>
-                <a:latin typeface="Calibri"/>
-              </a:rPr>
-              <a:t>Money kept, so that a saved customer who needed a large discount is not counted as a win.</a:t>
+              <a:rPr lang="en-US" sz="1400" dirty="0">
+                <a:solidFill>
+                  <a:srgbClr val="5A6270"/>
+                </a:solidFill>
+              </a:rPr>
+              <a:t>Did we maintain our profit margins after discounts? </a:t>
             </a:r>
           </a:p>
           <a:p>
@@ -7052,14 +7224,19 @@
               <a:buAutoNum type="arabicPeriod"/>
             </a:pPr>
             <a:r>
-              <a:rPr sz="1400" b="0" i="0" dirty="0">
-                <a:solidFill>
-                  <a:srgbClr val="5A6270"/>
-                </a:solidFill>
-                <a:latin typeface="Calibri"/>
-              </a:rPr>
-              <a:t>Value of the campaign compared with calling everyone. Zero is the wrong thing to compare against.</a:t>
-            </a:r>
+              <a:rPr lang="en-US" sz="1400" dirty="0">
+                <a:solidFill>
+                  <a:srgbClr val="5A6270"/>
+                </a:solidFill>
+              </a:rPr>
+              <a:t>Was the model worth using? Compare it against just calling everyone.</a:t>
+            </a:r>
+            <a:endParaRPr sz="1400" b="0" i="0" dirty="0">
+              <a:solidFill>
+                <a:srgbClr val="5A6270"/>
+              </a:solidFill>
+              <a:latin typeface="Calibri"/>
+            </a:endParaRPr>
           </a:p>
           <a:p>
             <a:pPr algn="just">
@@ -7075,68 +7252,16 @@
                 <a:latin typeface="Calibri"/>
               </a:rPr>
               <a:t> </a:t>
-            </a:r>
-          </a:p>
-          <a:p>
-            <a:pPr algn="just">
-              <a:spcAft>
-                <a:spcPts val="900"/>
-              </a:spcAft>
-            </a:pPr>
-            <a:r>
-              <a:rPr sz="1600" b="1" i="0" dirty="0">
-                <a:solidFill>
-                  <a:srgbClr val="2E5F8A"/>
-                </a:solidFill>
-                <a:latin typeface="Calibri"/>
-              </a:rPr>
-              <a:t>Limits I set before starting</a:t>
-            </a:r>
-          </a:p>
-          <a:p>
-            <a:pPr marL="800100" lvl="1" indent="-342900" algn="just">
-              <a:spcAft>
-                <a:spcPts val="900"/>
-              </a:spcAft>
-              <a:buFont typeface="+mj-lt"/>
-              <a:buAutoNum type="arabicPeriod"/>
-            </a:pPr>
-            <a:r>
-              <a:rPr sz="1400" b="0" i="0" dirty="0">
-                <a:solidFill>
-                  <a:srgbClr val="5A6270"/>
-                </a:solidFill>
-                <a:latin typeface="Calibri"/>
-              </a:rPr>
-              <a:t>The model has to beat guessing at the bottom of its range, not just on average. It also has to beat simply calling every customer.</a:t>
-            </a:r>
-          </a:p>
-          <a:p>
-            <a:pPr marL="800100" lvl="1" indent="-342900" algn="just">
-              <a:spcAft>
-                <a:spcPts val="900"/>
-              </a:spcAft>
-              <a:buFont typeface="+mj-lt"/>
-              <a:buAutoNum type="arabicPeriod"/>
-            </a:pPr>
-            <a:r>
-              <a:rPr sz="1400" b="0" i="0" dirty="0">
-                <a:solidFill>
-                  <a:srgbClr val="5A6270"/>
-                </a:solidFill>
-                <a:latin typeface="Calibri"/>
-              </a:rPr>
-              <a:t>Scores order a call list. They never trigger an action on their own.</a:t>
             </a:r>
           </a:p>
         </p:txBody>
       </p:sp>
       <p:pic>
         <p:nvPicPr>
-          <p:cNvPr id="6" name="Picture 5">
+          <p:cNvPr id="7" name="Picture 6">
             <a:extLst>
               <a:ext uri="{FF2B5EF4-FFF2-40B4-BE49-F238E27FC236}">
-                <a16:creationId xmlns:a16="http://schemas.microsoft.com/office/drawing/2014/main" id="{E355C817-C75E-F7EE-C8D2-DD4E3A010816}"/>
+                <a16:creationId xmlns:a16="http://schemas.microsoft.com/office/drawing/2014/main" id="{D4F31BD9-B3BF-043E-1566-F360B51678E4}"/>
               </a:ext>
             </a:extLst>
           </p:cNvPr>
@@ -7153,8 +7278,8 @@
         </p:blipFill>
         <p:spPr>
           <a:xfrm>
-            <a:off x="2616200" y="2667249"/>
-            <a:ext cx="8158700" cy="2039676"/>
+            <a:off x="1355557" y="2851558"/>
+            <a:ext cx="9766300" cy="2441575"/>
           </a:xfrm>
           <a:prstGeom prst="rect">
             <a:avLst/>
@@ -7309,7 +7434,7 @@
               </a:spcAft>
             </a:pPr>
             <a:r>
-              <a:rPr sz="1400" b="1" i="0">
+              <a:rPr sz="1400" b="1" i="0" dirty="0">
                 <a:solidFill>
                   <a:srgbClr val="B02E2E"/>
                 </a:solidFill>
@@ -7325,7 +7450,7 @@
               </a:spcAft>
             </a:pPr>
             <a:r>
-              <a:rPr sz="1200" b="0" i="0">
+              <a:rPr sz="1200" b="0" i="0" dirty="0">
                 <a:solidFill>
                   <a:srgbClr val="5A6270"/>
                 </a:solidFill>
@@ -7341,7 +7466,7 @@
               </a:spcAft>
             </a:pPr>
             <a:r>
-              <a:rPr sz="1200" b="0" i="0">
+              <a:rPr sz="1200" b="0" i="0" dirty="0">
                 <a:solidFill>
                   <a:srgbClr val="5A6270"/>
                 </a:solidFill>
@@ -7357,7 +7482,7 @@
               </a:spcAft>
             </a:pPr>
             <a:r>
-              <a:rPr sz="1200" b="0" i="0">
+              <a:rPr sz="1200" b="0" i="0" dirty="0">
                 <a:solidFill>
                   <a:srgbClr val="5A6270"/>
                 </a:solidFill>
@@ -7373,7 +7498,7 @@
               </a:spcAft>
             </a:pPr>
             <a:r>
-              <a:rPr sz="1200" b="0" i="0">
+              <a:rPr sz="1200" b="0" i="0" dirty="0">
                 <a:solidFill>
                   <a:srgbClr val="5A6270"/>
                 </a:solidFill>
@@ -7389,7 +7514,7 @@
               </a:spcAft>
             </a:pPr>
             <a:r>
-              <a:rPr sz="1200" b="0" i="0">
+              <a:rPr sz="1200" b="0" i="0" dirty="0">
                 <a:solidFill>
                   <a:srgbClr val="5A6270"/>
                 </a:solidFill>
@@ -7405,7 +7530,7 @@
               </a:spcAft>
             </a:pPr>
             <a:r>
-              <a:rPr sz="600" b="0" i="0">
+              <a:rPr sz="600" b="0" i="0" dirty="0">
                 <a:solidFill>
                   <a:srgbClr val="1A1A1A"/>
                 </a:solidFill>
@@ -7421,7 +7546,7 @@
               </a:spcAft>
             </a:pPr>
             <a:r>
-              <a:rPr sz="1400" b="1" i="0">
+              <a:rPr sz="1400" b="1" i="0" dirty="0">
                 <a:solidFill>
                   <a:srgbClr val="1A1A1A"/>
                 </a:solidFill>
@@ -7437,7 +7562,7 @@
               </a:spcAft>
             </a:pPr>
             <a:r>
-              <a:rPr sz="600" b="0" i="0">
+              <a:rPr sz="600" b="0" i="0" dirty="0">
                 <a:solidFill>
                   <a:srgbClr val="1A1A1A"/>
                 </a:solidFill>
@@ -7453,7 +7578,7 @@
               </a:spcAft>
             </a:pPr>
             <a:r>
-              <a:rPr sz="1400" b="1" i="0">
+              <a:rPr sz="1400" b="1" i="0" dirty="0">
                 <a:solidFill>
                   <a:srgbClr val="1A1A1A"/>
                 </a:solidFill>
@@ -7469,7 +7594,7 @@
               </a:spcAft>
             </a:pPr>
             <a:r>
-              <a:rPr sz="600" b="0" i="0">
+              <a:rPr sz="600" b="0" i="0" dirty="0">
                 <a:solidFill>
                   <a:srgbClr val="1A1A1A"/>
                 </a:solidFill>
@@ -7485,7 +7610,7 @@
               </a:spcAft>
             </a:pPr>
             <a:r>
-              <a:rPr sz="1400" b="1" i="0">
+              <a:rPr sz="1400" b="1" i="0" dirty="0">
                 <a:solidFill>
                   <a:srgbClr val="1A1A1A"/>
                 </a:solidFill>
@@ -7501,7 +7626,7 @@
               </a:spcAft>
             </a:pPr>
             <a:r>
-              <a:rPr sz="1200" b="0" i="0">
+              <a:rPr sz="1200" b="0" i="0" dirty="0">
                 <a:solidFill>
                   <a:srgbClr val="5A6270"/>
                 </a:solidFill>
@@ -7517,7 +7642,7 @@
               </a:spcAft>
             </a:pPr>
             <a:r>
-              <a:rPr sz="1200" b="0" i="0">
+              <a:rPr sz="1200" b="0" i="0" dirty="0">
                 <a:solidFill>
                   <a:srgbClr val="5A6270"/>
                 </a:solidFill>
@@ -7533,7 +7658,7 @@
               </a:spcAft>
             </a:pPr>
             <a:r>
-              <a:rPr sz="1200" b="0" i="0">
+              <a:rPr sz="1200" b="0" i="0" dirty="0">
                 <a:solidFill>
                   <a:srgbClr val="5A6270"/>
                 </a:solidFill>

</xml_diff>

<commit_message>
Update `AvePoint_Case_Study.pptx` with additional content revisions
- Revised the `AvePoint_Case_Study.pptx` to incorporate further updates, enhancing the presentation's alignment with the latest insights and analysis.
- Improved visual elements to ensure clarity and engagement in conveying key findings.

These modifications aim to refine the overall quality and effectiveness of the case study presentation.
</commit_message>
<xml_diff>
--- a/outputs/decks/AvePoint_Case_Study.pptx
+++ b/outputs/decks/AvePoint_Case_Study.pptx
@@ -5,7 +5,7 @@
     <p:sldMasterId id="2147483648" r:id="rId1"/>
   </p:sldMasterIdLst>
   <p:notesMasterIdLst>
-    <p:notesMasterId r:id="rId19"/>
+    <p:notesMasterId r:id="rId20"/>
   </p:notesMasterIdLst>
   <p:sldIdLst>
     <p:sldId id="256" r:id="rId2"/>
@@ -13,18 +13,19 @@
     <p:sldId id="258" r:id="rId4"/>
     <p:sldId id="259" r:id="rId5"/>
     <p:sldId id="272" r:id="rId6"/>
-    <p:sldId id="260" r:id="rId7"/>
-    <p:sldId id="261" r:id="rId8"/>
-    <p:sldId id="262" r:id="rId9"/>
-    <p:sldId id="263" r:id="rId10"/>
-    <p:sldId id="264" r:id="rId11"/>
-    <p:sldId id="265" r:id="rId12"/>
-    <p:sldId id="266" r:id="rId13"/>
-    <p:sldId id="267" r:id="rId14"/>
-    <p:sldId id="268" r:id="rId15"/>
-    <p:sldId id="269" r:id="rId16"/>
-    <p:sldId id="270" r:id="rId17"/>
-    <p:sldId id="271" r:id="rId18"/>
+    <p:sldId id="273" r:id="rId7"/>
+    <p:sldId id="260" r:id="rId8"/>
+    <p:sldId id="261" r:id="rId9"/>
+    <p:sldId id="262" r:id="rId10"/>
+    <p:sldId id="263" r:id="rId11"/>
+    <p:sldId id="264" r:id="rId12"/>
+    <p:sldId id="265" r:id="rId13"/>
+    <p:sldId id="266" r:id="rId14"/>
+    <p:sldId id="267" r:id="rId15"/>
+    <p:sldId id="268" r:id="rId16"/>
+    <p:sldId id="269" r:id="rId17"/>
+    <p:sldId id="270" r:id="rId18"/>
+    <p:sldId id="271" r:id="rId19"/>
   </p:sldIdLst>
   <p:sldSz cx="12192000" cy="6858000"/>
   <p:notesSz cx="6858000" cy="9144000"/>
@@ -145,7 +146,7 @@
 <file path=ppt/revisionInfo.xml><?xml version="1.0" encoding="utf-8"?>
 <p1510:revInfo xmlns:a="http://schemas.openxmlformats.org/drawingml/2006/main" xmlns:r="http://schemas.openxmlformats.org/officeDocument/2006/relationships" xmlns:p1510="http://schemas.microsoft.com/office/powerpoint/2015/10/main">
   <p1510:revLst>
-    <p1510:client id="{25DC7B8B-EC09-4841-A573-8FF6489E0CC5}" v="87" dt="2026-07-29T04:05:41.376"/>
+    <p1510:client id="{25DC7B8B-EC09-4841-A573-8FF6489E0CC5}" v="91" dt="2026-07-29T04:34:16.235"/>
   </p1510:revLst>
 </p1510:revInfo>
 </file>
@@ -155,7 +156,7 @@
   <pc:docChgLst>
     <pc:chgData name="Dmitriy Ratushny" userId="08050032e8047aee" providerId="LiveId" clId="{78EB1A6D-D3A9-4525-A4D5-A50D4E20D487}"/>
     <pc:docChg chg="undo custSel addSld modSld">
-      <pc:chgData name="Dmitriy Ratushny" userId="08050032e8047aee" providerId="LiveId" clId="{78EB1A6D-D3A9-4525-A4D5-A50D4E20D487}" dt="2026-07-29T04:10:32.206" v="1621" actId="1076"/>
+      <pc:chgData name="Dmitriy Ratushny" userId="08050032e8047aee" providerId="LiveId" clId="{78EB1A6D-D3A9-4525-A4D5-A50D4E20D487}" dt="2026-07-29T04:34:24.604" v="1631" actId="1076"/>
       <pc:docMkLst>
         <pc:docMk/>
       </pc:docMkLst>
@@ -330,8 +331,8 @@
           </ac:picMkLst>
         </pc:picChg>
       </pc:sldChg>
-      <pc:sldChg chg="addSp modSp new mod">
-        <pc:chgData name="Dmitriy Ratushny" userId="08050032e8047aee" providerId="LiveId" clId="{78EB1A6D-D3A9-4525-A4D5-A50D4E20D487}" dt="2026-07-29T04:06:18.688" v="1618" actId="20577"/>
+      <pc:sldChg chg="addSp delSp modSp new mod">
+        <pc:chgData name="Dmitriy Ratushny" userId="08050032e8047aee" providerId="LiveId" clId="{78EB1A6D-D3A9-4525-A4D5-A50D4E20D487}" dt="2026-07-29T04:32:12.401" v="1623" actId="22"/>
         <pc:sldMkLst>
           <pc:docMk/>
           <pc:sldMk cId="727656364" sldId="272"/>
@@ -342,6 +343,14 @@
             <pc:docMk/>
             <pc:sldMk cId="727656364" sldId="272"/>
             <ac:spMk id="3" creationId="{502800D6-974F-2F17-A52E-0A306D35DF0C}"/>
+          </ac:spMkLst>
+        </pc:spChg>
+        <pc:spChg chg="add del">
+          <ac:chgData name="Dmitriy Ratushny" userId="08050032e8047aee" providerId="LiveId" clId="{78EB1A6D-D3A9-4525-A4D5-A50D4E20D487}" dt="2026-07-29T04:32:12.401" v="1623" actId="22"/>
+          <ac:spMkLst>
+            <pc:docMk/>
+            <pc:sldMk cId="727656364" sldId="272"/>
+            <ac:spMk id="4" creationId="{ADD1133A-118A-E00D-C649-50786DE58214}"/>
           </ac:spMkLst>
         </pc:spChg>
         <pc:spChg chg="add">
@@ -360,6 +369,37 @@
             <ac:spMk id="7" creationId="{9F1B9989-6A7C-C50E-2B6A-E012B6E3A475}"/>
           </ac:spMkLst>
         </pc:spChg>
+      </pc:sldChg>
+      <pc:sldChg chg="modSp add mod">
+        <pc:chgData name="Dmitriy Ratushny" userId="08050032e8047aee" providerId="LiveId" clId="{78EB1A6D-D3A9-4525-A4D5-A50D4E20D487}" dt="2026-07-29T04:34:24.604" v="1631" actId="1076"/>
+        <pc:sldMkLst>
+          <pc:docMk/>
+          <pc:sldMk cId="0" sldId="273"/>
+        </pc:sldMkLst>
+        <pc:spChg chg="mod">
+          <ac:chgData name="Dmitriy Ratushny" userId="08050032e8047aee" providerId="LiveId" clId="{78EB1A6D-D3A9-4525-A4D5-A50D4E20D487}" dt="2026-07-29T04:34:16.235" v="1629"/>
+          <ac:spMkLst>
+            <pc:docMk/>
+            <pc:sldMk cId="0" sldId="273"/>
+            <ac:spMk id="2" creationId="{00000000-0000-0000-0000-000000000000}"/>
+          </ac:spMkLst>
+        </pc:spChg>
+        <pc:spChg chg="mod">
+          <ac:chgData name="Dmitriy Ratushny" userId="08050032e8047aee" providerId="LiveId" clId="{78EB1A6D-D3A9-4525-A4D5-A50D4E20D487}" dt="2026-07-29T04:34:21.479" v="1630" actId="1076"/>
+          <ac:spMkLst>
+            <pc:docMk/>
+            <pc:sldMk cId="0" sldId="273"/>
+            <ac:spMk id="3" creationId="{00000000-0000-0000-0000-000000000000}"/>
+          </ac:spMkLst>
+        </pc:spChg>
+        <pc:picChg chg="mod">
+          <ac:chgData name="Dmitriy Ratushny" userId="08050032e8047aee" providerId="LiveId" clId="{78EB1A6D-D3A9-4525-A4D5-A50D4E20D487}" dt="2026-07-29T04:34:24.604" v="1631" actId="1076"/>
+          <ac:picMkLst>
+            <pc:docMk/>
+            <pc:sldMk cId="0" sldId="273"/>
+            <ac:picMk id="4" creationId="{00000000-0000-0000-0000-000000000000}"/>
+          </ac:picMkLst>
+        </pc:picChg>
       </pc:sldChg>
     </pc:docChg>
   </pc:docChgLst>
@@ -727,6 +767,100 @@
           </p:nvPr>
         </p:nvSpPr>
         <p:spPr/>
+      </p:sp>
+      <p:sp>
+        <p:nvSpPr>
+          <p:cNvPr id="3" name="Notes Placeholder 2"/>
+          <p:cNvSpPr>
+            <a:spLocks noGrp="1"/>
+          </p:cNvSpPr>
+          <p:nvPr>
+            <p:ph type="body" sz="quarter" idx="3"/>
+          </p:nvPr>
+        </p:nvSpPr>
+        <p:spPr/>
+        <p:txBody>
+          <a:bodyPr/>
+          <a:lstStyle/>
+          <a:p>
+            <a:r>
+              <a:t>The slide to open with if anyone asks what the data looks like.</a:t>
+            </a:r>
+          </a:p>
+          <a:p>
+            <a:endParaRPr/>
+          </a:p>
+          <a:p>
+            <a:r>
+              <a:t>Read the arrows, not the boxes. Referential integrity is perfect: every subscription_id in feature_usage resolves, every account_id in support_tickets and churn_events resolves, and no contract predates its account. A schema check passes cleanly, which is why a cleaning pipeline does not catch this — and the other published analysis of this dataset ran one and reported nothing.</a:t>
+            </a:r>
+          </a:p>
+          <a:p>
+            <a:endParaRPr/>
+          </a:p>
+          <a:p>
+            <a:r>
+              <a:t>What fails is temporal integrity, and nothing in a data dictionary tests it. 13,198 of 25,000 usage rows and 1,077 of 2,000 tickets are dated before their customer signed up. Correlation between event date and signup date is 0.002 and 0.016. Every behavioural feature in the model is built from those two tables.</a:t>
+            </a:r>
+          </a:p>
+          <a:p>
+            <a:endParaRPr/>
+          </a:p>
+          <a:p>
+            <a:r>
+              <a:t>The left column of the read-out is every check a reviewer would ask for. The right column is why passing them settles nothing.</a:t>
+            </a:r>
+          </a:p>
+        </p:txBody>
+      </p:sp>
+      <p:sp>
+        <p:nvSpPr>
+          <p:cNvPr id="4" name="Slide Number Placeholder 3"/>
+          <p:cNvSpPr>
+            <a:spLocks noGrp="1"/>
+          </p:cNvSpPr>
+          <p:nvPr>
+            <p:ph type="sldNum" sz="quarter" idx="5"/>
+          </p:nvPr>
+        </p:nvSpPr>
+        <p:spPr/>
+      </p:sp>
+    </p:spTree>
+  </p:cSld>
+  <p:clrMapOvr>
+    <a:masterClrMapping/>
+  </p:clrMapOvr>
+</p:notes>
+</file>
+
+<file path=ppt/notesSlides/notesSlide4.xml><?xml version="1.0" encoding="utf-8"?>
+<p:notes xmlns:a="http://schemas.openxmlformats.org/drawingml/2006/main" xmlns:r="http://schemas.openxmlformats.org/officeDocument/2006/relationships" xmlns:p="http://schemas.openxmlformats.org/presentationml/2006/main">
+  <p:cSld>
+    <p:spTree>
+      <p:nvGrpSpPr>
+        <p:cNvPr id="1" name=""/>
+        <p:cNvGrpSpPr/>
+        <p:nvPr/>
+      </p:nvGrpSpPr>
+      <p:grpSpPr>
+        <a:xfrm>
+          <a:off x="0" y="0"/>
+          <a:ext cx="0" cy="0"/>
+          <a:chOff x="0" y="0"/>
+          <a:chExt cx="0" cy="0"/>
+        </a:xfrm>
+      </p:grpSpPr>
+      <p:sp>
+        <p:nvSpPr>
+          <p:cNvPr id="2" name="Slide Image Placeholder 1"/>
+          <p:cNvSpPr>
+            <a:spLocks noGrp="1" noRot="1" noChangeAspect="1"/>
+          </p:cNvSpPr>
+          <p:nvPr>
+            <p:ph type="sldImg" idx="2"/>
+          </p:nvPr>
+        </p:nvSpPr>
+        <p:spPr/>
         <p:txBody>
           <a:bodyPr/>
           <a:lstStyle/>
@@ -1002,7 +1136,7 @@
           <a:p>
             <a:fld id="{5BCAD085-E8A6-8845-BD4E-CB4CCA059FC4}" type="datetimeFigureOut">
               <a:rPr lang="en-US" smtClean="0"/>
-              <a:t>7/28/2026</a:t>
+              <a:t>7/29/2026</a:t>
             </a:fld>
             <a:endParaRPr lang="en-US"/>
           </a:p>
@@ -1170,7 +1304,7 @@
           <a:p>
             <a:fld id="{5BCAD085-E8A6-8845-BD4E-CB4CCA059FC4}" type="datetimeFigureOut">
               <a:rPr lang="en-US" smtClean="0"/>
-              <a:t>7/28/2026</a:t>
+              <a:t>7/29/2026</a:t>
             </a:fld>
             <a:endParaRPr lang="en-US"/>
           </a:p>
@@ -1348,7 +1482,7 @@
           <a:p>
             <a:fld id="{5BCAD085-E8A6-8845-BD4E-CB4CCA059FC4}" type="datetimeFigureOut">
               <a:rPr lang="en-US" smtClean="0"/>
-              <a:t>7/28/2026</a:t>
+              <a:t>7/29/2026</a:t>
             </a:fld>
             <a:endParaRPr lang="en-US"/>
           </a:p>
@@ -1516,7 +1650,7 @@
           <a:p>
             <a:fld id="{5BCAD085-E8A6-8845-BD4E-CB4CCA059FC4}" type="datetimeFigureOut">
               <a:rPr lang="en-US" smtClean="0"/>
-              <a:t>7/28/2026</a:t>
+              <a:t>7/29/2026</a:t>
             </a:fld>
             <a:endParaRPr lang="en-US"/>
           </a:p>
@@ -1761,7 +1895,7 @@
           <a:p>
             <a:fld id="{5BCAD085-E8A6-8845-BD4E-CB4CCA059FC4}" type="datetimeFigureOut">
               <a:rPr lang="en-US" smtClean="0"/>
-              <a:t>7/28/2026</a:t>
+              <a:t>7/29/2026</a:t>
             </a:fld>
             <a:endParaRPr lang="en-US"/>
           </a:p>
@@ -2046,7 +2180,7 @@
           <a:p>
             <a:fld id="{5BCAD085-E8A6-8845-BD4E-CB4CCA059FC4}" type="datetimeFigureOut">
               <a:rPr lang="en-US" smtClean="0"/>
-              <a:t>7/28/2026</a:t>
+              <a:t>7/29/2026</a:t>
             </a:fld>
             <a:endParaRPr lang="en-US"/>
           </a:p>
@@ -2465,7 +2599,7 @@
           <a:p>
             <a:fld id="{5BCAD085-E8A6-8845-BD4E-CB4CCA059FC4}" type="datetimeFigureOut">
               <a:rPr lang="en-US" smtClean="0"/>
-              <a:t>7/28/2026</a:t>
+              <a:t>7/29/2026</a:t>
             </a:fld>
             <a:endParaRPr lang="en-US"/>
           </a:p>
@@ -2582,7 +2716,7 @@
           <a:p>
             <a:fld id="{5BCAD085-E8A6-8845-BD4E-CB4CCA059FC4}" type="datetimeFigureOut">
               <a:rPr lang="en-US" smtClean="0"/>
-              <a:t>7/28/2026</a:t>
+              <a:t>7/29/2026</a:t>
             </a:fld>
             <a:endParaRPr lang="en-US"/>
           </a:p>
@@ -2677,7 +2811,7 @@
           <a:p>
             <a:fld id="{5BCAD085-E8A6-8845-BD4E-CB4CCA059FC4}" type="datetimeFigureOut">
               <a:rPr lang="en-US" smtClean="0"/>
-              <a:t>7/28/2026</a:t>
+              <a:t>7/29/2026</a:t>
             </a:fld>
             <a:endParaRPr lang="en-US"/>
           </a:p>
@@ -2952,7 +3086,7 @@
           <a:p>
             <a:fld id="{5BCAD085-E8A6-8845-BD4E-CB4CCA059FC4}" type="datetimeFigureOut">
               <a:rPr lang="en-US" smtClean="0"/>
-              <a:t>7/28/2026</a:t>
+              <a:t>7/29/2026</a:t>
             </a:fld>
             <a:endParaRPr lang="en-US"/>
           </a:p>
@@ -3204,7 +3338,7 @@
           <a:p>
             <a:fld id="{5BCAD085-E8A6-8845-BD4E-CB4CCA059FC4}" type="datetimeFigureOut">
               <a:rPr lang="en-US" smtClean="0"/>
-              <a:t>7/28/2026</a:t>
+              <a:t>7/29/2026</a:t>
             </a:fld>
             <a:endParaRPr lang="en-US"/>
           </a:p>
@@ -3415,7 +3549,7 @@
           <a:p>
             <a:fld id="{5BCAD085-E8A6-8845-BD4E-CB4CCA059FC4}" type="datetimeFigureOut">
               <a:rPr lang="en-US" smtClean="0"/>
-              <a:t>7/28/2026</a:t>
+              <a:t>7/29/2026</a:t>
             </a:fld>
             <a:endParaRPr lang="en-US"/>
           </a:p>
@@ -3945,11 +4079,11 @@
             <a:r>
               <a:rPr sz="2800" b="1" i="0">
                 <a:solidFill>
-                  <a:srgbClr val="1A1A1A"/>
-                </a:solidFill>
-                <a:latin typeface="Calibri"/>
-              </a:rPr>
-              <a:t>Class imbalance, and what leakage is worth</a:t>
+                  <a:srgbClr val="B02E2E"/>
+                </a:solidFill>
+                <a:latin typeface="Calibri"/>
+              </a:rPr>
+              <a:t>How it performs, and why the number is low</a:t>
             </a:r>
           </a:p>
         </p:txBody>
@@ -4001,7 +4135,7 @@
       </p:sp>
       <p:pic>
         <p:nvPicPr>
-          <p:cNvPr id="4" name="Picture 3" descr="06_leakage_effect.png"/>
+          <p:cNvPr id="4" name="Picture 3" descr="09_selection_null.png"/>
           <p:cNvPicPr>
             <a:picLocks noChangeAspect="1"/>
           </p:cNvPicPr>
@@ -4015,8 +4149,8 @@
         </p:blipFill>
         <p:spPr>
           <a:xfrm>
-            <a:off x="6446520" y="1737360"/>
-            <a:ext cx="5533595" cy="3063240"/>
+            <a:off x="6812280" y="1783080"/>
+            <a:ext cx="4212139" cy="2331720"/>
           </a:xfrm>
           <a:prstGeom prst="rect">
             <a:avLst/>
@@ -4031,8 +4165,8 @@
         </p:nvSpPr>
         <p:spPr>
           <a:xfrm>
-            <a:off x="685800" y="1737360"/>
-            <a:ext cx="5486400" cy="4572000"/>
+            <a:off x="685800" y="1783080"/>
+            <a:ext cx="5760720" cy="4572000"/>
           </a:xfrm>
           <a:prstGeom prst="rect">
             <a:avLst/>
@@ -4047,120 +4181,207 @@
           <a:p>
             <a:pPr>
               <a:spcAft>
-                <a:spcPts val="600"/>
-              </a:spcAft>
-            </a:pPr>
-            <a:r>
-              <a:rPr sz="1350" b="1" i="0">
+                <a:spcPts val="500"/>
+              </a:spcAft>
+            </a:pPr>
+            <a:r>
+              <a:rPr sz="1300" b="0" i="0">
+                <a:solidFill>
+                  <a:srgbClr val="5A6270"/>
+                </a:solidFill>
+                <a:latin typeface="Calibri"/>
+              </a:rPr>
+              <a:t>Best single model, taken at face value:  AUC 0.583</a:t>
+            </a:r>
+          </a:p>
+          <a:p>
+            <a:pPr>
+              <a:spcAft>
+                <a:spcPts val="500"/>
+              </a:spcAft>
+            </a:pPr>
+            <a:r>
+              <a:rPr sz="1300" b="1" i="0">
                 <a:solidFill>
                   <a:srgbClr val="1A1A1A"/>
                 </a:solidFill>
                 <a:latin typeface="Calibri"/>
               </a:rPr>
-              <a:t>Class imbalance</a:t>
+              <a:t>The honest score:  AUC 0.534, give or take 0.016</a:t>
+            </a:r>
+          </a:p>
+          <a:p>
+            <a:pPr>
+              <a:spcAft>
+                <a:spcPts val="500"/>
+              </a:spcAft>
+            </a:pPr>
+            <a:r>
+              <a:rPr sz="1300" b="0" i="0">
+                <a:solidFill>
+                  <a:srgbClr val="5A6270"/>
+                </a:solidFill>
+                <a:latin typeface="Calibri"/>
+              </a:rPr>
+              <a:t>Guessing:  AUC 0.500</a:t>
+            </a:r>
+          </a:p>
+          <a:p>
+            <a:pPr>
+              <a:spcAft>
+                <a:spcPts val="500"/>
+              </a:spcAft>
+            </a:pPr>
+            <a:r>
+              <a:rPr sz="600" b="0" i="0">
+                <a:solidFill>
+                  <a:srgbClr val="1A1A1A"/>
+                </a:solidFill>
+                <a:latin typeface="Calibri"/>
+              </a:rPr>
+              <a:t> </a:t>
+            </a:r>
+          </a:p>
+          <a:p>
+            <a:pPr>
+              <a:spcAft>
+                <a:spcPts val="500"/>
+              </a:spcAft>
+            </a:pPr>
+            <a:r>
+              <a:rPr sz="1300" b="1" i="0">
+                <a:solidFill>
+                  <a:srgbClr val="B02E2E"/>
+                </a:solidFill>
+                <a:latin typeface="Calibri"/>
+              </a:rPr>
+              <a:t>Picking the best of ten models is itself a form of fitting.</a:t>
             </a:r>
           </a:p>
           <a:p>
             <a:pPr lvl="1">
               <a:spcAft>
-                <a:spcPts val="600"/>
-              </a:spcAft>
-            </a:pPr>
-            <a:r>
-              <a:rPr sz="1150" b="0" i="0">
+                <a:spcPts val="500"/>
+              </a:spcAft>
+            </a:pPr>
+            <a:r>
+              <a:rPr sz="1100" b="0" i="0">
                 <a:solidFill>
                   <a:srgbClr val="5A6270"/>
                 </a:solidFill>
                 <a:latin typeface="Calibri"/>
               </a:rPr>
-              <a:t>31% of customers left, so the classes are uneven but not badly so. I weight the rare class rather than inventing synthetic customers: with 54 real examples, synthetic ones are copies of copies and they flatter the score.</a:t>
+              <a:t>Measure that properly and 0.049 of AUC disappears — most of what looked like signal. The chart is why: run the same ten-model search against shuffled labels and the whole distribution slides right, past our result.</a:t>
             </a:r>
           </a:p>
           <a:p>
             <a:pPr lvl="1">
               <a:spcAft>
-                <a:spcPts val="600"/>
-              </a:spcAft>
-            </a:pPr>
-            <a:r>
-              <a:rPr sz="1150" b="0" i="0">
+                <a:spcPts val="500"/>
+              </a:spcAft>
+            </a:pPr>
+            <a:r>
+              <a:rPr sz="1100" b="0" i="0">
                 <a:solidFill>
                   <a:srgbClr val="5A6270"/>
                 </a:solidFill>
                 <a:latin typeface="Calibri"/>
               </a:rPr>
-              <a:t>I set the cut-off to favour catching leavers, because missing one costs far more than a wasted phone call. That gives 75% of leavers caught, and 1 in 3 of the flagged customers actually leaving.</a:t>
+              <a:t>Across 25 rounds, eight of the ten models won at least once. A genuinely better model wins nearly every time.</a:t>
+            </a:r>
+          </a:p>
+        </p:txBody>
+      </p:sp>
+      <p:sp>
+        <p:nvSpPr>
+          <p:cNvPr id="6" name="TextBox 5"/>
+          <p:cNvSpPr txBox="1"/>
+          <p:nvPr/>
+        </p:nvSpPr>
+        <p:spPr>
+          <a:xfrm>
+            <a:off x="685800" y="4315968"/>
+            <a:ext cx="10820095" cy="4572000"/>
+          </a:xfrm>
+          <a:prstGeom prst="rect">
+            <a:avLst/>
+          </a:prstGeom>
+          <a:noFill/>
+        </p:spPr>
+        <p:txBody>
+          <a:bodyPr wrap="square">
+            <a:spAutoFit/>
+          </a:bodyPr>
+          <a:lstStyle/>
+          <a:p>
+            <a:pPr>
+              <a:spcAft>
+                <a:spcPts val="500"/>
+              </a:spcAft>
+            </a:pPr>
+            <a:r>
+              <a:rPr sz="1300" b="1" i="0">
+                <a:solidFill>
+                  <a:srgbClr val="1A1A1A"/>
+                </a:solidFill>
+                <a:latin typeface="Calibri"/>
+              </a:rPr>
+              <a:t>Why the score is low. Each cause is measured, not guessed at.</a:t>
             </a:r>
           </a:p>
           <a:p>
             <a:pPr lvl="1">
               <a:spcAft>
-                <a:spcPts val="600"/>
-              </a:spcAft>
-            </a:pPr>
-            <a:r>
-              <a:rPr sz="1150" b="0" i="0">
+                <a:spcPts val="500"/>
+              </a:spcAft>
+            </a:pPr>
+            <a:r>
+              <a:rPr sz="1100" b="0" i="0">
                 <a:solidFill>
                   <a:srgbClr val="5A6270"/>
                 </a:solidFill>
                 <a:latin typeface="Calibri"/>
               </a:rPr>
-              <a:t>I report ROC-AUC because its baseline stays 0.50 at any class balance, which keeps the twelve horizon cells comparable when their churn rates run 11% to 45%. Precision-recall and F1 agree.</a:t>
-            </a:r>
-          </a:p>
-          <a:p>
-            <a:pPr>
-              <a:spcAft>
-                <a:spcPts val="600"/>
-              </a:spcAft>
-            </a:pPr>
-            <a:r>
-              <a:rPr sz="600" b="0" i="0">
-                <a:solidFill>
-                  <a:srgbClr val="1A1A1A"/>
-                </a:solidFill>
-                <a:latin typeface="Calibri"/>
-              </a:rPr>
-              <a:t> </a:t>
-            </a:r>
-          </a:p>
-          <a:p>
-            <a:pPr>
-              <a:spcAft>
-                <a:spcPts val="600"/>
-              </a:spcAft>
-            </a:pPr>
-            <a:r>
-              <a:rPr sz="1350" b="1" i="0">
-                <a:solidFill>
-                  <a:srgbClr val="B02E2E"/>
-                </a:solidFill>
-                <a:latin typeface="Calibri"/>
-              </a:rPr>
-              <a:t>I do not rely on reading the code to catch leakage.</a:t>
+              <a:t>The inputs hold nothing. Usage and ticket dates are scattered at random across the two years and match their own customer's signup date at r = 0.002 and r = 0.014. Inside those tables, priority does not predict how fast we answered and plan does not predict how much people used.</a:t>
             </a:r>
           </a:p>
           <a:p>
             <a:pPr lvl="1">
               <a:spcAft>
-                <a:spcPts val="600"/>
-              </a:spcAft>
-            </a:pPr>
-            <a:r>
-              <a:rPr sz="1150" b="0" i="0">
+                <a:spcPts val="500"/>
+              </a:spcAft>
+            </a:pPr>
+            <a:r>
+              <a:rPr sz="1100" b="0" i="0">
                 <a:solidFill>
                   <a:srgbClr val="5A6270"/>
                 </a:solidFill>
                 <a:latin typeface="Calibri"/>
               </a:rPr>
-              <a:t>Automatic checks run before any result is reported and block it if anything fails. They look for dates after the cutoff, banned columns by name, and any single feature that predicts too well.</a:t>
-            </a:r>
-          </a:p>
-        </p:txBody>
-      </p:sp>
-      <p:sp>
-        <p:nvSpPr>
-          <p:cNvPr id="6" name="TextBox 5"/>
+              <a:t>The target is a random date — a coin toss between the day the customer joined and the last day of the file. Slide 11 is that test. Subscriptions is the one table with real rules, and none of it relates to churn.</a:t>
+            </a:r>
+          </a:p>
+          <a:p>
+            <a:pPr lvl="1">
+              <a:spcAft>
+                <a:spcPts val="500"/>
+              </a:spcAft>
+            </a:pPr>
+            <a:r>
+              <a:rPr sz="1100" b="0" i="0">
+                <a:solidFill>
+                  <a:srgbClr val="5A6270"/>
+                </a:solidFill>
+                <a:latin typeface="Calibri"/>
+              </a:rPr>
+              <a:t>Sample size is real but secondary: 54 churners against 73 features. It is not leakage, not the feature build, and not tuning. I checked all three.</a:t>
+            </a:r>
+          </a:p>
+        </p:txBody>
+      </p:sp>
+      <p:sp>
+        <p:nvSpPr>
+          <p:cNvPr id="7" name="TextBox 6"/>
           <p:cNvSpPr txBox="1"/>
           <p:nvPr/>
         </p:nvSpPr>
@@ -4187,7 +4408,7 @@
                 </a:solidFill>
                 <a:latin typeface="Calibri"/>
               </a:rPr>
-              <a:t>The chart is why those checks earn their place. Columns that only exist after a customer leaves are worth 0.37 of extra AUC — they push the model to 0.79, which looks like a good model rather than a broken one. A pipeline that lets the future in scores 0.42, below guessing. Both failures are invisible in the score alone.</a:t>
+              <a:t>Scores are ROC-AUC: 0.50 is guessing, 1.00 is perfect. I confirmed the pipeline works by planting targets of known strength — a strong one scores AUC 0.965, a deliberately weak one 0.584, a meaningless one 0.494. The method works. AUC 0.534 is the right answer to the question this data can be asked.</a:t>
             </a:r>
           </a:p>
         </p:txBody>
@@ -4258,11 +4479,11 @@
             <a:r>
               <a:rPr sz="2800" b="1" i="0">
                 <a:solidFill>
-                  <a:srgbClr val="2E5F8A"/>
-                </a:solidFill>
-                <a:latin typeface="Calibri"/>
-              </a:rPr>
-              <a:t>Interpretability, and how it can mislead you</a:t>
+                  <a:srgbClr val="1A1A1A"/>
+                </a:solidFill>
+                <a:latin typeface="Calibri"/>
+              </a:rPr>
+              <a:t>Class imbalance, and what leakage is worth</a:t>
             </a:r>
           </a:p>
         </p:txBody>
@@ -4314,7 +4535,7 @@
       </p:sp>
       <p:pic>
         <p:nvPicPr>
-          <p:cNvPr id="4" name="Picture 3" descr="13_shap_real_vs_shuffled.png"/>
+          <p:cNvPr id="4" name="Picture 3" descr="06_leakage_effect.png"/>
           <p:cNvPicPr>
             <a:picLocks noChangeAspect="1"/>
           </p:cNvPicPr>
@@ -4328,8 +4549,8 @@
         </p:blipFill>
         <p:spPr>
           <a:xfrm>
-            <a:off x="2260186" y="1572768"/>
-            <a:ext cx="7671323" cy="2514600"/>
+            <a:off x="6446520" y="1737360"/>
+            <a:ext cx="5533595" cy="3063240"/>
           </a:xfrm>
           <a:prstGeom prst="rect">
             <a:avLst/>
@@ -4344,8 +4565,8 @@
         </p:nvSpPr>
         <p:spPr>
           <a:xfrm>
-            <a:off x="685800" y="4315968"/>
-            <a:ext cx="10820095" cy="4572000"/>
+            <a:off x="685800" y="1737360"/>
+            <a:ext cx="5486400" cy="4572000"/>
           </a:xfrm>
           <a:prstGeom prst="rect">
             <a:avLst/>
@@ -4360,49 +4581,113 @@
           <a:p>
             <a:pPr>
               <a:spcAft>
-                <a:spcPts val="400"/>
-              </a:spcAft>
-            </a:pPr>
-            <a:r>
-              <a:rPr sz="1250" b="1" i="0">
+                <a:spcPts val="600"/>
+              </a:spcAft>
+            </a:pPr>
+            <a:r>
+              <a:rPr sz="1350" b="1" i="0">
+                <a:solidFill>
+                  <a:srgbClr val="1A1A1A"/>
+                </a:solidFill>
+                <a:latin typeface="Calibri"/>
+              </a:rPr>
+              <a:t>Class imbalance</a:t>
+            </a:r>
+          </a:p>
+          <a:p>
+            <a:pPr lvl="1">
+              <a:spcAft>
+                <a:spcPts val="600"/>
+              </a:spcAft>
+            </a:pPr>
+            <a:r>
+              <a:rPr sz="1150" b="0" i="0">
+                <a:solidFill>
+                  <a:srgbClr val="5A6270"/>
+                </a:solidFill>
+                <a:latin typeface="Calibri"/>
+              </a:rPr>
+              <a:t>31% of customers left, so the classes are uneven but not badly so. I weight the rare class rather than inventing synthetic customers: with 54 real examples, synthetic ones are copies of copies and they flatter the score.</a:t>
+            </a:r>
+          </a:p>
+          <a:p>
+            <a:pPr lvl="1">
+              <a:spcAft>
+                <a:spcPts val="600"/>
+              </a:spcAft>
+            </a:pPr>
+            <a:r>
+              <a:rPr sz="1150" b="0" i="0">
+                <a:solidFill>
+                  <a:srgbClr val="5A6270"/>
+                </a:solidFill>
+                <a:latin typeface="Calibri"/>
+              </a:rPr>
+              <a:t>I set the cut-off to favour catching leavers, because missing one costs far more than a wasted phone call. That gives 75% of leavers caught, and 1 in 3 of the flagged customers actually leaving.</a:t>
+            </a:r>
+          </a:p>
+          <a:p>
+            <a:pPr lvl="1">
+              <a:spcAft>
+                <a:spcPts val="600"/>
+              </a:spcAft>
+            </a:pPr>
+            <a:r>
+              <a:rPr sz="1150" b="0" i="0">
+                <a:solidFill>
+                  <a:srgbClr val="5A6270"/>
+                </a:solidFill>
+                <a:latin typeface="Calibri"/>
+              </a:rPr>
+              <a:t>I report ROC-AUC because its baseline stays 0.50 at any class balance, which keeps the twelve horizon cells comparable when their churn rates run 11% to 45%. Precision-recall and F1 agree.</a:t>
+            </a:r>
+          </a:p>
+          <a:p>
+            <a:pPr>
+              <a:spcAft>
+                <a:spcPts val="600"/>
+              </a:spcAft>
+            </a:pPr>
+            <a:r>
+              <a:rPr sz="600" b="0" i="0">
+                <a:solidFill>
+                  <a:srgbClr val="1A1A1A"/>
+                </a:solidFill>
+                <a:latin typeface="Calibri"/>
+              </a:rPr>
+              <a:t> </a:t>
+            </a:r>
+          </a:p>
+          <a:p>
+            <a:pPr>
+              <a:spcAft>
+                <a:spcPts val="600"/>
+              </a:spcAft>
+            </a:pPr>
+            <a:r>
+              <a:rPr sz="1350" b="1" i="0">
                 <a:solidFill>
                   <a:srgbClr val="B02E2E"/>
                 </a:solidFill>
                 <a:latin typeface="Calibri"/>
               </a:rPr>
-              <a:t>These are the same chart. The right-hand one is built from labels I shuffled at random — and it is more confident about its winner than the real one is.</a:t>
-            </a:r>
-          </a:p>
-          <a:p>
-            <a:pPr>
-              <a:spcAft>
-                <a:spcPts val="400"/>
-              </a:spcAft>
-            </a:pPr>
-            <a:r>
-              <a:rPr sz="1250" b="1" i="0">
-                <a:solidFill>
-                  <a:srgbClr val="1A1A1A"/>
-                </a:solidFill>
-                <a:latin typeface="Calibri"/>
-              </a:rPr>
-              <a:t>SHAP will always return a clean, ordered, plausible ranking. It has no way to tell you it has nothing to say, which is why every attribution method here is paired with a random baseline before it is believed.</a:t>
-            </a:r>
-          </a:p>
-          <a:p>
-            <a:pPr>
-              <a:spcAft>
-                <a:spcPts val="400"/>
-              </a:spcAft>
-            </a:pPr>
-            <a:r>
-              <a:rPr sz="1250" b="0" i="0">
-                <a:solidFill>
-                  <a:srgbClr val="1A1A1A"/>
-                </a:solidFill>
-                <a:latin typeface="Calibri"/>
-              </a:rPr>
-              <a:t>The numbers underneath: the top feature beats random labels only 3 times in 4 (p = 0.24). Twelve different features take first place across 25 reruns. Permutation importance on held-out data is beaten by noise outright.</a:t>
+              <a:t>I do not rely on reading the code to catch leakage.</a:t>
+            </a:r>
+          </a:p>
+          <a:p>
+            <a:pPr lvl="1">
+              <a:spcAft>
+                <a:spcPts val="600"/>
+              </a:spcAft>
+            </a:pPr>
+            <a:r>
+              <a:rPr sz="1150" b="0" i="0">
+                <a:solidFill>
+                  <a:srgbClr val="5A6270"/>
+                </a:solidFill>
+                <a:latin typeface="Calibri"/>
+              </a:rPr>
+              <a:t>Automatic checks run before any result is reported and block it if anything fails. They look for dates after the cutoff, banned columns by name, and any single feature that predicts too well.</a:t>
             </a:r>
           </a:p>
         </p:txBody>
@@ -4432,11 +4717,11 @@
             <a:r>
               <a:rPr sz="1150" b="0" i="1">
                 <a:solidFill>
-                  <a:srgbClr val="5A6270"/>
-                </a:solidFill>
-                <a:latin typeface="Calibri"/>
-              </a:rPr>
-              <a:t>Read without the right-hand panel, the left one says support load per seat drives churn, then contract size, then tenure. All three are plausible. That is exactly what makes it dangerous.</a:t>
+                  <a:srgbClr val="1A1A1A"/>
+                </a:solidFill>
+                <a:latin typeface="Calibri"/>
+              </a:rPr>
+              <a:t>The chart is why those checks earn their place. Columns that only exist after a customer leaves are worth 0.37 of extra AUC — they push the model to 0.79, which looks like a good model rather than a broken one. A pipeline that lets the future in scores 0.42, below guessing. Both failures are invisible in the score alone.</a:t>
             </a:r>
           </a:p>
         </p:txBody>
@@ -4495,7 +4780,7 @@
                 </a:solidFill>
                 <a:latin typeface="Calibri"/>
               </a:rPr>
-              <a:t>PART 4 · RECOMMENDATION 1</a:t>
+              <a:t>PART 3 · MODELLING</a:t>
             </a:r>
           </a:p>
           <a:p>
@@ -4507,11 +4792,11 @@
             <a:r>
               <a:rPr sz="2800" b="1" i="0">
                 <a:solidFill>
-                  <a:srgbClr val="B02E2E"/>
-                </a:solidFill>
-                <a:latin typeface="Calibri"/>
-              </a:rPr>
-              <a:t>Do not go looking for what changed in 2024</a:t>
+                  <a:srgbClr val="2E5F8A"/>
+                </a:solidFill>
+                <a:latin typeface="Calibri"/>
+              </a:rPr>
+              <a:t>Interpretability, and how it can mislead you</a:t>
             </a:r>
           </a:p>
         </p:txBody>
@@ -4563,22 +4848,22 @@
       </p:sp>
       <p:pic>
         <p:nvPicPr>
-          <p:cNvPr id="4" name="Picture 3" descr="16_generator_artefact.png"/>
+          <p:cNvPr id="4" name="Picture 3" descr="13_shap_real_vs_shuffled.png"/>
           <p:cNvPicPr>
             <a:picLocks noChangeAspect="1"/>
           </p:cNvPicPr>
           <p:nvPr/>
         </p:nvPicPr>
         <p:blipFill>
-          <a:blip r:embed="rId3"/>
+          <a:blip r:embed="rId2"/>
           <a:stretch>
             <a:fillRect/>
           </a:stretch>
         </p:blipFill>
         <p:spPr>
           <a:xfrm>
-            <a:off x="1906186" y="1554480"/>
-            <a:ext cx="8379323" cy="2788920"/>
+            <a:off x="2260186" y="1572768"/>
+            <a:ext cx="7671323" cy="2514600"/>
           </a:xfrm>
           <a:prstGeom prst="rect">
             <a:avLst/>
@@ -4593,7 +4878,7 @@
         </p:nvSpPr>
         <p:spPr>
           <a:xfrm>
-            <a:off x="685800" y="4572000"/>
+            <a:off x="685800" y="4315968"/>
             <a:ext cx="10820095" cy="4572000"/>
           </a:xfrm>
           <a:prstGeom prst="rect">
@@ -4615,11 +4900,27 @@
             <a:r>
               <a:rPr sz="1250" b="1" i="0">
                 <a:solidFill>
+                  <a:srgbClr val="B02E2E"/>
+                </a:solidFill>
+                <a:latin typeface="Calibri"/>
+              </a:rPr>
+              <a:t>These are the same chart. The right-hand one is built from labels I shuffled at random — and it is more confident about its winner than the real one is.</a:t>
+            </a:r>
+          </a:p>
+          <a:p>
+            <a:pPr>
+              <a:spcAft>
+                <a:spcPts val="400"/>
+              </a:spcAft>
+            </a:pPr>
+            <a:r>
+              <a:rPr sz="1250" b="1" i="0">
+                <a:solidFill>
                   <a:srgbClr val="1A1A1A"/>
                 </a:solidFill>
                 <a:latin typeface="Calibri"/>
               </a:rPr>
-              <a:t>Churn looks like it is accelerating. About 5 in every 100 customers left each month in 2023, rising to 22 in 100 by December 2024 — a 2.8x rise per year, p = 2e-16. It was by far the strongest number in this study.</a:t>
+              <a:t>SHAP will always return a clean, ordered, plausible ranking. It has no way to tell you it has nothing to say, which is why every attribution method here is paired with a random baseline before it is believed.</a:t>
             </a:r>
           </a:p>
           <a:p>
@@ -4629,29 +4930,13 @@
               </a:spcAft>
             </a:pPr>
             <a:r>
-              <a:rPr sz="1250" b="1" i="0">
-                <a:solidFill>
-                  <a:srgbClr val="B02E2E"/>
-                </a:solidFill>
-                <a:latin typeface="Calibri"/>
-              </a:rPr>
-              <a:t>It is not a fact about customers. Every churn date in this file is a random date between the day the customer joined and the last day of the extract. A random date has nowhere to go but the end of the file, so the rate climbs on its own, with nothing happening in the business.</a:t>
-            </a:r>
-          </a:p>
-          <a:p>
-            <a:pPr>
-              <a:spcAft>
-                <a:spcPts val="400"/>
-              </a:spcAft>
-            </a:pPr>
-            <a:r>
-              <a:rPr sz="1250" b="1" i="0">
+              <a:rPr sz="1250" b="0" i="0">
                 <a:solidFill>
                   <a:srgbClr val="1A1A1A"/>
                 </a:solidFill>
                 <a:latin typeface="Calibri"/>
               </a:rPr>
-              <a:t>Rebuilding the data from that one rule gives the same answer: a 2.78x rise per year, all 24 months inside the range chance produces, and our result sitting at the 52nd percentile of pure noise. So there is nothing here to investigate, and that is the recommendation.</a:t>
+              <a:t>The numbers underneath: the top feature beats random labels only 3 times in 4 (p = 0.24). Twelve different features take first place across 25 reruns. Permutation importance on held-out data is beaten by noise outright.</a:t>
             </a:r>
           </a:p>
         </p:txBody>
@@ -4681,11 +4966,11 @@
             <a:r>
               <a:rPr sz="1150" b="0" i="1">
                 <a:solidFill>
-                  <a:srgbClr val="1A1A1A"/>
-                </a:solidFill>
-                <a:latin typeface="Calibri"/>
-              </a:rPr>
-              <a:t>The test that mattered was not "is this bigger than noise" — it was, comfortably. It was "would the file produce this on its own". On generated data that is the only null worth testing, and it is the one I had not run.</a:t>
+                  <a:srgbClr val="5A6270"/>
+                </a:solidFill>
+                <a:latin typeface="Calibri"/>
+              </a:rPr>
+              <a:t>Read without the right-hand panel, the left one says support load per seat drives churn, then contract size, then tenure. All three are plausible. That is exactly what makes it dangerous.</a:t>
             </a:r>
           </a:p>
         </p:txBody>
@@ -4744,7 +5029,7 @@
                 </a:solidFill>
                 <a:latin typeface="Calibri"/>
               </a:rPr>
-              <a:t>PART 4 · RECOMMENDATION 2</a:t>
+              <a:t>PART 4 · RECOMMENDATION 1</a:t>
             </a:r>
           </a:p>
           <a:p>
@@ -4760,7 +5045,7 @@
                 </a:solidFill>
                 <a:latin typeface="Calibri"/>
               </a:rPr>
-              <a:t>Do not build the onboarding programme</a:t>
+              <a:t>Do not go looking for what changed in 2024</a:t>
             </a:r>
           </a:p>
         </p:txBody>
@@ -4812,22 +5097,22 @@
       </p:sp>
       <p:pic>
         <p:nvPicPr>
-          <p:cNvPr id="4" name="Picture 3" descr="12_cohort_gradient.png"/>
+          <p:cNvPr id="4" name="Picture 3" descr="16_generator_artefact.png"/>
           <p:cNvPicPr>
             <a:picLocks noChangeAspect="1"/>
           </p:cNvPicPr>
           <p:nvPr/>
         </p:nvPicPr>
         <p:blipFill>
-          <a:blip r:embed="rId2"/>
+          <a:blip r:embed="rId3"/>
           <a:stretch>
             <a:fillRect/>
           </a:stretch>
         </p:blipFill>
         <p:spPr>
           <a:xfrm>
-            <a:off x="3590694" y="1627632"/>
-            <a:ext cx="5010307" cy="2743200"/>
+            <a:off x="1906186" y="1554480"/>
+            <a:ext cx="8379323" cy="2788920"/>
           </a:xfrm>
           <a:prstGeom prst="rect">
             <a:avLst/>
@@ -4842,7 +5127,7 @@
         </p:nvSpPr>
         <p:spPr>
           <a:xfrm>
-            <a:off x="685800" y="4526280"/>
+            <a:off x="685800" y="4572000"/>
             <a:ext cx="10820095" cy="4572000"/>
           </a:xfrm>
           <a:prstGeom prst="rect">
@@ -4868,7 +5153,7 @@
                 </a:solidFill>
                 <a:latin typeface="Calibri"/>
               </a:rPr>
-              <a:t>New customers look fragile, and risk looks like it falls with age. That is the usual reason to fund onboarding, and the evidence for it looks strong: 30-day survival drops from 0.98 for the 2023 intake to 0.59 for the 2024 one, measured at the same age.</a:t>
+              <a:t>Churn looks like it is accelerating. About 5 in every 100 customers left each month in 2023, rising to 22 in 100 by December 2024 — a 2.8x rise per year, p = 2e-16. It was by far the strongest number in this study.</a:t>
             </a:r>
           </a:p>
           <a:p>
@@ -4884,7 +5169,7 @@
                 </a:solidFill>
                 <a:latin typeface="Calibri"/>
               </a:rPr>
-              <a:t>It is the same random date. A customer who joined recently has a shorter window for that date to land in, so a larger share of their draws fall inside any 90-day question we ask. They look worse at every age without anything about them being worse.</a:t>
+              <a:t>It is not a fact about customers. Every churn date in this file is a random date between the day the customer joined and the last day of the extract. A random date has nowhere to go but the end of the file, so the rate climbs on its own, with nothing happening in the business.</a:t>
             </a:r>
           </a:p>
           <a:p>
@@ -4900,7 +5185,7 @@
                 </a:solidFill>
                 <a:latin typeface="Calibri"/>
               </a:rPr>
-              <a:t>Simulated data with no tenure effect in it at all clears the significance bar in 93% of runs, and does so more strongly than the real data does (p = 0.002 against 0.006). Within one joining month there is nothing left: a day-300 customer leaves as often as a day-10 one.</a:t>
+              <a:t>Rebuilding the data from that one rule gives the same answer: a 2.78x rise per year, all 24 months inside the range chance produces, and our result sitting at the 52nd percentile of pure noise. So there is nothing here to investigate, and that is the recommendation.</a:t>
             </a:r>
           </a:p>
         </p:txBody>
@@ -4930,11 +5215,11 @@
             <a:r>
               <a:rPr sz="1150" b="0" i="1">
                 <a:solidFill>
-                  <a:srgbClr val="5A6270"/>
-                </a:solidFill>
-                <a:latin typeface="Calibri"/>
-              </a:rPr>
-              <a:t>The recommendation does not change; the reason for it gets one layer deeper. This is the same finding as slide 11, applied to a spending decision instead of an investigation.</a:t>
+                  <a:srgbClr val="1A1A1A"/>
+                </a:solidFill>
+                <a:latin typeface="Calibri"/>
+              </a:rPr>
+              <a:t>The test that mattered was not "is this bigger than noise" — it was, comfortably. It was "would the file produce this on its own". On generated data that is the only null worth testing, and it is the one I had not run.</a:t>
             </a:r>
           </a:p>
         </p:txBody>
@@ -4993,7 +5278,7 @@
                 </a:solidFill>
                 <a:latin typeface="Calibri"/>
               </a:rPr>
-              <a:t>PART 4 · RECOMMENDATION 3</a:t>
+              <a:t>PART 4 · RECOMMENDATION 2</a:t>
             </a:r>
           </a:p>
           <a:p>
@@ -5005,11 +5290,11 @@
             <a:r>
               <a:rPr sz="2800" b="1" i="0">
                 <a:solidFill>
-                  <a:srgbClr val="1E7A4B"/>
-                </a:solidFill>
-                <a:latin typeface="Calibri"/>
-              </a:rPr>
-              <a:t>Call every at-risk customer, do not rank them</a:t>
+                  <a:srgbClr val="B02E2E"/>
+                </a:solidFill>
+                <a:latin typeface="Calibri"/>
+              </a:rPr>
+              <a:t>Do not build the onboarding programme</a:t>
             </a:r>
           </a:p>
         </p:txBody>
@@ -5061,7 +5346,7 @@
       </p:sp>
       <p:pic>
         <p:nvPicPr>
-          <p:cNvPr id="4" name="Picture 3" descr="15_breakeven_grid.png"/>
+          <p:cNvPr id="4" name="Picture 3" descr="12_cohort_gradient.png"/>
           <p:cNvPicPr>
             <a:picLocks noChangeAspect="1"/>
           </p:cNvPicPr>
@@ -5075,8 +5360,8 @@
         </p:blipFill>
         <p:spPr>
           <a:xfrm>
-            <a:off x="3492925" y="1645920"/>
-            <a:ext cx="5205845" cy="3017520"/>
+            <a:off x="3590694" y="1627632"/>
+            <a:ext cx="5010307" cy="2743200"/>
           </a:xfrm>
           <a:prstGeom prst="rect">
             <a:avLst/>
@@ -5091,7 +5376,7 @@
         </p:nvSpPr>
         <p:spPr>
           <a:xfrm>
-            <a:off x="685800" y="4846320"/>
+            <a:off x="685800" y="4526280"/>
             <a:ext cx="10820095" cy="4572000"/>
           </a:xfrm>
           <a:prstGeom prst="rect">
@@ -5107,33 +5392,49 @@
           <a:p>
             <a:pPr>
               <a:spcAft>
-                <a:spcPts val="900"/>
-              </a:spcAft>
-            </a:pPr>
-            <a:r>
-              <a:rPr sz="1300" b="1" i="0">
+                <a:spcPts val="400"/>
+              </a:spcAft>
+            </a:pPr>
+            <a:r>
+              <a:rPr sz="1250" b="1" i="0">
                 <a:solidFill>
                   <a:srgbClr val="1A1A1A"/>
                 </a:solidFill>
                 <a:latin typeface="Calibri"/>
               </a:rPr>
-              <a:t>A call costs about $150. A customer is worth about $7,300. If the call works one time in five, it pays for itself on any customer with more than a 10% chance of leaving. In this group, 31% leave.</a:t>
+              <a:t>New customers look fragile, and risk looks like it falls with age. That is the usual reason to fund onboarding, and the evidence for it looks strong: 30-day survival drops from 0.98 for the 2023 intake to 0.59 for the 2024 one, measured at the same age.</a:t>
             </a:r>
           </a:p>
           <a:p>
             <a:pPr>
               <a:spcAft>
-                <a:spcPts val="900"/>
-              </a:spcAft>
-            </a:pPr>
-            <a:r>
-              <a:rPr sz="1300" b="1" i="0">
-                <a:solidFill>
-                  <a:srgbClr val="1E7A4B"/>
-                </a:solidFill>
-                <a:latin typeface="Calibri"/>
-              </a:rPr>
-              <a:t>So calling everyone already makes money, and no ranking can improve on a decision that is right for every customer. Using the model adds $600 on top of $52,400. That is a 1% gain, and even that is generous.</a:t>
+                <a:spcPts val="400"/>
+              </a:spcAft>
+            </a:pPr>
+            <a:r>
+              <a:rPr sz="1250" b="1" i="0">
+                <a:solidFill>
+                  <a:srgbClr val="B02E2E"/>
+                </a:solidFill>
+                <a:latin typeface="Calibri"/>
+              </a:rPr>
+              <a:t>It is the same random date. A customer who joined recently has a shorter window for that date to land in, so a larger share of their draws fall inside any 90-day question we ask. They look worse at every age without anything about them being worse.</a:t>
+            </a:r>
+          </a:p>
+          <a:p>
+            <a:pPr>
+              <a:spcAft>
+                <a:spcPts val="400"/>
+              </a:spcAft>
+            </a:pPr>
+            <a:r>
+              <a:rPr sz="1250" b="1" i="0">
+                <a:solidFill>
+                  <a:srgbClr val="1A1A1A"/>
+                </a:solidFill>
+                <a:latin typeface="Calibri"/>
+              </a:rPr>
+              <a:t>Simulated data with no tenure effect in it at all clears the significance bar in 93% of runs, and does so more strongly than the real data does (p = 0.002 against 0.006). Within one joining month there is nothing left: a day-300 customer leaves as often as a day-10 one.</a:t>
             </a:r>
           </a:p>
         </p:txBody>
@@ -5167,7 +5468,7 @@
                 </a:solidFill>
                 <a:latin typeface="Calibri"/>
               </a:rPr>
-              <a:t>This is one division. Had I run it first, it would have shown that a working model was never the thing standing between us and the decision.</a:t>
+              <a:t>The recommendation does not change; the reason for it gets one layer deeper. This is the same finding as slide 11, applied to a spending decision instead of an investigation.</a:t>
             </a:r>
           </a:p>
         </p:txBody>
@@ -5226,7 +5527,7 @@
                 </a:solidFill>
                 <a:latin typeface="Calibri"/>
               </a:rPr>
-              <a:t>PART 4 · TESTING APPROACH</a:t>
+              <a:t>PART 4 · RECOMMENDATION 3</a:t>
             </a:r>
           </a:p>
           <a:p>
@@ -5238,11 +5539,11 @@
             <a:r>
               <a:rPr sz="2800" b="1" i="0">
                 <a:solidFill>
-                  <a:srgbClr val="1A1A1A"/>
-                </a:solidFill>
-                <a:latin typeface="Calibri"/>
-              </a:rPr>
-              <a:t>How I would test this, and what is worth testing</a:t>
+                  <a:srgbClr val="1E7A4B"/>
+                </a:solidFill>
+                <a:latin typeface="Calibri"/>
+              </a:rPr>
+              <a:t>Call every at-risk customer, do not rank them</a:t>
             </a:r>
           </a:p>
         </p:txBody>
@@ -5294,7 +5595,7 @@
       </p:sp>
       <p:pic>
         <p:nvPicPr>
-          <p:cNvPr id="4" name="Picture 3" descr="15_experiment_power.png"/>
+          <p:cNvPr id="4" name="Picture 3" descr="15_breakeven_grid.png"/>
           <p:cNvPicPr>
             <a:picLocks noChangeAspect="1"/>
           </p:cNvPicPr>
@@ -5308,8 +5609,8 @@
         </p:blipFill>
         <p:spPr>
           <a:xfrm>
-            <a:off x="6492240" y="1737360"/>
-            <a:ext cx="5344328" cy="2926080"/>
+            <a:off x="3492925" y="1645920"/>
+            <a:ext cx="5205845" cy="3017520"/>
           </a:xfrm>
           <a:prstGeom prst="rect">
             <a:avLst/>
@@ -5324,8 +5625,8 @@
         </p:nvSpPr>
         <p:spPr>
           <a:xfrm>
-            <a:off x="685800" y="1719072"/>
-            <a:ext cx="5486400" cy="4572000"/>
+            <a:off x="685800" y="4846320"/>
+            <a:ext cx="10820095" cy="4572000"/>
           </a:xfrm>
           <a:prstGeom prst="rect">
             <a:avLst/>
@@ -5344,157 +5645,29 @@
               </a:spcAft>
             </a:pPr>
             <a:r>
-              <a:rPr sz="1400" b="1" i="0">
+              <a:rPr sz="1300" b="1" i="0">
                 <a:solidFill>
                   <a:srgbClr val="1A1A1A"/>
                 </a:solidFill>
                 <a:latin typeface="Calibri"/>
               </a:rPr>
-              <a:t>Recommendation 1 is not an experiment. It is a data request.</a:t>
-            </a:r>
-          </a:p>
-          <a:p>
-            <a:pPr lvl="1">
+              <a:t>A call costs about $150. A customer is worth about $7,300. If the call works one time in five, it pays for itself on any customer with more than a 10% chance of leaving. In this group, 31% leave.</a:t>
+            </a:r>
+          </a:p>
+          <a:p>
+            <a:pPr>
               <a:spcAft>
                 <a:spcPts val="900"/>
               </a:spcAft>
             </a:pPr>
             <a:r>
-              <a:rPr sz="1200" b="0" i="0">
-                <a:solidFill>
-                  <a:srgbClr val="5A6270"/>
-                </a:solidFill>
-                <a:latin typeface="Calibri"/>
-              </a:rPr>
-              <a:t>Nothing in this extract can say why customers leave, because the timestamps were never recorded against the customers they belong to. Ask for an export where they are, then rerun this pipeline and compare against the score written down today.</a:t>
-            </a:r>
-          </a:p>
-          <a:p>
-            <a:pPr>
-              <a:spcAft>
-                <a:spcPts val="900"/>
-              </a:spcAft>
-            </a:pPr>
-            <a:r>
-              <a:rPr sz="600" b="0" i="0">
-                <a:solidFill>
-                  <a:srgbClr val="1A1A1A"/>
-                </a:solidFill>
-                <a:latin typeface="Calibri"/>
-              </a:rPr>
-              <a:t> </a:t>
-            </a:r>
-          </a:p>
-          <a:p>
-            <a:pPr>
-              <a:spcAft>
-                <a:spcPts val="900"/>
-              </a:spcAft>
-            </a:pPr>
-            <a:r>
-              <a:rPr sz="1400" b="1" i="0">
-                <a:solidFill>
-                  <a:srgbClr val="1A1A1A"/>
-                </a:solidFill>
-                <a:latin typeface="Calibri"/>
-              </a:rPr>
-              <a:t>Recommendation 3 is a proper experiment.</a:t>
-            </a:r>
-          </a:p>
-          <a:p>
-            <a:pPr lvl="1">
-              <a:spcAft>
-                <a:spcPts val="900"/>
-              </a:spcAft>
-            </a:pPr>
-            <a:r>
-              <a:rPr sz="1200" b="0" i="0">
-                <a:solidFill>
-                  <a:srgbClr val="5A6270"/>
-                </a:solidFill>
-                <a:latin typeface="Calibri"/>
-              </a:rPr>
-              <a:t>Split the at-risk customers in half at random. One half gets a call, one half does not. Measure retention after 180 days, and measure money kept as well, so a costly save is not mistaken for a win.</a:t>
-            </a:r>
-          </a:p>
-          <a:p>
-            <a:pPr>
-              <a:spcAft>
-                <a:spcPts val="900"/>
-              </a:spcAft>
-            </a:pPr>
-            <a:r>
-              <a:rPr sz="600" b="0" i="0">
-                <a:solidFill>
-                  <a:srgbClr val="1A1A1A"/>
-                </a:solidFill>
-                <a:latin typeface="Calibri"/>
-              </a:rPr>
-              <a:t> </a:t>
-            </a:r>
-          </a:p>
-          <a:p>
-            <a:pPr>
-              <a:spcAft>
-                <a:spcPts val="900"/>
-              </a:spcAft>
-            </a:pPr>
-            <a:r>
-              <a:rPr sz="1400" b="1" i="0">
-                <a:solidFill>
-                  <a:srgbClr val="B02E2E"/>
-                </a:solidFill>
-                <a:latin typeface="Calibri"/>
-              </a:rPr>
-              <a:t>But be realistic about what we can detect.</a:t>
-            </a:r>
-          </a:p>
-          <a:p>
-            <a:pPr lvl="1">
-              <a:spcAft>
-                <a:spcPts val="900"/>
-              </a:spcAft>
-            </a:pPr>
-            <a:r>
-              <a:rPr sz="1200" b="0" i="0">
-                <a:solidFill>
-                  <a:srgbClr val="5A6270"/>
-                </a:solidFill>
-                <a:latin typeface="Calibri"/>
-              </a:rPr>
-              <a:t>At about 21 new customers a month, only a very large effect can be proved:</a:t>
-            </a:r>
-          </a:p>
-          <a:p>
-            <a:pPr lvl="1">
-              <a:spcAft>
-                <a:spcPts val="900"/>
-              </a:spcAft>
-            </a:pPr>
-            <a:r>
-              <a:rPr sz="1200" b="0" i="0">
-                <a:solidFill>
-                  <a:srgbClr val="5A6270"/>
-                </a:solidFill>
-                <a:latin typeface="Calibri"/>
-              </a:rPr>
-              <a:t>Halving churn takes about 15 months to show.</a:t>
-            </a:r>
-          </a:p>
-          <a:p>
-            <a:pPr lvl="1">
-              <a:spcAft>
-                <a:spcPts val="900"/>
-              </a:spcAft>
-            </a:pPr>
-            <a:r>
-              <a:rPr sz="1200" b="0" i="0">
-                <a:solidFill>
-                  <a:srgbClr val="5A6270"/>
-                </a:solidFill>
-                <a:latin typeface="Calibri"/>
-              </a:rPr>
-              <a:t>A 5 point improvement would take over 10 years.</a:t>
+              <a:rPr sz="1300" b="1" i="0">
+                <a:solidFill>
+                  <a:srgbClr val="1E7A4B"/>
+                </a:solidFill>
+                <a:latin typeface="Calibri"/>
+              </a:rPr>
+              <a:t>So calling everyone already makes money, and no ranking can improve on a decision that is right for every customer. Using the model adds $600 on top of $52,400. That is a 1% gain, and even that is generous.</a:t>
             </a:r>
           </a:p>
         </p:txBody>
@@ -5528,7 +5701,7 @@
                 </a:solidFill>
                 <a:latin typeface="Calibri"/>
               </a:rPr>
-              <a:t>Two separate methods agree on this. A standard power calculation and a simulation both say we cannot detect anything smaller than about a 15 point change.</a:t>
+              <a:t>This is one division. Had I run it first, it would have shown that a working model was never the thing standing between us and the decision.</a:t>
             </a:r>
           </a:p>
         </p:txBody>
@@ -5587,7 +5760,7 @@
                 </a:solidFill>
                 <a:latin typeface="Calibri"/>
               </a:rPr>
-              <a:t>PART 5 · MENTORSHIP</a:t>
+              <a:t>PART 4 · TESTING APPROACH</a:t>
             </a:r>
           </a:p>
           <a:p>
@@ -5603,7 +5776,7 @@
                 </a:solidFill>
                 <a:latin typeface="Calibri"/>
               </a:rPr>
-              <a:t>What I would teach a junior engineer</a:t>
+              <a:t>How I would test this, and what is worth testing</a:t>
             </a:r>
           </a:p>
         </p:txBody>
@@ -5653,6 +5826,367 @@
           </a:p>
         </p:txBody>
       </p:sp>
+      <p:pic>
+        <p:nvPicPr>
+          <p:cNvPr id="4" name="Picture 3" descr="15_experiment_power.png"/>
+          <p:cNvPicPr>
+            <a:picLocks noChangeAspect="1"/>
+          </p:cNvPicPr>
+          <p:nvPr/>
+        </p:nvPicPr>
+        <p:blipFill>
+          <a:blip r:embed="rId2"/>
+          <a:stretch>
+            <a:fillRect/>
+          </a:stretch>
+        </p:blipFill>
+        <p:spPr>
+          <a:xfrm>
+            <a:off x="6492240" y="1737360"/>
+            <a:ext cx="5344328" cy="2926080"/>
+          </a:xfrm>
+          <a:prstGeom prst="rect">
+            <a:avLst/>
+          </a:prstGeom>
+        </p:spPr>
+      </p:pic>
+      <p:sp>
+        <p:nvSpPr>
+          <p:cNvPr id="5" name="TextBox 4"/>
+          <p:cNvSpPr txBox="1"/>
+          <p:nvPr/>
+        </p:nvSpPr>
+        <p:spPr>
+          <a:xfrm>
+            <a:off x="685800" y="1719072"/>
+            <a:ext cx="5486400" cy="4572000"/>
+          </a:xfrm>
+          <a:prstGeom prst="rect">
+            <a:avLst/>
+          </a:prstGeom>
+          <a:noFill/>
+        </p:spPr>
+        <p:txBody>
+          <a:bodyPr wrap="square">
+            <a:spAutoFit/>
+          </a:bodyPr>
+          <a:lstStyle/>
+          <a:p>
+            <a:pPr>
+              <a:spcAft>
+                <a:spcPts val="900"/>
+              </a:spcAft>
+            </a:pPr>
+            <a:r>
+              <a:rPr sz="1400" b="1" i="0">
+                <a:solidFill>
+                  <a:srgbClr val="1A1A1A"/>
+                </a:solidFill>
+                <a:latin typeface="Calibri"/>
+              </a:rPr>
+              <a:t>Recommendation 1 is not an experiment. It is a data request.</a:t>
+            </a:r>
+          </a:p>
+          <a:p>
+            <a:pPr lvl="1">
+              <a:spcAft>
+                <a:spcPts val="900"/>
+              </a:spcAft>
+            </a:pPr>
+            <a:r>
+              <a:rPr sz="1200" b="0" i="0">
+                <a:solidFill>
+                  <a:srgbClr val="5A6270"/>
+                </a:solidFill>
+                <a:latin typeface="Calibri"/>
+              </a:rPr>
+              <a:t>Nothing in this extract can say why customers leave, because the timestamps were never recorded against the customers they belong to. Ask for an export where they are, then rerun this pipeline and compare against the score written down today.</a:t>
+            </a:r>
+          </a:p>
+          <a:p>
+            <a:pPr>
+              <a:spcAft>
+                <a:spcPts val="900"/>
+              </a:spcAft>
+            </a:pPr>
+            <a:r>
+              <a:rPr sz="600" b="0" i="0">
+                <a:solidFill>
+                  <a:srgbClr val="1A1A1A"/>
+                </a:solidFill>
+                <a:latin typeface="Calibri"/>
+              </a:rPr>
+              <a:t> </a:t>
+            </a:r>
+          </a:p>
+          <a:p>
+            <a:pPr>
+              <a:spcAft>
+                <a:spcPts val="900"/>
+              </a:spcAft>
+            </a:pPr>
+            <a:r>
+              <a:rPr sz="1400" b="1" i="0">
+                <a:solidFill>
+                  <a:srgbClr val="1A1A1A"/>
+                </a:solidFill>
+                <a:latin typeface="Calibri"/>
+              </a:rPr>
+              <a:t>Recommendation 3 is a proper experiment.</a:t>
+            </a:r>
+          </a:p>
+          <a:p>
+            <a:pPr lvl="1">
+              <a:spcAft>
+                <a:spcPts val="900"/>
+              </a:spcAft>
+            </a:pPr>
+            <a:r>
+              <a:rPr sz="1200" b="0" i="0">
+                <a:solidFill>
+                  <a:srgbClr val="5A6270"/>
+                </a:solidFill>
+                <a:latin typeface="Calibri"/>
+              </a:rPr>
+              <a:t>Split the at-risk customers in half at random. One half gets a call, one half does not. Measure retention after 180 days, and measure money kept as well, so a costly save is not mistaken for a win.</a:t>
+            </a:r>
+          </a:p>
+          <a:p>
+            <a:pPr>
+              <a:spcAft>
+                <a:spcPts val="900"/>
+              </a:spcAft>
+            </a:pPr>
+            <a:r>
+              <a:rPr sz="600" b="0" i="0">
+                <a:solidFill>
+                  <a:srgbClr val="1A1A1A"/>
+                </a:solidFill>
+                <a:latin typeface="Calibri"/>
+              </a:rPr>
+              <a:t> </a:t>
+            </a:r>
+          </a:p>
+          <a:p>
+            <a:pPr>
+              <a:spcAft>
+                <a:spcPts val="900"/>
+              </a:spcAft>
+            </a:pPr>
+            <a:r>
+              <a:rPr sz="1400" b="1" i="0">
+                <a:solidFill>
+                  <a:srgbClr val="B02E2E"/>
+                </a:solidFill>
+                <a:latin typeface="Calibri"/>
+              </a:rPr>
+              <a:t>But be realistic about what we can detect.</a:t>
+            </a:r>
+          </a:p>
+          <a:p>
+            <a:pPr lvl="1">
+              <a:spcAft>
+                <a:spcPts val="900"/>
+              </a:spcAft>
+            </a:pPr>
+            <a:r>
+              <a:rPr sz="1200" b="0" i="0">
+                <a:solidFill>
+                  <a:srgbClr val="5A6270"/>
+                </a:solidFill>
+                <a:latin typeface="Calibri"/>
+              </a:rPr>
+              <a:t>At about 21 new customers a month, only a very large effect can be proved:</a:t>
+            </a:r>
+          </a:p>
+          <a:p>
+            <a:pPr lvl="1">
+              <a:spcAft>
+                <a:spcPts val="900"/>
+              </a:spcAft>
+            </a:pPr>
+            <a:r>
+              <a:rPr sz="1200" b="0" i="0">
+                <a:solidFill>
+                  <a:srgbClr val="5A6270"/>
+                </a:solidFill>
+                <a:latin typeface="Calibri"/>
+              </a:rPr>
+              <a:t>Halving churn takes about 15 months to show.</a:t>
+            </a:r>
+          </a:p>
+          <a:p>
+            <a:pPr lvl="1">
+              <a:spcAft>
+                <a:spcPts val="900"/>
+              </a:spcAft>
+            </a:pPr>
+            <a:r>
+              <a:rPr sz="1200" b="0" i="0">
+                <a:solidFill>
+                  <a:srgbClr val="5A6270"/>
+                </a:solidFill>
+                <a:latin typeface="Calibri"/>
+              </a:rPr>
+              <a:t>A 5 point improvement would take over 10 years.</a:t>
+            </a:r>
+          </a:p>
+        </p:txBody>
+      </p:sp>
+      <p:sp>
+        <p:nvSpPr>
+          <p:cNvPr id="6" name="TextBox 5"/>
+          <p:cNvSpPr txBox="1"/>
+          <p:nvPr/>
+        </p:nvSpPr>
+        <p:spPr>
+          <a:xfrm>
+            <a:off x="685800" y="6126480"/>
+            <a:ext cx="10820095" cy="502920"/>
+          </a:xfrm>
+          <a:prstGeom prst="rect">
+            <a:avLst/>
+          </a:prstGeom>
+          <a:noFill/>
+        </p:spPr>
+        <p:txBody>
+          <a:bodyPr wrap="square">
+            <a:spAutoFit/>
+          </a:bodyPr>
+          <a:lstStyle/>
+          <a:p>
+            <a:r>
+              <a:rPr sz="1150" b="0" i="1">
+                <a:solidFill>
+                  <a:srgbClr val="5A6270"/>
+                </a:solidFill>
+                <a:latin typeface="Calibri"/>
+              </a:rPr>
+              <a:t>Two separate methods agree on this. A standard power calculation and a simulation both say we cannot detect anything smaller than about a 15 point change.</a:t>
+            </a:r>
+          </a:p>
+        </p:txBody>
+      </p:sp>
+    </p:spTree>
+  </p:cSld>
+  <p:clrMapOvr>
+    <a:masterClrMapping/>
+  </p:clrMapOvr>
+</p:sld>
+</file>
+
+<file path=ppt/slides/slide17.xml><?xml version="1.0" encoding="utf-8"?>
+<p:sld xmlns:a="http://schemas.openxmlformats.org/drawingml/2006/main" xmlns:r="http://schemas.openxmlformats.org/officeDocument/2006/relationships" xmlns:p="http://schemas.openxmlformats.org/presentationml/2006/main">
+  <p:cSld>
+    <p:spTree>
+      <p:nvGrpSpPr>
+        <p:cNvPr id="1" name=""/>
+        <p:cNvGrpSpPr/>
+        <p:nvPr/>
+      </p:nvGrpSpPr>
+      <p:grpSpPr>
+        <a:xfrm>
+          <a:off x="0" y="0"/>
+          <a:ext cx="0" cy="0"/>
+          <a:chOff x="0" y="0"/>
+          <a:chExt cx="0" cy="0"/>
+        </a:xfrm>
+      </p:grpSpPr>
+      <p:sp>
+        <p:nvSpPr>
+          <p:cNvPr id="2" name="TextBox 1"/>
+          <p:cNvSpPr txBox="1"/>
+          <p:nvPr/>
+        </p:nvSpPr>
+        <p:spPr>
+          <a:xfrm>
+            <a:off x="685800" y="365760"/>
+            <a:ext cx="10820095" cy="1051560"/>
+          </a:xfrm>
+          <a:prstGeom prst="rect">
+            <a:avLst/>
+          </a:prstGeom>
+          <a:noFill/>
+        </p:spPr>
+        <p:txBody>
+          <a:bodyPr wrap="square">
+            <a:spAutoFit/>
+          </a:bodyPr>
+          <a:lstStyle/>
+          <a:p>
+            <a:r>
+              <a:rPr sz="1200" b="1" i="0">
+                <a:solidFill>
+                  <a:srgbClr val="5A6270"/>
+                </a:solidFill>
+                <a:latin typeface="Calibri"/>
+              </a:rPr>
+              <a:t>PART 5 · MENTORSHIP</a:t>
+            </a:r>
+          </a:p>
+          <a:p>
+            <a:pPr>
+              <a:spcBef>
+                <a:spcPts val="400"/>
+              </a:spcBef>
+            </a:pPr>
+            <a:r>
+              <a:rPr sz="2800" b="1" i="0">
+                <a:solidFill>
+                  <a:srgbClr val="1A1A1A"/>
+                </a:solidFill>
+                <a:latin typeface="Calibri"/>
+              </a:rPr>
+              <a:t>What I would teach a junior engineer</a:t>
+            </a:r>
+          </a:p>
+        </p:txBody>
+      </p:sp>
+      <p:sp>
+        <p:nvSpPr>
+          <p:cNvPr id="3" name="Rectangle 2"/>
+          <p:cNvSpPr/>
+          <p:nvPr/>
+        </p:nvSpPr>
+        <p:spPr>
+          <a:xfrm>
+            <a:off x="685800" y="1426464"/>
+            <a:ext cx="10820095" cy="9525"/>
+          </a:xfrm>
+          <a:prstGeom prst="rect">
+            <a:avLst/>
+          </a:prstGeom>
+          <a:solidFill>
+            <a:srgbClr val="D8DCE0"/>
+          </a:solidFill>
+          <a:ln>
+            <a:noFill/>
+          </a:ln>
+          <a:effectLst/>
+        </p:spPr>
+        <p:style>
+          <a:lnRef idx="1">
+            <a:schemeClr val="accent1"/>
+          </a:lnRef>
+          <a:fillRef idx="3">
+            <a:schemeClr val="accent1"/>
+          </a:fillRef>
+          <a:effectRef idx="2">
+            <a:schemeClr val="accent1"/>
+          </a:effectRef>
+          <a:fontRef idx="minor">
+            <a:schemeClr val="lt1"/>
+          </a:fontRef>
+        </p:style>
+        <p:txBody>
+          <a:bodyPr rtlCol="0" anchor="ctr"/>
+          <a:lstStyle/>
+          <a:p>
+            <a:pPr algn="ctr"/>
+            <a:endParaRPr/>
+          </a:p>
+        </p:txBody>
+      </p:sp>
       <p:sp>
         <p:nvSpPr>
           <p:cNvPr id="4" name="TextBox 3"/>
@@ -5942,7 +6476,7 @@
 </p:sld>
 </file>
 
-<file path=ppt/slides/slide17.xml><?xml version="1.0" encoding="utf-8"?>
+<file path=ppt/slides/slide18.xml><?xml version="1.0" encoding="utf-8"?>
 <p:sld xmlns:a="http://schemas.openxmlformats.org/drawingml/2006/main" xmlns:r="http://schemas.openxmlformats.org/officeDocument/2006/relationships" xmlns:p="http://schemas.openxmlformats.org/presentationml/2006/main">
   <p:cSld>
     <p:spTree>
@@ -9246,6 +9780,155 @@
         <p:spPr>
           <a:xfrm>
             <a:off x="685800" y="365760"/>
+            <a:ext cx="10820095" cy="759182"/>
+          </a:xfrm>
+          <a:prstGeom prst="rect">
+            <a:avLst/>
+          </a:prstGeom>
+          <a:noFill/>
+        </p:spPr>
+        <p:txBody>
+          <a:bodyPr wrap="square">
+            <a:spAutoFit/>
+          </a:bodyPr>
+          <a:lstStyle/>
+          <a:p>
+            <a:r>
+              <a:rPr sz="1200" b="1" i="0" dirty="0">
+                <a:solidFill>
+                  <a:srgbClr val="5A6270"/>
+                </a:solidFill>
+                <a:latin typeface="Calibri"/>
+              </a:rPr>
+              <a:t>PART 2 · DATA EXPLORATION</a:t>
+            </a:r>
+          </a:p>
+          <a:p>
+            <a:pPr>
+              <a:spcBef>
+                <a:spcPts val="400"/>
+              </a:spcBef>
+            </a:pPr>
+            <a:r>
+              <a:rPr lang="en-US" sz="2800" b="1" dirty="0">
+                <a:solidFill>
+                  <a:srgbClr val="1A1A1A"/>
+                </a:solidFill>
+              </a:rPr>
+              <a:t>Schema, scale and integrity</a:t>
+            </a:r>
+            <a:endParaRPr sz="2800" b="1" i="0" dirty="0">
+              <a:solidFill>
+                <a:srgbClr val="1A1A1A"/>
+              </a:solidFill>
+              <a:latin typeface="Calibri"/>
+            </a:endParaRPr>
+          </a:p>
+        </p:txBody>
+      </p:sp>
+      <p:sp>
+        <p:nvSpPr>
+          <p:cNvPr id="3" name="Rectangle 2"/>
+          <p:cNvSpPr/>
+          <p:nvPr/>
+        </p:nvSpPr>
+        <p:spPr>
+          <a:xfrm>
+            <a:off x="685799" y="1270635"/>
+            <a:ext cx="10820095" cy="9525"/>
+          </a:xfrm>
+          <a:prstGeom prst="rect">
+            <a:avLst/>
+          </a:prstGeom>
+          <a:solidFill>
+            <a:srgbClr val="D8DCE0"/>
+          </a:solidFill>
+          <a:ln>
+            <a:noFill/>
+          </a:ln>
+          <a:effectLst/>
+        </p:spPr>
+        <p:style>
+          <a:lnRef idx="1">
+            <a:schemeClr val="accent1"/>
+          </a:lnRef>
+          <a:fillRef idx="3">
+            <a:schemeClr val="accent1"/>
+          </a:fillRef>
+          <a:effectRef idx="2">
+            <a:schemeClr val="accent1"/>
+          </a:effectRef>
+          <a:fontRef idx="minor">
+            <a:schemeClr val="lt1"/>
+          </a:fontRef>
+        </p:style>
+        <p:txBody>
+          <a:bodyPr rtlCol="0" anchor="ctr"/>
+          <a:lstStyle/>
+          <a:p>
+            <a:pPr algn="ctr"/>
+            <a:endParaRPr/>
+          </a:p>
+        </p:txBody>
+      </p:sp>
+      <p:pic>
+        <p:nvPicPr>
+          <p:cNvPr id="4" name="Picture 3" descr="19_data_model.png"/>
+          <p:cNvPicPr>
+            <a:picLocks noChangeAspect="1"/>
+          </p:cNvPicPr>
+          <p:nvPr/>
+        </p:nvPicPr>
+        <p:blipFill>
+          <a:blip r:embed="rId3"/>
+          <a:stretch>
+            <a:fillRect/>
+          </a:stretch>
+        </p:blipFill>
+        <p:spPr>
+          <a:xfrm>
+            <a:off x="1105078" y="1425853"/>
+            <a:ext cx="9428085" cy="5394960"/>
+          </a:xfrm>
+          <a:prstGeom prst="rect">
+            <a:avLst/>
+          </a:prstGeom>
+        </p:spPr>
+      </p:pic>
+    </p:spTree>
+  </p:cSld>
+  <p:clrMapOvr>
+    <a:masterClrMapping/>
+  </p:clrMapOvr>
+</p:sld>
+</file>
+
+<file path=ppt/slides/slide7.xml><?xml version="1.0" encoding="utf-8"?>
+<p:sld xmlns:a="http://schemas.openxmlformats.org/drawingml/2006/main" xmlns:r="http://schemas.openxmlformats.org/officeDocument/2006/relationships" xmlns:p="http://schemas.openxmlformats.org/presentationml/2006/main">
+  <p:cSld>
+    <p:spTree>
+      <p:nvGrpSpPr>
+        <p:cNvPr id="1" name=""/>
+        <p:cNvGrpSpPr/>
+        <p:nvPr/>
+      </p:nvGrpSpPr>
+      <p:grpSpPr>
+        <a:xfrm>
+          <a:off x="0" y="0"/>
+          <a:ext cx="0" cy="0"/>
+          <a:chOff x="0" y="0"/>
+          <a:chExt cx="0" cy="0"/>
+        </a:xfrm>
+      </p:grpSpPr>
+      <p:sp>
+        <p:nvSpPr>
+          <p:cNvPr id="2" name="TextBox 1"/>
+          <p:cNvSpPr txBox="1"/>
+          <p:nvPr/>
+        </p:nvSpPr>
+        <p:spPr>
+          <a:xfrm>
+            <a:off x="685800" y="365760"/>
             <a:ext cx="10820095" cy="1051560"/>
           </a:xfrm>
           <a:prstGeom prst="rect">
@@ -9419,7 +10102,7 @@
 </p:sld>
 </file>
 
-<file path=ppt/slides/slide7.xml><?xml version="1.0" encoding="utf-8"?>
+<file path=ppt/slides/slide8.xml><?xml version="1.0" encoding="utf-8"?>
 <p:sld xmlns:a="http://schemas.openxmlformats.org/drawingml/2006/main" xmlns:r="http://schemas.openxmlformats.org/officeDocument/2006/relationships" xmlns:p="http://schemas.openxmlformats.org/presentationml/2006/main">
   <p:cSld>
     <p:spTree>
@@ -9698,7 +10381,7 @@
 </p:sld>
 </file>
 
-<file path=ppt/slides/slide8.xml><?xml version="1.0" encoding="utf-8"?>
+<file path=ppt/slides/slide9.xml><?xml version="1.0" encoding="utf-8"?>
 <p:sld xmlns:a="http://schemas.openxmlformats.org/drawingml/2006/main" xmlns:r="http://schemas.openxmlformats.org/officeDocument/2006/relationships" xmlns:p="http://schemas.openxmlformats.org/presentationml/2006/main">
   <p:cSld>
     <p:spTree>
@@ -9885,406 +10568,6 @@
                 <a:latin typeface="Calibri"/>
               </a:rPr>
               <a:t>Every model is tested on exactly the same splits, so the comparison is fair. The boosting models get their preferred treatment of missing values and categories. With only 177 customers, the simple regularised model still wins.</a:t>
-            </a:r>
-          </a:p>
-        </p:txBody>
-      </p:sp>
-    </p:spTree>
-  </p:cSld>
-  <p:clrMapOvr>
-    <a:masterClrMapping/>
-  </p:clrMapOvr>
-</p:sld>
-</file>
-
-<file path=ppt/slides/slide9.xml><?xml version="1.0" encoding="utf-8"?>
-<p:sld xmlns:a="http://schemas.openxmlformats.org/drawingml/2006/main" xmlns:r="http://schemas.openxmlformats.org/officeDocument/2006/relationships" xmlns:p="http://schemas.openxmlformats.org/presentationml/2006/main">
-  <p:cSld>
-    <p:spTree>
-      <p:nvGrpSpPr>
-        <p:cNvPr id="1" name=""/>
-        <p:cNvGrpSpPr/>
-        <p:nvPr/>
-      </p:nvGrpSpPr>
-      <p:grpSpPr>
-        <a:xfrm>
-          <a:off x="0" y="0"/>
-          <a:ext cx="0" cy="0"/>
-          <a:chOff x="0" y="0"/>
-          <a:chExt cx="0" cy="0"/>
-        </a:xfrm>
-      </p:grpSpPr>
-      <p:sp>
-        <p:nvSpPr>
-          <p:cNvPr id="2" name="TextBox 1"/>
-          <p:cNvSpPr txBox="1"/>
-          <p:nvPr/>
-        </p:nvSpPr>
-        <p:spPr>
-          <a:xfrm>
-            <a:off x="685800" y="365760"/>
-            <a:ext cx="10820095" cy="1051560"/>
-          </a:xfrm>
-          <a:prstGeom prst="rect">
-            <a:avLst/>
-          </a:prstGeom>
-          <a:noFill/>
-        </p:spPr>
-        <p:txBody>
-          <a:bodyPr wrap="square">
-            <a:spAutoFit/>
-          </a:bodyPr>
-          <a:lstStyle/>
-          <a:p>
-            <a:r>
-              <a:rPr sz="1200" b="1" i="0">
-                <a:solidFill>
-                  <a:srgbClr val="5A6270"/>
-                </a:solidFill>
-                <a:latin typeface="Calibri"/>
-              </a:rPr>
-              <a:t>PART 3 · MODELLING</a:t>
-            </a:r>
-          </a:p>
-          <a:p>
-            <a:pPr>
-              <a:spcBef>
-                <a:spcPts val="400"/>
-              </a:spcBef>
-            </a:pPr>
-            <a:r>
-              <a:rPr sz="2800" b="1" i="0">
-                <a:solidFill>
-                  <a:srgbClr val="B02E2E"/>
-                </a:solidFill>
-                <a:latin typeface="Calibri"/>
-              </a:rPr>
-              <a:t>How it performs, and why the number is low</a:t>
-            </a:r>
-          </a:p>
-        </p:txBody>
-      </p:sp>
-      <p:sp>
-        <p:nvSpPr>
-          <p:cNvPr id="3" name="Rectangle 2"/>
-          <p:cNvSpPr/>
-          <p:nvPr/>
-        </p:nvSpPr>
-        <p:spPr>
-          <a:xfrm>
-            <a:off x="685800" y="1426464"/>
-            <a:ext cx="10820095" cy="9525"/>
-          </a:xfrm>
-          <a:prstGeom prst="rect">
-            <a:avLst/>
-          </a:prstGeom>
-          <a:solidFill>
-            <a:srgbClr val="D8DCE0"/>
-          </a:solidFill>
-          <a:ln>
-            <a:noFill/>
-          </a:ln>
-          <a:effectLst/>
-        </p:spPr>
-        <p:style>
-          <a:lnRef idx="1">
-            <a:schemeClr val="accent1"/>
-          </a:lnRef>
-          <a:fillRef idx="3">
-            <a:schemeClr val="accent1"/>
-          </a:fillRef>
-          <a:effectRef idx="2">
-            <a:schemeClr val="accent1"/>
-          </a:effectRef>
-          <a:fontRef idx="minor">
-            <a:schemeClr val="lt1"/>
-          </a:fontRef>
-        </p:style>
-        <p:txBody>
-          <a:bodyPr rtlCol="0" anchor="ctr"/>
-          <a:lstStyle/>
-          <a:p>
-            <a:pPr algn="ctr"/>
-            <a:endParaRPr/>
-          </a:p>
-        </p:txBody>
-      </p:sp>
-      <p:pic>
-        <p:nvPicPr>
-          <p:cNvPr id="4" name="Picture 3" descr="09_selection_null.png"/>
-          <p:cNvPicPr>
-            <a:picLocks noChangeAspect="1"/>
-          </p:cNvPicPr>
-          <p:nvPr/>
-        </p:nvPicPr>
-        <p:blipFill>
-          <a:blip r:embed="rId2"/>
-          <a:stretch>
-            <a:fillRect/>
-          </a:stretch>
-        </p:blipFill>
-        <p:spPr>
-          <a:xfrm>
-            <a:off x="6812280" y="1783080"/>
-            <a:ext cx="4212139" cy="2331720"/>
-          </a:xfrm>
-          <a:prstGeom prst="rect">
-            <a:avLst/>
-          </a:prstGeom>
-        </p:spPr>
-      </p:pic>
-      <p:sp>
-        <p:nvSpPr>
-          <p:cNvPr id="5" name="TextBox 4"/>
-          <p:cNvSpPr txBox="1"/>
-          <p:nvPr/>
-        </p:nvSpPr>
-        <p:spPr>
-          <a:xfrm>
-            <a:off x="685800" y="1783080"/>
-            <a:ext cx="5760720" cy="4572000"/>
-          </a:xfrm>
-          <a:prstGeom prst="rect">
-            <a:avLst/>
-          </a:prstGeom>
-          <a:noFill/>
-        </p:spPr>
-        <p:txBody>
-          <a:bodyPr wrap="square">
-            <a:spAutoFit/>
-          </a:bodyPr>
-          <a:lstStyle/>
-          <a:p>
-            <a:pPr>
-              <a:spcAft>
-                <a:spcPts val="500"/>
-              </a:spcAft>
-            </a:pPr>
-            <a:r>
-              <a:rPr sz="1300" b="0" i="0">
-                <a:solidFill>
-                  <a:srgbClr val="5A6270"/>
-                </a:solidFill>
-                <a:latin typeface="Calibri"/>
-              </a:rPr>
-              <a:t>Best single model, taken at face value:  AUC 0.583</a:t>
-            </a:r>
-          </a:p>
-          <a:p>
-            <a:pPr>
-              <a:spcAft>
-                <a:spcPts val="500"/>
-              </a:spcAft>
-            </a:pPr>
-            <a:r>
-              <a:rPr sz="1300" b="1" i="0">
-                <a:solidFill>
-                  <a:srgbClr val="1A1A1A"/>
-                </a:solidFill>
-                <a:latin typeface="Calibri"/>
-              </a:rPr>
-              <a:t>The honest score:  AUC 0.534, give or take 0.016</a:t>
-            </a:r>
-          </a:p>
-          <a:p>
-            <a:pPr>
-              <a:spcAft>
-                <a:spcPts val="500"/>
-              </a:spcAft>
-            </a:pPr>
-            <a:r>
-              <a:rPr sz="1300" b="0" i="0">
-                <a:solidFill>
-                  <a:srgbClr val="5A6270"/>
-                </a:solidFill>
-                <a:latin typeface="Calibri"/>
-              </a:rPr>
-              <a:t>Guessing:  AUC 0.500</a:t>
-            </a:r>
-          </a:p>
-          <a:p>
-            <a:pPr>
-              <a:spcAft>
-                <a:spcPts val="500"/>
-              </a:spcAft>
-            </a:pPr>
-            <a:r>
-              <a:rPr sz="600" b="0" i="0">
-                <a:solidFill>
-                  <a:srgbClr val="1A1A1A"/>
-                </a:solidFill>
-                <a:latin typeface="Calibri"/>
-              </a:rPr>
-              <a:t> </a:t>
-            </a:r>
-          </a:p>
-          <a:p>
-            <a:pPr>
-              <a:spcAft>
-                <a:spcPts val="500"/>
-              </a:spcAft>
-            </a:pPr>
-            <a:r>
-              <a:rPr sz="1300" b="1" i="0">
-                <a:solidFill>
-                  <a:srgbClr val="B02E2E"/>
-                </a:solidFill>
-                <a:latin typeface="Calibri"/>
-              </a:rPr>
-              <a:t>Picking the best of ten models is itself a form of fitting.</a:t>
-            </a:r>
-          </a:p>
-          <a:p>
-            <a:pPr lvl="1">
-              <a:spcAft>
-                <a:spcPts val="500"/>
-              </a:spcAft>
-            </a:pPr>
-            <a:r>
-              <a:rPr sz="1100" b="0" i="0">
-                <a:solidFill>
-                  <a:srgbClr val="5A6270"/>
-                </a:solidFill>
-                <a:latin typeface="Calibri"/>
-              </a:rPr>
-              <a:t>Measure that properly and 0.049 of AUC disappears — most of what looked like signal. The chart is why: run the same ten-model search against shuffled labels and the whole distribution slides right, past our result.</a:t>
-            </a:r>
-          </a:p>
-          <a:p>
-            <a:pPr lvl="1">
-              <a:spcAft>
-                <a:spcPts val="500"/>
-              </a:spcAft>
-            </a:pPr>
-            <a:r>
-              <a:rPr sz="1100" b="0" i="0">
-                <a:solidFill>
-                  <a:srgbClr val="5A6270"/>
-                </a:solidFill>
-                <a:latin typeface="Calibri"/>
-              </a:rPr>
-              <a:t>Across 25 rounds, eight of the ten models won at least once. A genuinely better model wins nearly every time.</a:t>
-            </a:r>
-          </a:p>
-        </p:txBody>
-      </p:sp>
-      <p:sp>
-        <p:nvSpPr>
-          <p:cNvPr id="6" name="TextBox 5"/>
-          <p:cNvSpPr txBox="1"/>
-          <p:nvPr/>
-        </p:nvSpPr>
-        <p:spPr>
-          <a:xfrm>
-            <a:off x="685800" y="4315968"/>
-            <a:ext cx="10820095" cy="4572000"/>
-          </a:xfrm>
-          <a:prstGeom prst="rect">
-            <a:avLst/>
-          </a:prstGeom>
-          <a:noFill/>
-        </p:spPr>
-        <p:txBody>
-          <a:bodyPr wrap="square">
-            <a:spAutoFit/>
-          </a:bodyPr>
-          <a:lstStyle/>
-          <a:p>
-            <a:pPr>
-              <a:spcAft>
-                <a:spcPts val="500"/>
-              </a:spcAft>
-            </a:pPr>
-            <a:r>
-              <a:rPr sz="1300" b="1" i="0">
-                <a:solidFill>
-                  <a:srgbClr val="1A1A1A"/>
-                </a:solidFill>
-                <a:latin typeface="Calibri"/>
-              </a:rPr>
-              <a:t>Why the score is low. Each cause is measured, not guessed at.</a:t>
-            </a:r>
-          </a:p>
-          <a:p>
-            <a:pPr lvl="1">
-              <a:spcAft>
-                <a:spcPts val="500"/>
-              </a:spcAft>
-            </a:pPr>
-            <a:r>
-              <a:rPr sz="1100" b="0" i="0">
-                <a:solidFill>
-                  <a:srgbClr val="5A6270"/>
-                </a:solidFill>
-                <a:latin typeface="Calibri"/>
-              </a:rPr>
-              <a:t>The inputs hold nothing. Usage and ticket dates are scattered at random across the two years and match their own customer's signup date at r = 0.002 and r = 0.014. Inside those tables, priority does not predict how fast we answered and plan does not predict how much people used.</a:t>
-            </a:r>
-          </a:p>
-          <a:p>
-            <a:pPr lvl="1">
-              <a:spcAft>
-                <a:spcPts val="500"/>
-              </a:spcAft>
-            </a:pPr>
-            <a:r>
-              <a:rPr sz="1100" b="0" i="0">
-                <a:solidFill>
-                  <a:srgbClr val="5A6270"/>
-                </a:solidFill>
-                <a:latin typeface="Calibri"/>
-              </a:rPr>
-              <a:t>The target is a random date — a coin toss between the day the customer joined and the last day of the file. Slide 11 is that test. Subscriptions is the one table with real rules, and none of it relates to churn.</a:t>
-            </a:r>
-          </a:p>
-          <a:p>
-            <a:pPr lvl="1">
-              <a:spcAft>
-                <a:spcPts val="500"/>
-              </a:spcAft>
-            </a:pPr>
-            <a:r>
-              <a:rPr sz="1100" b="0" i="0">
-                <a:solidFill>
-                  <a:srgbClr val="5A6270"/>
-                </a:solidFill>
-                <a:latin typeface="Calibri"/>
-              </a:rPr>
-              <a:t>Sample size is real but secondary: 54 churners against 73 features. It is not leakage, not the feature build, and not tuning. I checked all three.</a:t>
-            </a:r>
-          </a:p>
-        </p:txBody>
-      </p:sp>
-      <p:sp>
-        <p:nvSpPr>
-          <p:cNvPr id="7" name="TextBox 6"/>
-          <p:cNvSpPr txBox="1"/>
-          <p:nvPr/>
-        </p:nvSpPr>
-        <p:spPr>
-          <a:xfrm>
-            <a:off x="685800" y="6126480"/>
-            <a:ext cx="10820095" cy="502920"/>
-          </a:xfrm>
-          <a:prstGeom prst="rect">
-            <a:avLst/>
-          </a:prstGeom>
-          <a:noFill/>
-        </p:spPr>
-        <p:txBody>
-          <a:bodyPr wrap="square">
-            <a:spAutoFit/>
-          </a:bodyPr>
-          <a:lstStyle/>
-          <a:p>
-            <a:r>
-              <a:rPr sz="1150" b="0" i="1">
-                <a:solidFill>
-                  <a:srgbClr val="1A1A1A"/>
-                </a:solidFill>
-                <a:latin typeface="Calibri"/>
-              </a:rPr>
-              <a:t>Scores are ROC-AUC: 0.50 is guessing, 1.00 is perfect. I confirmed the pipeline works by planting targets of known strength — a strong one scores AUC 0.965, a deliberately weak one 0.584, a meaningless one 0.494. The method works. AUC 0.534 is the right answer to the question this data can be asked.</a:t>
             </a:r>
           </a:p>
         </p:txBody>

</xml_diff>

<commit_message>
Update `AvePoint_Case_Study.pptx` with revised content and enhancements
- Updated the `AvePoint_Case_Study.pptx` to reflect further revisions, improving the alignment with recent insights and analysis.
- Enhanced visual elements to boost clarity and engagement in presenting key findings.

These changes aim to refine the overall quality and effectiveness of the case study presentation.
</commit_message>
<xml_diff>
--- a/outputs/decks/AvePoint_Case_Study.pptx
+++ b/outputs/decks/AvePoint_Case_Study.pptx
@@ -146,7 +146,7 @@
 <file path=ppt/revisionInfo.xml><?xml version="1.0" encoding="utf-8"?>
 <p1510:revInfo xmlns:a="http://schemas.openxmlformats.org/drawingml/2006/main" xmlns:r="http://schemas.openxmlformats.org/officeDocument/2006/relationships" xmlns:p1510="http://schemas.microsoft.com/office/powerpoint/2015/10/main">
   <p1510:revLst>
-    <p1510:client id="{25DC7B8B-EC09-4841-A573-8FF6489E0CC5}" v="91" dt="2026-07-29T04:34:16.235"/>
+    <p1510:client id="{25DC7B8B-EC09-4841-A573-8FF6489E0CC5}" v="97" dt="2026-07-29T11:25:55.045"/>
   </p1510:revLst>
 </p1510:revInfo>
 </file>
@@ -156,7 +156,7 @@
   <pc:docChgLst>
     <pc:chgData name="Dmitriy Ratushny" userId="08050032e8047aee" providerId="LiveId" clId="{78EB1A6D-D3A9-4525-A4D5-A50D4E20D487}"/>
     <pc:docChg chg="undo custSel addSld modSld">
-      <pc:chgData name="Dmitriy Ratushny" userId="08050032e8047aee" providerId="LiveId" clId="{78EB1A6D-D3A9-4525-A4D5-A50D4E20D487}" dt="2026-07-29T04:34:24.604" v="1631" actId="1076"/>
+      <pc:chgData name="Dmitriy Ratushny" userId="08050032e8047aee" providerId="LiveId" clId="{78EB1A6D-D3A9-4525-A4D5-A50D4E20D487}" dt="2026-07-29T11:26:45.518" v="1890" actId="20577"/>
       <pc:docMkLst>
         <pc:docMk/>
       </pc:docMkLst>
@@ -270,7 +270,7 @@
         </pc:picChg>
       </pc:sldChg>
       <pc:sldChg chg="addSp delSp modSp mod">
-        <pc:chgData name="Dmitriy Ratushny" userId="08050032e8047aee" providerId="LiveId" clId="{78EB1A6D-D3A9-4525-A4D5-A50D4E20D487}" dt="2026-07-29T03:49:06.748" v="1504" actId="572"/>
+        <pc:chgData name="Dmitriy Ratushny" userId="08050032e8047aee" providerId="LiveId" clId="{78EB1A6D-D3A9-4525-A4D5-A50D4E20D487}" dt="2026-07-29T11:11:12.385" v="1638" actId="20577"/>
         <pc:sldMkLst>
           <pc:docMk/>
           <pc:sldMk cId="0" sldId="259"/>
@@ -300,7 +300,7 @@
           </ac:spMkLst>
         </pc:spChg>
         <pc:graphicFrameChg chg="add mod modGraphic">
-          <ac:chgData name="Dmitriy Ratushny" userId="08050032e8047aee" providerId="LiveId" clId="{78EB1A6D-D3A9-4525-A4D5-A50D4E20D487}" dt="2026-07-29T03:49:06.748" v="1504" actId="572"/>
+          <ac:chgData name="Dmitriy Ratushny" userId="08050032e8047aee" providerId="LiveId" clId="{78EB1A6D-D3A9-4525-A4D5-A50D4E20D487}" dt="2026-07-29T11:11:12.385" v="1638" actId="20577"/>
           <ac:graphicFrameMkLst>
             <pc:docMk/>
             <pc:sldMk cId="0" sldId="259"/>
@@ -332,13 +332,13 @@
         </pc:picChg>
       </pc:sldChg>
       <pc:sldChg chg="addSp delSp modSp new mod">
-        <pc:chgData name="Dmitriy Ratushny" userId="08050032e8047aee" providerId="LiveId" clId="{78EB1A6D-D3A9-4525-A4D5-A50D4E20D487}" dt="2026-07-29T04:32:12.401" v="1623" actId="22"/>
+        <pc:chgData name="Dmitriy Ratushny" userId="08050032e8047aee" providerId="LiveId" clId="{78EB1A6D-D3A9-4525-A4D5-A50D4E20D487}" dt="2026-07-29T11:26:45.518" v="1890" actId="20577"/>
         <pc:sldMkLst>
           <pc:docMk/>
           <pc:sldMk cId="727656364" sldId="272"/>
         </pc:sldMkLst>
         <pc:spChg chg="add mod">
-          <ac:chgData name="Dmitriy Ratushny" userId="08050032e8047aee" providerId="LiveId" clId="{78EB1A6D-D3A9-4525-A4D5-A50D4E20D487}" dt="2026-07-29T04:06:18.688" v="1618" actId="20577"/>
+          <ac:chgData name="Dmitriy Ratushny" userId="08050032e8047aee" providerId="LiveId" clId="{78EB1A6D-D3A9-4525-A4D5-A50D4E20D487}" dt="2026-07-29T11:26:45.518" v="1890" actId="20577"/>
           <ac:spMkLst>
             <pc:docMk/>
             <pc:sldMk cId="727656364" sldId="272"/>
@@ -8433,7 +8433,7 @@
           <p:nvPr>
             <p:extLst>
               <p:ext uri="{D42A27DB-BD31-4B8C-83A1-F6EECF244321}">
-                <p14:modId xmlns:p14="http://schemas.microsoft.com/office/powerpoint/2010/main" val="1355601465"/>
+                <p14:modId xmlns:p14="http://schemas.microsoft.com/office/powerpoint/2010/main" val="3112051045"/>
               </p:ext>
             </p:extLst>
           </p:nvPr>
@@ -9317,7 +9317,7 @@
                     <a:p>
                       <a:r>
                         <a:rPr lang="en-US" sz="1400" dirty="0"/>
-                        <a:t>Label only, never a feature</a:t>
+                        <a:t>usable</a:t>
                       </a:r>
                     </a:p>
                   </a:txBody>
@@ -9460,7 +9460,7 @@
         <p:spPr>
           <a:xfrm>
             <a:off x="747998" y="1869170"/>
-            <a:ext cx="11202905" cy="2759730"/>
+            <a:ext cx="11202905" cy="3159839"/>
           </a:xfrm>
           <a:prstGeom prst="rect">
             <a:avLst/>
@@ -9505,6 +9505,19 @@
             </a:r>
           </a:p>
           <a:p>
+            <a:pPr>
+              <a:spcAft>
+                <a:spcPts val="500"/>
+              </a:spcAft>
+            </a:pPr>
+            <a:endParaRPr lang="en-US" sz="1400" b="1" i="0" dirty="0">
+              <a:solidFill>
+                <a:srgbClr val="1A1A1A"/>
+              </a:solidFill>
+              <a:latin typeface="Calibri"/>
+            </a:endParaRPr>
+          </a:p>
+          <a:p>
             <a:pPr marL="685800" lvl="1" indent="-228600">
               <a:spcAft>
                 <a:spcPts val="500"/>
@@ -9518,7 +9531,7 @@
                   <a:srgbClr val="5A6270"/>
                 </a:solidFill>
               </a:rPr>
-              <a:t>Churn means a row in </a:t>
+              <a:t>I used churn from the churn defined by rows in </a:t>
             </a:r>
             <a:r>
               <a:rPr lang="en-US" sz="1200" b="1" dirty="0" err="1">
@@ -9534,7 +9547,23 @@
                   <a:srgbClr val="5A6270"/>
                 </a:solidFill>
               </a:rPr>
-              <a:t>. Three records claim to say who left and they disagree. I picked the one with a usable date. If that is the wrong one, everything downstream is wrong.</a:t>
+              <a:t>. Three records claim to say who left and they disagree - I picked </a:t>
+            </a:r>
+            <a:r>
+              <a:rPr lang="en-US" sz="1200" b="1" dirty="0" err="1">
+                <a:solidFill>
+                  <a:schemeClr val="tx2"/>
+                </a:solidFill>
+              </a:rPr>
+              <a:t>churn_events</a:t>
+            </a:r>
+            <a:r>
+              <a:rPr lang="en-US" sz="1200" dirty="0">
+                <a:solidFill>
+                  <a:srgbClr val="5A6270"/>
+                </a:solidFill>
+              </a:rPr>
+              <a:t> table because it has a usable date. </a:t>
             </a:r>
           </a:p>
           <a:p>
@@ -9568,7 +9597,7 @@
                   <a:srgbClr val="5A6270"/>
                 </a:solidFill>
               </a:rPr>
-              <a:t>A 90-day window and quarter-end dates. I chose both before running anything, then swept horizons from 30 to 180 days to see if the choice mattered. It moved the score by 0.026, basically noise.</a:t>
+              <a:t>A 90-day window and quarter-end dates. I chose both before running anything, then swept horizons from 30 to 180 days to see if the choice mattered. It moved the AUC score by 0.026, basically noise.</a:t>
             </a:r>
           </a:p>
           <a:p>
@@ -9596,20 +9625,14 @@
               <a:buFont typeface="+mj-lt"/>
               <a:buAutoNum type="arabicPeriod"/>
             </a:pPr>
-            <a:endParaRPr lang="en-US" sz="1200" dirty="0">
-              <a:solidFill>
-                <a:srgbClr val="5A6270"/>
-              </a:solidFill>
-            </a:endParaRPr>
-          </a:p>
-          <a:p>
-            <a:pPr marL="685800" lvl="1" indent="-228600">
-              <a:spcAft>
-                <a:spcPts val="500"/>
-              </a:spcAft>
-              <a:buFont typeface="+mj-lt"/>
-              <a:buAutoNum type="arabicPeriod"/>
-            </a:pPr>
+            <a:r>
+              <a:rPr lang="en-US" sz="1200" dirty="0">
+                <a:solidFill>
+                  <a:srgbClr val="5A6270"/>
+                </a:solidFill>
+              </a:rPr>
+              <a:t>Events dated before their customer are kept. Over half of all usage rows and tickets predate their customer's signup by a median of seven months — too far to be pre-sales evaluation, but not something I can prove wrong. Dropping them costs 43% of usage and 68% of tickets and takes AUC from 0.596 to 0.517. So I kept every row and accounted for this in feature engineering.</a:t>
+            </a:r>
             <a:endParaRPr lang="en-US" sz="1200" b="0" i="0" dirty="0">
               <a:solidFill>
                 <a:srgbClr val="5A6270"/>

</xml_diff>

<commit_message>
Enhance data exploration and visualization in presentation materials
- Updated `build_new_slides.py` to include a new section on data exploration, highlighting the lack of standout customer segments when tested against chance.
- Revised `fig_feature_catalogue.py` to improve feature descriptions and streamline the code structure.
- Enhanced `fig_segment_shuffle_html.py` with additional variables for analysis and improved visual layout for better clarity.
- Updated HTML and PNG outputs to reflect the latest changes in the data exploration findings.

These modifications aim to provide clearer insights into customer behavior and improve the overall presentation quality.
</commit_message>
<xml_diff>
--- a/outputs/decks/AvePoint_Case_Study.pptx
+++ b/outputs/decks/AvePoint_Case_Study.pptx
@@ -15,7 +15,7 @@
     <p:sldId id="272" r:id="rId6"/>
     <p:sldId id="273" r:id="rId7"/>
     <p:sldId id="276" r:id="rId8"/>
-    <p:sldId id="277" r:id="rId9"/>
+    <p:sldId id="278" r:id="rId9"/>
     <p:sldId id="261" r:id="rId10"/>
     <p:sldId id="262" r:id="rId11"/>
     <p:sldId id="263" r:id="rId12"/>
@@ -147,7 +147,7 @@
 <file path=ppt/revisionInfo.xml><?xml version="1.0" encoding="utf-8"?>
 <p1510:revInfo xmlns:a="http://schemas.openxmlformats.org/drawingml/2006/main" xmlns:r="http://schemas.openxmlformats.org/officeDocument/2006/relationships" xmlns:p1510="http://schemas.microsoft.com/office/powerpoint/2015/10/main">
   <p1510:revLst>
-    <p1510:client id="{25DC7B8B-EC09-4841-A573-8FF6489E0CC5}" v="106" dt="2026-07-29T12:13:55.305"/>
+    <p1510:client id="{25DC7B8B-EC09-4841-A573-8FF6489E0CC5}" v="135" dt="2026-07-29T13:46:55.803"/>
   </p1510:revLst>
 </p1510:revInfo>
 </file>
@@ -157,7 +157,7 @@
   <pc:docChgLst>
     <pc:chgData name="Dmitriy Ratushny" userId="08050032e8047aee" providerId="LiveId" clId="{78EB1A6D-D3A9-4525-A4D5-A50D4E20D487}"/>
     <pc:docChg chg="undo custSel addSld delSld modSld">
-      <pc:chgData name="Dmitriy Ratushny" userId="08050032e8047aee" providerId="LiveId" clId="{78EB1A6D-D3A9-4525-A4D5-A50D4E20D487}" dt="2026-07-29T12:18:14.207" v="2148" actId="21"/>
+      <pc:chgData name="Dmitriy Ratushny" userId="08050032e8047aee" providerId="LiveId" clId="{78EB1A6D-D3A9-4525-A4D5-A50D4E20D487}" dt="2026-07-29T13:47:14.229" v="3031" actId="20577"/>
       <pc:docMkLst>
         <pc:docMk/>
       </pc:docMkLst>
@@ -177,7 +177,7 @@
         </pc:spChg>
       </pc:sldChg>
       <pc:sldChg chg="delSp modSp mod">
-        <pc:chgData name="Dmitriy Ratushny" userId="08050032e8047aee" providerId="LiveId" clId="{78EB1A6D-D3A9-4525-A4D5-A50D4E20D487}" dt="2026-07-29T04:10:32.206" v="1621" actId="1076"/>
+        <pc:chgData name="Dmitriy Ratushny" userId="08050032e8047aee" providerId="LiveId" clId="{78EB1A6D-D3A9-4525-A4D5-A50D4E20D487}" dt="2026-07-29T13:47:14.229" v="3031" actId="20577"/>
         <pc:sldMkLst>
           <pc:docMk/>
           <pc:sldMk cId="0" sldId="257"/>
@@ -199,7 +199,7 @@
           </ac:spMkLst>
         </pc:spChg>
         <pc:spChg chg="mod">
-          <ac:chgData name="Dmitriy Ratushny" userId="08050032e8047aee" providerId="LiveId" clId="{78EB1A6D-D3A9-4525-A4D5-A50D4E20D487}" dt="2026-07-29T04:10:28.776" v="1619" actId="1076"/>
+          <ac:chgData name="Dmitriy Ratushny" userId="08050032e8047aee" providerId="LiveId" clId="{78EB1A6D-D3A9-4525-A4D5-A50D4E20D487}" dt="2026-07-29T13:47:14.229" v="3031" actId="20577"/>
           <ac:spMkLst>
             <pc:docMk/>
             <pc:sldMk cId="0" sldId="257"/>
@@ -332,23 +332,79 @@
           </ac:picMkLst>
         </pc:picChg>
       </pc:sldChg>
-      <pc:sldChg chg="modSp add del mod">
-        <pc:chgData name="Dmitriy Ratushny" userId="08050032e8047aee" providerId="LiveId" clId="{78EB1A6D-D3A9-4525-A4D5-A50D4E20D487}" dt="2026-07-29T12:16:55.676" v="2147" actId="20577"/>
+      <pc:sldChg chg="addSp delSp modSp add del mod">
+        <pc:chgData name="Dmitriy Ratushny" userId="08050032e8047aee" providerId="LiveId" clId="{78EB1A6D-D3A9-4525-A4D5-A50D4E20D487}" dt="2026-07-29T12:44:10.995" v="2392" actId="1076"/>
         <pc:sldMkLst>
           <pc:docMk/>
           <pc:sldMk cId="0" sldId="261"/>
         </pc:sldMkLst>
         <pc:spChg chg="mod">
-          <ac:chgData name="Dmitriy Ratushny" userId="08050032e8047aee" providerId="LiveId" clId="{78EB1A6D-D3A9-4525-A4D5-A50D4E20D487}" dt="2026-07-29T12:16:55.676" v="2147" actId="20577"/>
+          <ac:chgData name="Dmitriy Ratushny" userId="08050032e8047aee" providerId="LiveId" clId="{78EB1A6D-D3A9-4525-A4D5-A50D4E20D487}" dt="2026-07-29T12:32:30.375" v="2175" actId="20577"/>
+          <ac:spMkLst>
+            <pc:docMk/>
+            <pc:sldMk cId="0" sldId="261"/>
+            <ac:spMk id="2" creationId="{00000000-0000-0000-0000-000000000000}"/>
+          </ac:spMkLst>
+        </pc:spChg>
+        <pc:spChg chg="del mod">
+          <ac:chgData name="Dmitriy Ratushny" userId="08050032e8047aee" providerId="LiveId" clId="{78EB1A6D-D3A9-4525-A4D5-A50D4E20D487}" dt="2026-07-29T12:32:09.070" v="2154" actId="478"/>
           <ac:spMkLst>
             <pc:docMk/>
             <pc:sldMk cId="0" sldId="261"/>
             <ac:spMk id="5" creationId="{00000000-0000-0000-0000-000000000000}"/>
           </ac:spMkLst>
         </pc:spChg>
+        <pc:picChg chg="mod modCrop">
+          <ac:chgData name="Dmitriy Ratushny" userId="08050032e8047aee" providerId="LiveId" clId="{78EB1A6D-D3A9-4525-A4D5-A50D4E20D487}" dt="2026-07-29T12:44:06.558" v="2391" actId="1076"/>
+          <ac:picMkLst>
+            <pc:docMk/>
+            <pc:sldMk cId="0" sldId="261"/>
+            <ac:picMk id="4" creationId="{00000000-0000-0000-0000-000000000000}"/>
+          </ac:picMkLst>
+        </pc:picChg>
+        <pc:picChg chg="add del mod">
+          <ac:chgData name="Dmitriy Ratushny" userId="08050032e8047aee" providerId="LiveId" clId="{78EB1A6D-D3A9-4525-A4D5-A50D4E20D487}" dt="2026-07-29T12:35:12.480" v="2265" actId="478"/>
+          <ac:picMkLst>
+            <pc:docMk/>
+            <pc:sldMk cId="0" sldId="261"/>
+            <ac:picMk id="7" creationId="{989B4BEC-82C1-D8F5-B42B-DE4CA80E73FE}"/>
+          </ac:picMkLst>
+        </pc:picChg>
+        <pc:picChg chg="add del mod">
+          <ac:chgData name="Dmitriy Ratushny" userId="08050032e8047aee" providerId="LiveId" clId="{78EB1A6D-D3A9-4525-A4D5-A50D4E20D487}" dt="2026-07-29T12:40:20.235" v="2338" actId="478"/>
+          <ac:picMkLst>
+            <pc:docMk/>
+            <pc:sldMk cId="0" sldId="261"/>
+            <ac:picMk id="9" creationId="{AC078ECF-97B9-D617-4209-FCCDA9079EAF}"/>
+          </ac:picMkLst>
+        </pc:picChg>
+        <pc:picChg chg="add mod modCrop">
+          <ac:chgData name="Dmitriy Ratushny" userId="08050032e8047aee" providerId="LiveId" clId="{78EB1A6D-D3A9-4525-A4D5-A50D4E20D487}" dt="2026-07-29T12:44:10.995" v="2392" actId="1076"/>
+          <ac:picMkLst>
+            <pc:docMk/>
+            <pc:sldMk cId="0" sldId="261"/>
+            <ac:picMk id="11" creationId="{D9478685-84BF-2555-1422-7F7ACAB891D9}"/>
+          </ac:picMkLst>
+        </pc:picChg>
+        <pc:picChg chg="add del mod">
+          <ac:chgData name="Dmitriy Ratushny" userId="08050032e8047aee" providerId="LiveId" clId="{78EB1A6D-D3A9-4525-A4D5-A50D4E20D487}" dt="2026-07-29T12:39:40.095" v="2307" actId="22"/>
+          <ac:picMkLst>
+            <pc:docMk/>
+            <pc:sldMk cId="0" sldId="261"/>
+            <ac:picMk id="13" creationId="{41F7F728-083D-E261-5219-EE4799768DBC}"/>
+          </ac:picMkLst>
+        </pc:picChg>
+        <pc:picChg chg="add mod">
+          <ac:chgData name="Dmitriy Ratushny" userId="08050032e8047aee" providerId="LiveId" clId="{78EB1A6D-D3A9-4525-A4D5-A50D4E20D487}" dt="2026-07-29T12:43:58.821" v="2389" actId="1076"/>
+          <ac:picMkLst>
+            <pc:docMk/>
+            <pc:sldMk cId="0" sldId="261"/>
+            <ac:picMk id="15" creationId="{3A739226-CB47-DDA5-CE8E-5B5A1839E840}"/>
+          </ac:picMkLst>
+        </pc:picChg>
       </pc:sldChg>
-      <pc:sldChg chg="modSp mod">
-        <pc:chgData name="Dmitriy Ratushny" userId="08050032e8047aee" providerId="LiveId" clId="{78EB1A6D-D3A9-4525-A4D5-A50D4E20D487}" dt="2026-07-29T12:18:14.207" v="2148" actId="21"/>
+      <pc:sldChg chg="addSp delSp modSp mod">
+        <pc:chgData name="Dmitriy Ratushny" userId="08050032e8047aee" providerId="LiveId" clId="{78EB1A6D-D3A9-4525-A4D5-A50D4E20D487}" dt="2026-07-29T13:23:39.412" v="2944" actId="1076"/>
         <pc:sldMkLst>
           <pc:docMk/>
           <pc:sldMk cId="0" sldId="262"/>
@@ -358,6 +414,184 @@
           <ac:spMkLst>
             <pc:docMk/>
             <pc:sldMk cId="0" sldId="262"/>
+            <ac:spMk id="2" creationId="{00000000-0000-0000-0000-000000000000}"/>
+          </ac:spMkLst>
+        </pc:spChg>
+        <pc:spChg chg="mod">
+          <ac:chgData name="Dmitriy Ratushny" userId="08050032e8047aee" providerId="LiveId" clId="{78EB1A6D-D3A9-4525-A4D5-A50D4E20D487}" dt="2026-07-29T13:23:39.412" v="2944" actId="1076"/>
+          <ac:spMkLst>
+            <pc:docMk/>
+            <pc:sldMk cId="0" sldId="262"/>
+            <ac:spMk id="5" creationId="{00000000-0000-0000-0000-000000000000}"/>
+          </ac:spMkLst>
+        </pc:spChg>
+        <pc:picChg chg="add del mod">
+          <ac:chgData name="Dmitriy Ratushny" userId="08050032e8047aee" providerId="LiveId" clId="{78EB1A6D-D3A9-4525-A4D5-A50D4E20D487}" dt="2026-07-29T13:23:05.261" v="2936" actId="478"/>
+          <ac:picMkLst>
+            <pc:docMk/>
+            <pc:sldMk cId="0" sldId="262"/>
+            <ac:picMk id="4" creationId="{00000000-0000-0000-0000-000000000000}"/>
+          </ac:picMkLst>
+        </pc:picChg>
+        <pc:picChg chg="add del mod modCrop">
+          <ac:chgData name="Dmitriy Ratushny" userId="08050032e8047aee" providerId="LiveId" clId="{78EB1A6D-D3A9-4525-A4D5-A50D4E20D487}" dt="2026-07-29T13:10:32.502" v="2855" actId="22"/>
+          <ac:picMkLst>
+            <pc:docMk/>
+            <pc:sldMk cId="0" sldId="262"/>
+            <ac:picMk id="7" creationId="{20B3470F-8F09-7BE4-1522-0C096A5A4A2B}"/>
+          </ac:picMkLst>
+        </pc:picChg>
+        <pc:picChg chg="add mod">
+          <ac:chgData name="Dmitriy Ratushny" userId="08050032e8047aee" providerId="LiveId" clId="{78EB1A6D-D3A9-4525-A4D5-A50D4E20D487}" dt="2026-07-29T13:16:21.699" v="2866" actId="1076"/>
+          <ac:picMkLst>
+            <pc:docMk/>
+            <pc:sldMk cId="0" sldId="262"/>
+            <ac:picMk id="9" creationId="{EE34B78E-69C8-C210-CBE4-DCFCFA91AFED}"/>
+          </ac:picMkLst>
+        </pc:picChg>
+        <pc:picChg chg="add mod">
+          <ac:chgData name="Dmitriy Ratushny" userId="08050032e8047aee" providerId="LiveId" clId="{78EB1A6D-D3A9-4525-A4D5-A50D4E20D487}" dt="2026-07-29T13:23:14.188" v="2940" actId="1076"/>
+          <ac:picMkLst>
+            <pc:docMk/>
+            <pc:sldMk cId="0" sldId="262"/>
+            <ac:picMk id="11" creationId="{AD950E2A-4BCA-F823-06CD-8AE5F2C59ADE}"/>
+          </ac:picMkLst>
+        </pc:picChg>
+      </pc:sldChg>
+      <pc:sldChg chg="addSp delSp modSp mod">
+        <pc:chgData name="Dmitriy Ratushny" userId="08050032e8047aee" providerId="LiveId" clId="{78EB1A6D-D3A9-4525-A4D5-A50D4E20D487}" dt="2026-07-29T13:37:40.697" v="3026" actId="22"/>
+        <pc:sldMkLst>
+          <pc:docMk/>
+          <pc:sldMk cId="0" sldId="263"/>
+        </pc:sldMkLst>
+        <pc:spChg chg="mod">
+          <ac:chgData name="Dmitriy Ratushny" userId="08050032e8047aee" providerId="LiveId" clId="{78EB1A6D-D3A9-4525-A4D5-A50D4E20D487}" dt="2026-07-29T13:03:35.038" v="2730" actId="207"/>
+          <ac:spMkLst>
+            <pc:docMk/>
+            <pc:sldMk cId="0" sldId="263"/>
+            <ac:spMk id="2" creationId="{00000000-0000-0000-0000-000000000000}"/>
+          </ac:spMkLst>
+        </pc:spChg>
+        <pc:spChg chg="mod">
+          <ac:chgData name="Dmitriy Ratushny" userId="08050032e8047aee" providerId="LiveId" clId="{78EB1A6D-D3A9-4525-A4D5-A50D4E20D487}" dt="2026-07-29T13:37:39.531" v="3023" actId="20577"/>
+          <ac:spMkLst>
+            <pc:docMk/>
+            <pc:sldMk cId="0" sldId="263"/>
+            <ac:spMk id="5" creationId="{00000000-0000-0000-0000-000000000000}"/>
+          </ac:spMkLst>
+        </pc:spChg>
+        <pc:spChg chg="mod">
+          <ac:chgData name="Dmitriy Ratushny" userId="08050032e8047aee" providerId="LiveId" clId="{78EB1A6D-D3A9-4525-A4D5-A50D4E20D487}" dt="2026-07-29T13:37:38.535" v="3019" actId="1076"/>
+          <ac:spMkLst>
+            <pc:docMk/>
+            <pc:sldMk cId="0" sldId="263"/>
+            <ac:spMk id="6" creationId="{00000000-0000-0000-0000-000000000000}"/>
+          </ac:spMkLst>
+        </pc:spChg>
+        <pc:spChg chg="del">
+          <ac:chgData name="Dmitriy Ratushny" userId="08050032e8047aee" providerId="LiveId" clId="{78EB1A6D-D3A9-4525-A4D5-A50D4E20D487}" dt="2026-07-29T13:31:44.968" v="3008" actId="478"/>
+          <ac:spMkLst>
+            <pc:docMk/>
+            <pc:sldMk cId="0" sldId="263"/>
+            <ac:spMk id="7" creationId="{00000000-0000-0000-0000-000000000000}"/>
+          </ac:spMkLst>
+        </pc:spChg>
+        <pc:spChg chg="add mod">
+          <ac:chgData name="Dmitriy Ratushny" userId="08050032e8047aee" providerId="LiveId" clId="{78EB1A6D-D3A9-4525-A4D5-A50D4E20D487}" dt="2026-07-29T13:29:51.835" v="3006" actId="14100"/>
+          <ac:spMkLst>
+            <pc:docMk/>
+            <pc:sldMk cId="0" sldId="263"/>
+            <ac:spMk id="8" creationId="{12C611BC-1707-F619-DD30-259262FFA0D2}"/>
+          </ac:spMkLst>
+        </pc:spChg>
+        <pc:picChg chg="add del mod">
+          <ac:chgData name="Dmitriy Ratushny" userId="08050032e8047aee" providerId="LiveId" clId="{78EB1A6D-D3A9-4525-A4D5-A50D4E20D487}" dt="2026-07-29T13:37:40.697" v="3026" actId="22"/>
+          <ac:picMkLst>
+            <pc:docMk/>
+            <pc:sldMk cId="0" sldId="263"/>
+            <ac:picMk id="10" creationId="{E7FB8800-1062-9A37-EE8A-C1D5F26BFB26}"/>
+          </ac:picMkLst>
+        </pc:picChg>
+      </pc:sldChg>
+      <pc:sldChg chg="modSp mod">
+        <pc:chgData name="Dmitriy Ratushny" userId="08050032e8047aee" providerId="LiveId" clId="{78EB1A6D-D3A9-4525-A4D5-A50D4E20D487}" dt="2026-07-29T13:46:55.803" v="3027"/>
+        <pc:sldMkLst>
+          <pc:docMk/>
+          <pc:sldMk cId="0" sldId="264"/>
+        </pc:sldMkLst>
+        <pc:spChg chg="mod">
+          <ac:chgData name="Dmitriy Ratushny" userId="08050032e8047aee" providerId="LiveId" clId="{78EB1A6D-D3A9-4525-A4D5-A50D4E20D487}" dt="2026-07-29T13:03:14.930" v="2708" actId="6549"/>
+          <ac:spMkLst>
+            <pc:docMk/>
+            <pc:sldMk cId="0" sldId="264"/>
+            <ac:spMk id="2" creationId="{00000000-0000-0000-0000-000000000000}"/>
+          </ac:spMkLst>
+        </pc:spChg>
+        <pc:spChg chg="mod">
+          <ac:chgData name="Dmitriy Ratushny" userId="08050032e8047aee" providerId="LiveId" clId="{78EB1A6D-D3A9-4525-A4D5-A50D4E20D487}" dt="2026-07-29T13:46:55.803" v="3027"/>
+          <ac:spMkLst>
+            <pc:docMk/>
+            <pc:sldMk cId="0" sldId="264"/>
+            <ac:spMk id="5" creationId="{00000000-0000-0000-0000-000000000000}"/>
+          </ac:spMkLst>
+        </pc:spChg>
+      </pc:sldChg>
+      <pc:sldChg chg="modSp mod">
+        <pc:chgData name="Dmitriy Ratushny" userId="08050032e8047aee" providerId="LiveId" clId="{78EB1A6D-D3A9-4525-A4D5-A50D4E20D487}" dt="2026-07-29T13:04:05.667" v="2732" actId="108"/>
+        <pc:sldMkLst>
+          <pc:docMk/>
+          <pc:sldMk cId="0" sldId="265"/>
+        </pc:sldMkLst>
+        <pc:spChg chg="mod">
+          <ac:chgData name="Dmitriy Ratushny" userId="08050032e8047aee" providerId="LiveId" clId="{78EB1A6D-D3A9-4525-A4D5-A50D4E20D487}" dt="2026-07-29T13:04:05.667" v="2732" actId="108"/>
+          <ac:spMkLst>
+            <pc:docMk/>
+            <pc:sldMk cId="0" sldId="265"/>
+            <ac:spMk id="2" creationId="{00000000-0000-0000-0000-000000000000}"/>
+          </ac:spMkLst>
+        </pc:spChg>
+      </pc:sldChg>
+      <pc:sldChg chg="modSp mod">
+        <pc:chgData name="Dmitriy Ratushny" userId="08050032e8047aee" providerId="LiveId" clId="{78EB1A6D-D3A9-4525-A4D5-A50D4E20D487}" dt="2026-07-29T13:04:49.312" v="2752" actId="207"/>
+        <pc:sldMkLst>
+          <pc:docMk/>
+          <pc:sldMk cId="0" sldId="266"/>
+        </pc:sldMkLst>
+        <pc:spChg chg="mod">
+          <ac:chgData name="Dmitriy Ratushny" userId="08050032e8047aee" providerId="LiveId" clId="{78EB1A6D-D3A9-4525-A4D5-A50D4E20D487}" dt="2026-07-29T13:04:49.312" v="2752" actId="207"/>
+          <ac:spMkLst>
+            <pc:docMk/>
+            <pc:sldMk cId="0" sldId="266"/>
+            <ac:spMk id="2" creationId="{00000000-0000-0000-0000-000000000000}"/>
+          </ac:spMkLst>
+        </pc:spChg>
+      </pc:sldChg>
+      <pc:sldChg chg="modSp mod">
+        <pc:chgData name="Dmitriy Ratushny" userId="08050032e8047aee" providerId="LiveId" clId="{78EB1A6D-D3A9-4525-A4D5-A50D4E20D487}" dt="2026-07-29T13:04:57.467" v="2764" actId="207"/>
+        <pc:sldMkLst>
+          <pc:docMk/>
+          <pc:sldMk cId="0" sldId="267"/>
+        </pc:sldMkLst>
+        <pc:spChg chg="mod">
+          <ac:chgData name="Dmitriy Ratushny" userId="08050032e8047aee" providerId="LiveId" clId="{78EB1A6D-D3A9-4525-A4D5-A50D4E20D487}" dt="2026-07-29T13:04:57.467" v="2764" actId="207"/>
+          <ac:spMkLst>
+            <pc:docMk/>
+            <pc:sldMk cId="0" sldId="267"/>
+            <ac:spMk id="2" creationId="{00000000-0000-0000-0000-000000000000}"/>
+          </ac:spMkLst>
+        </pc:spChg>
+      </pc:sldChg>
+      <pc:sldChg chg="modSp mod">
+        <pc:chgData name="Dmitriy Ratushny" userId="08050032e8047aee" providerId="LiveId" clId="{78EB1A6D-D3A9-4525-A4D5-A50D4E20D487}" dt="2026-07-29T13:05:04.462" v="2776" actId="207"/>
+        <pc:sldMkLst>
+          <pc:docMk/>
+          <pc:sldMk cId="0" sldId="268"/>
+        </pc:sldMkLst>
+        <pc:spChg chg="mod">
+          <ac:chgData name="Dmitriy Ratushny" userId="08050032e8047aee" providerId="LiveId" clId="{78EB1A6D-D3A9-4525-A4D5-A50D4E20D487}" dt="2026-07-29T13:05:04.462" v="2776" actId="207"/>
+          <ac:spMkLst>
+            <pc:docMk/>
+            <pc:sldMk cId="0" sldId="268"/>
             <ac:spMk id="2" creationId="{00000000-0000-0000-0000-000000000000}"/>
           </ac:spMkLst>
         </pc:spChg>
@@ -485,8 +719,8 @@
           </ac:picMkLst>
         </pc:picChg>
       </pc:sldChg>
-      <pc:sldChg chg="addSp delSp modSp add mod">
-        <pc:chgData name="Dmitriy Ratushny" userId="08050032e8047aee" providerId="LiveId" clId="{78EB1A6D-D3A9-4525-A4D5-A50D4E20D487}" dt="2026-07-29T12:14:43.485" v="2145" actId="20577"/>
+      <pc:sldChg chg="addSp delSp modSp add del mod">
+        <pc:chgData name="Dmitriy Ratushny" userId="08050032e8047aee" providerId="LiveId" clId="{78EB1A6D-D3A9-4525-A4D5-A50D4E20D487}" dt="2026-07-29T12:27:23.616" v="2150" actId="47"/>
         <pc:sldMkLst>
           <pc:docMk/>
           <pc:sldMk cId="0" sldId="277"/>
@@ -507,6 +741,53 @@
             <ac:spMk id="8" creationId="{03FA6BE2-C20B-E0BF-644E-235352149894}"/>
           </ac:spMkLst>
         </pc:spChg>
+      </pc:sldChg>
+      <pc:sldChg chg="addSp delSp modSp add mod">
+        <pc:chgData name="Dmitriy Ratushny" userId="08050032e8047aee" providerId="LiveId" clId="{78EB1A6D-D3A9-4525-A4D5-A50D4E20D487}" dt="2026-07-29T13:46:55.803" v="3027"/>
+        <pc:sldMkLst>
+          <pc:docMk/>
+          <pc:sldMk cId="0" sldId="278"/>
+        </pc:sldMkLst>
+        <pc:spChg chg="mod">
+          <ac:chgData name="Dmitriy Ratushny" userId="08050032e8047aee" providerId="LiveId" clId="{78EB1A6D-D3A9-4525-A4D5-A50D4E20D487}" dt="2026-07-29T12:58:36.164" v="2687" actId="20577"/>
+          <ac:spMkLst>
+            <pc:docMk/>
+            <pc:sldMk cId="0" sldId="278"/>
+            <ac:spMk id="2" creationId="{00000000-0000-0000-0000-000000000000}"/>
+          </ac:spMkLst>
+        </pc:spChg>
+        <pc:spChg chg="mod">
+          <ac:chgData name="Dmitriy Ratushny" userId="08050032e8047aee" providerId="LiveId" clId="{78EB1A6D-D3A9-4525-A4D5-A50D4E20D487}" dt="2026-07-29T13:46:55.803" v="3027"/>
+          <ac:spMkLst>
+            <pc:docMk/>
+            <pc:sldMk cId="0" sldId="278"/>
+            <ac:spMk id="5" creationId="{00000000-0000-0000-0000-000000000000}"/>
+          </ac:spMkLst>
+        </pc:spChg>
+        <pc:spChg chg="del">
+          <ac:chgData name="Dmitriy Ratushny" userId="08050032e8047aee" providerId="LiveId" clId="{78EB1A6D-D3A9-4525-A4D5-A50D4E20D487}" dt="2026-07-29T12:58:11.629" v="2607" actId="478"/>
+          <ac:spMkLst>
+            <pc:docMk/>
+            <pc:sldMk cId="0" sldId="278"/>
+            <ac:spMk id="6" creationId="{00000000-0000-0000-0000-000000000000}"/>
+          </ac:spMkLst>
+        </pc:spChg>
+        <pc:graphicFrameChg chg="add del mod modGraphic">
+          <ac:chgData name="Dmitriy Ratushny" userId="08050032e8047aee" providerId="LiveId" clId="{78EB1A6D-D3A9-4525-A4D5-A50D4E20D487}" dt="2026-07-29T12:52:27.964" v="2531" actId="478"/>
+          <ac:graphicFrameMkLst>
+            <pc:docMk/>
+            <pc:sldMk cId="0" sldId="278"/>
+            <ac:graphicFrameMk id="7" creationId="{8F69452C-4A1F-7480-655D-B13E379593C2}"/>
+          </ac:graphicFrameMkLst>
+        </pc:graphicFrameChg>
+        <pc:picChg chg="mod modCrop">
+          <ac:chgData name="Dmitriy Ratushny" userId="08050032e8047aee" providerId="LiveId" clId="{78EB1A6D-D3A9-4525-A4D5-A50D4E20D487}" dt="2026-07-29T13:01:20.506" v="2689" actId="1076"/>
+          <ac:picMkLst>
+            <pc:docMk/>
+            <pc:sldMk cId="0" sldId="278"/>
+            <ac:picMk id="4" creationId="{00000000-0000-0000-0000-000000000000}"/>
+          </ac:picMkLst>
+        </pc:picChg>
       </pc:sldChg>
     </pc:docChg>
   </pc:docChgLst>
@@ -1079,7 +1360,7 @@
           <a:lstStyle/>
           <a:p>
             <a:r>
-              <a:t>Replaces the three bar charts. Bars of churn rate invited exactly the comparison the slide argues against — a viewer saw Cybersecurity at 0.09 against DevTools at 0.41 and read a threefold effect, when it is two churners out of twenty-three.</a:t>
+              <a:t>Replaces both the bar charts and an earlier version built on confidence intervals. Intervals show precision but do not perform the test, and reading significance off whether they cross a line disagreed with the actual test — Cybersecurity's interval excluded the base rate while industry sat at p = 0.08.</a:t>
             </a:r>
           </a:p>
           <a:p>
@@ -1087,7 +1368,7 @@
           </a:p>
           <a:p>
             <a:r>
-              <a:t>Volunteer Cybersecurity rather than waiting to be asked. Producing the one result that looks significant, and showing it is what 22 comparisons produce on their own, is the same move as the generator null later in the deck.</a:t>
+              <a:t>This does the test directly, with no formula and no distributional assumption. Shuffle the labels, keep the group sizes, recompute the statistic, repeat.</a:t>
             </a:r>
           </a:p>
           <a:p>
@@ -1095,7 +1376,7 @@
           </a:p>
           <a:p>
             <a:r>
-              <a:t>IF ASKED HOW THE LINES ARE CALCULATED. They are Wilson intervals. The question they answer is 'which true churn rates could have produced what I saw'. For Cybersecurity we saw 2 of 23. A true rate of 5% produces that easily, 25% produces it occasionally, 45% almost never — so the line runs 2% to 27%.</a:t>
+              <a:t>The last row is the slide. Industry at p = 0.03 is exactly the finding I would have reported if I had stopped there, and it is the same mistake the deck later catches on the calendar-hazard result: testing against the wrong null. Volunteer it rather than waiting to be asked.</a:t>
             </a:r>
           </a:p>
           <a:p>
@@ -1103,7 +1384,7 @@
           </a:p>
           <a:p>
             <a:r>
-              <a:t>The textbook version is p +/- 2 x sqrt(p(1-p)/n), and it breaks here: for Cybersecurity it returns -3% to 21%, a negative churn rate, and for Canada with 0 of 6 it returns 0% to 0%, claiming certainty from six customers. Wilson is the same idea done properly and cannot leave the 0 to 1 range. Standard choice at these group sizes.</a:t>
+              <a:t>The last five variables come from subscriptions, the one table with internal rules, so a null there carries more weight than a null in the tables already known to be scrambled.</a:t>
             </a:r>
           </a:p>
           <a:p>
@@ -1111,15 +1392,7 @@
           </a:p>
           <a:p>
             <a:r>
-              <a:t>Width is driven by n under a square root, so quadrupling the group halves the line: CA at n=6 spans +/-0.20, Cybersecurity at n=23 +/-0.12, the US at n=100 +/-0.09.</a:t>
-            </a:r>
-          </a:p>
-          <a:p>
-            <a:endParaRPr/>
-          </a:p>
-          <a:p>
-            <a:r>
-              <a:t>Chi-square p-values: industry 0.079, referral 0.086, plan 0.837, country 0.428, trial 0.548. The figure is built by build/fig_segment_forest.py.</a:t>
+              <a:t>Per-variable p: industry 0.033, contract size 0.058, company size 0.098, tenure 0.118, referral 0.136, country 0.501, trial 0.543, billing 0.751, plan 0.863, downgrade 1.000. Family-wise 0.262 from 20,000 shuffles, seed 0, at the 30 June 2024 cutoff. Built by build/fig_segment_shuffle_html.py.</a:t>
             </a:r>
           </a:p>
         </p:txBody>
@@ -4444,9 +4717,164 @@
           </a:p>
         </p:txBody>
       </p:sp>
+      <p:sp>
+        <p:nvSpPr>
+          <p:cNvPr id="5" name="TextBox 4"/>
+          <p:cNvSpPr txBox="1"/>
+          <p:nvPr/>
+        </p:nvSpPr>
+        <p:spPr>
+          <a:xfrm>
+            <a:off x="6918158" y="4035339"/>
+            <a:ext cx="4521563" cy="1777410"/>
+          </a:xfrm>
+          <a:prstGeom prst="rect">
+            <a:avLst/>
+          </a:prstGeom>
+          <a:noFill/>
+        </p:spPr>
+        <p:txBody>
+          <a:bodyPr wrap="square">
+            <a:spAutoFit/>
+          </a:bodyPr>
+          <a:lstStyle/>
+          <a:p>
+            <a:pPr>
+              <a:spcAft>
+                <a:spcPts val="900"/>
+              </a:spcAft>
+            </a:pPr>
+            <a:r>
+              <a:rPr sz="1350" b="1" i="0" dirty="0">
+                <a:solidFill>
+                  <a:srgbClr val="1A1A1A"/>
+                </a:solidFill>
+                <a:latin typeface="Calibri"/>
+              </a:rPr>
+              <a:t>I start with a model that uses no features at all. It has to score </a:t>
+            </a:r>
+            <a:r>
+              <a:rPr lang="en-US" sz="1350" b="1" i="0" dirty="0">
+                <a:solidFill>
+                  <a:srgbClr val="1A1A1A"/>
+                </a:solidFill>
+                <a:latin typeface="Calibri"/>
+              </a:rPr>
+              <a:t>ROC-AUC </a:t>
+            </a:r>
+            <a:r>
+              <a:rPr sz="1350" b="1" i="0" dirty="0">
+                <a:solidFill>
+                  <a:srgbClr val="1A1A1A"/>
+                </a:solidFill>
+                <a:latin typeface="Calibri"/>
+              </a:rPr>
+              <a:t>0.5. </a:t>
+            </a:r>
+            <a:r>
+              <a:rPr lang="en-US" sz="1350" b="1" i="0" dirty="0">
+                <a:solidFill>
+                  <a:srgbClr val="1A1A1A"/>
+                </a:solidFill>
+                <a:latin typeface="Calibri"/>
+              </a:rPr>
+              <a:t>Use this </a:t>
+            </a:r>
+            <a:r>
+              <a:rPr sz="1350" b="1" i="0" dirty="0">
+                <a:solidFill>
+                  <a:srgbClr val="1A1A1A"/>
+                </a:solidFill>
+                <a:latin typeface="Calibri"/>
+              </a:rPr>
+              <a:t>floor </a:t>
+            </a:r>
+            <a:r>
+              <a:rPr lang="en-US" sz="1350" b="1" i="0" dirty="0">
+                <a:solidFill>
+                  <a:srgbClr val="1A1A1A"/>
+                </a:solidFill>
+                <a:latin typeface="Calibri"/>
+              </a:rPr>
+              <a:t>to contrast better models</a:t>
+            </a:r>
+            <a:r>
+              <a:rPr sz="1350" b="1" i="0" dirty="0">
+                <a:solidFill>
+                  <a:srgbClr val="1A1A1A"/>
+                </a:solidFill>
+                <a:latin typeface="Calibri"/>
+              </a:rPr>
+              <a:t>. </a:t>
+            </a:r>
+            <a:endParaRPr lang="en-US" sz="1350" b="1" i="0" dirty="0">
+              <a:solidFill>
+                <a:srgbClr val="1A1A1A"/>
+              </a:solidFill>
+              <a:latin typeface="Calibri"/>
+            </a:endParaRPr>
+          </a:p>
+          <a:p>
+            <a:pPr>
+              <a:spcAft>
+                <a:spcPts val="900"/>
+              </a:spcAft>
+            </a:pPr>
+            <a:r>
+              <a:rPr sz="1350" b="1" i="0" dirty="0">
+                <a:solidFill>
+                  <a:srgbClr val="1A1A1A"/>
+                </a:solidFill>
+                <a:latin typeface="Calibri"/>
+              </a:rPr>
+              <a:t>Then I add complexity one step at a time: a single</a:t>
+            </a:r>
+            <a:r>
+              <a:rPr lang="en-US" sz="1350" b="1" i="0" dirty="0">
+                <a:solidFill>
+                  <a:srgbClr val="1A1A1A"/>
+                </a:solidFill>
+                <a:latin typeface="Calibri"/>
+              </a:rPr>
+              <a:t> decision stump</a:t>
+            </a:r>
+            <a:r>
+              <a:rPr sz="1350" b="1" i="0" dirty="0">
+                <a:solidFill>
+                  <a:srgbClr val="1A1A1A"/>
+                </a:solidFill>
+                <a:latin typeface="Calibri"/>
+              </a:rPr>
+              <a:t> rule, then logistic regression, then a random forest, then three gradient boosting models.</a:t>
+            </a:r>
+          </a:p>
+          <a:p>
+            <a:pPr>
+              <a:spcAft>
+                <a:spcPts val="900"/>
+              </a:spcAft>
+            </a:pPr>
+            <a:r>
+              <a:rPr sz="1350" b="0" i="0" dirty="0">
+                <a:solidFill>
+                  <a:srgbClr val="5A6270"/>
+                </a:solidFill>
+                <a:latin typeface="Calibri"/>
+              </a:rPr>
+              <a:t>Every model is tested on exactly the same splits, so the comparison is fair. </a:t>
+            </a:r>
+          </a:p>
+        </p:txBody>
+      </p:sp>
       <p:pic>
         <p:nvPicPr>
-          <p:cNvPr id="4" name="Picture 3" descr="04_model_ladder.png"/>
+          <p:cNvPr id="9" name="Picture 8" descr="03_how_the_range_is_made_html.png">
+            <a:extLst>
+              <a:ext uri="{FF2B5EF4-FFF2-40B4-BE49-F238E27FC236}">
+                <a16:creationId xmlns:a16="http://schemas.microsoft.com/office/drawing/2014/main" id="{EE34B78E-69C8-C210-CBE4-DCFCFA91AFED}"/>
+              </a:ext>
+            </a:extLst>
+          </p:cNvPr>
           <p:cNvPicPr>
             <a:picLocks noChangeAspect="1"/>
           </p:cNvPicPr>
@@ -4460,69 +4888,44 @@
         </p:blipFill>
         <p:spPr>
           <a:xfrm>
-            <a:off x="2836454" y="1645920"/>
-            <a:ext cx="6518787" cy="3200400"/>
+            <a:off x="1654342" y="1225411"/>
+            <a:ext cx="9326880" cy="2331720"/>
           </a:xfrm>
           <a:prstGeom prst="rect">
             <a:avLst/>
           </a:prstGeom>
         </p:spPr>
       </p:pic>
-      <p:sp>
-        <p:nvSpPr>
-          <p:cNvPr id="5" name="TextBox 4"/>
-          <p:cNvSpPr txBox="1"/>
+      <p:pic>
+        <p:nvPicPr>
+          <p:cNvPr id="11" name="Picture 10">
+            <a:extLst>
+              <a:ext uri="{FF2B5EF4-FFF2-40B4-BE49-F238E27FC236}">
+                <a16:creationId xmlns:a16="http://schemas.microsoft.com/office/drawing/2014/main" id="{AD950E2A-4BCA-F823-06CD-8AE5F2C59ADE}"/>
+              </a:ext>
+            </a:extLst>
+          </p:cNvPr>
+          <p:cNvPicPr>
+            <a:picLocks noChangeAspect="1"/>
+          </p:cNvPicPr>
           <p:nvPr/>
-        </p:nvSpPr>
+        </p:nvPicPr>
+        <p:blipFill>
+          <a:blip r:embed="rId3"/>
+          <a:stretch>
+            <a:fillRect/>
+          </a:stretch>
+        </p:blipFill>
         <p:spPr>
           <a:xfrm>
-            <a:off x="685800" y="4846320"/>
-            <a:ext cx="10820095" cy="4572000"/>
+            <a:off x="239930" y="3758184"/>
+            <a:ext cx="6321289" cy="2331721"/>
           </a:xfrm>
           <a:prstGeom prst="rect">
             <a:avLst/>
           </a:prstGeom>
-          <a:noFill/>
         </p:spPr>
-        <p:txBody>
-          <a:bodyPr wrap="square">
-            <a:spAutoFit/>
-          </a:bodyPr>
-          <a:lstStyle/>
-          <a:p>
-            <a:pPr>
-              <a:spcAft>
-                <a:spcPts val="900"/>
-              </a:spcAft>
-            </a:pPr>
-            <a:r>
-              <a:rPr sz="1350" b="1" i="0">
-                <a:solidFill>
-                  <a:srgbClr val="1A1A1A"/>
-                </a:solidFill>
-                <a:latin typeface="Calibri"/>
-              </a:rPr>
-              <a:t>I start with a model that uses no features at all. It has to score 0.5. Without that floor you cannot tell whether a real model is doing anything. Then I add complexity one step at a time: a single rule, then logistic regression, then a random forest, then three gradient boosting models.</a:t>
-            </a:r>
-          </a:p>
-          <a:p>
-            <a:pPr>
-              <a:spcAft>
-                <a:spcPts val="900"/>
-              </a:spcAft>
-            </a:pPr>
-            <a:r>
-              <a:rPr sz="1350" b="0" i="0">
-                <a:solidFill>
-                  <a:srgbClr val="5A6270"/>
-                </a:solidFill>
-                <a:latin typeface="Calibri"/>
-              </a:rPr>
-              <a:t>Every model is tested on exactly the same splits, so the comparison is fair. The boosting models get their preferred treatment of missing values and categories. With only 177 customers, the simple regularised model still wins.</a:t>
-            </a:r>
-          </a:p>
-        </p:txBody>
-      </p:sp>
+      </p:pic>
     </p:spTree>
   </p:cSld>
   <p:clrMapOvr>
@@ -4557,7 +4960,7 @@
         <p:spPr>
           <a:xfrm>
             <a:off x="685800" y="365760"/>
-            <a:ext cx="10820095" cy="1051560"/>
+            <a:ext cx="10820095" cy="759182"/>
           </a:xfrm>
           <a:prstGeom prst="rect">
             <a:avLst/>
@@ -4571,7 +4974,7 @@
           <a:lstStyle/>
           <a:p>
             <a:r>
-              <a:rPr sz="1200" b="1" i="0">
+              <a:rPr sz="1200" b="1" i="0" dirty="0">
                 <a:solidFill>
                   <a:srgbClr val="5A6270"/>
                 </a:solidFill>
@@ -4587,13 +4990,8 @@
               </a:spcBef>
             </a:pPr>
             <a:r>
-              <a:rPr sz="2800" b="1" i="0">
-                <a:solidFill>
-                  <a:srgbClr val="B02E2E"/>
-                </a:solidFill>
-                <a:latin typeface="Calibri"/>
-              </a:rPr>
-              <a:t>How it performs, and why the number is low</a:t>
+              <a:rPr lang="en-US" sz="2800" b="1" dirty="0"/>
+              <a:t>Evaluate Performance</a:t>
             </a:r>
           </a:p>
         </p:txBody>
@@ -4676,7 +5074,7 @@
         <p:spPr>
           <a:xfrm>
             <a:off x="685800" y="1783080"/>
-            <a:ext cx="5760720" cy="4572000"/>
+            <a:ext cx="5760720" cy="1284967"/>
           </a:xfrm>
           <a:prstGeom prst="rect">
             <a:avLst/>
@@ -4695,14 +5093,19 @@
               </a:spcAft>
             </a:pPr>
             <a:r>
-              <a:rPr sz="1300" b="0" i="0">
+              <a:rPr lang="en-US" sz="1300" dirty="0">
                 <a:solidFill>
                   <a:srgbClr val="5A6270"/>
                 </a:solidFill>
-                <a:latin typeface="Calibri"/>
-              </a:rPr>
-              <a:t>Best single model, taken at face value:  AUC 0.583</a:t>
-            </a:r>
+              </a:rPr>
+              <a:t>AUC measures how well the model sorts customers by risk. A coin flip scores 0.50. A perfect model scores 1.00</a:t>
+            </a:r>
+            <a:endParaRPr lang="en-US" sz="1300" dirty="0">
+              <a:solidFill>
+                <a:srgbClr val="5A6270"/>
+              </a:solidFill>
+              <a:latin typeface="Calibri"/>
+            </a:endParaRPr>
           </a:p>
           <a:p>
             <a:pPr>
@@ -4711,93 +5114,51 @@
               </a:spcAft>
             </a:pPr>
             <a:r>
-              <a:rPr sz="1300" b="1" i="0">
+              <a:rPr lang="en-US" sz="1300" dirty="0">
+                <a:solidFill>
+                  <a:srgbClr val="5A6270"/>
+                </a:solidFill>
+              </a:rPr>
+              <a:t>Coin flip · 0.500</a:t>
+            </a:r>
+          </a:p>
+          <a:p>
+            <a:pPr>
+              <a:spcAft>
+                <a:spcPts val="500"/>
+              </a:spcAft>
+            </a:pPr>
+            <a:r>
+              <a:rPr lang="en-US" sz="1300" dirty="0">
+                <a:solidFill>
+                  <a:srgbClr val="5A6270"/>
+                </a:solidFill>
+              </a:rPr>
+              <a:t>Our best model · 0.583</a:t>
+            </a:r>
+          </a:p>
+          <a:p>
+            <a:pPr>
+              <a:spcAft>
+                <a:spcPts val="500"/>
+              </a:spcAft>
+            </a:pPr>
+            <a:r>
+              <a:rPr lang="en-US" sz="1300" dirty="0">
+                <a:solidFill>
+                  <a:srgbClr val="5A6270"/>
+                </a:solidFill>
+              </a:rPr>
+              <a:t>Our best model, corrected · 0.534</a:t>
+            </a:r>
+            <a:r>
+              <a:rPr sz="600" b="0" i="0" dirty="0">
                 <a:solidFill>
                   <a:srgbClr val="1A1A1A"/>
                 </a:solidFill>
                 <a:latin typeface="Calibri"/>
               </a:rPr>
-              <a:t>The honest score:  AUC 0.534, give or take 0.016</a:t>
-            </a:r>
-          </a:p>
-          <a:p>
-            <a:pPr>
-              <a:spcAft>
-                <a:spcPts val="500"/>
-              </a:spcAft>
-            </a:pPr>
-            <a:r>
-              <a:rPr sz="1300" b="0" i="0">
-                <a:solidFill>
-                  <a:srgbClr val="5A6270"/>
-                </a:solidFill>
-                <a:latin typeface="Calibri"/>
-              </a:rPr>
-              <a:t>Guessing:  AUC 0.500</a:t>
-            </a:r>
-          </a:p>
-          <a:p>
-            <a:pPr>
-              <a:spcAft>
-                <a:spcPts val="500"/>
-              </a:spcAft>
-            </a:pPr>
-            <a:r>
-              <a:rPr sz="600" b="0" i="0">
-                <a:solidFill>
-                  <a:srgbClr val="1A1A1A"/>
-                </a:solidFill>
-                <a:latin typeface="Calibri"/>
-              </a:rPr>
               <a:t> </a:t>
-            </a:r>
-          </a:p>
-          <a:p>
-            <a:pPr>
-              <a:spcAft>
-                <a:spcPts val="500"/>
-              </a:spcAft>
-            </a:pPr>
-            <a:r>
-              <a:rPr sz="1300" b="1" i="0">
-                <a:solidFill>
-                  <a:srgbClr val="B02E2E"/>
-                </a:solidFill>
-                <a:latin typeface="Calibri"/>
-              </a:rPr>
-              <a:t>Picking the best of ten models is itself a form of fitting.</a:t>
-            </a:r>
-          </a:p>
-          <a:p>
-            <a:pPr lvl="1">
-              <a:spcAft>
-                <a:spcPts val="500"/>
-              </a:spcAft>
-            </a:pPr>
-            <a:r>
-              <a:rPr sz="1100" b="0" i="0">
-                <a:solidFill>
-                  <a:srgbClr val="5A6270"/>
-                </a:solidFill>
-                <a:latin typeface="Calibri"/>
-              </a:rPr>
-              <a:t>Measure that properly and 0.049 of AUC disappears — most of what looked like signal. The chart is why: run the same ten-model search against shuffled labels and the whole distribution slides right, past our result.</a:t>
-            </a:r>
-          </a:p>
-          <a:p>
-            <a:pPr lvl="1">
-              <a:spcAft>
-                <a:spcPts val="500"/>
-              </a:spcAft>
-            </a:pPr>
-            <a:r>
-              <a:rPr sz="1100" b="0" i="0">
-                <a:solidFill>
-                  <a:srgbClr val="5A6270"/>
-                </a:solidFill>
-                <a:latin typeface="Calibri"/>
-              </a:rPr>
-              <a:t>Across 25 rounds, eight of the ten models won at least once. A genuinely better model wins nearly every time.</a:t>
             </a:r>
           </a:p>
         </p:txBody>
@@ -4810,8 +5171,8 @@
         </p:nvSpPr>
         <p:spPr>
           <a:xfrm>
-            <a:off x="685800" y="4315968"/>
-            <a:ext cx="10820095" cy="4572000"/>
+            <a:off x="685800" y="3363920"/>
+            <a:ext cx="5197643" cy="1469633"/>
           </a:xfrm>
           <a:prstGeom prst="rect">
             <a:avLst/>
@@ -4830,75 +5191,89 @@
               </a:spcAft>
             </a:pPr>
             <a:r>
-              <a:rPr sz="1300" b="1" i="0">
-                <a:solidFill>
-                  <a:srgbClr val="1A1A1A"/>
-                </a:solidFill>
-                <a:latin typeface="Calibri"/>
-              </a:rPr>
-              <a:t>Why the score is low. Each cause is measured, not guessed at.</a:t>
-            </a:r>
-          </a:p>
-          <a:p>
-            <a:pPr lvl="1">
+              <a:rPr lang="en-US" sz="1100" b="1" dirty="0">
+                <a:solidFill>
+                  <a:srgbClr val="5A6270"/>
+                </a:solidFill>
+              </a:rPr>
+              <a:t>Why the 0.583 is not a realistic measure</a:t>
+            </a:r>
+          </a:p>
+          <a:p>
+            <a:pPr marL="228600" indent="-228600">
               <a:spcAft>
                 <a:spcPts val="500"/>
               </a:spcAft>
-            </a:pPr>
-            <a:r>
-              <a:rPr sz="1100" b="0" i="0">
+              <a:buFont typeface="+mj-lt"/>
+              <a:buAutoNum type="arabicPeriod"/>
+            </a:pPr>
+            <a:r>
+              <a:rPr lang="en-US" sz="1100" dirty="0">
                 <a:solidFill>
                   <a:srgbClr val="5A6270"/>
                 </a:solidFill>
-                <a:latin typeface="Calibri"/>
-              </a:rPr>
-              <a:t>The inputs hold nothing. Usage and ticket dates are scattered at random across the two years and match their own customer's signup date at r = 0.002 and r = 0.014. Inside those tables, priority does not predict how fast we answered and plan does not predict how much people used.</a:t>
-            </a:r>
-          </a:p>
-          <a:p>
-            <a:pPr lvl="1">
+              </a:rPr>
+              <a:t>I tried ten models and reported the best one. </a:t>
+            </a:r>
+          </a:p>
+          <a:p>
+            <a:pPr marL="228600" indent="-228600">
               <a:spcAft>
                 <a:spcPts val="500"/>
               </a:spcAft>
-            </a:pPr>
-            <a:r>
-              <a:rPr sz="1100" b="0" i="0">
+              <a:buFont typeface="+mj-lt"/>
+              <a:buAutoNum type="arabicPeriod"/>
+            </a:pPr>
+            <a:r>
+              <a:rPr lang="en-US" sz="1100" dirty="0">
                 <a:solidFill>
                   <a:srgbClr val="5A6270"/>
                 </a:solidFill>
-                <a:latin typeface="Calibri"/>
-              </a:rPr>
-              <a:t>The target is a random date — a coin toss between the day the customer joined and the last day of the file. Slide 11 is that test. Subscriptions is the one table with real rules, and none of it relates to churn.</a:t>
-            </a:r>
-          </a:p>
-          <a:p>
-            <a:pPr lvl="1">
+              </a:rPr>
+              <a:t>To measure how much, I shuffled the labels so there was genuinely nothing to learn, then ran the same ten-model search. Its winner scored 0.594 — higher than ours. Our number is what noise produces when you pick a winner from ten.</a:t>
+            </a:r>
+          </a:p>
+          <a:p>
+            <a:pPr marL="228600" indent="-228600">
               <a:spcAft>
                 <a:spcPts val="500"/>
               </a:spcAft>
-            </a:pPr>
-            <a:r>
-              <a:rPr sz="1100" b="0" i="0">
+              <a:buFont typeface="+mj-lt"/>
+              <a:buAutoNum type="arabicPeriod"/>
+            </a:pPr>
+            <a:r>
+              <a:rPr lang="en-US" sz="1100" dirty="0">
                 <a:solidFill>
                   <a:srgbClr val="5A6270"/>
                 </a:solidFill>
-                <a:latin typeface="Calibri"/>
-              </a:rPr>
-              <a:t>Sample size is real but secondary: 54 churners against 73 features. It is not leakage, not the feature build, and not tuning. I checked all three.</a:t>
-            </a:r>
-          </a:p>
-        </p:txBody>
-      </p:sp>
-      <p:sp>
-        <p:nvSpPr>
-          <p:cNvPr id="7" name="TextBox 6"/>
+              </a:rPr>
+              <a:t>A second check says the same thing: across 25 repeats, eight of the ten models won at least once. A genuinely better model wins nearly every time.</a:t>
+            </a:r>
+            <a:endParaRPr sz="1100" b="0" i="0" dirty="0">
+              <a:solidFill>
+                <a:srgbClr val="5A6270"/>
+              </a:solidFill>
+              <a:latin typeface="Calibri"/>
+            </a:endParaRPr>
+          </a:p>
+        </p:txBody>
+      </p:sp>
+      <p:sp>
+        <p:nvSpPr>
+          <p:cNvPr id="8" name="TextBox 7">
+            <a:extLst>
+              <a:ext uri="{FF2B5EF4-FFF2-40B4-BE49-F238E27FC236}">
+                <a16:creationId xmlns:a16="http://schemas.microsoft.com/office/drawing/2014/main" id="{12C611BC-1707-F619-DD30-259262FFA0D2}"/>
+              </a:ext>
+            </a:extLst>
+          </p:cNvPr>
           <p:cNvSpPr txBox="1"/>
           <p:nvPr/>
         </p:nvSpPr>
         <p:spPr>
           <a:xfrm>
-            <a:off x="685800" y="6126480"/>
-            <a:ext cx="10820095" cy="502920"/>
+            <a:off x="7044488" y="4142012"/>
+            <a:ext cx="3979931" cy="1569660"/>
           </a:xfrm>
           <a:prstGeom prst="rect">
             <a:avLst/>
@@ -4906,19 +5281,39 @@
           <a:noFill/>
         </p:spPr>
         <p:txBody>
-          <a:bodyPr wrap="square">
+          <a:bodyPr wrap="square" rtlCol="0">
             <a:spAutoFit/>
           </a:bodyPr>
           <a:lstStyle/>
           <a:p>
             <a:r>
-              <a:rPr sz="1150" b="0" i="1">
-                <a:solidFill>
-                  <a:srgbClr val="1A1A1A"/>
-                </a:solidFill>
-                <a:latin typeface="Calibri"/>
-              </a:rPr>
-              <a:t>Scores are ROC-AUC: 0.50 is guessing, 1.00 is perfect. I confirmed the pipeline works by planting targets of known strength — a strong one scores AUC 0.965, a deliberately weak one 0.584, a meaningless one 0.494. The method works. AUC 0.534 is the right answer to the question this data can be asked.</a:t>
+              <a:rPr lang="en-US" sz="1200" b="1" dirty="0">
+                <a:solidFill>
+                  <a:srgbClr val="9FD2CC"/>
+                </a:solidFill>
+              </a:rPr>
+              <a:t>Green</a:t>
+            </a:r>
+            <a:r>
+              <a:rPr lang="en-US" sz="1200" dirty="0"/>
+              <a:t> = every model, scored on shuffled labels. 20 shuffles × 15 models = 300 scores, all plotted. Mean 0.498 — pure chance, which is correct, since the labels were effectively removed</a:t>
+            </a:r>
+          </a:p>
+          <a:p>
+            <a:endParaRPr lang="en-US" sz="1200" dirty="0"/>
+          </a:p>
+          <a:p>
+            <a:r>
+              <a:rPr lang="en-US" sz="1200" b="1" dirty="0">
+                <a:solidFill>
+                  <a:srgbClr val="D6C782"/>
+                </a:solidFill>
+              </a:rPr>
+              <a:t>Orange</a:t>
+            </a:r>
+            <a:r>
+              <a:rPr lang="en-US" sz="1200" dirty="0"/>
+              <a:t> = the winner from each shuffle. For each of the 20 shuffles, take only the best of the 15 models. 20 values. Mean 0.566, reaching 0.624.</a:t>
             </a:r>
           </a:p>
         </p:txBody>
@@ -4957,7 +5352,7 @@
         <p:spPr>
           <a:xfrm>
             <a:off x="685800" y="365760"/>
-            <a:ext cx="10820095" cy="1051560"/>
+            <a:ext cx="10820095" cy="759182"/>
           </a:xfrm>
           <a:prstGeom prst="rect">
             <a:avLst/>
@@ -4971,7 +5366,7 @@
           <a:lstStyle/>
           <a:p>
             <a:r>
-              <a:rPr sz="1200" b="1" i="0">
+              <a:rPr sz="1200" b="1" i="0" dirty="0">
                 <a:solidFill>
                   <a:srgbClr val="5A6270"/>
                 </a:solidFill>
@@ -4987,13 +5382,31 @@
               </a:spcBef>
             </a:pPr>
             <a:r>
-              <a:rPr sz="2800" b="1" i="0">
+              <a:rPr sz="2800" b="1" i="0" dirty="0">
                 <a:solidFill>
                   <a:srgbClr val="1A1A1A"/>
                 </a:solidFill>
                 <a:latin typeface="Calibri"/>
               </a:rPr>
-              <a:t>Class imbalance, and what leakage is worth</a:t>
+              <a:t>Class imbalance</a:t>
+            </a:r>
+            <a:r>
+              <a:rPr lang="en-US" sz="2800" b="1" i="0" dirty="0">
+                <a:solidFill>
+                  <a:srgbClr val="1A1A1A"/>
+                </a:solidFill>
+                <a:latin typeface="Calibri"/>
+              </a:rPr>
+              <a:t> and </a:t>
+            </a:r>
+            <a:r>
+              <a:rPr sz="2800" b="1" i="0" dirty="0">
+                <a:solidFill>
+                  <a:srgbClr val="1A1A1A"/>
+                </a:solidFill>
+                <a:latin typeface="Calibri"/>
+              </a:rPr>
+              <a:t>leakage</a:t>
             </a:r>
           </a:p>
         </p:txBody>
@@ -5076,7 +5489,7 @@
         <p:spPr>
           <a:xfrm>
             <a:off x="685800" y="1737360"/>
-            <a:ext cx="5486400" cy="4572000"/>
+            <a:ext cx="5486400" cy="3185487"/>
           </a:xfrm>
           <a:prstGeom prst="rect">
             <a:avLst/>
@@ -5095,7 +5508,7 @@
               </a:spcAft>
             </a:pPr>
             <a:r>
-              <a:rPr sz="1350" b="1" i="0">
+              <a:rPr sz="1350" b="1" i="0" dirty="0">
                 <a:solidFill>
                   <a:srgbClr val="1A1A1A"/>
                 </a:solidFill>
@@ -5111,7 +5524,7 @@
               </a:spcAft>
             </a:pPr>
             <a:r>
-              <a:rPr sz="1150" b="0" i="0">
+              <a:rPr sz="1150" b="0" i="0" dirty="0">
                 <a:solidFill>
                   <a:srgbClr val="5A6270"/>
                 </a:solidFill>
@@ -5127,13 +5540,67 @@
               </a:spcAft>
             </a:pPr>
             <a:r>
-              <a:rPr sz="1150" b="0" i="0">
+              <a:rPr sz="1150" b="0" i="0" dirty="0">
                 <a:solidFill>
                   <a:srgbClr val="5A6270"/>
                 </a:solidFill>
                 <a:latin typeface="Calibri"/>
               </a:rPr>
-              <a:t>I set the cut-off to favour catching leavers, because missing one costs far more than a wasted phone call. That gives 75% of leavers caught, and 1 in 3 of the flagged customers actually leaving.</a:t>
+              <a:t>I set the cut-off to </a:t>
+            </a:r>
+            <a:r>
+              <a:rPr sz="1150" b="0" i="0" dirty="0" err="1">
+                <a:solidFill>
+                  <a:srgbClr val="5A6270"/>
+                </a:solidFill>
+                <a:latin typeface="Calibri"/>
+              </a:rPr>
+              <a:t>favour</a:t>
+            </a:r>
+            <a:r>
+              <a:rPr sz="1150" b="0" i="0" dirty="0">
+                <a:solidFill>
+                  <a:srgbClr val="5A6270"/>
+                </a:solidFill>
+                <a:latin typeface="Calibri"/>
+              </a:rPr>
+              <a:t> catching </a:t>
+            </a:r>
+            <a:r>
+              <a:rPr lang="en-US" sz="1150" b="0" i="0" dirty="0">
+                <a:solidFill>
+                  <a:srgbClr val="5A6270"/>
+                </a:solidFill>
+                <a:latin typeface="Calibri"/>
+              </a:rPr>
+              <a:t>customers who churned</a:t>
+            </a:r>
+            <a:r>
+              <a:rPr sz="1150" b="0" i="0" dirty="0">
+                <a:solidFill>
+                  <a:srgbClr val="5A6270"/>
+                </a:solidFill>
+                <a:latin typeface="Calibri"/>
+              </a:rPr>
+              <a:t>, because missing one costs far more than a wasted phone call. That gives 75% of </a:t>
+            </a:r>
+            <a:r>
+              <a:rPr lang="en-US" sz="1150" b="0" i="0" dirty="0">
+                <a:solidFill>
+                  <a:srgbClr val="5A6270"/>
+                </a:solidFill>
+                <a:latin typeface="Calibri"/>
+              </a:rPr>
+              <a:t>customers who churned</a:t>
+            </a:r>
+            <a:r>
+              <a:rPr sz="1150" b="0" i="0" dirty="0">
+                <a:solidFill>
+                  <a:srgbClr val="5A6270"/>
+                </a:solidFill>
+                <a:latin typeface="Calibri"/>
+              </a:rPr>
+              <a:t> caught, and 1 in 3 of the flagged customers actually leaving.</a:t>
             </a:r>
           </a:p>
           <a:p>
@@ -5143,7 +5610,7 @@
               </a:spcAft>
             </a:pPr>
             <a:r>
-              <a:rPr sz="1150" b="0" i="0">
+              <a:rPr sz="1150" b="0" i="0" dirty="0">
                 <a:solidFill>
                   <a:srgbClr val="5A6270"/>
                 </a:solidFill>
@@ -5159,7 +5626,7 @@
               </a:spcAft>
             </a:pPr>
             <a:r>
-              <a:rPr sz="600" b="0" i="0">
+              <a:rPr sz="600" b="0" i="0" dirty="0">
                 <a:solidFill>
                   <a:srgbClr val="1A1A1A"/>
                 </a:solidFill>
@@ -5175,7 +5642,7 @@
               </a:spcAft>
             </a:pPr>
             <a:r>
-              <a:rPr sz="1350" b="1" i="0">
+              <a:rPr sz="1350" b="1" i="0" dirty="0">
                 <a:solidFill>
                   <a:srgbClr val="B02E2E"/>
                 </a:solidFill>
@@ -5191,7 +5658,7 @@
               </a:spcAft>
             </a:pPr>
             <a:r>
-              <a:rPr sz="1150" b="0" i="0">
+              <a:rPr sz="1150" b="0" i="0" dirty="0">
                 <a:solidFill>
                   <a:srgbClr val="5A6270"/>
                 </a:solidFill>
@@ -5270,7 +5737,7 @@
         <p:spPr>
           <a:xfrm>
             <a:off x="685800" y="365760"/>
-            <a:ext cx="10820095" cy="1051560"/>
+            <a:ext cx="10820095" cy="759182"/>
           </a:xfrm>
           <a:prstGeom prst="rect">
             <a:avLst/>
@@ -5284,7 +5751,7 @@
           <a:lstStyle/>
           <a:p>
             <a:r>
-              <a:rPr sz="1200" b="1" i="0">
+              <a:rPr sz="1200" b="1" i="0" dirty="0">
                 <a:solidFill>
                   <a:srgbClr val="5A6270"/>
                 </a:solidFill>
@@ -5300,13 +5767,13 @@
               </a:spcBef>
             </a:pPr>
             <a:r>
-              <a:rPr sz="2800" b="1" i="0">
-                <a:solidFill>
-                  <a:srgbClr val="2E5F8A"/>
-                </a:solidFill>
-                <a:latin typeface="Calibri"/>
-              </a:rPr>
-              <a:t>Interpretability, and how it can mislead you</a:t>
+              <a:rPr sz="2800" b="1" dirty="0">
+                <a:solidFill>
+                  <a:srgbClr val="1A1A1A"/>
+                </a:solidFill>
+                <a:latin typeface="Calibri"/>
+              </a:rPr>
+              <a:t>Interpretability</a:t>
             </a:r>
           </a:p>
         </p:txBody>
@@ -5519,7 +5986,7 @@
         <p:spPr>
           <a:xfrm>
             <a:off x="685800" y="365760"/>
-            <a:ext cx="10820095" cy="1051560"/>
+            <a:ext cx="10820095" cy="759182"/>
           </a:xfrm>
           <a:prstGeom prst="rect">
             <a:avLst/>
@@ -5533,7 +6000,7 @@
           <a:lstStyle/>
           <a:p>
             <a:r>
-              <a:rPr sz="1200" b="1" i="0">
+              <a:rPr sz="1200" b="1" i="0" dirty="0">
                 <a:solidFill>
                   <a:srgbClr val="5A6270"/>
                 </a:solidFill>
@@ -5549,10 +6016,13 @@
               </a:spcBef>
             </a:pPr>
             <a:r>
-              <a:rPr sz="2800" b="1" i="0">
-                <a:solidFill>
-                  <a:srgbClr val="B02E2E"/>
-                </a:solidFill>
+              <a:rPr lang="en-US" sz="2800" b="1" i="0" dirty="0">
+                <a:latin typeface="Calibri"/>
+              </a:rPr>
+              <a:t>Insight 1: </a:t>
+            </a:r>
+            <a:r>
+              <a:rPr sz="2800" b="1" i="0" dirty="0">
                 <a:latin typeface="Calibri"/>
               </a:rPr>
               <a:t>Do not go looking for what changed in 2024</a:t>
@@ -5768,7 +6238,7 @@
         <p:spPr>
           <a:xfrm>
             <a:off x="685800" y="365760"/>
-            <a:ext cx="10820095" cy="1051560"/>
+            <a:ext cx="10820095" cy="759182"/>
           </a:xfrm>
           <a:prstGeom prst="rect">
             <a:avLst/>
@@ -5782,7 +6252,7 @@
           <a:lstStyle/>
           <a:p>
             <a:r>
-              <a:rPr sz="1200" b="1" i="0">
+              <a:rPr sz="1200" b="1" i="0" dirty="0">
                 <a:solidFill>
                   <a:srgbClr val="5A6270"/>
                 </a:solidFill>
@@ -5798,14 +6268,26 @@
               </a:spcBef>
             </a:pPr>
             <a:r>
-              <a:rPr sz="2800" b="1" i="0">
-                <a:solidFill>
-                  <a:srgbClr val="B02E2E"/>
-                </a:solidFill>
-                <a:latin typeface="Calibri"/>
-              </a:rPr>
-              <a:t>Do not build the onboarding programme</a:t>
-            </a:r>
+              <a:rPr lang="en-US" sz="2800" b="1" i="0" dirty="0">
+                <a:latin typeface="Calibri"/>
+              </a:rPr>
+              <a:t>Insight 2: </a:t>
+            </a:r>
+            <a:r>
+              <a:rPr sz="2800" b="1" i="0" dirty="0">
+                <a:latin typeface="Calibri"/>
+              </a:rPr>
+              <a:t>Do not build the onboarding </a:t>
+            </a:r>
+            <a:r>
+              <a:rPr sz="2800" b="1" i="0" dirty="0" err="1">
+                <a:latin typeface="Calibri"/>
+              </a:rPr>
+              <a:t>programme</a:t>
+            </a:r>
+            <a:endParaRPr sz="2800" b="1" i="0" dirty="0">
+              <a:latin typeface="Calibri"/>
+            </a:endParaRPr>
           </a:p>
         </p:txBody>
       </p:sp>
@@ -6017,7 +6499,7 @@
         <p:spPr>
           <a:xfrm>
             <a:off x="685800" y="365760"/>
-            <a:ext cx="10820095" cy="1051560"/>
+            <a:ext cx="10820095" cy="759182"/>
           </a:xfrm>
           <a:prstGeom prst="rect">
             <a:avLst/>
@@ -6031,7 +6513,7 @@
           <a:lstStyle/>
           <a:p>
             <a:r>
-              <a:rPr sz="1200" b="1" i="0">
+              <a:rPr sz="1200" b="1" i="0" dirty="0">
                 <a:solidFill>
                   <a:srgbClr val="5A6270"/>
                 </a:solidFill>
@@ -6047,10 +6529,13 @@
               </a:spcBef>
             </a:pPr>
             <a:r>
-              <a:rPr sz="2800" b="1" i="0">
-                <a:solidFill>
-                  <a:srgbClr val="1E7A4B"/>
-                </a:solidFill>
+              <a:rPr lang="en-US" sz="2800" b="1" i="0" dirty="0">
+                <a:latin typeface="Calibri"/>
+              </a:rPr>
+              <a:t>Insight 3: </a:t>
+            </a:r>
+            <a:r>
+              <a:rPr sz="2800" b="1" i="0" dirty="0">
                 <a:latin typeface="Calibri"/>
               </a:rPr>
               <a:t>Call every at-risk customer, do not rank them</a:t>
@@ -6725,7 +7210,7 @@
               </a:spcAft>
             </a:pPr>
             <a:r>
-              <a:rPr sz="1300" b="1" i="0">
+              <a:rPr sz="1300" b="1" i="0" dirty="0">
                 <a:solidFill>
                   <a:srgbClr val="1A1A1A"/>
                 </a:solidFill>
@@ -6741,7 +7226,7 @@
               </a:spcAft>
             </a:pPr>
             <a:r>
-              <a:rPr sz="600" b="0" i="0">
+              <a:rPr sz="600" b="0" i="0" dirty="0">
                 <a:solidFill>
                   <a:srgbClr val="1A1A1A"/>
                 </a:solidFill>
@@ -6757,7 +7242,7 @@
               </a:spcAft>
             </a:pPr>
             <a:r>
-              <a:rPr sz="1300" b="1" i="0">
+              <a:rPr sz="1300" b="1" i="0" dirty="0">
                 <a:solidFill>
                   <a:srgbClr val="B02E2E"/>
                 </a:solidFill>
@@ -6773,7 +7258,7 @@
               </a:spcAft>
             </a:pPr>
             <a:r>
-              <a:rPr sz="1100" b="0" i="0">
+              <a:rPr sz="1100" b="0" i="0" dirty="0">
                 <a:solidFill>
                   <a:srgbClr val="5A6270"/>
                 </a:solidFill>
@@ -6789,7 +7274,7 @@
               </a:spcAft>
             </a:pPr>
             <a:r>
-              <a:rPr sz="1300" b="1" i="0">
+              <a:rPr sz="1300" b="1" i="0" dirty="0">
                 <a:solidFill>
                   <a:srgbClr val="B02E2E"/>
                 </a:solidFill>
@@ -6805,7 +7290,7 @@
               </a:spcAft>
             </a:pPr>
             <a:r>
-              <a:rPr sz="1100" b="0" i="0">
+              <a:rPr sz="1100" b="0" i="0" dirty="0">
                 <a:solidFill>
                   <a:srgbClr val="5A6270"/>
                 </a:solidFill>
@@ -6821,7 +7306,7 @@
               </a:spcAft>
             </a:pPr>
             <a:r>
-              <a:rPr sz="1300" b="1" i="0">
+              <a:rPr sz="1300" b="1" i="0" dirty="0">
                 <a:solidFill>
                   <a:srgbClr val="1A1A1A"/>
                 </a:solidFill>
@@ -6837,7 +7322,7 @@
               </a:spcAft>
             </a:pPr>
             <a:r>
-              <a:rPr sz="1100" b="0" i="0">
+              <a:rPr sz="1100" b="0" i="0" dirty="0">
                 <a:solidFill>
                   <a:srgbClr val="5A6270"/>
                 </a:solidFill>
@@ -6853,7 +7338,7 @@
               </a:spcAft>
             </a:pPr>
             <a:r>
-              <a:rPr sz="1300" b="1" i="0">
+              <a:rPr sz="1300" b="1" i="0" dirty="0">
                 <a:solidFill>
                   <a:srgbClr val="1A1A1A"/>
                 </a:solidFill>
@@ -6869,7 +7354,7 @@
               </a:spcAft>
             </a:pPr>
             <a:r>
-              <a:rPr sz="1100" b="0" i="0">
+              <a:rPr sz="1100" b="0" i="0" dirty="0">
                 <a:solidFill>
                   <a:srgbClr val="5A6270"/>
                 </a:solidFill>
@@ -6885,7 +7370,7 @@
               </a:spcAft>
             </a:pPr>
             <a:r>
-              <a:rPr sz="1300" b="1" i="0">
+              <a:rPr sz="1300" b="1" i="0" dirty="0">
                 <a:solidFill>
                   <a:srgbClr val="1A1A1A"/>
                 </a:solidFill>
@@ -6901,7 +7386,7 @@
               </a:spcAft>
             </a:pPr>
             <a:r>
-              <a:rPr sz="1100" b="0" i="0">
+              <a:rPr sz="1100" b="0" i="0" dirty="0">
                 <a:solidFill>
                   <a:srgbClr val="5A6270"/>
                 </a:solidFill>
@@ -6917,7 +7402,7 @@
               </a:spcAft>
             </a:pPr>
             <a:r>
-              <a:rPr sz="1300" b="1" i="0">
+              <a:rPr sz="1300" b="1" i="0" dirty="0">
                 <a:solidFill>
                   <a:srgbClr val="2E5F8A"/>
                 </a:solidFill>
@@ -6933,7 +7418,7 @@
               </a:spcAft>
             </a:pPr>
             <a:r>
-              <a:rPr sz="1100" b="0" i="0">
+              <a:rPr sz="1100" b="0" i="0" dirty="0">
                 <a:solidFill>
                   <a:srgbClr val="5A6270"/>
                 </a:solidFill>
@@ -8214,7 +8699,31 @@
                   <a:srgbClr val="5A6270"/>
                 </a:solidFill>
               </a:rPr>
-              <a:t>That gives 648 customer-dates, 281 distinct customers, and 159 leavers - 24.5%. The rate per cutoff runs 17% to 31%</a:t>
+              <a:t>That gives 648 customer-dates, 281 distinct customers, and 159 customers who churned </a:t>
+            </a:r>
+            <a:r>
+              <a:rPr lang="en-US" sz="1200" dirty="0" err="1">
+                <a:solidFill>
+                  <a:srgbClr val="5A6270"/>
+                </a:solidFill>
+              </a:rPr>
+              <a:t>i.e</a:t>
+            </a:r>
+            <a:r>
+              <a:rPr lang="en-US" sz="1200">
+                <a:solidFill>
+                  <a:srgbClr val="5A6270"/>
+                </a:solidFill>
+              </a:rPr>
+              <a:t> </a:t>
+            </a:r>
+            <a:r>
+              <a:rPr lang="en-US" sz="1200" dirty="0">
+                <a:solidFill>
+                  <a:srgbClr val="5A6270"/>
+                </a:solidFill>
+              </a:rPr>
+              <a:t>24.5%. The rate per cutoff runs 17% to 31%</a:t>
             </a:r>
           </a:p>
           <a:p>
@@ -10658,7 +11167,7 @@
         <p:spPr>
           <a:xfrm>
             <a:off x="685800" y="365760"/>
-            <a:ext cx="10820095" cy="1051560"/>
+            <a:ext cx="10820095" cy="759182"/>
           </a:xfrm>
           <a:prstGeom prst="rect">
             <a:avLst/>
@@ -10672,7 +11181,7 @@
           <a:lstStyle/>
           <a:p>
             <a:r>
-              <a:rPr sz="1200" b="1" i="0">
+              <a:rPr sz="1200" b="1" i="0" dirty="0">
                 <a:solidFill>
                   <a:srgbClr val="5A6270"/>
                 </a:solidFill>
@@ -10688,14 +11197,20 @@
               </a:spcBef>
             </a:pPr>
             <a:r>
-              <a:rPr sz="2800" b="1" i="0">
+              <a:rPr lang="en-US" sz="2800" b="1" i="0" dirty="0">
                 <a:solidFill>
                   <a:srgbClr val="1A1A1A"/>
                 </a:solidFill>
                 <a:latin typeface="Calibri"/>
               </a:rPr>
-              <a:t>No group of customers stands out</a:t>
-            </a:r>
+              <a:t>Early Signal Evaluation</a:t>
+            </a:r>
+            <a:endParaRPr sz="2800" b="1" i="0" dirty="0">
+              <a:solidFill>
+                <a:srgbClr val="1A1A1A"/>
+              </a:solidFill>
+              <a:latin typeface="Calibri"/>
+            </a:endParaRPr>
           </a:p>
         </p:txBody>
       </p:sp>
@@ -10746,7 +11261,7 @@
       </p:sp>
       <p:pic>
         <p:nvPicPr>
-          <p:cNvPr id="4" name="Picture 3" descr="05_segment_forest_html.png"/>
+          <p:cNvPr id="4" name="Picture 3" descr="05_segment_shuffle.png"/>
           <p:cNvPicPr>
             <a:picLocks noChangeAspect="1"/>
           </p:cNvPicPr>
@@ -10754,14 +11269,15 @@
         </p:nvPicPr>
         <p:blipFill>
           <a:blip r:embed="rId3"/>
+          <a:srcRect b="11876"/>
           <a:stretch>
             <a:fillRect/>
           </a:stretch>
         </p:blipFill>
         <p:spPr>
           <a:xfrm>
-            <a:off x="457200" y="1572768"/>
-            <a:ext cx="5029200" cy="4526280"/>
+            <a:off x="166838" y="1737511"/>
+            <a:ext cx="5929162" cy="3861276"/>
           </a:xfrm>
           <a:prstGeom prst="rect">
             <a:avLst/>
@@ -10770,14 +11286,14 @@
       </p:pic>
       <p:sp>
         <p:nvSpPr>
-          <p:cNvPr id="6" name="TextBox 5"/>
+          <p:cNvPr id="5" name="TextBox 4"/>
           <p:cNvSpPr txBox="1"/>
           <p:nvPr/>
         </p:nvSpPr>
         <p:spPr>
           <a:xfrm>
-            <a:off x="685800" y="6126480"/>
-            <a:ext cx="10820095" cy="502920"/>
+            <a:off x="6720840" y="1627632"/>
+            <a:ext cx="4846320" cy="4216539"/>
           </a:xfrm>
           <a:prstGeom prst="rect">
             <a:avLst/>
@@ -10790,149 +11306,28 @@
           </a:bodyPr>
           <a:lstStyle/>
           <a:p>
-            <a:r>
-              <a:rPr sz="1150" b="0" i="1">
-                <a:solidFill>
-                  <a:srgbClr val="5A6270"/>
-                </a:solidFill>
-                <a:latin typeface="Calibri"/>
-              </a:rPr>
-              <a:t>A group of 23 customers cannot tell you much. The width of these intervals is the finding, not the position of the dots.</a:t>
-            </a:r>
-          </a:p>
-        </p:txBody>
-      </p:sp>
-      <p:sp>
-        <p:nvSpPr>
-          <p:cNvPr id="8" name="TextBox 7">
-            <a:extLst>
-              <a:ext uri="{FF2B5EF4-FFF2-40B4-BE49-F238E27FC236}">
-                <a16:creationId xmlns:a16="http://schemas.microsoft.com/office/drawing/2014/main" id="{03FA6BE2-C20B-E0BF-644E-235352149894}"/>
-              </a:ext>
-            </a:extLst>
-          </p:cNvPr>
-          <p:cNvSpPr txBox="1"/>
-          <p:nvPr/>
-        </p:nvSpPr>
-        <p:spPr>
-          <a:xfrm>
-            <a:off x="5989320" y="1645920"/>
-            <a:ext cx="5577840" cy="3931846"/>
-          </a:xfrm>
-          <a:prstGeom prst="rect">
-            <a:avLst/>
-          </a:prstGeom>
-          <a:noFill/>
-        </p:spPr>
-        <p:txBody>
-          <a:bodyPr wrap="square">
-            <a:spAutoFit/>
-          </a:bodyPr>
-          <a:lstStyle/>
-          <a:p>
             <a:pPr>
               <a:spcAft>
                 <a:spcPts val="300"/>
               </a:spcAft>
             </a:pPr>
             <a:r>
-              <a:rPr lang="en-US" sz="1400" dirty="0">
-                <a:solidFill>
-                  <a:srgbClr val="5A6270"/>
-                </a:solidFill>
-              </a:rPr>
-              <a:t>This is one cutoff, 30 June 2024</a:t>
-            </a:r>
-          </a:p>
-          <a:p>
-            <a:pPr>
-              <a:spcAft>
-                <a:spcPts val="300"/>
-              </a:spcAft>
-            </a:pPr>
-            <a:endParaRPr lang="en-US" sz="1300" b="1" i="0" dirty="0">
-              <a:solidFill>
-                <a:srgbClr val="1A1A1A"/>
-              </a:solidFill>
-              <a:latin typeface="Calibri"/>
-            </a:endParaRPr>
-          </a:p>
-          <a:p>
-            <a:pPr>
-              <a:spcAft>
-                <a:spcPts val="300"/>
-              </a:spcAft>
-            </a:pPr>
-            <a:r>
-              <a:rPr sz="1300" b="1" i="0" dirty="0">
+              <a:rPr lang="en-US" sz="1250" b="1" i="0" dirty="0">
                 <a:solidFill>
                   <a:srgbClr val="1A1A1A"/>
                 </a:solidFill>
                 <a:latin typeface="Calibri"/>
               </a:rPr>
-              <a:t>I checked industry, country, plan, how they found us, and whether they started on a trial. Not one of them separates the customers who leave from the ones who stay.</a:t>
-            </a:r>
-          </a:p>
-          <a:p>
-            <a:pPr>
-              <a:spcAft>
-                <a:spcPts val="300"/>
-              </a:spcAft>
-            </a:pPr>
-            <a:r>
-              <a:rPr sz="600" b="0" i="0" dirty="0">
+              <a:t>Preliminary Signal Analysis:</a:t>
+            </a:r>
+            <a:br>
+              <a:rPr lang="en-US" sz="1250" b="1" i="0" dirty="0">
                 <a:solidFill>
                   <a:srgbClr val="1A1A1A"/>
                 </a:solidFill>
                 <a:latin typeface="Calibri"/>
               </a:rPr>
-              <a:t> </a:t>
-            </a:r>
-          </a:p>
-          <a:p>
-            <a:pPr>
-              <a:spcAft>
-                <a:spcPts val="300"/>
-              </a:spcAft>
-            </a:pPr>
-            <a:r>
-              <a:rPr sz="1300" b="1" i="0" dirty="0">
-                <a:solidFill>
-                  <a:srgbClr val="1A1A1A"/>
-                </a:solidFill>
-                <a:latin typeface="Calibri"/>
-              </a:rPr>
-              <a:t>The red line is 31%: 54 of the 177 customers left.</a:t>
-            </a:r>
-          </a:p>
-          <a:p>
-            <a:pPr lvl="1">
-              <a:spcAft>
-                <a:spcPts val="300"/>
-              </a:spcAft>
-            </a:pPr>
-            <a:r>
-              <a:rPr sz="1100" b="0" i="0" dirty="0">
-                <a:solidFill>
-                  <a:srgbClr val="5A6270"/>
-                </a:solidFill>
-                <a:latin typeface="Calibri"/>
-              </a:rPr>
-              <a:t>This is one cutoff, 30 June 2024</a:t>
-            </a:r>
-            <a:endParaRPr lang="en-US" sz="1100" b="0" i="0" dirty="0">
-              <a:solidFill>
-                <a:srgbClr val="5A6270"/>
-              </a:solidFill>
-              <a:latin typeface="Calibri"/>
-            </a:endParaRPr>
-          </a:p>
-          <a:p>
-            <a:pPr lvl="1">
-              <a:spcAft>
-                <a:spcPts val="300"/>
-              </a:spcAft>
-            </a:pPr>
+            </a:br>
             <a:endParaRPr sz="600" b="0" i="0" dirty="0">
               <a:solidFill>
                 <a:srgbClr val="1A1A1A"/>
@@ -10947,34 +11342,74 @@
               </a:spcAft>
             </a:pPr>
             <a:r>
-              <a:rPr sz="1300" b="1" i="0" dirty="0">
+              <a:rPr sz="1250" b="1" i="0" dirty="0">
                 <a:solidFill>
                   <a:srgbClr val="1A1A1A"/>
                 </a:solidFill>
                 <a:latin typeface="Calibri"/>
               </a:rPr>
-              <a:t>The lines say how little a group this size can tell you.</a:t>
-            </a:r>
-          </a:p>
-          <a:p>
-            <a:pPr lvl="1">
+              <a:t>Method</a:t>
+            </a:r>
+          </a:p>
+          <a:p>
+            <a:pPr marL="685800" lvl="1" indent="-228600">
               <a:spcAft>
                 <a:spcPts val="300"/>
               </a:spcAft>
-            </a:pPr>
-            <a:r>
-              <a:rPr lang="en-US" sz="1100" dirty="0">
+              <a:buAutoNum type="arabicPeriod"/>
+            </a:pPr>
+            <a:r>
+              <a:rPr lang="en-US" sz="1050" dirty="0">
                 <a:solidFill>
                   <a:srgbClr val="5A6270"/>
                 </a:solidFill>
               </a:rPr>
-              <a:t>We used Wilson interval with input being the customers who churned and group size and the output the range of true rates consistent with that count</a:t>
-            </a:r>
-            <a:endParaRPr sz="1100" b="0" i="0" dirty="0">
+              <a:t>Red lines: The gap we observed|. For industry: the highest-churn industry (EdTech, 41%) minus the lowest (Cybersecurity, 9%) = 32 points.</a:t>
+            </a:r>
+          </a:p>
+          <a:p>
+            <a:pPr marL="685800" lvl="1" indent="-228600">
+              <a:spcAft>
+                <a:spcPts val="300"/>
+              </a:spcAft>
+              <a:buAutoNum type="arabicPeriod"/>
+            </a:pPr>
+            <a:r>
+              <a:rPr lang="en-US" sz="1050" dirty="0">
+                <a:solidFill>
+                  <a:srgbClr val="5A6270"/>
+                </a:solidFill>
+              </a:rPr>
+              <a:t>The blue bars: To build each fake version: keep every customer in their real industry, then randomly reassign who churned. Take the difference of highest churn and lowest churn and do this 20,000 times</a:t>
+            </a:r>
+          </a:p>
+          <a:p>
+            <a:pPr marL="685800" lvl="1" indent="-228600">
+              <a:spcAft>
+                <a:spcPts val="300"/>
+              </a:spcAft>
+              <a:buAutoNum type="arabicPeriod"/>
+            </a:pPr>
+            <a:r>
+              <a:rPr lang="en-US" sz="1050" dirty="0">
+                <a:solidFill>
+                  <a:srgbClr val="5A6270"/>
+                </a:solidFill>
+              </a:rPr>
+              <a:t>P value: The share of blue bars sitting at or to the right of the red line.</a:t>
+            </a:r>
+          </a:p>
+          <a:p>
+            <a:pPr marL="685800" lvl="1" indent="-228600">
+              <a:spcAft>
+                <a:spcPts val="300"/>
+              </a:spcAft>
+              <a:buAutoNum type="arabicPeriod"/>
+            </a:pPr>
+            <a:endParaRPr lang="en-US" sz="1050" dirty="0">
               <a:solidFill>
                 <a:srgbClr val="5A6270"/>
               </a:solidFill>
-              <a:latin typeface="Calibri"/>
             </a:endParaRPr>
           </a:p>
           <a:p>
@@ -10984,30 +11419,107 @@
               </a:spcAft>
             </a:pPr>
             <a:r>
-              <a:rPr sz="600" b="0" i="0" dirty="0">
+              <a:rPr lang="en-US" sz="1250" b="1" dirty="0">
                 <a:solidFill>
                   <a:srgbClr val="1A1A1A"/>
                 </a:solidFill>
-                <a:latin typeface="Calibri"/>
-              </a:rPr>
-              <a:t> </a:t>
-            </a:r>
-          </a:p>
-          <a:p>
-            <a:pPr>
+              </a:rPr>
+              <a:t>Findings</a:t>
+            </a:r>
+          </a:p>
+          <a:p>
+            <a:pPr marL="685800" lvl="1" indent="-228600">
               <a:spcAft>
                 <a:spcPts val="300"/>
               </a:spcAft>
-            </a:pPr>
-            <a:r>
-              <a:rPr sz="1300" b="1" i="0" dirty="0">
-                <a:solidFill>
-                  <a:srgbClr val="1A1A1A"/>
-                </a:solidFill>
-                <a:latin typeface="Calibri"/>
-              </a:rPr>
-              <a:t>One group does miss the line, and it is the one to volunteer.</a:t>
-            </a:r>
+              <a:buAutoNum type="arabicPeriod"/>
+            </a:pPr>
+            <a:r>
+              <a:rPr lang="en-US" sz="1050" dirty="0">
+                <a:solidFill>
+                  <a:srgbClr val="5A6270"/>
+                </a:solidFill>
+              </a:rPr>
+              <a:t>What we found: nothing is a strong churn predictor from these 10 variables. Ten different ways of grouping customers, none of them separates customers who churned from stayers</a:t>
+            </a:r>
+          </a:p>
+          <a:p>
+            <a:pPr marL="685800" lvl="1" indent="-228600">
+              <a:spcAft>
+                <a:spcPts val="300"/>
+              </a:spcAft>
+              <a:buAutoNum type="arabicPeriod"/>
+            </a:pPr>
+            <a:r>
+              <a:rPr lang="en-US" sz="1050" dirty="0">
+                <a:solidFill>
+                  <a:srgbClr val="5A6270"/>
+                </a:solidFill>
+              </a:rPr>
+              <a:t>Industry came closest; p = 0.03. But one customer changes the answer. The result rests on Cybersecurity, where 2 of 23 customers left. I re-ran it with 3 customers who churned instead of 2 — a single customer:</a:t>
+            </a:r>
+            <a:br>
+              <a:rPr lang="en-US" sz="1050" dirty="0">
+                <a:solidFill>
+                  <a:srgbClr val="5A6270"/>
+                </a:solidFill>
+              </a:rPr>
+            </a:br>
+            <a:br>
+              <a:rPr lang="en-US" sz="1050" dirty="0">
+                <a:solidFill>
+                  <a:srgbClr val="5A6270"/>
+                </a:solidFill>
+              </a:rPr>
+            </a:br>
+            <a:r>
+              <a:rPr lang="en-US" sz="1050" dirty="0">
+                <a:solidFill>
+                  <a:srgbClr val="5A6270"/>
+                </a:solidFill>
+              </a:rPr>
+              <a:t>- As the data stands (2 of 23) p = 0.03</a:t>
+            </a:r>
+            <a:br>
+              <a:rPr lang="en-US" sz="1050" dirty="0">
+                <a:solidFill>
+                  <a:srgbClr val="5A6270"/>
+                </a:solidFill>
+              </a:rPr>
+            </a:br>
+            <a:r>
+              <a:rPr lang="en-US" sz="1050" dirty="0">
+                <a:solidFill>
+                  <a:srgbClr val="5A6270"/>
+                </a:solidFill>
+              </a:rPr>
+              <a:t>- One more customer who churns (3 of 23) p = 0.09</a:t>
+            </a:r>
+            <a:br>
+              <a:rPr lang="en-US" sz="1050" dirty="0">
+                <a:solidFill>
+                  <a:srgbClr val="5A6270"/>
+                </a:solidFill>
+              </a:rPr>
+            </a:br>
+            <a:endParaRPr lang="en-US" sz="1050" dirty="0">
+              <a:solidFill>
+                <a:srgbClr val="5A6270"/>
+              </a:solidFill>
+            </a:endParaRPr>
+          </a:p>
+          <a:p>
+            <a:pPr marL="1143000" lvl="2" indent="-228600">
+              <a:spcAft>
+                <a:spcPts val="300"/>
+              </a:spcAft>
+              <a:buAutoNum type="arabicPeriod"/>
+            </a:pPr>
+            <a:endParaRPr lang="en-US" sz="1050" dirty="0">
+              <a:solidFill>
+                <a:srgbClr val="5A6270"/>
+              </a:solidFill>
+            </a:endParaRPr>
           </a:p>
           <a:p>
             <a:pPr lvl="1">
@@ -11015,47 +11527,11 @@
                 <a:spcPts val="300"/>
               </a:spcAft>
             </a:pPr>
-            <a:r>
-              <a:rPr sz="1100" b="0" i="0" dirty="0">
-                <a:solidFill>
-                  <a:srgbClr val="5A6270"/>
-                </a:solidFill>
-                <a:latin typeface="Calibri"/>
-              </a:rPr>
-              <a:t>Cybersecurity. But testing 22 groups at 95% confidence, you expect 1.1 to miss by chance. We got one.</a:t>
-            </a:r>
-          </a:p>
-          <a:p>
-            <a:pPr>
-              <a:spcAft>
-                <a:spcPts val="300"/>
-              </a:spcAft>
-            </a:pPr>
-            <a:r>
-              <a:rPr sz="600" b="0" i="0" dirty="0">
-                <a:solidFill>
-                  <a:srgbClr val="1A1A1A"/>
-                </a:solidFill>
-                <a:latin typeface="Calibri"/>
-              </a:rPr>
-              <a:t> </a:t>
-            </a:r>
-          </a:p>
-          <a:p>
-            <a:pPr lvl="1">
-              <a:spcAft>
-                <a:spcPts val="300"/>
-              </a:spcAft>
-            </a:pPr>
-            <a:r>
-              <a:rPr sz="1100" b="0" i="0" dirty="0">
-                <a:solidFill>
-                  <a:srgbClr val="5A6270"/>
-                </a:solidFill>
-                <a:latin typeface="Calibri"/>
-              </a:rPr>
-              <a:t>Strongest association across all five is p = 0.08, before accounting for having looked at five. I explored this on a held-out slice, so the data I modelled on did not influence what I chose to look at.</a:t>
-            </a:r>
+            <a:endParaRPr lang="en-US" sz="1050" dirty="0">
+              <a:solidFill>
+                <a:srgbClr val="5A6270"/>
+              </a:solidFill>
+            </a:endParaRPr>
           </a:p>
         </p:txBody>
       </p:sp>
@@ -11093,7 +11569,7 @@
         <p:spPr>
           <a:xfrm>
             <a:off x="685800" y="365760"/>
-            <a:ext cx="10820095" cy="1051560"/>
+            <a:ext cx="10820095" cy="759182"/>
           </a:xfrm>
           <a:prstGeom prst="rect">
             <a:avLst/>
@@ -11107,7 +11583,7 @@
           <a:lstStyle/>
           <a:p>
             <a:r>
-              <a:rPr sz="1200" b="1" i="0">
+              <a:rPr sz="1200" b="1" i="0" dirty="0">
                 <a:solidFill>
                   <a:srgbClr val="5A6270"/>
                 </a:solidFill>
@@ -11123,14 +11599,29 @@
               </a:spcBef>
             </a:pPr>
             <a:r>
-              <a:rPr sz="2800" b="1" i="0">
+              <a:rPr sz="2800" b="1" i="0" dirty="0">
                 <a:solidFill>
                   <a:srgbClr val="1A1A1A"/>
                 </a:solidFill>
                 <a:latin typeface="Calibri"/>
               </a:rPr>
-              <a:t>73 features, and the reason for each one</a:t>
-            </a:r>
+              <a:t>73 features</a:t>
+            </a:r>
+            <a:r>
+              <a:rPr lang="en-US" sz="2800" b="1" i="0" dirty="0">
+                <a:solidFill>
+                  <a:srgbClr val="1A1A1A"/>
+                </a:solidFill>
+                <a:latin typeface="Calibri"/>
+              </a:rPr>
+              <a:t> and rational</a:t>
+            </a:r>
+            <a:endParaRPr sz="2800" b="1" i="0" dirty="0">
+              <a:solidFill>
+                <a:srgbClr val="1A1A1A"/>
+              </a:solidFill>
+              <a:latin typeface="Calibri"/>
+            </a:endParaRPr>
           </a:p>
         </p:txBody>
       </p:sp>
@@ -11189,136 +11680,89 @@
         </p:nvPicPr>
         <p:blipFill>
           <a:blip r:embed="rId2"/>
+          <a:srcRect r="67813"/>
           <a:stretch>
             <a:fillRect/>
           </a:stretch>
         </p:blipFill>
         <p:spPr>
           <a:xfrm>
-            <a:off x="1270216" y="1536192"/>
-            <a:ext cx="9651263" cy="2788920"/>
+            <a:off x="361593" y="1607822"/>
+            <a:ext cx="2387413" cy="2143406"/>
           </a:xfrm>
           <a:prstGeom prst="rect">
             <a:avLst/>
           </a:prstGeom>
         </p:spPr>
       </p:pic>
-      <p:sp>
-        <p:nvSpPr>
-          <p:cNvPr id="5" name="TextBox 4"/>
-          <p:cNvSpPr txBox="1"/>
+      <p:pic>
+        <p:nvPicPr>
+          <p:cNvPr id="11" name="Picture 10" descr="03_point_in_time.png">
+            <a:extLst>
+              <a:ext uri="{FF2B5EF4-FFF2-40B4-BE49-F238E27FC236}">
+                <a16:creationId xmlns:a16="http://schemas.microsoft.com/office/drawing/2014/main" id="{D9478685-84BF-2555-1422-7F7ACAB891D9}"/>
+              </a:ext>
+            </a:extLst>
+          </p:cNvPr>
+          <p:cNvPicPr>
+            <a:picLocks noChangeAspect="1"/>
+          </p:cNvPicPr>
           <p:nvPr/>
-        </p:nvSpPr>
+        </p:nvPicPr>
+        <p:blipFill>
+          <a:blip r:embed="rId2"/>
+          <a:srcRect l="30083"/>
+          <a:stretch>
+            <a:fillRect/>
+          </a:stretch>
+        </p:blipFill>
         <p:spPr>
           <a:xfrm>
-            <a:off x="685800" y="4480560"/>
-            <a:ext cx="10820095" cy="1408078"/>
+            <a:off x="0" y="3853496"/>
+            <a:ext cx="5011486" cy="2071262"/>
           </a:xfrm>
           <a:prstGeom prst="rect">
             <a:avLst/>
           </a:prstGeom>
-          <a:noFill/>
         </p:spPr>
-        <p:txBody>
-          <a:bodyPr wrap="square">
-            <a:spAutoFit/>
-          </a:bodyPr>
-          <a:lstStyle/>
-          <a:p>
-            <a:pPr>
-              <a:spcAft>
-                <a:spcPts val="300"/>
-              </a:spcAft>
-            </a:pPr>
-            <a:r>
-              <a:rPr sz="1150" b="1" i="0" dirty="0">
-                <a:solidFill>
-                  <a:srgbClr val="1A1A1A"/>
-                </a:solidFill>
-                <a:latin typeface="Calibri"/>
-              </a:rPr>
-              <a:t>What each family measures.</a:t>
-            </a:r>
-          </a:p>
-          <a:p>
-            <a:pPr lvl="1">
-              <a:spcAft>
-                <a:spcPts val="300"/>
-              </a:spcAft>
-            </a:pPr>
-            <a:r>
-              <a:rPr sz="950" b="0" i="0" dirty="0">
-                <a:solidFill>
-                  <a:srgbClr val="5A6270"/>
-                </a:solidFill>
-                <a:latin typeface="Calibri"/>
-              </a:rPr>
-              <a:t>Subscription: what they pay, how steady it is, upgrades, downgrades, how long they have been a customer.  Usage: activity over 30 to 180 days, and whether it is speeding up or slowing down.  Support: ticket load, how fast we answered, how long fixes took, satisfaction, escalations.  Account and ratios: industry, country, how they found us, plan, and per-seat versions of usage and tickets so a 10 seat and a 500 seat customer sit on the same scale.</a:t>
-            </a:r>
-          </a:p>
-          <a:p>
-            <a:pPr>
-              <a:spcAft>
-                <a:spcPts val="300"/>
-              </a:spcAft>
-            </a:pPr>
-            <a:r>
-              <a:rPr sz="600" b="0" i="0" dirty="0">
-                <a:solidFill>
-                  <a:srgbClr val="1A1A1A"/>
-                </a:solidFill>
-                <a:latin typeface="Calibri"/>
-              </a:rPr>
-              <a:t> </a:t>
-            </a:r>
-          </a:p>
-          <a:p>
-            <a:pPr>
-              <a:spcAft>
-                <a:spcPts val="300"/>
-              </a:spcAft>
-            </a:pPr>
-            <a:r>
-              <a:rPr sz="1150" b="1" i="0" dirty="0">
-                <a:solidFill>
-                  <a:srgbClr val="2E5F8A"/>
-                </a:solidFill>
-                <a:latin typeface="Calibri"/>
-              </a:rPr>
-              <a:t>The same code builds these in training and in production.</a:t>
-            </a:r>
-          </a:p>
-          <a:p>
-            <a:pPr lvl="1">
-              <a:spcAft>
-                <a:spcPts val="300"/>
-              </a:spcAft>
-            </a:pPr>
-            <a:r>
-              <a:rPr sz="950" b="0" i="0" dirty="0">
-                <a:solidFill>
-                  <a:srgbClr val="5A6270"/>
-                </a:solidFill>
-                <a:latin typeface="Calibri"/>
-              </a:rPr>
-              <a:t>Training passes 30 June 2024, production passes today, so the two cannot drift apart. The blanking on the right is the part that reading the code misses: an automatic check found those 5 tickets, I did not.</a:t>
-            </a:r>
-          </a:p>
-          <a:p>
-            <a:pPr>
-              <a:spcAft>
-                <a:spcPts val="300"/>
-              </a:spcAft>
-            </a:pPr>
-            <a:endParaRPr sz="600" b="0" i="0" dirty="0">
-              <a:solidFill>
-                <a:srgbClr val="1A1A1A"/>
-              </a:solidFill>
-              <a:latin typeface="Calibri"/>
-            </a:endParaRPr>
-          </a:p>
-        </p:txBody>
-      </p:sp>
+      </p:pic>
+      <p:pic>
+        <p:nvPicPr>
+          <p:cNvPr id="15" name="Picture 14">
+            <a:extLst>
+              <a:ext uri="{FF2B5EF4-FFF2-40B4-BE49-F238E27FC236}">
+                <a16:creationId xmlns:a16="http://schemas.microsoft.com/office/drawing/2014/main" id="{3A739226-CB47-DDA5-CE8E-5B5A1839E840}"/>
+              </a:ext>
+            </a:extLst>
+          </p:cNvPr>
+          <p:cNvPicPr>
+            <a:picLocks noChangeAspect="1"/>
+          </p:cNvPicPr>
+          <p:nvPr/>
+        </p:nvPicPr>
+        <p:blipFill>
+          <a:blip r:embed="rId3"/>
+          <a:stretch>
+            <a:fillRect/>
+          </a:stretch>
+        </p:blipFill>
+        <p:spPr>
+          <a:xfrm>
+            <a:off x="5083343" y="1601362"/>
+            <a:ext cx="7053024" cy="4221128"/>
+          </a:xfrm>
+          <a:prstGeom prst="rect">
+            <a:avLst/>
+          </a:prstGeom>
+          <a:ln w="6350">
+            <a:solidFill>
+              <a:schemeClr val="bg1">
+                <a:lumMod val="85000"/>
+              </a:schemeClr>
+            </a:solidFill>
+          </a:ln>
+        </p:spPr>
+      </p:pic>
     </p:spTree>
   </p:cSld>
   <p:clrMapOvr>

</xml_diff>

<commit_message>
Enhance modeling and performance analysis in presentation materials
- Added a new section in `build_new_slides.py` detailing the impact of increased data rows on customer churn analysis, including updated performance metrics and model evaluation.
- Revised the `pooled_selection_null.csv` to include additional AUC values for improved analysis of model performance.
- Updated `AvePoint_Case_Study.pptx` to reflect these enhancements, ensuring alignment with the latest insights and visual clarity.

These changes aim to provide a more comprehensive understanding of the modeling process and its implications for customer retention strategies.
</commit_message>
<xml_diff>
--- a/outputs/decks/AvePoint_Case_Study.pptx
+++ b/outputs/decks/AvePoint_Case_Study.pptx
@@ -5,7 +5,7 @@
     <p:sldMasterId id="2147483648" r:id="rId1"/>
   </p:sldMasterIdLst>
   <p:notesMasterIdLst>
-    <p:notesMasterId r:id="rId21"/>
+    <p:notesMasterId r:id="rId22"/>
   </p:notesMasterIdLst>
   <p:sldIdLst>
     <p:sldId id="256" r:id="rId2"/>
@@ -18,15 +18,16 @@
     <p:sldId id="278" r:id="rId9"/>
     <p:sldId id="261" r:id="rId10"/>
     <p:sldId id="262" r:id="rId11"/>
-    <p:sldId id="263" r:id="rId12"/>
-    <p:sldId id="264" r:id="rId13"/>
-    <p:sldId id="265" r:id="rId14"/>
-    <p:sldId id="266" r:id="rId15"/>
-    <p:sldId id="267" r:id="rId16"/>
-    <p:sldId id="268" r:id="rId17"/>
-    <p:sldId id="269" r:id="rId18"/>
-    <p:sldId id="270" r:id="rId19"/>
-    <p:sldId id="271" r:id="rId20"/>
+    <p:sldId id="281" r:id="rId12"/>
+    <p:sldId id="263" r:id="rId13"/>
+    <p:sldId id="264" r:id="rId14"/>
+    <p:sldId id="282" r:id="rId15"/>
+    <p:sldId id="266" r:id="rId16"/>
+    <p:sldId id="267" r:id="rId17"/>
+    <p:sldId id="268" r:id="rId18"/>
+    <p:sldId id="269" r:id="rId19"/>
+    <p:sldId id="270" r:id="rId20"/>
+    <p:sldId id="271" r:id="rId21"/>
   </p:sldIdLst>
   <p:sldSz cx="12192000" cy="6858000"/>
   <p:notesSz cx="6858000" cy="9144000"/>
@@ -147,7 +148,7 @@
 <file path=ppt/revisionInfo.xml><?xml version="1.0" encoding="utf-8"?>
 <p1510:revInfo xmlns:a="http://schemas.openxmlformats.org/drawingml/2006/main" xmlns:r="http://schemas.openxmlformats.org/officeDocument/2006/relationships" xmlns:p1510="http://schemas.microsoft.com/office/powerpoint/2015/10/main">
   <p1510:revLst>
-    <p1510:client id="{25DC7B8B-EC09-4841-A573-8FF6489E0CC5}" v="135" dt="2026-07-29T13:46:55.803"/>
+    <p1510:client id="{25DC7B8B-EC09-4841-A573-8FF6489E0CC5}" v="155" dt="2026-07-29T14:51:32.883"/>
   </p1510:revLst>
 </p1510:revInfo>
 </file>
@@ -157,7 +158,7 @@
   <pc:docChgLst>
     <pc:chgData name="Dmitriy Ratushny" userId="08050032e8047aee" providerId="LiveId" clId="{78EB1A6D-D3A9-4525-A4D5-A50D4E20D487}"/>
     <pc:docChg chg="undo custSel addSld delSld modSld">
-      <pc:chgData name="Dmitriy Ratushny" userId="08050032e8047aee" providerId="LiveId" clId="{78EB1A6D-D3A9-4525-A4D5-A50D4E20D487}" dt="2026-07-29T13:47:14.229" v="3031" actId="20577"/>
+      <pc:chgData name="Dmitriy Ratushny" userId="08050032e8047aee" providerId="LiveId" clId="{78EB1A6D-D3A9-4525-A4D5-A50D4E20D487}" dt="2026-07-29T15:04:33.733" v="3319" actId="20577"/>
       <pc:docMkLst>
         <pc:docMk/>
       </pc:docMkLst>
@@ -404,7 +405,7 @@
         </pc:picChg>
       </pc:sldChg>
       <pc:sldChg chg="addSp delSp modSp mod">
-        <pc:chgData name="Dmitriy Ratushny" userId="08050032e8047aee" providerId="LiveId" clId="{78EB1A6D-D3A9-4525-A4D5-A50D4E20D487}" dt="2026-07-29T13:23:39.412" v="2944" actId="1076"/>
+        <pc:chgData name="Dmitriy Ratushny" userId="08050032e8047aee" providerId="LiveId" clId="{78EB1A6D-D3A9-4525-A4D5-A50D4E20D487}" dt="2026-07-29T14:26:14.460" v="3212" actId="22"/>
         <pc:sldMkLst>
           <pc:docMk/>
           <pc:sldMk cId="0" sldId="262"/>
@@ -423,6 +424,14 @@
             <pc:docMk/>
             <pc:sldMk cId="0" sldId="262"/>
             <ac:spMk id="5" creationId="{00000000-0000-0000-0000-000000000000}"/>
+          </ac:spMkLst>
+        </pc:spChg>
+        <pc:spChg chg="add del">
+          <ac:chgData name="Dmitriy Ratushny" userId="08050032e8047aee" providerId="LiveId" clId="{78EB1A6D-D3A9-4525-A4D5-A50D4E20D487}" dt="2026-07-29T14:26:14.460" v="3212" actId="22"/>
+          <ac:spMkLst>
+            <pc:docMk/>
+            <pc:sldMk cId="0" sldId="262"/>
+            <ac:spMk id="6" creationId="{28ED71EF-B393-59AC-85FF-6AE959784BFE}"/>
           </ac:spMkLst>
         </pc:spChg>
         <pc:picChg chg="add del mod">
@@ -458,8 +467,8 @@
           </ac:picMkLst>
         </pc:picChg>
       </pc:sldChg>
-      <pc:sldChg chg="addSp delSp modSp mod">
-        <pc:chgData name="Dmitriy Ratushny" userId="08050032e8047aee" providerId="LiveId" clId="{78EB1A6D-D3A9-4525-A4D5-A50D4E20D487}" dt="2026-07-29T13:37:40.697" v="3026" actId="22"/>
+      <pc:sldChg chg="addSp delSp modSp add del mod">
+        <pc:chgData name="Dmitriy Ratushny" userId="08050032e8047aee" providerId="LiveId" clId="{78EB1A6D-D3A9-4525-A4D5-A50D4E20D487}" dt="2026-07-29T14:42:57.973" v="3229" actId="20577"/>
         <pc:sldMkLst>
           <pc:docMk/>
           <pc:sldMk cId="0" sldId="263"/>
@@ -473,7 +482,7 @@
           </ac:spMkLst>
         </pc:spChg>
         <pc:spChg chg="mod">
-          <ac:chgData name="Dmitriy Ratushny" userId="08050032e8047aee" providerId="LiveId" clId="{78EB1A6D-D3A9-4525-A4D5-A50D4E20D487}" dt="2026-07-29T13:37:39.531" v="3023" actId="20577"/>
+          <ac:chgData name="Dmitriy Ratushny" userId="08050032e8047aee" providerId="LiveId" clId="{78EB1A6D-D3A9-4525-A4D5-A50D4E20D487}" dt="2026-07-29T14:42:39.610" v="3226" actId="1076"/>
           <ac:spMkLst>
             <pc:docMk/>
             <pc:sldMk cId="0" sldId="263"/>
@@ -481,7 +490,7 @@
           </ac:spMkLst>
         </pc:spChg>
         <pc:spChg chg="mod">
-          <ac:chgData name="Dmitriy Ratushny" userId="08050032e8047aee" providerId="LiveId" clId="{78EB1A6D-D3A9-4525-A4D5-A50D4E20D487}" dt="2026-07-29T13:37:38.535" v="3019" actId="1076"/>
+          <ac:chgData name="Dmitriy Ratushny" userId="08050032e8047aee" providerId="LiveId" clId="{78EB1A6D-D3A9-4525-A4D5-A50D4E20D487}" dt="2026-07-29T14:42:57.973" v="3229" actId="20577"/>
           <ac:spMkLst>
             <pc:docMk/>
             <pc:sldMk cId="0" sldId="263"/>
@@ -513,8 +522,8 @@
           </ac:picMkLst>
         </pc:picChg>
       </pc:sldChg>
-      <pc:sldChg chg="modSp mod">
-        <pc:chgData name="Dmitriy Ratushny" userId="08050032e8047aee" providerId="LiveId" clId="{78EB1A6D-D3A9-4525-A4D5-A50D4E20D487}" dt="2026-07-29T13:46:55.803" v="3027"/>
+      <pc:sldChg chg="addSp delSp modSp mod">
+        <pc:chgData name="Dmitriy Ratushny" userId="08050032e8047aee" providerId="LiveId" clId="{78EB1A6D-D3A9-4525-A4D5-A50D4E20D487}" dt="2026-07-29T14:20:52.416" v="3208" actId="1076"/>
         <pc:sldMkLst>
           <pc:docMk/>
           <pc:sldMk cId="0" sldId="264"/>
@@ -528,16 +537,48 @@
           </ac:spMkLst>
         </pc:spChg>
         <pc:spChg chg="mod">
-          <ac:chgData name="Dmitriy Ratushny" userId="08050032e8047aee" providerId="LiveId" clId="{78EB1A6D-D3A9-4525-A4D5-A50D4E20D487}" dt="2026-07-29T13:46:55.803" v="3027"/>
+          <ac:chgData name="Dmitriy Ratushny" userId="08050032e8047aee" providerId="LiveId" clId="{78EB1A6D-D3A9-4525-A4D5-A50D4E20D487}" dt="2026-07-29T14:20:21.027" v="3202" actId="21"/>
           <ac:spMkLst>
             <pc:docMk/>
             <pc:sldMk cId="0" sldId="264"/>
             <ac:spMk id="5" creationId="{00000000-0000-0000-0000-000000000000}"/>
           </ac:spMkLst>
         </pc:spChg>
+        <pc:spChg chg="del">
+          <ac:chgData name="Dmitriy Ratushny" userId="08050032e8047aee" providerId="LiveId" clId="{78EB1A6D-D3A9-4525-A4D5-A50D4E20D487}" dt="2026-07-29T14:00:24.915" v="3069" actId="478"/>
+          <ac:spMkLst>
+            <pc:docMk/>
+            <pc:sldMk cId="0" sldId="264"/>
+            <ac:spMk id="6" creationId="{00000000-0000-0000-0000-000000000000}"/>
+          </ac:spMkLst>
+        </pc:spChg>
+        <pc:spChg chg="add mod">
+          <ac:chgData name="Dmitriy Ratushny" userId="08050032e8047aee" providerId="LiveId" clId="{78EB1A6D-D3A9-4525-A4D5-A50D4E20D487}" dt="2026-07-29T14:20:24.788" v="3204" actId="1076"/>
+          <ac:spMkLst>
+            <pc:docMk/>
+            <pc:sldMk cId="0" sldId="264"/>
+            <ac:spMk id="10" creationId="{59D5E82D-6C5D-1F05-AF59-8F1C90CA5BFE}"/>
+          </ac:spMkLst>
+        </pc:spChg>
+        <pc:picChg chg="del mod">
+          <ac:chgData name="Dmitriy Ratushny" userId="08050032e8047aee" providerId="LiveId" clId="{78EB1A6D-D3A9-4525-A4D5-A50D4E20D487}" dt="2026-07-29T14:20:12.226" v="3199" actId="478"/>
+          <ac:picMkLst>
+            <pc:docMk/>
+            <pc:sldMk cId="0" sldId="264"/>
+            <ac:picMk id="4" creationId="{00000000-0000-0000-0000-000000000000}"/>
+          </ac:picMkLst>
+        </pc:picChg>
+        <pc:picChg chg="add mod">
+          <ac:chgData name="Dmitriy Ratushny" userId="08050032e8047aee" providerId="LiveId" clId="{78EB1A6D-D3A9-4525-A4D5-A50D4E20D487}" dt="2026-07-29T14:20:52.416" v="3208" actId="1076"/>
+          <ac:picMkLst>
+            <pc:docMk/>
+            <pc:sldMk cId="0" sldId="264"/>
+            <ac:picMk id="8" creationId="{591DEB87-1430-93AA-46A6-A24096F970A6}"/>
+          </ac:picMkLst>
+        </pc:picChg>
       </pc:sldChg>
-      <pc:sldChg chg="modSp mod">
-        <pc:chgData name="Dmitriy Ratushny" userId="08050032e8047aee" providerId="LiveId" clId="{78EB1A6D-D3A9-4525-A4D5-A50D4E20D487}" dt="2026-07-29T13:04:05.667" v="2732" actId="108"/>
+      <pc:sldChg chg="modSp del mod">
+        <pc:chgData name="Dmitriy Ratushny" userId="08050032e8047aee" providerId="LiveId" clId="{78EB1A6D-D3A9-4525-A4D5-A50D4E20D487}" dt="2026-07-29T14:43:48.988" v="3232" actId="47"/>
         <pc:sldMkLst>
           <pc:docMk/>
           <pc:sldMk cId="0" sldId="265"/>
@@ -551,8 +592,8 @@
           </ac:spMkLst>
         </pc:spChg>
       </pc:sldChg>
-      <pc:sldChg chg="modSp mod">
-        <pc:chgData name="Dmitriy Ratushny" userId="08050032e8047aee" providerId="LiveId" clId="{78EB1A6D-D3A9-4525-A4D5-A50D4E20D487}" dt="2026-07-29T13:04:49.312" v="2752" actId="207"/>
+      <pc:sldChg chg="delSp modSp mod">
+        <pc:chgData name="Dmitriy Ratushny" userId="08050032e8047aee" providerId="LiveId" clId="{78EB1A6D-D3A9-4525-A4D5-A50D4E20D487}" dt="2026-07-29T14:50:10.583" v="3238" actId="478"/>
         <pc:sldMkLst>
           <pc:docMk/>
           <pc:sldMk cId="0" sldId="266"/>
@@ -563,6 +604,14 @@
             <pc:docMk/>
             <pc:sldMk cId="0" sldId="266"/>
             <ac:spMk id="2" creationId="{00000000-0000-0000-0000-000000000000}"/>
+          </ac:spMkLst>
+        </pc:spChg>
+        <pc:spChg chg="del">
+          <ac:chgData name="Dmitriy Ratushny" userId="08050032e8047aee" providerId="LiveId" clId="{78EB1A6D-D3A9-4525-A4D5-A50D4E20D487}" dt="2026-07-29T14:50:10.583" v="3238" actId="478"/>
+          <ac:spMkLst>
+            <pc:docMk/>
+            <pc:sldMk cId="0" sldId="266"/>
+            <ac:spMk id="6" creationId="{00000000-0000-0000-0000-000000000000}"/>
           </ac:spMkLst>
         </pc:spChg>
       </pc:sldChg>
@@ -582,7 +631,7 @@
         </pc:spChg>
       </pc:sldChg>
       <pc:sldChg chg="modSp mod">
-        <pc:chgData name="Dmitriy Ratushny" userId="08050032e8047aee" providerId="LiveId" clId="{78EB1A6D-D3A9-4525-A4D5-A50D4E20D487}" dt="2026-07-29T13:05:04.462" v="2776" actId="207"/>
+        <pc:chgData name="Dmitriy Ratushny" userId="08050032e8047aee" providerId="LiveId" clId="{78EB1A6D-D3A9-4525-A4D5-A50D4E20D487}" dt="2026-07-29T15:04:33.733" v="3319" actId="20577"/>
         <pc:sldMkLst>
           <pc:docMk/>
           <pc:sldMk cId="0" sldId="268"/>
@@ -593,6 +642,14 @@
             <pc:docMk/>
             <pc:sldMk cId="0" sldId="268"/>
             <ac:spMk id="2" creationId="{00000000-0000-0000-0000-000000000000}"/>
+          </ac:spMkLst>
+        </pc:spChg>
+        <pc:spChg chg="mod">
+          <ac:chgData name="Dmitriy Ratushny" userId="08050032e8047aee" providerId="LiveId" clId="{78EB1A6D-D3A9-4525-A4D5-A50D4E20D487}" dt="2026-07-29T15:04:33.733" v="3319" actId="20577"/>
+          <ac:spMkLst>
+            <pc:docMk/>
+            <pc:sldMk cId="0" sldId="268"/>
+            <ac:spMk id="5" creationId="{00000000-0000-0000-0000-000000000000}"/>
           </ac:spMkLst>
         </pc:spChg>
       </pc:sldChg>
@@ -789,6 +846,161 @@
           </ac:picMkLst>
         </pc:picChg>
       </pc:sldChg>
+      <pc:sldChg chg="modSp add del mod">
+        <pc:chgData name="Dmitriy Ratushny" userId="08050032e8047aee" providerId="LiveId" clId="{78EB1A6D-D3A9-4525-A4D5-A50D4E20D487}" dt="2026-07-29T14:26:27.229" v="3215" actId="47"/>
+        <pc:sldMkLst>
+          <pc:docMk/>
+          <pc:sldMk cId="0" sldId="279"/>
+        </pc:sldMkLst>
+        <pc:spChg chg="mod">
+          <ac:chgData name="Dmitriy Ratushny" userId="08050032e8047aee" providerId="LiveId" clId="{78EB1A6D-D3A9-4525-A4D5-A50D4E20D487}" dt="2026-07-29T14:14:04.290" v="3195" actId="20577"/>
+          <ac:spMkLst>
+            <pc:docMk/>
+            <pc:sldMk cId="0" sldId="279"/>
+            <ac:spMk id="2" creationId="{00000000-0000-0000-0000-000000000000}"/>
+          </ac:spMkLst>
+        </pc:spChg>
+        <pc:spChg chg="mod">
+          <ac:chgData name="Dmitriy Ratushny" userId="08050032e8047aee" providerId="LiveId" clId="{78EB1A6D-D3A9-4525-A4D5-A50D4E20D487}" dt="2026-07-29T14:26:04.164" v="3210" actId="1076"/>
+          <ac:spMkLst>
+            <pc:docMk/>
+            <pc:sldMk cId="0" sldId="279"/>
+            <ac:spMk id="7" creationId="{00000000-0000-0000-0000-000000000000}"/>
+          </ac:spMkLst>
+        </pc:spChg>
+        <pc:picChg chg="mod">
+          <ac:chgData name="Dmitriy Ratushny" userId="08050032e8047aee" providerId="LiveId" clId="{78EB1A6D-D3A9-4525-A4D5-A50D4E20D487}" dt="2026-07-29T14:21:43.296" v="3209" actId="1076"/>
+          <ac:picMkLst>
+            <pc:docMk/>
+            <pc:sldMk cId="0" sldId="279"/>
+            <ac:picMk id="5" creationId="{00000000-0000-0000-0000-000000000000}"/>
+          </ac:picMkLst>
+        </pc:picChg>
+      </pc:sldChg>
+      <pc:sldChg chg="modSp add del">
+        <pc:chgData name="Dmitriy Ratushny" userId="08050032e8047aee" providerId="LiveId" clId="{78EB1A6D-D3A9-4525-A4D5-A50D4E20D487}" dt="2026-07-29T14:38:52.464" v="3218" actId="47"/>
+        <pc:sldMkLst>
+          <pc:docMk/>
+          <pc:sldMk cId="0" sldId="280"/>
+        </pc:sldMkLst>
+        <pc:spChg chg="mod">
+          <ac:chgData name="Dmitriy Ratushny" userId="08050032e8047aee" providerId="LiveId" clId="{78EB1A6D-D3A9-4525-A4D5-A50D4E20D487}" dt="2026-07-29T14:26:24.516" v="3214"/>
+          <ac:spMkLst>
+            <pc:docMk/>
+            <pc:sldMk cId="0" sldId="280"/>
+            <ac:spMk id="2" creationId="{00000000-0000-0000-0000-000000000000}"/>
+          </ac:spMkLst>
+        </pc:spChg>
+      </pc:sldChg>
+      <pc:sldChg chg="delSp modSp add mod">
+        <pc:chgData name="Dmitriy Ratushny" userId="08050032e8047aee" providerId="LiveId" clId="{78EB1A6D-D3A9-4525-A4D5-A50D4E20D487}" dt="2026-07-29T14:40:21.811" v="3224" actId="1076"/>
+        <pc:sldMkLst>
+          <pc:docMk/>
+          <pc:sldMk cId="0" sldId="281"/>
+        </pc:sldMkLst>
+        <pc:spChg chg="mod">
+          <ac:chgData name="Dmitriy Ratushny" userId="08050032e8047aee" providerId="LiveId" clId="{78EB1A6D-D3A9-4525-A4D5-A50D4E20D487}" dt="2026-07-29T14:38:50.970" v="3217"/>
+          <ac:spMkLst>
+            <pc:docMk/>
+            <pc:sldMk cId="0" sldId="281"/>
+            <ac:spMk id="2" creationId="{00000000-0000-0000-0000-000000000000}"/>
+          </ac:spMkLst>
+        </pc:spChg>
+        <pc:spChg chg="mod">
+          <ac:chgData name="Dmitriy Ratushny" userId="08050032e8047aee" providerId="LiveId" clId="{78EB1A6D-D3A9-4525-A4D5-A50D4E20D487}" dt="2026-07-29T14:40:21.811" v="3224" actId="1076"/>
+          <ac:spMkLst>
+            <pc:docMk/>
+            <pc:sldMk cId="0" sldId="281"/>
+            <ac:spMk id="6" creationId="{00000000-0000-0000-0000-000000000000}"/>
+          </ac:spMkLst>
+        </pc:spChg>
+        <pc:spChg chg="del">
+          <ac:chgData name="Dmitriy Ratushny" userId="08050032e8047aee" providerId="LiveId" clId="{78EB1A6D-D3A9-4525-A4D5-A50D4E20D487}" dt="2026-07-29T14:39:05.847" v="3219" actId="478"/>
+          <ac:spMkLst>
+            <pc:docMk/>
+            <pc:sldMk cId="0" sldId="281"/>
+            <ac:spMk id="7" creationId="{00000000-0000-0000-0000-000000000000}"/>
+          </ac:spMkLst>
+        </pc:spChg>
+        <pc:picChg chg="mod">
+          <ac:chgData name="Dmitriy Ratushny" userId="08050032e8047aee" providerId="LiveId" clId="{78EB1A6D-D3A9-4525-A4D5-A50D4E20D487}" dt="2026-07-29T14:40:09.032" v="3223" actId="1076"/>
+          <ac:picMkLst>
+            <pc:docMk/>
+            <pc:sldMk cId="0" sldId="281"/>
+            <ac:picMk id="5" creationId="{00000000-0000-0000-0000-000000000000}"/>
+          </ac:picMkLst>
+        </pc:picChg>
+      </pc:sldChg>
+      <pc:sldChg chg="addSp delSp modSp add mod">
+        <pc:chgData name="Dmitriy Ratushny" userId="08050032e8047aee" providerId="LiveId" clId="{78EB1A6D-D3A9-4525-A4D5-A50D4E20D487}" dt="2026-07-29T15:01:17.742" v="3269" actId="1076"/>
+        <pc:sldMkLst>
+          <pc:docMk/>
+          <pc:sldMk cId="0" sldId="282"/>
+        </pc:sldMkLst>
+        <pc:spChg chg="mod">
+          <ac:chgData name="Dmitriy Ratushny" userId="08050032e8047aee" providerId="LiveId" clId="{78EB1A6D-D3A9-4525-A4D5-A50D4E20D487}" dt="2026-07-29T14:43:43.885" v="3231"/>
+          <ac:spMkLst>
+            <pc:docMk/>
+            <pc:sldMk cId="0" sldId="282"/>
+            <ac:spMk id="2" creationId="{00000000-0000-0000-0000-000000000000}"/>
+          </ac:spMkLst>
+        </pc:spChg>
+        <pc:spChg chg="mod">
+          <ac:chgData name="Dmitriy Ratushny" userId="08050032e8047aee" providerId="LiveId" clId="{78EB1A6D-D3A9-4525-A4D5-A50D4E20D487}" dt="2026-07-29T14:52:09.039" v="3253" actId="1076"/>
+          <ac:spMkLst>
+            <pc:docMk/>
+            <pc:sldMk cId="0" sldId="282"/>
+            <ac:spMk id="5" creationId="{00000000-0000-0000-0000-000000000000}"/>
+          </ac:spMkLst>
+        </pc:spChg>
+        <pc:spChg chg="del mod">
+          <ac:chgData name="Dmitriy Ratushny" userId="08050032e8047aee" providerId="LiveId" clId="{78EB1A6D-D3A9-4525-A4D5-A50D4E20D487}" dt="2026-07-29T14:44:54.403" v="3235" actId="478"/>
+          <ac:spMkLst>
+            <pc:docMk/>
+            <pc:sldMk cId="0" sldId="282"/>
+            <ac:spMk id="6" creationId="{00000000-0000-0000-0000-000000000000}"/>
+          </ac:spMkLst>
+        </pc:spChg>
+        <pc:picChg chg="del mod">
+          <ac:chgData name="Dmitriy Ratushny" userId="08050032e8047aee" providerId="LiveId" clId="{78EB1A6D-D3A9-4525-A4D5-A50D4E20D487}" dt="2026-07-29T14:51:37.882" v="3240" actId="478"/>
+          <ac:picMkLst>
+            <pc:docMk/>
+            <pc:sldMk cId="0" sldId="282"/>
+            <ac:picMk id="4" creationId="{00000000-0000-0000-0000-000000000000}"/>
+          </ac:picMkLst>
+        </pc:picChg>
+        <pc:picChg chg="add del mod">
+          <ac:chgData name="Dmitriy Ratushny" userId="08050032e8047aee" providerId="LiveId" clId="{78EB1A6D-D3A9-4525-A4D5-A50D4E20D487}" dt="2026-07-29T15:00:28.366" v="3259" actId="478"/>
+          <ac:picMkLst>
+            <pc:docMk/>
+            <pc:sldMk cId="0" sldId="282"/>
+            <ac:picMk id="8" creationId="{8C7726FE-9EFF-D61E-354E-2C27471AC428}"/>
+          </ac:picMkLst>
+        </pc:picChg>
+        <pc:picChg chg="add mod modCrop">
+          <ac:chgData name="Dmitriy Ratushny" userId="08050032e8047aee" providerId="LiveId" clId="{78EB1A6D-D3A9-4525-A4D5-A50D4E20D487}" dt="2026-07-29T15:01:17.742" v="3269" actId="1076"/>
+          <ac:picMkLst>
+            <pc:docMk/>
+            <pc:sldMk cId="0" sldId="282"/>
+            <ac:picMk id="10" creationId="{42C08F25-67CE-D88A-2AF5-D2B92CFFCE48}"/>
+          </ac:picMkLst>
+        </pc:picChg>
+      </pc:sldChg>
+      <pc:sldChg chg="delSp modSp add del mod">
+        <pc:chgData name="Dmitriy Ratushny" userId="08050032e8047aee" providerId="LiveId" clId="{78EB1A6D-D3A9-4525-A4D5-A50D4E20D487}" dt="2026-07-29T14:59:37.358" v="3258" actId="47"/>
+        <pc:sldMkLst>
+          <pc:docMk/>
+          <pc:sldMk cId="0" sldId="283"/>
+        </pc:sldMkLst>
+        <pc:spChg chg="del mod">
+          <ac:chgData name="Dmitriy Ratushny" userId="08050032e8047aee" providerId="LiveId" clId="{78EB1A6D-D3A9-4525-A4D5-A50D4E20D487}" dt="2026-07-29T14:59:33.455" v="3257" actId="478"/>
+          <ac:spMkLst>
+            <pc:docMk/>
+            <pc:sldMk cId="0" sldId="283"/>
+            <ac:spMk id="6" creationId="{00000000-0000-0000-0000-000000000000}"/>
+          </ac:spMkLst>
+        </pc:spChg>
+      </pc:sldChg>
     </pc:docChg>
   </pc:docChgLst>
 </pc:chgInfo>
@@ -1418,6 +1630,320 @@
 </file>
 
 <file path=ppt/notesSlides/notesSlide6.xml><?xml version="1.0" encoding="utf-8"?>
+<p:notes xmlns:a="http://schemas.openxmlformats.org/drawingml/2006/main" xmlns:r="http://schemas.openxmlformats.org/officeDocument/2006/relationships" xmlns:p="http://schemas.openxmlformats.org/presentationml/2006/main">
+  <p:cSld>
+    <p:spTree>
+      <p:nvGrpSpPr>
+        <p:cNvPr id="1" name=""/>
+        <p:cNvGrpSpPr/>
+        <p:nvPr/>
+      </p:nvGrpSpPr>
+      <p:grpSpPr>
+        <a:xfrm>
+          <a:off x="0" y="0"/>
+          <a:ext cx="0" cy="0"/>
+          <a:chOff x="0" y="0"/>
+          <a:chExt cx="0" cy="0"/>
+        </a:xfrm>
+      </p:grpSpPr>
+      <p:sp>
+        <p:nvSpPr>
+          <p:cNvPr id="2" name="Slide Image Placeholder 1"/>
+          <p:cNvSpPr>
+            <a:spLocks noGrp="1" noRot="1" noChangeAspect="1"/>
+          </p:cNvSpPr>
+          <p:nvPr>
+            <p:ph type="sldImg" idx="2"/>
+          </p:nvPr>
+        </p:nvSpPr>
+        <p:spPr/>
+      </p:sp>
+      <p:sp>
+        <p:nvSpPr>
+          <p:cNvPr id="3" name="Notes Placeholder 2"/>
+          <p:cNvSpPr>
+            <a:spLocks noGrp="1"/>
+          </p:cNvSpPr>
+          <p:nvPr>
+            <p:ph type="body" sz="quarter" idx="3"/>
+          </p:nvPr>
+        </p:nvSpPr>
+        <p:spPr/>
+        <p:txBody>
+          <a:bodyPr/>
+          <a:lstStyle/>
+          <a:p>
+            <a:r>
+              <a:t>The brief asks for performance, so lead with the confusion matrix and the threshold reasoning rather than with methodology.</a:t>
+            </a:r>
+          </a:p>
+          <a:p>
+            <a:endParaRPr/>
+          </a:p>
+          <a:p>
+            <a:r>
+              <a:t>Threshold 0.245, picked out of fold on F1. TP 39, FP 67, FN 15, TN 56. Recall 0.722, precision 0.368, 106 names on a 177-customer list. Lift over random is 1.21.</a:t>
+            </a:r>
+          </a:p>
+          <a:p>
+            <a:endParaRPr/>
+          </a:p>
+          <a:p>
+            <a:r>
+              <a:t>Deliberately no currency. src/economics.py carries an illustrative call cost and success rate; neither appears anywhere in the RavenStack tables, and every money figure downstream scales with them. If finance supplies real numbers the same slide takes them without changing shape. If asked for a dollar answer, say that and give the ratio.</a:t>
+            </a:r>
+          </a:p>
+          <a:p>
+            <a:endParaRPr/>
+          </a:p>
+          <a:p>
+            <a:r>
+              <a:t>The strongest line is the skip list. A model that cannot find a safe group cannot save anyone a phone call, which is the whole reason to rank in the first place.</a:t>
+            </a:r>
+          </a:p>
+          <a:p>
+            <a:endParaRPr/>
+          </a:p>
+          <a:p>
+            <a:r>
+              <a:t>One inconsistency worth owning if raised: the threshold maximises F1, which weights the two errors equally, while the argument above says they are not equal. A cost-minimising threshold needs the cost figures we do not have.</a:t>
+            </a:r>
+          </a:p>
+          <a:p>
+            <a:endParaRPr/>
+          </a:p>
+          <a:p>
+            <a:r>
+              <a:t>Built by build/fig_performance_html.py.</a:t>
+            </a:r>
+          </a:p>
+        </p:txBody>
+      </p:sp>
+      <p:sp>
+        <p:nvSpPr>
+          <p:cNvPr id="4" name="Slide Number Placeholder 3"/>
+          <p:cNvSpPr>
+            <a:spLocks noGrp="1"/>
+          </p:cNvSpPr>
+          <p:nvPr>
+            <p:ph type="sldNum" sz="quarter" idx="5"/>
+          </p:nvPr>
+        </p:nvSpPr>
+        <p:spPr/>
+      </p:sp>
+    </p:spTree>
+  </p:cSld>
+  <p:clrMapOvr>
+    <a:masterClrMapping/>
+  </p:clrMapOvr>
+</p:notes>
+</file>
+
+<file path=ppt/notesSlides/notesSlide7.xml><?xml version="1.0" encoding="utf-8"?>
+<p:notes xmlns:a="http://schemas.openxmlformats.org/drawingml/2006/main" xmlns:r="http://schemas.openxmlformats.org/officeDocument/2006/relationships" xmlns:p="http://schemas.openxmlformats.org/presentationml/2006/main">
+  <p:cSld>
+    <p:spTree>
+      <p:nvGrpSpPr>
+        <p:cNvPr id="1" name=""/>
+        <p:cNvGrpSpPr/>
+        <p:nvPr/>
+      </p:nvGrpSpPr>
+      <p:grpSpPr>
+        <a:xfrm>
+          <a:off x="0" y="0"/>
+          <a:ext cx="0" cy="0"/>
+          <a:chOff x="0" y="0"/>
+          <a:chExt cx="0" cy="0"/>
+        </a:xfrm>
+      </p:grpSpPr>
+      <p:sp>
+        <p:nvSpPr>
+          <p:cNvPr id="2" name="Slide Image Placeholder 1"/>
+          <p:cNvSpPr>
+            <a:spLocks noGrp="1" noRot="1" noChangeAspect="1"/>
+          </p:cNvSpPr>
+          <p:nvPr>
+            <p:ph type="sldImg" idx="2"/>
+          </p:nvPr>
+        </p:nvSpPr>
+        <p:spPr/>
+      </p:sp>
+      <p:sp>
+        <p:nvSpPr>
+          <p:cNvPr id="3" name="Notes Placeholder 2"/>
+          <p:cNvSpPr>
+            <a:spLocks noGrp="1"/>
+          </p:cNvSpPr>
+          <p:nvPr>
+            <p:ph type="body" sz="quarter" idx="3"/>
+          </p:nvPr>
+        </p:nvSpPr>
+        <p:spPr/>
+        <p:txBody>
+          <a:bodyPr/>
+          <a:lstStyle/>
+          <a:p>
+            <a:r>
+              <a:t>Companion to the performance slide, for the reviewer who wants the curves rather than a single operating point.</a:t>
+            </a:r>
+          </a:p>
+          <a:p>
+            <a:endParaRPr/>
+          </a:p>
+          <a:p>
+            <a:r>
+              <a:t>AUC here is 0.589 from pooled out-of-fold predictions, against 0.583 as the mean of per-fold AUCs on the ladder slide. Same quantity, two estimators; say so if the difference is noticed.</a:t>
+            </a:r>
+          </a:p>
+          <a:p>
+            <a:endParaRPr/>
+          </a:p>
+          <a:p>
+            <a:r>
+              <a:t>The PR floor is the point worth making. A reviewer who only sees AP = 0.378 may read it as weak-but-real; drawn against a 0.31 base rate it is plainly near-worthless. This is also why ROC-AUC is the headline metric across the four cutoffs, where churn rates run 17% to 31% and a PR floor would move underneath the comparison.</a:t>
+            </a:r>
+          </a:p>
+          <a:p>
+            <a:endParaRPr/>
+          </a:p>
+          <a:p>
+            <a:r>
+              <a:t>Calibration uses 5 quantile bins because 177 rows will not support more. The flat shape is characteristic of a model with little signal: predictions are pulled toward the base rate at both ends.</a:t>
+            </a:r>
+          </a:p>
+          <a:p>
+            <a:endParaRPr/>
+          </a:p>
+          <a:p>
+            <a:r>
+              <a:t>Built by build/fig_curves_html.py.</a:t>
+            </a:r>
+          </a:p>
+        </p:txBody>
+      </p:sp>
+      <p:sp>
+        <p:nvSpPr>
+          <p:cNvPr id="4" name="Slide Number Placeholder 3"/>
+          <p:cNvSpPr>
+            <a:spLocks noGrp="1"/>
+          </p:cNvSpPr>
+          <p:nvPr>
+            <p:ph type="sldNum" sz="quarter" idx="5"/>
+          </p:nvPr>
+        </p:nvSpPr>
+        <p:spPr/>
+      </p:sp>
+    </p:spTree>
+  </p:cSld>
+  <p:clrMapOvr>
+    <a:masterClrMapping/>
+  </p:clrMapOvr>
+</p:notes>
+</file>
+
+<file path=ppt/notesSlides/notesSlide8.xml><?xml version="1.0" encoding="utf-8"?>
+<p:notes xmlns:a="http://schemas.openxmlformats.org/drawingml/2006/main" xmlns:r="http://schemas.openxmlformats.org/officeDocument/2006/relationships" xmlns:p="http://schemas.openxmlformats.org/presentationml/2006/main">
+  <p:cSld>
+    <p:spTree>
+      <p:nvGrpSpPr>
+        <p:cNvPr id="1" name=""/>
+        <p:cNvGrpSpPr/>
+        <p:nvPr/>
+      </p:nvGrpSpPr>
+      <p:grpSpPr>
+        <a:xfrm>
+          <a:off x="0" y="0"/>
+          <a:ext cx="0" cy="0"/>
+          <a:chOff x="0" y="0"/>
+          <a:chExt cx="0" cy="0"/>
+        </a:xfrm>
+      </p:grpSpPr>
+      <p:sp>
+        <p:nvSpPr>
+          <p:cNvPr id="2" name="Slide Image Placeholder 1"/>
+          <p:cNvSpPr>
+            <a:spLocks noGrp="1" noRot="1" noChangeAspect="1"/>
+          </p:cNvSpPr>
+          <p:nvPr>
+            <p:ph type="sldImg" idx="2"/>
+          </p:nvPr>
+        </p:nvSpPr>
+        <p:spPr/>
+      </p:sp>
+      <p:sp>
+        <p:nvSpPr>
+          <p:cNvPr id="3" name="Notes Placeholder 2"/>
+          <p:cNvSpPr>
+            <a:spLocks noGrp="1"/>
+          </p:cNvSpPr>
+          <p:nvPr>
+            <p:ph type="body" sz="quarter" idx="3"/>
+          </p:nvPr>
+        </p:nvSpPr>
+        <p:spPr/>
+        <p:txBody>
+          <a:bodyPr/>
+          <a:lstStyle/>
+          <a:p>
+            <a:r>
+              <a:t>Replaces the SHAP slide, which answered a question nobody asked. The brief asks what the model says is important, so answer that first, then say why it cannot be reported.</a:t>
+            </a:r>
+          </a:p>
+          <a:p>
+            <a:endParaRPr/>
+          </a:p>
+          <a:p>
+            <a:r>
+              <a:t>Reading coefficients directly is also the honest choice here. The shipped rung is Logistic L2 C=1 on standardised inputs, so the coefficients are the explanation. SHAP would add a layer of machinery over a linear model and change nothing.</a:t>
+            </a:r>
+          </a:p>
+          <a:p>
+            <a:endParaRPr/>
+          </a:p>
+          <a:p>
+            <a:r>
+              <a:t>The comparison that matters is against shuffled labels, not against zero. Any fitted model produces a clean ordered ranking; the question is whether it is larger than the ranking you get from nothing. Here it is not: largest real coefficient 1.45, chance reaches 1.68 at the 95th percentile, family-wise p = 0.222 over 500 refits.</a:t>
+            </a:r>
+          </a:p>
+          <a:p>
+            <a:endParaRPr/>
+          </a:p>
+          <a:p>
+            <a:r>
+              <a:t>If asked why the coefficient signs look stable across refits: five-fold folds share 80% of their rows, so sign agreement across them is close to guaranteed and is not evidence. The shuffle test is the one that carries weight.</a:t>
+            </a:r>
+          </a:p>
+          <a:p>
+            <a:endParaRPr/>
+          </a:p>
+          <a:p>
+            <a:r>
+              <a:t>Built by build/fig_drivers_html.py, tables in outputs/reports/coef_null.csv and coef_stability.csv.</a:t>
+            </a:r>
+          </a:p>
+        </p:txBody>
+      </p:sp>
+      <p:sp>
+        <p:nvSpPr>
+          <p:cNvPr id="4" name="Slide Number Placeholder 3"/>
+          <p:cNvSpPr>
+            <a:spLocks noGrp="1"/>
+          </p:cNvSpPr>
+          <p:nvPr>
+            <p:ph type="sldNum" sz="quarter" idx="5"/>
+          </p:nvPr>
+        </p:nvSpPr>
+        <p:spPr/>
+      </p:sp>
+    </p:spTree>
+  </p:cSld>
+  <p:clrMapOvr>
+    <a:masterClrMapping/>
+  </p:clrMapOvr>
+</p:notes>
+</file>
+
+<file path=ppt/notesSlides/notesSlide9.xml><?xml version="1.0" encoding="utf-8"?>
 <p:notes xmlns:a="http://schemas.openxmlformats.org/drawingml/2006/main" xmlns:r="http://schemas.openxmlformats.org/officeDocument/2006/relationships" xmlns:p="http://schemas.openxmlformats.org/presentationml/2006/main">
   <p:cSld>
     <p:spTree>
@@ -4990,7 +5516,11 @@
               </a:spcBef>
             </a:pPr>
             <a:r>
-              <a:rPr lang="en-US" sz="2800" b="1" dirty="0"/>
+              <a:rPr lang="en-US" sz="2800" b="1" dirty="0">
+                <a:solidFill>
+                  <a:srgbClr val="1A1A1A"/>
+                </a:solidFill>
+              </a:rPr>
               <a:t>Evaluate Performance</a:t>
             </a:r>
           </a:p>
@@ -5041,24 +5571,79 @@
           </a:p>
         </p:txBody>
       </p:sp>
+      <p:sp>
+        <p:nvSpPr>
+          <p:cNvPr id="4" name="TextBox 3"/>
+          <p:cNvSpPr txBox="1"/>
+          <p:nvPr/>
+        </p:nvSpPr>
+        <p:spPr>
+          <a:xfrm>
+            <a:off x="685800" y="1572768"/>
+            <a:ext cx="10820095" cy="4572000"/>
+          </a:xfrm>
+          <a:prstGeom prst="rect">
+            <a:avLst/>
+          </a:prstGeom>
+          <a:noFill/>
+        </p:spPr>
+        <p:txBody>
+          <a:bodyPr wrap="square">
+            <a:spAutoFit/>
+          </a:bodyPr>
+          <a:lstStyle/>
+          <a:p>
+            <a:pPr>
+              <a:spcAft>
+                <a:spcPts val="400"/>
+              </a:spcAft>
+            </a:pPr>
+            <a:r>
+              <a:rPr sz="1350" b="1" i="0">
+                <a:solidFill>
+                  <a:srgbClr val="1A1A1A"/>
+                </a:solidFill>
+                <a:latin typeface="Calibri"/>
+              </a:rPr>
+              <a:t>Logistic regression, L2 penalty, C = 1. It won the ten-rung ladder on the 30 June 2024 cohort: 177 customers, 54 of whom left within 90 days.</a:t>
+            </a:r>
+          </a:p>
+          <a:p>
+            <a:pPr lvl="1">
+              <a:spcAft>
+                <a:spcPts val="400"/>
+              </a:spcAft>
+            </a:pPr>
+            <a:r>
+              <a:rPr sz="1150" b="0" i="0">
+                <a:solidFill>
+                  <a:srgbClr val="5A6270"/>
+                </a:solidFill>
+                <a:latin typeface="Calibri"/>
+              </a:rPr>
+              <a:t>ROC-AUC 0.583 in cross-validation. Nested CV, which puts model selection inside the outer folds, gives 0.534 ± 0.016. Chance is 0.500. The 0.049 gap is selection optimism.</a:t>
+            </a:r>
+          </a:p>
+        </p:txBody>
+      </p:sp>
       <p:pic>
         <p:nvPicPr>
-          <p:cNvPr id="4" name="Picture 3" descr="09_selection_null.png"/>
+          <p:cNvPr id="5" name="Picture 4" descr="04_performance.png"/>
           <p:cNvPicPr>
             <a:picLocks noChangeAspect="1"/>
           </p:cNvPicPr>
           <p:nvPr/>
         </p:nvPicPr>
         <p:blipFill>
-          <a:blip r:embed="rId2"/>
+          <a:blip r:embed="rId3"/>
           <a:stretch>
             <a:fillRect/>
           </a:stretch>
         </p:blipFill>
         <p:spPr>
           <a:xfrm>
-            <a:off x="6812280" y="1783080"/>
-            <a:ext cx="4212139" cy="2331720"/>
+            <a:off x="2126707" y="2322575"/>
+            <a:ext cx="8623509" cy="3617489"/>
           </a:xfrm>
           <a:prstGeom prst="rect">
             <a:avLst/>
@@ -5067,14 +5652,14 @@
       </p:pic>
       <p:sp>
         <p:nvSpPr>
-          <p:cNvPr id="5" name="TextBox 4"/>
+          <p:cNvPr id="6" name="TextBox 5"/>
           <p:cNvSpPr txBox="1"/>
           <p:nvPr/>
         </p:nvSpPr>
         <p:spPr>
           <a:xfrm>
-            <a:off x="685800" y="1783080"/>
-            <a:ext cx="5760720" cy="1284967"/>
+            <a:off x="1112922" y="6036617"/>
+            <a:ext cx="10820095" cy="815608"/>
           </a:xfrm>
           <a:prstGeom prst="rect">
             <a:avLst/>
@@ -5089,231 +5674,83 @@
           <a:p>
             <a:pPr>
               <a:spcAft>
-                <a:spcPts val="500"/>
-              </a:spcAft>
-            </a:pPr>
-            <a:r>
-              <a:rPr lang="en-US" sz="1300" dirty="0">
+                <a:spcPts val="300"/>
+              </a:spcAft>
+            </a:pPr>
+            <a:r>
+              <a:rPr sz="1250" b="1" i="0" dirty="0">
+                <a:solidFill>
+                  <a:srgbClr val="1A1A1A"/>
+                </a:solidFill>
+                <a:latin typeface="Calibri"/>
+              </a:rPr>
+              <a:t>Threshold 0.245, chosen to </a:t>
+            </a:r>
+            <a:r>
+              <a:rPr sz="1250" b="1" i="0" dirty="0" err="1">
+                <a:solidFill>
+                  <a:srgbClr val="1A1A1A"/>
+                </a:solidFill>
+                <a:latin typeface="Calibri"/>
+              </a:rPr>
+              <a:t>maximise</a:t>
+            </a:r>
+            <a:r>
+              <a:rPr sz="1250" b="1" i="0" dirty="0">
+                <a:solidFill>
+                  <a:srgbClr val="1A1A1A"/>
+                </a:solidFill>
+                <a:latin typeface="Calibri"/>
+              </a:rPr>
+              <a:t> F1 on out-of-fold predictions rather than at the 0.5 default.</a:t>
+            </a:r>
+          </a:p>
+          <a:p>
+            <a:pPr lvl="1">
+              <a:spcAft>
+                <a:spcPts val="300"/>
+              </a:spcAft>
+            </a:pPr>
+            <a:r>
+              <a:rPr sz="1050" b="0" i="0" dirty="0">
                 <a:solidFill>
                   <a:srgbClr val="5A6270"/>
                 </a:solidFill>
-              </a:rPr>
-              <a:t>AUC measures how well the model sorts customers by risk. A coin flip scores 0.50. A perfect model scores 1.00</a:t>
-            </a:r>
-            <a:endParaRPr lang="en-US" sz="1300" dirty="0">
-              <a:solidFill>
-                <a:srgbClr val="5A6270"/>
-              </a:solidFill>
-              <a:latin typeface="Calibri"/>
-            </a:endParaRPr>
+                <a:latin typeface="Calibri"/>
+              </a:rPr>
+              <a:t>At that operating point: precision 0.368, recall 0.722, F1 0.487. The model recovers 39 of 54 leavers and puts 106 of 177 customers on the list.</a:t>
+            </a:r>
           </a:p>
           <a:p>
             <a:pPr>
               <a:spcAft>
-                <a:spcPts val="500"/>
-              </a:spcAft>
-            </a:pPr>
-            <a:r>
-              <a:rPr lang="en-US" sz="1300" dirty="0">
+                <a:spcPts val="300"/>
+              </a:spcAft>
+            </a:pPr>
+            <a:r>
+              <a:rPr sz="600" b="0" i="0" dirty="0">
+                <a:solidFill>
+                  <a:srgbClr val="1A1A1A"/>
+                </a:solidFill>
+                <a:latin typeface="Calibri"/>
+              </a:rPr>
+              <a:t> </a:t>
+            </a:r>
+          </a:p>
+          <a:p>
+            <a:pPr>
+              <a:spcAft>
+                <a:spcPts val="300"/>
+              </a:spcAft>
+            </a:pPr>
+            <a:r>
+              <a:rPr sz="1050" b="0" i="0" dirty="0">
                 <a:solidFill>
                   <a:srgbClr val="5A6270"/>
                 </a:solidFill>
-              </a:rPr>
-              <a:t>Coin flip · 0.500</a:t>
-            </a:r>
-          </a:p>
-          <a:p>
-            <a:pPr>
-              <a:spcAft>
-                <a:spcPts val="500"/>
-              </a:spcAft>
-            </a:pPr>
-            <a:r>
-              <a:rPr lang="en-US" sz="1300" dirty="0">
-                <a:solidFill>
-                  <a:srgbClr val="5A6270"/>
-                </a:solidFill>
-              </a:rPr>
-              <a:t>Our best model · 0.583</a:t>
-            </a:r>
-          </a:p>
-          <a:p>
-            <a:pPr>
-              <a:spcAft>
-                <a:spcPts val="500"/>
-              </a:spcAft>
-            </a:pPr>
-            <a:r>
-              <a:rPr lang="en-US" sz="1300" dirty="0">
-                <a:solidFill>
-                  <a:srgbClr val="5A6270"/>
-                </a:solidFill>
-              </a:rPr>
-              <a:t>Our best model, corrected · 0.534</a:t>
-            </a:r>
-            <a:r>
-              <a:rPr sz="600" b="0" i="0" dirty="0">
-                <a:solidFill>
-                  <a:srgbClr val="1A1A1A"/>
-                </a:solidFill>
-                <a:latin typeface="Calibri"/>
-              </a:rPr>
-              <a:t> </a:t>
-            </a:r>
-          </a:p>
-        </p:txBody>
-      </p:sp>
-      <p:sp>
-        <p:nvSpPr>
-          <p:cNvPr id="6" name="TextBox 5"/>
-          <p:cNvSpPr txBox="1"/>
-          <p:nvPr/>
-        </p:nvSpPr>
-        <p:spPr>
-          <a:xfrm>
-            <a:off x="685800" y="3363920"/>
-            <a:ext cx="5197643" cy="1469633"/>
-          </a:xfrm>
-          <a:prstGeom prst="rect">
-            <a:avLst/>
-          </a:prstGeom>
-          <a:noFill/>
-        </p:spPr>
-        <p:txBody>
-          <a:bodyPr wrap="square">
-            <a:spAutoFit/>
-          </a:bodyPr>
-          <a:lstStyle/>
-          <a:p>
-            <a:pPr>
-              <a:spcAft>
-                <a:spcPts val="500"/>
-              </a:spcAft>
-            </a:pPr>
-            <a:r>
-              <a:rPr lang="en-US" sz="1100" b="1" dirty="0">
-                <a:solidFill>
-                  <a:srgbClr val="5A6270"/>
-                </a:solidFill>
-              </a:rPr>
-              <a:t>Why the 0.583 is not a realistic measure</a:t>
-            </a:r>
-          </a:p>
-          <a:p>
-            <a:pPr marL="228600" indent="-228600">
-              <a:spcAft>
-                <a:spcPts val="500"/>
-              </a:spcAft>
-              <a:buFont typeface="+mj-lt"/>
-              <a:buAutoNum type="arabicPeriod"/>
-            </a:pPr>
-            <a:r>
-              <a:rPr lang="en-US" sz="1100" dirty="0">
-                <a:solidFill>
-                  <a:srgbClr val="5A6270"/>
-                </a:solidFill>
-              </a:rPr>
-              <a:t>I tried ten models and reported the best one. </a:t>
-            </a:r>
-          </a:p>
-          <a:p>
-            <a:pPr marL="228600" indent="-228600">
-              <a:spcAft>
-                <a:spcPts val="500"/>
-              </a:spcAft>
-              <a:buFont typeface="+mj-lt"/>
-              <a:buAutoNum type="arabicPeriod"/>
-            </a:pPr>
-            <a:r>
-              <a:rPr lang="en-US" sz="1100" dirty="0">
-                <a:solidFill>
-                  <a:srgbClr val="5A6270"/>
-                </a:solidFill>
-              </a:rPr>
-              <a:t>To measure how much, I shuffled the labels so there was genuinely nothing to learn, then ran the same ten-model search. Its winner scored 0.594 — higher than ours. Our number is what noise produces when you pick a winner from ten.</a:t>
-            </a:r>
-          </a:p>
-          <a:p>
-            <a:pPr marL="228600" indent="-228600">
-              <a:spcAft>
-                <a:spcPts val="500"/>
-              </a:spcAft>
-              <a:buFont typeface="+mj-lt"/>
-              <a:buAutoNum type="arabicPeriod"/>
-            </a:pPr>
-            <a:r>
-              <a:rPr lang="en-US" sz="1100" dirty="0">
-                <a:solidFill>
-                  <a:srgbClr val="5A6270"/>
-                </a:solidFill>
-              </a:rPr>
-              <a:t>A second check says the same thing: across 25 repeats, eight of the ten models won at least once. A genuinely better model wins nearly every time.</a:t>
-            </a:r>
-            <a:endParaRPr sz="1100" b="0" i="0" dirty="0">
-              <a:solidFill>
-                <a:srgbClr val="5A6270"/>
-              </a:solidFill>
-              <a:latin typeface="Calibri"/>
-            </a:endParaRPr>
-          </a:p>
-        </p:txBody>
-      </p:sp>
-      <p:sp>
-        <p:nvSpPr>
-          <p:cNvPr id="8" name="TextBox 7">
-            <a:extLst>
-              <a:ext uri="{FF2B5EF4-FFF2-40B4-BE49-F238E27FC236}">
-                <a16:creationId xmlns:a16="http://schemas.microsoft.com/office/drawing/2014/main" id="{12C611BC-1707-F619-DD30-259262FFA0D2}"/>
-              </a:ext>
-            </a:extLst>
-          </p:cNvPr>
-          <p:cNvSpPr txBox="1"/>
-          <p:nvPr/>
-        </p:nvSpPr>
-        <p:spPr>
-          <a:xfrm>
-            <a:off x="7044488" y="4142012"/>
-            <a:ext cx="3979931" cy="1569660"/>
-          </a:xfrm>
-          <a:prstGeom prst="rect">
-            <a:avLst/>
-          </a:prstGeom>
-          <a:noFill/>
-        </p:spPr>
-        <p:txBody>
-          <a:bodyPr wrap="square" rtlCol="0">
-            <a:spAutoFit/>
-          </a:bodyPr>
-          <a:lstStyle/>
-          <a:p>
-            <a:r>
-              <a:rPr lang="en-US" sz="1200" b="1" dirty="0">
-                <a:solidFill>
-                  <a:srgbClr val="9FD2CC"/>
-                </a:solidFill>
-              </a:rPr>
-              <a:t>Green</a:t>
-            </a:r>
-            <a:r>
-              <a:rPr lang="en-US" sz="1200" dirty="0"/>
-              <a:t> = every model, scored on shuffled labels. 20 shuffles × 15 models = 300 scores, all plotted. Mean 0.498 — pure chance, which is correct, since the labels were effectively removed</a:t>
-            </a:r>
-          </a:p>
-          <a:p>
-            <a:endParaRPr lang="en-US" sz="1200" dirty="0"/>
-          </a:p>
-          <a:p>
-            <a:r>
-              <a:rPr lang="en-US" sz="1200" b="1" dirty="0">
-                <a:solidFill>
-                  <a:srgbClr val="D6C782"/>
-                </a:solidFill>
-              </a:rPr>
-              <a:t>Orange</a:t>
-            </a:r>
-            <a:r>
-              <a:rPr lang="en-US" sz="1200" dirty="0"/>
-              <a:t> = the winner from each shuffle. For each of the 20 shuffles, take only the best of the 15 models. 20 values. Mean 0.566, reaching 0.624.</a:t>
+                <a:latin typeface="Calibri"/>
+              </a:rPr>
+              <a:t>.</a:t>
             </a:r>
           </a:p>
         </p:txBody>
@@ -5352,7 +5789,7 @@
         <p:spPr>
           <a:xfrm>
             <a:off x="685800" y="365760"/>
-            <a:ext cx="10820095" cy="759182"/>
+            <a:ext cx="10820095" cy="1051560"/>
           </a:xfrm>
           <a:prstGeom prst="rect">
             <a:avLst/>
@@ -5366,7 +5803,7 @@
           <a:lstStyle/>
           <a:p>
             <a:r>
-              <a:rPr sz="1200" b="1" i="0" dirty="0">
+              <a:rPr sz="1200" b="1" i="0">
                 <a:solidFill>
                   <a:srgbClr val="5A6270"/>
                 </a:solidFill>
@@ -5382,31 +5819,13 @@
               </a:spcBef>
             </a:pPr>
             <a:r>
-              <a:rPr sz="2800" b="1" i="0" dirty="0">
+              <a:rPr sz="2800" b="1" i="0">
                 <a:solidFill>
                   <a:srgbClr val="1A1A1A"/>
                 </a:solidFill>
                 <a:latin typeface="Calibri"/>
               </a:rPr>
-              <a:t>Class imbalance</a:t>
-            </a:r>
-            <a:r>
-              <a:rPr lang="en-US" sz="2800" b="1" i="0" dirty="0">
-                <a:solidFill>
-                  <a:srgbClr val="1A1A1A"/>
-                </a:solidFill>
-                <a:latin typeface="Calibri"/>
-              </a:rPr>
-              <a:t> and </a:t>
-            </a:r>
-            <a:r>
-              <a:rPr sz="2800" b="1" i="0" dirty="0">
-                <a:solidFill>
-                  <a:srgbClr val="1A1A1A"/>
-                </a:solidFill>
-                <a:latin typeface="Calibri"/>
-              </a:rPr>
-              <a:t>leakage</a:t>
+              <a:t>Ranking quality, three ways</a:t>
             </a:r>
           </a:p>
         </p:txBody>
@@ -5458,22 +5877,22 @@
       </p:sp>
       <p:pic>
         <p:nvPicPr>
-          <p:cNvPr id="4" name="Picture 3" descr="06_leakage_effect.png"/>
+          <p:cNvPr id="4" name="Picture 3" descr="04_curves_html.png"/>
           <p:cNvPicPr>
             <a:picLocks noChangeAspect="1"/>
           </p:cNvPicPr>
           <p:nvPr/>
         </p:nvPicPr>
         <p:blipFill>
-          <a:blip r:embed="rId2"/>
+          <a:blip r:embed="rId3"/>
           <a:stretch>
             <a:fillRect/>
           </a:stretch>
         </p:blipFill>
         <p:spPr>
           <a:xfrm>
-            <a:off x="6446520" y="1737360"/>
-            <a:ext cx="5533595" cy="3063240"/>
+            <a:off x="2449317" y="1572768"/>
+            <a:ext cx="7293060" cy="2788920"/>
           </a:xfrm>
           <a:prstGeom prst="rect">
             <a:avLst/>
@@ -5488,8 +5907,8 @@
         </p:nvSpPr>
         <p:spPr>
           <a:xfrm>
-            <a:off x="685800" y="1737360"/>
-            <a:ext cx="5486400" cy="3185487"/>
+            <a:off x="685798" y="4530952"/>
+            <a:ext cx="10820095" cy="4572000"/>
           </a:xfrm>
           <a:prstGeom prst="rect">
             <a:avLst/>
@@ -5504,167 +5923,113 @@
           <a:p>
             <a:pPr>
               <a:spcAft>
-                <a:spcPts val="600"/>
-              </a:spcAft>
-            </a:pPr>
-            <a:r>
-              <a:rPr sz="1350" b="1" i="0" dirty="0">
+                <a:spcPts val="300"/>
+              </a:spcAft>
+            </a:pPr>
+            <a:r>
+              <a:rPr sz="1250" b="1" i="0">
                 <a:solidFill>
                   <a:srgbClr val="1A1A1A"/>
                 </a:solidFill>
                 <a:latin typeface="Calibri"/>
               </a:rPr>
-              <a:t>Class imbalance</a:t>
+              <a:t>ROC-AUC 0.589 out of fold. The curve sits just above the diagonal for its whole length, with no region where the model separates cleanly.</a:t>
+            </a:r>
+          </a:p>
+          <a:p>
+            <a:pPr>
+              <a:spcAft>
+                <a:spcPts val="300"/>
+              </a:spcAft>
+            </a:pPr>
+            <a:r>
+              <a:rPr sz="600" b="0" i="0">
+                <a:solidFill>
+                  <a:srgbClr val="1A1A1A"/>
+                </a:solidFill>
+                <a:latin typeface="Calibri"/>
+              </a:rPr>
+              <a:t> </a:t>
+            </a:r>
+          </a:p>
+          <a:p>
+            <a:pPr>
+              <a:spcAft>
+                <a:spcPts val="300"/>
+              </a:spcAft>
+            </a:pPr>
+            <a:r>
+              <a:rPr sz="1250" b="1" i="0">
+                <a:solidFill>
+                  <a:srgbClr val="1A1A1A"/>
+                </a:solidFill>
+                <a:latin typeface="Calibri"/>
+              </a:rPr>
+              <a:t>Average precision 0.378 against a 0.31 base rate.</a:t>
             </a:r>
           </a:p>
           <a:p>
             <a:pPr lvl="1">
               <a:spcAft>
-                <a:spcPts val="600"/>
-              </a:spcAft>
-            </a:pPr>
-            <a:r>
-              <a:rPr sz="1150" b="0" i="0" dirty="0">
+                <a:spcPts val="300"/>
+              </a:spcAft>
+            </a:pPr>
+            <a:r>
+              <a:rPr sz="1050" b="0" i="0">
                 <a:solidFill>
                   <a:srgbClr val="5A6270"/>
                 </a:solidFill>
                 <a:latin typeface="Calibri"/>
               </a:rPr>
-              <a:t>31% of customers left, so the classes are uneven but not badly so. I weight the rare class rather than inventing synthetic customers: with 54 real examples, synthetic ones are copies of copies and they flatter the score.</a:t>
+              <a:t>PR is the honest picture for an imbalanced problem, because its floor moves with the class balance rather than staying at 0.50. Precision hovers just above the base-rate line at every recall, which is the same finding as the confusion matrix: flagging a customer barely raises their risk.</a:t>
+            </a:r>
+          </a:p>
+          <a:p>
+            <a:pPr>
+              <a:spcAft>
+                <a:spcPts val="300"/>
+              </a:spcAft>
+            </a:pPr>
+            <a:r>
+              <a:rPr sz="600" b="0" i="0">
+                <a:solidFill>
+                  <a:srgbClr val="1A1A1A"/>
+                </a:solidFill>
+                <a:latin typeface="Calibri"/>
+              </a:rPr>
+              <a:t> </a:t>
+            </a:r>
+          </a:p>
+          <a:p>
+            <a:pPr>
+              <a:spcAft>
+                <a:spcPts val="300"/>
+              </a:spcAft>
+            </a:pPr>
+            <a:r>
+              <a:rPr sz="1250" b="1" i="0">
+                <a:solidFill>
+                  <a:srgbClr val="1A1A1A"/>
+                </a:solidFill>
+                <a:latin typeface="Calibri"/>
+              </a:rPr>
+              <a:t>Calibration is the reason the break-even argument is usable.</a:t>
             </a:r>
           </a:p>
           <a:p>
             <a:pPr lvl="1">
               <a:spcAft>
-                <a:spcPts val="600"/>
-              </a:spcAft>
-            </a:pPr>
-            <a:r>
-              <a:rPr sz="1150" b="0" i="0" dirty="0">
+                <a:spcPts val="300"/>
+              </a:spcAft>
+            </a:pPr>
+            <a:r>
+              <a:rPr sz="1050" b="0" i="0">
                 <a:solidFill>
                   <a:srgbClr val="5A6270"/>
                 </a:solidFill>
                 <a:latin typeface="Calibri"/>
               </a:rPr>
-              <a:t>I set the cut-off to </a:t>
-            </a:r>
-            <a:r>
-              <a:rPr sz="1150" b="0" i="0" dirty="0" err="1">
-                <a:solidFill>
-                  <a:srgbClr val="5A6270"/>
-                </a:solidFill>
-                <a:latin typeface="Calibri"/>
-              </a:rPr>
-              <a:t>favour</a:t>
-            </a:r>
-            <a:r>
-              <a:rPr sz="1150" b="0" i="0" dirty="0">
-                <a:solidFill>
-                  <a:srgbClr val="5A6270"/>
-                </a:solidFill>
-                <a:latin typeface="Calibri"/>
-              </a:rPr>
-              <a:t> catching </a:t>
-            </a:r>
-            <a:r>
-              <a:rPr lang="en-US" sz="1150" b="0" i="0" dirty="0">
-                <a:solidFill>
-                  <a:srgbClr val="5A6270"/>
-                </a:solidFill>
-                <a:latin typeface="Calibri"/>
-              </a:rPr>
-              <a:t>customers who churned</a:t>
-            </a:r>
-            <a:r>
-              <a:rPr sz="1150" b="0" i="0" dirty="0">
-                <a:solidFill>
-                  <a:srgbClr val="5A6270"/>
-                </a:solidFill>
-                <a:latin typeface="Calibri"/>
-              </a:rPr>
-              <a:t>, because missing one costs far more than a wasted phone call. That gives 75% of </a:t>
-            </a:r>
-            <a:r>
-              <a:rPr lang="en-US" sz="1150" b="0" i="0" dirty="0">
-                <a:solidFill>
-                  <a:srgbClr val="5A6270"/>
-                </a:solidFill>
-                <a:latin typeface="Calibri"/>
-              </a:rPr>
-              <a:t>customers who churned</a:t>
-            </a:r>
-            <a:r>
-              <a:rPr sz="1150" b="0" i="0" dirty="0">
-                <a:solidFill>
-                  <a:srgbClr val="5A6270"/>
-                </a:solidFill>
-                <a:latin typeface="Calibri"/>
-              </a:rPr>
-              <a:t> caught, and 1 in 3 of the flagged customers actually leaving.</a:t>
-            </a:r>
-          </a:p>
-          <a:p>
-            <a:pPr lvl="1">
-              <a:spcAft>
-                <a:spcPts val="600"/>
-              </a:spcAft>
-            </a:pPr>
-            <a:r>
-              <a:rPr sz="1150" b="0" i="0" dirty="0">
-                <a:solidFill>
-                  <a:srgbClr val="5A6270"/>
-                </a:solidFill>
-                <a:latin typeface="Calibri"/>
-              </a:rPr>
-              <a:t>I report ROC-AUC because its baseline stays 0.50 at any class balance, which keeps the twelve horizon cells comparable when their churn rates run 11% to 45%. Precision-recall and F1 agree.</a:t>
-            </a:r>
-          </a:p>
-          <a:p>
-            <a:pPr>
-              <a:spcAft>
-                <a:spcPts val="600"/>
-              </a:spcAft>
-            </a:pPr>
-            <a:r>
-              <a:rPr sz="600" b="0" i="0" dirty="0">
-                <a:solidFill>
-                  <a:srgbClr val="1A1A1A"/>
-                </a:solidFill>
-                <a:latin typeface="Calibri"/>
-              </a:rPr>
-              <a:t> </a:t>
-            </a:r>
-          </a:p>
-          <a:p>
-            <a:pPr>
-              <a:spcAft>
-                <a:spcPts val="600"/>
-              </a:spcAft>
-            </a:pPr>
-            <a:r>
-              <a:rPr sz="1350" b="1" i="0" dirty="0">
-                <a:solidFill>
-                  <a:srgbClr val="B02E2E"/>
-                </a:solidFill>
-                <a:latin typeface="Calibri"/>
-              </a:rPr>
-              <a:t>I do not rely on reading the code to catch leakage.</a:t>
-            </a:r>
-          </a:p>
-          <a:p>
-            <a:pPr lvl="1">
-              <a:spcAft>
-                <a:spcPts val="600"/>
-              </a:spcAft>
-            </a:pPr>
-            <a:r>
-              <a:rPr sz="1150" b="0" i="0" dirty="0">
-                <a:solidFill>
-                  <a:srgbClr val="5A6270"/>
-                </a:solidFill>
-                <a:latin typeface="Calibri"/>
-              </a:rPr>
-              <a:t>Automatic checks run before any result is reported and block it if anything fails. They look for dates after the cutoff, banned columns by name, and any single feature that predicts too well.</a:t>
+              <a:t>Predicted probabilities track observed churn well enough in the middle bins to compare a score against a decision threshold. The curve is flat rather than diagonal, which is what a weak model looks like — it over-predicts at the bottom and under-predicts at the top.</a:t>
             </a:r>
           </a:p>
         </p:txBody>
@@ -5677,8 +6042,8 @@
         </p:nvSpPr>
         <p:spPr>
           <a:xfrm>
-            <a:off x="685800" y="6126480"/>
-            <a:ext cx="10820095" cy="502920"/>
+            <a:off x="734079" y="6445317"/>
+            <a:ext cx="10723841" cy="269304"/>
           </a:xfrm>
           <a:prstGeom prst="rect">
             <a:avLst/>
@@ -5692,13 +6057,13 @@
           <a:lstStyle/>
           <a:p>
             <a:r>
-              <a:rPr sz="1150" b="0" i="1">
-                <a:solidFill>
-                  <a:srgbClr val="1A1A1A"/>
-                </a:solidFill>
-                <a:latin typeface="Calibri"/>
-              </a:rPr>
-              <a:t>The chart is why those checks earn their place. Columns that only exist after a customer leaves are worth 0.37 of extra AUC — they push the model to 0.79, which looks like a good model rather than a broken one. A pipeline that lets the future in scores 0.42, below guessing. Both failures are invisible in the score alone.</a:t>
+              <a:rPr sz="1150" b="0" i="1" dirty="0">
+                <a:solidFill>
+                  <a:srgbClr val="5A6270"/>
+                </a:solidFill>
+                <a:latin typeface="Calibri"/>
+              </a:rPr>
+              <a:t>The red dot on each panel is the shipped threshold of 0.245.</a:t>
             </a:r>
           </a:p>
         </p:txBody>
@@ -5767,13 +6132,31 @@
               </a:spcBef>
             </a:pPr>
             <a:r>
-              <a:rPr sz="2800" b="1" dirty="0">
+              <a:rPr sz="2800" b="1" i="0" dirty="0">
                 <a:solidFill>
                   <a:srgbClr val="1A1A1A"/>
                 </a:solidFill>
                 <a:latin typeface="Calibri"/>
               </a:rPr>
-              <a:t>Interpretability</a:t>
+              <a:t>Class imbalance</a:t>
+            </a:r>
+            <a:r>
+              <a:rPr lang="en-US" sz="2800" b="1" i="0" dirty="0">
+                <a:solidFill>
+                  <a:srgbClr val="1A1A1A"/>
+                </a:solidFill>
+                <a:latin typeface="Calibri"/>
+              </a:rPr>
+              <a:t> and </a:t>
+            </a:r>
+            <a:r>
+              <a:rPr sz="2800" b="1" i="0" dirty="0">
+                <a:solidFill>
+                  <a:srgbClr val="1A1A1A"/>
+                </a:solidFill>
+                <a:latin typeface="Calibri"/>
+              </a:rPr>
+              <a:t>leakage</a:t>
             </a:r>
           </a:p>
         </p:txBody>
@@ -5823,9 +6206,166 @@
           </a:p>
         </p:txBody>
       </p:sp>
+      <p:sp>
+        <p:nvSpPr>
+          <p:cNvPr id="5" name="TextBox 4"/>
+          <p:cNvSpPr txBox="1"/>
+          <p:nvPr/>
+        </p:nvSpPr>
+        <p:spPr>
+          <a:xfrm>
+            <a:off x="259081" y="1460773"/>
+            <a:ext cx="5486400" cy="2716128"/>
+          </a:xfrm>
+          <a:prstGeom prst="rect">
+            <a:avLst/>
+          </a:prstGeom>
+          <a:noFill/>
+        </p:spPr>
+        <p:txBody>
+          <a:bodyPr wrap="square">
+            <a:spAutoFit/>
+          </a:bodyPr>
+          <a:lstStyle/>
+          <a:p>
+            <a:pPr>
+              <a:spcAft>
+                <a:spcPts val="600"/>
+              </a:spcAft>
+            </a:pPr>
+            <a:r>
+              <a:rPr sz="1350" b="1" i="0" dirty="0">
+                <a:solidFill>
+                  <a:srgbClr val="1A1A1A"/>
+                </a:solidFill>
+                <a:latin typeface="Calibri"/>
+              </a:rPr>
+              <a:t>Class imbalance</a:t>
+            </a:r>
+            <a:endParaRPr lang="en-US" sz="1350" b="1" i="0" dirty="0">
+              <a:solidFill>
+                <a:srgbClr val="1A1A1A"/>
+              </a:solidFill>
+              <a:latin typeface="Calibri"/>
+            </a:endParaRPr>
+          </a:p>
+          <a:p>
+            <a:pPr>
+              <a:spcAft>
+                <a:spcPts val="600"/>
+              </a:spcAft>
+            </a:pPr>
+            <a:r>
+              <a:rPr lang="en-US" sz="1350" b="1" dirty="0">
+                <a:solidFill>
+                  <a:srgbClr val="1A1A1A"/>
+                </a:solidFill>
+                <a:latin typeface="Calibri"/>
+              </a:rPr>
+              <a:t>	</a:t>
+            </a:r>
+            <a:r>
+              <a:rPr lang="en-US" sz="900" i="1" dirty="0"/>
+              <a:t>Class imbalance is when the classes in the target variable are unevenly distributed — one class holds a 	much larger share of the observations than the other.</a:t>
+            </a:r>
+            <a:endParaRPr sz="900" i="1" dirty="0"/>
+          </a:p>
+          <a:p>
+            <a:pPr marL="685800" lvl="1" indent="-228600">
+              <a:spcAft>
+                <a:spcPts val="600"/>
+              </a:spcAft>
+              <a:buFont typeface="+mj-lt"/>
+              <a:buAutoNum type="arabicPeriod"/>
+            </a:pPr>
+            <a:r>
+              <a:rPr lang="en-US" sz="1150" dirty="0">
+                <a:solidFill>
+                  <a:srgbClr val="5A6270"/>
+                </a:solidFill>
+              </a:rPr>
+              <a:t>31% of customers churned. That is uneven, but it is not a rare-event problem, and it does not need heavy handling.</a:t>
+            </a:r>
+            <a:endParaRPr lang="en-US" sz="1150" b="0" i="0" dirty="0">
+              <a:solidFill>
+                <a:srgbClr val="5A6270"/>
+              </a:solidFill>
+              <a:latin typeface="Calibri"/>
+            </a:endParaRPr>
+          </a:p>
+          <a:p>
+            <a:pPr marL="685800" lvl="1" indent="-228600">
+              <a:spcAft>
+                <a:spcPts val="600"/>
+              </a:spcAft>
+              <a:buFont typeface="+mj-lt"/>
+              <a:buAutoNum type="arabicPeriod"/>
+            </a:pPr>
+            <a:r>
+              <a:rPr lang="en-US" sz="1150" dirty="0">
+                <a:solidFill>
+                  <a:srgbClr val="5A6270"/>
+                </a:solidFill>
+              </a:rPr>
+              <a:t>I set the cut-off to favor catching customers who churned, because missing one likely costs more than unnecessary intervention. That catches 72% of the customers who churned, and 1 in 3 of the customers we flag do churn.</a:t>
+            </a:r>
+            <a:endParaRPr lang="en-US" sz="1150" b="0" i="0" dirty="0">
+              <a:solidFill>
+                <a:srgbClr val="5A6270"/>
+              </a:solidFill>
+              <a:latin typeface="Calibri"/>
+            </a:endParaRPr>
+          </a:p>
+          <a:p>
+            <a:pPr marL="685800" lvl="1" indent="-228600">
+              <a:spcAft>
+                <a:spcPts val="600"/>
+              </a:spcAft>
+              <a:buFont typeface="+mj-lt"/>
+              <a:buAutoNum type="arabicPeriod"/>
+            </a:pPr>
+            <a:r>
+              <a:rPr lang="en-US" sz="1150" dirty="0">
+                <a:solidFill>
+                  <a:srgbClr val="5A6270"/>
+                </a:solidFill>
+              </a:rPr>
+              <a:t>I report ROC-AUC because its floor stays at 0.50 whatever the class balance. That matters here: across the twelve horizon and buffer combinations the churn rate runs from 11% to 45%, and a metric that moved with the balance would make those twelve results incomparable. Precision-recall and F1 agree.</a:t>
+            </a:r>
+            <a:endParaRPr sz="1150" b="0" i="0" dirty="0">
+              <a:solidFill>
+                <a:srgbClr val="5A6270"/>
+              </a:solidFill>
+              <a:latin typeface="Calibri"/>
+            </a:endParaRPr>
+          </a:p>
+          <a:p>
+            <a:pPr>
+              <a:spcAft>
+                <a:spcPts val="600"/>
+              </a:spcAft>
+            </a:pPr>
+            <a:r>
+              <a:rPr sz="600" b="0" i="0" dirty="0">
+                <a:solidFill>
+                  <a:srgbClr val="1A1A1A"/>
+                </a:solidFill>
+                <a:latin typeface="Calibri"/>
+              </a:rPr>
+              <a:t> </a:t>
+            </a:r>
+          </a:p>
+        </p:txBody>
+      </p:sp>
       <p:pic>
         <p:nvPicPr>
-          <p:cNvPr id="4" name="Picture 3" descr="13_shap_real_vs_shuffled.png"/>
+          <p:cNvPr id="8" name="Picture 7">
+            <a:extLst>
+              <a:ext uri="{FF2B5EF4-FFF2-40B4-BE49-F238E27FC236}">
+                <a16:creationId xmlns:a16="http://schemas.microsoft.com/office/drawing/2014/main" id="{591DEB87-1430-93AA-46A6-A24096F970A6}"/>
+              </a:ext>
+            </a:extLst>
+          </p:cNvPr>
           <p:cNvPicPr>
             <a:picLocks noChangeAspect="1"/>
           </p:cNvPicPr>
@@ -5839,8 +6379,8 @@
         </p:blipFill>
         <p:spPr>
           <a:xfrm>
-            <a:off x="2260186" y="1572768"/>
-            <a:ext cx="7671323" cy="2514600"/>
+            <a:off x="1415255" y="4110064"/>
+            <a:ext cx="9361183" cy="2574326"/>
           </a:xfrm>
           <a:prstGeom prst="rect">
             <a:avLst/>
@@ -5849,14 +6389,20 @@
       </p:pic>
       <p:sp>
         <p:nvSpPr>
-          <p:cNvPr id="5" name="TextBox 4"/>
+          <p:cNvPr id="10" name="TextBox 9">
+            <a:extLst>
+              <a:ext uri="{FF2B5EF4-FFF2-40B4-BE49-F238E27FC236}">
+                <a16:creationId xmlns:a16="http://schemas.microsoft.com/office/drawing/2014/main" id="{59D5E82D-6C5D-1F05-AF59-8F1C90CA5BFE}"/>
+              </a:ext>
+            </a:extLst>
+          </p:cNvPr>
           <p:cNvSpPr txBox="1"/>
           <p:nvPr/>
         </p:nvSpPr>
         <p:spPr>
           <a:xfrm>
-            <a:off x="685800" y="4315968"/>
-            <a:ext cx="10820095" cy="4572000"/>
+            <a:off x="5745481" y="1460773"/>
+            <a:ext cx="6097002" cy="2485296"/>
           </a:xfrm>
           <a:prstGeom prst="rect">
             <a:avLst/>
@@ -5871,84 +6417,104 @@
           <a:p>
             <a:pPr>
               <a:spcAft>
-                <a:spcPts val="400"/>
-              </a:spcAft>
-            </a:pPr>
-            <a:r>
-              <a:rPr sz="1250" b="1" i="0">
-                <a:solidFill>
-                  <a:srgbClr val="B02E2E"/>
-                </a:solidFill>
-                <a:latin typeface="Calibri"/>
-              </a:rPr>
-              <a:t>These are the same chart. The right-hand one is built from labels I shuffled at random — and it is more confident about its winner than the real one is.</a:t>
-            </a:r>
-          </a:p>
-          <a:p>
-            <a:pPr>
-              <a:spcAft>
-                <a:spcPts val="400"/>
-              </a:spcAft>
-            </a:pPr>
-            <a:r>
-              <a:rPr sz="1250" b="1" i="0">
-                <a:solidFill>
-                  <a:srgbClr val="1A1A1A"/>
-                </a:solidFill>
-                <a:latin typeface="Calibri"/>
-              </a:rPr>
-              <a:t>SHAP will always return a clean, ordered, plausible ranking. It has no way to tell you it has nothing to say, which is why every attribution method here is paired with a random baseline before it is believed.</a:t>
-            </a:r>
-          </a:p>
-          <a:p>
-            <a:pPr>
-              <a:spcAft>
-                <a:spcPts val="400"/>
-              </a:spcAft>
-            </a:pPr>
-            <a:r>
-              <a:rPr sz="1250" b="0" i="0">
-                <a:solidFill>
-                  <a:srgbClr val="1A1A1A"/>
-                </a:solidFill>
-                <a:latin typeface="Calibri"/>
-              </a:rPr>
-              <a:t>The numbers underneath: the top feature beats random labels only 3 times in 4 (p = 0.24). Twelve different features take first place across 25 reruns. Permutation importance on held-out data is beaten by noise outright.</a:t>
-            </a:r>
-          </a:p>
-        </p:txBody>
-      </p:sp>
-      <p:sp>
-        <p:nvSpPr>
-          <p:cNvPr id="6" name="TextBox 5"/>
-          <p:cNvSpPr txBox="1"/>
-          <p:nvPr/>
-        </p:nvSpPr>
-        <p:spPr>
-          <a:xfrm>
-            <a:off x="685800" y="6126480"/>
-            <a:ext cx="10820095" cy="502920"/>
-          </a:xfrm>
-          <a:prstGeom prst="rect">
-            <a:avLst/>
-          </a:prstGeom>
-          <a:noFill/>
-        </p:spPr>
-        <p:txBody>
-          <a:bodyPr wrap="square">
-            <a:spAutoFit/>
-          </a:bodyPr>
-          <a:lstStyle/>
-          <a:p>
-            <a:r>
-              <a:rPr sz="1150" b="0" i="1">
+                <a:spcPts val="600"/>
+              </a:spcAft>
+            </a:pPr>
+            <a:r>
+              <a:rPr lang="en-US" sz="1350" b="1" i="0" dirty="0">
+                <a:latin typeface="Calibri"/>
+              </a:rPr>
+              <a:t>Leakage</a:t>
+            </a:r>
+          </a:p>
+          <a:p>
+            <a:pPr lvl="1">
+              <a:spcAft>
+                <a:spcPts val="600"/>
+              </a:spcAft>
+            </a:pPr>
+            <a:r>
+              <a:rPr lang="en-US" sz="900" i="1" dirty="0"/>
+              <a:t>Leakage is training the model on something we would not actually know on the day we make the prediction. It scores well in testing and then fails in production, because the thing it relied on wasn't there yet</a:t>
+            </a:r>
+            <a:r>
+              <a:rPr lang="en-US" sz="900" dirty="0"/>
+              <a:t>.</a:t>
+            </a:r>
+          </a:p>
+          <a:p>
+            <a:pPr marL="685800" lvl="1" indent="-228600">
+              <a:spcAft>
+                <a:spcPts val="600"/>
+              </a:spcAft>
+              <a:buFont typeface="+mj-lt"/>
+              <a:buAutoNum type="arabicPeriod"/>
+            </a:pPr>
+            <a:r>
+              <a:rPr lang="en-US" sz="1100" dirty="0">
                 <a:solidFill>
                   <a:srgbClr val="5A6270"/>
                 </a:solidFill>
-                <a:latin typeface="Calibri"/>
-              </a:rPr>
-              <a:t>Read without the right-hand panel, the left one says support load per seat drives churn, then contract size, then tenure. All three are plausible. That is exactly what makes it dangerous.</a:t>
-            </a:r>
+              </a:rPr>
+              <a:t>Every table is cut to the cutoff date before anything is built. Nothing dated 1 July onwards can reach a feature for our cut off date prediction.</a:t>
+            </a:r>
+          </a:p>
+          <a:p>
+            <a:pPr marL="685800" lvl="1" indent="-228600">
+              <a:spcAft>
+                <a:spcPts val="600"/>
+              </a:spcAft>
+              <a:buFont typeface="+mj-lt"/>
+              <a:buAutoNum type="arabicPeriod"/>
+            </a:pPr>
+            <a:r>
+              <a:rPr lang="en-US" sz="1100" dirty="0">
+                <a:solidFill>
+                  <a:srgbClr val="5A6270"/>
+                </a:solidFill>
+              </a:rPr>
+              <a:t>Anything still unfinished on the cutoff date is blanked (E.g., a support ticket still open on 30 June has no fix time and no satisfaction score, even though the file records them, because they were filled in later)</a:t>
+            </a:r>
+          </a:p>
+          <a:p>
+            <a:pPr marL="685800" lvl="1" indent="-228600">
+              <a:spcAft>
+                <a:spcPts val="600"/>
+              </a:spcAft>
+              <a:buFont typeface="+mj-lt"/>
+              <a:buAutoNum type="arabicPeriod"/>
+            </a:pPr>
+            <a:r>
+              <a:rPr lang="en-US" sz="1100" dirty="0">
+                <a:solidFill>
+                  <a:srgbClr val="5A6270"/>
+                </a:solidFill>
+              </a:rPr>
+              <a:t>Nothing from the churn record is ever used as a feature. Those columns exist because a customer left.</a:t>
+            </a:r>
+          </a:p>
+          <a:p>
+            <a:pPr marL="685800" lvl="1" indent="-228600">
+              <a:spcAft>
+                <a:spcPts val="600"/>
+              </a:spcAft>
+              <a:buFont typeface="+mj-lt"/>
+              <a:buAutoNum type="arabicPeriod"/>
+            </a:pPr>
+            <a:r>
+              <a:rPr lang="en-US" sz="1100" dirty="0">
+                <a:solidFill>
+                  <a:srgbClr val="5A6270"/>
+                </a:solidFill>
+              </a:rPr>
+              <a:t>The same code builds the features in training and in production. It takes a date and looks only before it, so the two cannot drift apart.</a:t>
+            </a:r>
+            <a:endParaRPr lang="en-US" sz="1100" b="0" i="0" dirty="0">
+              <a:solidFill>
+                <a:srgbClr val="5A6270"/>
+              </a:solidFill>
+              <a:latin typeface="Calibri"/>
+            </a:endParaRPr>
           </a:p>
         </p:txBody>
       </p:sp>
@@ -6006,7 +6572,7 @@
                 </a:solidFill>
                 <a:latin typeface="Calibri"/>
               </a:rPr>
-              <a:t>PART 4 · RECOMMENDATION 1</a:t>
+              <a:t>PART 3 · MODELLING</a:t>
             </a:r>
           </a:p>
           <a:p>
@@ -6016,16 +6582,12 @@
               </a:spcBef>
             </a:pPr>
             <a:r>
-              <a:rPr lang="en-US" sz="2800" b="1" i="0" dirty="0">
-                <a:latin typeface="Calibri"/>
-              </a:rPr>
-              <a:t>Insight 1: </a:t>
-            </a:r>
-            <a:r>
-              <a:rPr sz="2800" b="1" i="0" dirty="0">
-                <a:latin typeface="Calibri"/>
-              </a:rPr>
-              <a:t>Do not go looking for what changed in 2024</a:t>
+              <a:rPr lang="en-US" sz="2800" b="1" dirty="0">
+                <a:solidFill>
+                  <a:srgbClr val="1A1A1A"/>
+                </a:solidFill>
+              </a:rPr>
+              <a:t>Interpretability</a:t>
             </a:r>
           </a:p>
         </p:txBody>
@@ -6075,9 +6637,182 @@
           </a:p>
         </p:txBody>
       </p:sp>
+      <p:sp>
+        <p:nvSpPr>
+          <p:cNvPr id="5" name="TextBox 4"/>
+          <p:cNvSpPr txBox="1"/>
+          <p:nvPr/>
+        </p:nvSpPr>
+        <p:spPr>
+          <a:xfrm>
+            <a:off x="589547" y="1978155"/>
+            <a:ext cx="4186989" cy="3642023"/>
+          </a:xfrm>
+          <a:prstGeom prst="rect">
+            <a:avLst/>
+          </a:prstGeom>
+          <a:noFill/>
+        </p:spPr>
+        <p:txBody>
+          <a:bodyPr wrap="square">
+            <a:spAutoFit/>
+          </a:bodyPr>
+          <a:lstStyle/>
+          <a:p>
+            <a:pPr>
+              <a:spcAft>
+                <a:spcPts val="400"/>
+              </a:spcAft>
+            </a:pPr>
+            <a:r>
+              <a:rPr sz="1300" b="1" i="0" dirty="0">
+                <a:solidFill>
+                  <a:srgbClr val="1A1A1A"/>
+                </a:solidFill>
+                <a:latin typeface="Calibri"/>
+              </a:rPr>
+              <a:t>The shipped model is a logistic regression, so it can simply be read. Each bar is one input and the direction the model applies it.</a:t>
+            </a:r>
+          </a:p>
+          <a:p>
+            <a:pPr>
+              <a:spcAft>
+                <a:spcPts val="400"/>
+              </a:spcAft>
+            </a:pPr>
+            <a:r>
+              <a:rPr sz="600" b="0" i="0" dirty="0">
+                <a:solidFill>
+                  <a:srgbClr val="1A1A1A"/>
+                </a:solidFill>
+                <a:latin typeface="Calibri"/>
+              </a:rPr>
+              <a:t> </a:t>
+            </a:r>
+          </a:p>
+          <a:p>
+            <a:pPr>
+              <a:spcAft>
+                <a:spcPts val="400"/>
+              </a:spcAft>
+            </a:pPr>
+            <a:r>
+              <a:rPr sz="1300" b="1" i="0" dirty="0">
+                <a:solidFill>
+                  <a:srgbClr val="1A1A1A"/>
+                </a:solidFill>
+                <a:latin typeface="Calibri"/>
+              </a:rPr>
+              <a:t>Taken at face value it is a briefing.</a:t>
+            </a:r>
+          </a:p>
+          <a:p>
+            <a:pPr lvl="1">
+              <a:spcAft>
+                <a:spcPts val="400"/>
+              </a:spcAft>
+            </a:pPr>
+            <a:r>
+              <a:rPr sz="1100" b="0" i="0" dirty="0">
+                <a:solidFill>
+                  <a:srgbClr val="5A6270"/>
+                </a:solidFill>
+                <a:latin typeface="Calibri"/>
+              </a:rPr>
+              <a:t>Pro-plan customers stay. Partner-sourced customers leave. Customers holding several subscriptions leave. </a:t>
+            </a:r>
+          </a:p>
+          <a:p>
+            <a:pPr>
+              <a:spcAft>
+                <a:spcPts val="400"/>
+              </a:spcAft>
+            </a:pPr>
+            <a:r>
+              <a:rPr sz="600" b="0" i="0" dirty="0">
+                <a:solidFill>
+                  <a:srgbClr val="1A1A1A"/>
+                </a:solidFill>
+                <a:latin typeface="Calibri"/>
+              </a:rPr>
+              <a:t> </a:t>
+            </a:r>
+          </a:p>
+          <a:p>
+            <a:pPr>
+              <a:spcAft>
+                <a:spcPts val="400"/>
+              </a:spcAft>
+            </a:pPr>
+            <a:r>
+              <a:rPr sz="1300" b="1" i="0" dirty="0">
+                <a:solidFill>
+                  <a:srgbClr val="B02E2E"/>
+                </a:solidFill>
+                <a:latin typeface="Calibri"/>
+              </a:rPr>
+              <a:t>The dashed lines are why I am not reporting any of it.</a:t>
+            </a:r>
+          </a:p>
+          <a:p>
+            <a:pPr lvl="1">
+              <a:spcAft>
+                <a:spcPts val="400"/>
+              </a:spcAft>
+            </a:pPr>
+            <a:r>
+              <a:rPr sz="1100" b="0" i="0" dirty="0">
+                <a:solidFill>
+                  <a:srgbClr val="5A6270"/>
+                </a:solidFill>
+                <a:latin typeface="Calibri"/>
+              </a:rPr>
+              <a:t>I shuffled the churn labels 500 times, refitting each time, and recorded the largest coefficient. Chance reaches 1.68. The largest real coefficient is 1.45. Not one input in the model is as strong as what chance produces from labels that mean nothing.</a:t>
+            </a:r>
+          </a:p>
+          <a:p>
+            <a:pPr>
+              <a:spcAft>
+                <a:spcPts val="400"/>
+              </a:spcAft>
+            </a:pPr>
+            <a:r>
+              <a:rPr sz="600" b="0" i="0" dirty="0">
+                <a:solidFill>
+                  <a:srgbClr val="1A1A1A"/>
+                </a:solidFill>
+                <a:latin typeface="Calibri"/>
+              </a:rPr>
+              <a:t> </a:t>
+            </a:r>
+          </a:p>
+          <a:p>
+            <a:pPr lvl="1">
+              <a:spcAft>
+                <a:spcPts val="400"/>
+              </a:spcAft>
+            </a:pPr>
+            <a:r>
+              <a:rPr sz="1100" b="0" i="0" dirty="0">
+                <a:solidFill>
+                  <a:srgbClr val="5A6270"/>
+                </a:solidFill>
+                <a:latin typeface="Calibri"/>
+              </a:rPr>
+              <a:t>Seven of the 86 inputs clear p = 0.05 individually. Testing 86 inputs, chance delivers about 4. Asked properly — is any coefficient larger than chance reaches — the answer is p = 0.22.</a:t>
+            </a:r>
+          </a:p>
+        </p:txBody>
+      </p:sp>
       <p:pic>
         <p:nvPicPr>
-          <p:cNvPr id="4" name="Picture 3" descr="16_generator_artefact.png"/>
+          <p:cNvPr id="10" name="Picture 9" descr="13_drivers.png">
+            <a:extLst>
+              <a:ext uri="{FF2B5EF4-FFF2-40B4-BE49-F238E27FC236}">
+                <a16:creationId xmlns:a16="http://schemas.microsoft.com/office/drawing/2014/main" id="{42C08F25-67CE-D88A-2AF5-D2B92CFFCE48}"/>
+              </a:ext>
+            </a:extLst>
+          </p:cNvPr>
           <p:cNvPicPr>
             <a:picLocks noChangeAspect="1"/>
           </p:cNvPicPr>
@@ -6085,125 +6820,21 @@
         </p:nvPicPr>
         <p:blipFill>
           <a:blip r:embed="rId3"/>
+          <a:srcRect b="9490"/>
           <a:stretch>
             <a:fillRect/>
           </a:stretch>
         </p:blipFill>
         <p:spPr>
           <a:xfrm>
-            <a:off x="1906186" y="1554480"/>
-            <a:ext cx="8379323" cy="2788920"/>
+            <a:off x="5047871" y="1921796"/>
+            <a:ext cx="6702412" cy="3378114"/>
           </a:xfrm>
           <a:prstGeom prst="rect">
             <a:avLst/>
           </a:prstGeom>
         </p:spPr>
       </p:pic>
-      <p:sp>
-        <p:nvSpPr>
-          <p:cNvPr id="5" name="TextBox 4"/>
-          <p:cNvSpPr txBox="1"/>
-          <p:nvPr/>
-        </p:nvSpPr>
-        <p:spPr>
-          <a:xfrm>
-            <a:off x="685800" y="4572000"/>
-            <a:ext cx="10820095" cy="4572000"/>
-          </a:xfrm>
-          <a:prstGeom prst="rect">
-            <a:avLst/>
-          </a:prstGeom>
-          <a:noFill/>
-        </p:spPr>
-        <p:txBody>
-          <a:bodyPr wrap="square">
-            <a:spAutoFit/>
-          </a:bodyPr>
-          <a:lstStyle/>
-          <a:p>
-            <a:pPr>
-              <a:spcAft>
-                <a:spcPts val="400"/>
-              </a:spcAft>
-            </a:pPr>
-            <a:r>
-              <a:rPr sz="1250" b="1" i="0">
-                <a:solidFill>
-                  <a:srgbClr val="1A1A1A"/>
-                </a:solidFill>
-                <a:latin typeface="Calibri"/>
-              </a:rPr>
-              <a:t>Churn looks like it is accelerating. About 5 in every 100 customers left each month in 2023, rising to 22 in 100 by December 2024 — a 2.8x rise per year, p = 2e-16. It was by far the strongest number in this study.</a:t>
-            </a:r>
-          </a:p>
-          <a:p>
-            <a:pPr>
-              <a:spcAft>
-                <a:spcPts val="400"/>
-              </a:spcAft>
-            </a:pPr>
-            <a:r>
-              <a:rPr sz="1250" b="1" i="0">
-                <a:solidFill>
-                  <a:srgbClr val="B02E2E"/>
-                </a:solidFill>
-                <a:latin typeface="Calibri"/>
-              </a:rPr>
-              <a:t>It is not a fact about customers. Every churn date in this file is a random date between the day the customer joined and the last day of the extract. A random date has nowhere to go but the end of the file, so the rate climbs on its own, with nothing happening in the business.</a:t>
-            </a:r>
-          </a:p>
-          <a:p>
-            <a:pPr>
-              <a:spcAft>
-                <a:spcPts val="400"/>
-              </a:spcAft>
-            </a:pPr>
-            <a:r>
-              <a:rPr sz="1250" b="1" i="0">
-                <a:solidFill>
-                  <a:srgbClr val="1A1A1A"/>
-                </a:solidFill>
-                <a:latin typeface="Calibri"/>
-              </a:rPr>
-              <a:t>Rebuilding the data from that one rule gives the same answer: a 2.78x rise per year, all 24 months inside the range chance produces, and our result sitting at the 52nd percentile of pure noise. So there is nothing here to investigate, and that is the recommendation.</a:t>
-            </a:r>
-          </a:p>
-        </p:txBody>
-      </p:sp>
-      <p:sp>
-        <p:nvSpPr>
-          <p:cNvPr id="6" name="TextBox 5"/>
-          <p:cNvSpPr txBox="1"/>
-          <p:nvPr/>
-        </p:nvSpPr>
-        <p:spPr>
-          <a:xfrm>
-            <a:off x="685800" y="6126480"/>
-            <a:ext cx="10820095" cy="502920"/>
-          </a:xfrm>
-          <a:prstGeom prst="rect">
-            <a:avLst/>
-          </a:prstGeom>
-          <a:noFill/>
-        </p:spPr>
-        <p:txBody>
-          <a:bodyPr wrap="square">
-            <a:spAutoFit/>
-          </a:bodyPr>
-          <a:lstStyle/>
-          <a:p>
-            <a:r>
-              <a:rPr sz="1150" b="0" i="1">
-                <a:solidFill>
-                  <a:srgbClr val="1A1A1A"/>
-                </a:solidFill>
-                <a:latin typeface="Calibri"/>
-              </a:rPr>
-              <a:t>The test that mattered was not "is this bigger than noise" — it was, comfortably. It was "would the file produce this on its own". On generated data that is the only null worth testing, and it is the one I had not run.</a:t>
-            </a:r>
-          </a:p>
-        </p:txBody>
-      </p:sp>
     </p:spTree>
   </p:cSld>
   <p:clrMapOvr>
@@ -6258,7 +6889,7 @@
                 </a:solidFill>
                 <a:latin typeface="Calibri"/>
               </a:rPr>
-              <a:t>PART 4 · RECOMMENDATION 2</a:t>
+              <a:t>PART 4 · RECOMMENDATION 1</a:t>
             </a:r>
           </a:p>
           <a:p>
@@ -6271,23 +6902,14 @@
               <a:rPr lang="en-US" sz="2800" b="1" i="0" dirty="0">
                 <a:latin typeface="Calibri"/>
               </a:rPr>
-              <a:t>Insight 2: </a:t>
+              <a:t>Insight 1: </a:t>
             </a:r>
             <a:r>
               <a:rPr sz="2800" b="1" i="0" dirty="0">
                 <a:latin typeface="Calibri"/>
               </a:rPr>
-              <a:t>Do not build the onboarding </a:t>
-            </a:r>
-            <a:r>
-              <a:rPr sz="2800" b="1" i="0" dirty="0" err="1">
-                <a:latin typeface="Calibri"/>
-              </a:rPr>
-              <a:t>programme</a:t>
-            </a:r>
-            <a:endParaRPr sz="2800" b="1" i="0" dirty="0">
-              <a:latin typeface="Calibri"/>
-            </a:endParaRPr>
+              <a:t>Do not go looking for what changed in 2024</a:t>
+            </a:r>
           </a:p>
         </p:txBody>
       </p:sp>
@@ -6338,22 +6960,22 @@
       </p:sp>
       <p:pic>
         <p:nvPicPr>
-          <p:cNvPr id="4" name="Picture 3" descr="12_cohort_gradient.png"/>
+          <p:cNvPr id="4" name="Picture 3" descr="16_generator_artefact.png"/>
           <p:cNvPicPr>
             <a:picLocks noChangeAspect="1"/>
           </p:cNvPicPr>
           <p:nvPr/>
         </p:nvPicPr>
         <p:blipFill>
-          <a:blip r:embed="rId2"/>
+          <a:blip r:embed="rId3"/>
           <a:stretch>
             <a:fillRect/>
           </a:stretch>
         </p:blipFill>
         <p:spPr>
           <a:xfrm>
-            <a:off x="3590694" y="1627632"/>
-            <a:ext cx="5010307" cy="2743200"/>
+            <a:off x="1906186" y="1554480"/>
+            <a:ext cx="8379323" cy="2788920"/>
           </a:xfrm>
           <a:prstGeom prst="rect">
             <a:avLst/>
@@ -6368,7 +6990,7 @@
         </p:nvSpPr>
         <p:spPr>
           <a:xfrm>
-            <a:off x="685800" y="4526280"/>
+            <a:off x="685800" y="4572000"/>
             <a:ext cx="10820095" cy="4572000"/>
           </a:xfrm>
           <a:prstGeom prst="rect">
@@ -6388,13 +7010,13 @@
               </a:spcAft>
             </a:pPr>
             <a:r>
-              <a:rPr sz="1250" b="1" i="0">
+              <a:rPr sz="1250" b="1" i="0" dirty="0">
                 <a:solidFill>
                   <a:srgbClr val="1A1A1A"/>
                 </a:solidFill>
                 <a:latin typeface="Calibri"/>
               </a:rPr>
-              <a:t>New customers look fragile, and risk looks like it falls with age. That is the usual reason to fund onboarding, and the evidence for it looks strong: 30-day survival drops from 0.98 for the 2023 intake to 0.59 for the 2024 one, measured at the same age.</a:t>
+              <a:t>Churn looks like it is accelerating. About 5 in every 100 customers left each month in 2023, rising to 22 in 100 by December 2024 — a 2.8x rise per year, p = 2e-16. It was by far the strongest number in this study.</a:t>
             </a:r>
           </a:p>
           <a:p>
@@ -6404,13 +7026,13 @@
               </a:spcAft>
             </a:pPr>
             <a:r>
-              <a:rPr sz="1250" b="1" i="0">
+              <a:rPr sz="1250" b="1" i="0" dirty="0">
                 <a:solidFill>
                   <a:srgbClr val="B02E2E"/>
                 </a:solidFill>
                 <a:latin typeface="Calibri"/>
               </a:rPr>
-              <a:t>It is the same random date. A customer who joined recently has a shorter window for that date to land in, so a larger share of their draws fall inside any 90-day question we ask. They look worse at every age without anything about them being worse.</a:t>
+              <a:t>It is not a fact about customers. Every churn date in this file is a random date between the day the customer joined and the last day of the extract. A random date has nowhere to go but the end of the file, so the rate climbs on its own, with nothing happening in the business.</a:t>
             </a:r>
           </a:p>
           <a:p>
@@ -6420,47 +7042,13 @@
               </a:spcAft>
             </a:pPr>
             <a:r>
-              <a:rPr sz="1250" b="1" i="0">
+              <a:rPr sz="1250" b="1" i="0" dirty="0">
                 <a:solidFill>
                   <a:srgbClr val="1A1A1A"/>
                 </a:solidFill>
                 <a:latin typeface="Calibri"/>
               </a:rPr>
-              <a:t>Simulated data with no tenure effect in it at all clears the significance bar in 93% of runs, and does so more strongly than the real data does (p = 0.002 against 0.006). Within one joining month there is nothing left: a day-300 customer leaves as often as a day-10 one.</a:t>
-            </a:r>
-          </a:p>
-        </p:txBody>
-      </p:sp>
-      <p:sp>
-        <p:nvSpPr>
-          <p:cNvPr id="6" name="TextBox 5"/>
-          <p:cNvSpPr txBox="1"/>
-          <p:nvPr/>
-        </p:nvSpPr>
-        <p:spPr>
-          <a:xfrm>
-            <a:off x="685800" y="6126480"/>
-            <a:ext cx="10820095" cy="502920"/>
-          </a:xfrm>
-          <a:prstGeom prst="rect">
-            <a:avLst/>
-          </a:prstGeom>
-          <a:noFill/>
-        </p:spPr>
-        <p:txBody>
-          <a:bodyPr wrap="square">
-            <a:spAutoFit/>
-          </a:bodyPr>
-          <a:lstStyle/>
-          <a:p>
-            <a:r>
-              <a:rPr sz="1150" b="0" i="1">
-                <a:solidFill>
-                  <a:srgbClr val="5A6270"/>
-                </a:solidFill>
-                <a:latin typeface="Calibri"/>
-              </a:rPr>
-              <a:t>The recommendation does not change; the reason for it gets one layer deeper. This is the same finding as slide 11, applied to a spending decision instead of an investigation.</a:t>
+              <a:t>Rebuilding the data from that one rule gives the same answer: a 2.78x rise per year, all 24 months inside the range chance produces, and our result sitting at the 52nd percentile of pure noise. So there is nothing here to investigate, and that is the recommendation.</a:t>
             </a:r>
           </a:p>
         </p:txBody>
@@ -6519,7 +7107,7 @@
                 </a:solidFill>
                 <a:latin typeface="Calibri"/>
               </a:rPr>
-              <a:t>PART 4 · RECOMMENDATION 3</a:t>
+              <a:t>PART 4 · RECOMMENDATION 2</a:t>
             </a:r>
           </a:p>
           <a:p>
@@ -6532,14 +7120,23 @@
               <a:rPr lang="en-US" sz="2800" b="1" i="0" dirty="0">
                 <a:latin typeface="Calibri"/>
               </a:rPr>
-              <a:t>Insight 3: </a:t>
+              <a:t>Insight 2: </a:t>
             </a:r>
             <a:r>
               <a:rPr sz="2800" b="1" i="0" dirty="0">
                 <a:latin typeface="Calibri"/>
               </a:rPr>
-              <a:t>Call every at-risk customer, do not rank them</a:t>
-            </a:r>
+              <a:t>Do not build the onboarding </a:t>
+            </a:r>
+            <a:r>
+              <a:rPr sz="2800" b="1" i="0" dirty="0" err="1">
+                <a:latin typeface="Calibri"/>
+              </a:rPr>
+              <a:t>programme</a:t>
+            </a:r>
+            <a:endParaRPr sz="2800" b="1" i="0" dirty="0">
+              <a:latin typeface="Calibri"/>
+            </a:endParaRPr>
           </a:p>
         </p:txBody>
       </p:sp>
@@ -6590,7 +7187,7 @@
       </p:sp>
       <p:pic>
         <p:nvPicPr>
-          <p:cNvPr id="4" name="Picture 3" descr="15_breakeven_grid.png"/>
+          <p:cNvPr id="4" name="Picture 3" descr="12_cohort_gradient.png"/>
           <p:cNvPicPr>
             <a:picLocks noChangeAspect="1"/>
           </p:cNvPicPr>
@@ -6604,8 +7201,8 @@
         </p:blipFill>
         <p:spPr>
           <a:xfrm>
-            <a:off x="3492925" y="1645920"/>
-            <a:ext cx="5205845" cy="3017520"/>
+            <a:off x="3590694" y="1627632"/>
+            <a:ext cx="5010307" cy="2743200"/>
           </a:xfrm>
           <a:prstGeom prst="rect">
             <a:avLst/>
@@ -6620,7 +7217,7 @@
         </p:nvSpPr>
         <p:spPr>
           <a:xfrm>
-            <a:off x="685800" y="4846320"/>
+            <a:off x="685800" y="4526280"/>
             <a:ext cx="10820095" cy="4572000"/>
           </a:xfrm>
           <a:prstGeom prst="rect">
@@ -6636,33 +7233,49 @@
           <a:p>
             <a:pPr>
               <a:spcAft>
-                <a:spcPts val="900"/>
-              </a:spcAft>
-            </a:pPr>
-            <a:r>
-              <a:rPr sz="1300" b="1" i="0">
+                <a:spcPts val="400"/>
+              </a:spcAft>
+            </a:pPr>
+            <a:r>
+              <a:rPr sz="1250" b="1" i="0">
                 <a:solidFill>
                   <a:srgbClr val="1A1A1A"/>
                 </a:solidFill>
                 <a:latin typeface="Calibri"/>
               </a:rPr>
-              <a:t>A call costs about $150. A customer is worth about $7,300. If the call works one time in five, it pays for itself on any customer with more than a 10% chance of leaving. In this group, 31% leave.</a:t>
+              <a:t>New customers look fragile, and risk looks like it falls with age. That is the usual reason to fund onboarding, and the evidence for it looks strong: 30-day survival drops from 0.98 for the 2023 intake to 0.59 for the 2024 one, measured at the same age.</a:t>
             </a:r>
           </a:p>
           <a:p>
             <a:pPr>
               <a:spcAft>
-                <a:spcPts val="900"/>
-              </a:spcAft>
-            </a:pPr>
-            <a:r>
-              <a:rPr sz="1300" b="1" i="0">
-                <a:solidFill>
-                  <a:srgbClr val="1E7A4B"/>
-                </a:solidFill>
-                <a:latin typeface="Calibri"/>
-              </a:rPr>
-              <a:t>So calling everyone already makes money, and no ranking can improve on a decision that is right for every customer. Using the model adds $600 on top of $52,400. That is a 1% gain, and even that is generous.</a:t>
+                <a:spcPts val="400"/>
+              </a:spcAft>
+            </a:pPr>
+            <a:r>
+              <a:rPr sz="1250" b="1" i="0">
+                <a:solidFill>
+                  <a:srgbClr val="B02E2E"/>
+                </a:solidFill>
+                <a:latin typeface="Calibri"/>
+              </a:rPr>
+              <a:t>It is the same random date. A customer who joined recently has a shorter window for that date to land in, so a larger share of their draws fall inside any 90-day question we ask. They look worse at every age without anything about them being worse.</a:t>
+            </a:r>
+          </a:p>
+          <a:p>
+            <a:pPr>
+              <a:spcAft>
+                <a:spcPts val="400"/>
+              </a:spcAft>
+            </a:pPr>
+            <a:r>
+              <a:rPr sz="1250" b="1" i="0">
+                <a:solidFill>
+                  <a:srgbClr val="1A1A1A"/>
+                </a:solidFill>
+                <a:latin typeface="Calibri"/>
+              </a:rPr>
+              <a:t>Simulated data with no tenure effect in it at all clears the significance bar in 93% of runs, and does so more strongly than the real data does (p = 0.002 against 0.006). Within one joining month there is nothing left: a day-300 customer leaves as often as a day-10 one.</a:t>
             </a:r>
           </a:p>
         </p:txBody>
@@ -6696,7 +7309,7 @@
                 </a:solidFill>
                 <a:latin typeface="Calibri"/>
               </a:rPr>
-              <a:t>This is one division. Had I run it first, it would have shown that a working model was never the thing standing between us and the decision.</a:t>
+              <a:t>The recommendation does not change; the reason for it gets one layer deeper. This is the same finding as slide 11, applied to a spending decision instead of an investigation.</a:t>
             </a:r>
           </a:p>
         </p:txBody>
@@ -6735,7 +7348,7 @@
         <p:spPr>
           <a:xfrm>
             <a:off x="685800" y="365760"/>
-            <a:ext cx="10820095" cy="1051560"/>
+            <a:ext cx="10820095" cy="759182"/>
           </a:xfrm>
           <a:prstGeom prst="rect">
             <a:avLst/>
@@ -6749,13 +7362,13 @@
           <a:lstStyle/>
           <a:p>
             <a:r>
-              <a:rPr sz="1200" b="1" i="0">
+              <a:rPr sz="1200" b="1" i="0" dirty="0">
                 <a:solidFill>
                   <a:srgbClr val="5A6270"/>
                 </a:solidFill>
                 <a:latin typeface="Calibri"/>
               </a:rPr>
-              <a:t>PART 4 · TESTING APPROACH</a:t>
+              <a:t>PART 4 · RECOMMENDATION 3</a:t>
             </a:r>
           </a:p>
           <a:p>
@@ -6765,13 +7378,16 @@
               </a:spcBef>
             </a:pPr>
             <a:r>
-              <a:rPr sz="2800" b="1" i="0">
-                <a:solidFill>
-                  <a:srgbClr val="1A1A1A"/>
-                </a:solidFill>
-                <a:latin typeface="Calibri"/>
-              </a:rPr>
-              <a:t>How I would test this, and what is worth testing</a:t>
+              <a:rPr lang="en-US" sz="2800" b="1" i="0" dirty="0">
+                <a:latin typeface="Calibri"/>
+              </a:rPr>
+              <a:t>Insight 3: </a:t>
+            </a:r>
+            <a:r>
+              <a:rPr sz="2800" b="1" i="0" dirty="0">
+                <a:latin typeface="Calibri"/>
+              </a:rPr>
+              <a:t>Call every at-risk customer, do not rank them</a:t>
             </a:r>
           </a:p>
         </p:txBody>
@@ -6823,7 +7439,7 @@
       </p:sp>
       <p:pic>
         <p:nvPicPr>
-          <p:cNvPr id="4" name="Picture 3" descr="15_experiment_power.png"/>
+          <p:cNvPr id="4" name="Picture 3" descr="15_breakeven_grid.png"/>
           <p:cNvPicPr>
             <a:picLocks noChangeAspect="1"/>
           </p:cNvPicPr>
@@ -6837,8 +7453,8 @@
         </p:blipFill>
         <p:spPr>
           <a:xfrm>
-            <a:off x="6492240" y="1737360"/>
-            <a:ext cx="5344328" cy="2926080"/>
+            <a:off x="3492925" y="1645920"/>
+            <a:ext cx="5205845" cy="3017520"/>
           </a:xfrm>
           <a:prstGeom prst="rect">
             <a:avLst/>
@@ -6853,8 +7469,8 @@
         </p:nvSpPr>
         <p:spPr>
           <a:xfrm>
-            <a:off x="685800" y="1719072"/>
-            <a:ext cx="5486400" cy="4572000"/>
+            <a:off x="685800" y="4846320"/>
+            <a:ext cx="10820095" cy="1007968"/>
           </a:xfrm>
           <a:prstGeom prst="rect">
             <a:avLst/>
@@ -6873,157 +7489,137 @@
               </a:spcAft>
             </a:pPr>
             <a:r>
-              <a:rPr sz="1400" b="1" i="0">
+              <a:rPr lang="en-US" sz="1300" b="1" i="0" dirty="0">
                 <a:solidFill>
                   <a:srgbClr val="1A1A1A"/>
                 </a:solidFill>
                 <a:latin typeface="Calibri"/>
               </a:rPr>
-              <a:t>Recommendation 1 is not an experiment. It is a data request.</a:t>
-            </a:r>
-          </a:p>
-          <a:p>
-            <a:pPr lvl="1">
+              <a:t>If we assume a</a:t>
+            </a:r>
+            <a:r>
+              <a:rPr sz="1300" b="1" i="0" dirty="0">
+                <a:solidFill>
+                  <a:srgbClr val="1A1A1A"/>
+                </a:solidFill>
+                <a:latin typeface="Calibri"/>
+              </a:rPr>
+              <a:t> call costs about $</a:t>
+            </a:r>
+            <a:r>
+              <a:rPr sz="1300" b="1" i="0">
+                <a:solidFill>
+                  <a:srgbClr val="1A1A1A"/>
+                </a:solidFill>
+                <a:latin typeface="Calibri"/>
+              </a:rPr>
+              <a:t>150</a:t>
+            </a:r>
+            <a:r>
+              <a:rPr lang="en-US" sz="1300" b="1" i="0">
+                <a:solidFill>
+                  <a:srgbClr val="1A1A1A"/>
+                </a:solidFill>
+                <a:latin typeface="Calibri"/>
+              </a:rPr>
+              <a:t> and</a:t>
+            </a:r>
+            <a:r>
+              <a:rPr lang="en-US" sz="1300" b="1">
+                <a:solidFill>
+                  <a:srgbClr val="1A1A1A"/>
+                </a:solidFill>
+                <a:latin typeface="Calibri"/>
+              </a:rPr>
+              <a:t> a</a:t>
+            </a:r>
+            <a:r>
+              <a:rPr sz="1300" b="1" i="0">
+                <a:solidFill>
+                  <a:srgbClr val="1A1A1A"/>
+                </a:solidFill>
+                <a:latin typeface="Calibri"/>
+              </a:rPr>
+              <a:t> </a:t>
+            </a:r>
+            <a:r>
+              <a:rPr sz="1300" b="1" i="0" dirty="0">
+                <a:solidFill>
+                  <a:srgbClr val="1A1A1A"/>
+                </a:solidFill>
+                <a:latin typeface="Calibri"/>
+              </a:rPr>
+              <a:t>customer is worth about </a:t>
+            </a:r>
+            <a:r>
+              <a:rPr sz="1300" b="1" i="0">
+                <a:solidFill>
+                  <a:srgbClr val="1A1A1A"/>
+                </a:solidFill>
+                <a:latin typeface="Calibri"/>
+              </a:rPr>
+              <a:t>$7,300</a:t>
+            </a:r>
+            <a:r>
+              <a:rPr lang="en-US" sz="1300" b="1" i="0">
+                <a:solidFill>
+                  <a:srgbClr val="1A1A1A"/>
+                </a:solidFill>
+                <a:latin typeface="Calibri"/>
+              </a:rPr>
+              <a:t> then</a:t>
+            </a:r>
+            <a:r>
+              <a:rPr sz="1300" b="1" i="0">
+                <a:solidFill>
+                  <a:srgbClr val="1A1A1A"/>
+                </a:solidFill>
+                <a:latin typeface="Calibri"/>
+              </a:rPr>
+              <a:t> </a:t>
+            </a:r>
+            <a:r>
+              <a:rPr lang="en-US" sz="1300" b="1" i="0">
+                <a:solidFill>
+                  <a:srgbClr val="1A1A1A"/>
+                </a:solidFill>
+                <a:latin typeface="Calibri"/>
+              </a:rPr>
+              <a:t>i</a:t>
+            </a:r>
+            <a:r>
+              <a:rPr sz="1300" b="1" i="0">
+                <a:solidFill>
+                  <a:srgbClr val="1A1A1A"/>
+                </a:solidFill>
+                <a:latin typeface="Calibri"/>
+              </a:rPr>
+              <a:t>f </a:t>
+            </a:r>
+            <a:r>
+              <a:rPr sz="1300" b="1" i="0" dirty="0">
+                <a:solidFill>
+                  <a:srgbClr val="1A1A1A"/>
+                </a:solidFill>
+                <a:latin typeface="Calibri"/>
+              </a:rPr>
+              <a:t>the call works one time in five, it pays for itself on any customer with more than a 10% chance of leaving. In this group, 31% leave.</a:t>
+            </a:r>
+          </a:p>
+          <a:p>
+            <a:pPr>
               <a:spcAft>
                 <a:spcPts val="900"/>
               </a:spcAft>
             </a:pPr>
             <a:r>
-              <a:rPr sz="1200" b="0" i="0">
-                <a:solidFill>
-                  <a:srgbClr val="5A6270"/>
-                </a:solidFill>
-                <a:latin typeface="Calibri"/>
-              </a:rPr>
-              <a:t>Nothing in this extract can say why customers leave, because the timestamps were never recorded against the customers they belong to. Ask for an export where they are, then rerun this pipeline and compare against the score written down today.</a:t>
-            </a:r>
-          </a:p>
-          <a:p>
-            <a:pPr>
-              <a:spcAft>
-                <a:spcPts val="900"/>
-              </a:spcAft>
-            </a:pPr>
-            <a:r>
-              <a:rPr sz="600" b="0" i="0">
-                <a:solidFill>
-                  <a:srgbClr val="1A1A1A"/>
-                </a:solidFill>
-                <a:latin typeface="Calibri"/>
-              </a:rPr>
-              <a:t> </a:t>
-            </a:r>
-          </a:p>
-          <a:p>
-            <a:pPr>
-              <a:spcAft>
-                <a:spcPts val="900"/>
-              </a:spcAft>
-            </a:pPr>
-            <a:r>
-              <a:rPr sz="1400" b="1" i="0">
-                <a:solidFill>
-                  <a:srgbClr val="1A1A1A"/>
-                </a:solidFill>
-                <a:latin typeface="Calibri"/>
-              </a:rPr>
-              <a:t>Recommendation 3 is a proper experiment.</a:t>
-            </a:r>
-          </a:p>
-          <a:p>
-            <a:pPr lvl="1">
-              <a:spcAft>
-                <a:spcPts val="900"/>
-              </a:spcAft>
-            </a:pPr>
-            <a:r>
-              <a:rPr sz="1200" b="0" i="0">
-                <a:solidFill>
-                  <a:srgbClr val="5A6270"/>
-                </a:solidFill>
-                <a:latin typeface="Calibri"/>
-              </a:rPr>
-              <a:t>Split the at-risk customers in half at random. One half gets a call, one half does not. Measure retention after 180 days, and measure money kept as well, so a costly save is not mistaken for a win.</a:t>
-            </a:r>
-          </a:p>
-          <a:p>
-            <a:pPr>
-              <a:spcAft>
-                <a:spcPts val="900"/>
-              </a:spcAft>
-            </a:pPr>
-            <a:r>
-              <a:rPr sz="600" b="0" i="0">
-                <a:solidFill>
-                  <a:srgbClr val="1A1A1A"/>
-                </a:solidFill>
-                <a:latin typeface="Calibri"/>
-              </a:rPr>
-              <a:t> </a:t>
-            </a:r>
-          </a:p>
-          <a:p>
-            <a:pPr>
-              <a:spcAft>
-                <a:spcPts val="900"/>
-              </a:spcAft>
-            </a:pPr>
-            <a:r>
-              <a:rPr sz="1400" b="1" i="0">
-                <a:solidFill>
-                  <a:srgbClr val="B02E2E"/>
-                </a:solidFill>
-                <a:latin typeface="Calibri"/>
-              </a:rPr>
-              <a:t>But be realistic about what we can detect.</a:t>
-            </a:r>
-          </a:p>
-          <a:p>
-            <a:pPr lvl="1">
-              <a:spcAft>
-                <a:spcPts val="900"/>
-              </a:spcAft>
-            </a:pPr>
-            <a:r>
-              <a:rPr sz="1200" b="0" i="0">
-                <a:solidFill>
-                  <a:srgbClr val="5A6270"/>
-                </a:solidFill>
-                <a:latin typeface="Calibri"/>
-              </a:rPr>
-              <a:t>At about 21 new customers a month, only a very large effect can be proved:</a:t>
-            </a:r>
-          </a:p>
-          <a:p>
-            <a:pPr lvl="1">
-              <a:spcAft>
-                <a:spcPts val="900"/>
-              </a:spcAft>
-            </a:pPr>
-            <a:r>
-              <a:rPr sz="1200" b="0" i="0">
-                <a:solidFill>
-                  <a:srgbClr val="5A6270"/>
-                </a:solidFill>
-                <a:latin typeface="Calibri"/>
-              </a:rPr>
-              <a:t>Halving churn takes about 15 months to show.</a:t>
-            </a:r>
-          </a:p>
-          <a:p>
-            <a:pPr lvl="1">
-              <a:spcAft>
-                <a:spcPts val="900"/>
-              </a:spcAft>
-            </a:pPr>
-            <a:r>
-              <a:rPr sz="1200" b="0" i="0">
-                <a:solidFill>
-                  <a:srgbClr val="5A6270"/>
-                </a:solidFill>
-                <a:latin typeface="Calibri"/>
-              </a:rPr>
-              <a:t>A 5 point improvement would take over 10 years.</a:t>
+              <a:rPr sz="1300" b="1" i="0" dirty="0">
+                <a:solidFill>
+                  <a:srgbClr val="1E7A4B"/>
+                </a:solidFill>
+                <a:latin typeface="Calibri"/>
+              </a:rPr>
+              <a:t>So calling everyone already makes money, and no ranking can improve on a decision that is right for every customer. Using the model adds $600 on top of $52,400. That is a 1% gain, and even that is generous.</a:t>
             </a:r>
           </a:p>
         </p:txBody>
@@ -7057,7 +7653,7 @@
                 </a:solidFill>
                 <a:latin typeface="Calibri"/>
               </a:rPr>
-              <a:t>Two separate methods agree on this. A standard power calculation and a simulation both say we cannot detect anything smaller than about a 15 point change.</a:t>
+              <a:t>This is one division. Had I run it first, it would have shown that a working model was never the thing standing between us and the decision.</a:t>
             </a:r>
           </a:p>
         </p:txBody>
@@ -7116,7 +7712,7 @@
                 </a:solidFill>
                 <a:latin typeface="Calibri"/>
               </a:rPr>
-              <a:t>PART 5 · MENTORSHIP</a:t>
+              <a:t>PART 4 · TESTING APPROACH</a:t>
             </a:r>
           </a:p>
           <a:p>
@@ -7132,7 +7728,7 @@
                 </a:solidFill>
                 <a:latin typeface="Calibri"/>
               </a:rPr>
-              <a:t>What I would teach a junior engineer</a:t>
+              <a:t>How I would test this, and what is worth testing</a:t>
             </a:r>
           </a:p>
         </p:txBody>
@@ -7182,16 +7778,40 @@
           </a:p>
         </p:txBody>
       </p:sp>
-      <p:sp>
-        <p:nvSpPr>
-          <p:cNvPr id="4" name="TextBox 3"/>
+      <p:pic>
+        <p:nvPicPr>
+          <p:cNvPr id="4" name="Picture 3" descr="15_experiment_power.png"/>
+          <p:cNvPicPr>
+            <a:picLocks noChangeAspect="1"/>
+          </p:cNvPicPr>
+          <p:nvPr/>
+        </p:nvPicPr>
+        <p:blipFill>
+          <a:blip r:embed="rId2"/>
+          <a:stretch>
+            <a:fillRect/>
+          </a:stretch>
+        </p:blipFill>
+        <p:spPr>
+          <a:xfrm>
+            <a:off x="6492240" y="1737360"/>
+            <a:ext cx="5344328" cy="2926080"/>
+          </a:xfrm>
+          <a:prstGeom prst="rect">
+            <a:avLst/>
+          </a:prstGeom>
+        </p:spPr>
+      </p:pic>
+      <p:sp>
+        <p:nvSpPr>
+          <p:cNvPr id="5" name="TextBox 4"/>
           <p:cNvSpPr txBox="1"/>
           <p:nvPr/>
         </p:nvSpPr>
         <p:spPr>
           <a:xfrm>
             <a:off x="685800" y="1719072"/>
-            <a:ext cx="10820095" cy="4572000"/>
+            <a:ext cx="5486400" cy="4572000"/>
           </a:xfrm>
           <a:prstGeom prst="rect">
             <a:avLst/>
@@ -7206,27 +7826,43 @@
           <a:p>
             <a:pPr>
               <a:spcAft>
-                <a:spcPts val="400"/>
-              </a:spcAft>
-            </a:pPr>
-            <a:r>
-              <a:rPr sz="1300" b="1" i="0" dirty="0">
+                <a:spcPts val="900"/>
+              </a:spcAft>
+            </a:pPr>
+            <a:r>
+              <a:rPr sz="1400" b="1" i="0">
                 <a:solidFill>
                   <a:srgbClr val="1A1A1A"/>
                 </a:solidFill>
                 <a:latin typeface="Calibri"/>
               </a:rPr>
-              <a:t>I would hand them my own worst mistake on this project, because that is where the judgement that transfers to other work lives.</a:t>
+              <a:t>Recommendation 1 is not an experiment. It is a data request.</a:t>
+            </a:r>
+          </a:p>
+          <a:p>
+            <a:pPr lvl="1">
+              <a:spcAft>
+                <a:spcPts val="900"/>
+              </a:spcAft>
+            </a:pPr>
+            <a:r>
+              <a:rPr sz="1200" b="0" i="0">
+                <a:solidFill>
+                  <a:srgbClr val="5A6270"/>
+                </a:solidFill>
+                <a:latin typeface="Calibri"/>
+              </a:rPr>
+              <a:t>Nothing in this extract can say why customers leave, because the timestamps were never recorded against the customers they belong to. Ask for an export where they are, then rerun this pipeline and compare against the score written down today.</a:t>
             </a:r>
           </a:p>
           <a:p>
             <a:pPr>
               <a:spcAft>
-                <a:spcPts val="400"/>
-              </a:spcAft>
-            </a:pPr>
-            <a:r>
-              <a:rPr sz="600" b="0" i="0" dirty="0">
+                <a:spcPts val="900"/>
+              </a:spcAft>
+            </a:pPr>
+            <a:r>
+              <a:rPr sz="600" b="0" i="0">
                 <a:solidFill>
                   <a:srgbClr val="1A1A1A"/>
                 </a:solidFill>
@@ -7238,200 +7874,120 @@
           <a:p>
             <a:pPr>
               <a:spcAft>
-                <a:spcPts val="400"/>
-              </a:spcAft>
-            </a:pPr>
-            <a:r>
-              <a:rPr sz="1300" b="1" i="0" dirty="0">
+                <a:spcPts val="900"/>
+              </a:spcAft>
+            </a:pPr>
+            <a:r>
+              <a:rPr sz="1400" b="1" i="0">
+                <a:solidFill>
+                  <a:srgbClr val="1A1A1A"/>
+                </a:solidFill>
+                <a:latin typeface="Calibri"/>
+              </a:rPr>
+              <a:t>Recommendation 3 is a proper experiment.</a:t>
+            </a:r>
+          </a:p>
+          <a:p>
+            <a:pPr lvl="1">
+              <a:spcAft>
+                <a:spcPts val="900"/>
+              </a:spcAft>
+            </a:pPr>
+            <a:r>
+              <a:rPr sz="1200" b="0" i="0">
+                <a:solidFill>
+                  <a:srgbClr val="5A6270"/>
+                </a:solidFill>
+                <a:latin typeface="Calibri"/>
+              </a:rPr>
+              <a:t>Split the at-risk customers in half at random. One half gets a call, one half does not. Measure retention after 180 days, and measure money kept as well, so a costly save is not mistaken for a win.</a:t>
+            </a:r>
+          </a:p>
+          <a:p>
+            <a:pPr>
+              <a:spcAft>
+                <a:spcPts val="900"/>
+              </a:spcAft>
+            </a:pPr>
+            <a:r>
+              <a:rPr sz="600" b="0" i="0">
+                <a:solidFill>
+                  <a:srgbClr val="1A1A1A"/>
+                </a:solidFill>
+                <a:latin typeface="Calibri"/>
+              </a:rPr>
+              <a:t> </a:t>
+            </a:r>
+          </a:p>
+          <a:p>
+            <a:pPr>
+              <a:spcAft>
+                <a:spcPts val="900"/>
+              </a:spcAft>
+            </a:pPr>
+            <a:r>
+              <a:rPr sz="1400" b="1" i="0">
                 <a:solidFill>
                   <a:srgbClr val="B02E2E"/>
                 </a:solidFill>
                 <a:latin typeface="Calibri"/>
               </a:rPr>
-              <a:t>1. Be hardest on the finding you like.</a:t>
+              <a:t>But be realistic about what we can detect.</a:t>
             </a:r>
           </a:p>
           <a:p>
             <a:pPr lvl="1">
               <a:spcAft>
-                <a:spcPts val="400"/>
-              </a:spcAft>
-            </a:pPr>
-            <a:r>
-              <a:rPr sz="1100" b="0" i="0" dirty="0">
+                <a:spcPts val="900"/>
+              </a:spcAft>
+            </a:pPr>
+            <a:r>
+              <a:rPr sz="1200" b="0" i="0">
                 <a:solidFill>
                   <a:srgbClr val="5A6270"/>
                 </a:solidFill>
                 <a:latin typeface="Calibri"/>
               </a:rPr>
-              <a:t>I had one positive result and a page of nulls, and I checked the nulls. The positive one was manufactured by the file. Ask of any finding: what else could have produced this, and can I generate it from nothing?</a:t>
-            </a:r>
-          </a:p>
-          <a:p>
-            <a:pPr>
-              <a:spcAft>
-                <a:spcPts val="400"/>
-              </a:spcAft>
-            </a:pPr>
-            <a:r>
-              <a:rPr sz="1300" b="1" i="0" dirty="0">
-                <a:solidFill>
-                  <a:srgbClr val="B02E2E"/>
-                </a:solidFill>
-                <a:latin typeface="Calibri"/>
-              </a:rPr>
-              <a:t>2. A small p-value is not evidence. It is evidence against one null.</a:t>
+              <a:t>At about 21 new customers a month, only a very large effect can be proved:</a:t>
             </a:r>
           </a:p>
           <a:p>
             <a:pPr lvl="1">
               <a:spcAft>
-                <a:spcPts val="400"/>
-              </a:spcAft>
-            </a:pPr>
-            <a:r>
-              <a:rPr sz="1100" b="0" i="0" dirty="0">
+                <a:spcPts val="900"/>
+              </a:spcAft>
+            </a:pPr>
+            <a:r>
+              <a:rPr sz="1200" b="0" i="0">
                 <a:solidFill>
                   <a:srgbClr val="5A6270"/>
                 </a:solidFill>
                 <a:latin typeface="Calibri"/>
               </a:rPr>
-              <a:t>p = 2e-16 felt unarguable. Random dates gave p = 3e-16. If the null is the wrong one, no amount of significance rescues it.</a:t>
-            </a:r>
-          </a:p>
-          <a:p>
-            <a:pPr>
-              <a:spcAft>
-                <a:spcPts val="400"/>
-              </a:spcAft>
-            </a:pPr>
-            <a:r>
-              <a:rPr sz="1300" b="1" i="0" dirty="0">
-                <a:solidFill>
-                  <a:srgbClr val="1A1A1A"/>
-                </a:solidFill>
-                <a:latin typeface="Calibri"/>
-              </a:rPr>
-              <a:t>3. Start with the target, not the model.</a:t>
+              <a:t>Halving churn takes about 15 months to show.</a:t>
             </a:r>
           </a:p>
           <a:p>
             <a:pPr lvl="1">
               <a:spcAft>
-                <a:spcPts val="400"/>
-              </a:spcAft>
-            </a:pPr>
-            <a:r>
-              <a:rPr sz="1100" b="0" i="0" dirty="0">
+                <a:spcPts val="900"/>
+              </a:spcAft>
+            </a:pPr>
+            <a:r>
+              <a:rPr sz="1200" b="0" i="0">
                 <a:solidFill>
                   <a:srgbClr val="5A6270"/>
                 </a:solidFill>
                 <a:latin typeface="Calibri"/>
               </a:rPr>
-              <a:t>My first version modelled a flag unrelated to the event log. Counting rows found it. Then check your own check: I first called 38% agreement ‘worse than a coin flip’, and it is not — for two columns this different in size, chance agreement is 39%, not 50%.</a:t>
-            </a:r>
-          </a:p>
-          <a:p>
-            <a:pPr>
-              <a:spcAft>
-                <a:spcPts val="400"/>
-              </a:spcAft>
-            </a:pPr>
-            <a:r>
-              <a:rPr sz="1300" b="1" i="0" dirty="0">
-                <a:solidFill>
-                  <a:srgbClr val="1A1A1A"/>
-                </a:solidFill>
-                <a:latin typeface="Calibri"/>
-              </a:rPr>
-              <a:t>4. Ask of every column: would I really have this on the day I predict?</a:t>
-            </a:r>
-          </a:p>
-          <a:p>
-            <a:pPr lvl="1">
-              <a:spcAft>
-                <a:spcPts val="400"/>
-              </a:spcAft>
-            </a:pPr>
-            <a:r>
-              <a:rPr sz="1100" b="0" i="0" dirty="0">
-                <a:solidFill>
-                  <a:srgbClr val="5A6270"/>
-                </a:solidFill>
-                <a:latin typeface="Calibri"/>
-              </a:rPr>
-              <a:t>Then write the check down so a machine runs it. Reading caught the obvious problem; the automatic check caught the one I missed.</a:t>
-            </a:r>
-          </a:p>
-          <a:p>
-            <a:pPr>
-              <a:spcAft>
-                <a:spcPts val="400"/>
-              </a:spcAft>
-            </a:pPr>
-            <a:r>
-              <a:rPr sz="1300" b="1" i="0" dirty="0">
-                <a:solidFill>
-                  <a:srgbClr val="1A1A1A"/>
-                </a:solidFill>
-                <a:latin typeface="Calibri"/>
-              </a:rPr>
-              <a:t>5. Find the floor, and report the range.</a:t>
-            </a:r>
-          </a:p>
-          <a:p>
-            <a:pPr lvl="1">
-              <a:spcAft>
-                <a:spcPts val="400"/>
-              </a:spcAft>
-            </a:pPr>
-            <a:r>
-              <a:rPr sz="1100" b="0" i="0" dirty="0">
-                <a:solidFill>
-                  <a:srgbClr val="5A6270"/>
-                </a:solidFill>
-                <a:latin typeface="Calibri"/>
-              </a:rPr>
-              <a:t>Always run the model with no features first. A range that includes guessing says something the average hides.</a:t>
-            </a:r>
-          </a:p>
-          <a:p>
-            <a:pPr>
-              <a:spcAft>
-                <a:spcPts val="400"/>
-              </a:spcAft>
-            </a:pPr>
-            <a:r>
-              <a:rPr sz="1300" b="1" i="0" dirty="0">
-                <a:solidFill>
-                  <a:srgbClr val="2E5F8A"/>
-                </a:solidFill>
-                <a:latin typeface="Calibri"/>
-              </a:rPr>
-              <a:t>6. Choosing a model is part of fitting it.</a:t>
-            </a:r>
-          </a:p>
-          <a:p>
-            <a:pPr lvl="1">
-              <a:spcAft>
-                <a:spcPts val="400"/>
-              </a:spcAft>
-            </a:pPr>
-            <a:r>
-              <a:rPr sz="1100" b="0" i="0" dirty="0">
-                <a:solidFill>
-                  <a:srgbClr val="5A6270"/>
-                </a:solidFill>
-                <a:latin typeface="Calibri"/>
-              </a:rPr>
-              <a:t>Here the gap between the best model and the honest score was the entire apparent signal.</a:t>
-            </a:r>
-          </a:p>
-        </p:txBody>
-      </p:sp>
-      <p:sp>
-        <p:nvSpPr>
-          <p:cNvPr id="5" name="TextBox 4"/>
+              <a:t>A 5 point improvement would take over 10 years.</a:t>
+            </a:r>
+          </a:p>
+        </p:txBody>
+      </p:sp>
+      <p:sp>
+        <p:nvSpPr>
+          <p:cNvPr id="6" name="TextBox 5"/>
           <p:cNvSpPr txBox="1"/>
           <p:nvPr/>
         </p:nvSpPr>
@@ -7458,7 +8014,7 @@
                 </a:solidFill>
                 <a:latin typeface="Calibri"/>
               </a:rPr>
-              <a:t>I would teach all of it as experiments rather than lectures. Switch off the banned column list and watch AUC jump from 0.58 to 0.79. Then simulate a dataset with nothing in it and watch it produce a publishable-looking trend.</a:t>
+              <a:t>Two separate methods agree on this. A standard power calculation and a simulation both say we cannot detect anything smaller than about a 15 point change.</a:t>
             </a:r>
           </a:p>
         </p:txBody>
@@ -7517,7 +8073,7 @@
                 </a:solidFill>
                 <a:latin typeface="Calibri"/>
               </a:rPr>
-              <a:t>PART 5 · SCALABILITY</a:t>
+              <a:t>PART 5 · MENTORSHIP</a:t>
             </a:r>
           </a:p>
           <a:p>
@@ -7533,7 +8089,7 @@
                 </a:solidFill>
                 <a:latin typeface="Calibri"/>
               </a:rPr>
-              <a:t>How I would run this in production</a:t>
+              <a:t>What I would teach a junior engineer</a:t>
             </a:r>
           </a:p>
         </p:txBody>
@@ -7592,7 +8148,7 @@
         <p:spPr>
           <a:xfrm>
             <a:off x="685800" y="1719072"/>
-            <a:ext cx="5577840" cy="4206240"/>
+            <a:ext cx="10820095" cy="4572000"/>
           </a:xfrm>
           <a:prstGeom prst="rect">
             <a:avLst/>
@@ -7607,209 +8163,225 @@
           <a:p>
             <a:pPr>
               <a:spcAft>
-                <a:spcPts val="300"/>
-              </a:spcAft>
-            </a:pPr>
-            <a:r>
-              <a:rPr sz="1250" b="1" i="0">
+                <a:spcPts val="400"/>
+              </a:spcAft>
+            </a:pPr>
+            <a:r>
+              <a:rPr sz="1300" b="1" i="0" dirty="0">
                 <a:solidFill>
                   <a:srgbClr val="1A1A1A"/>
                 </a:solidFill>
                 <a:latin typeface="Calibri"/>
               </a:rPr>
-              <a:t>Sources:  billing and CRM, product usage, support desk</a:t>
+              <a:t>I would hand them my own worst mistake on this project, because that is where the judgement that transfers to other work lives.</a:t>
             </a:r>
           </a:p>
           <a:p>
             <a:pPr>
               <a:spcAft>
-                <a:spcPts val="300"/>
-              </a:spcAft>
-            </a:pPr>
-            <a:r>
-              <a:rPr sz="1250" b="0" i="0">
+                <a:spcPts val="400"/>
+              </a:spcAft>
+            </a:pPr>
+            <a:r>
+              <a:rPr sz="600" b="0" i="0" dirty="0">
+                <a:solidFill>
+                  <a:srgbClr val="1A1A1A"/>
+                </a:solidFill>
+                <a:latin typeface="Calibri"/>
+              </a:rPr>
+              <a:t> </a:t>
+            </a:r>
+          </a:p>
+          <a:p>
+            <a:pPr>
+              <a:spcAft>
+                <a:spcPts val="400"/>
+              </a:spcAft>
+            </a:pPr>
+            <a:r>
+              <a:rPr sz="1300" b="1" i="0" dirty="0">
+                <a:solidFill>
+                  <a:srgbClr val="B02E2E"/>
+                </a:solidFill>
+                <a:latin typeface="Calibri"/>
+              </a:rPr>
+              <a:t>1. Be hardest on the finding you like.</a:t>
+            </a:r>
+          </a:p>
+          <a:p>
+            <a:pPr lvl="1">
+              <a:spcAft>
+                <a:spcPts val="400"/>
+              </a:spcAft>
+            </a:pPr>
+            <a:r>
+              <a:rPr sz="1100" b="0" i="0" dirty="0">
                 <a:solidFill>
                   <a:srgbClr val="5A6270"/>
                 </a:solidFill>
                 <a:latin typeface="Calibri"/>
               </a:rPr>
-              <a:t>        |  runs once a night</a:t>
+              <a:t>I had one positive result and a page of nulls, and I checked the nulls. The positive one was manufactured by the file. Ask of any finding: what else could have produced this, and can I generate it from nothing?</a:t>
             </a:r>
           </a:p>
           <a:p>
             <a:pPr>
               <a:spcAft>
-                <a:spcPts val="300"/>
-              </a:spcAft>
-            </a:pPr>
-            <a:r>
-              <a:rPr sz="1250" b="1" i="0">
+                <a:spcPts val="400"/>
+              </a:spcAft>
+            </a:pPr>
+            <a:r>
+              <a:rPr sz="1300" b="1" i="0" dirty="0">
+                <a:solidFill>
+                  <a:srgbClr val="B02E2E"/>
+                </a:solidFill>
+                <a:latin typeface="Calibri"/>
+              </a:rPr>
+              <a:t>2. A small p-value is not evidence. It is evidence against one null.</a:t>
+            </a:r>
+          </a:p>
+          <a:p>
+            <a:pPr lvl="1">
+              <a:spcAft>
+                <a:spcPts val="400"/>
+              </a:spcAft>
+            </a:pPr>
+            <a:r>
+              <a:rPr sz="1100" b="0" i="0" dirty="0">
+                <a:solidFill>
+                  <a:srgbClr val="5A6270"/>
+                </a:solidFill>
+                <a:latin typeface="Calibri"/>
+              </a:rPr>
+              <a:t>p = 2e-16 felt unarguable. Random dates gave p = 3e-16. If the null is the wrong one, no amount of significance rescues it.</a:t>
+            </a:r>
+          </a:p>
+          <a:p>
+            <a:pPr>
+              <a:spcAft>
+                <a:spcPts val="400"/>
+              </a:spcAft>
+            </a:pPr>
+            <a:r>
+              <a:rPr sz="1300" b="1" i="0" dirty="0">
                 <a:solidFill>
                   <a:srgbClr val="1A1A1A"/>
                 </a:solidFill>
                 <a:latin typeface="Calibri"/>
               </a:rPr>
-              <a:t>Feature build  (THE SAME CODE USED IN TRAINING)</a:t>
+              <a:t>3. Start with the target, not the model.</a:t>
+            </a:r>
+          </a:p>
+          <a:p>
+            <a:pPr lvl="1">
+              <a:spcAft>
+                <a:spcPts val="400"/>
+              </a:spcAft>
+            </a:pPr>
+            <a:r>
+              <a:rPr sz="1100" b="0" i="0" dirty="0">
+                <a:solidFill>
+                  <a:srgbClr val="5A6270"/>
+                </a:solidFill>
+                <a:latin typeface="Calibri"/>
+              </a:rPr>
+              <a:t>My first version modelled a flag unrelated to the event log. Counting rows found it. Then check your own check: I first called 38% agreement ‘worse than a coin flip’, and it is not — for two columns this different in size, chance agreement is 39%, not 50%.</a:t>
             </a:r>
           </a:p>
           <a:p>
             <a:pPr>
               <a:spcAft>
-                <a:spcPts val="300"/>
-              </a:spcAft>
-            </a:pPr>
-            <a:r>
-              <a:rPr sz="1250" b="0" i="0">
+                <a:spcPts val="400"/>
+              </a:spcAft>
+            </a:pPr>
+            <a:r>
+              <a:rPr sz="1300" b="1" i="0" dirty="0">
+                <a:solidFill>
+                  <a:srgbClr val="1A1A1A"/>
+                </a:solidFill>
+                <a:latin typeface="Calibri"/>
+              </a:rPr>
+              <a:t>4. Ask of every column: would I really have this on the day I predict?</a:t>
+            </a:r>
+          </a:p>
+          <a:p>
+            <a:pPr lvl="1">
+              <a:spcAft>
+                <a:spcPts val="400"/>
+              </a:spcAft>
+            </a:pPr>
+            <a:r>
+              <a:rPr sz="1100" b="0" i="0" dirty="0">
                 <a:solidFill>
                   <a:srgbClr val="5A6270"/>
                 </a:solidFill>
                 <a:latin typeface="Calibri"/>
               </a:rPr>
-              <a:t>   · every calculation takes a date and looks only before it</a:t>
+              <a:t>Then write the check down so a machine runs it. Reading caught the obvious problem; the automatic check caught the one I missed.</a:t>
             </a:r>
           </a:p>
           <a:p>
             <a:pPr>
               <a:spcAft>
-                <a:spcPts val="300"/>
-              </a:spcAft>
-            </a:pPr>
-            <a:r>
-              <a:rPr sz="1250" b="0" i="0">
+                <a:spcPts val="400"/>
+              </a:spcAft>
+            </a:pPr>
+            <a:r>
+              <a:rPr sz="1300" b="1" i="0" dirty="0">
+                <a:solidFill>
+                  <a:srgbClr val="1A1A1A"/>
+                </a:solidFill>
+                <a:latin typeface="Calibri"/>
+              </a:rPr>
+              <a:t>5. Find the floor, and report the range.</a:t>
+            </a:r>
+          </a:p>
+          <a:p>
+            <a:pPr lvl="1">
+              <a:spcAft>
+                <a:spcPts val="400"/>
+              </a:spcAft>
+            </a:pPr>
+            <a:r>
+              <a:rPr sz="1100" b="0" i="0" dirty="0">
                 <a:solidFill>
                   <a:srgbClr val="5A6270"/>
                 </a:solidFill>
                 <a:latin typeface="Calibri"/>
               </a:rPr>
-              <a:t>   · blanks out anything not yet known on that date</a:t>
+              <a:t>Always run the model with no features first. A range that includes guessing says something the average hides.</a:t>
             </a:r>
           </a:p>
           <a:p>
             <a:pPr>
               <a:spcAft>
-                <a:spcPts val="300"/>
-              </a:spcAft>
-            </a:pPr>
-            <a:r>
-              <a:rPr sz="1250" b="0" i="0">
+                <a:spcPts val="400"/>
+              </a:spcAft>
+            </a:pPr>
+            <a:r>
+              <a:rPr sz="1300" b="1" i="0" dirty="0">
+                <a:solidFill>
+                  <a:srgbClr val="2E5F8A"/>
+                </a:solidFill>
+                <a:latin typeface="Calibri"/>
+              </a:rPr>
+              <a:t>6. Choosing a model is part of fitting it.</a:t>
+            </a:r>
+          </a:p>
+          <a:p>
+            <a:pPr lvl="1">
+              <a:spcAft>
+                <a:spcPts val="400"/>
+              </a:spcAft>
+            </a:pPr>
+            <a:r>
+              <a:rPr sz="1100" b="0" i="0" dirty="0">
                 <a:solidFill>
                   <a:srgbClr val="5A6270"/>
                 </a:solidFill>
                 <a:latin typeface="Calibri"/>
               </a:rPr>
-              <a:t>   · the leakage checks run here and stop the job if they fail</a:t>
-            </a:r>
-          </a:p>
-          <a:p>
-            <a:pPr>
-              <a:spcAft>
-                <a:spcPts val="300"/>
-              </a:spcAft>
-            </a:pPr>
-            <a:r>
-              <a:rPr sz="1250" b="0" i="0">
-                <a:solidFill>
-                  <a:srgbClr val="5A6270"/>
-                </a:solidFill>
-                <a:latin typeface="Calibri"/>
-              </a:rPr>
-              <a:t>        |</a:t>
-            </a:r>
-          </a:p>
-          <a:p>
-            <a:pPr>
-              <a:spcAft>
-                <a:spcPts val="300"/>
-              </a:spcAft>
-            </a:pPr>
-            <a:r>
-              <a:rPr sz="1250" b="1" i="0">
-                <a:solidFill>
-                  <a:srgbClr val="1A1A1A"/>
-                </a:solidFill>
-                <a:latin typeface="Calibri"/>
-              </a:rPr>
-              <a:t>Scoring  (once a day is plenty for a 90 day question)</a:t>
-            </a:r>
-          </a:p>
-          <a:p>
-            <a:pPr>
-              <a:spcAft>
-                <a:spcPts val="300"/>
-              </a:spcAft>
-            </a:pPr>
-            <a:r>
-              <a:rPr sz="1250" b="0" i="0">
-                <a:solidFill>
-                  <a:srgbClr val="5A6270"/>
-                </a:solidFill>
-                <a:latin typeface="Calibri"/>
-              </a:rPr>
-              <a:t>   · writes the customer, the score, and the main reasons</a:t>
-            </a:r>
-          </a:p>
-          <a:p>
-            <a:pPr>
-              <a:spcAft>
-                <a:spcPts val="300"/>
-              </a:spcAft>
-            </a:pPr>
-            <a:r>
-              <a:rPr sz="1250" b="0" i="0">
-                <a:solidFill>
-                  <a:srgbClr val="5A6270"/>
-                </a:solidFill>
-                <a:latin typeface="Calibri"/>
-              </a:rPr>
-              <a:t>        |</a:t>
-            </a:r>
-          </a:p>
-          <a:p>
-            <a:pPr>
-              <a:spcAft>
-                <a:spcPts val="300"/>
-              </a:spcAft>
-            </a:pPr>
-            <a:r>
-              <a:rPr sz="1250" b="1" i="0">
-                <a:solidFill>
-                  <a:srgbClr val="1A1A1A"/>
-                </a:solidFill>
-                <a:latin typeface="Calibri"/>
-              </a:rPr>
-              <a:t>Use  (a call list for the success team)</a:t>
-            </a:r>
-          </a:p>
-          <a:p>
-            <a:pPr>
-              <a:spcAft>
-                <a:spcPts val="300"/>
-              </a:spcAft>
-            </a:pPr>
-            <a:r>
-              <a:rPr sz="1250" b="0" i="0">
-                <a:solidFill>
-                  <a:srgbClr val="5A6270"/>
-                </a:solidFill>
-                <a:latin typeface="Calibri"/>
-              </a:rPr>
-              <a:t>   · scores also written back to the CRM for context</a:t>
-            </a:r>
-          </a:p>
-          <a:p>
-            <a:pPr>
-              <a:spcAft>
-                <a:spcPts val="300"/>
-              </a:spcAft>
-            </a:pPr>
-            <a:r>
-              <a:rPr sz="1250" b="0" i="0">
-                <a:solidFill>
-                  <a:srgbClr val="5A6270"/>
-                </a:solidFill>
-                <a:latin typeface="Calibri"/>
-              </a:rPr>
-              <a:t>   · nothing is ever triggered automatically</a:t>
+              <a:t>Here the gap between the best model and the honest score was the entire apparent signal.</a:t>
             </a:r>
           </a:p>
         </p:txBody>
@@ -7817,189 +8389,6 @@
       <p:sp>
         <p:nvSpPr>
           <p:cNvPr id="5" name="TextBox 4"/>
-          <p:cNvSpPr txBox="1"/>
-          <p:nvPr/>
-        </p:nvSpPr>
-        <p:spPr>
-          <a:xfrm>
-            <a:off x="6492240" y="1719072"/>
-            <a:ext cx="5029200" cy="4572000"/>
-          </a:xfrm>
-          <a:prstGeom prst="rect">
-            <a:avLst/>
-          </a:prstGeom>
-          <a:noFill/>
-        </p:spPr>
-        <p:txBody>
-          <a:bodyPr wrap="square">
-            <a:spAutoFit/>
-          </a:bodyPr>
-          <a:lstStyle/>
-          <a:p>
-            <a:pPr>
-              <a:spcAft>
-                <a:spcPts val="900"/>
-              </a:spcAft>
-            </a:pPr>
-            <a:r>
-              <a:rPr sz="1300" b="1" i="0">
-                <a:solidFill>
-                  <a:srgbClr val="1A1A1A"/>
-                </a:solidFill>
-                <a:latin typeface="Calibri"/>
-              </a:rPr>
-              <a:t>What I would watch</a:t>
-            </a:r>
-          </a:p>
-          <a:p>
-            <a:pPr lvl="1">
-              <a:spcAft>
-                <a:spcPts val="900"/>
-              </a:spcAft>
-            </a:pPr>
-            <a:r>
-              <a:rPr sz="1100" b="0" i="0">
-                <a:solidFill>
-                  <a:srgbClr val="5A6270"/>
-                </a:solidFill>
-                <a:latin typeface="Calibri"/>
-              </a:rPr>
-              <a:t>Whether the incoming data still looks like the data we trained on. Checked weekly.</a:t>
-            </a:r>
-          </a:p>
-          <a:p>
-            <a:pPr lvl="1">
-              <a:spcAft>
-                <a:spcPts val="900"/>
-              </a:spcAft>
-            </a:pPr>
-            <a:r>
-              <a:rPr sz="1100" b="0" i="0">
-                <a:solidFill>
-                  <a:srgbClr val="5A6270"/>
-                </a:solidFill>
-                <a:latin typeface="Calibri"/>
-              </a:rPr>
-              <a:t>Whether columns have gone missing or empty. Checked daily, and the job fails if the shape changes.</a:t>
-            </a:r>
-          </a:p>
-          <a:p>
-            <a:pPr lvl="1">
-              <a:spcAft>
-                <a:spcPts val="900"/>
-              </a:spcAft>
-            </a:pPr>
-            <a:r>
-              <a:rPr sz="1100" b="0" i="0">
-                <a:solidFill>
-                  <a:srgbClr val="5A6270"/>
-                </a:solidFill>
-                <a:latin typeface="Calibri"/>
-              </a:rPr>
-              <a:t>The leakage checks. Run every single time, and they stop the job.</a:t>
-            </a:r>
-          </a:p>
-          <a:p>
-            <a:pPr lvl="1">
-              <a:spcAft>
-                <a:spcPts val="900"/>
-              </a:spcAft>
-            </a:pPr>
-            <a:r>
-              <a:rPr sz="1100" b="0" i="0">
-                <a:solidFill>
-                  <a:srgbClr val="5A6270"/>
-                </a:solidFill>
-                <a:latin typeface="Calibri"/>
-              </a:rPr>
-              <a:t>Whether the scores themselves have drifted. Checked weekly.</a:t>
-            </a:r>
-          </a:p>
-          <a:p>
-            <a:pPr lvl="1">
-              <a:spcAft>
-                <a:spcPts val="900"/>
-              </a:spcAft>
-            </a:pPr>
-            <a:r>
-              <a:rPr sz="1100" b="0" i="0">
-                <a:solidFill>
-                  <a:srgbClr val="5A6270"/>
-                </a:solidFill>
-                <a:latin typeface="Calibri"/>
-              </a:rPr>
-              <a:t>Whether the model is still accurate. Checked every quarter, once we know who actually left.</a:t>
-            </a:r>
-          </a:p>
-          <a:p>
-            <a:pPr>
-              <a:spcAft>
-                <a:spcPts val="900"/>
-              </a:spcAft>
-            </a:pPr>
-            <a:r>
-              <a:rPr sz="600" b="0" i="0">
-                <a:solidFill>
-                  <a:srgbClr val="1A1A1A"/>
-                </a:solidFill>
-                <a:latin typeface="Calibri"/>
-              </a:rPr>
-              <a:t> </a:t>
-            </a:r>
-          </a:p>
-          <a:p>
-            <a:pPr>
-              <a:spcAft>
-                <a:spcPts val="900"/>
-              </a:spcAft>
-            </a:pPr>
-            <a:r>
-              <a:rPr sz="1300" b="0" i="0">
-                <a:solidFill>
-                  <a:srgbClr val="5A6270"/>
-                </a:solidFill>
-                <a:latin typeface="Calibri"/>
-              </a:rPr>
-              <a:t>We only learn if we were right 90 days later. So accuracy checks are always late. Watching the incoming data is the early warning, and accuracy confirms it afterwards.</a:t>
-            </a:r>
-          </a:p>
-          <a:p>
-            <a:pPr>
-              <a:spcAft>
-                <a:spcPts val="900"/>
-              </a:spcAft>
-            </a:pPr>
-            <a:r>
-              <a:rPr sz="600" b="0" i="0">
-                <a:solidFill>
-                  <a:srgbClr val="1A1A1A"/>
-                </a:solidFill>
-                <a:latin typeface="Calibri"/>
-              </a:rPr>
-              <a:t> </a:t>
-            </a:r>
-          </a:p>
-          <a:p>
-            <a:pPr>
-              <a:spcAft>
-                <a:spcPts val="900"/>
-              </a:spcAft>
-            </a:pPr>
-            <a:r>
-              <a:rPr sz="1300" b="1" i="0">
-                <a:solidFill>
-                  <a:srgbClr val="2E5F8A"/>
-                </a:solidFill>
-                <a:latin typeface="Calibri"/>
-              </a:rPr>
-              <a:t>The part I would argue for hardest is running the leakage checks in production. The bug in this project was in the pipeline, and pipeline bugs come back every time someone adds a feature.</a:t>
-            </a:r>
-          </a:p>
-        </p:txBody>
-      </p:sp>
-      <p:sp>
-        <p:nvSpPr>
-          <p:cNvPr id="6" name="TextBox 5"/>
           <p:cNvSpPr txBox="1"/>
           <p:nvPr/>
         </p:nvSpPr>
@@ -8022,11 +8411,11 @@
             <a:r>
               <a:rPr sz="1150" b="0" i="1">
                 <a:solidFill>
-                  <a:srgbClr val="1A1A1A"/>
-                </a:solidFill>
-                <a:latin typeface="Calibri"/>
-              </a:rPr>
-              <a:t>This is what I would build if the model were worth shipping. On these results it is not, and this extract cannot be repaired into one — the timestamps have to be collected against the right customers, not corrected. Once they are, the pipeline takes a date, so re-measuring is one command.</a:t>
+                  <a:srgbClr val="5A6270"/>
+                </a:solidFill>
+                <a:latin typeface="Calibri"/>
+              </a:rPr>
+              <a:t>I would teach all of it as experiments rather than lectures. Switch off the banned column list and watch AUC jump from 0.58 to 0.79. Then simulate a dataset with nothing in it and watch it produce a publishable-looking trend.</a:t>
             </a:r>
           </a:p>
         </p:txBody>
@@ -8808,6 +9197,574 @@
           </a:prstGeom>
         </p:spPr>
       </p:pic>
+    </p:spTree>
+  </p:cSld>
+  <p:clrMapOvr>
+    <a:masterClrMapping/>
+  </p:clrMapOvr>
+</p:sld>
+</file>
+
+<file path=ppt/slides/slide20.xml><?xml version="1.0" encoding="utf-8"?>
+<p:sld xmlns:a="http://schemas.openxmlformats.org/drawingml/2006/main" xmlns:r="http://schemas.openxmlformats.org/officeDocument/2006/relationships" xmlns:p="http://schemas.openxmlformats.org/presentationml/2006/main">
+  <p:cSld>
+    <p:spTree>
+      <p:nvGrpSpPr>
+        <p:cNvPr id="1" name=""/>
+        <p:cNvGrpSpPr/>
+        <p:nvPr/>
+      </p:nvGrpSpPr>
+      <p:grpSpPr>
+        <a:xfrm>
+          <a:off x="0" y="0"/>
+          <a:ext cx="0" cy="0"/>
+          <a:chOff x="0" y="0"/>
+          <a:chExt cx="0" cy="0"/>
+        </a:xfrm>
+      </p:grpSpPr>
+      <p:sp>
+        <p:nvSpPr>
+          <p:cNvPr id="2" name="TextBox 1"/>
+          <p:cNvSpPr txBox="1"/>
+          <p:nvPr/>
+        </p:nvSpPr>
+        <p:spPr>
+          <a:xfrm>
+            <a:off x="685800" y="365760"/>
+            <a:ext cx="10820095" cy="1051560"/>
+          </a:xfrm>
+          <a:prstGeom prst="rect">
+            <a:avLst/>
+          </a:prstGeom>
+          <a:noFill/>
+        </p:spPr>
+        <p:txBody>
+          <a:bodyPr wrap="square">
+            <a:spAutoFit/>
+          </a:bodyPr>
+          <a:lstStyle/>
+          <a:p>
+            <a:r>
+              <a:rPr sz="1200" b="1" i="0">
+                <a:solidFill>
+                  <a:srgbClr val="5A6270"/>
+                </a:solidFill>
+                <a:latin typeface="Calibri"/>
+              </a:rPr>
+              <a:t>PART 5 · SCALABILITY</a:t>
+            </a:r>
+          </a:p>
+          <a:p>
+            <a:pPr>
+              <a:spcBef>
+                <a:spcPts val="400"/>
+              </a:spcBef>
+            </a:pPr>
+            <a:r>
+              <a:rPr sz="2800" b="1" i="0">
+                <a:solidFill>
+                  <a:srgbClr val="1A1A1A"/>
+                </a:solidFill>
+                <a:latin typeface="Calibri"/>
+              </a:rPr>
+              <a:t>How I would run this in production</a:t>
+            </a:r>
+          </a:p>
+        </p:txBody>
+      </p:sp>
+      <p:sp>
+        <p:nvSpPr>
+          <p:cNvPr id="3" name="Rectangle 2"/>
+          <p:cNvSpPr/>
+          <p:nvPr/>
+        </p:nvSpPr>
+        <p:spPr>
+          <a:xfrm>
+            <a:off x="685800" y="1426464"/>
+            <a:ext cx="10820095" cy="9525"/>
+          </a:xfrm>
+          <a:prstGeom prst="rect">
+            <a:avLst/>
+          </a:prstGeom>
+          <a:solidFill>
+            <a:srgbClr val="D8DCE0"/>
+          </a:solidFill>
+          <a:ln>
+            <a:noFill/>
+          </a:ln>
+          <a:effectLst/>
+        </p:spPr>
+        <p:style>
+          <a:lnRef idx="1">
+            <a:schemeClr val="accent1"/>
+          </a:lnRef>
+          <a:fillRef idx="3">
+            <a:schemeClr val="accent1"/>
+          </a:fillRef>
+          <a:effectRef idx="2">
+            <a:schemeClr val="accent1"/>
+          </a:effectRef>
+          <a:fontRef idx="minor">
+            <a:schemeClr val="lt1"/>
+          </a:fontRef>
+        </p:style>
+        <p:txBody>
+          <a:bodyPr rtlCol="0" anchor="ctr"/>
+          <a:lstStyle/>
+          <a:p>
+            <a:pPr algn="ctr"/>
+            <a:endParaRPr/>
+          </a:p>
+        </p:txBody>
+      </p:sp>
+      <p:sp>
+        <p:nvSpPr>
+          <p:cNvPr id="4" name="TextBox 3"/>
+          <p:cNvSpPr txBox="1"/>
+          <p:nvPr/>
+        </p:nvSpPr>
+        <p:spPr>
+          <a:xfrm>
+            <a:off x="685800" y="1719072"/>
+            <a:ext cx="5577840" cy="4206240"/>
+          </a:xfrm>
+          <a:prstGeom prst="rect">
+            <a:avLst/>
+          </a:prstGeom>
+          <a:noFill/>
+        </p:spPr>
+        <p:txBody>
+          <a:bodyPr wrap="square">
+            <a:spAutoFit/>
+          </a:bodyPr>
+          <a:lstStyle/>
+          <a:p>
+            <a:pPr>
+              <a:spcAft>
+                <a:spcPts val="300"/>
+              </a:spcAft>
+            </a:pPr>
+            <a:r>
+              <a:rPr sz="1250" b="1" i="0">
+                <a:solidFill>
+                  <a:srgbClr val="1A1A1A"/>
+                </a:solidFill>
+                <a:latin typeface="Calibri"/>
+              </a:rPr>
+              <a:t>Sources:  billing and CRM, product usage, support desk</a:t>
+            </a:r>
+          </a:p>
+          <a:p>
+            <a:pPr>
+              <a:spcAft>
+                <a:spcPts val="300"/>
+              </a:spcAft>
+            </a:pPr>
+            <a:r>
+              <a:rPr sz="1250" b="0" i="0">
+                <a:solidFill>
+                  <a:srgbClr val="5A6270"/>
+                </a:solidFill>
+                <a:latin typeface="Calibri"/>
+              </a:rPr>
+              <a:t>        |  runs once a night</a:t>
+            </a:r>
+          </a:p>
+          <a:p>
+            <a:pPr>
+              <a:spcAft>
+                <a:spcPts val="300"/>
+              </a:spcAft>
+            </a:pPr>
+            <a:r>
+              <a:rPr sz="1250" b="1" i="0">
+                <a:solidFill>
+                  <a:srgbClr val="1A1A1A"/>
+                </a:solidFill>
+                <a:latin typeface="Calibri"/>
+              </a:rPr>
+              <a:t>Feature build  (THE SAME CODE USED IN TRAINING)</a:t>
+            </a:r>
+          </a:p>
+          <a:p>
+            <a:pPr>
+              <a:spcAft>
+                <a:spcPts val="300"/>
+              </a:spcAft>
+            </a:pPr>
+            <a:r>
+              <a:rPr sz="1250" b="0" i="0">
+                <a:solidFill>
+                  <a:srgbClr val="5A6270"/>
+                </a:solidFill>
+                <a:latin typeface="Calibri"/>
+              </a:rPr>
+              <a:t>   · every calculation takes a date and looks only before it</a:t>
+            </a:r>
+          </a:p>
+          <a:p>
+            <a:pPr>
+              <a:spcAft>
+                <a:spcPts val="300"/>
+              </a:spcAft>
+            </a:pPr>
+            <a:r>
+              <a:rPr sz="1250" b="0" i="0">
+                <a:solidFill>
+                  <a:srgbClr val="5A6270"/>
+                </a:solidFill>
+                <a:latin typeface="Calibri"/>
+              </a:rPr>
+              <a:t>   · blanks out anything not yet known on that date</a:t>
+            </a:r>
+          </a:p>
+          <a:p>
+            <a:pPr>
+              <a:spcAft>
+                <a:spcPts val="300"/>
+              </a:spcAft>
+            </a:pPr>
+            <a:r>
+              <a:rPr sz="1250" b="0" i="0">
+                <a:solidFill>
+                  <a:srgbClr val="5A6270"/>
+                </a:solidFill>
+                <a:latin typeface="Calibri"/>
+              </a:rPr>
+              <a:t>   · the leakage checks run here and stop the job if they fail</a:t>
+            </a:r>
+          </a:p>
+          <a:p>
+            <a:pPr>
+              <a:spcAft>
+                <a:spcPts val="300"/>
+              </a:spcAft>
+            </a:pPr>
+            <a:r>
+              <a:rPr sz="1250" b="0" i="0">
+                <a:solidFill>
+                  <a:srgbClr val="5A6270"/>
+                </a:solidFill>
+                <a:latin typeface="Calibri"/>
+              </a:rPr>
+              <a:t>        |</a:t>
+            </a:r>
+          </a:p>
+          <a:p>
+            <a:pPr>
+              <a:spcAft>
+                <a:spcPts val="300"/>
+              </a:spcAft>
+            </a:pPr>
+            <a:r>
+              <a:rPr sz="1250" b="1" i="0">
+                <a:solidFill>
+                  <a:srgbClr val="1A1A1A"/>
+                </a:solidFill>
+                <a:latin typeface="Calibri"/>
+              </a:rPr>
+              <a:t>Scoring  (once a day is plenty for a 90 day question)</a:t>
+            </a:r>
+          </a:p>
+          <a:p>
+            <a:pPr>
+              <a:spcAft>
+                <a:spcPts val="300"/>
+              </a:spcAft>
+            </a:pPr>
+            <a:r>
+              <a:rPr sz="1250" b="0" i="0">
+                <a:solidFill>
+                  <a:srgbClr val="5A6270"/>
+                </a:solidFill>
+                <a:latin typeface="Calibri"/>
+              </a:rPr>
+              <a:t>   · writes the customer, the score, and the main reasons</a:t>
+            </a:r>
+          </a:p>
+          <a:p>
+            <a:pPr>
+              <a:spcAft>
+                <a:spcPts val="300"/>
+              </a:spcAft>
+            </a:pPr>
+            <a:r>
+              <a:rPr sz="1250" b="0" i="0">
+                <a:solidFill>
+                  <a:srgbClr val="5A6270"/>
+                </a:solidFill>
+                <a:latin typeface="Calibri"/>
+              </a:rPr>
+              <a:t>        |</a:t>
+            </a:r>
+          </a:p>
+          <a:p>
+            <a:pPr>
+              <a:spcAft>
+                <a:spcPts val="300"/>
+              </a:spcAft>
+            </a:pPr>
+            <a:r>
+              <a:rPr sz="1250" b="1" i="0">
+                <a:solidFill>
+                  <a:srgbClr val="1A1A1A"/>
+                </a:solidFill>
+                <a:latin typeface="Calibri"/>
+              </a:rPr>
+              <a:t>Use  (a call list for the success team)</a:t>
+            </a:r>
+          </a:p>
+          <a:p>
+            <a:pPr>
+              <a:spcAft>
+                <a:spcPts val="300"/>
+              </a:spcAft>
+            </a:pPr>
+            <a:r>
+              <a:rPr sz="1250" b="0" i="0">
+                <a:solidFill>
+                  <a:srgbClr val="5A6270"/>
+                </a:solidFill>
+                <a:latin typeface="Calibri"/>
+              </a:rPr>
+              <a:t>   · scores also written back to the CRM for context</a:t>
+            </a:r>
+          </a:p>
+          <a:p>
+            <a:pPr>
+              <a:spcAft>
+                <a:spcPts val="300"/>
+              </a:spcAft>
+            </a:pPr>
+            <a:r>
+              <a:rPr sz="1250" b="0" i="0">
+                <a:solidFill>
+                  <a:srgbClr val="5A6270"/>
+                </a:solidFill>
+                <a:latin typeface="Calibri"/>
+              </a:rPr>
+              <a:t>   · nothing is ever triggered automatically</a:t>
+            </a:r>
+          </a:p>
+        </p:txBody>
+      </p:sp>
+      <p:sp>
+        <p:nvSpPr>
+          <p:cNvPr id="5" name="TextBox 4"/>
+          <p:cNvSpPr txBox="1"/>
+          <p:nvPr/>
+        </p:nvSpPr>
+        <p:spPr>
+          <a:xfrm>
+            <a:off x="6492240" y="1719072"/>
+            <a:ext cx="5029200" cy="4572000"/>
+          </a:xfrm>
+          <a:prstGeom prst="rect">
+            <a:avLst/>
+          </a:prstGeom>
+          <a:noFill/>
+        </p:spPr>
+        <p:txBody>
+          <a:bodyPr wrap="square">
+            <a:spAutoFit/>
+          </a:bodyPr>
+          <a:lstStyle/>
+          <a:p>
+            <a:pPr>
+              <a:spcAft>
+                <a:spcPts val="900"/>
+              </a:spcAft>
+            </a:pPr>
+            <a:r>
+              <a:rPr sz="1300" b="1" i="0">
+                <a:solidFill>
+                  <a:srgbClr val="1A1A1A"/>
+                </a:solidFill>
+                <a:latin typeface="Calibri"/>
+              </a:rPr>
+              <a:t>What I would watch</a:t>
+            </a:r>
+          </a:p>
+          <a:p>
+            <a:pPr lvl="1">
+              <a:spcAft>
+                <a:spcPts val="900"/>
+              </a:spcAft>
+            </a:pPr>
+            <a:r>
+              <a:rPr sz="1100" b="0" i="0">
+                <a:solidFill>
+                  <a:srgbClr val="5A6270"/>
+                </a:solidFill>
+                <a:latin typeface="Calibri"/>
+              </a:rPr>
+              <a:t>Whether the incoming data still looks like the data we trained on. Checked weekly.</a:t>
+            </a:r>
+          </a:p>
+          <a:p>
+            <a:pPr lvl="1">
+              <a:spcAft>
+                <a:spcPts val="900"/>
+              </a:spcAft>
+            </a:pPr>
+            <a:r>
+              <a:rPr sz="1100" b="0" i="0">
+                <a:solidFill>
+                  <a:srgbClr val="5A6270"/>
+                </a:solidFill>
+                <a:latin typeface="Calibri"/>
+              </a:rPr>
+              <a:t>Whether columns have gone missing or empty. Checked daily, and the job fails if the shape changes.</a:t>
+            </a:r>
+          </a:p>
+          <a:p>
+            <a:pPr lvl="1">
+              <a:spcAft>
+                <a:spcPts val="900"/>
+              </a:spcAft>
+            </a:pPr>
+            <a:r>
+              <a:rPr sz="1100" b="0" i="0">
+                <a:solidFill>
+                  <a:srgbClr val="5A6270"/>
+                </a:solidFill>
+                <a:latin typeface="Calibri"/>
+              </a:rPr>
+              <a:t>The leakage checks. Run every single time, and they stop the job.</a:t>
+            </a:r>
+          </a:p>
+          <a:p>
+            <a:pPr lvl="1">
+              <a:spcAft>
+                <a:spcPts val="900"/>
+              </a:spcAft>
+            </a:pPr>
+            <a:r>
+              <a:rPr sz="1100" b="0" i="0">
+                <a:solidFill>
+                  <a:srgbClr val="5A6270"/>
+                </a:solidFill>
+                <a:latin typeface="Calibri"/>
+              </a:rPr>
+              <a:t>Whether the scores themselves have drifted. Checked weekly.</a:t>
+            </a:r>
+          </a:p>
+          <a:p>
+            <a:pPr lvl="1">
+              <a:spcAft>
+                <a:spcPts val="900"/>
+              </a:spcAft>
+            </a:pPr>
+            <a:r>
+              <a:rPr sz="1100" b="0" i="0">
+                <a:solidFill>
+                  <a:srgbClr val="5A6270"/>
+                </a:solidFill>
+                <a:latin typeface="Calibri"/>
+              </a:rPr>
+              <a:t>Whether the model is still accurate. Checked every quarter, once we know who actually left.</a:t>
+            </a:r>
+          </a:p>
+          <a:p>
+            <a:pPr>
+              <a:spcAft>
+                <a:spcPts val="900"/>
+              </a:spcAft>
+            </a:pPr>
+            <a:r>
+              <a:rPr sz="600" b="0" i="0">
+                <a:solidFill>
+                  <a:srgbClr val="1A1A1A"/>
+                </a:solidFill>
+                <a:latin typeface="Calibri"/>
+              </a:rPr>
+              <a:t> </a:t>
+            </a:r>
+          </a:p>
+          <a:p>
+            <a:pPr>
+              <a:spcAft>
+                <a:spcPts val="900"/>
+              </a:spcAft>
+            </a:pPr>
+            <a:r>
+              <a:rPr sz="1300" b="0" i="0">
+                <a:solidFill>
+                  <a:srgbClr val="5A6270"/>
+                </a:solidFill>
+                <a:latin typeface="Calibri"/>
+              </a:rPr>
+              <a:t>We only learn if we were right 90 days later. So accuracy checks are always late. Watching the incoming data is the early warning, and accuracy confirms it afterwards.</a:t>
+            </a:r>
+          </a:p>
+          <a:p>
+            <a:pPr>
+              <a:spcAft>
+                <a:spcPts val="900"/>
+              </a:spcAft>
+            </a:pPr>
+            <a:r>
+              <a:rPr sz="600" b="0" i="0">
+                <a:solidFill>
+                  <a:srgbClr val="1A1A1A"/>
+                </a:solidFill>
+                <a:latin typeface="Calibri"/>
+              </a:rPr>
+              <a:t> </a:t>
+            </a:r>
+          </a:p>
+          <a:p>
+            <a:pPr>
+              <a:spcAft>
+                <a:spcPts val="900"/>
+              </a:spcAft>
+            </a:pPr>
+            <a:r>
+              <a:rPr sz="1300" b="1" i="0">
+                <a:solidFill>
+                  <a:srgbClr val="2E5F8A"/>
+                </a:solidFill>
+                <a:latin typeface="Calibri"/>
+              </a:rPr>
+              <a:t>The part I would argue for hardest is running the leakage checks in production. The bug in this project was in the pipeline, and pipeline bugs come back every time someone adds a feature.</a:t>
+            </a:r>
+          </a:p>
+        </p:txBody>
+      </p:sp>
+      <p:sp>
+        <p:nvSpPr>
+          <p:cNvPr id="6" name="TextBox 5"/>
+          <p:cNvSpPr txBox="1"/>
+          <p:nvPr/>
+        </p:nvSpPr>
+        <p:spPr>
+          <a:xfrm>
+            <a:off x="685800" y="6126480"/>
+            <a:ext cx="10820095" cy="502920"/>
+          </a:xfrm>
+          <a:prstGeom prst="rect">
+            <a:avLst/>
+          </a:prstGeom>
+          <a:noFill/>
+        </p:spPr>
+        <p:txBody>
+          <a:bodyPr wrap="square">
+            <a:spAutoFit/>
+          </a:bodyPr>
+          <a:lstStyle/>
+          <a:p>
+            <a:r>
+              <a:rPr sz="1150" b="0" i="1">
+                <a:solidFill>
+                  <a:srgbClr val="1A1A1A"/>
+                </a:solidFill>
+                <a:latin typeface="Calibri"/>
+              </a:rPr>
+              <a:t>This is what I would build if the model were worth shipping. On these results it is not, and this extract cannot be repaired into one — the timestamps have to be collected against the right customers, not corrected. Once they are, the pipeline takes a date, so re-measuring is one command.</a:t>
+            </a:r>
+          </a:p>
+        </p:txBody>
+      </p:sp>
     </p:spTree>
   </p:cSld>
   <p:clrMapOvr>

</xml_diff>

<commit_message>
Enhance presentation materials with new insights and visual updates
- Updated `build_new_slides.py` to include new recommendations on customer churn analysis, emphasizing the importance of calling at-risk customers and the ineffectiveness of ranking.
- Introduced new figures in `fig_breakeven_html.py`, `fig_tenure_null_html.py`, and `fig_what_to_do_html.py` to visually represent key findings and recommendations.
- Revised HTML outputs to improve clarity and presentation of data, ensuring alignment with the latest insights.
- Updated `AvePoint_Case_Study.pptx` to reflect these changes, enhancing the overall quality and effectiveness of the presentation.

These modifications aim to provide a more comprehensive understanding of customer retention strategies and improve the visual communication of findings.
</commit_message>
<xml_diff>
--- a/outputs/decks/AvePoint_Case_Study.pptx
+++ b/outputs/decks/AvePoint_Case_Study.pptx
@@ -5,7 +5,7 @@
     <p:sldMasterId id="2147483648" r:id="rId1"/>
   </p:sldMasterIdLst>
   <p:notesMasterIdLst>
-    <p:notesMasterId r:id="rId22"/>
+    <p:notesMasterId r:id="rId20"/>
   </p:notesMasterIdLst>
   <p:sldIdLst>
     <p:sldId id="256" r:id="rId2"/>
@@ -22,12 +22,10 @@
     <p:sldId id="263" r:id="rId13"/>
     <p:sldId id="264" r:id="rId14"/>
     <p:sldId id="282" r:id="rId15"/>
-    <p:sldId id="266" r:id="rId16"/>
-    <p:sldId id="267" r:id="rId17"/>
-    <p:sldId id="268" r:id="rId18"/>
-    <p:sldId id="269" r:id="rId19"/>
-    <p:sldId id="270" r:id="rId20"/>
-    <p:sldId id="271" r:id="rId21"/>
+    <p:sldId id="267" r:id="rId16"/>
+    <p:sldId id="266" r:id="rId17"/>
+    <p:sldId id="283" r:id="rId18"/>
+    <p:sldId id="271" r:id="rId19"/>
   </p:sldIdLst>
   <p:sldSz cx="12192000" cy="6858000"/>
   <p:notesSz cx="6858000" cy="9144000"/>
@@ -148,7 +146,7 @@
 <file path=ppt/revisionInfo.xml><?xml version="1.0" encoding="utf-8"?>
 <p1510:revInfo xmlns:a="http://schemas.openxmlformats.org/drawingml/2006/main" xmlns:r="http://schemas.openxmlformats.org/officeDocument/2006/relationships" xmlns:p1510="http://schemas.microsoft.com/office/powerpoint/2015/10/main">
   <p1510:revLst>
-    <p1510:client id="{25DC7B8B-EC09-4841-A573-8FF6489E0CC5}" v="155" dt="2026-07-29T14:51:32.883"/>
+    <p1510:client id="{25DC7B8B-EC09-4841-A573-8FF6489E0CC5}" v="168" dt="2026-07-29T16:27:33.826"/>
   </p1510:revLst>
 </p1510:revInfo>
 </file>
@@ -157,8 +155,8 @@
 <pc:chgInfo xmlns:a="http://schemas.openxmlformats.org/drawingml/2006/main" xmlns:r="http://schemas.openxmlformats.org/officeDocument/2006/relationships" xmlns:ac="http://schemas.microsoft.com/office/drawing/2013/main/command" xmlns:pc="http://schemas.microsoft.com/office/powerpoint/2013/main/command">
   <pc:docChgLst>
     <pc:chgData name="Dmitriy Ratushny" userId="08050032e8047aee" providerId="LiveId" clId="{78EB1A6D-D3A9-4525-A4D5-A50D4E20D487}"/>
-    <pc:docChg chg="undo custSel addSld delSld modSld">
-      <pc:chgData name="Dmitriy Ratushny" userId="08050032e8047aee" providerId="LiveId" clId="{78EB1A6D-D3A9-4525-A4D5-A50D4E20D487}" dt="2026-07-29T15:04:33.733" v="3319" actId="20577"/>
+    <pc:docChg chg="undo custSel addSld delSld modSld sldOrd">
+      <pc:chgData name="Dmitriy Ratushny" userId="08050032e8047aee" providerId="LiveId" clId="{78EB1A6D-D3A9-4525-A4D5-A50D4E20D487}" dt="2026-07-29T16:29:17.780" v="3481"/>
       <pc:docMkLst>
         <pc:docMk/>
       </pc:docMkLst>
@@ -577,8 +575,8 @@
           </ac:picMkLst>
         </pc:picChg>
       </pc:sldChg>
-      <pc:sldChg chg="modSp del mod">
-        <pc:chgData name="Dmitriy Ratushny" userId="08050032e8047aee" providerId="LiveId" clId="{78EB1A6D-D3A9-4525-A4D5-A50D4E20D487}" dt="2026-07-29T14:43:48.988" v="3232" actId="47"/>
+      <pc:sldChg chg="modSp add del mod">
+        <pc:chgData name="Dmitriy Ratushny" userId="08050032e8047aee" providerId="LiveId" clId="{78EB1A6D-D3A9-4525-A4D5-A50D4E20D487}" dt="2026-07-29T15:53:54.528" v="3398" actId="47"/>
         <pc:sldMkLst>
           <pc:docMk/>
           <pc:sldMk cId="0" sldId="265"/>
@@ -592,18 +590,26 @@
           </ac:spMkLst>
         </pc:spChg>
       </pc:sldChg>
-      <pc:sldChg chg="delSp modSp mod">
-        <pc:chgData name="Dmitriy Ratushny" userId="08050032e8047aee" providerId="LiveId" clId="{78EB1A6D-D3A9-4525-A4D5-A50D4E20D487}" dt="2026-07-29T14:50:10.583" v="3238" actId="478"/>
+      <pc:sldChg chg="addSp delSp modSp add del mod">
+        <pc:chgData name="Dmitriy Ratushny" userId="08050032e8047aee" providerId="LiveId" clId="{78EB1A6D-D3A9-4525-A4D5-A50D4E20D487}" dt="2026-07-29T16:29:09.628" v="3479" actId="47"/>
         <pc:sldMkLst>
           <pc:docMk/>
           <pc:sldMk cId="0" sldId="266"/>
         </pc:sldMkLst>
         <pc:spChg chg="mod">
-          <ac:chgData name="Dmitriy Ratushny" userId="08050032e8047aee" providerId="LiveId" clId="{78EB1A6D-D3A9-4525-A4D5-A50D4E20D487}" dt="2026-07-29T13:04:49.312" v="2752" actId="207"/>
+          <ac:chgData name="Dmitriy Ratushny" userId="08050032e8047aee" providerId="LiveId" clId="{78EB1A6D-D3A9-4525-A4D5-A50D4E20D487}" dt="2026-07-29T15:16:19.764" v="3384" actId="6549"/>
           <ac:spMkLst>
             <pc:docMk/>
             <pc:sldMk cId="0" sldId="266"/>
             <ac:spMk id="2" creationId="{00000000-0000-0000-0000-000000000000}"/>
+          </ac:spMkLst>
+        </pc:spChg>
+        <pc:spChg chg="del">
+          <ac:chgData name="Dmitriy Ratushny" userId="08050032e8047aee" providerId="LiveId" clId="{78EB1A6D-D3A9-4525-A4D5-A50D4E20D487}" dt="2026-07-29T15:13:29.668" v="3333" actId="478"/>
+          <ac:spMkLst>
+            <pc:docMk/>
+            <pc:sldMk cId="0" sldId="266"/>
+            <ac:spMk id="5" creationId="{00000000-0000-0000-0000-000000000000}"/>
           </ac:spMkLst>
         </pc:spChg>
         <pc:spChg chg="del">
@@ -614,9 +620,41 @@
             <ac:spMk id="6" creationId="{00000000-0000-0000-0000-000000000000}"/>
           </ac:spMkLst>
         </pc:spChg>
+        <pc:spChg chg="add mod">
+          <ac:chgData name="Dmitriy Ratushny" userId="08050032e8047aee" providerId="LiveId" clId="{78EB1A6D-D3A9-4525-A4D5-A50D4E20D487}" dt="2026-07-29T15:33:56.924" v="3397" actId="20577"/>
+          <ac:spMkLst>
+            <pc:docMk/>
+            <pc:sldMk cId="0" sldId="266"/>
+            <ac:spMk id="7" creationId="{A7236729-E287-7283-0A77-C4717D568D37}"/>
+          </ac:spMkLst>
+        </pc:spChg>
+        <pc:picChg chg="del">
+          <ac:chgData name="Dmitriy Ratushny" userId="08050032e8047aee" providerId="LiveId" clId="{78EB1A6D-D3A9-4525-A4D5-A50D4E20D487}" dt="2026-07-29T15:13:25.669" v="3332" actId="478"/>
+          <ac:picMkLst>
+            <pc:docMk/>
+            <pc:sldMk cId="0" sldId="266"/>
+            <ac:picMk id="4" creationId="{00000000-0000-0000-0000-000000000000}"/>
+          </ac:picMkLst>
+        </pc:picChg>
+        <pc:picChg chg="add del mod">
+          <ac:chgData name="Dmitriy Ratushny" userId="08050032e8047aee" providerId="LiveId" clId="{78EB1A6D-D3A9-4525-A4D5-A50D4E20D487}" dt="2026-07-29T15:22:52.305" v="3388" actId="478"/>
+          <ac:picMkLst>
+            <pc:docMk/>
+            <pc:sldMk cId="0" sldId="266"/>
+            <ac:picMk id="9" creationId="{33E6DD1A-D7D2-2CB5-EFC5-7C5C90646EF6}"/>
+          </ac:picMkLst>
+        </pc:picChg>
+        <pc:picChg chg="add mod">
+          <ac:chgData name="Dmitriy Ratushny" userId="08050032e8047aee" providerId="LiveId" clId="{78EB1A6D-D3A9-4525-A4D5-A50D4E20D487}" dt="2026-07-29T15:22:56.400" v="3391" actId="14100"/>
+          <ac:picMkLst>
+            <pc:docMk/>
+            <pc:sldMk cId="0" sldId="266"/>
+            <ac:picMk id="11" creationId="{C69554E6-A1EF-E6EB-DCA9-B1FAEA444E36}"/>
+          </ac:picMkLst>
+        </pc:picChg>
       </pc:sldChg>
-      <pc:sldChg chg="modSp mod">
-        <pc:chgData name="Dmitriy Ratushny" userId="08050032e8047aee" providerId="LiveId" clId="{78EB1A6D-D3A9-4525-A4D5-A50D4E20D487}" dt="2026-07-29T13:04:57.467" v="2764" actId="207"/>
+      <pc:sldChg chg="delSp modSp add del mod ord">
+        <pc:chgData name="Dmitriy Ratushny" userId="08050032e8047aee" providerId="LiveId" clId="{78EB1A6D-D3A9-4525-A4D5-A50D4E20D487}" dt="2026-07-29T16:29:17.780" v="3481"/>
         <pc:sldMkLst>
           <pc:docMk/>
           <pc:sldMk cId="0" sldId="267"/>
@@ -629,15 +667,23 @@
             <ac:spMk id="2" creationId="{00000000-0000-0000-0000-000000000000}"/>
           </ac:spMkLst>
         </pc:spChg>
+        <pc:spChg chg="del">
+          <ac:chgData name="Dmitriy Ratushny" userId="08050032e8047aee" providerId="LiveId" clId="{78EB1A6D-D3A9-4525-A4D5-A50D4E20D487}" dt="2026-07-29T15:57:02.948" v="3399" actId="478"/>
+          <ac:spMkLst>
+            <pc:docMk/>
+            <pc:sldMk cId="0" sldId="267"/>
+            <ac:spMk id="6" creationId="{00000000-0000-0000-0000-000000000000}"/>
+          </ac:spMkLst>
+        </pc:spChg>
       </pc:sldChg>
-      <pc:sldChg chg="modSp mod">
-        <pc:chgData name="Dmitriy Ratushny" userId="08050032e8047aee" providerId="LiveId" clId="{78EB1A6D-D3A9-4525-A4D5-A50D4E20D487}" dt="2026-07-29T15:04:33.733" v="3319" actId="20577"/>
+      <pc:sldChg chg="modSp add del mod">
+        <pc:chgData name="Dmitriy Ratushny" userId="08050032e8047aee" providerId="LiveId" clId="{78EB1A6D-D3A9-4525-A4D5-A50D4E20D487}" dt="2026-07-29T16:26:27.921" v="3469" actId="47"/>
         <pc:sldMkLst>
           <pc:docMk/>
           <pc:sldMk cId="0" sldId="268"/>
         </pc:sldMkLst>
         <pc:spChg chg="mod">
-          <ac:chgData name="Dmitriy Ratushny" userId="08050032e8047aee" providerId="LiveId" clId="{78EB1A6D-D3A9-4525-A4D5-A50D4E20D487}" dt="2026-07-29T13:05:04.462" v="2776" actId="207"/>
+          <ac:chgData name="Dmitriy Ratushny" userId="08050032e8047aee" providerId="LiveId" clId="{78EB1A6D-D3A9-4525-A4D5-A50D4E20D487}" dt="2026-07-29T16:26:21.431" v="3466" actId="6549"/>
           <ac:spMkLst>
             <pc:docMk/>
             <pc:sldMk cId="0" sldId="268"/>
@@ -652,6 +698,52 @@
             <ac:spMk id="5" creationId="{00000000-0000-0000-0000-000000000000}"/>
           </ac:spMkLst>
         </pc:spChg>
+      </pc:sldChg>
+      <pc:sldChg chg="delSp modSp del mod ord">
+        <pc:chgData name="Dmitriy Ratushny" userId="08050032e8047aee" providerId="LiveId" clId="{78EB1A6D-D3A9-4525-A4D5-A50D4E20D487}" dt="2026-07-29T16:29:08.501" v="3477" actId="47"/>
+        <pc:sldMkLst>
+          <pc:docMk/>
+          <pc:sldMk cId="0" sldId="269"/>
+        </pc:sldMkLst>
+        <pc:spChg chg="mod">
+          <ac:chgData name="Dmitriy Ratushny" userId="08050032e8047aee" providerId="LiveId" clId="{78EB1A6D-D3A9-4525-A4D5-A50D4E20D487}" dt="2026-07-29T16:08:01.321" v="3461" actId="20577"/>
+          <ac:spMkLst>
+            <pc:docMk/>
+            <pc:sldMk cId="0" sldId="269"/>
+            <ac:spMk id="2" creationId="{00000000-0000-0000-0000-000000000000}"/>
+          </ac:spMkLst>
+        </pc:spChg>
+        <pc:spChg chg="mod">
+          <ac:chgData name="Dmitriy Ratushny" userId="08050032e8047aee" providerId="LiveId" clId="{78EB1A6D-D3A9-4525-A4D5-A50D4E20D487}" dt="2026-07-29T16:07:25.033" v="3438" actId="20577"/>
+          <ac:spMkLst>
+            <pc:docMk/>
+            <pc:sldMk cId="0" sldId="269"/>
+            <ac:spMk id="5" creationId="{00000000-0000-0000-0000-000000000000}"/>
+          </ac:spMkLst>
+        </pc:spChg>
+        <pc:spChg chg="del">
+          <ac:chgData name="Dmitriy Ratushny" userId="08050032e8047aee" providerId="LiveId" clId="{78EB1A6D-D3A9-4525-A4D5-A50D4E20D487}" dt="2026-07-29T15:59:15.614" v="3409" actId="478"/>
+          <ac:spMkLst>
+            <pc:docMk/>
+            <pc:sldMk cId="0" sldId="269"/>
+            <ac:spMk id="6" creationId="{00000000-0000-0000-0000-000000000000}"/>
+          </ac:spMkLst>
+        </pc:spChg>
+        <pc:picChg chg="del">
+          <ac:chgData name="Dmitriy Ratushny" userId="08050032e8047aee" providerId="LiveId" clId="{78EB1A6D-D3A9-4525-A4D5-A50D4E20D487}" dt="2026-07-29T15:59:12.251" v="3408" actId="478"/>
+          <ac:picMkLst>
+            <pc:docMk/>
+            <pc:sldMk cId="0" sldId="269"/>
+            <ac:picMk id="4" creationId="{00000000-0000-0000-0000-000000000000}"/>
+          </ac:picMkLst>
+        </pc:picChg>
+      </pc:sldChg>
+      <pc:sldChg chg="del">
+        <pc:chgData name="Dmitriy Ratushny" userId="08050032e8047aee" providerId="LiveId" clId="{78EB1A6D-D3A9-4525-A4D5-A50D4E20D487}" dt="2026-07-29T16:00:23.538" v="3410" actId="47"/>
+        <pc:sldMkLst>
+          <pc:docMk/>
+          <pc:sldMk cId="0" sldId="270"/>
+        </pc:sldMkLst>
       </pc:sldChg>
       <pc:sldChg chg="addSp delSp modSp new mod">
         <pc:chgData name="Dmitriy Ratushny" userId="08050032e8047aee" providerId="LiveId" clId="{78EB1A6D-D3A9-4525-A4D5-A50D4E20D487}" dt="2026-07-29T11:26:45.518" v="1890" actId="20577"/>
@@ -746,11 +838,19 @@
         </pc:spChg>
       </pc:sldChg>
       <pc:sldChg chg="delSp modSp add del mod">
-        <pc:chgData name="Dmitriy Ratushny" userId="08050032e8047aee" providerId="LiveId" clId="{78EB1A6D-D3A9-4525-A4D5-A50D4E20D487}" dt="2026-07-29T12:10:32.324" v="1976" actId="1076"/>
+        <pc:chgData name="Dmitriy Ratushny" userId="08050032e8047aee" providerId="LiveId" clId="{78EB1A6D-D3A9-4525-A4D5-A50D4E20D487}" dt="2026-07-29T15:12:25.555" v="3331" actId="20577"/>
         <pc:sldMkLst>
           <pc:docMk/>
           <pc:sldMk cId="0" sldId="276"/>
         </pc:sldMkLst>
+        <pc:spChg chg="mod">
+          <ac:chgData name="Dmitriy Ratushny" userId="08050032e8047aee" providerId="LiveId" clId="{78EB1A6D-D3A9-4525-A4D5-A50D4E20D487}" dt="2026-07-29T15:12:25.555" v="3331" actId="20577"/>
+          <ac:spMkLst>
+            <pc:docMk/>
+            <pc:sldMk cId="0" sldId="276"/>
+            <ac:spMk id="2" creationId="{00000000-0000-0000-0000-000000000000}"/>
+          </ac:spMkLst>
+        </pc:spChg>
         <pc:spChg chg="del mod">
           <ac:chgData name="Dmitriy Ratushny" userId="08050032e8047aee" providerId="LiveId" clId="{78EB1A6D-D3A9-4525-A4D5-A50D4E20D487}" dt="2026-07-29T12:09:56.344" v="1959" actId="478"/>
           <ac:spMkLst>
@@ -800,7 +900,7 @@
         </pc:spChg>
       </pc:sldChg>
       <pc:sldChg chg="addSp delSp modSp add mod">
-        <pc:chgData name="Dmitriy Ratushny" userId="08050032e8047aee" providerId="LiveId" clId="{78EB1A6D-D3A9-4525-A4D5-A50D4E20D487}" dt="2026-07-29T13:46:55.803" v="3027"/>
+        <pc:chgData name="Dmitriy Ratushny" userId="08050032e8047aee" providerId="LiveId" clId="{78EB1A6D-D3A9-4525-A4D5-A50D4E20D487}" dt="2026-07-29T15:11:37.798" v="3320" actId="20577"/>
         <pc:sldMkLst>
           <pc:docMk/>
           <pc:sldMk cId="0" sldId="278"/>
@@ -814,7 +914,7 @@
           </ac:spMkLst>
         </pc:spChg>
         <pc:spChg chg="mod">
-          <ac:chgData name="Dmitriy Ratushny" userId="08050032e8047aee" providerId="LiveId" clId="{78EB1A6D-D3A9-4525-A4D5-A50D4E20D487}" dt="2026-07-29T13:46:55.803" v="3027"/>
+          <ac:chgData name="Dmitriy Ratushny" userId="08050032e8047aee" providerId="LiveId" clId="{78EB1A6D-D3A9-4525-A4D5-A50D4E20D487}" dt="2026-07-29T15:11:37.798" v="3320" actId="20577"/>
           <ac:spMkLst>
             <pc:docMk/>
             <pc:sldMk cId="0" sldId="278"/>
@@ -986,8 +1086,8 @@
           </ac:picMkLst>
         </pc:picChg>
       </pc:sldChg>
-      <pc:sldChg chg="delSp modSp add del mod">
-        <pc:chgData name="Dmitriy Ratushny" userId="08050032e8047aee" providerId="LiveId" clId="{78EB1A6D-D3A9-4525-A4D5-A50D4E20D487}" dt="2026-07-29T14:59:37.358" v="3258" actId="47"/>
+      <pc:sldChg chg="delSp modSp add del mod ord">
+        <pc:chgData name="Dmitriy Ratushny" userId="08050032e8047aee" providerId="LiveId" clId="{78EB1A6D-D3A9-4525-A4D5-A50D4E20D487}" dt="2026-07-29T16:26:30.223" v="3471"/>
         <pc:sldMkLst>
           <pc:docMk/>
           <pc:sldMk cId="0" sldId="283"/>
@@ -1223,6 +1323,224 @@
 </p:notes>
 </file>
 
+<file path=ppt/notesSlides/notesSlide10.xml><?xml version="1.0" encoding="utf-8"?>
+<p:notes xmlns:a="http://schemas.openxmlformats.org/drawingml/2006/main" xmlns:r="http://schemas.openxmlformats.org/officeDocument/2006/relationships" xmlns:p="http://schemas.openxmlformats.org/presentationml/2006/main">
+  <p:cSld>
+    <p:spTree>
+      <p:nvGrpSpPr>
+        <p:cNvPr id="1" name=""/>
+        <p:cNvGrpSpPr/>
+        <p:nvPr/>
+      </p:nvGrpSpPr>
+      <p:grpSpPr>
+        <a:xfrm>
+          <a:off x="0" y="0"/>
+          <a:ext cx="0" cy="0"/>
+          <a:chOff x="0" y="0"/>
+          <a:chExt cx="0" cy="0"/>
+        </a:xfrm>
+      </p:grpSpPr>
+      <p:sp>
+        <p:nvSpPr>
+          <p:cNvPr id="2" name="Slide Image Placeholder 1"/>
+          <p:cNvSpPr>
+            <a:spLocks noGrp="1" noRot="1" noChangeAspect="1"/>
+          </p:cNvSpPr>
+          <p:nvPr>
+            <p:ph type="sldImg" idx="2"/>
+          </p:nvPr>
+        </p:nvSpPr>
+        <p:spPr/>
+        <p:txBody>
+          <a:bodyPr/>
+          <a:lstStyle/>
+          <a:p>
+            <a:endParaRPr lang="en-US"/>
+          </a:p>
+        </p:txBody>
+      </p:sp>
+      <p:sp>
+        <p:nvSpPr>
+          <p:cNvPr id="3" name="Notes Placeholder 2"/>
+          <p:cNvSpPr>
+            <a:spLocks noGrp="1"/>
+          </p:cNvSpPr>
+          <p:nvPr>
+            <p:ph type="body" sz="quarter" idx="3"/>
+          </p:nvPr>
+        </p:nvSpPr>
+        <p:spPr/>
+        <p:txBody>
+          <a:bodyPr/>
+          <a:lstStyle/>
+          <a:p>
+            <a:r>
+              <a:t>This is the slide I would want to be asked about.</a:t>
+            </a:r>
+          </a:p>
+          <a:p>
+            <a:endParaRPr/>
+          </a:p>
+          <a:p>
+            <a:r>
+              <a:t>How the artefact works: no churn date can land after 2024-12-31. If each is drawn uniformly between signup and that boundary, the hazard is 1/(END - t), which rises without limit as t approaches the end. Pooled across accounts that signed up over two years, that is indistinguishable by eye from a business problem.</a:t>
+            </a:r>
+          </a:p>
+          <a:p>
+            <a:endParaRPr/>
+          </a:p>
+          <a:p>
+            <a:r>
+              <a:t>The evidence, in order. Rescale each churn date to its position in the account's own window: uniform, KS p = 0.92 on 600 events, mean position 0.503, and uniform inside every signup quarter. Then the simulation — keep each account's real signup date and real number of churn events, redraw only the dates, run the same survival.calendar_hazard used to produce the original claim, 400 times. Observed rate ratio 1.0893, null 1.0885 with a 95% band of [1.072, 1.106].</a:t>
+            </a:r>
+          </a:p>
+          <a:p>
+            <a:endParaRPr/>
+          </a:p>
+          <a:p>
+            <a:r>
+              <a:t>The p-value is the part worth dwelling on. p = 2e-16 felt like the most secure number I had. The null rule produces a median p of 2.8e-16 — very slightly more significant than the real data. A p-value tells you nothing about whether the null it tests is the one that matters.</a:t>
+            </a:r>
+          </a:p>
+          <a:p>
+            <a:endParaRPr/>
+          </a:p>
+          <a:p>
+            <a:r>
+              <a:t>If asked what I would have done differently: run this before writing the recommendation, not after. On any generated or vendor-supplied extract, simulate the file before trusting a time trend in it.</a:t>
+            </a:r>
+          </a:p>
+          <a:p>
+            <a:endParaRPr/>
+          </a:p>
+          <a:p>
+            <a:r>
+              <a:t>src/generator.py, notebook 16.</a:t>
+            </a:r>
+          </a:p>
+        </p:txBody>
+      </p:sp>
+      <p:sp>
+        <p:nvSpPr>
+          <p:cNvPr id="4" name="Slide Number Placeholder 3"/>
+          <p:cNvSpPr>
+            <a:spLocks noGrp="1"/>
+          </p:cNvSpPr>
+          <p:nvPr>
+            <p:ph type="sldNum" sz="quarter" idx="5"/>
+          </p:nvPr>
+        </p:nvSpPr>
+        <p:spPr/>
+        <p:txBody>
+          <a:bodyPr/>
+          <a:lstStyle/>
+          <a:p>
+            <a:endParaRPr lang="en-US"/>
+          </a:p>
+        </p:txBody>
+      </p:sp>
+    </p:spTree>
+  </p:cSld>
+  <p:clrMapOvr>
+    <a:masterClrMapping/>
+  </p:clrMapOvr>
+</p:notes>
+</file>
+
+<file path=ppt/notesSlides/notesSlide11.xml><?xml version="1.0" encoding="utf-8"?>
+<p:notes xmlns:a="http://schemas.openxmlformats.org/drawingml/2006/main" xmlns:r="http://schemas.openxmlformats.org/officeDocument/2006/relationships" xmlns:p="http://schemas.openxmlformats.org/presentationml/2006/main">
+  <p:cSld>
+    <p:spTree>
+      <p:nvGrpSpPr>
+        <p:cNvPr id="1" name=""/>
+        <p:cNvGrpSpPr/>
+        <p:nvPr/>
+      </p:nvGrpSpPr>
+      <p:grpSpPr>
+        <a:xfrm>
+          <a:off x="0" y="0"/>
+          <a:ext cx="0" cy="0"/>
+          <a:chOff x="0" y="0"/>
+          <a:chExt cx="0" cy="0"/>
+        </a:xfrm>
+      </p:grpSpPr>
+      <p:sp>
+        <p:nvSpPr>
+          <p:cNvPr id="2" name="Slide Image Placeholder 1"/>
+          <p:cNvSpPr>
+            <a:spLocks noGrp="1" noRot="1" noChangeAspect="1"/>
+          </p:cNvSpPr>
+          <p:nvPr>
+            <p:ph type="sldImg" idx="2"/>
+          </p:nvPr>
+        </p:nvSpPr>
+        <p:spPr/>
+      </p:sp>
+      <p:sp>
+        <p:nvSpPr>
+          <p:cNvPr id="3" name="Notes Placeholder 2"/>
+          <p:cNvSpPr>
+            <a:spLocks noGrp="1"/>
+          </p:cNvSpPr>
+          <p:nvPr>
+            <p:ph type="body" sz="quarter" idx="3"/>
+          </p:nvPr>
+        </p:nvSpPr>
+        <p:spPr/>
+        <p:txBody>
+          <a:bodyPr/>
+          <a:lstStyle/>
+          <a:p>
+            <a:r>
+              <a:t>Replaces the break-even heatmap, which swept call cost against customer value across sixteen cells. The sweep asked the reader to find their cell, compare it against a base rate printed in the title, and infer the conclusion themselves.</a:t>
+            </a:r>
+          </a:p>
+          <a:p>
+            <a:endParaRPr/>
+          </a:p>
+          <a:p>
+            <a:r>
+              <a:t>Only two cells of that grid ever mattered, and they are now stated as the two points where the decision flips: $446 a call, or $2,459 a customer.</a:t>
+            </a:r>
+          </a:p>
+          <a:p>
+            <a:endParaRPr/>
+          </a:p>
+          <a:p>
+            <a:r>
+              <a:t>Both inputs are assumptions, not measurements. DEFAULT_INTERVENTION_COST = 150 and DEFAULT_EFFECTIVENESS = 0.20 in src/economics.py; nothing in the data supports either. Say so before being asked. The conclusion survives a wide range of both, which is what the two flip points are there to show.</a:t>
+            </a:r>
+          </a:p>
+          <a:p>
+            <a:endParaRPr/>
+          </a:p>
+          <a:p>
+            <a:r>
+              <a:t>Numbers from outputs/reports/retention_economics.csv. The figure is built by build/fig_breakeven_html.py.</a:t>
+            </a:r>
+          </a:p>
+        </p:txBody>
+      </p:sp>
+      <p:sp>
+        <p:nvSpPr>
+          <p:cNvPr id="4" name="Slide Number Placeholder 3"/>
+          <p:cNvSpPr>
+            <a:spLocks noGrp="1"/>
+          </p:cNvSpPr>
+          <p:nvPr>
+            <p:ph type="sldNum" sz="quarter" idx="5"/>
+          </p:nvPr>
+        </p:nvSpPr>
+        <p:spPr/>
+      </p:sp>
+    </p:spTree>
+  </p:cSld>
+  <p:clrMapOvr>
+    <a:masterClrMapping/>
+  </p:clrMapOvr>
+</p:notes>
+</file>
+
 <file path=ppt/notesSlides/notesSlide2.xml><?xml version="1.0" encoding="utf-8"?>
 <p:notes xmlns:a="http://schemas.openxmlformats.org/drawingml/2006/main" xmlns:r="http://schemas.openxmlformats.org/officeDocument/2006/relationships" xmlns:p="http://schemas.openxmlformats.org/presentationml/2006/main">
   <p:cSld>
@@ -1971,13 +2289,6 @@
           </p:nvPr>
         </p:nvSpPr>
         <p:spPr/>
-        <p:txBody>
-          <a:bodyPr/>
-          <a:lstStyle/>
-          <a:p>
-            <a:endParaRPr lang="en-US"/>
-          </a:p>
-        </p:txBody>
       </p:sp>
       <p:sp>
         <p:nvSpPr>
@@ -1995,7 +2306,7 @@
           <a:lstStyle/>
           <a:p>
             <a:r>
-              <a:t>This is the slide I would want to be asked about.</a:t>
+              <a:t>The slide to present if there is only time for one. Everything else in Part 4 is the working behind a column of this.</a:t>
             </a:r>
           </a:p>
           <a:p>
@@ -2003,7 +2314,7 @@
           </a:p>
           <a:p>
             <a:r>
-              <a:t>How the artefact works: no churn date can land after 2024-12-31. If each is drawn uniformly between signup and that boundary, the hazard is 1/(END - t), which rises without limit as t approaches the end. Pooled across accounts that signed up over two years, that is indistinguishable by eye from a business problem.</a:t>
+              <a:t>The three columns are deliberately in that order. A hiring panel wants to hear an action before it hears a caveat, and the data request lands better once they have seen why the obvious moves are wrong.</a:t>
             </a:r>
           </a:p>
           <a:p>
@@ -2011,7 +2322,7 @@
           </a:p>
           <a:p>
             <a:r>
-              <a:t>The evidence, in order. Rescale each churn date to its position in the account's own window: uniform, KS p = 0.92 on 600 events, mean position 0.503, and uniform inside every signup quarter. Then the simulation — keep each account's real signup date and real number of churn events, redraw only the dates, run the same survival.calendar_hazard used to produce the original claim, 400 times. Observed rate ratio 1.0893, null 1.0885 with a 95% band of [1.072, 1.106].</a:t>
+              <a:t>No currency appears. The repo carries an illustrative call cost and success rate, neither of which is in the data, so the break-even is stated as a ratio instead.</a:t>
             </a:r>
           </a:p>
           <a:p>
@@ -2019,23 +2330,7 @@
           </a:p>
           <a:p>
             <a:r>
-              <a:t>The p-value is the part worth dwelling on. p = 2e-16 felt like the most secure number I had. The null rule produces a median p of 2.8e-16 — very slightly more significant than the real data. A p-value tells you nothing about whether the null it tests is the one that matters.</a:t>
-            </a:r>
-          </a:p>
-          <a:p>
-            <a:endParaRPr/>
-          </a:p>
-          <a:p>
-            <a:r>
-              <a:t>If asked what I would have done differently: run this before writing the recommendation, not after. On any generated or vendor-supplied extract, simulate the file before trusting a time trend in it.</a:t>
-            </a:r>
-          </a:p>
-          <a:p>
-            <a:endParaRPr/>
-          </a:p>
-          <a:p>
-            <a:r>
-              <a:t>src/generator.py, notebook 16.</a:t>
+              <a:t>Built by build/fig_what_to_do_html.py.</a:t>
             </a:r>
           </a:p>
         </p:txBody>
@@ -2051,13 +2346,6 @@
           </p:nvPr>
         </p:nvSpPr>
         <p:spPr/>
-        <p:txBody>
-          <a:bodyPr/>
-          <a:lstStyle/>
-          <a:p>
-            <a:endParaRPr lang="en-US"/>
-          </a:p>
-        </p:txBody>
       </p:sp>
     </p:spTree>
   </p:cSld>
@@ -6869,7 +7157,7 @@
         <p:spPr>
           <a:xfrm>
             <a:off x="685800" y="365760"/>
-            <a:ext cx="10820095" cy="759182"/>
+            <a:ext cx="10820095" cy="1051560"/>
           </a:xfrm>
           <a:prstGeom prst="rect">
             <a:avLst/>
@@ -6883,13 +7171,13 @@
           <a:lstStyle/>
           <a:p>
             <a:r>
-              <a:rPr sz="1200" b="1" i="0" dirty="0">
+              <a:rPr sz="1200" b="1" i="0">
                 <a:solidFill>
                   <a:srgbClr val="5A6270"/>
                 </a:solidFill>
                 <a:latin typeface="Calibri"/>
               </a:rPr>
-              <a:t>PART 4 · RECOMMENDATION 1</a:t>
+              <a:t>PART 4 · RECOMMENDATIONS</a:t>
             </a:r>
           </a:p>
           <a:p>
@@ -6899,16 +7187,13 @@
               </a:spcBef>
             </a:pPr>
             <a:r>
-              <a:rPr lang="en-US" sz="2800" b="1" i="0" dirty="0">
-                <a:latin typeface="Calibri"/>
-              </a:rPr>
-              <a:t>Insight 1: </a:t>
-            </a:r>
-            <a:r>
-              <a:rPr sz="2800" b="1" i="0" dirty="0">
-                <a:latin typeface="Calibri"/>
-              </a:rPr>
-              <a:t>Do not go looking for what changed in 2024</a:t>
+              <a:rPr sz="2800" b="1" i="0">
+                <a:solidFill>
+                  <a:srgbClr val="1A1A1A"/>
+                </a:solidFill>
+                <a:latin typeface="Calibri"/>
+              </a:rPr>
+              <a:t>What to do about churn</a:t>
             </a:r>
           </a:p>
         </p:txBody>
@@ -6960,7 +7245,7 @@
       </p:sp>
       <p:pic>
         <p:nvPicPr>
-          <p:cNvPr id="4" name="Picture 3" descr="16_generator_artefact.png"/>
+          <p:cNvPr id="4" name="Picture 3" descr="15_what_to_do.png"/>
           <p:cNvPicPr>
             <a:picLocks noChangeAspect="1"/>
           </p:cNvPicPr>
@@ -6974,8 +7259,8 @@
         </p:blipFill>
         <p:spPr>
           <a:xfrm>
-            <a:off x="1906186" y="1554480"/>
-            <a:ext cx="8379323" cy="2788920"/>
+            <a:off x="848694" y="1627632"/>
+            <a:ext cx="10494306" cy="3246120"/>
           </a:xfrm>
           <a:prstGeom prst="rect">
             <a:avLst/>
@@ -6990,7 +7275,7 @@
         </p:nvSpPr>
         <p:spPr>
           <a:xfrm>
-            <a:off x="685800" y="4572000"/>
+            <a:off x="685800" y="5138928"/>
             <a:ext cx="10820095" cy="4572000"/>
           </a:xfrm>
           <a:prstGeom prst="rect">
@@ -7010,45 +7295,63 @@
               </a:spcAft>
             </a:pPr>
             <a:r>
-              <a:rPr sz="1250" b="1" i="0" dirty="0">
+              <a:rPr sz="1350" b="1" i="0">
                 <a:solidFill>
                   <a:srgbClr val="1A1A1A"/>
                 </a:solidFill>
                 <a:latin typeface="Calibri"/>
               </a:rPr>
-              <a:t>Churn looks like it is accelerating. About 5 in every 100 customers left each month in 2023, rising to 22 in 100 by December 2024 — a 2.8x rise per year, p = 2e-16. It was by far the strongest number in this study.</a:t>
-            </a:r>
-          </a:p>
-          <a:p>
-            <a:pPr>
+              <a:t>Three things follow from this work, and none of them needs a model.</a:t>
+            </a:r>
+          </a:p>
+          <a:p>
+            <a:pPr lvl="1">
               <a:spcAft>
                 <a:spcPts val="400"/>
               </a:spcAft>
             </a:pPr>
             <a:r>
-              <a:rPr sz="1250" b="1" i="0" dirty="0">
-                <a:solidFill>
-                  <a:srgbClr val="B02E2E"/>
-                </a:solidFill>
-                <a:latin typeface="Calibri"/>
-              </a:rPr>
-              <a:t>It is not a fact about customers. Every churn date in this file is a random date between the day the customer joined and the last day of the extract. A random date has nowhere to go but the end of the file, so the rate climbs on its own, with nothing happening in the business.</a:t>
-            </a:r>
-          </a:p>
-          <a:p>
-            <a:pPr>
-              <a:spcAft>
-                <a:spcPts val="400"/>
-              </a:spcAft>
-            </a:pPr>
-            <a:r>
-              <a:rPr sz="1250" b="1" i="0" dirty="0">
-                <a:solidFill>
-                  <a:srgbClr val="1A1A1A"/>
-                </a:solidFill>
-                <a:latin typeface="Calibri"/>
-              </a:rPr>
-              <a:t>Rebuilding the data from that one rule gives the same answer: a 2.78x rise per year, all 24 months inside the range chance produces, and our result sitting at the 52nd percentile of pure noise. So there is nothing here to investigate, and that is the recommendation.</a:t>
+              <a:rPr sz="1150" b="0" i="0">
+                <a:solidFill>
+                  <a:srgbClr val="5A6270"/>
+                </a:solidFill>
+                <a:latin typeface="Calibri"/>
+              </a:rPr>
+              <a:t>Call everybody at risk, because at a 31% churn rate the decision is already right for every customer. Do not spend on the two things the data appears to recommend, because both come from the same artefact. Fix three things in the export and the question becomes answerable.</a:t>
+            </a:r>
+          </a:p>
+        </p:txBody>
+      </p:sp>
+      <p:sp>
+        <p:nvSpPr>
+          <p:cNvPr id="6" name="TextBox 5"/>
+          <p:cNvSpPr txBox="1"/>
+          <p:nvPr/>
+        </p:nvSpPr>
+        <p:spPr>
+          <a:xfrm>
+            <a:off x="685800" y="6126480"/>
+            <a:ext cx="10820095" cy="502920"/>
+          </a:xfrm>
+          <a:prstGeom prst="rect">
+            <a:avLst/>
+          </a:prstGeom>
+          <a:noFill/>
+        </p:spPr>
+        <p:txBody>
+          <a:bodyPr wrap="square">
+            <a:spAutoFit/>
+          </a:bodyPr>
+          <a:lstStyle/>
+          <a:p>
+            <a:r>
+              <a:rPr sz="1150" b="0" i="1">
+                <a:solidFill>
+                  <a:srgbClr val="5A6270"/>
+                </a:solidFill>
+                <a:latin typeface="Calibri"/>
+              </a:rPr>
+              <a:t>Every number here is a count from the tables. Nothing is modelled and nothing is assumed.</a:t>
             </a:r>
           </a:p>
         </p:txBody>
@@ -7107,7 +7410,7 @@
                 </a:solidFill>
                 <a:latin typeface="Calibri"/>
               </a:rPr>
-              <a:t>PART 4 · RECOMMENDATION 2</a:t>
+              <a:t>PART 4 · RECOMMENDATION 1</a:t>
             </a:r>
           </a:p>
           <a:p>
@@ -7120,19 +7423,11 @@
               <a:rPr lang="en-US" sz="2800" b="1" i="0" dirty="0">
                 <a:latin typeface="Calibri"/>
               </a:rPr>
-              <a:t>Insight 2: </a:t>
-            </a:r>
-            <a:r>
-              <a:rPr sz="2800" b="1" i="0" dirty="0">
-                <a:latin typeface="Calibri"/>
-              </a:rPr>
-              <a:t>Do not build the onboarding </a:t>
-            </a:r>
-            <a:r>
-              <a:rPr sz="2800" b="1" i="0" dirty="0" err="1">
-                <a:latin typeface="Calibri"/>
-              </a:rPr>
-              <a:t>programme</a:t>
+              <a:t>Insight 1: </a:t>
+            </a:r>
+            <a:r>
+              <a:rPr lang="en-US" sz="2800" b="1" dirty="0"/>
+              <a:t> The 2024 churn rise does not appear to be real</a:t>
             </a:r>
             <a:endParaRPr sz="2800" b="1" i="0" dirty="0">
               <a:latin typeface="Calibri"/>
@@ -7185,135 +7480,194 @@
           </a:p>
         </p:txBody>
       </p:sp>
+      <p:sp>
+        <p:nvSpPr>
+          <p:cNvPr id="7" name="TextBox 6">
+            <a:extLst>
+              <a:ext uri="{FF2B5EF4-FFF2-40B4-BE49-F238E27FC236}">
+                <a16:creationId xmlns:a16="http://schemas.microsoft.com/office/drawing/2014/main" id="{A7236729-E287-7283-0A77-C4717D568D37}"/>
+              </a:ext>
+            </a:extLst>
+          </p:cNvPr>
+          <p:cNvSpPr txBox="1"/>
+          <p:nvPr/>
+        </p:nvSpPr>
+        <p:spPr>
+          <a:xfrm>
+            <a:off x="469232" y="2144521"/>
+            <a:ext cx="3124504" cy="3947234"/>
+          </a:xfrm>
+          <a:prstGeom prst="rect">
+            <a:avLst/>
+          </a:prstGeom>
+          <a:noFill/>
+        </p:spPr>
+        <p:txBody>
+          <a:bodyPr wrap="square">
+            <a:spAutoFit/>
+          </a:bodyPr>
+          <a:lstStyle/>
+          <a:p>
+            <a:pPr>
+              <a:spcAft>
+                <a:spcPts val="300"/>
+              </a:spcAft>
+            </a:pPr>
+            <a:r>
+              <a:rPr sz="1250" b="1" i="0" dirty="0">
+                <a:solidFill>
+                  <a:srgbClr val="1A1A1A"/>
+                </a:solidFill>
+                <a:latin typeface="Calibri"/>
+              </a:rPr>
+              <a:t>Churn looks like it is accelerating. About 5 customers in every 100 left each month in 2023, rising to 22 in 100 by December 2024. A 2.8x rise per year, p = 2e-16, and by far the strongest number in this study.</a:t>
+            </a:r>
+            <a:endParaRPr lang="en-US" sz="1250" b="1" i="0" dirty="0">
+              <a:solidFill>
+                <a:srgbClr val="1A1A1A"/>
+              </a:solidFill>
+              <a:latin typeface="Calibri"/>
+            </a:endParaRPr>
+          </a:p>
+          <a:p>
+            <a:pPr>
+              <a:spcAft>
+                <a:spcPts val="300"/>
+              </a:spcAft>
+            </a:pPr>
+            <a:endParaRPr lang="en-US" sz="1250" b="1" dirty="0">
+              <a:solidFill>
+                <a:srgbClr val="1A1A1A"/>
+              </a:solidFill>
+              <a:latin typeface="Calibri"/>
+            </a:endParaRPr>
+          </a:p>
+          <a:p>
+            <a:pPr>
+              <a:spcAft>
+                <a:spcPts val="300"/>
+              </a:spcAft>
+            </a:pPr>
+            <a:endParaRPr sz="1250" b="1" i="0" dirty="0">
+              <a:solidFill>
+                <a:srgbClr val="1A1A1A"/>
+              </a:solidFill>
+              <a:latin typeface="Calibri"/>
+            </a:endParaRPr>
+          </a:p>
+          <a:p>
+            <a:pPr>
+              <a:spcAft>
+                <a:spcPts val="300"/>
+              </a:spcAft>
+            </a:pPr>
+            <a:r>
+              <a:rPr sz="600" b="0" i="0" dirty="0">
+                <a:solidFill>
+                  <a:srgbClr val="1A1A1A"/>
+                </a:solidFill>
+                <a:latin typeface="Calibri"/>
+              </a:rPr>
+              <a:t> </a:t>
+            </a:r>
+          </a:p>
+          <a:p>
+            <a:pPr>
+              <a:spcAft>
+                <a:spcPts val="300"/>
+              </a:spcAft>
+            </a:pPr>
+            <a:r>
+              <a:rPr lang="en-US" sz="1250" b="1" dirty="0">
+                <a:solidFill>
+                  <a:srgbClr val="B02E2E"/>
+                </a:solidFill>
+              </a:rPr>
+              <a:t>Then the test. Take the file, throw away every churn date, and replace each with a random date between that customer's signup and the last day of the file. Change nothing else. Rebuild it 200 times. The pink band is the middle 95% of what those rebuilds produce.</a:t>
+            </a:r>
+            <a:endParaRPr lang="en-US" sz="1250" b="1" i="0" dirty="0">
+              <a:solidFill>
+                <a:srgbClr val="B02E2E"/>
+              </a:solidFill>
+              <a:latin typeface="Calibri"/>
+            </a:endParaRPr>
+          </a:p>
+          <a:p>
+            <a:pPr>
+              <a:spcAft>
+                <a:spcPts val="300"/>
+              </a:spcAft>
+            </a:pPr>
+            <a:endParaRPr sz="1250" b="1" i="0" dirty="0">
+              <a:solidFill>
+                <a:srgbClr val="B02E2E"/>
+              </a:solidFill>
+              <a:latin typeface="Calibri"/>
+            </a:endParaRPr>
+          </a:p>
+          <a:p>
+            <a:pPr lvl="1">
+              <a:spcAft>
+                <a:spcPts val="300"/>
+              </a:spcAft>
+            </a:pPr>
+            <a:r>
+              <a:rPr sz="1050" b="0" i="0" dirty="0">
+                <a:solidFill>
+                  <a:srgbClr val="5A6270"/>
+                </a:solidFill>
+                <a:latin typeface="Calibri"/>
+              </a:rPr>
+              <a:t>x2.76 a year against our x2.79. Every one of the 24 months sits inside the range those rebuilds produce, and our result lands at the 58th percentile of pure noise</a:t>
+            </a:r>
+            <a:r>
+              <a:rPr lang="en-US" sz="1050" b="0" i="0" dirty="0">
+                <a:solidFill>
+                  <a:srgbClr val="5A6270"/>
+                </a:solidFill>
+                <a:latin typeface="Calibri"/>
+              </a:rPr>
+              <a:t>.</a:t>
+            </a:r>
+            <a:endParaRPr sz="1050" b="0" i="0" dirty="0">
+              <a:solidFill>
+                <a:srgbClr val="5A6270"/>
+              </a:solidFill>
+              <a:latin typeface="Calibri"/>
+            </a:endParaRPr>
+          </a:p>
+        </p:txBody>
+      </p:sp>
       <p:pic>
         <p:nvPicPr>
-          <p:cNvPr id="4" name="Picture 3" descr="12_cohort_gradient.png"/>
+          <p:cNvPr id="11" name="Picture 10" descr="12_calendar_null.png">
+            <a:extLst>
+              <a:ext uri="{FF2B5EF4-FFF2-40B4-BE49-F238E27FC236}">
+                <a16:creationId xmlns:a16="http://schemas.microsoft.com/office/drawing/2014/main" id="{C69554E6-A1EF-E6EB-DCA9-B1FAEA444E36}"/>
+              </a:ext>
+            </a:extLst>
+          </p:cNvPr>
           <p:cNvPicPr>
             <a:picLocks noChangeAspect="1"/>
           </p:cNvPicPr>
           <p:nvPr/>
         </p:nvPicPr>
         <p:blipFill>
-          <a:blip r:embed="rId2"/>
+          <a:blip r:embed="rId3"/>
           <a:stretch>
             <a:fillRect/>
           </a:stretch>
         </p:blipFill>
         <p:spPr>
           <a:xfrm>
-            <a:off x="3590694" y="1627632"/>
-            <a:ext cx="5010307" cy="2743200"/>
+            <a:off x="3749929" y="1559533"/>
+            <a:ext cx="7913206" cy="4535963"/>
           </a:xfrm>
           <a:prstGeom prst="rect">
             <a:avLst/>
           </a:prstGeom>
         </p:spPr>
       </p:pic>
-      <p:sp>
-        <p:nvSpPr>
-          <p:cNvPr id="5" name="TextBox 4"/>
-          <p:cNvSpPr txBox="1"/>
-          <p:nvPr/>
-        </p:nvSpPr>
-        <p:spPr>
-          <a:xfrm>
-            <a:off x="685800" y="4526280"/>
-            <a:ext cx="10820095" cy="4572000"/>
-          </a:xfrm>
-          <a:prstGeom prst="rect">
-            <a:avLst/>
-          </a:prstGeom>
-          <a:noFill/>
-        </p:spPr>
-        <p:txBody>
-          <a:bodyPr wrap="square">
-            <a:spAutoFit/>
-          </a:bodyPr>
-          <a:lstStyle/>
-          <a:p>
-            <a:pPr>
-              <a:spcAft>
-                <a:spcPts val="400"/>
-              </a:spcAft>
-            </a:pPr>
-            <a:r>
-              <a:rPr sz="1250" b="1" i="0">
-                <a:solidFill>
-                  <a:srgbClr val="1A1A1A"/>
-                </a:solidFill>
-                <a:latin typeface="Calibri"/>
-              </a:rPr>
-              <a:t>New customers look fragile, and risk looks like it falls with age. That is the usual reason to fund onboarding, and the evidence for it looks strong: 30-day survival drops from 0.98 for the 2023 intake to 0.59 for the 2024 one, measured at the same age.</a:t>
-            </a:r>
-          </a:p>
-          <a:p>
-            <a:pPr>
-              <a:spcAft>
-                <a:spcPts val="400"/>
-              </a:spcAft>
-            </a:pPr>
-            <a:r>
-              <a:rPr sz="1250" b="1" i="0">
-                <a:solidFill>
-                  <a:srgbClr val="B02E2E"/>
-                </a:solidFill>
-                <a:latin typeface="Calibri"/>
-              </a:rPr>
-              <a:t>It is the same random date. A customer who joined recently has a shorter window for that date to land in, so a larger share of their draws fall inside any 90-day question we ask. They look worse at every age without anything about them being worse.</a:t>
-            </a:r>
-          </a:p>
-          <a:p>
-            <a:pPr>
-              <a:spcAft>
-                <a:spcPts val="400"/>
-              </a:spcAft>
-            </a:pPr>
-            <a:r>
-              <a:rPr sz="1250" b="1" i="0">
-                <a:solidFill>
-                  <a:srgbClr val="1A1A1A"/>
-                </a:solidFill>
-                <a:latin typeface="Calibri"/>
-              </a:rPr>
-              <a:t>Simulated data with no tenure effect in it at all clears the significance bar in 93% of runs, and does so more strongly than the real data does (p = 0.002 against 0.006). Within one joining month there is nothing left: a day-300 customer leaves as often as a day-10 one.</a:t>
-            </a:r>
-          </a:p>
-        </p:txBody>
-      </p:sp>
-      <p:sp>
-        <p:nvSpPr>
-          <p:cNvPr id="6" name="TextBox 5"/>
-          <p:cNvSpPr txBox="1"/>
-          <p:nvPr/>
-        </p:nvSpPr>
-        <p:spPr>
-          <a:xfrm>
-            <a:off x="685800" y="6126480"/>
-            <a:ext cx="10820095" cy="502920"/>
-          </a:xfrm>
-          <a:prstGeom prst="rect">
-            <a:avLst/>
-          </a:prstGeom>
-          <a:noFill/>
-        </p:spPr>
-        <p:txBody>
-          <a:bodyPr wrap="square">
-            <a:spAutoFit/>
-          </a:bodyPr>
-          <a:lstStyle/>
-          <a:p>
-            <a:r>
-              <a:rPr sz="1150" b="0" i="1">
-                <a:solidFill>
-                  <a:srgbClr val="5A6270"/>
-                </a:solidFill>
-                <a:latin typeface="Calibri"/>
-              </a:rPr>
-              <a:t>The recommendation does not change; the reason for it gets one layer deeper. This is the same finding as slide 11, applied to a spending decision instead of an investigation.</a:t>
-            </a:r>
-          </a:p>
-        </p:txBody>
-      </p:sp>
     </p:spTree>
   </p:cSld>
   <p:clrMapOvr>
@@ -7348,7 +7702,7 @@
         <p:spPr>
           <a:xfrm>
             <a:off x="685800" y="365760"/>
-            <a:ext cx="10820095" cy="759182"/>
+            <a:ext cx="10820095" cy="1051560"/>
           </a:xfrm>
           <a:prstGeom prst="rect">
             <a:avLst/>
@@ -7362,7 +7716,7 @@
           <a:lstStyle/>
           <a:p>
             <a:r>
-              <a:rPr sz="1200" b="1" i="0" dirty="0">
+              <a:rPr sz="1200" b="1" i="0">
                 <a:solidFill>
                   <a:srgbClr val="5A6270"/>
                 </a:solidFill>
@@ -7378,13 +7732,10 @@
               </a:spcBef>
             </a:pPr>
             <a:r>
-              <a:rPr lang="en-US" sz="2800" b="1" i="0" dirty="0">
-                <a:latin typeface="Calibri"/>
-              </a:rPr>
-              <a:t>Insight 3: </a:t>
-            </a:r>
-            <a:r>
-              <a:rPr sz="2800" b="1" i="0" dirty="0">
+              <a:rPr sz="2800" b="1" i="0">
+                <a:solidFill>
+                  <a:srgbClr val="1A1A1A"/>
+                </a:solidFill>
                 <a:latin typeface="Calibri"/>
               </a:rPr>
               <a:t>Call every at-risk customer, do not rank them</a:t>
@@ -7439,22 +7790,22 @@
       </p:sp>
       <p:pic>
         <p:nvPicPr>
-          <p:cNvPr id="4" name="Picture 3" descr="15_breakeven_grid.png"/>
+          <p:cNvPr id="4" name="Picture 3" descr="15_breakeven_simple.png"/>
           <p:cNvPicPr>
             <a:picLocks noChangeAspect="1"/>
           </p:cNvPicPr>
           <p:nvPr/>
         </p:nvPicPr>
         <p:blipFill>
-          <a:blip r:embed="rId2"/>
+          <a:blip r:embed="rId3"/>
           <a:stretch>
             <a:fillRect/>
           </a:stretch>
         </p:blipFill>
         <p:spPr>
           <a:xfrm>
-            <a:off x="3492925" y="1645920"/>
-            <a:ext cx="5205845" cy="3017520"/>
+            <a:off x="2534703" y="1554480"/>
+            <a:ext cx="7122289" cy="3246120"/>
           </a:xfrm>
           <a:prstGeom prst="rect">
             <a:avLst/>
@@ -7469,8 +7820,8 @@
         </p:nvSpPr>
         <p:spPr>
           <a:xfrm>
-            <a:off x="685800" y="4846320"/>
-            <a:ext cx="10820095" cy="1007968"/>
+            <a:off x="685800" y="4956048"/>
+            <a:ext cx="10820095" cy="4572000"/>
           </a:xfrm>
           <a:prstGeom prst="rect">
             <a:avLst/>
@@ -7485,56 +7836,91 @@
           <a:p>
             <a:pPr>
               <a:spcAft>
-                <a:spcPts val="900"/>
-              </a:spcAft>
-            </a:pPr>
-            <a:r>
-              <a:rPr lang="en-US" sz="1300" b="1" i="0" dirty="0">
+                <a:spcPts val="400"/>
+              </a:spcAft>
+            </a:pPr>
+            <a:r>
+              <a:rPr sz="1350" b="1" i="0">
                 <a:solidFill>
                   <a:srgbClr val="1A1A1A"/>
                 </a:solidFill>
                 <a:latin typeface="Calibri"/>
               </a:rPr>
-              <a:t>If we assume a</a:t>
-            </a:r>
-            <a:r>
-              <a:rPr sz="1300" b="1" i="0" dirty="0">
+              <a:t>A call costs about $150. A customer is worth about $7,300. If one call in five saves the customer, the call pays for itself on anyone with more than a 10.3% chance of leaving.</a:t>
+            </a:r>
+          </a:p>
+          <a:p>
+            <a:pPr>
+              <a:spcAft>
+                <a:spcPts val="400"/>
+              </a:spcAft>
+            </a:pPr>
+            <a:r>
+              <a:rPr sz="600" b="0" i="0">
                 <a:solidFill>
                   <a:srgbClr val="1A1A1A"/>
                 </a:solidFill>
                 <a:latin typeface="Calibri"/>
               </a:rPr>
-              <a:t> call costs about $</a:t>
-            </a:r>
-            <a:r>
-              <a:rPr sz="1300" b="1" i="0">
+              <a:t> </a:t>
+            </a:r>
+          </a:p>
+          <a:p>
+            <a:pPr>
+              <a:spcAft>
+                <a:spcPts val="400"/>
+              </a:spcAft>
+            </a:pPr>
+            <a:r>
+              <a:rPr sz="1350" b="0" i="0">
                 <a:solidFill>
                   <a:srgbClr val="1A1A1A"/>
                 </a:solidFill>
                 <a:latin typeface="Calibri"/>
               </a:rPr>
-              <a:t>150</a:t>
-            </a:r>
-            <a:r>
-              <a:rPr lang="en-US" sz="1300" b="1" i="0">
+              <a:t>Everyone in this cohort is at 30.5%, three times over that bar. So the right action for every customer is the same one, and no ordering can improve on a decision that is already correct for all of them.</a:t>
+            </a:r>
+          </a:p>
+          <a:p>
+            <a:pPr>
+              <a:spcAft>
+                <a:spcPts val="400"/>
+              </a:spcAft>
+            </a:pPr>
+            <a:r>
+              <a:rPr sz="600" b="0" i="0">
                 <a:solidFill>
                   <a:srgbClr val="1A1A1A"/>
                 </a:solidFill>
                 <a:latin typeface="Calibri"/>
               </a:rPr>
-              <a:t> and</a:t>
-            </a:r>
-            <a:r>
-              <a:rPr lang="en-US" sz="1300" b="1">
+              <a:t> </a:t>
+            </a:r>
+          </a:p>
+          <a:p>
+            <a:pPr>
+              <a:spcAft>
+                <a:spcPts val="400"/>
+              </a:spcAft>
+            </a:pPr>
+            <a:r>
+              <a:rPr sz="1350" b="0" i="0">
                 <a:solidFill>
                   <a:srgbClr val="1A1A1A"/>
                 </a:solidFill>
                 <a:latin typeface="Calibri"/>
               </a:rPr>
-              <a:t> a</a:t>
-            </a:r>
-            <a:r>
-              <a:rPr sz="1300" b="1" i="0">
+              <a:t>Ranking would only start to matter if a call cost $446 rather than $150, or a customer were worth $2,459 rather than $7,310. Both are a factor of three away.</a:t>
+            </a:r>
+          </a:p>
+          <a:p>
+            <a:pPr>
+              <a:spcAft>
+                <a:spcPts val="400"/>
+              </a:spcAft>
+            </a:pPr>
+            <a:r>
+              <a:rPr sz="600" b="0" i="0">
                 <a:solidFill>
                   <a:srgbClr val="1A1A1A"/>
                 </a:solidFill>
@@ -7542,118 +7928,21 @@
               </a:rPr>
               <a:t> </a:t>
             </a:r>
-            <a:r>
-              <a:rPr sz="1300" b="1" i="0" dirty="0">
-                <a:solidFill>
-                  <a:srgbClr val="1A1A1A"/>
-                </a:solidFill>
-                <a:latin typeface="Calibri"/>
-              </a:rPr>
-              <a:t>customer is worth about </a:t>
-            </a:r>
-            <a:r>
-              <a:rPr sz="1300" b="1" i="0">
-                <a:solidFill>
-                  <a:srgbClr val="1A1A1A"/>
-                </a:solidFill>
-                <a:latin typeface="Calibri"/>
-              </a:rPr>
-              <a:t>$7,300</a:t>
-            </a:r>
-            <a:r>
-              <a:rPr lang="en-US" sz="1300" b="1" i="0">
-                <a:solidFill>
-                  <a:srgbClr val="1A1A1A"/>
-                </a:solidFill>
-                <a:latin typeface="Calibri"/>
-              </a:rPr>
-              <a:t> then</a:t>
-            </a:r>
-            <a:r>
-              <a:rPr sz="1300" b="1" i="0">
-                <a:solidFill>
-                  <a:srgbClr val="1A1A1A"/>
-                </a:solidFill>
-                <a:latin typeface="Calibri"/>
-              </a:rPr>
-              <a:t> </a:t>
-            </a:r>
-            <a:r>
-              <a:rPr lang="en-US" sz="1300" b="1" i="0">
-                <a:solidFill>
-                  <a:srgbClr val="1A1A1A"/>
-                </a:solidFill>
-                <a:latin typeface="Calibri"/>
-              </a:rPr>
-              <a:t>i</a:t>
-            </a:r>
-            <a:r>
-              <a:rPr sz="1300" b="1" i="0">
-                <a:solidFill>
-                  <a:srgbClr val="1A1A1A"/>
-                </a:solidFill>
-                <a:latin typeface="Calibri"/>
-              </a:rPr>
-              <a:t>f </a:t>
-            </a:r>
-            <a:r>
-              <a:rPr sz="1300" b="1" i="0" dirty="0">
-                <a:solidFill>
-                  <a:srgbClr val="1A1A1A"/>
-                </a:solidFill>
-                <a:latin typeface="Calibri"/>
-              </a:rPr>
-              <a:t>the call works one time in five, it pays for itself on any customer with more than a 10% chance of leaving. In this group, 31% leave.</a:t>
-            </a:r>
           </a:p>
           <a:p>
             <a:pPr>
               <a:spcAft>
-                <a:spcPts val="900"/>
-              </a:spcAft>
-            </a:pPr>
-            <a:r>
-              <a:rPr sz="1300" b="1" i="0" dirty="0">
+                <a:spcPts val="400"/>
+              </a:spcAft>
+            </a:pPr>
+            <a:r>
+              <a:rPr sz="1350" b="1" i="0">
                 <a:solidFill>
                   <a:srgbClr val="1E7A4B"/>
                 </a:solidFill>
                 <a:latin typeface="Calibri"/>
               </a:rPr>
-              <a:t>So calling everyone already makes money, and no ranking can improve on a decision that is right for every customer. Using the model adds $600 on top of $52,400. That is a 1% gain, and even that is generous.</a:t>
-            </a:r>
-          </a:p>
-        </p:txBody>
-      </p:sp>
-      <p:sp>
-        <p:nvSpPr>
-          <p:cNvPr id="6" name="TextBox 5"/>
-          <p:cNvSpPr txBox="1"/>
-          <p:nvPr/>
-        </p:nvSpPr>
-        <p:spPr>
-          <a:xfrm>
-            <a:off x="685800" y="6126480"/>
-            <a:ext cx="10820095" cy="502920"/>
-          </a:xfrm>
-          <a:prstGeom prst="rect">
-            <a:avLst/>
-          </a:prstGeom>
-          <a:noFill/>
-        </p:spPr>
-        <p:txBody>
-          <a:bodyPr wrap="square">
-            <a:spAutoFit/>
-          </a:bodyPr>
-          <a:lstStyle/>
-          <a:p>
-            <a:r>
-              <a:rPr sz="1150" b="0" i="1">
-                <a:solidFill>
-                  <a:srgbClr val="5A6270"/>
-                </a:solidFill>
-                <a:latin typeface="Calibri"/>
-              </a:rPr>
-              <a:t>This is one division. Had I run it first, it would have shown that a working model was never the thing standing between us and the decision.</a:t>
+              <a:t>Using the model adds $600 on top of $52,400. A 1% gain, and generous at that, because the threshold it uses was chosen with hindsight on the same customers.</a:t>
             </a:r>
           </a:p>
         </p:txBody>
@@ -7712,7 +8001,7 @@
                 </a:solidFill>
                 <a:latin typeface="Calibri"/>
               </a:rPr>
-              <a:t>PART 4 · TESTING APPROACH</a:t>
+              <a:t>PART 5 · SCALABILITY</a:t>
             </a:r>
           </a:p>
           <a:p>
@@ -7728,7 +8017,7 @@
                 </a:solidFill>
                 <a:latin typeface="Calibri"/>
               </a:rPr>
-              <a:t>How I would test this, and what is worth testing</a:t>
+              <a:t>How I would run this in production</a:t>
             </a:r>
           </a:p>
         </p:txBody>
@@ -7778,40 +8067,16 @@
           </a:p>
         </p:txBody>
       </p:sp>
-      <p:pic>
-        <p:nvPicPr>
-          <p:cNvPr id="4" name="Picture 3" descr="15_experiment_power.png"/>
-          <p:cNvPicPr>
-            <a:picLocks noChangeAspect="1"/>
-          </p:cNvPicPr>
-          <p:nvPr/>
-        </p:nvPicPr>
-        <p:blipFill>
-          <a:blip r:embed="rId2"/>
-          <a:stretch>
-            <a:fillRect/>
-          </a:stretch>
-        </p:blipFill>
-        <p:spPr>
-          <a:xfrm>
-            <a:off x="6492240" y="1737360"/>
-            <a:ext cx="5344328" cy="2926080"/>
-          </a:xfrm>
-          <a:prstGeom prst="rect">
-            <a:avLst/>
-          </a:prstGeom>
-        </p:spPr>
-      </p:pic>
-      <p:sp>
-        <p:nvSpPr>
-          <p:cNvPr id="5" name="TextBox 4"/>
+      <p:sp>
+        <p:nvSpPr>
+          <p:cNvPr id="4" name="TextBox 3"/>
           <p:cNvSpPr txBox="1"/>
           <p:nvPr/>
         </p:nvSpPr>
         <p:spPr>
           <a:xfrm>
             <a:off x="685800" y="1719072"/>
-            <a:ext cx="5486400" cy="4572000"/>
+            <a:ext cx="5577840" cy="4206240"/>
           </a:xfrm>
           <a:prstGeom prst="rect">
             <a:avLst/>
@@ -7826,17 +8091,248 @@
           <a:p>
             <a:pPr>
               <a:spcAft>
+                <a:spcPts val="300"/>
+              </a:spcAft>
+            </a:pPr>
+            <a:r>
+              <a:rPr sz="1250" b="1" i="0">
+                <a:solidFill>
+                  <a:srgbClr val="1A1A1A"/>
+                </a:solidFill>
+                <a:latin typeface="Calibri"/>
+              </a:rPr>
+              <a:t>Sources:  billing and CRM, product usage, support desk</a:t>
+            </a:r>
+          </a:p>
+          <a:p>
+            <a:pPr>
+              <a:spcAft>
+                <a:spcPts val="300"/>
+              </a:spcAft>
+            </a:pPr>
+            <a:r>
+              <a:rPr sz="1250" b="0" i="0">
+                <a:solidFill>
+                  <a:srgbClr val="5A6270"/>
+                </a:solidFill>
+                <a:latin typeface="Calibri"/>
+              </a:rPr>
+              <a:t>        |  runs once a night</a:t>
+            </a:r>
+          </a:p>
+          <a:p>
+            <a:pPr>
+              <a:spcAft>
+                <a:spcPts val="300"/>
+              </a:spcAft>
+            </a:pPr>
+            <a:r>
+              <a:rPr sz="1250" b="1" i="0">
+                <a:solidFill>
+                  <a:srgbClr val="1A1A1A"/>
+                </a:solidFill>
+                <a:latin typeface="Calibri"/>
+              </a:rPr>
+              <a:t>Feature build  (THE SAME CODE USED IN TRAINING)</a:t>
+            </a:r>
+          </a:p>
+          <a:p>
+            <a:pPr>
+              <a:spcAft>
+                <a:spcPts val="300"/>
+              </a:spcAft>
+            </a:pPr>
+            <a:r>
+              <a:rPr sz="1250" b="0" i="0">
+                <a:solidFill>
+                  <a:srgbClr val="5A6270"/>
+                </a:solidFill>
+                <a:latin typeface="Calibri"/>
+              </a:rPr>
+              <a:t>   · every calculation takes a date and looks only before it</a:t>
+            </a:r>
+          </a:p>
+          <a:p>
+            <a:pPr>
+              <a:spcAft>
+                <a:spcPts val="300"/>
+              </a:spcAft>
+            </a:pPr>
+            <a:r>
+              <a:rPr sz="1250" b="0" i="0">
+                <a:solidFill>
+                  <a:srgbClr val="5A6270"/>
+                </a:solidFill>
+                <a:latin typeface="Calibri"/>
+              </a:rPr>
+              <a:t>   · blanks out anything not yet known on that date</a:t>
+            </a:r>
+          </a:p>
+          <a:p>
+            <a:pPr>
+              <a:spcAft>
+                <a:spcPts val="300"/>
+              </a:spcAft>
+            </a:pPr>
+            <a:r>
+              <a:rPr sz="1250" b="0" i="0">
+                <a:solidFill>
+                  <a:srgbClr val="5A6270"/>
+                </a:solidFill>
+                <a:latin typeface="Calibri"/>
+              </a:rPr>
+              <a:t>   · the leakage checks run here and stop the job if they fail</a:t>
+            </a:r>
+          </a:p>
+          <a:p>
+            <a:pPr>
+              <a:spcAft>
+                <a:spcPts val="300"/>
+              </a:spcAft>
+            </a:pPr>
+            <a:r>
+              <a:rPr sz="1250" b="0" i="0">
+                <a:solidFill>
+                  <a:srgbClr val="5A6270"/>
+                </a:solidFill>
+                <a:latin typeface="Calibri"/>
+              </a:rPr>
+              <a:t>        |</a:t>
+            </a:r>
+          </a:p>
+          <a:p>
+            <a:pPr>
+              <a:spcAft>
+                <a:spcPts val="300"/>
+              </a:spcAft>
+            </a:pPr>
+            <a:r>
+              <a:rPr sz="1250" b="1" i="0">
+                <a:solidFill>
+                  <a:srgbClr val="1A1A1A"/>
+                </a:solidFill>
+                <a:latin typeface="Calibri"/>
+              </a:rPr>
+              <a:t>Scoring  (once a day is plenty for a 90 day question)</a:t>
+            </a:r>
+          </a:p>
+          <a:p>
+            <a:pPr>
+              <a:spcAft>
+                <a:spcPts val="300"/>
+              </a:spcAft>
+            </a:pPr>
+            <a:r>
+              <a:rPr sz="1250" b="0" i="0">
+                <a:solidFill>
+                  <a:srgbClr val="5A6270"/>
+                </a:solidFill>
+                <a:latin typeface="Calibri"/>
+              </a:rPr>
+              <a:t>   · writes the customer, the score, and the main reasons</a:t>
+            </a:r>
+          </a:p>
+          <a:p>
+            <a:pPr>
+              <a:spcAft>
+                <a:spcPts val="300"/>
+              </a:spcAft>
+            </a:pPr>
+            <a:r>
+              <a:rPr sz="1250" b="0" i="0">
+                <a:solidFill>
+                  <a:srgbClr val="5A6270"/>
+                </a:solidFill>
+                <a:latin typeface="Calibri"/>
+              </a:rPr>
+              <a:t>        |</a:t>
+            </a:r>
+          </a:p>
+          <a:p>
+            <a:pPr>
+              <a:spcAft>
+                <a:spcPts val="300"/>
+              </a:spcAft>
+            </a:pPr>
+            <a:r>
+              <a:rPr sz="1250" b="1" i="0">
+                <a:solidFill>
+                  <a:srgbClr val="1A1A1A"/>
+                </a:solidFill>
+                <a:latin typeface="Calibri"/>
+              </a:rPr>
+              <a:t>Use  (a call list for the success team)</a:t>
+            </a:r>
+          </a:p>
+          <a:p>
+            <a:pPr>
+              <a:spcAft>
+                <a:spcPts val="300"/>
+              </a:spcAft>
+            </a:pPr>
+            <a:r>
+              <a:rPr sz="1250" b="0" i="0">
+                <a:solidFill>
+                  <a:srgbClr val="5A6270"/>
+                </a:solidFill>
+                <a:latin typeface="Calibri"/>
+              </a:rPr>
+              <a:t>   · scores also written back to the CRM for context</a:t>
+            </a:r>
+          </a:p>
+          <a:p>
+            <a:pPr>
+              <a:spcAft>
+                <a:spcPts val="300"/>
+              </a:spcAft>
+            </a:pPr>
+            <a:r>
+              <a:rPr sz="1250" b="0" i="0">
+                <a:solidFill>
+                  <a:srgbClr val="5A6270"/>
+                </a:solidFill>
+                <a:latin typeface="Calibri"/>
+              </a:rPr>
+              <a:t>   · nothing is ever triggered automatically</a:t>
+            </a:r>
+          </a:p>
+        </p:txBody>
+      </p:sp>
+      <p:sp>
+        <p:nvSpPr>
+          <p:cNvPr id="5" name="TextBox 4"/>
+          <p:cNvSpPr txBox="1"/>
+          <p:nvPr/>
+        </p:nvSpPr>
+        <p:spPr>
+          <a:xfrm>
+            <a:off x="6492240" y="1719072"/>
+            <a:ext cx="5029200" cy="4572000"/>
+          </a:xfrm>
+          <a:prstGeom prst="rect">
+            <a:avLst/>
+          </a:prstGeom>
+          <a:noFill/>
+        </p:spPr>
+        <p:txBody>
+          <a:bodyPr wrap="square">
+            <a:spAutoFit/>
+          </a:bodyPr>
+          <a:lstStyle/>
+          <a:p>
+            <a:pPr>
+              <a:spcAft>
                 <a:spcPts val="900"/>
               </a:spcAft>
             </a:pPr>
             <a:r>
-              <a:rPr sz="1400" b="1" i="0">
+              <a:rPr sz="1300" b="1" i="0">
                 <a:solidFill>
                   <a:srgbClr val="1A1A1A"/>
                 </a:solidFill>
                 <a:latin typeface="Calibri"/>
               </a:rPr>
-              <a:t>Recommendation 1 is not an experiment. It is a data request.</a:t>
+              <a:t>What I would watch</a:t>
             </a:r>
           </a:p>
           <a:p>
@@ -7846,13 +8342,77 @@
               </a:spcAft>
             </a:pPr>
             <a:r>
-              <a:rPr sz="1200" b="0" i="0">
+              <a:rPr sz="1100" b="0" i="0">
                 <a:solidFill>
                   <a:srgbClr val="5A6270"/>
                 </a:solidFill>
                 <a:latin typeface="Calibri"/>
               </a:rPr>
-              <a:t>Nothing in this extract can say why customers leave, because the timestamps were never recorded against the customers they belong to. Ask for an export where they are, then rerun this pipeline and compare against the score written down today.</a:t>
+              <a:t>Whether the incoming data still looks like the data we trained on. Checked weekly.</a:t>
+            </a:r>
+          </a:p>
+          <a:p>
+            <a:pPr lvl="1">
+              <a:spcAft>
+                <a:spcPts val="900"/>
+              </a:spcAft>
+            </a:pPr>
+            <a:r>
+              <a:rPr sz="1100" b="0" i="0">
+                <a:solidFill>
+                  <a:srgbClr val="5A6270"/>
+                </a:solidFill>
+                <a:latin typeface="Calibri"/>
+              </a:rPr>
+              <a:t>Whether columns have gone missing or empty. Checked daily, and the job fails if the shape changes.</a:t>
+            </a:r>
+          </a:p>
+          <a:p>
+            <a:pPr lvl="1">
+              <a:spcAft>
+                <a:spcPts val="900"/>
+              </a:spcAft>
+            </a:pPr>
+            <a:r>
+              <a:rPr sz="1100" b="0" i="0">
+                <a:solidFill>
+                  <a:srgbClr val="5A6270"/>
+                </a:solidFill>
+                <a:latin typeface="Calibri"/>
+              </a:rPr>
+              <a:t>The leakage checks. Run every single time, and they stop the job.</a:t>
+            </a:r>
+          </a:p>
+          <a:p>
+            <a:pPr lvl="1">
+              <a:spcAft>
+                <a:spcPts val="900"/>
+              </a:spcAft>
+            </a:pPr>
+            <a:r>
+              <a:rPr sz="1100" b="0" i="0">
+                <a:solidFill>
+                  <a:srgbClr val="5A6270"/>
+                </a:solidFill>
+                <a:latin typeface="Calibri"/>
+              </a:rPr>
+              <a:t>Whether the scores themselves have drifted. Checked weekly.</a:t>
+            </a:r>
+          </a:p>
+          <a:p>
+            <a:pPr lvl="1">
+              <a:spcAft>
+                <a:spcPts val="900"/>
+              </a:spcAft>
+            </a:pPr>
+            <a:r>
+              <a:rPr sz="1100" b="0" i="0">
+                <a:solidFill>
+                  <a:srgbClr val="5A6270"/>
+                </a:solidFill>
+                <a:latin typeface="Calibri"/>
+              </a:rPr>
+              <a:t>Whether the model is still accurate. Checked every quarter, once we know who actually left.</a:t>
             </a:r>
           </a:p>
           <a:p>
@@ -7878,109 +8438,45 @@
               </a:spcAft>
             </a:pPr>
             <a:r>
-              <a:rPr sz="1400" b="1" i="0">
+              <a:rPr sz="1300" b="0" i="0">
+                <a:solidFill>
+                  <a:srgbClr val="5A6270"/>
+                </a:solidFill>
+                <a:latin typeface="Calibri"/>
+              </a:rPr>
+              <a:t>We only learn if we were right 90 days later. So accuracy checks are always late. Watching the incoming data is the early warning, and accuracy confirms it afterwards.</a:t>
+            </a:r>
+          </a:p>
+          <a:p>
+            <a:pPr>
+              <a:spcAft>
+                <a:spcPts val="900"/>
+              </a:spcAft>
+            </a:pPr>
+            <a:r>
+              <a:rPr sz="600" b="0" i="0">
                 <a:solidFill>
                   <a:srgbClr val="1A1A1A"/>
                 </a:solidFill>
                 <a:latin typeface="Calibri"/>
               </a:rPr>
-              <a:t>Recommendation 3 is a proper experiment.</a:t>
-            </a:r>
-          </a:p>
-          <a:p>
-            <a:pPr lvl="1">
+              <a:t> </a:t>
+            </a:r>
+          </a:p>
+          <a:p>
+            <a:pPr>
               <a:spcAft>
                 <a:spcPts val="900"/>
               </a:spcAft>
             </a:pPr>
             <a:r>
-              <a:rPr sz="1200" b="0" i="0">
-                <a:solidFill>
-                  <a:srgbClr val="5A6270"/>
-                </a:solidFill>
-                <a:latin typeface="Calibri"/>
-              </a:rPr>
-              <a:t>Split the at-risk customers in half at random. One half gets a call, one half does not. Measure retention after 180 days, and measure money kept as well, so a costly save is not mistaken for a win.</a:t>
-            </a:r>
-          </a:p>
-          <a:p>
-            <a:pPr>
-              <a:spcAft>
-                <a:spcPts val="900"/>
-              </a:spcAft>
-            </a:pPr>
-            <a:r>
-              <a:rPr sz="600" b="0" i="0">
-                <a:solidFill>
-                  <a:srgbClr val="1A1A1A"/>
-                </a:solidFill>
-                <a:latin typeface="Calibri"/>
-              </a:rPr>
-              <a:t> </a:t>
-            </a:r>
-          </a:p>
-          <a:p>
-            <a:pPr>
-              <a:spcAft>
-                <a:spcPts val="900"/>
-              </a:spcAft>
-            </a:pPr>
-            <a:r>
-              <a:rPr sz="1400" b="1" i="0">
-                <a:solidFill>
-                  <a:srgbClr val="B02E2E"/>
-                </a:solidFill>
-                <a:latin typeface="Calibri"/>
-              </a:rPr>
-              <a:t>But be realistic about what we can detect.</a:t>
-            </a:r>
-          </a:p>
-          <a:p>
-            <a:pPr lvl="1">
-              <a:spcAft>
-                <a:spcPts val="900"/>
-              </a:spcAft>
-            </a:pPr>
-            <a:r>
-              <a:rPr sz="1200" b="0" i="0">
-                <a:solidFill>
-                  <a:srgbClr val="5A6270"/>
-                </a:solidFill>
-                <a:latin typeface="Calibri"/>
-              </a:rPr>
-              <a:t>At about 21 new customers a month, only a very large effect can be proved:</a:t>
-            </a:r>
-          </a:p>
-          <a:p>
-            <a:pPr lvl="1">
-              <a:spcAft>
-                <a:spcPts val="900"/>
-              </a:spcAft>
-            </a:pPr>
-            <a:r>
-              <a:rPr sz="1200" b="0" i="0">
-                <a:solidFill>
-                  <a:srgbClr val="5A6270"/>
-                </a:solidFill>
-                <a:latin typeface="Calibri"/>
-              </a:rPr>
-              <a:t>Halving churn takes about 15 months to show.</a:t>
-            </a:r>
-          </a:p>
-          <a:p>
-            <a:pPr lvl="1">
-              <a:spcAft>
-                <a:spcPts val="900"/>
-              </a:spcAft>
-            </a:pPr>
-            <a:r>
-              <a:rPr sz="1200" b="0" i="0">
-                <a:solidFill>
-                  <a:srgbClr val="5A6270"/>
-                </a:solidFill>
-                <a:latin typeface="Calibri"/>
-              </a:rPr>
-              <a:t>A 5 point improvement would take over 10 years.</a:t>
+              <a:rPr sz="1300" b="1" i="0">
+                <a:solidFill>
+                  <a:srgbClr val="2E5F8A"/>
+                </a:solidFill>
+                <a:latin typeface="Calibri"/>
+              </a:rPr>
+              <a:t>The part I would argue for hardest is running the leakage checks in production. The bug in this project was in the pipeline, and pipeline bugs come back every time someone adds a feature.</a:t>
             </a:r>
           </a:p>
         </p:txBody>
@@ -8010,412 +8506,11 @@
             <a:r>
               <a:rPr sz="1150" b="0" i="1">
                 <a:solidFill>
-                  <a:srgbClr val="5A6270"/>
-                </a:solidFill>
-                <a:latin typeface="Calibri"/>
-              </a:rPr>
-              <a:t>Two separate methods agree on this. A standard power calculation and a simulation both say we cannot detect anything smaller than about a 15 point change.</a:t>
-            </a:r>
-          </a:p>
-        </p:txBody>
-      </p:sp>
-    </p:spTree>
-  </p:cSld>
-  <p:clrMapOvr>
-    <a:masterClrMapping/>
-  </p:clrMapOvr>
-</p:sld>
-</file>
-
-<file path=ppt/slides/slide19.xml><?xml version="1.0" encoding="utf-8"?>
-<p:sld xmlns:a="http://schemas.openxmlformats.org/drawingml/2006/main" xmlns:r="http://schemas.openxmlformats.org/officeDocument/2006/relationships" xmlns:p="http://schemas.openxmlformats.org/presentationml/2006/main">
-  <p:cSld>
-    <p:spTree>
-      <p:nvGrpSpPr>
-        <p:cNvPr id="1" name=""/>
-        <p:cNvGrpSpPr/>
-        <p:nvPr/>
-      </p:nvGrpSpPr>
-      <p:grpSpPr>
-        <a:xfrm>
-          <a:off x="0" y="0"/>
-          <a:ext cx="0" cy="0"/>
-          <a:chOff x="0" y="0"/>
-          <a:chExt cx="0" cy="0"/>
-        </a:xfrm>
-      </p:grpSpPr>
-      <p:sp>
-        <p:nvSpPr>
-          <p:cNvPr id="2" name="TextBox 1"/>
-          <p:cNvSpPr txBox="1"/>
-          <p:nvPr/>
-        </p:nvSpPr>
-        <p:spPr>
-          <a:xfrm>
-            <a:off x="685800" y="365760"/>
-            <a:ext cx="10820095" cy="1051560"/>
-          </a:xfrm>
-          <a:prstGeom prst="rect">
-            <a:avLst/>
-          </a:prstGeom>
-          <a:noFill/>
-        </p:spPr>
-        <p:txBody>
-          <a:bodyPr wrap="square">
-            <a:spAutoFit/>
-          </a:bodyPr>
-          <a:lstStyle/>
-          <a:p>
-            <a:r>
-              <a:rPr sz="1200" b="1" i="0">
-                <a:solidFill>
-                  <a:srgbClr val="5A6270"/>
-                </a:solidFill>
-                <a:latin typeface="Calibri"/>
-              </a:rPr>
-              <a:t>PART 5 · MENTORSHIP</a:t>
-            </a:r>
-          </a:p>
-          <a:p>
-            <a:pPr>
-              <a:spcBef>
-                <a:spcPts val="400"/>
-              </a:spcBef>
-            </a:pPr>
-            <a:r>
-              <a:rPr sz="2800" b="1" i="0">
-                <a:solidFill>
                   <a:srgbClr val="1A1A1A"/>
                 </a:solidFill>
                 <a:latin typeface="Calibri"/>
               </a:rPr>
-              <a:t>What I would teach a junior engineer</a:t>
-            </a:r>
-          </a:p>
-        </p:txBody>
-      </p:sp>
-      <p:sp>
-        <p:nvSpPr>
-          <p:cNvPr id="3" name="Rectangle 2"/>
-          <p:cNvSpPr/>
-          <p:nvPr/>
-        </p:nvSpPr>
-        <p:spPr>
-          <a:xfrm>
-            <a:off x="685800" y="1426464"/>
-            <a:ext cx="10820095" cy="9525"/>
-          </a:xfrm>
-          <a:prstGeom prst="rect">
-            <a:avLst/>
-          </a:prstGeom>
-          <a:solidFill>
-            <a:srgbClr val="D8DCE0"/>
-          </a:solidFill>
-          <a:ln>
-            <a:noFill/>
-          </a:ln>
-          <a:effectLst/>
-        </p:spPr>
-        <p:style>
-          <a:lnRef idx="1">
-            <a:schemeClr val="accent1"/>
-          </a:lnRef>
-          <a:fillRef idx="3">
-            <a:schemeClr val="accent1"/>
-          </a:fillRef>
-          <a:effectRef idx="2">
-            <a:schemeClr val="accent1"/>
-          </a:effectRef>
-          <a:fontRef idx="minor">
-            <a:schemeClr val="lt1"/>
-          </a:fontRef>
-        </p:style>
-        <p:txBody>
-          <a:bodyPr rtlCol="0" anchor="ctr"/>
-          <a:lstStyle/>
-          <a:p>
-            <a:pPr algn="ctr"/>
-            <a:endParaRPr/>
-          </a:p>
-        </p:txBody>
-      </p:sp>
-      <p:sp>
-        <p:nvSpPr>
-          <p:cNvPr id="4" name="TextBox 3"/>
-          <p:cNvSpPr txBox="1"/>
-          <p:nvPr/>
-        </p:nvSpPr>
-        <p:spPr>
-          <a:xfrm>
-            <a:off x="685800" y="1719072"/>
-            <a:ext cx="10820095" cy="4572000"/>
-          </a:xfrm>
-          <a:prstGeom prst="rect">
-            <a:avLst/>
-          </a:prstGeom>
-          <a:noFill/>
-        </p:spPr>
-        <p:txBody>
-          <a:bodyPr wrap="square">
-            <a:spAutoFit/>
-          </a:bodyPr>
-          <a:lstStyle/>
-          <a:p>
-            <a:pPr>
-              <a:spcAft>
-                <a:spcPts val="400"/>
-              </a:spcAft>
-            </a:pPr>
-            <a:r>
-              <a:rPr sz="1300" b="1" i="0" dirty="0">
-                <a:solidFill>
-                  <a:srgbClr val="1A1A1A"/>
-                </a:solidFill>
-                <a:latin typeface="Calibri"/>
-              </a:rPr>
-              <a:t>I would hand them my own worst mistake on this project, because that is where the judgement that transfers to other work lives.</a:t>
-            </a:r>
-          </a:p>
-          <a:p>
-            <a:pPr>
-              <a:spcAft>
-                <a:spcPts val="400"/>
-              </a:spcAft>
-            </a:pPr>
-            <a:r>
-              <a:rPr sz="600" b="0" i="0" dirty="0">
-                <a:solidFill>
-                  <a:srgbClr val="1A1A1A"/>
-                </a:solidFill>
-                <a:latin typeface="Calibri"/>
-              </a:rPr>
-              <a:t> </a:t>
-            </a:r>
-          </a:p>
-          <a:p>
-            <a:pPr>
-              <a:spcAft>
-                <a:spcPts val="400"/>
-              </a:spcAft>
-            </a:pPr>
-            <a:r>
-              <a:rPr sz="1300" b="1" i="0" dirty="0">
-                <a:solidFill>
-                  <a:srgbClr val="B02E2E"/>
-                </a:solidFill>
-                <a:latin typeface="Calibri"/>
-              </a:rPr>
-              <a:t>1. Be hardest on the finding you like.</a:t>
-            </a:r>
-          </a:p>
-          <a:p>
-            <a:pPr lvl="1">
-              <a:spcAft>
-                <a:spcPts val="400"/>
-              </a:spcAft>
-            </a:pPr>
-            <a:r>
-              <a:rPr sz="1100" b="0" i="0" dirty="0">
-                <a:solidFill>
-                  <a:srgbClr val="5A6270"/>
-                </a:solidFill>
-                <a:latin typeface="Calibri"/>
-              </a:rPr>
-              <a:t>I had one positive result and a page of nulls, and I checked the nulls. The positive one was manufactured by the file. Ask of any finding: what else could have produced this, and can I generate it from nothing?</a:t>
-            </a:r>
-          </a:p>
-          <a:p>
-            <a:pPr>
-              <a:spcAft>
-                <a:spcPts val="400"/>
-              </a:spcAft>
-            </a:pPr>
-            <a:r>
-              <a:rPr sz="1300" b="1" i="0" dirty="0">
-                <a:solidFill>
-                  <a:srgbClr val="B02E2E"/>
-                </a:solidFill>
-                <a:latin typeface="Calibri"/>
-              </a:rPr>
-              <a:t>2. A small p-value is not evidence. It is evidence against one null.</a:t>
-            </a:r>
-          </a:p>
-          <a:p>
-            <a:pPr lvl="1">
-              <a:spcAft>
-                <a:spcPts val="400"/>
-              </a:spcAft>
-            </a:pPr>
-            <a:r>
-              <a:rPr sz="1100" b="0" i="0" dirty="0">
-                <a:solidFill>
-                  <a:srgbClr val="5A6270"/>
-                </a:solidFill>
-                <a:latin typeface="Calibri"/>
-              </a:rPr>
-              <a:t>p = 2e-16 felt unarguable. Random dates gave p = 3e-16. If the null is the wrong one, no amount of significance rescues it.</a:t>
-            </a:r>
-          </a:p>
-          <a:p>
-            <a:pPr>
-              <a:spcAft>
-                <a:spcPts val="400"/>
-              </a:spcAft>
-            </a:pPr>
-            <a:r>
-              <a:rPr sz="1300" b="1" i="0" dirty="0">
-                <a:solidFill>
-                  <a:srgbClr val="1A1A1A"/>
-                </a:solidFill>
-                <a:latin typeface="Calibri"/>
-              </a:rPr>
-              <a:t>3. Start with the target, not the model.</a:t>
-            </a:r>
-          </a:p>
-          <a:p>
-            <a:pPr lvl="1">
-              <a:spcAft>
-                <a:spcPts val="400"/>
-              </a:spcAft>
-            </a:pPr>
-            <a:r>
-              <a:rPr sz="1100" b="0" i="0" dirty="0">
-                <a:solidFill>
-                  <a:srgbClr val="5A6270"/>
-                </a:solidFill>
-                <a:latin typeface="Calibri"/>
-              </a:rPr>
-              <a:t>My first version modelled a flag unrelated to the event log. Counting rows found it. Then check your own check: I first called 38% agreement ‘worse than a coin flip’, and it is not — for two columns this different in size, chance agreement is 39%, not 50%.</a:t>
-            </a:r>
-          </a:p>
-          <a:p>
-            <a:pPr>
-              <a:spcAft>
-                <a:spcPts val="400"/>
-              </a:spcAft>
-            </a:pPr>
-            <a:r>
-              <a:rPr sz="1300" b="1" i="0" dirty="0">
-                <a:solidFill>
-                  <a:srgbClr val="1A1A1A"/>
-                </a:solidFill>
-                <a:latin typeface="Calibri"/>
-              </a:rPr>
-              <a:t>4. Ask of every column: would I really have this on the day I predict?</a:t>
-            </a:r>
-          </a:p>
-          <a:p>
-            <a:pPr lvl="1">
-              <a:spcAft>
-                <a:spcPts val="400"/>
-              </a:spcAft>
-            </a:pPr>
-            <a:r>
-              <a:rPr sz="1100" b="0" i="0" dirty="0">
-                <a:solidFill>
-                  <a:srgbClr val="5A6270"/>
-                </a:solidFill>
-                <a:latin typeface="Calibri"/>
-              </a:rPr>
-              <a:t>Then write the check down so a machine runs it. Reading caught the obvious problem; the automatic check caught the one I missed.</a:t>
-            </a:r>
-          </a:p>
-          <a:p>
-            <a:pPr>
-              <a:spcAft>
-                <a:spcPts val="400"/>
-              </a:spcAft>
-            </a:pPr>
-            <a:r>
-              <a:rPr sz="1300" b="1" i="0" dirty="0">
-                <a:solidFill>
-                  <a:srgbClr val="1A1A1A"/>
-                </a:solidFill>
-                <a:latin typeface="Calibri"/>
-              </a:rPr>
-              <a:t>5. Find the floor, and report the range.</a:t>
-            </a:r>
-          </a:p>
-          <a:p>
-            <a:pPr lvl="1">
-              <a:spcAft>
-                <a:spcPts val="400"/>
-              </a:spcAft>
-            </a:pPr>
-            <a:r>
-              <a:rPr sz="1100" b="0" i="0" dirty="0">
-                <a:solidFill>
-                  <a:srgbClr val="5A6270"/>
-                </a:solidFill>
-                <a:latin typeface="Calibri"/>
-              </a:rPr>
-              <a:t>Always run the model with no features first. A range that includes guessing says something the average hides.</a:t>
-            </a:r>
-          </a:p>
-          <a:p>
-            <a:pPr>
-              <a:spcAft>
-                <a:spcPts val="400"/>
-              </a:spcAft>
-            </a:pPr>
-            <a:r>
-              <a:rPr sz="1300" b="1" i="0" dirty="0">
-                <a:solidFill>
-                  <a:srgbClr val="2E5F8A"/>
-                </a:solidFill>
-                <a:latin typeface="Calibri"/>
-              </a:rPr>
-              <a:t>6. Choosing a model is part of fitting it.</a:t>
-            </a:r>
-          </a:p>
-          <a:p>
-            <a:pPr lvl="1">
-              <a:spcAft>
-                <a:spcPts val="400"/>
-              </a:spcAft>
-            </a:pPr>
-            <a:r>
-              <a:rPr sz="1100" b="0" i="0" dirty="0">
-                <a:solidFill>
-                  <a:srgbClr val="5A6270"/>
-                </a:solidFill>
-                <a:latin typeface="Calibri"/>
-              </a:rPr>
-              <a:t>Here the gap between the best model and the honest score was the entire apparent signal.</a:t>
-            </a:r>
-          </a:p>
-        </p:txBody>
-      </p:sp>
-      <p:sp>
-        <p:nvSpPr>
-          <p:cNvPr id="5" name="TextBox 4"/>
-          <p:cNvSpPr txBox="1"/>
-          <p:nvPr/>
-        </p:nvSpPr>
-        <p:spPr>
-          <a:xfrm>
-            <a:off x="685800" y="6126480"/>
-            <a:ext cx="10820095" cy="502920"/>
-          </a:xfrm>
-          <a:prstGeom prst="rect">
-            <a:avLst/>
-          </a:prstGeom>
-          <a:noFill/>
-        </p:spPr>
-        <p:txBody>
-          <a:bodyPr wrap="square">
-            <a:spAutoFit/>
-          </a:bodyPr>
-          <a:lstStyle/>
-          <a:p>
-            <a:r>
-              <a:rPr sz="1150" b="0" i="1">
-                <a:solidFill>
-                  <a:srgbClr val="5A6270"/>
-                </a:solidFill>
-                <a:latin typeface="Calibri"/>
-              </a:rPr>
-              <a:t>I would teach all of it as experiments rather than lectures. Switch off the banned column list and watch AUC jump from 0.58 to 0.79. Then simulate a dataset with nothing in it and watch it produce a publishable-looking trend.</a:t>
+              <a:t>This is what I would build if the model were worth shipping. On these results it is not, and this extract cannot be repaired into one — the timestamps have to be collected against the right customers, not corrected. Once they are, the pipeline takes a date, so re-measuring is one command.</a:t>
             </a:r>
           </a:p>
         </p:txBody>
@@ -9197,574 +9292,6 @@
           </a:prstGeom>
         </p:spPr>
       </p:pic>
-    </p:spTree>
-  </p:cSld>
-  <p:clrMapOvr>
-    <a:masterClrMapping/>
-  </p:clrMapOvr>
-</p:sld>
-</file>
-
-<file path=ppt/slides/slide20.xml><?xml version="1.0" encoding="utf-8"?>
-<p:sld xmlns:a="http://schemas.openxmlformats.org/drawingml/2006/main" xmlns:r="http://schemas.openxmlformats.org/officeDocument/2006/relationships" xmlns:p="http://schemas.openxmlformats.org/presentationml/2006/main">
-  <p:cSld>
-    <p:spTree>
-      <p:nvGrpSpPr>
-        <p:cNvPr id="1" name=""/>
-        <p:cNvGrpSpPr/>
-        <p:nvPr/>
-      </p:nvGrpSpPr>
-      <p:grpSpPr>
-        <a:xfrm>
-          <a:off x="0" y="0"/>
-          <a:ext cx="0" cy="0"/>
-          <a:chOff x="0" y="0"/>
-          <a:chExt cx="0" cy="0"/>
-        </a:xfrm>
-      </p:grpSpPr>
-      <p:sp>
-        <p:nvSpPr>
-          <p:cNvPr id="2" name="TextBox 1"/>
-          <p:cNvSpPr txBox="1"/>
-          <p:nvPr/>
-        </p:nvSpPr>
-        <p:spPr>
-          <a:xfrm>
-            <a:off x="685800" y="365760"/>
-            <a:ext cx="10820095" cy="1051560"/>
-          </a:xfrm>
-          <a:prstGeom prst="rect">
-            <a:avLst/>
-          </a:prstGeom>
-          <a:noFill/>
-        </p:spPr>
-        <p:txBody>
-          <a:bodyPr wrap="square">
-            <a:spAutoFit/>
-          </a:bodyPr>
-          <a:lstStyle/>
-          <a:p>
-            <a:r>
-              <a:rPr sz="1200" b="1" i="0">
-                <a:solidFill>
-                  <a:srgbClr val="5A6270"/>
-                </a:solidFill>
-                <a:latin typeface="Calibri"/>
-              </a:rPr>
-              <a:t>PART 5 · SCALABILITY</a:t>
-            </a:r>
-          </a:p>
-          <a:p>
-            <a:pPr>
-              <a:spcBef>
-                <a:spcPts val="400"/>
-              </a:spcBef>
-            </a:pPr>
-            <a:r>
-              <a:rPr sz="2800" b="1" i="0">
-                <a:solidFill>
-                  <a:srgbClr val="1A1A1A"/>
-                </a:solidFill>
-                <a:latin typeface="Calibri"/>
-              </a:rPr>
-              <a:t>How I would run this in production</a:t>
-            </a:r>
-          </a:p>
-        </p:txBody>
-      </p:sp>
-      <p:sp>
-        <p:nvSpPr>
-          <p:cNvPr id="3" name="Rectangle 2"/>
-          <p:cNvSpPr/>
-          <p:nvPr/>
-        </p:nvSpPr>
-        <p:spPr>
-          <a:xfrm>
-            <a:off x="685800" y="1426464"/>
-            <a:ext cx="10820095" cy="9525"/>
-          </a:xfrm>
-          <a:prstGeom prst="rect">
-            <a:avLst/>
-          </a:prstGeom>
-          <a:solidFill>
-            <a:srgbClr val="D8DCE0"/>
-          </a:solidFill>
-          <a:ln>
-            <a:noFill/>
-          </a:ln>
-          <a:effectLst/>
-        </p:spPr>
-        <p:style>
-          <a:lnRef idx="1">
-            <a:schemeClr val="accent1"/>
-          </a:lnRef>
-          <a:fillRef idx="3">
-            <a:schemeClr val="accent1"/>
-          </a:fillRef>
-          <a:effectRef idx="2">
-            <a:schemeClr val="accent1"/>
-          </a:effectRef>
-          <a:fontRef idx="minor">
-            <a:schemeClr val="lt1"/>
-          </a:fontRef>
-        </p:style>
-        <p:txBody>
-          <a:bodyPr rtlCol="0" anchor="ctr"/>
-          <a:lstStyle/>
-          <a:p>
-            <a:pPr algn="ctr"/>
-            <a:endParaRPr/>
-          </a:p>
-        </p:txBody>
-      </p:sp>
-      <p:sp>
-        <p:nvSpPr>
-          <p:cNvPr id="4" name="TextBox 3"/>
-          <p:cNvSpPr txBox="1"/>
-          <p:nvPr/>
-        </p:nvSpPr>
-        <p:spPr>
-          <a:xfrm>
-            <a:off x="685800" y="1719072"/>
-            <a:ext cx="5577840" cy="4206240"/>
-          </a:xfrm>
-          <a:prstGeom prst="rect">
-            <a:avLst/>
-          </a:prstGeom>
-          <a:noFill/>
-        </p:spPr>
-        <p:txBody>
-          <a:bodyPr wrap="square">
-            <a:spAutoFit/>
-          </a:bodyPr>
-          <a:lstStyle/>
-          <a:p>
-            <a:pPr>
-              <a:spcAft>
-                <a:spcPts val="300"/>
-              </a:spcAft>
-            </a:pPr>
-            <a:r>
-              <a:rPr sz="1250" b="1" i="0">
-                <a:solidFill>
-                  <a:srgbClr val="1A1A1A"/>
-                </a:solidFill>
-                <a:latin typeface="Calibri"/>
-              </a:rPr>
-              <a:t>Sources:  billing and CRM, product usage, support desk</a:t>
-            </a:r>
-          </a:p>
-          <a:p>
-            <a:pPr>
-              <a:spcAft>
-                <a:spcPts val="300"/>
-              </a:spcAft>
-            </a:pPr>
-            <a:r>
-              <a:rPr sz="1250" b="0" i="0">
-                <a:solidFill>
-                  <a:srgbClr val="5A6270"/>
-                </a:solidFill>
-                <a:latin typeface="Calibri"/>
-              </a:rPr>
-              <a:t>        |  runs once a night</a:t>
-            </a:r>
-          </a:p>
-          <a:p>
-            <a:pPr>
-              <a:spcAft>
-                <a:spcPts val="300"/>
-              </a:spcAft>
-            </a:pPr>
-            <a:r>
-              <a:rPr sz="1250" b="1" i="0">
-                <a:solidFill>
-                  <a:srgbClr val="1A1A1A"/>
-                </a:solidFill>
-                <a:latin typeface="Calibri"/>
-              </a:rPr>
-              <a:t>Feature build  (THE SAME CODE USED IN TRAINING)</a:t>
-            </a:r>
-          </a:p>
-          <a:p>
-            <a:pPr>
-              <a:spcAft>
-                <a:spcPts val="300"/>
-              </a:spcAft>
-            </a:pPr>
-            <a:r>
-              <a:rPr sz="1250" b="0" i="0">
-                <a:solidFill>
-                  <a:srgbClr val="5A6270"/>
-                </a:solidFill>
-                <a:latin typeface="Calibri"/>
-              </a:rPr>
-              <a:t>   · every calculation takes a date and looks only before it</a:t>
-            </a:r>
-          </a:p>
-          <a:p>
-            <a:pPr>
-              <a:spcAft>
-                <a:spcPts val="300"/>
-              </a:spcAft>
-            </a:pPr>
-            <a:r>
-              <a:rPr sz="1250" b="0" i="0">
-                <a:solidFill>
-                  <a:srgbClr val="5A6270"/>
-                </a:solidFill>
-                <a:latin typeface="Calibri"/>
-              </a:rPr>
-              <a:t>   · blanks out anything not yet known on that date</a:t>
-            </a:r>
-          </a:p>
-          <a:p>
-            <a:pPr>
-              <a:spcAft>
-                <a:spcPts val="300"/>
-              </a:spcAft>
-            </a:pPr>
-            <a:r>
-              <a:rPr sz="1250" b="0" i="0">
-                <a:solidFill>
-                  <a:srgbClr val="5A6270"/>
-                </a:solidFill>
-                <a:latin typeface="Calibri"/>
-              </a:rPr>
-              <a:t>   · the leakage checks run here and stop the job if they fail</a:t>
-            </a:r>
-          </a:p>
-          <a:p>
-            <a:pPr>
-              <a:spcAft>
-                <a:spcPts val="300"/>
-              </a:spcAft>
-            </a:pPr>
-            <a:r>
-              <a:rPr sz="1250" b="0" i="0">
-                <a:solidFill>
-                  <a:srgbClr val="5A6270"/>
-                </a:solidFill>
-                <a:latin typeface="Calibri"/>
-              </a:rPr>
-              <a:t>        |</a:t>
-            </a:r>
-          </a:p>
-          <a:p>
-            <a:pPr>
-              <a:spcAft>
-                <a:spcPts val="300"/>
-              </a:spcAft>
-            </a:pPr>
-            <a:r>
-              <a:rPr sz="1250" b="1" i="0">
-                <a:solidFill>
-                  <a:srgbClr val="1A1A1A"/>
-                </a:solidFill>
-                <a:latin typeface="Calibri"/>
-              </a:rPr>
-              <a:t>Scoring  (once a day is plenty for a 90 day question)</a:t>
-            </a:r>
-          </a:p>
-          <a:p>
-            <a:pPr>
-              <a:spcAft>
-                <a:spcPts val="300"/>
-              </a:spcAft>
-            </a:pPr>
-            <a:r>
-              <a:rPr sz="1250" b="0" i="0">
-                <a:solidFill>
-                  <a:srgbClr val="5A6270"/>
-                </a:solidFill>
-                <a:latin typeface="Calibri"/>
-              </a:rPr>
-              <a:t>   · writes the customer, the score, and the main reasons</a:t>
-            </a:r>
-          </a:p>
-          <a:p>
-            <a:pPr>
-              <a:spcAft>
-                <a:spcPts val="300"/>
-              </a:spcAft>
-            </a:pPr>
-            <a:r>
-              <a:rPr sz="1250" b="0" i="0">
-                <a:solidFill>
-                  <a:srgbClr val="5A6270"/>
-                </a:solidFill>
-                <a:latin typeface="Calibri"/>
-              </a:rPr>
-              <a:t>        |</a:t>
-            </a:r>
-          </a:p>
-          <a:p>
-            <a:pPr>
-              <a:spcAft>
-                <a:spcPts val="300"/>
-              </a:spcAft>
-            </a:pPr>
-            <a:r>
-              <a:rPr sz="1250" b="1" i="0">
-                <a:solidFill>
-                  <a:srgbClr val="1A1A1A"/>
-                </a:solidFill>
-                <a:latin typeface="Calibri"/>
-              </a:rPr>
-              <a:t>Use  (a call list for the success team)</a:t>
-            </a:r>
-          </a:p>
-          <a:p>
-            <a:pPr>
-              <a:spcAft>
-                <a:spcPts val="300"/>
-              </a:spcAft>
-            </a:pPr>
-            <a:r>
-              <a:rPr sz="1250" b="0" i="0">
-                <a:solidFill>
-                  <a:srgbClr val="5A6270"/>
-                </a:solidFill>
-                <a:latin typeface="Calibri"/>
-              </a:rPr>
-              <a:t>   · scores also written back to the CRM for context</a:t>
-            </a:r>
-          </a:p>
-          <a:p>
-            <a:pPr>
-              <a:spcAft>
-                <a:spcPts val="300"/>
-              </a:spcAft>
-            </a:pPr>
-            <a:r>
-              <a:rPr sz="1250" b="0" i="0">
-                <a:solidFill>
-                  <a:srgbClr val="5A6270"/>
-                </a:solidFill>
-                <a:latin typeface="Calibri"/>
-              </a:rPr>
-              <a:t>   · nothing is ever triggered automatically</a:t>
-            </a:r>
-          </a:p>
-        </p:txBody>
-      </p:sp>
-      <p:sp>
-        <p:nvSpPr>
-          <p:cNvPr id="5" name="TextBox 4"/>
-          <p:cNvSpPr txBox="1"/>
-          <p:nvPr/>
-        </p:nvSpPr>
-        <p:spPr>
-          <a:xfrm>
-            <a:off x="6492240" y="1719072"/>
-            <a:ext cx="5029200" cy="4572000"/>
-          </a:xfrm>
-          <a:prstGeom prst="rect">
-            <a:avLst/>
-          </a:prstGeom>
-          <a:noFill/>
-        </p:spPr>
-        <p:txBody>
-          <a:bodyPr wrap="square">
-            <a:spAutoFit/>
-          </a:bodyPr>
-          <a:lstStyle/>
-          <a:p>
-            <a:pPr>
-              <a:spcAft>
-                <a:spcPts val="900"/>
-              </a:spcAft>
-            </a:pPr>
-            <a:r>
-              <a:rPr sz="1300" b="1" i="0">
-                <a:solidFill>
-                  <a:srgbClr val="1A1A1A"/>
-                </a:solidFill>
-                <a:latin typeface="Calibri"/>
-              </a:rPr>
-              <a:t>What I would watch</a:t>
-            </a:r>
-          </a:p>
-          <a:p>
-            <a:pPr lvl="1">
-              <a:spcAft>
-                <a:spcPts val="900"/>
-              </a:spcAft>
-            </a:pPr>
-            <a:r>
-              <a:rPr sz="1100" b="0" i="0">
-                <a:solidFill>
-                  <a:srgbClr val="5A6270"/>
-                </a:solidFill>
-                <a:latin typeface="Calibri"/>
-              </a:rPr>
-              <a:t>Whether the incoming data still looks like the data we trained on. Checked weekly.</a:t>
-            </a:r>
-          </a:p>
-          <a:p>
-            <a:pPr lvl="1">
-              <a:spcAft>
-                <a:spcPts val="900"/>
-              </a:spcAft>
-            </a:pPr>
-            <a:r>
-              <a:rPr sz="1100" b="0" i="0">
-                <a:solidFill>
-                  <a:srgbClr val="5A6270"/>
-                </a:solidFill>
-                <a:latin typeface="Calibri"/>
-              </a:rPr>
-              <a:t>Whether columns have gone missing or empty. Checked daily, and the job fails if the shape changes.</a:t>
-            </a:r>
-          </a:p>
-          <a:p>
-            <a:pPr lvl="1">
-              <a:spcAft>
-                <a:spcPts val="900"/>
-              </a:spcAft>
-            </a:pPr>
-            <a:r>
-              <a:rPr sz="1100" b="0" i="0">
-                <a:solidFill>
-                  <a:srgbClr val="5A6270"/>
-                </a:solidFill>
-                <a:latin typeface="Calibri"/>
-              </a:rPr>
-              <a:t>The leakage checks. Run every single time, and they stop the job.</a:t>
-            </a:r>
-          </a:p>
-          <a:p>
-            <a:pPr lvl="1">
-              <a:spcAft>
-                <a:spcPts val="900"/>
-              </a:spcAft>
-            </a:pPr>
-            <a:r>
-              <a:rPr sz="1100" b="0" i="0">
-                <a:solidFill>
-                  <a:srgbClr val="5A6270"/>
-                </a:solidFill>
-                <a:latin typeface="Calibri"/>
-              </a:rPr>
-              <a:t>Whether the scores themselves have drifted. Checked weekly.</a:t>
-            </a:r>
-          </a:p>
-          <a:p>
-            <a:pPr lvl="1">
-              <a:spcAft>
-                <a:spcPts val="900"/>
-              </a:spcAft>
-            </a:pPr>
-            <a:r>
-              <a:rPr sz="1100" b="0" i="0">
-                <a:solidFill>
-                  <a:srgbClr val="5A6270"/>
-                </a:solidFill>
-                <a:latin typeface="Calibri"/>
-              </a:rPr>
-              <a:t>Whether the model is still accurate. Checked every quarter, once we know who actually left.</a:t>
-            </a:r>
-          </a:p>
-          <a:p>
-            <a:pPr>
-              <a:spcAft>
-                <a:spcPts val="900"/>
-              </a:spcAft>
-            </a:pPr>
-            <a:r>
-              <a:rPr sz="600" b="0" i="0">
-                <a:solidFill>
-                  <a:srgbClr val="1A1A1A"/>
-                </a:solidFill>
-                <a:latin typeface="Calibri"/>
-              </a:rPr>
-              <a:t> </a:t>
-            </a:r>
-          </a:p>
-          <a:p>
-            <a:pPr>
-              <a:spcAft>
-                <a:spcPts val="900"/>
-              </a:spcAft>
-            </a:pPr>
-            <a:r>
-              <a:rPr sz="1300" b="0" i="0">
-                <a:solidFill>
-                  <a:srgbClr val="5A6270"/>
-                </a:solidFill>
-                <a:latin typeface="Calibri"/>
-              </a:rPr>
-              <a:t>We only learn if we were right 90 days later. So accuracy checks are always late. Watching the incoming data is the early warning, and accuracy confirms it afterwards.</a:t>
-            </a:r>
-          </a:p>
-          <a:p>
-            <a:pPr>
-              <a:spcAft>
-                <a:spcPts val="900"/>
-              </a:spcAft>
-            </a:pPr>
-            <a:r>
-              <a:rPr sz="600" b="0" i="0">
-                <a:solidFill>
-                  <a:srgbClr val="1A1A1A"/>
-                </a:solidFill>
-                <a:latin typeface="Calibri"/>
-              </a:rPr>
-              <a:t> </a:t>
-            </a:r>
-          </a:p>
-          <a:p>
-            <a:pPr>
-              <a:spcAft>
-                <a:spcPts val="900"/>
-              </a:spcAft>
-            </a:pPr>
-            <a:r>
-              <a:rPr sz="1300" b="1" i="0">
-                <a:solidFill>
-                  <a:srgbClr val="2E5F8A"/>
-                </a:solidFill>
-                <a:latin typeface="Calibri"/>
-              </a:rPr>
-              <a:t>The part I would argue for hardest is running the leakage checks in production. The bug in this project was in the pipeline, and pipeline bugs come back every time someone adds a feature.</a:t>
-            </a:r>
-          </a:p>
-        </p:txBody>
-      </p:sp>
-      <p:sp>
-        <p:nvSpPr>
-          <p:cNvPr id="6" name="TextBox 5"/>
-          <p:cNvSpPr txBox="1"/>
-          <p:nvPr/>
-        </p:nvSpPr>
-        <p:spPr>
-          <a:xfrm>
-            <a:off x="685800" y="6126480"/>
-            <a:ext cx="10820095" cy="502920"/>
-          </a:xfrm>
-          <a:prstGeom prst="rect">
-            <a:avLst/>
-          </a:prstGeom>
-          <a:noFill/>
-        </p:spPr>
-        <p:txBody>
-          <a:bodyPr wrap="square">
-            <a:spAutoFit/>
-          </a:bodyPr>
-          <a:lstStyle/>
-          <a:p>
-            <a:r>
-              <a:rPr sz="1150" b="0" i="1">
-                <a:solidFill>
-                  <a:srgbClr val="1A1A1A"/>
-                </a:solidFill>
-                <a:latin typeface="Calibri"/>
-              </a:rPr>
-              <a:t>This is what I would build if the model were worth shipping. On these results it is not, and this extract cannot be repaired into one — the timestamps have to be collected against the right customers, not corrected. Once they are, the pipeline takes a date, so re-measuring is one command.</a:t>
-            </a:r>
-          </a:p>
-        </p:txBody>
-      </p:sp>
     </p:spTree>
   </p:cSld>
   <p:clrMapOvr>
@@ -11928,7 +11455,7 @@
         <p:spPr>
           <a:xfrm>
             <a:off x="685800" y="365760"/>
-            <a:ext cx="10820095" cy="1051560"/>
+            <a:ext cx="10820095" cy="759182"/>
           </a:xfrm>
           <a:prstGeom prst="rect">
             <a:avLst/>
@@ -11942,7 +11469,7 @@
           <a:lstStyle/>
           <a:p>
             <a:r>
-              <a:rPr sz="1200" b="1" i="0">
+              <a:rPr sz="1200" b="1" i="0" dirty="0">
                 <a:solidFill>
                   <a:srgbClr val="5A6270"/>
                 </a:solidFill>
@@ -11958,14 +11485,20 @@
               </a:spcBef>
             </a:pPr>
             <a:r>
-              <a:rPr sz="2800" b="1" i="0">
+              <a:rPr lang="en-US" sz="2800" b="1" i="0" dirty="0">
                 <a:solidFill>
                   <a:srgbClr val="1A1A1A"/>
                 </a:solidFill>
                 <a:latin typeface="Calibri"/>
               </a:rPr>
-              <a:t>Every field, one at a time</a:t>
-            </a:r>
+              <a:t>Basic EDA</a:t>
+            </a:r>
+            <a:endParaRPr sz="2800" b="1" i="0" dirty="0">
+              <a:solidFill>
+                <a:srgbClr val="1A1A1A"/>
+              </a:solidFill>
+              <a:latin typeface="Calibri"/>
+            </a:endParaRPr>
           </a:p>
         </p:txBody>
       </p:sp>
@@ -12321,7 +11854,7 @@
                   <a:srgbClr val="5A6270"/>
                 </a:solidFill>
               </a:rPr>
-              <a:t>Red lines: The gap we observed|. For industry: the highest-churn industry (EdTech, 41%) minus the lowest (Cybersecurity, 9%) = 32 points.</a:t>
+              <a:t>Red lines: The gap we observed. For industry: the highest-churn industry (EdTech, 41%) minus the lowest (Cybersecurity, 9%) = 32 points.</a:t>
             </a:r>
           </a:p>
           <a:p>

</xml_diff>

<commit_message>
Revise presentation materials with updated insights and visual enhancements
- Updated `build_main_deck.py` to reflect new recommendations on customer churn, emphasizing the importance of calling all at-risk customers and the limitations of ranking.
- Enhanced figures in `fig_breakeven_html.py` and `fig_what_to_do_html.py` to visually represent key findings, including the economic rationale behind calling strategies.
- Improved HTML outputs for clarity and presentation, ensuring alignment with the latest insights.
- Updated `AvePoint_Case_Study.pptx` to incorporate these changes, enhancing the overall effectiveness of the presentation.

These modifications aim to provide a clearer understanding of customer retention strategies and improve the visual communication of findings.
</commit_message>
<xml_diff>
--- a/outputs/decks/AvePoint_Case_Study.pptx
+++ b/outputs/decks/AvePoint_Case_Study.pptx
@@ -22,9 +22,9 @@
     <p:sldId id="263" r:id="rId13"/>
     <p:sldId id="264" r:id="rId14"/>
     <p:sldId id="282" r:id="rId15"/>
-    <p:sldId id="267" r:id="rId16"/>
-    <p:sldId id="266" r:id="rId17"/>
-    <p:sldId id="283" r:id="rId18"/>
+    <p:sldId id="266" r:id="rId16"/>
+    <p:sldId id="284" r:id="rId17"/>
+    <p:sldId id="285" r:id="rId18"/>
     <p:sldId id="271" r:id="rId19"/>
   </p:sldIdLst>
   <p:sldSz cx="12192000" cy="6858000"/>
@@ -146,7 +146,7 @@
 <file path=ppt/revisionInfo.xml><?xml version="1.0" encoding="utf-8"?>
 <p1510:revInfo xmlns:a="http://schemas.openxmlformats.org/drawingml/2006/main" xmlns:r="http://schemas.openxmlformats.org/officeDocument/2006/relationships" xmlns:p1510="http://schemas.microsoft.com/office/powerpoint/2015/10/main">
   <p1510:revLst>
-    <p1510:client id="{25DC7B8B-EC09-4841-A573-8FF6489E0CC5}" v="168" dt="2026-07-29T16:27:33.826"/>
+    <p1510:client id="{25DC7B8B-EC09-4841-A573-8FF6489E0CC5}" v="170" dt="2026-07-29T21:01:24.889"/>
   </p1510:revLst>
 </p1510:revInfo>
 </file>
@@ -156,7 +156,7 @@
   <pc:docChgLst>
     <pc:chgData name="Dmitriy Ratushny" userId="08050032e8047aee" providerId="LiveId" clId="{78EB1A6D-D3A9-4525-A4D5-A50D4E20D487}"/>
     <pc:docChg chg="undo custSel addSld delSld modSld sldOrd">
-      <pc:chgData name="Dmitriy Ratushny" userId="08050032e8047aee" providerId="LiveId" clId="{78EB1A6D-D3A9-4525-A4D5-A50D4E20D487}" dt="2026-07-29T16:29:17.780" v="3481"/>
+      <pc:chgData name="Dmitriy Ratushny" userId="08050032e8047aee" providerId="LiveId" clId="{78EB1A6D-D3A9-4525-A4D5-A50D4E20D487}" dt="2026-07-29T21:02:14.766" v="3518" actId="1076"/>
       <pc:docMkLst>
         <pc:docMk/>
       </pc:docMkLst>
@@ -654,7 +654,7 @@
         </pc:picChg>
       </pc:sldChg>
       <pc:sldChg chg="delSp modSp add del mod ord">
-        <pc:chgData name="Dmitriy Ratushny" userId="08050032e8047aee" providerId="LiveId" clId="{78EB1A6D-D3A9-4525-A4D5-A50D4E20D487}" dt="2026-07-29T16:29:17.780" v="3481"/>
+        <pc:chgData name="Dmitriy Ratushny" userId="08050032e8047aee" providerId="LiveId" clId="{78EB1A6D-D3A9-4525-A4D5-A50D4E20D487}" dt="2026-07-29T21:01:28.070" v="3515" actId="47"/>
         <pc:sldMkLst>
           <pc:docMk/>
           <pc:sldMk cId="0" sldId="267"/>
@@ -1087,11 +1087,27 @@
         </pc:picChg>
       </pc:sldChg>
       <pc:sldChg chg="delSp modSp add del mod ord">
-        <pc:chgData name="Dmitriy Ratushny" userId="08050032e8047aee" providerId="LiveId" clId="{78EB1A6D-D3A9-4525-A4D5-A50D4E20D487}" dt="2026-07-29T16:26:30.223" v="3471"/>
+        <pc:chgData name="Dmitriy Ratushny" userId="08050032e8047aee" providerId="LiveId" clId="{78EB1A6D-D3A9-4525-A4D5-A50D4E20D487}" dt="2026-07-29T20:28:43.110" v="3487" actId="47"/>
         <pc:sldMkLst>
           <pc:docMk/>
           <pc:sldMk cId="0" sldId="283"/>
         </pc:sldMkLst>
+        <pc:spChg chg="mod">
+          <ac:chgData name="Dmitriy Ratushny" userId="08050032e8047aee" providerId="LiveId" clId="{78EB1A6D-D3A9-4525-A4D5-A50D4E20D487}" dt="2026-07-29T19:51:00.729" v="3484" actId="1076"/>
+          <ac:spMkLst>
+            <pc:docMk/>
+            <pc:sldMk cId="0" sldId="283"/>
+            <ac:spMk id="3" creationId="{00000000-0000-0000-0000-000000000000}"/>
+          </ac:spMkLst>
+        </pc:spChg>
+        <pc:spChg chg="mod">
+          <ac:chgData name="Dmitriy Ratushny" userId="08050032e8047aee" providerId="LiveId" clId="{78EB1A6D-D3A9-4525-A4D5-A50D4E20D487}" dt="2026-07-29T19:50:52.522" v="3482" actId="1076"/>
+          <ac:spMkLst>
+            <pc:docMk/>
+            <pc:sldMk cId="0" sldId="283"/>
+            <ac:spMk id="5" creationId="{00000000-0000-0000-0000-000000000000}"/>
+          </ac:spMkLst>
+        </pc:spChg>
         <pc:spChg chg="del mod">
           <ac:chgData name="Dmitriy Ratushny" userId="08050032e8047aee" providerId="LiveId" clId="{78EB1A6D-D3A9-4525-A4D5-A50D4E20D487}" dt="2026-07-29T14:59:33.455" v="3257" actId="478"/>
           <ac:spMkLst>
@@ -1100,6 +1116,60 @@
             <ac:spMk id="6" creationId="{00000000-0000-0000-0000-000000000000}"/>
           </ac:spMkLst>
         </pc:spChg>
+        <pc:picChg chg="mod">
+          <ac:chgData name="Dmitriy Ratushny" userId="08050032e8047aee" providerId="LiveId" clId="{78EB1A6D-D3A9-4525-A4D5-A50D4E20D487}" dt="2026-07-29T19:51:04.359" v="3485" actId="1076"/>
+          <ac:picMkLst>
+            <pc:docMk/>
+            <pc:sldMk cId="0" sldId="283"/>
+            <ac:picMk id="4" creationId="{00000000-0000-0000-0000-000000000000}"/>
+          </ac:picMkLst>
+        </pc:picChg>
+      </pc:sldChg>
+      <pc:sldChg chg="modSp add mod">
+        <pc:chgData name="Dmitriy Ratushny" userId="08050032e8047aee" providerId="LiveId" clId="{78EB1A6D-D3A9-4525-A4D5-A50D4E20D487}" dt="2026-07-29T20:43:38.057" v="3513" actId="20577"/>
+        <pc:sldMkLst>
+          <pc:docMk/>
+          <pc:sldMk cId="0" sldId="284"/>
+        </pc:sldMkLst>
+        <pc:spChg chg="mod">
+          <ac:chgData name="Dmitriy Ratushny" userId="08050032e8047aee" providerId="LiveId" clId="{78EB1A6D-D3A9-4525-A4D5-A50D4E20D487}" dt="2026-07-29T20:43:38.057" v="3513" actId="20577"/>
+          <ac:spMkLst>
+            <pc:docMk/>
+            <pc:sldMk cId="0" sldId="284"/>
+            <ac:spMk id="2" creationId="{00000000-0000-0000-0000-000000000000}"/>
+          </ac:spMkLst>
+        </pc:spChg>
+        <pc:spChg chg="mod">
+          <ac:chgData name="Dmitriy Ratushny" userId="08050032e8047aee" providerId="LiveId" clId="{78EB1A6D-D3A9-4525-A4D5-A50D4E20D487}" dt="2026-07-29T20:30:20.771" v="3496" actId="20577"/>
+          <ac:spMkLst>
+            <pc:docMk/>
+            <pc:sldMk cId="0" sldId="284"/>
+            <ac:spMk id="5" creationId="{00000000-0000-0000-0000-000000000000}"/>
+          </ac:spMkLst>
+        </pc:spChg>
+        <pc:spChg chg="mod">
+          <ac:chgData name="Dmitriy Ratushny" userId="08050032e8047aee" providerId="LiveId" clId="{78EB1A6D-D3A9-4525-A4D5-A50D4E20D487}" dt="2026-07-29T20:31:09.746" v="3511" actId="20577"/>
+          <ac:spMkLst>
+            <pc:docMk/>
+            <pc:sldMk cId="0" sldId="284"/>
+            <ac:spMk id="6" creationId="{00000000-0000-0000-0000-000000000000}"/>
+          </ac:spMkLst>
+        </pc:spChg>
+      </pc:sldChg>
+      <pc:sldChg chg="modSp add mod ord">
+        <pc:chgData name="Dmitriy Ratushny" userId="08050032e8047aee" providerId="LiveId" clId="{78EB1A6D-D3A9-4525-A4D5-A50D4E20D487}" dt="2026-07-29T21:02:14.766" v="3518" actId="1076"/>
+        <pc:sldMkLst>
+          <pc:docMk/>
+          <pc:sldMk cId="0" sldId="285"/>
+        </pc:sldMkLst>
+        <pc:picChg chg="mod">
+          <ac:chgData name="Dmitriy Ratushny" userId="08050032e8047aee" providerId="LiveId" clId="{78EB1A6D-D3A9-4525-A4D5-A50D4E20D487}" dt="2026-07-29T21:02:14.766" v="3518" actId="1076"/>
+          <ac:picMkLst>
+            <pc:docMk/>
+            <pc:sldMk cId="0" sldId="285"/>
+            <ac:picMk id="4" creationId="{00000000-0000-0000-0000-000000000000}"/>
+          </ac:picMkLst>
+        </pc:picChg>
       </pc:sldChg>
     </pc:docChg>
   </pc:docChgLst>
@@ -1351,13 +1421,6 @@
           </p:nvPr>
         </p:nvSpPr>
         <p:spPr/>
-        <p:txBody>
-          <a:bodyPr/>
-          <a:lstStyle/>
-          <a:p>
-            <a:endParaRPr lang="en-US"/>
-          </a:p>
-        </p:txBody>
       </p:sp>
       <p:sp>
         <p:nvSpPr>
@@ -1375,47 +1438,7 @@
           <a:lstStyle/>
           <a:p>
             <a:r>
-              <a:t>This is the slide I would want to be asked about.</a:t>
-            </a:r>
-          </a:p>
-          <a:p>
-            <a:endParaRPr/>
-          </a:p>
-          <a:p>
-            <a:r>
-              <a:t>How the artefact works: no churn date can land after 2024-12-31. If each is drawn uniformly between signup and that boundary, the hazard is 1/(END - t), which rises without limit as t approaches the end. Pooled across accounts that signed up over two years, that is indistinguishable by eye from a business problem.</a:t>
-            </a:r>
-          </a:p>
-          <a:p>
-            <a:endParaRPr/>
-          </a:p>
-          <a:p>
-            <a:r>
-              <a:t>The evidence, in order. Rescale each churn date to its position in the account's own window: uniform, KS p = 0.92 on 600 events, mean position 0.503, and uniform inside every signup quarter. Then the simulation — keep each account's real signup date and real number of churn events, redraw only the dates, run the same survival.calendar_hazard used to produce the original claim, 400 times. Observed rate ratio 1.0893, null 1.0885 with a 95% band of [1.072, 1.106].</a:t>
-            </a:r>
-          </a:p>
-          <a:p>
-            <a:endParaRPr/>
-          </a:p>
-          <a:p>
-            <a:r>
-              <a:t>The p-value is the part worth dwelling on. p = 2e-16 felt like the most secure number I had. The null rule produces a median p of 2.8e-16 — very slightly more significant than the real data. A p-value tells you nothing about whether the null it tests is the one that matters.</a:t>
-            </a:r>
-          </a:p>
-          <a:p>
-            <a:endParaRPr/>
-          </a:p>
-          <a:p>
-            <a:r>
-              <a:t>If asked what I would have done differently: run this before writing the recommendation, not after. On any generated or vendor-supplied extract, simulate the file before trusting a time trend in it.</a:t>
-            </a:r>
-          </a:p>
-          <a:p>
-            <a:endParaRPr/>
-          </a:p>
-          <a:p>
-            <a:r>
-              <a:t>src/generator.py, notebook 16.</a:t>
+              <a:t>TN +$150 vs FN -$1,310 → need ~9:1. Value sweep: +$600 on $52,400.</a:t>
             </a:r>
           </a:p>
         </p:txBody>
@@ -1431,13 +1454,6 @@
           </p:nvPr>
         </p:nvSpPr>
         <p:spPr/>
-        <p:txBody>
-          <a:bodyPr/>
-          <a:lstStyle/>
-          <a:p>
-            <a:endParaRPr lang="en-US"/>
-          </a:p>
-        </p:txBody>
       </p:sp>
     </p:spTree>
   </p:cSld>
@@ -1492,7 +1508,7 @@
           <a:lstStyle/>
           <a:p>
             <a:r>
-              <a:t>Replaces the break-even heatmap, which swept call cost against customer value across sixteen cells. The sweep asked the reader to find their cell, compare it against a base rate printed in the title, and infer the conclusion themselves.</a:t>
+              <a:t>Constructive reframing of the summary slide.</a:t>
             </a:r>
           </a:p>
           <a:p>
@@ -1500,7 +1516,7 @@
           </a:p>
           <a:p>
             <a:r>
-              <a:t>Only two cells of that grid ever mattered, and they are now stated as the two points where the decision flips: $446 a call, or $2,459 a customer.</a:t>
+              <a:t>Do-this leads with treat-all NPV as a positive finding and the 9:1 skip bar; adds experiment sizing (15pp / 15 months).</a:t>
             </a:r>
           </a:p>
           <a:p>
@@ -1508,7 +1524,7 @@
           </a:p>
           <a:p>
             <a:r>
-              <a:t>Both inputs are assumptions, not measurements. DEFAULT_INTERVENTION_COST = 150 and DEFAULT_EFFECTIVENESS = 0.20 in src/economics.py; nothing in the data supports either. Say so before being asked. The conclusion survives a wide range of both, which is what the two flip points are there to show.</a:t>
+              <a:t>Do-not softens onboarding to tenure-targeted only; keeps calendar + SHAP nulls.</a:t>
             </a:r>
           </a:p>
           <a:p>
@@ -1516,7 +1532,15 @@
           </a:p>
           <a:p>
             <a:r>
-              <a:t>Numbers from outputs/reports/retention_economics.csv. The figure is built by build/fig_breakeven_html.py.</a:t>
+              <a:t>Fix-this scopes the data ask: usage/tickets poison (AUC 0.41) vs billing usable; 0.63 when dropped is the modelling silver lining, flagged in the footnote as post-hoc.</a:t>
+            </a:r>
+          </a:p>
+          <a:p>
+            <a:endParaRPr/>
+          </a:p>
+          <a:p>
+            <a:r>
+              <a:t>Built by build/fig_what_to_do_html.py.</a:t>
             </a:r>
           </a:p>
         </p:txBody>
@@ -2289,6 +2313,13 @@
           </p:nvPr>
         </p:nvSpPr>
         <p:spPr/>
+        <p:txBody>
+          <a:bodyPr/>
+          <a:lstStyle/>
+          <a:p>
+            <a:endParaRPr lang="en-US"/>
+          </a:p>
+        </p:txBody>
       </p:sp>
       <p:sp>
         <p:nvSpPr>
@@ -2306,7 +2337,7 @@
           <a:lstStyle/>
           <a:p>
             <a:r>
-              <a:t>The slide to present if there is only time for one. Everything else in Part 4 is the working behind a column of this.</a:t>
+              <a:t>This is the slide I would want to be asked about.</a:t>
             </a:r>
           </a:p>
           <a:p>
@@ -2314,7 +2345,7 @@
           </a:p>
           <a:p>
             <a:r>
-              <a:t>The three columns are deliberately in that order. A hiring panel wants to hear an action before it hears a caveat, and the data request lands better once they have seen why the obvious moves are wrong.</a:t>
+              <a:t>How the artefact works: no churn date can land after 2024-12-31. If each is drawn uniformly between signup and that boundary, the hazard is 1/(END - t), which rises without limit as t approaches the end. Pooled across accounts that signed up over two years, that is indistinguishable by eye from a business problem.</a:t>
             </a:r>
           </a:p>
           <a:p>
@@ -2322,7 +2353,7 @@
           </a:p>
           <a:p>
             <a:r>
-              <a:t>No currency appears. The repo carries an illustrative call cost and success rate, neither of which is in the data, so the break-even is stated as a ratio instead.</a:t>
+              <a:t>The evidence, in order. Rescale each churn date to its position in the account's own window: uniform, KS p = 0.92 on 600 events, mean position 0.503, and uniform inside every signup quarter. Then the simulation — keep each account's real signup date and real number of churn events, redraw only the dates, run the same survival.calendar_hazard used to produce the original claim, 400 times. Observed rate ratio 1.0893, null 1.0885 with a 95% band of [1.072, 1.106].</a:t>
             </a:r>
           </a:p>
           <a:p>
@@ -2330,7 +2361,23 @@
           </a:p>
           <a:p>
             <a:r>
-              <a:t>Built by build/fig_what_to_do_html.py.</a:t>
+              <a:t>The p-value is the part worth dwelling on. p = 2e-16 felt like the most secure number I had. The null rule produces a median p of 2.8e-16 — very slightly more significant than the real data. A p-value tells you nothing about whether the null it tests is the one that matters.</a:t>
+            </a:r>
+          </a:p>
+          <a:p>
+            <a:endParaRPr/>
+          </a:p>
+          <a:p>
+            <a:r>
+              <a:t>If asked what I would have done differently: run this before writing the recommendation, not after. On any generated or vendor-supplied extract, simulate the file before trusting a time trend in it.</a:t>
+            </a:r>
+          </a:p>
+          <a:p>
+            <a:endParaRPr/>
+          </a:p>
+          <a:p>
+            <a:r>
+              <a:t>src/generator.py, notebook 16.</a:t>
             </a:r>
           </a:p>
         </p:txBody>
@@ -2346,6 +2393,13 @@
           </p:nvPr>
         </p:nvSpPr>
         <p:spPr/>
+        <p:txBody>
+          <a:bodyPr/>
+          <a:lstStyle/>
+          <a:p>
+            <a:endParaRPr lang="en-US"/>
+          </a:p>
+        </p:txBody>
       </p:sp>
     </p:spTree>
   </p:cSld>
@@ -7157,239 +7211,6 @@
         <p:spPr>
           <a:xfrm>
             <a:off x="685800" y="365760"/>
-            <a:ext cx="10820095" cy="1051560"/>
-          </a:xfrm>
-          <a:prstGeom prst="rect">
-            <a:avLst/>
-          </a:prstGeom>
-          <a:noFill/>
-        </p:spPr>
-        <p:txBody>
-          <a:bodyPr wrap="square">
-            <a:spAutoFit/>
-          </a:bodyPr>
-          <a:lstStyle/>
-          <a:p>
-            <a:r>
-              <a:rPr sz="1200" b="1" i="0">
-                <a:solidFill>
-                  <a:srgbClr val="5A6270"/>
-                </a:solidFill>
-                <a:latin typeface="Calibri"/>
-              </a:rPr>
-              <a:t>PART 4 · RECOMMENDATIONS</a:t>
-            </a:r>
-          </a:p>
-          <a:p>
-            <a:pPr>
-              <a:spcBef>
-                <a:spcPts val="400"/>
-              </a:spcBef>
-            </a:pPr>
-            <a:r>
-              <a:rPr sz="2800" b="1" i="0">
-                <a:solidFill>
-                  <a:srgbClr val="1A1A1A"/>
-                </a:solidFill>
-                <a:latin typeface="Calibri"/>
-              </a:rPr>
-              <a:t>What to do about churn</a:t>
-            </a:r>
-          </a:p>
-        </p:txBody>
-      </p:sp>
-      <p:sp>
-        <p:nvSpPr>
-          <p:cNvPr id="3" name="Rectangle 2"/>
-          <p:cNvSpPr/>
-          <p:nvPr/>
-        </p:nvSpPr>
-        <p:spPr>
-          <a:xfrm>
-            <a:off x="685800" y="1426464"/>
-            <a:ext cx="10820095" cy="9525"/>
-          </a:xfrm>
-          <a:prstGeom prst="rect">
-            <a:avLst/>
-          </a:prstGeom>
-          <a:solidFill>
-            <a:srgbClr val="D8DCE0"/>
-          </a:solidFill>
-          <a:ln>
-            <a:noFill/>
-          </a:ln>
-          <a:effectLst/>
-        </p:spPr>
-        <p:style>
-          <a:lnRef idx="1">
-            <a:schemeClr val="accent1"/>
-          </a:lnRef>
-          <a:fillRef idx="3">
-            <a:schemeClr val="accent1"/>
-          </a:fillRef>
-          <a:effectRef idx="2">
-            <a:schemeClr val="accent1"/>
-          </a:effectRef>
-          <a:fontRef idx="minor">
-            <a:schemeClr val="lt1"/>
-          </a:fontRef>
-        </p:style>
-        <p:txBody>
-          <a:bodyPr rtlCol="0" anchor="ctr"/>
-          <a:lstStyle/>
-          <a:p>
-            <a:pPr algn="ctr"/>
-            <a:endParaRPr/>
-          </a:p>
-        </p:txBody>
-      </p:sp>
-      <p:pic>
-        <p:nvPicPr>
-          <p:cNvPr id="4" name="Picture 3" descr="15_what_to_do.png"/>
-          <p:cNvPicPr>
-            <a:picLocks noChangeAspect="1"/>
-          </p:cNvPicPr>
-          <p:nvPr/>
-        </p:nvPicPr>
-        <p:blipFill>
-          <a:blip r:embed="rId3"/>
-          <a:stretch>
-            <a:fillRect/>
-          </a:stretch>
-        </p:blipFill>
-        <p:spPr>
-          <a:xfrm>
-            <a:off x="848694" y="1627632"/>
-            <a:ext cx="10494306" cy="3246120"/>
-          </a:xfrm>
-          <a:prstGeom prst="rect">
-            <a:avLst/>
-          </a:prstGeom>
-        </p:spPr>
-      </p:pic>
-      <p:sp>
-        <p:nvSpPr>
-          <p:cNvPr id="5" name="TextBox 4"/>
-          <p:cNvSpPr txBox="1"/>
-          <p:nvPr/>
-        </p:nvSpPr>
-        <p:spPr>
-          <a:xfrm>
-            <a:off x="685800" y="5138928"/>
-            <a:ext cx="10820095" cy="4572000"/>
-          </a:xfrm>
-          <a:prstGeom prst="rect">
-            <a:avLst/>
-          </a:prstGeom>
-          <a:noFill/>
-        </p:spPr>
-        <p:txBody>
-          <a:bodyPr wrap="square">
-            <a:spAutoFit/>
-          </a:bodyPr>
-          <a:lstStyle/>
-          <a:p>
-            <a:pPr>
-              <a:spcAft>
-                <a:spcPts val="400"/>
-              </a:spcAft>
-            </a:pPr>
-            <a:r>
-              <a:rPr sz="1350" b="1" i="0">
-                <a:solidFill>
-                  <a:srgbClr val="1A1A1A"/>
-                </a:solidFill>
-                <a:latin typeface="Calibri"/>
-              </a:rPr>
-              <a:t>Three things follow from this work, and none of them needs a model.</a:t>
-            </a:r>
-          </a:p>
-          <a:p>
-            <a:pPr lvl="1">
-              <a:spcAft>
-                <a:spcPts val="400"/>
-              </a:spcAft>
-            </a:pPr>
-            <a:r>
-              <a:rPr sz="1150" b="0" i="0">
-                <a:solidFill>
-                  <a:srgbClr val="5A6270"/>
-                </a:solidFill>
-                <a:latin typeface="Calibri"/>
-              </a:rPr>
-              <a:t>Call everybody at risk, because at a 31% churn rate the decision is already right for every customer. Do not spend on the two things the data appears to recommend, because both come from the same artefact. Fix three things in the export and the question becomes answerable.</a:t>
-            </a:r>
-          </a:p>
-        </p:txBody>
-      </p:sp>
-      <p:sp>
-        <p:nvSpPr>
-          <p:cNvPr id="6" name="TextBox 5"/>
-          <p:cNvSpPr txBox="1"/>
-          <p:nvPr/>
-        </p:nvSpPr>
-        <p:spPr>
-          <a:xfrm>
-            <a:off x="685800" y="6126480"/>
-            <a:ext cx="10820095" cy="502920"/>
-          </a:xfrm>
-          <a:prstGeom prst="rect">
-            <a:avLst/>
-          </a:prstGeom>
-          <a:noFill/>
-        </p:spPr>
-        <p:txBody>
-          <a:bodyPr wrap="square">
-            <a:spAutoFit/>
-          </a:bodyPr>
-          <a:lstStyle/>
-          <a:p>
-            <a:r>
-              <a:rPr sz="1150" b="0" i="1">
-                <a:solidFill>
-                  <a:srgbClr val="5A6270"/>
-                </a:solidFill>
-                <a:latin typeface="Calibri"/>
-              </a:rPr>
-              <a:t>Every number here is a count from the tables. Nothing is modelled and nothing is assumed.</a:t>
-            </a:r>
-          </a:p>
-        </p:txBody>
-      </p:sp>
-    </p:spTree>
-  </p:cSld>
-  <p:clrMapOvr>
-    <a:masterClrMapping/>
-  </p:clrMapOvr>
-</p:sld>
-</file>
-
-<file path=ppt/slides/slide16.xml><?xml version="1.0" encoding="utf-8"?>
-<p:sld xmlns:a="http://schemas.openxmlformats.org/drawingml/2006/main" xmlns:r="http://schemas.openxmlformats.org/officeDocument/2006/relationships" xmlns:p="http://schemas.openxmlformats.org/presentationml/2006/main">
-  <p:cSld>
-    <p:spTree>
-      <p:nvGrpSpPr>
-        <p:cNvPr id="1" name=""/>
-        <p:cNvGrpSpPr/>
-        <p:nvPr/>
-      </p:nvGrpSpPr>
-      <p:grpSpPr>
-        <a:xfrm>
-          <a:off x="0" y="0"/>
-          <a:ext cx="0" cy="0"/>
-          <a:chOff x="0" y="0"/>
-          <a:chExt cx="0" cy="0"/>
-        </a:xfrm>
-      </p:grpSpPr>
-      <p:sp>
-        <p:nvSpPr>
-          <p:cNvPr id="2" name="TextBox 1"/>
-          <p:cNvSpPr txBox="1"/>
-          <p:nvPr/>
-        </p:nvSpPr>
-        <p:spPr>
-          <a:xfrm>
-            <a:off x="685800" y="365760"/>
             <a:ext cx="10820095" cy="759182"/>
           </a:xfrm>
           <a:prstGeom prst="rect">
@@ -7676,7 +7497,7 @@
 </p:sld>
 </file>
 
-<file path=ppt/slides/slide17.xml><?xml version="1.0" encoding="utf-8"?>
+<file path=ppt/slides/slide16.xml><?xml version="1.0" encoding="utf-8"?>
 <p:sld xmlns:a="http://schemas.openxmlformats.org/drawingml/2006/main" xmlns:r="http://schemas.openxmlformats.org/officeDocument/2006/relationships" xmlns:p="http://schemas.openxmlformats.org/presentationml/2006/main">
   <p:cSld>
     <p:spTree>
@@ -7702,7 +7523,7 @@
         <p:spPr>
           <a:xfrm>
             <a:off x="685800" y="365760"/>
-            <a:ext cx="10820095" cy="1051560"/>
+            <a:ext cx="10820095" cy="759182"/>
           </a:xfrm>
           <a:prstGeom prst="rect">
             <a:avLst/>
@@ -7716,14 +7537,29 @@
           <a:lstStyle/>
           <a:p>
             <a:r>
-              <a:rPr sz="1200" b="1" i="0">
+              <a:rPr sz="1200" b="1" i="0" dirty="0">
                 <a:solidFill>
                   <a:srgbClr val="5A6270"/>
                 </a:solidFill>
                 <a:latin typeface="Calibri"/>
               </a:rPr>
-              <a:t>PART 4 · RECOMMENDATION 3</a:t>
-            </a:r>
+              <a:t>PART 4 · RECOMMENDATION </a:t>
+            </a:r>
+            <a:r>
+              <a:rPr lang="en-US" sz="1200" b="1" i="0" dirty="0">
+                <a:solidFill>
+                  <a:srgbClr val="5A6270"/>
+                </a:solidFill>
+                <a:latin typeface="Calibri"/>
+              </a:rPr>
+              <a:t>2</a:t>
+            </a:r>
+            <a:endParaRPr sz="1200" b="1" i="0" dirty="0">
+              <a:solidFill>
+                <a:srgbClr val="5A6270"/>
+              </a:solidFill>
+              <a:latin typeface="Calibri"/>
+            </a:endParaRPr>
           </a:p>
           <a:p>
             <a:pPr>
@@ -7732,7 +7568,7 @@
               </a:spcBef>
             </a:pPr>
             <a:r>
-              <a:rPr sz="2800" b="1" i="0">
+              <a:rPr sz="2800" b="1" i="0" dirty="0">
                 <a:solidFill>
                   <a:srgbClr val="1A1A1A"/>
                 </a:solidFill>
@@ -7804,8 +7640,8 @@
         </p:blipFill>
         <p:spPr>
           <a:xfrm>
-            <a:off x="2534703" y="1554480"/>
-            <a:ext cx="7122289" cy="3246120"/>
+            <a:off x="1025287" y="1481328"/>
+            <a:ext cx="10141121" cy="3703320"/>
           </a:xfrm>
           <a:prstGeom prst="rect">
             <a:avLst/>
@@ -7820,7 +7656,233 @@
         </p:nvSpPr>
         <p:spPr>
           <a:xfrm>
-            <a:off x="685800" y="4956048"/>
+            <a:off x="685800" y="5403502"/>
+            <a:ext cx="10820095" cy="523220"/>
+          </a:xfrm>
+          <a:prstGeom prst="rect">
+            <a:avLst/>
+          </a:prstGeom>
+          <a:noFill/>
+        </p:spPr>
+        <p:txBody>
+          <a:bodyPr wrap="square">
+            <a:spAutoFit/>
+          </a:bodyPr>
+          <a:lstStyle/>
+          <a:p>
+            <a:pPr>
+              <a:spcAft>
+                <a:spcPts val="500"/>
+              </a:spcAft>
+            </a:pPr>
+            <a:r>
+              <a:rPr lang="en-US" sz="1400" b="1" dirty="0">
+                <a:solidFill>
+                  <a:srgbClr val="1A1A1A"/>
+                </a:solidFill>
+                <a:latin typeface="Calibri"/>
+              </a:rPr>
+              <a:t>P</a:t>
+            </a:r>
+            <a:r>
+              <a:rPr sz="1400" b="1" i="0" dirty="0">
+                <a:solidFill>
+                  <a:srgbClr val="1A1A1A"/>
+                </a:solidFill>
+                <a:latin typeface="Calibri"/>
+              </a:rPr>
+              <a:t>rice every threshold from its confusion matrix. Skipping a stayer saves $150; skipping a leaver costs about $1,310. You need roughly nine of the first for every one of the second before ranking beats calling everyone.</a:t>
+            </a:r>
+          </a:p>
+        </p:txBody>
+      </p:sp>
+      <p:sp>
+        <p:nvSpPr>
+          <p:cNvPr id="6" name="TextBox 5"/>
+          <p:cNvSpPr txBox="1"/>
+          <p:nvPr/>
+        </p:nvSpPr>
+        <p:spPr>
+          <a:xfrm>
+            <a:off x="685800" y="6126480"/>
+            <a:ext cx="10820095" cy="269304"/>
+          </a:xfrm>
+          <a:prstGeom prst="rect">
+            <a:avLst/>
+          </a:prstGeom>
+          <a:noFill/>
+        </p:spPr>
+        <p:txBody>
+          <a:bodyPr wrap="square">
+            <a:spAutoFit/>
+          </a:bodyPr>
+          <a:lstStyle/>
+          <a:p>
+            <a:r>
+              <a:rPr lang="en-US" sz="1150" b="0" i="1" dirty="0">
+                <a:solidFill>
+                  <a:srgbClr val="5A6270"/>
+                </a:solidFill>
+                <a:latin typeface="Calibri"/>
+              </a:rPr>
+              <a:t>Call cost of $150 and save rate of 20% are assumptions, not measurements. </a:t>
+            </a:r>
+          </a:p>
+        </p:txBody>
+      </p:sp>
+    </p:spTree>
+  </p:cSld>
+  <p:clrMapOvr>
+    <a:masterClrMapping/>
+  </p:clrMapOvr>
+</p:sld>
+</file>
+
+<file path=ppt/slides/slide17.xml><?xml version="1.0" encoding="utf-8"?>
+<p:sld xmlns:a="http://schemas.openxmlformats.org/drawingml/2006/main" xmlns:r="http://schemas.openxmlformats.org/officeDocument/2006/relationships" xmlns:p="http://schemas.openxmlformats.org/presentationml/2006/main">
+  <p:cSld>
+    <p:spTree>
+      <p:nvGrpSpPr>
+        <p:cNvPr id="1" name=""/>
+        <p:cNvGrpSpPr/>
+        <p:nvPr/>
+      </p:nvGrpSpPr>
+      <p:grpSpPr>
+        <a:xfrm>
+          <a:off x="0" y="0"/>
+          <a:ext cx="0" cy="0"/>
+          <a:chOff x="0" y="0"/>
+          <a:chExt cx="0" cy="0"/>
+        </a:xfrm>
+      </p:grpSpPr>
+      <p:sp>
+        <p:nvSpPr>
+          <p:cNvPr id="2" name="TextBox 1"/>
+          <p:cNvSpPr txBox="1"/>
+          <p:nvPr/>
+        </p:nvSpPr>
+        <p:spPr>
+          <a:xfrm>
+            <a:off x="685800" y="365760"/>
+            <a:ext cx="10820095" cy="1051560"/>
+          </a:xfrm>
+          <a:prstGeom prst="rect">
+            <a:avLst/>
+          </a:prstGeom>
+          <a:noFill/>
+        </p:spPr>
+        <p:txBody>
+          <a:bodyPr wrap="square">
+            <a:spAutoFit/>
+          </a:bodyPr>
+          <a:lstStyle/>
+          <a:p>
+            <a:r>
+              <a:rPr sz="1200" b="1" i="0">
+                <a:solidFill>
+                  <a:srgbClr val="5A6270"/>
+                </a:solidFill>
+                <a:latin typeface="Calibri"/>
+              </a:rPr>
+              <a:t>PART 4 · RECOMMENDATIONS</a:t>
+            </a:r>
+          </a:p>
+          <a:p>
+            <a:pPr>
+              <a:spcBef>
+                <a:spcPts val="400"/>
+              </a:spcBef>
+            </a:pPr>
+            <a:r>
+              <a:rPr sz="2800" b="1" i="0">
+                <a:solidFill>
+                  <a:srgbClr val="1A1A1A"/>
+                </a:solidFill>
+                <a:latin typeface="Calibri"/>
+              </a:rPr>
+              <a:t>What to do about churn</a:t>
+            </a:r>
+          </a:p>
+        </p:txBody>
+      </p:sp>
+      <p:sp>
+        <p:nvSpPr>
+          <p:cNvPr id="3" name="Rectangle 2"/>
+          <p:cNvSpPr/>
+          <p:nvPr/>
+        </p:nvSpPr>
+        <p:spPr>
+          <a:xfrm>
+            <a:off x="685800" y="1426464"/>
+            <a:ext cx="10820095" cy="9525"/>
+          </a:xfrm>
+          <a:prstGeom prst="rect">
+            <a:avLst/>
+          </a:prstGeom>
+          <a:solidFill>
+            <a:srgbClr val="D8DCE0"/>
+          </a:solidFill>
+          <a:ln>
+            <a:noFill/>
+          </a:ln>
+          <a:effectLst/>
+        </p:spPr>
+        <p:style>
+          <a:lnRef idx="1">
+            <a:schemeClr val="accent1"/>
+          </a:lnRef>
+          <a:fillRef idx="3">
+            <a:schemeClr val="accent1"/>
+          </a:fillRef>
+          <a:effectRef idx="2">
+            <a:schemeClr val="accent1"/>
+          </a:effectRef>
+          <a:fontRef idx="minor">
+            <a:schemeClr val="lt1"/>
+          </a:fontRef>
+        </p:style>
+        <p:txBody>
+          <a:bodyPr rtlCol="0" anchor="ctr"/>
+          <a:lstStyle/>
+          <a:p>
+            <a:pPr algn="ctr"/>
+            <a:endParaRPr/>
+          </a:p>
+        </p:txBody>
+      </p:sp>
+      <p:pic>
+        <p:nvPicPr>
+          <p:cNvPr id="4" name="Picture 3" descr="15_what_to_do.png"/>
+          <p:cNvPicPr>
+            <a:picLocks noChangeAspect="1"/>
+          </p:cNvPicPr>
+          <p:nvPr/>
+        </p:nvPicPr>
+        <p:blipFill>
+          <a:blip r:embed="rId3"/>
+          <a:stretch>
+            <a:fillRect/>
+          </a:stretch>
+        </p:blipFill>
+        <p:spPr>
+          <a:xfrm>
+            <a:off x="562003" y="1536192"/>
+            <a:ext cx="11208366" cy="3429000"/>
+          </a:xfrm>
+          <a:prstGeom prst="rect">
+            <a:avLst/>
+          </a:prstGeom>
+        </p:spPr>
+      </p:pic>
+      <p:sp>
+        <p:nvSpPr>
+          <p:cNvPr id="5" name="TextBox 4"/>
+          <p:cNvSpPr txBox="1"/>
+          <p:nvPr/>
+        </p:nvSpPr>
+        <p:spPr>
+          <a:xfrm>
+            <a:off x="685800" y="5074920"/>
             <a:ext cx="10820095" cy="4572000"/>
           </a:xfrm>
           <a:prstGeom prst="rect">
@@ -7846,103 +7908,57 @@
                 </a:solidFill>
                 <a:latin typeface="Calibri"/>
               </a:rPr>
-              <a:t>A call costs about $150. A customer is worth about $7,300. If one call in five saves the customer, the call pays for itself on anyone with more than a 10.3% chance of leaving.</a:t>
-            </a:r>
-          </a:p>
-          <a:p>
-            <a:pPr>
+              <a:t>Monday's plan is constructive, not a list of stops.</a:t>
+            </a:r>
+          </a:p>
+          <a:p>
+            <a:pPr lvl="1">
               <a:spcAft>
                 <a:spcPts val="400"/>
               </a:spcAft>
             </a:pPr>
             <a:r>
-              <a:rPr sz="600" b="0" i="0">
-                <a:solidFill>
-                  <a:srgbClr val="1A1A1A"/>
-                </a:solidFill>
-                <a:latin typeface="Calibri"/>
-              </a:rPr>
-              <a:t> </a:t>
-            </a:r>
-          </a:p>
-          <a:p>
-            <a:pPr>
-              <a:spcAft>
-                <a:spcPts val="400"/>
-              </a:spcAft>
-            </a:pPr>
-            <a:r>
-              <a:rPr sz="1350" b="0" i="0">
-                <a:solidFill>
-                  <a:srgbClr val="1A1A1A"/>
-                </a:solidFill>
-                <a:latin typeface="Calibri"/>
-              </a:rPr>
-              <a:t>Everyone in this cohort is at 30.5%, three times over that bar. So the right action for every customer is the same one, and no ordering can improve on a decision that is already correct for all of them.</a:t>
-            </a:r>
-          </a:p>
-          <a:p>
-            <a:pPr>
-              <a:spcAft>
-                <a:spcPts val="400"/>
-              </a:spcAft>
-            </a:pPr>
-            <a:r>
-              <a:rPr sz="600" b="0" i="0">
-                <a:solidFill>
-                  <a:srgbClr val="1A1A1A"/>
-                </a:solidFill>
-                <a:latin typeface="Calibri"/>
-              </a:rPr>
-              <a:t> </a:t>
-            </a:r>
-          </a:p>
-          <a:p>
-            <a:pPr>
-              <a:spcAft>
-                <a:spcPts val="400"/>
-              </a:spcAft>
-            </a:pPr>
-            <a:r>
-              <a:rPr sz="1350" b="0" i="0">
-                <a:solidFill>
-                  <a:srgbClr val="1A1A1A"/>
-                </a:solidFill>
-                <a:latin typeface="Calibri"/>
-              </a:rPr>
-              <a:t>Ranking would only start to matter if a call cost $446 rather than $150, or a customer were worth $2,459 rather than $7,310. Both are a factor of three away.</a:t>
-            </a:r>
-          </a:p>
-          <a:p>
-            <a:pPr>
-              <a:spcAft>
-                <a:spcPts val="400"/>
-              </a:spcAft>
-            </a:pPr>
-            <a:r>
-              <a:rPr sz="600" b="0" i="0">
-                <a:solidFill>
-                  <a:srgbClr val="1A1A1A"/>
-                </a:solidFill>
-                <a:latin typeface="Calibri"/>
-              </a:rPr>
-              <a:t> </a:t>
-            </a:r>
-          </a:p>
-          <a:p>
-            <a:pPr>
-              <a:spcAft>
-                <a:spcPts val="400"/>
-              </a:spcAft>
-            </a:pPr>
-            <a:r>
-              <a:rPr sz="1350" b="1" i="0">
-                <a:solidFill>
-                  <a:srgbClr val="1E7A4B"/>
-                </a:solidFill>
-                <a:latin typeface="Calibri"/>
-              </a:rPr>
-              <a:t>Using the model adds $600 on top of $52,400. A 1% gain, and generous at that, because the threshold it uses was chosen with hindsight on the same customers.</a:t>
+              <a:rPr sz="1150" b="0" i="0">
+                <a:solidFill>
+                  <a:srgbClr val="5A6270"/>
+                </a:solidFill>
+                <a:latin typeface="Calibri"/>
+              </a:rPr>
+              <a:t>Call the at-risk list (~$52k net under the assumed economics), hold half back, and log every touch. Do not spend on the 2024 trend, the SHAP list, or tenure-targeted onboarding — those are artefacts. Ask for usage and ticket timestamps rebuilt (they alone score AUC 0.41); keep billing; then re-run.</a:t>
+            </a:r>
+          </a:p>
+        </p:txBody>
+      </p:sp>
+      <p:sp>
+        <p:nvSpPr>
+          <p:cNvPr id="6" name="TextBox 5"/>
+          <p:cNvSpPr txBox="1"/>
+          <p:nvPr/>
+        </p:nvSpPr>
+        <p:spPr>
+          <a:xfrm>
+            <a:off x="685800" y="6126480"/>
+            <a:ext cx="10820095" cy="502920"/>
+          </a:xfrm>
+          <a:prstGeom prst="rect">
+            <a:avLst/>
+          </a:prstGeom>
+          <a:noFill/>
+        </p:spPr>
+        <p:txBody>
+          <a:bodyPr wrap="square">
+            <a:spAutoFit/>
+          </a:bodyPr>
+          <a:lstStyle/>
+          <a:p>
+            <a:r>
+              <a:rPr sz="1150" b="0" i="1">
+                <a:solidFill>
+                  <a:srgbClr val="5A6270"/>
+                </a:solidFill>
+                <a:latin typeface="Calibri"/>
+              </a:rPr>
+              <a:t>Call cost and save rate are assumptions. The 0.41 → 0.63 contrast is a post-hoc feature-family check — directional, not a new champion model.</a:t>
             </a:r>
           </a:p>
         </p:txBody>

</xml_diff>